<commit_message>
Same three dots on every cover page, moved rather than rearranged
The previous pass gave each page its own composition: a cluster, a diagonal, a
row, a triangle and so on. That changed the dots themselves, which was not what
was wanted.

Each page now carries the cover's own trio, unchanged in size and overlap, set
in a different position: high right, low right, hard against the right edge,
centred, and so on. Same dots, different place.

Co-Authored-By: Claude Opus 5 <noreply@anthropic.com>
Claude-Session: https://claude.ai/code/session_01CVBAFohBCYXt1ufjTVDiZj
</commit_message>
<xml_diff>
--- a/deck/CTS Monthly Business Review - 30092026.pptx
+++ b/deck/CTS Monthly Business Review - 30092026.pptx
@@ -7053,8 +7053,8 @@
         </p:nvSpPr>
         <p:spPr>
           <a:xfrm>
-            <a:off x="7543800" y="2971800"/>
-            <a:ext cx="2057400" cy="2057400"/>
+            <a:off x="7040880" y="2743200"/>
+            <a:ext cx="2240280" cy="2240280"/>
           </a:xfrm>
           <a:prstGeom prst="ellipse">
             <a:avLst/>
@@ -7082,14 +7082,14 @@
         </p:nvSpPr>
         <p:spPr>
           <a:xfrm>
-            <a:off x="6126480" y="1508760"/>
-            <a:ext cx="2240280" cy="2240280"/>
+            <a:off x="7772400" y="1874519"/>
+            <a:ext cx="1783080" cy="1783080"/>
           </a:xfrm>
           <a:prstGeom prst="ellipse">
             <a:avLst/>
           </a:prstGeom>
           <a:solidFill>
-            <a:srgbClr val="3FD0C9">
+            <a:srgbClr val="6D71FF">
               <a:alpha val="55000"/>
             </a:srgbClr>
           </a:solidFill>
@@ -7111,14 +7111,14 @@
         </p:nvSpPr>
         <p:spPr>
           <a:xfrm>
-            <a:off x="6629400" y="274320"/>
-            <a:ext cx="1463040" cy="1463040"/>
+            <a:off x="6812280" y="960120"/>
+            <a:ext cx="2148840" cy="2148840"/>
           </a:xfrm>
           <a:prstGeom prst="ellipse">
             <a:avLst/>
           </a:prstGeom>
           <a:solidFill>
-            <a:srgbClr val="6D71FF">
+            <a:srgbClr val="3FD0C9">
               <a:alpha val="55000"/>
             </a:srgbClr>
           </a:solidFill>
@@ -9588,8 +9588,37 @@
         </p:nvSpPr>
         <p:spPr>
           <a:xfrm>
-            <a:off x="6355080" y="822960"/>
-            <a:ext cx="960120" cy="960120"/>
+            <a:off x="6355080" y="2697480"/>
+            <a:ext cx="2240280" cy="2240280"/>
+          </a:xfrm>
+          <a:prstGeom prst="ellipse">
+            <a:avLst/>
+          </a:prstGeom>
+          <a:solidFill>
+            <a:srgbClr val="F33844">
+              <a:alpha val="55000"/>
+            </a:srgbClr>
+          </a:solidFill>
+          <a:ln/>
+        </p:spPr>
+        <p:txBody>
+          <a:bodyPr/>
+          <a:lstStyle/>
+          <a:p>
+            <a:endParaRPr lang="en-AU"/>
+          </a:p>
+        </p:txBody>
+      </p:sp>
+      <p:sp>
+        <p:nvSpPr>
+          <p:cNvPr id="2" name="dot 1"/>
+          <p:cNvSpPr/>
+          <p:nvPr/>
+        </p:nvSpPr>
+        <p:spPr>
+          <a:xfrm>
+            <a:off x="7086600" y="1828800"/>
+            <a:ext cx="1783080" cy="1783080"/>
           </a:xfrm>
           <a:prstGeom prst="ellipse">
             <a:avLst/>
@@ -9611,49 +9640,20 @@
       </p:sp>
       <p:sp>
         <p:nvSpPr>
-          <p:cNvPr id="2" name="dot 1"/>
+          <p:cNvPr id="2" name="dot 0"/>
           <p:cNvSpPr/>
           <p:nvPr/>
         </p:nvSpPr>
         <p:spPr>
           <a:xfrm>
-            <a:off x="7635240" y="685800"/>
-            <a:ext cx="1234440" cy="1234440"/>
+            <a:off x="6126480" y="914400"/>
+            <a:ext cx="2148840" cy="2148840"/>
           </a:xfrm>
           <a:prstGeom prst="ellipse">
             <a:avLst/>
           </a:prstGeom>
           <a:solidFill>
             <a:srgbClr val="3FD0C9">
-              <a:alpha val="55000"/>
-            </a:srgbClr>
-          </a:solidFill>
-          <a:ln/>
-        </p:spPr>
-        <p:txBody>
-          <a:bodyPr/>
-          <a:lstStyle/>
-          <a:p>
-            <a:endParaRPr lang="en-AU"/>
-          </a:p>
-        </p:txBody>
-      </p:sp>
-      <p:sp>
-        <p:nvSpPr>
-          <p:cNvPr id="2" name="dot 0"/>
-          <p:cNvSpPr/>
-          <p:nvPr/>
-        </p:nvSpPr>
-        <p:spPr>
-          <a:xfrm>
-            <a:off x="6263640" y="1965960"/>
-            <a:ext cx="2697480" cy="2697480"/>
-          </a:xfrm>
-          <a:prstGeom prst="ellipse">
-            <a:avLst/>
-          </a:prstGeom>
-          <a:solidFill>
-            <a:srgbClr val="F33844">
               <a:alpha val="55000"/>
             </a:srgbClr>
           </a:solidFill>
@@ -10945,8 +10945,8 @@
         </p:nvSpPr>
         <p:spPr>
           <a:xfrm>
-            <a:off x="8183879" y="3337560"/>
-            <a:ext cx="1508760" cy="1508760"/>
+            <a:off x="7178040" y="2057400"/>
+            <a:ext cx="2240280" cy="2240280"/>
           </a:xfrm>
           <a:prstGeom prst="ellipse">
             <a:avLst/>
@@ -10974,8 +10974,8 @@
         </p:nvSpPr>
         <p:spPr>
           <a:xfrm>
-            <a:off x="6903720" y="2743200"/>
-            <a:ext cx="1965960" cy="1965960"/>
+            <a:off x="7909560" y="1188720"/>
+            <a:ext cx="1783080" cy="1783080"/>
           </a:xfrm>
           <a:prstGeom prst="ellipse">
             <a:avLst/>
@@ -11003,8 +11003,8 @@
         </p:nvSpPr>
         <p:spPr>
           <a:xfrm>
-            <a:off x="5623560" y="3063240"/>
-            <a:ext cx="1600200" cy="1600200"/>
+            <a:off x="6949440" y="274320"/>
+            <a:ext cx="2148840" cy="2148840"/>
           </a:xfrm>
           <a:prstGeom prst="ellipse">
             <a:avLst/>
@@ -12305,37 +12305,8 @@
         </p:nvSpPr>
         <p:spPr>
           <a:xfrm>
-            <a:off x="6629400" y="2880360"/>
-            <a:ext cx="1691640" cy="1691640"/>
-          </a:xfrm>
-          <a:prstGeom prst="ellipse">
-            <a:avLst/>
-          </a:prstGeom>
-          <a:solidFill>
-            <a:srgbClr val="3FD0C9">
-              <a:alpha val="55000"/>
-            </a:srgbClr>
-          </a:solidFill>
-          <a:ln/>
-        </p:spPr>
-        <p:txBody>
-          <a:bodyPr/>
-          <a:lstStyle/>
-          <a:p>
-            <a:endParaRPr lang="en-AU"/>
-          </a:p>
-        </p:txBody>
-      </p:sp>
-      <p:sp>
-        <p:nvSpPr>
-          <p:cNvPr id="2" name="dot 1"/>
-          <p:cNvSpPr/>
-          <p:nvPr/>
-        </p:nvSpPr>
-        <p:spPr>
-          <a:xfrm>
-            <a:off x="7818120" y="1783080"/>
-            <a:ext cx="2148840" cy="2148840"/>
+            <a:off x="6263640" y="2971800"/>
+            <a:ext cx="2240280" cy="2240280"/>
           </a:xfrm>
           <a:prstGeom prst="ellipse">
             <a:avLst/>
@@ -12357,20 +12328,49 @@
       </p:sp>
       <p:sp>
         <p:nvSpPr>
+          <p:cNvPr id="2" name="dot 1"/>
+          <p:cNvSpPr/>
+          <p:nvPr/>
+        </p:nvSpPr>
+        <p:spPr>
+          <a:xfrm>
+            <a:off x="6995159" y="2103120"/>
+            <a:ext cx="1783080" cy="1783080"/>
+          </a:xfrm>
+          <a:prstGeom prst="ellipse">
+            <a:avLst/>
+          </a:prstGeom>
+          <a:solidFill>
+            <a:srgbClr val="6D71FF">
+              <a:alpha val="55000"/>
+            </a:srgbClr>
+          </a:solidFill>
+          <a:ln/>
+        </p:spPr>
+        <p:txBody>
+          <a:bodyPr/>
+          <a:lstStyle/>
+          <a:p>
+            <a:endParaRPr lang="en-AU"/>
+          </a:p>
+        </p:txBody>
+      </p:sp>
+      <p:sp>
+        <p:nvSpPr>
           <p:cNvPr id="2" name="dot 0"/>
           <p:cNvSpPr/>
           <p:nvPr/>
         </p:nvSpPr>
         <p:spPr>
           <a:xfrm>
-            <a:off x="6355080" y="1051560"/>
-            <a:ext cx="1783080" cy="1783080"/>
+            <a:off x="6035040" y="1188720"/>
+            <a:ext cx="2148840" cy="2148840"/>
           </a:xfrm>
           <a:prstGeom prst="ellipse">
             <a:avLst/>
           </a:prstGeom>
           <a:solidFill>
-            <a:srgbClr val="6D71FF">
+            <a:srgbClr val="3FD0C9">
               <a:alpha val="55000"/>
             </a:srgbClr>
           </a:solidFill>
@@ -17316,7 +17316,7 @@
         </p:nvSpPr>
         <p:spPr>
           <a:xfrm>
-            <a:off x="7178040" y="3063240"/>
+            <a:off x="6812280" y="2377440"/>
             <a:ext cx="2240280" cy="2240280"/>
           </a:xfrm>
           <a:prstGeom prst="ellipse">
@@ -17351,8 +17351,8 @@
         </p:nvSpPr>
         <p:spPr>
           <a:xfrm>
-            <a:off x="7635240" y="1691640"/>
-            <a:ext cx="1874519" cy="1874519"/>
+            <a:off x="7543800" y="1508760"/>
+            <a:ext cx="1783080" cy="1783080"/>
           </a:xfrm>
           <a:prstGeom prst="ellipse">
             <a:avLst/>
@@ -17386,8 +17386,8 @@
         </p:nvSpPr>
         <p:spPr>
           <a:xfrm>
-            <a:off x="6903720" y="502920"/>
-            <a:ext cx="1417320" cy="1417320"/>
+            <a:off x="6583680" y="594360"/>
+            <a:ext cx="2148840" cy="2148840"/>
           </a:xfrm>
           <a:prstGeom prst="ellipse">
             <a:avLst/>
@@ -17672,8 +17672,37 @@
         </p:nvSpPr>
         <p:spPr>
           <a:xfrm>
-            <a:off x="5440680" y="2697480"/>
-            <a:ext cx="2011680" cy="2011680"/>
+            <a:off x="5074920" y="2148840"/>
+            <a:ext cx="2240280" cy="2240280"/>
+          </a:xfrm>
+          <a:prstGeom prst="ellipse">
+            <a:avLst/>
+          </a:prstGeom>
+          <a:solidFill>
+            <a:srgbClr val="F33844">
+              <a:alpha val="82000"/>
+            </a:srgbClr>
+          </a:solidFill>
+          <a:ln/>
+        </p:spPr>
+        <p:txBody>
+          <a:bodyPr/>
+          <a:lstStyle/>
+          <a:p>
+            <a:endParaRPr lang="en-AU"/>
+          </a:p>
+        </p:txBody>
+      </p:sp>
+      <p:sp>
+        <p:nvSpPr>
+          <p:cNvPr id="2" name="dot 1"/>
+          <p:cNvSpPr/>
+          <p:nvPr/>
+        </p:nvSpPr>
+        <p:spPr>
+          <a:xfrm>
+            <a:off x="5806440" y="1280160"/>
+            <a:ext cx="1783080" cy="1783080"/>
           </a:xfrm>
           <a:prstGeom prst="ellipse">
             <a:avLst/>
@@ -17695,49 +17724,20 @@
       </p:sp>
       <p:sp>
         <p:nvSpPr>
-          <p:cNvPr id="2" name="dot 1"/>
+          <p:cNvPr id="2" name="dot 0"/>
           <p:cNvSpPr/>
           <p:nvPr/>
         </p:nvSpPr>
         <p:spPr>
           <a:xfrm>
-            <a:off x="6035040" y="1417320"/>
-            <a:ext cx="2377440" cy="2377440"/>
+            <a:off x="4846320" y="365760"/>
+            <a:ext cx="2148840" cy="2148840"/>
           </a:xfrm>
           <a:prstGeom prst="ellipse">
             <a:avLst/>
           </a:prstGeom>
           <a:solidFill>
             <a:srgbClr val="3FD0C9">
-              <a:alpha val="82000"/>
-            </a:srgbClr>
-          </a:solidFill>
-          <a:ln/>
-        </p:spPr>
-        <p:txBody>
-          <a:bodyPr/>
-          <a:lstStyle/>
-          <a:p>
-            <a:endParaRPr lang="en-AU"/>
-          </a:p>
-        </p:txBody>
-      </p:sp>
-      <p:sp>
-        <p:nvSpPr>
-          <p:cNvPr id="2" name="dot 0"/>
-          <p:cNvSpPr/>
-          <p:nvPr/>
-        </p:nvSpPr>
-        <p:spPr>
-          <a:xfrm>
-            <a:off x="4892040" y="411480"/>
-            <a:ext cx="1920240" cy="1920240"/>
-          </a:xfrm>
-          <a:prstGeom prst="ellipse">
-            <a:avLst/>
-          </a:prstGeom>
-          <a:solidFill>
-            <a:srgbClr val="F33844">
               <a:alpha val="82000"/>
             </a:srgbClr>
           </a:solidFill>
@@ -17928,8 +17928,8 @@
         </p:nvSpPr>
         <p:spPr>
           <a:xfrm>
-            <a:off x="6720840" y="3246120"/>
-            <a:ext cx="1874519" cy="1874519"/>
+            <a:off x="6537960" y="1965960"/>
+            <a:ext cx="2240280" cy="2240280"/>
           </a:xfrm>
           <a:prstGeom prst="ellipse">
             <a:avLst/>
@@ -17957,8 +17957,8 @@
         </p:nvSpPr>
         <p:spPr>
           <a:xfrm>
-            <a:off x="7360920" y="1234440"/>
-            <a:ext cx="1554480" cy="1554480"/>
+            <a:off x="7269480" y="1097280"/>
+            <a:ext cx="1783080" cy="1783080"/>
           </a:xfrm>
           <a:prstGeom prst="ellipse">
             <a:avLst/>
@@ -17986,7 +17986,7 @@
         </p:nvSpPr>
         <p:spPr>
           <a:xfrm>
-            <a:off x="6035040" y="2240280"/>
+            <a:off x="6309360" y="182880"/>
             <a:ext cx="2148840" cy="2148840"/>
           </a:xfrm>
           <a:prstGeom prst="ellipse">

</xml_diff>

<commit_message>
A small CTS mark in the top right of every light page
Twenty four light pages now carry the mark: "cts" at 15 point in navy with
"Seamless AV" under it at 6.5 point in the muted grey the pack already uses,
right aligned at the top of the page and clear of both the eyebrow and the
title.

There is no logo image in the deck or anywhere in the project, so this is the
same wordmark the cover and closing pages carry, set small for a light
background. If there is an actual logo file it can be dropped in to replace it.

Co-Authored-By: Claude Opus 5 <noreply@anthropic.com>
Claude-Session: https://claude.ai/code/session_01CVBAFohBCYXt1ufjTVDiZj
</commit_message>
<xml_diff>
--- a/deck/CTS Monthly Business Review - 30092026.pptx
+++ b/deck/CTS Monthly Business Review - 30092026.pptx
@@ -5588,6 +5588,74 @@
           </a:p>
         </p:txBody>
       </p:sp>
+      <p:sp>
+        <p:nvSpPr>
+          <p:cNvPr id="26" name="cts mark"/>
+          <p:cNvSpPr txBox="1"/>
+          <p:nvPr/>
+        </p:nvSpPr>
+        <p:spPr>
+          <a:xfrm>
+            <a:off x="7726679" y="155448"/>
+            <a:ext cx="914400" cy="274320"/>
+          </a:xfrm>
+          <a:prstGeom prst="rect">
+            <a:avLst/>
+          </a:prstGeom>
+          <a:noFill/>
+        </p:spPr>
+        <p:txBody>
+          <a:bodyPr wrap="none" lIns="0" rIns="0" tIns="0" bIns="0">
+            <a:spAutoFit/>
+          </a:bodyPr>
+          <a:lstStyle/>
+          <a:p>
+            <a:pPr algn="r"/>
+            <a:r>
+              <a:rPr sz="1500" b="1">
+                <a:solidFill>
+                  <a:srgbClr val="242C39"/>
+                </a:solidFill>
+              </a:rPr>
+              <a:t>cts</a:t>
+            </a:r>
+          </a:p>
+        </p:txBody>
+      </p:sp>
+      <p:sp>
+        <p:nvSpPr>
+          <p:cNvPr id="27" name="cts mark sub"/>
+          <p:cNvSpPr txBox="1"/>
+          <p:nvPr/>
+        </p:nvSpPr>
+        <p:spPr>
+          <a:xfrm>
+            <a:off x="7726679" y="384048"/>
+            <a:ext cx="914400" cy="164592"/>
+          </a:xfrm>
+          <a:prstGeom prst="rect">
+            <a:avLst/>
+          </a:prstGeom>
+          <a:noFill/>
+        </p:spPr>
+        <p:txBody>
+          <a:bodyPr wrap="none" lIns="0" rIns="0" tIns="0" bIns="0">
+            <a:spAutoFit/>
+          </a:bodyPr>
+          <a:lstStyle/>
+          <a:p>
+            <a:pPr algn="r"/>
+            <a:r>
+              <a:rPr sz="650">
+                <a:solidFill>
+                  <a:srgbClr val="6B7585"/>
+                </a:solidFill>
+              </a:rPr>
+              <a:t>Seamless AV</a:t>
+            </a:r>
+          </a:p>
+        </p:txBody>
+      </p:sp>
     </p:spTree>
   </p:cSld>
   <p:clrMapOvr>
@@ -5946,6 +6014,74 @@
           </a:p>
         </p:txBody>
       </p:sp>
+      <p:sp>
+        <p:nvSpPr>
+          <p:cNvPr id="26" name="cts mark"/>
+          <p:cNvSpPr txBox="1"/>
+          <p:nvPr/>
+        </p:nvSpPr>
+        <p:spPr>
+          <a:xfrm>
+            <a:off x="7726679" y="155448"/>
+            <a:ext cx="914400" cy="274320"/>
+          </a:xfrm>
+          <a:prstGeom prst="rect">
+            <a:avLst/>
+          </a:prstGeom>
+          <a:noFill/>
+        </p:spPr>
+        <p:txBody>
+          <a:bodyPr wrap="none" lIns="0" rIns="0" tIns="0" bIns="0">
+            <a:spAutoFit/>
+          </a:bodyPr>
+          <a:lstStyle/>
+          <a:p>
+            <a:pPr algn="r"/>
+            <a:r>
+              <a:rPr sz="1500" b="1">
+                <a:solidFill>
+                  <a:srgbClr val="242C39"/>
+                </a:solidFill>
+              </a:rPr>
+              <a:t>cts</a:t>
+            </a:r>
+          </a:p>
+        </p:txBody>
+      </p:sp>
+      <p:sp>
+        <p:nvSpPr>
+          <p:cNvPr id="27" name="cts mark sub"/>
+          <p:cNvSpPr txBox="1"/>
+          <p:nvPr/>
+        </p:nvSpPr>
+        <p:spPr>
+          <a:xfrm>
+            <a:off x="7726679" y="384048"/>
+            <a:ext cx="914400" cy="164592"/>
+          </a:xfrm>
+          <a:prstGeom prst="rect">
+            <a:avLst/>
+          </a:prstGeom>
+          <a:noFill/>
+        </p:spPr>
+        <p:txBody>
+          <a:bodyPr wrap="none" lIns="0" rIns="0" tIns="0" bIns="0">
+            <a:spAutoFit/>
+          </a:bodyPr>
+          <a:lstStyle/>
+          <a:p>
+            <a:pPr algn="r"/>
+            <a:r>
+              <a:rPr sz="650">
+                <a:solidFill>
+                  <a:srgbClr val="6B7585"/>
+                </a:solidFill>
+              </a:rPr>
+              <a:t>Seamless AV</a:t>
+            </a:r>
+          </a:p>
+        </p:txBody>
+      </p:sp>
     </p:spTree>
   </p:cSld>
   <p:clrMapOvr>
@@ -6304,6 +6440,74 @@
           </a:p>
         </p:txBody>
       </p:sp>
+      <p:sp>
+        <p:nvSpPr>
+          <p:cNvPr id="26" name="cts mark"/>
+          <p:cNvSpPr txBox="1"/>
+          <p:nvPr/>
+        </p:nvSpPr>
+        <p:spPr>
+          <a:xfrm>
+            <a:off x="7726679" y="155448"/>
+            <a:ext cx="914400" cy="274320"/>
+          </a:xfrm>
+          <a:prstGeom prst="rect">
+            <a:avLst/>
+          </a:prstGeom>
+          <a:noFill/>
+        </p:spPr>
+        <p:txBody>
+          <a:bodyPr wrap="none" lIns="0" rIns="0" tIns="0" bIns="0">
+            <a:spAutoFit/>
+          </a:bodyPr>
+          <a:lstStyle/>
+          <a:p>
+            <a:pPr algn="r"/>
+            <a:r>
+              <a:rPr sz="1500" b="1">
+                <a:solidFill>
+                  <a:srgbClr val="242C39"/>
+                </a:solidFill>
+              </a:rPr>
+              <a:t>cts</a:t>
+            </a:r>
+          </a:p>
+        </p:txBody>
+      </p:sp>
+      <p:sp>
+        <p:nvSpPr>
+          <p:cNvPr id="27" name="cts mark sub"/>
+          <p:cNvSpPr txBox="1"/>
+          <p:nvPr/>
+        </p:nvSpPr>
+        <p:spPr>
+          <a:xfrm>
+            <a:off x="7726679" y="384048"/>
+            <a:ext cx="914400" cy="164592"/>
+          </a:xfrm>
+          <a:prstGeom prst="rect">
+            <a:avLst/>
+          </a:prstGeom>
+          <a:noFill/>
+        </p:spPr>
+        <p:txBody>
+          <a:bodyPr wrap="none" lIns="0" rIns="0" tIns="0" bIns="0">
+            <a:spAutoFit/>
+          </a:bodyPr>
+          <a:lstStyle/>
+          <a:p>
+            <a:pPr algn="r"/>
+            <a:r>
+              <a:rPr sz="650">
+                <a:solidFill>
+                  <a:srgbClr val="6B7585"/>
+                </a:solidFill>
+              </a:rPr>
+              <a:t>Seamless AV</a:t>
+            </a:r>
+          </a:p>
+        </p:txBody>
+      </p:sp>
     </p:spTree>
   </p:cSld>
   <p:clrMapOvr>
@@ -6662,6 +6866,74 @@
           </a:p>
         </p:txBody>
       </p:sp>
+      <p:sp>
+        <p:nvSpPr>
+          <p:cNvPr id="26" name="cts mark"/>
+          <p:cNvSpPr txBox="1"/>
+          <p:nvPr/>
+        </p:nvSpPr>
+        <p:spPr>
+          <a:xfrm>
+            <a:off x="7726679" y="155448"/>
+            <a:ext cx="914400" cy="274320"/>
+          </a:xfrm>
+          <a:prstGeom prst="rect">
+            <a:avLst/>
+          </a:prstGeom>
+          <a:noFill/>
+        </p:spPr>
+        <p:txBody>
+          <a:bodyPr wrap="none" lIns="0" rIns="0" tIns="0" bIns="0">
+            <a:spAutoFit/>
+          </a:bodyPr>
+          <a:lstStyle/>
+          <a:p>
+            <a:pPr algn="r"/>
+            <a:r>
+              <a:rPr sz="1500" b="1">
+                <a:solidFill>
+                  <a:srgbClr val="242C39"/>
+                </a:solidFill>
+              </a:rPr>
+              <a:t>cts</a:t>
+            </a:r>
+          </a:p>
+        </p:txBody>
+      </p:sp>
+      <p:sp>
+        <p:nvSpPr>
+          <p:cNvPr id="27" name="cts mark sub"/>
+          <p:cNvSpPr txBox="1"/>
+          <p:nvPr/>
+        </p:nvSpPr>
+        <p:spPr>
+          <a:xfrm>
+            <a:off x="7726679" y="384048"/>
+            <a:ext cx="914400" cy="164592"/>
+          </a:xfrm>
+          <a:prstGeom prst="rect">
+            <a:avLst/>
+          </a:prstGeom>
+          <a:noFill/>
+        </p:spPr>
+        <p:txBody>
+          <a:bodyPr wrap="none" lIns="0" rIns="0" tIns="0" bIns="0">
+            <a:spAutoFit/>
+          </a:bodyPr>
+          <a:lstStyle/>
+          <a:p>
+            <a:pPr algn="r"/>
+            <a:r>
+              <a:rPr sz="650">
+                <a:solidFill>
+                  <a:srgbClr val="6B7585"/>
+                </a:solidFill>
+              </a:rPr>
+              <a:t>Seamless AV</a:t>
+            </a:r>
+          </a:p>
+        </p:txBody>
+      </p:sp>
     </p:spTree>
   </p:cSld>
   <p:clrMapOvr>
@@ -7020,6 +7292,74 @@
           </a:p>
         </p:txBody>
       </p:sp>
+      <p:sp>
+        <p:nvSpPr>
+          <p:cNvPr id="26" name="cts mark"/>
+          <p:cNvSpPr txBox="1"/>
+          <p:nvPr/>
+        </p:nvSpPr>
+        <p:spPr>
+          <a:xfrm>
+            <a:off x="7726679" y="155448"/>
+            <a:ext cx="914400" cy="274320"/>
+          </a:xfrm>
+          <a:prstGeom prst="rect">
+            <a:avLst/>
+          </a:prstGeom>
+          <a:noFill/>
+        </p:spPr>
+        <p:txBody>
+          <a:bodyPr wrap="none" lIns="0" rIns="0" tIns="0" bIns="0">
+            <a:spAutoFit/>
+          </a:bodyPr>
+          <a:lstStyle/>
+          <a:p>
+            <a:pPr algn="r"/>
+            <a:r>
+              <a:rPr sz="1500" b="1">
+                <a:solidFill>
+                  <a:srgbClr val="242C39"/>
+                </a:solidFill>
+              </a:rPr>
+              <a:t>cts</a:t>
+            </a:r>
+          </a:p>
+        </p:txBody>
+      </p:sp>
+      <p:sp>
+        <p:nvSpPr>
+          <p:cNvPr id="27" name="cts mark sub"/>
+          <p:cNvSpPr txBox="1"/>
+          <p:nvPr/>
+        </p:nvSpPr>
+        <p:spPr>
+          <a:xfrm>
+            <a:off x="7726679" y="384048"/>
+            <a:ext cx="914400" cy="164592"/>
+          </a:xfrm>
+          <a:prstGeom prst="rect">
+            <a:avLst/>
+          </a:prstGeom>
+          <a:noFill/>
+        </p:spPr>
+        <p:txBody>
+          <a:bodyPr wrap="none" lIns="0" rIns="0" tIns="0" bIns="0">
+            <a:spAutoFit/>
+          </a:bodyPr>
+          <a:lstStyle/>
+          <a:p>
+            <a:pPr algn="r"/>
+            <a:r>
+              <a:rPr sz="650">
+                <a:solidFill>
+                  <a:srgbClr val="6B7585"/>
+                </a:solidFill>
+              </a:rPr>
+              <a:t>Seamless AV</a:t>
+            </a:r>
+          </a:p>
+        </p:txBody>
+      </p:sp>
     </p:spTree>
   </p:cSld>
   <p:clrMapOvr>
@@ -7661,6 +8001,74 @@
           </a:p>
         </p:txBody>
       </p:sp>
+      <p:sp>
+        <p:nvSpPr>
+          <p:cNvPr id="26" name="cts mark"/>
+          <p:cNvSpPr txBox="1"/>
+          <p:nvPr/>
+        </p:nvSpPr>
+        <p:spPr>
+          <a:xfrm>
+            <a:off x="7726679" y="155448"/>
+            <a:ext cx="914400" cy="274320"/>
+          </a:xfrm>
+          <a:prstGeom prst="rect">
+            <a:avLst/>
+          </a:prstGeom>
+          <a:noFill/>
+        </p:spPr>
+        <p:txBody>
+          <a:bodyPr wrap="none" lIns="0" rIns="0" tIns="0" bIns="0">
+            <a:spAutoFit/>
+          </a:bodyPr>
+          <a:lstStyle/>
+          <a:p>
+            <a:pPr algn="r"/>
+            <a:r>
+              <a:rPr sz="1500" b="1">
+                <a:solidFill>
+                  <a:srgbClr val="242C39"/>
+                </a:solidFill>
+              </a:rPr>
+              <a:t>cts</a:t>
+            </a:r>
+          </a:p>
+        </p:txBody>
+      </p:sp>
+      <p:sp>
+        <p:nvSpPr>
+          <p:cNvPr id="27" name="cts mark sub"/>
+          <p:cNvSpPr txBox="1"/>
+          <p:nvPr/>
+        </p:nvSpPr>
+        <p:spPr>
+          <a:xfrm>
+            <a:off x="7726679" y="384048"/>
+            <a:ext cx="914400" cy="164592"/>
+          </a:xfrm>
+          <a:prstGeom prst="rect">
+            <a:avLst/>
+          </a:prstGeom>
+          <a:noFill/>
+        </p:spPr>
+        <p:txBody>
+          <a:bodyPr wrap="none" lIns="0" rIns="0" tIns="0" bIns="0">
+            <a:spAutoFit/>
+          </a:bodyPr>
+          <a:lstStyle/>
+          <a:p>
+            <a:pPr algn="r"/>
+            <a:r>
+              <a:rPr sz="650">
+                <a:solidFill>
+                  <a:srgbClr val="6B7585"/>
+                </a:solidFill>
+              </a:rPr>
+              <a:t>Seamless AV</a:t>
+            </a:r>
+          </a:p>
+        </p:txBody>
+      </p:sp>
     </p:spTree>
   </p:cSld>
   <p:clrMapOvr>
@@ -8019,6 +8427,74 @@
           </a:p>
         </p:txBody>
       </p:sp>
+      <p:sp>
+        <p:nvSpPr>
+          <p:cNvPr id="26" name="cts mark"/>
+          <p:cNvSpPr txBox="1"/>
+          <p:nvPr/>
+        </p:nvSpPr>
+        <p:spPr>
+          <a:xfrm>
+            <a:off x="7726679" y="155448"/>
+            <a:ext cx="914400" cy="274320"/>
+          </a:xfrm>
+          <a:prstGeom prst="rect">
+            <a:avLst/>
+          </a:prstGeom>
+          <a:noFill/>
+        </p:spPr>
+        <p:txBody>
+          <a:bodyPr wrap="none" lIns="0" rIns="0" tIns="0" bIns="0">
+            <a:spAutoFit/>
+          </a:bodyPr>
+          <a:lstStyle/>
+          <a:p>
+            <a:pPr algn="r"/>
+            <a:r>
+              <a:rPr sz="1500" b="1">
+                <a:solidFill>
+                  <a:srgbClr val="242C39"/>
+                </a:solidFill>
+              </a:rPr>
+              <a:t>cts</a:t>
+            </a:r>
+          </a:p>
+        </p:txBody>
+      </p:sp>
+      <p:sp>
+        <p:nvSpPr>
+          <p:cNvPr id="27" name="cts mark sub"/>
+          <p:cNvSpPr txBox="1"/>
+          <p:nvPr/>
+        </p:nvSpPr>
+        <p:spPr>
+          <a:xfrm>
+            <a:off x="7726679" y="384048"/>
+            <a:ext cx="914400" cy="164592"/>
+          </a:xfrm>
+          <a:prstGeom prst="rect">
+            <a:avLst/>
+          </a:prstGeom>
+          <a:noFill/>
+        </p:spPr>
+        <p:txBody>
+          <a:bodyPr wrap="none" lIns="0" rIns="0" tIns="0" bIns="0">
+            <a:spAutoFit/>
+          </a:bodyPr>
+          <a:lstStyle/>
+          <a:p>
+            <a:pPr algn="r"/>
+            <a:r>
+              <a:rPr sz="650">
+                <a:solidFill>
+                  <a:srgbClr val="6B7585"/>
+                </a:solidFill>
+              </a:rPr>
+              <a:t>Seamless AV</a:t>
+            </a:r>
+          </a:p>
+        </p:txBody>
+      </p:sp>
     </p:spTree>
   </p:cSld>
   <p:clrMapOvr>
@@ -8377,6 +8853,74 @@
           </a:p>
         </p:txBody>
       </p:sp>
+      <p:sp>
+        <p:nvSpPr>
+          <p:cNvPr id="26" name="cts mark"/>
+          <p:cNvSpPr txBox="1"/>
+          <p:nvPr/>
+        </p:nvSpPr>
+        <p:spPr>
+          <a:xfrm>
+            <a:off x="7726679" y="155448"/>
+            <a:ext cx="914400" cy="274320"/>
+          </a:xfrm>
+          <a:prstGeom prst="rect">
+            <a:avLst/>
+          </a:prstGeom>
+          <a:noFill/>
+        </p:spPr>
+        <p:txBody>
+          <a:bodyPr wrap="none" lIns="0" rIns="0" tIns="0" bIns="0">
+            <a:spAutoFit/>
+          </a:bodyPr>
+          <a:lstStyle/>
+          <a:p>
+            <a:pPr algn="r"/>
+            <a:r>
+              <a:rPr sz="1500" b="1">
+                <a:solidFill>
+                  <a:srgbClr val="242C39"/>
+                </a:solidFill>
+              </a:rPr>
+              <a:t>cts</a:t>
+            </a:r>
+          </a:p>
+        </p:txBody>
+      </p:sp>
+      <p:sp>
+        <p:nvSpPr>
+          <p:cNvPr id="27" name="cts mark sub"/>
+          <p:cNvSpPr txBox="1"/>
+          <p:nvPr/>
+        </p:nvSpPr>
+        <p:spPr>
+          <a:xfrm>
+            <a:off x="7726679" y="384048"/>
+            <a:ext cx="914400" cy="164592"/>
+          </a:xfrm>
+          <a:prstGeom prst="rect">
+            <a:avLst/>
+          </a:prstGeom>
+          <a:noFill/>
+        </p:spPr>
+        <p:txBody>
+          <a:bodyPr wrap="none" lIns="0" rIns="0" tIns="0" bIns="0">
+            <a:spAutoFit/>
+          </a:bodyPr>
+          <a:lstStyle/>
+          <a:p>
+            <a:pPr algn="r"/>
+            <a:r>
+              <a:rPr sz="650">
+                <a:solidFill>
+                  <a:srgbClr val="6B7585"/>
+                </a:solidFill>
+              </a:rPr>
+              <a:t>Seamless AV</a:t>
+            </a:r>
+          </a:p>
+        </p:txBody>
+      </p:sp>
     </p:spTree>
   </p:cSld>
   <p:clrMapOvr>
@@ -8738,6 +9282,74 @@
           </a:p>
         </p:txBody>
       </p:sp>
+      <p:sp>
+        <p:nvSpPr>
+          <p:cNvPr id="26" name="cts mark"/>
+          <p:cNvSpPr txBox="1"/>
+          <p:nvPr/>
+        </p:nvSpPr>
+        <p:spPr>
+          <a:xfrm>
+            <a:off x="7726679" y="155448"/>
+            <a:ext cx="914400" cy="274320"/>
+          </a:xfrm>
+          <a:prstGeom prst="rect">
+            <a:avLst/>
+          </a:prstGeom>
+          <a:noFill/>
+        </p:spPr>
+        <p:txBody>
+          <a:bodyPr wrap="none" lIns="0" rIns="0" tIns="0" bIns="0">
+            <a:spAutoFit/>
+          </a:bodyPr>
+          <a:lstStyle/>
+          <a:p>
+            <a:pPr algn="r"/>
+            <a:r>
+              <a:rPr sz="1500" b="1">
+                <a:solidFill>
+                  <a:srgbClr val="242C39"/>
+                </a:solidFill>
+              </a:rPr>
+              <a:t>cts</a:t>
+            </a:r>
+          </a:p>
+        </p:txBody>
+      </p:sp>
+      <p:sp>
+        <p:nvSpPr>
+          <p:cNvPr id="27" name="cts mark sub"/>
+          <p:cNvSpPr txBox="1"/>
+          <p:nvPr/>
+        </p:nvSpPr>
+        <p:spPr>
+          <a:xfrm>
+            <a:off x="7726679" y="384048"/>
+            <a:ext cx="914400" cy="164592"/>
+          </a:xfrm>
+          <a:prstGeom prst="rect">
+            <a:avLst/>
+          </a:prstGeom>
+          <a:noFill/>
+        </p:spPr>
+        <p:txBody>
+          <a:bodyPr wrap="none" lIns="0" rIns="0" tIns="0" bIns="0">
+            <a:spAutoFit/>
+          </a:bodyPr>
+          <a:lstStyle/>
+          <a:p>
+            <a:pPr algn="r"/>
+            <a:r>
+              <a:rPr sz="650">
+                <a:solidFill>
+                  <a:srgbClr val="6B7585"/>
+                </a:solidFill>
+              </a:rPr>
+              <a:t>Seamless AV</a:t>
+            </a:r>
+          </a:p>
+        </p:txBody>
+      </p:sp>
     </p:spTree>
   </p:cSld>
   <p:clrMapOvr>
@@ -9555,6 +10167,74 @@
           </a:p>
         </p:txBody>
       </p:sp>
+      <p:sp>
+        <p:nvSpPr>
+          <p:cNvPr id="26" name="cts mark"/>
+          <p:cNvSpPr txBox="1"/>
+          <p:nvPr/>
+        </p:nvSpPr>
+        <p:spPr>
+          <a:xfrm>
+            <a:off x="7726679" y="155448"/>
+            <a:ext cx="914400" cy="274320"/>
+          </a:xfrm>
+          <a:prstGeom prst="rect">
+            <a:avLst/>
+          </a:prstGeom>
+          <a:noFill/>
+        </p:spPr>
+        <p:txBody>
+          <a:bodyPr wrap="none" lIns="0" rIns="0" tIns="0" bIns="0">
+            <a:spAutoFit/>
+          </a:bodyPr>
+          <a:lstStyle/>
+          <a:p>
+            <a:pPr algn="r"/>
+            <a:r>
+              <a:rPr sz="1500" b="1">
+                <a:solidFill>
+                  <a:srgbClr val="242C39"/>
+                </a:solidFill>
+              </a:rPr>
+              <a:t>cts</a:t>
+            </a:r>
+          </a:p>
+        </p:txBody>
+      </p:sp>
+      <p:sp>
+        <p:nvSpPr>
+          <p:cNvPr id="27" name="cts mark sub"/>
+          <p:cNvSpPr txBox="1"/>
+          <p:nvPr/>
+        </p:nvSpPr>
+        <p:spPr>
+          <a:xfrm>
+            <a:off x="7726679" y="384048"/>
+            <a:ext cx="914400" cy="164592"/>
+          </a:xfrm>
+          <a:prstGeom prst="rect">
+            <a:avLst/>
+          </a:prstGeom>
+          <a:noFill/>
+        </p:spPr>
+        <p:txBody>
+          <a:bodyPr wrap="none" lIns="0" rIns="0" tIns="0" bIns="0">
+            <a:spAutoFit/>
+          </a:bodyPr>
+          <a:lstStyle/>
+          <a:p>
+            <a:pPr algn="r"/>
+            <a:r>
+              <a:rPr sz="650">
+                <a:solidFill>
+                  <a:srgbClr val="6B7585"/>
+                </a:solidFill>
+              </a:rPr>
+              <a:t>Seamless AV</a:t>
+            </a:r>
+          </a:p>
+        </p:txBody>
+      </p:sp>
     </p:spTree>
   </p:cSld>
   <p:clrMapOvr>
@@ -10196,6 +10876,74 @@
           </a:p>
         </p:txBody>
       </p:sp>
+      <p:sp>
+        <p:nvSpPr>
+          <p:cNvPr id="26" name="cts mark"/>
+          <p:cNvSpPr txBox="1"/>
+          <p:nvPr/>
+        </p:nvSpPr>
+        <p:spPr>
+          <a:xfrm>
+            <a:off x="7726679" y="155448"/>
+            <a:ext cx="914400" cy="274320"/>
+          </a:xfrm>
+          <a:prstGeom prst="rect">
+            <a:avLst/>
+          </a:prstGeom>
+          <a:noFill/>
+        </p:spPr>
+        <p:txBody>
+          <a:bodyPr wrap="none" lIns="0" rIns="0" tIns="0" bIns="0">
+            <a:spAutoFit/>
+          </a:bodyPr>
+          <a:lstStyle/>
+          <a:p>
+            <a:pPr algn="r"/>
+            <a:r>
+              <a:rPr sz="1500" b="1">
+                <a:solidFill>
+                  <a:srgbClr val="242C39"/>
+                </a:solidFill>
+              </a:rPr>
+              <a:t>cts</a:t>
+            </a:r>
+          </a:p>
+        </p:txBody>
+      </p:sp>
+      <p:sp>
+        <p:nvSpPr>
+          <p:cNvPr id="27" name="cts mark sub"/>
+          <p:cNvSpPr txBox="1"/>
+          <p:nvPr/>
+        </p:nvSpPr>
+        <p:spPr>
+          <a:xfrm>
+            <a:off x="7726679" y="384048"/>
+            <a:ext cx="914400" cy="164592"/>
+          </a:xfrm>
+          <a:prstGeom prst="rect">
+            <a:avLst/>
+          </a:prstGeom>
+          <a:noFill/>
+        </p:spPr>
+        <p:txBody>
+          <a:bodyPr wrap="none" lIns="0" rIns="0" tIns="0" bIns="0">
+            <a:spAutoFit/>
+          </a:bodyPr>
+          <a:lstStyle/>
+          <a:p>
+            <a:pPr algn="r"/>
+            <a:r>
+              <a:rPr sz="650">
+                <a:solidFill>
+                  <a:srgbClr val="6B7585"/>
+                </a:solidFill>
+              </a:rPr>
+              <a:t>Seamless AV</a:t>
+            </a:r>
+          </a:p>
+        </p:txBody>
+      </p:sp>
     </p:spTree>
   </p:cSld>
   <p:clrMapOvr>
@@ -10554,6 +11302,74 @@
           </a:p>
         </p:txBody>
       </p:sp>
+      <p:sp>
+        <p:nvSpPr>
+          <p:cNvPr id="26" name="cts mark"/>
+          <p:cNvSpPr txBox="1"/>
+          <p:nvPr/>
+        </p:nvSpPr>
+        <p:spPr>
+          <a:xfrm>
+            <a:off x="7726679" y="155448"/>
+            <a:ext cx="914400" cy="274320"/>
+          </a:xfrm>
+          <a:prstGeom prst="rect">
+            <a:avLst/>
+          </a:prstGeom>
+          <a:noFill/>
+        </p:spPr>
+        <p:txBody>
+          <a:bodyPr wrap="none" lIns="0" rIns="0" tIns="0" bIns="0">
+            <a:spAutoFit/>
+          </a:bodyPr>
+          <a:lstStyle/>
+          <a:p>
+            <a:pPr algn="r"/>
+            <a:r>
+              <a:rPr sz="1500" b="1">
+                <a:solidFill>
+                  <a:srgbClr val="242C39"/>
+                </a:solidFill>
+              </a:rPr>
+              <a:t>cts</a:t>
+            </a:r>
+          </a:p>
+        </p:txBody>
+      </p:sp>
+      <p:sp>
+        <p:nvSpPr>
+          <p:cNvPr id="27" name="cts mark sub"/>
+          <p:cNvSpPr txBox="1"/>
+          <p:nvPr/>
+        </p:nvSpPr>
+        <p:spPr>
+          <a:xfrm>
+            <a:off x="7726679" y="384048"/>
+            <a:ext cx="914400" cy="164592"/>
+          </a:xfrm>
+          <a:prstGeom prst="rect">
+            <a:avLst/>
+          </a:prstGeom>
+          <a:noFill/>
+        </p:spPr>
+        <p:txBody>
+          <a:bodyPr wrap="none" lIns="0" rIns="0" tIns="0" bIns="0">
+            <a:spAutoFit/>
+          </a:bodyPr>
+          <a:lstStyle/>
+          <a:p>
+            <a:pPr algn="r"/>
+            <a:r>
+              <a:rPr sz="650">
+                <a:solidFill>
+                  <a:srgbClr val="6B7585"/>
+                </a:solidFill>
+              </a:rPr>
+              <a:t>Seamless AV</a:t>
+            </a:r>
+          </a:p>
+        </p:txBody>
+      </p:sp>
     </p:spTree>
   </p:cSld>
   <p:clrMapOvr>
@@ -10912,6 +11728,74 @@
           </a:p>
         </p:txBody>
       </p:sp>
+      <p:sp>
+        <p:nvSpPr>
+          <p:cNvPr id="26" name="cts mark"/>
+          <p:cNvSpPr txBox="1"/>
+          <p:nvPr/>
+        </p:nvSpPr>
+        <p:spPr>
+          <a:xfrm>
+            <a:off x="7726679" y="155448"/>
+            <a:ext cx="914400" cy="274320"/>
+          </a:xfrm>
+          <a:prstGeom prst="rect">
+            <a:avLst/>
+          </a:prstGeom>
+          <a:noFill/>
+        </p:spPr>
+        <p:txBody>
+          <a:bodyPr wrap="none" lIns="0" rIns="0" tIns="0" bIns="0">
+            <a:spAutoFit/>
+          </a:bodyPr>
+          <a:lstStyle/>
+          <a:p>
+            <a:pPr algn="r"/>
+            <a:r>
+              <a:rPr sz="1500" b="1">
+                <a:solidFill>
+                  <a:srgbClr val="242C39"/>
+                </a:solidFill>
+              </a:rPr>
+              <a:t>cts</a:t>
+            </a:r>
+          </a:p>
+        </p:txBody>
+      </p:sp>
+      <p:sp>
+        <p:nvSpPr>
+          <p:cNvPr id="27" name="cts mark sub"/>
+          <p:cNvSpPr txBox="1"/>
+          <p:nvPr/>
+        </p:nvSpPr>
+        <p:spPr>
+          <a:xfrm>
+            <a:off x="7726679" y="384048"/>
+            <a:ext cx="914400" cy="164592"/>
+          </a:xfrm>
+          <a:prstGeom prst="rect">
+            <a:avLst/>
+          </a:prstGeom>
+          <a:noFill/>
+        </p:spPr>
+        <p:txBody>
+          <a:bodyPr wrap="none" lIns="0" rIns="0" tIns="0" bIns="0">
+            <a:spAutoFit/>
+          </a:bodyPr>
+          <a:lstStyle/>
+          <a:p>
+            <a:pPr algn="r"/>
+            <a:r>
+              <a:rPr sz="650">
+                <a:solidFill>
+                  <a:srgbClr val="6B7585"/>
+                </a:solidFill>
+              </a:rPr>
+              <a:t>Seamless AV</a:t>
+            </a:r>
+          </a:p>
+        </p:txBody>
+      </p:sp>
     </p:spTree>
   </p:cSld>
   <p:clrMapOvr>
@@ -11556,6 +12440,74 @@
           </a:p>
         </p:txBody>
       </p:sp>
+      <p:sp>
+        <p:nvSpPr>
+          <p:cNvPr id="26" name="cts mark"/>
+          <p:cNvSpPr txBox="1"/>
+          <p:nvPr/>
+        </p:nvSpPr>
+        <p:spPr>
+          <a:xfrm>
+            <a:off x="7726679" y="155448"/>
+            <a:ext cx="914400" cy="274320"/>
+          </a:xfrm>
+          <a:prstGeom prst="rect">
+            <a:avLst/>
+          </a:prstGeom>
+          <a:noFill/>
+        </p:spPr>
+        <p:txBody>
+          <a:bodyPr wrap="none" lIns="0" rIns="0" tIns="0" bIns="0">
+            <a:spAutoFit/>
+          </a:bodyPr>
+          <a:lstStyle/>
+          <a:p>
+            <a:pPr algn="r"/>
+            <a:r>
+              <a:rPr sz="1500" b="1">
+                <a:solidFill>
+                  <a:srgbClr val="242C39"/>
+                </a:solidFill>
+              </a:rPr>
+              <a:t>cts</a:t>
+            </a:r>
+          </a:p>
+        </p:txBody>
+      </p:sp>
+      <p:sp>
+        <p:nvSpPr>
+          <p:cNvPr id="27" name="cts mark sub"/>
+          <p:cNvSpPr txBox="1"/>
+          <p:nvPr/>
+        </p:nvSpPr>
+        <p:spPr>
+          <a:xfrm>
+            <a:off x="7726679" y="384048"/>
+            <a:ext cx="914400" cy="164592"/>
+          </a:xfrm>
+          <a:prstGeom prst="rect">
+            <a:avLst/>
+          </a:prstGeom>
+          <a:noFill/>
+        </p:spPr>
+        <p:txBody>
+          <a:bodyPr wrap="none" lIns="0" rIns="0" tIns="0" bIns="0">
+            <a:spAutoFit/>
+          </a:bodyPr>
+          <a:lstStyle/>
+          <a:p>
+            <a:pPr algn="r"/>
+            <a:r>
+              <a:rPr sz="650">
+                <a:solidFill>
+                  <a:srgbClr val="6B7585"/>
+                </a:solidFill>
+              </a:rPr>
+              <a:t>Seamless AV</a:t>
+            </a:r>
+          </a:p>
+        </p:txBody>
+      </p:sp>
     </p:spTree>
   </p:cSld>
   <p:clrMapOvr>
@@ -11914,6 +12866,74 @@
           </a:p>
         </p:txBody>
       </p:sp>
+      <p:sp>
+        <p:nvSpPr>
+          <p:cNvPr id="26" name="cts mark"/>
+          <p:cNvSpPr txBox="1"/>
+          <p:nvPr/>
+        </p:nvSpPr>
+        <p:spPr>
+          <a:xfrm>
+            <a:off x="7726679" y="155448"/>
+            <a:ext cx="914400" cy="274320"/>
+          </a:xfrm>
+          <a:prstGeom prst="rect">
+            <a:avLst/>
+          </a:prstGeom>
+          <a:noFill/>
+        </p:spPr>
+        <p:txBody>
+          <a:bodyPr wrap="none" lIns="0" rIns="0" tIns="0" bIns="0">
+            <a:spAutoFit/>
+          </a:bodyPr>
+          <a:lstStyle/>
+          <a:p>
+            <a:pPr algn="r"/>
+            <a:r>
+              <a:rPr sz="1500" b="1">
+                <a:solidFill>
+                  <a:srgbClr val="242C39"/>
+                </a:solidFill>
+              </a:rPr>
+              <a:t>cts</a:t>
+            </a:r>
+          </a:p>
+        </p:txBody>
+      </p:sp>
+      <p:sp>
+        <p:nvSpPr>
+          <p:cNvPr id="27" name="cts mark sub"/>
+          <p:cNvSpPr txBox="1"/>
+          <p:nvPr/>
+        </p:nvSpPr>
+        <p:spPr>
+          <a:xfrm>
+            <a:off x="7726679" y="384048"/>
+            <a:ext cx="914400" cy="164592"/>
+          </a:xfrm>
+          <a:prstGeom prst="rect">
+            <a:avLst/>
+          </a:prstGeom>
+          <a:noFill/>
+        </p:spPr>
+        <p:txBody>
+          <a:bodyPr wrap="none" lIns="0" rIns="0" tIns="0" bIns="0">
+            <a:spAutoFit/>
+          </a:bodyPr>
+          <a:lstStyle/>
+          <a:p>
+            <a:pPr algn="r"/>
+            <a:r>
+              <a:rPr sz="650">
+                <a:solidFill>
+                  <a:srgbClr val="6B7585"/>
+                </a:solidFill>
+              </a:rPr>
+              <a:t>Seamless AV</a:t>
+            </a:r>
+          </a:p>
+        </p:txBody>
+      </p:sp>
     </p:spTree>
   </p:cSld>
   <p:clrMapOvr>
@@ -12272,6 +13292,74 @@
           </a:p>
         </p:txBody>
       </p:sp>
+      <p:sp>
+        <p:nvSpPr>
+          <p:cNvPr id="26" name="cts mark"/>
+          <p:cNvSpPr txBox="1"/>
+          <p:nvPr/>
+        </p:nvSpPr>
+        <p:spPr>
+          <a:xfrm>
+            <a:off x="7726679" y="155448"/>
+            <a:ext cx="914400" cy="274320"/>
+          </a:xfrm>
+          <a:prstGeom prst="rect">
+            <a:avLst/>
+          </a:prstGeom>
+          <a:noFill/>
+        </p:spPr>
+        <p:txBody>
+          <a:bodyPr wrap="none" lIns="0" rIns="0" tIns="0" bIns="0">
+            <a:spAutoFit/>
+          </a:bodyPr>
+          <a:lstStyle/>
+          <a:p>
+            <a:pPr algn="r"/>
+            <a:r>
+              <a:rPr sz="1500" b="1">
+                <a:solidFill>
+                  <a:srgbClr val="242C39"/>
+                </a:solidFill>
+              </a:rPr>
+              <a:t>cts</a:t>
+            </a:r>
+          </a:p>
+        </p:txBody>
+      </p:sp>
+      <p:sp>
+        <p:nvSpPr>
+          <p:cNvPr id="27" name="cts mark sub"/>
+          <p:cNvSpPr txBox="1"/>
+          <p:nvPr/>
+        </p:nvSpPr>
+        <p:spPr>
+          <a:xfrm>
+            <a:off x="7726679" y="384048"/>
+            <a:ext cx="914400" cy="164592"/>
+          </a:xfrm>
+          <a:prstGeom prst="rect">
+            <a:avLst/>
+          </a:prstGeom>
+          <a:noFill/>
+        </p:spPr>
+        <p:txBody>
+          <a:bodyPr wrap="none" lIns="0" rIns="0" tIns="0" bIns="0">
+            <a:spAutoFit/>
+          </a:bodyPr>
+          <a:lstStyle/>
+          <a:p>
+            <a:pPr algn="r"/>
+            <a:r>
+              <a:rPr sz="650">
+                <a:solidFill>
+                  <a:srgbClr val="6B7585"/>
+                </a:solidFill>
+              </a:rPr>
+              <a:t>Seamless AV</a:t>
+            </a:r>
+          </a:p>
+        </p:txBody>
+      </p:sp>
     </p:spTree>
   </p:cSld>
   <p:clrMapOvr>
@@ -12913,6 +14001,74 @@
           </a:p>
         </p:txBody>
       </p:sp>
+      <p:sp>
+        <p:nvSpPr>
+          <p:cNvPr id="26" name="cts mark"/>
+          <p:cNvSpPr txBox="1"/>
+          <p:nvPr/>
+        </p:nvSpPr>
+        <p:spPr>
+          <a:xfrm>
+            <a:off x="7726679" y="155448"/>
+            <a:ext cx="914400" cy="274320"/>
+          </a:xfrm>
+          <a:prstGeom prst="rect">
+            <a:avLst/>
+          </a:prstGeom>
+          <a:noFill/>
+        </p:spPr>
+        <p:txBody>
+          <a:bodyPr wrap="none" lIns="0" rIns="0" tIns="0" bIns="0">
+            <a:spAutoFit/>
+          </a:bodyPr>
+          <a:lstStyle/>
+          <a:p>
+            <a:pPr algn="r"/>
+            <a:r>
+              <a:rPr sz="1500" b="1">
+                <a:solidFill>
+                  <a:srgbClr val="242C39"/>
+                </a:solidFill>
+              </a:rPr>
+              <a:t>cts</a:t>
+            </a:r>
+          </a:p>
+        </p:txBody>
+      </p:sp>
+      <p:sp>
+        <p:nvSpPr>
+          <p:cNvPr id="27" name="cts mark sub"/>
+          <p:cNvSpPr txBox="1"/>
+          <p:nvPr/>
+        </p:nvSpPr>
+        <p:spPr>
+          <a:xfrm>
+            <a:off x="7726679" y="384048"/>
+            <a:ext cx="914400" cy="164592"/>
+          </a:xfrm>
+          <a:prstGeom prst="rect">
+            <a:avLst/>
+          </a:prstGeom>
+          <a:noFill/>
+        </p:spPr>
+        <p:txBody>
+          <a:bodyPr wrap="none" lIns="0" rIns="0" tIns="0" bIns="0">
+            <a:spAutoFit/>
+          </a:bodyPr>
+          <a:lstStyle/>
+          <a:p>
+            <a:pPr algn="r"/>
+            <a:r>
+              <a:rPr sz="650">
+                <a:solidFill>
+                  <a:srgbClr val="6B7585"/>
+                </a:solidFill>
+              </a:rPr>
+              <a:t>Seamless AV</a:t>
+            </a:r>
+          </a:p>
+        </p:txBody>
+      </p:sp>
     </p:spTree>
   </p:cSld>
   <p:clrMapOvr>
@@ -15138,6 +16294,74 @@
               <a:t>Ahead of budget by $148k</a:t>
             </a:r>
             <a:endParaRPr lang="en-US" sz="750"/>
+          </a:p>
+        </p:txBody>
+      </p:sp>
+      <p:sp>
+        <p:nvSpPr>
+          <p:cNvPr id="57" name="cts mark"/>
+          <p:cNvSpPr txBox="1"/>
+          <p:nvPr/>
+        </p:nvSpPr>
+        <p:spPr>
+          <a:xfrm>
+            <a:off x="7726679" y="155448"/>
+            <a:ext cx="914400" cy="274320"/>
+          </a:xfrm>
+          <a:prstGeom prst="rect">
+            <a:avLst/>
+          </a:prstGeom>
+          <a:noFill/>
+        </p:spPr>
+        <p:txBody>
+          <a:bodyPr wrap="none" lIns="0" rIns="0" tIns="0" bIns="0">
+            <a:spAutoFit/>
+          </a:bodyPr>
+          <a:lstStyle/>
+          <a:p>
+            <a:pPr algn="r"/>
+            <a:r>
+              <a:rPr sz="1500" b="1">
+                <a:solidFill>
+                  <a:srgbClr val="242C39"/>
+                </a:solidFill>
+              </a:rPr>
+              <a:t>cts</a:t>
+            </a:r>
+          </a:p>
+        </p:txBody>
+      </p:sp>
+      <p:sp>
+        <p:nvSpPr>
+          <p:cNvPr id="58" name="cts mark sub"/>
+          <p:cNvSpPr txBox="1"/>
+          <p:nvPr/>
+        </p:nvSpPr>
+        <p:spPr>
+          <a:xfrm>
+            <a:off x="7726679" y="384048"/>
+            <a:ext cx="914400" cy="164592"/>
+          </a:xfrm>
+          <a:prstGeom prst="rect">
+            <a:avLst/>
+          </a:prstGeom>
+          <a:noFill/>
+        </p:spPr>
+        <p:txBody>
+          <a:bodyPr wrap="none" lIns="0" rIns="0" tIns="0" bIns="0">
+            <a:spAutoFit/>
+          </a:bodyPr>
+          <a:lstStyle/>
+          <a:p>
+            <a:pPr algn="r"/>
+            <a:r>
+              <a:rPr sz="650">
+                <a:solidFill>
+                  <a:srgbClr val="6B7585"/>
+                </a:solidFill>
+              </a:rPr>
+              <a:t>Seamless AV</a:t>
+            </a:r>
           </a:p>
         </p:txBody>
       </p:sp>
@@ -17263,6 +18487,74 @@
           </a:p>
         </p:txBody>
       </p:sp>
+      <p:sp>
+        <p:nvSpPr>
+          <p:cNvPr id="32" name="cts mark"/>
+          <p:cNvSpPr txBox="1"/>
+          <p:nvPr/>
+        </p:nvSpPr>
+        <p:spPr>
+          <a:xfrm>
+            <a:off x="7726679" y="155448"/>
+            <a:ext cx="914400" cy="274320"/>
+          </a:xfrm>
+          <a:prstGeom prst="rect">
+            <a:avLst/>
+          </a:prstGeom>
+          <a:noFill/>
+        </p:spPr>
+        <p:txBody>
+          <a:bodyPr wrap="none" lIns="0" rIns="0" tIns="0" bIns="0">
+            <a:spAutoFit/>
+          </a:bodyPr>
+          <a:lstStyle/>
+          <a:p>
+            <a:pPr algn="r"/>
+            <a:r>
+              <a:rPr sz="1500" b="1">
+                <a:solidFill>
+                  <a:srgbClr val="242C39"/>
+                </a:solidFill>
+              </a:rPr>
+              <a:t>cts</a:t>
+            </a:r>
+          </a:p>
+        </p:txBody>
+      </p:sp>
+      <p:sp>
+        <p:nvSpPr>
+          <p:cNvPr id="33" name="cts mark sub"/>
+          <p:cNvSpPr txBox="1"/>
+          <p:nvPr/>
+        </p:nvSpPr>
+        <p:spPr>
+          <a:xfrm>
+            <a:off x="7726679" y="384048"/>
+            <a:ext cx="914400" cy="164592"/>
+          </a:xfrm>
+          <a:prstGeom prst="rect">
+            <a:avLst/>
+          </a:prstGeom>
+          <a:noFill/>
+        </p:spPr>
+        <p:txBody>
+          <a:bodyPr wrap="none" lIns="0" rIns="0" tIns="0" bIns="0">
+            <a:spAutoFit/>
+          </a:bodyPr>
+          <a:lstStyle/>
+          <a:p>
+            <a:pPr algn="r"/>
+            <a:r>
+              <a:rPr sz="650">
+                <a:solidFill>
+                  <a:srgbClr val="6B7585"/>
+                </a:solidFill>
+              </a:rPr>
+              <a:t>Seamless AV</a:t>
+            </a:r>
+          </a:p>
+        </p:txBody>
+      </p:sp>
     </p:spTree>
   </p:cSld>
   <p:clrMapOvr>
@@ -18560,6 +19852,74 @@
           </a:p>
         </p:txBody>
       </p:sp>
+      <p:sp>
+        <p:nvSpPr>
+          <p:cNvPr id="27" name="cts mark"/>
+          <p:cNvSpPr txBox="1"/>
+          <p:nvPr/>
+        </p:nvSpPr>
+        <p:spPr>
+          <a:xfrm>
+            <a:off x="7726679" y="155448"/>
+            <a:ext cx="914400" cy="274320"/>
+          </a:xfrm>
+          <a:prstGeom prst="rect">
+            <a:avLst/>
+          </a:prstGeom>
+          <a:noFill/>
+        </p:spPr>
+        <p:txBody>
+          <a:bodyPr wrap="none" lIns="0" rIns="0" tIns="0" bIns="0">
+            <a:spAutoFit/>
+          </a:bodyPr>
+          <a:lstStyle/>
+          <a:p>
+            <a:pPr algn="r"/>
+            <a:r>
+              <a:rPr sz="1500" b="1">
+                <a:solidFill>
+                  <a:srgbClr val="242C39"/>
+                </a:solidFill>
+              </a:rPr>
+              <a:t>cts</a:t>
+            </a:r>
+          </a:p>
+        </p:txBody>
+      </p:sp>
+      <p:sp>
+        <p:nvSpPr>
+          <p:cNvPr id="28" name="cts mark sub"/>
+          <p:cNvSpPr txBox="1"/>
+          <p:nvPr/>
+        </p:nvSpPr>
+        <p:spPr>
+          <a:xfrm>
+            <a:off x="7726679" y="384048"/>
+            <a:ext cx="914400" cy="164592"/>
+          </a:xfrm>
+          <a:prstGeom prst="rect">
+            <a:avLst/>
+          </a:prstGeom>
+          <a:noFill/>
+        </p:spPr>
+        <p:txBody>
+          <a:bodyPr wrap="none" lIns="0" rIns="0" tIns="0" bIns="0">
+            <a:spAutoFit/>
+          </a:bodyPr>
+          <a:lstStyle/>
+          <a:p>
+            <a:pPr algn="r"/>
+            <a:r>
+              <a:rPr sz="650">
+                <a:solidFill>
+                  <a:srgbClr val="6B7585"/>
+                </a:solidFill>
+              </a:rPr>
+              <a:t>Seamless AV</a:t>
+            </a:r>
+          </a:p>
+        </p:txBody>
+      </p:sp>
     </p:spTree>
   </p:cSld>
   <p:clrMapOvr>
@@ -18918,6 +20278,74 @@
           </a:p>
         </p:txBody>
       </p:sp>
+      <p:sp>
+        <p:nvSpPr>
+          <p:cNvPr id="26" name="cts mark"/>
+          <p:cNvSpPr txBox="1"/>
+          <p:nvPr/>
+        </p:nvSpPr>
+        <p:spPr>
+          <a:xfrm>
+            <a:off x="7726679" y="155448"/>
+            <a:ext cx="914400" cy="274320"/>
+          </a:xfrm>
+          <a:prstGeom prst="rect">
+            <a:avLst/>
+          </a:prstGeom>
+          <a:noFill/>
+        </p:spPr>
+        <p:txBody>
+          <a:bodyPr wrap="none" lIns="0" rIns="0" tIns="0" bIns="0">
+            <a:spAutoFit/>
+          </a:bodyPr>
+          <a:lstStyle/>
+          <a:p>
+            <a:pPr algn="r"/>
+            <a:r>
+              <a:rPr sz="1500" b="1">
+                <a:solidFill>
+                  <a:srgbClr val="242C39"/>
+                </a:solidFill>
+              </a:rPr>
+              <a:t>cts</a:t>
+            </a:r>
+          </a:p>
+        </p:txBody>
+      </p:sp>
+      <p:sp>
+        <p:nvSpPr>
+          <p:cNvPr id="27" name="cts mark sub"/>
+          <p:cNvSpPr txBox="1"/>
+          <p:nvPr/>
+        </p:nvSpPr>
+        <p:spPr>
+          <a:xfrm>
+            <a:off x="7726679" y="384048"/>
+            <a:ext cx="914400" cy="164592"/>
+          </a:xfrm>
+          <a:prstGeom prst="rect">
+            <a:avLst/>
+          </a:prstGeom>
+          <a:noFill/>
+        </p:spPr>
+        <p:txBody>
+          <a:bodyPr wrap="none" lIns="0" rIns="0" tIns="0" bIns="0">
+            <a:spAutoFit/>
+          </a:bodyPr>
+          <a:lstStyle/>
+          <a:p>
+            <a:pPr algn="r"/>
+            <a:r>
+              <a:rPr sz="650">
+                <a:solidFill>
+                  <a:srgbClr val="6B7585"/>
+                </a:solidFill>
+              </a:rPr>
+              <a:t>Seamless AV</a:t>
+            </a:r>
+          </a:p>
+        </p:txBody>
+      </p:sp>
     </p:spTree>
   </p:cSld>
   <p:clrMapOvr>
@@ -19279,6 +20707,74 @@
           </a:p>
         </p:txBody>
       </p:sp>
+      <p:sp>
+        <p:nvSpPr>
+          <p:cNvPr id="26" name="cts mark"/>
+          <p:cNvSpPr txBox="1"/>
+          <p:nvPr/>
+        </p:nvSpPr>
+        <p:spPr>
+          <a:xfrm>
+            <a:off x="7726679" y="155448"/>
+            <a:ext cx="914400" cy="274320"/>
+          </a:xfrm>
+          <a:prstGeom prst="rect">
+            <a:avLst/>
+          </a:prstGeom>
+          <a:noFill/>
+        </p:spPr>
+        <p:txBody>
+          <a:bodyPr wrap="none" lIns="0" rIns="0" tIns="0" bIns="0">
+            <a:spAutoFit/>
+          </a:bodyPr>
+          <a:lstStyle/>
+          <a:p>
+            <a:pPr algn="r"/>
+            <a:r>
+              <a:rPr sz="1500" b="1">
+                <a:solidFill>
+                  <a:srgbClr val="242C39"/>
+                </a:solidFill>
+              </a:rPr>
+              <a:t>cts</a:t>
+            </a:r>
+          </a:p>
+        </p:txBody>
+      </p:sp>
+      <p:sp>
+        <p:nvSpPr>
+          <p:cNvPr id="27" name="cts mark sub"/>
+          <p:cNvSpPr txBox="1"/>
+          <p:nvPr/>
+        </p:nvSpPr>
+        <p:spPr>
+          <a:xfrm>
+            <a:off x="7726679" y="384048"/>
+            <a:ext cx="914400" cy="164592"/>
+          </a:xfrm>
+          <a:prstGeom prst="rect">
+            <a:avLst/>
+          </a:prstGeom>
+          <a:noFill/>
+        </p:spPr>
+        <p:txBody>
+          <a:bodyPr wrap="none" lIns="0" rIns="0" tIns="0" bIns="0">
+            <a:spAutoFit/>
+          </a:bodyPr>
+          <a:lstStyle/>
+          <a:p>
+            <a:pPr algn="r"/>
+            <a:r>
+              <a:rPr sz="650">
+                <a:solidFill>
+                  <a:srgbClr val="6B7585"/>
+                </a:solidFill>
+              </a:rPr>
+              <a:t>Seamless AV</a:t>
+            </a:r>
+          </a:p>
+        </p:txBody>
+      </p:sp>
     </p:spTree>
   </p:cSld>
   <p:clrMapOvr>
@@ -19640,6 +21136,74 @@
           </a:p>
         </p:txBody>
       </p:sp>
+      <p:sp>
+        <p:nvSpPr>
+          <p:cNvPr id="26" name="cts mark"/>
+          <p:cNvSpPr txBox="1"/>
+          <p:nvPr/>
+        </p:nvSpPr>
+        <p:spPr>
+          <a:xfrm>
+            <a:off x="7726679" y="155448"/>
+            <a:ext cx="914400" cy="274320"/>
+          </a:xfrm>
+          <a:prstGeom prst="rect">
+            <a:avLst/>
+          </a:prstGeom>
+          <a:noFill/>
+        </p:spPr>
+        <p:txBody>
+          <a:bodyPr wrap="none" lIns="0" rIns="0" tIns="0" bIns="0">
+            <a:spAutoFit/>
+          </a:bodyPr>
+          <a:lstStyle/>
+          <a:p>
+            <a:pPr algn="r"/>
+            <a:r>
+              <a:rPr sz="1500" b="1">
+                <a:solidFill>
+                  <a:srgbClr val="242C39"/>
+                </a:solidFill>
+              </a:rPr>
+              <a:t>cts</a:t>
+            </a:r>
+          </a:p>
+        </p:txBody>
+      </p:sp>
+      <p:sp>
+        <p:nvSpPr>
+          <p:cNvPr id="27" name="cts mark sub"/>
+          <p:cNvSpPr txBox="1"/>
+          <p:nvPr/>
+        </p:nvSpPr>
+        <p:spPr>
+          <a:xfrm>
+            <a:off x="7726679" y="384048"/>
+            <a:ext cx="914400" cy="164592"/>
+          </a:xfrm>
+          <a:prstGeom prst="rect">
+            <a:avLst/>
+          </a:prstGeom>
+          <a:noFill/>
+        </p:spPr>
+        <p:txBody>
+          <a:bodyPr wrap="none" lIns="0" rIns="0" tIns="0" bIns="0">
+            <a:spAutoFit/>
+          </a:bodyPr>
+          <a:lstStyle/>
+          <a:p>
+            <a:pPr algn="r"/>
+            <a:r>
+              <a:rPr sz="650">
+                <a:solidFill>
+                  <a:srgbClr val="6B7585"/>
+                </a:solidFill>
+              </a:rPr>
+              <a:t>Seamless AV</a:t>
+            </a:r>
+          </a:p>
+        </p:txBody>
+      </p:sp>
     </p:spTree>
   </p:cSld>
   <p:clrMapOvr>
@@ -19995,6 +21559,74 @@
               <a:t>9</a:t>
             </a:fld>
             <a:endParaRPr lang="en-US"/>
+          </a:p>
+        </p:txBody>
+      </p:sp>
+      <p:sp>
+        <p:nvSpPr>
+          <p:cNvPr id="26" name="cts mark"/>
+          <p:cNvSpPr txBox="1"/>
+          <p:nvPr/>
+        </p:nvSpPr>
+        <p:spPr>
+          <a:xfrm>
+            <a:off x="7726679" y="155448"/>
+            <a:ext cx="914400" cy="274320"/>
+          </a:xfrm>
+          <a:prstGeom prst="rect">
+            <a:avLst/>
+          </a:prstGeom>
+          <a:noFill/>
+        </p:spPr>
+        <p:txBody>
+          <a:bodyPr wrap="none" lIns="0" rIns="0" tIns="0" bIns="0">
+            <a:spAutoFit/>
+          </a:bodyPr>
+          <a:lstStyle/>
+          <a:p>
+            <a:pPr algn="r"/>
+            <a:r>
+              <a:rPr sz="1500" b="1">
+                <a:solidFill>
+                  <a:srgbClr val="242C39"/>
+                </a:solidFill>
+              </a:rPr>
+              <a:t>cts</a:t>
+            </a:r>
+          </a:p>
+        </p:txBody>
+      </p:sp>
+      <p:sp>
+        <p:nvSpPr>
+          <p:cNvPr id="27" name="cts mark sub"/>
+          <p:cNvSpPr txBox="1"/>
+          <p:nvPr/>
+        </p:nvSpPr>
+        <p:spPr>
+          <a:xfrm>
+            <a:off x="7726679" y="384048"/>
+            <a:ext cx="914400" cy="164592"/>
+          </a:xfrm>
+          <a:prstGeom prst="rect">
+            <a:avLst/>
+          </a:prstGeom>
+          <a:noFill/>
+        </p:spPr>
+        <p:txBody>
+          <a:bodyPr wrap="none" lIns="0" rIns="0" tIns="0" bIns="0">
+            <a:spAutoFit/>
+          </a:bodyPr>
+          <a:lstStyle/>
+          <a:p>
+            <a:pPr algn="r"/>
+            <a:r>
+              <a:rPr sz="650">
+                <a:solidFill>
+                  <a:srgbClr val="6B7585"/>
+                </a:solidFill>
+              </a:rPr>
+              <a:t>Seamless AV</a:t>
+            </a:r>
           </a:p>
         </p:txBody>
       </p:sp>

</xml_diff>

<commit_message>
The CTS mark in the brand colours
The wordmark on the light pages was flat navy. Each letter now carries one of
the three brand colours that run through the cover pages: c in dark teal, t in
blue, s in red, with "Seamless AV" under it in the muted grey.

Dark teal is used rather than the bright teal, which is too light to read at
15 point on white.

Co-Authored-By: Claude Opus 5 <noreply@anthropic.com>
Claude-Session: https://claude.ai/code/session_01CVBAFohBCYXt1ufjTVDiZj
</commit_message>
<xml_diff>
--- a/deck/CTS Monthly Business Review - 30092026.pptx
+++ b/deck/CTS Monthly Business Review - 30092026.pptx
@@ -5614,10 +5614,26 @@
             <a:r>
               <a:rPr sz="1500" b="1">
                 <a:solidFill>
-                  <a:srgbClr val="242C39"/>
-                </a:solidFill>
-              </a:rPr>
-              <a:t>cts</a:t>
+                  <a:srgbClr val="005358"/>
+                </a:solidFill>
+              </a:rPr>
+              <a:t>c</a:t>
+            </a:r>
+            <a:r>
+              <a:rPr sz="1500" b="1">
+                <a:solidFill>
+                  <a:srgbClr val="6D71FF"/>
+                </a:solidFill>
+              </a:rPr>
+              <a:t>t</a:t>
+            </a:r>
+            <a:r>
+              <a:rPr sz="1500" b="1">
+                <a:solidFill>
+                  <a:srgbClr val="F33844"/>
+                </a:solidFill>
+              </a:rPr>
+              <a:t>s</a:t>
             </a:r>
           </a:p>
         </p:txBody>
@@ -6040,10 +6056,26 @@
             <a:r>
               <a:rPr sz="1500" b="1">
                 <a:solidFill>
-                  <a:srgbClr val="242C39"/>
-                </a:solidFill>
-              </a:rPr>
-              <a:t>cts</a:t>
+                  <a:srgbClr val="005358"/>
+                </a:solidFill>
+              </a:rPr>
+              <a:t>c</a:t>
+            </a:r>
+            <a:r>
+              <a:rPr sz="1500" b="1">
+                <a:solidFill>
+                  <a:srgbClr val="6D71FF"/>
+                </a:solidFill>
+              </a:rPr>
+              <a:t>t</a:t>
+            </a:r>
+            <a:r>
+              <a:rPr sz="1500" b="1">
+                <a:solidFill>
+                  <a:srgbClr val="F33844"/>
+                </a:solidFill>
+              </a:rPr>
+              <a:t>s</a:t>
             </a:r>
           </a:p>
         </p:txBody>
@@ -6466,10 +6498,26 @@
             <a:r>
               <a:rPr sz="1500" b="1">
                 <a:solidFill>
-                  <a:srgbClr val="242C39"/>
-                </a:solidFill>
-              </a:rPr>
-              <a:t>cts</a:t>
+                  <a:srgbClr val="005358"/>
+                </a:solidFill>
+              </a:rPr>
+              <a:t>c</a:t>
+            </a:r>
+            <a:r>
+              <a:rPr sz="1500" b="1">
+                <a:solidFill>
+                  <a:srgbClr val="6D71FF"/>
+                </a:solidFill>
+              </a:rPr>
+              <a:t>t</a:t>
+            </a:r>
+            <a:r>
+              <a:rPr sz="1500" b="1">
+                <a:solidFill>
+                  <a:srgbClr val="F33844"/>
+                </a:solidFill>
+              </a:rPr>
+              <a:t>s</a:t>
             </a:r>
           </a:p>
         </p:txBody>
@@ -6892,10 +6940,26 @@
             <a:r>
               <a:rPr sz="1500" b="1">
                 <a:solidFill>
-                  <a:srgbClr val="242C39"/>
-                </a:solidFill>
-              </a:rPr>
-              <a:t>cts</a:t>
+                  <a:srgbClr val="005358"/>
+                </a:solidFill>
+              </a:rPr>
+              <a:t>c</a:t>
+            </a:r>
+            <a:r>
+              <a:rPr sz="1500" b="1">
+                <a:solidFill>
+                  <a:srgbClr val="6D71FF"/>
+                </a:solidFill>
+              </a:rPr>
+              <a:t>t</a:t>
+            </a:r>
+            <a:r>
+              <a:rPr sz="1500" b="1">
+                <a:solidFill>
+                  <a:srgbClr val="F33844"/>
+                </a:solidFill>
+              </a:rPr>
+              <a:t>s</a:t>
             </a:r>
           </a:p>
         </p:txBody>
@@ -7318,10 +7382,26 @@
             <a:r>
               <a:rPr sz="1500" b="1">
                 <a:solidFill>
-                  <a:srgbClr val="242C39"/>
-                </a:solidFill>
-              </a:rPr>
-              <a:t>cts</a:t>
+                  <a:srgbClr val="005358"/>
+                </a:solidFill>
+              </a:rPr>
+              <a:t>c</a:t>
+            </a:r>
+            <a:r>
+              <a:rPr sz="1500" b="1">
+                <a:solidFill>
+                  <a:srgbClr val="6D71FF"/>
+                </a:solidFill>
+              </a:rPr>
+              <a:t>t</a:t>
+            </a:r>
+            <a:r>
+              <a:rPr sz="1500" b="1">
+                <a:solidFill>
+                  <a:srgbClr val="F33844"/>
+                </a:solidFill>
+              </a:rPr>
+              <a:t>s</a:t>
             </a:r>
           </a:p>
         </p:txBody>
@@ -8027,10 +8107,26 @@
             <a:r>
               <a:rPr sz="1500" b="1">
                 <a:solidFill>
-                  <a:srgbClr val="242C39"/>
-                </a:solidFill>
-              </a:rPr>
-              <a:t>cts</a:t>
+                  <a:srgbClr val="005358"/>
+                </a:solidFill>
+              </a:rPr>
+              <a:t>c</a:t>
+            </a:r>
+            <a:r>
+              <a:rPr sz="1500" b="1">
+                <a:solidFill>
+                  <a:srgbClr val="6D71FF"/>
+                </a:solidFill>
+              </a:rPr>
+              <a:t>t</a:t>
+            </a:r>
+            <a:r>
+              <a:rPr sz="1500" b="1">
+                <a:solidFill>
+                  <a:srgbClr val="F33844"/>
+                </a:solidFill>
+              </a:rPr>
+              <a:t>s</a:t>
             </a:r>
           </a:p>
         </p:txBody>
@@ -8453,10 +8549,26 @@
             <a:r>
               <a:rPr sz="1500" b="1">
                 <a:solidFill>
-                  <a:srgbClr val="242C39"/>
-                </a:solidFill>
-              </a:rPr>
-              <a:t>cts</a:t>
+                  <a:srgbClr val="005358"/>
+                </a:solidFill>
+              </a:rPr>
+              <a:t>c</a:t>
+            </a:r>
+            <a:r>
+              <a:rPr sz="1500" b="1">
+                <a:solidFill>
+                  <a:srgbClr val="6D71FF"/>
+                </a:solidFill>
+              </a:rPr>
+              <a:t>t</a:t>
+            </a:r>
+            <a:r>
+              <a:rPr sz="1500" b="1">
+                <a:solidFill>
+                  <a:srgbClr val="F33844"/>
+                </a:solidFill>
+              </a:rPr>
+              <a:t>s</a:t>
             </a:r>
           </a:p>
         </p:txBody>
@@ -8879,10 +8991,26 @@
             <a:r>
               <a:rPr sz="1500" b="1">
                 <a:solidFill>
-                  <a:srgbClr val="242C39"/>
-                </a:solidFill>
-              </a:rPr>
-              <a:t>cts</a:t>
+                  <a:srgbClr val="005358"/>
+                </a:solidFill>
+              </a:rPr>
+              <a:t>c</a:t>
+            </a:r>
+            <a:r>
+              <a:rPr sz="1500" b="1">
+                <a:solidFill>
+                  <a:srgbClr val="6D71FF"/>
+                </a:solidFill>
+              </a:rPr>
+              <a:t>t</a:t>
+            </a:r>
+            <a:r>
+              <a:rPr sz="1500" b="1">
+                <a:solidFill>
+                  <a:srgbClr val="F33844"/>
+                </a:solidFill>
+              </a:rPr>
+              <a:t>s</a:t>
             </a:r>
           </a:p>
         </p:txBody>
@@ -9308,10 +9436,26 @@
             <a:r>
               <a:rPr sz="1500" b="1">
                 <a:solidFill>
-                  <a:srgbClr val="242C39"/>
-                </a:solidFill>
-              </a:rPr>
-              <a:t>cts</a:t>
+                  <a:srgbClr val="005358"/>
+                </a:solidFill>
+              </a:rPr>
+              <a:t>c</a:t>
+            </a:r>
+            <a:r>
+              <a:rPr sz="1500" b="1">
+                <a:solidFill>
+                  <a:srgbClr val="6D71FF"/>
+                </a:solidFill>
+              </a:rPr>
+              <a:t>t</a:t>
+            </a:r>
+            <a:r>
+              <a:rPr sz="1500" b="1">
+                <a:solidFill>
+                  <a:srgbClr val="F33844"/>
+                </a:solidFill>
+              </a:rPr>
+              <a:t>s</a:t>
             </a:r>
           </a:p>
         </p:txBody>
@@ -10193,10 +10337,26 @@
             <a:r>
               <a:rPr sz="1500" b="1">
                 <a:solidFill>
-                  <a:srgbClr val="242C39"/>
-                </a:solidFill>
-              </a:rPr>
-              <a:t>cts</a:t>
+                  <a:srgbClr val="005358"/>
+                </a:solidFill>
+              </a:rPr>
+              <a:t>c</a:t>
+            </a:r>
+            <a:r>
+              <a:rPr sz="1500" b="1">
+                <a:solidFill>
+                  <a:srgbClr val="6D71FF"/>
+                </a:solidFill>
+              </a:rPr>
+              <a:t>t</a:t>
+            </a:r>
+            <a:r>
+              <a:rPr sz="1500" b="1">
+                <a:solidFill>
+                  <a:srgbClr val="F33844"/>
+                </a:solidFill>
+              </a:rPr>
+              <a:t>s</a:t>
             </a:r>
           </a:p>
         </p:txBody>
@@ -10902,10 +11062,26 @@
             <a:r>
               <a:rPr sz="1500" b="1">
                 <a:solidFill>
-                  <a:srgbClr val="242C39"/>
-                </a:solidFill>
-              </a:rPr>
-              <a:t>cts</a:t>
+                  <a:srgbClr val="005358"/>
+                </a:solidFill>
+              </a:rPr>
+              <a:t>c</a:t>
+            </a:r>
+            <a:r>
+              <a:rPr sz="1500" b="1">
+                <a:solidFill>
+                  <a:srgbClr val="6D71FF"/>
+                </a:solidFill>
+              </a:rPr>
+              <a:t>t</a:t>
+            </a:r>
+            <a:r>
+              <a:rPr sz="1500" b="1">
+                <a:solidFill>
+                  <a:srgbClr val="F33844"/>
+                </a:solidFill>
+              </a:rPr>
+              <a:t>s</a:t>
             </a:r>
           </a:p>
         </p:txBody>
@@ -11328,10 +11504,26 @@
             <a:r>
               <a:rPr sz="1500" b="1">
                 <a:solidFill>
-                  <a:srgbClr val="242C39"/>
-                </a:solidFill>
-              </a:rPr>
-              <a:t>cts</a:t>
+                  <a:srgbClr val="005358"/>
+                </a:solidFill>
+              </a:rPr>
+              <a:t>c</a:t>
+            </a:r>
+            <a:r>
+              <a:rPr sz="1500" b="1">
+                <a:solidFill>
+                  <a:srgbClr val="6D71FF"/>
+                </a:solidFill>
+              </a:rPr>
+              <a:t>t</a:t>
+            </a:r>
+            <a:r>
+              <a:rPr sz="1500" b="1">
+                <a:solidFill>
+                  <a:srgbClr val="F33844"/>
+                </a:solidFill>
+              </a:rPr>
+              <a:t>s</a:t>
             </a:r>
           </a:p>
         </p:txBody>
@@ -11754,10 +11946,26 @@
             <a:r>
               <a:rPr sz="1500" b="1">
                 <a:solidFill>
-                  <a:srgbClr val="242C39"/>
-                </a:solidFill>
-              </a:rPr>
-              <a:t>cts</a:t>
+                  <a:srgbClr val="005358"/>
+                </a:solidFill>
+              </a:rPr>
+              <a:t>c</a:t>
+            </a:r>
+            <a:r>
+              <a:rPr sz="1500" b="1">
+                <a:solidFill>
+                  <a:srgbClr val="6D71FF"/>
+                </a:solidFill>
+              </a:rPr>
+              <a:t>t</a:t>
+            </a:r>
+            <a:r>
+              <a:rPr sz="1500" b="1">
+                <a:solidFill>
+                  <a:srgbClr val="F33844"/>
+                </a:solidFill>
+              </a:rPr>
+              <a:t>s</a:t>
             </a:r>
           </a:p>
         </p:txBody>
@@ -12466,10 +12674,26 @@
             <a:r>
               <a:rPr sz="1500" b="1">
                 <a:solidFill>
-                  <a:srgbClr val="242C39"/>
-                </a:solidFill>
-              </a:rPr>
-              <a:t>cts</a:t>
+                  <a:srgbClr val="005358"/>
+                </a:solidFill>
+              </a:rPr>
+              <a:t>c</a:t>
+            </a:r>
+            <a:r>
+              <a:rPr sz="1500" b="1">
+                <a:solidFill>
+                  <a:srgbClr val="6D71FF"/>
+                </a:solidFill>
+              </a:rPr>
+              <a:t>t</a:t>
+            </a:r>
+            <a:r>
+              <a:rPr sz="1500" b="1">
+                <a:solidFill>
+                  <a:srgbClr val="F33844"/>
+                </a:solidFill>
+              </a:rPr>
+              <a:t>s</a:t>
             </a:r>
           </a:p>
         </p:txBody>
@@ -12892,10 +13116,26 @@
             <a:r>
               <a:rPr sz="1500" b="1">
                 <a:solidFill>
-                  <a:srgbClr val="242C39"/>
-                </a:solidFill>
-              </a:rPr>
-              <a:t>cts</a:t>
+                  <a:srgbClr val="005358"/>
+                </a:solidFill>
+              </a:rPr>
+              <a:t>c</a:t>
+            </a:r>
+            <a:r>
+              <a:rPr sz="1500" b="1">
+                <a:solidFill>
+                  <a:srgbClr val="6D71FF"/>
+                </a:solidFill>
+              </a:rPr>
+              <a:t>t</a:t>
+            </a:r>
+            <a:r>
+              <a:rPr sz="1500" b="1">
+                <a:solidFill>
+                  <a:srgbClr val="F33844"/>
+                </a:solidFill>
+              </a:rPr>
+              <a:t>s</a:t>
             </a:r>
           </a:p>
         </p:txBody>
@@ -13318,10 +13558,26 @@
             <a:r>
               <a:rPr sz="1500" b="1">
                 <a:solidFill>
-                  <a:srgbClr val="242C39"/>
-                </a:solidFill>
-              </a:rPr>
-              <a:t>cts</a:t>
+                  <a:srgbClr val="005358"/>
+                </a:solidFill>
+              </a:rPr>
+              <a:t>c</a:t>
+            </a:r>
+            <a:r>
+              <a:rPr sz="1500" b="1">
+                <a:solidFill>
+                  <a:srgbClr val="6D71FF"/>
+                </a:solidFill>
+              </a:rPr>
+              <a:t>t</a:t>
+            </a:r>
+            <a:r>
+              <a:rPr sz="1500" b="1">
+                <a:solidFill>
+                  <a:srgbClr val="F33844"/>
+                </a:solidFill>
+              </a:rPr>
+              <a:t>s</a:t>
             </a:r>
           </a:p>
         </p:txBody>
@@ -14027,10 +14283,26 @@
             <a:r>
               <a:rPr sz="1500" b="1">
                 <a:solidFill>
-                  <a:srgbClr val="242C39"/>
-                </a:solidFill>
-              </a:rPr>
-              <a:t>cts</a:t>
+                  <a:srgbClr val="005358"/>
+                </a:solidFill>
+              </a:rPr>
+              <a:t>c</a:t>
+            </a:r>
+            <a:r>
+              <a:rPr sz="1500" b="1">
+                <a:solidFill>
+                  <a:srgbClr val="6D71FF"/>
+                </a:solidFill>
+              </a:rPr>
+              <a:t>t</a:t>
+            </a:r>
+            <a:r>
+              <a:rPr sz="1500" b="1">
+                <a:solidFill>
+                  <a:srgbClr val="F33844"/>
+                </a:solidFill>
+              </a:rPr>
+              <a:t>s</a:t>
             </a:r>
           </a:p>
         </p:txBody>
@@ -16323,10 +16595,26 @@
             <a:r>
               <a:rPr sz="1500" b="1">
                 <a:solidFill>
-                  <a:srgbClr val="242C39"/>
-                </a:solidFill>
-              </a:rPr>
-              <a:t>cts</a:t>
+                  <a:srgbClr val="005358"/>
+                </a:solidFill>
+              </a:rPr>
+              <a:t>c</a:t>
+            </a:r>
+            <a:r>
+              <a:rPr sz="1500" b="1">
+                <a:solidFill>
+                  <a:srgbClr val="6D71FF"/>
+                </a:solidFill>
+              </a:rPr>
+              <a:t>t</a:t>
+            </a:r>
+            <a:r>
+              <a:rPr sz="1500" b="1">
+                <a:solidFill>
+                  <a:srgbClr val="F33844"/>
+                </a:solidFill>
+              </a:rPr>
+              <a:t>s</a:t>
             </a:r>
           </a:p>
         </p:txBody>
@@ -18513,10 +18801,26 @@
             <a:r>
               <a:rPr sz="1500" b="1">
                 <a:solidFill>
-                  <a:srgbClr val="242C39"/>
-                </a:solidFill>
-              </a:rPr>
-              <a:t>cts</a:t>
+                  <a:srgbClr val="005358"/>
+                </a:solidFill>
+              </a:rPr>
+              <a:t>c</a:t>
+            </a:r>
+            <a:r>
+              <a:rPr sz="1500" b="1">
+                <a:solidFill>
+                  <a:srgbClr val="6D71FF"/>
+                </a:solidFill>
+              </a:rPr>
+              <a:t>t</a:t>
+            </a:r>
+            <a:r>
+              <a:rPr sz="1500" b="1">
+                <a:solidFill>
+                  <a:srgbClr val="F33844"/>
+                </a:solidFill>
+              </a:rPr>
+              <a:t>s</a:t>
             </a:r>
           </a:p>
         </p:txBody>
@@ -19878,10 +20182,26 @@
             <a:r>
               <a:rPr sz="1500" b="1">
                 <a:solidFill>
-                  <a:srgbClr val="242C39"/>
-                </a:solidFill>
-              </a:rPr>
-              <a:t>cts</a:t>
+                  <a:srgbClr val="005358"/>
+                </a:solidFill>
+              </a:rPr>
+              <a:t>c</a:t>
+            </a:r>
+            <a:r>
+              <a:rPr sz="1500" b="1">
+                <a:solidFill>
+                  <a:srgbClr val="6D71FF"/>
+                </a:solidFill>
+              </a:rPr>
+              <a:t>t</a:t>
+            </a:r>
+            <a:r>
+              <a:rPr sz="1500" b="1">
+                <a:solidFill>
+                  <a:srgbClr val="F33844"/>
+                </a:solidFill>
+              </a:rPr>
+              <a:t>s</a:t>
             </a:r>
           </a:p>
         </p:txBody>
@@ -20304,10 +20624,26 @@
             <a:r>
               <a:rPr sz="1500" b="1">
                 <a:solidFill>
-                  <a:srgbClr val="242C39"/>
-                </a:solidFill>
-              </a:rPr>
-              <a:t>cts</a:t>
+                  <a:srgbClr val="005358"/>
+                </a:solidFill>
+              </a:rPr>
+              <a:t>c</a:t>
+            </a:r>
+            <a:r>
+              <a:rPr sz="1500" b="1">
+                <a:solidFill>
+                  <a:srgbClr val="6D71FF"/>
+                </a:solidFill>
+              </a:rPr>
+              <a:t>t</a:t>
+            </a:r>
+            <a:r>
+              <a:rPr sz="1500" b="1">
+                <a:solidFill>
+                  <a:srgbClr val="F33844"/>
+                </a:solidFill>
+              </a:rPr>
+              <a:t>s</a:t>
             </a:r>
           </a:p>
         </p:txBody>
@@ -20733,10 +21069,26 @@
             <a:r>
               <a:rPr sz="1500" b="1">
                 <a:solidFill>
-                  <a:srgbClr val="242C39"/>
-                </a:solidFill>
-              </a:rPr>
-              <a:t>cts</a:t>
+                  <a:srgbClr val="005358"/>
+                </a:solidFill>
+              </a:rPr>
+              <a:t>c</a:t>
+            </a:r>
+            <a:r>
+              <a:rPr sz="1500" b="1">
+                <a:solidFill>
+                  <a:srgbClr val="6D71FF"/>
+                </a:solidFill>
+              </a:rPr>
+              <a:t>t</a:t>
+            </a:r>
+            <a:r>
+              <a:rPr sz="1500" b="1">
+                <a:solidFill>
+                  <a:srgbClr val="F33844"/>
+                </a:solidFill>
+              </a:rPr>
+              <a:t>s</a:t>
             </a:r>
           </a:p>
         </p:txBody>
@@ -21162,10 +21514,26 @@
             <a:r>
               <a:rPr sz="1500" b="1">
                 <a:solidFill>
-                  <a:srgbClr val="242C39"/>
-                </a:solidFill>
-              </a:rPr>
-              <a:t>cts</a:t>
+                  <a:srgbClr val="005358"/>
+                </a:solidFill>
+              </a:rPr>
+              <a:t>c</a:t>
+            </a:r>
+            <a:r>
+              <a:rPr sz="1500" b="1">
+                <a:solidFill>
+                  <a:srgbClr val="6D71FF"/>
+                </a:solidFill>
+              </a:rPr>
+              <a:t>t</a:t>
+            </a:r>
+            <a:r>
+              <a:rPr sz="1500" b="1">
+                <a:solidFill>
+                  <a:srgbClr val="F33844"/>
+                </a:solidFill>
+              </a:rPr>
+              <a:t>s</a:t>
             </a:r>
           </a:p>
         </p:txBody>
@@ -21588,10 +21956,26 @@
             <a:r>
               <a:rPr sz="1500" b="1">
                 <a:solidFill>
-                  <a:srgbClr val="242C39"/>
-                </a:solidFill>
-              </a:rPr>
-              <a:t>cts</a:t>
+                  <a:srgbClr val="005358"/>
+                </a:solidFill>
+              </a:rPr>
+              <a:t>c</a:t>
+            </a:r>
+            <a:r>
+              <a:rPr sz="1500" b="1">
+                <a:solidFill>
+                  <a:srgbClr val="6D71FF"/>
+                </a:solidFill>
+              </a:rPr>
+              <a:t>t</a:t>
+            </a:r>
+            <a:r>
+              <a:rPr sz="1500" b="1">
+                <a:solidFill>
+                  <a:srgbClr val="F33844"/>
+                </a:solidFill>
+              </a:rPr>
+              <a:t>s</a:t>
             </a:r>
           </a:p>
         </p:txBody>

</xml_diff>

<commit_message>
Use the real CTS logo on the light pages
Danica supplied the artwork, so the text wordmark that stood in for it is gone.
The file is trimmed to its ink and held in deck/assets/cts-logo.png, and sits
1.05 inches wide in the top right of all 24 light pages, clear of the eyebrow
and the title.

It stays off the dark pages: the lettering is black and would not read on navy,
and those pages already carry the white lockup.

Co-Authored-By: Claude Opus 5 <noreply@anthropic.com>
Claude-Session: https://claude.ai/code/session_01CVBAFohBCYXt1ufjTVDiZj
</commit_message>
<xml_diff>
--- a/deck/CTS Monthly Business Review - 30092026.pptx
+++ b/deck/CTS Monthly Business Review - 30092026.pptx
@@ -5588,90 +5588,30 @@
           </a:p>
         </p:txBody>
       </p:sp>
-      <p:sp>
-        <p:nvSpPr>
-          <p:cNvPr id="26" name="cts mark"/>
-          <p:cNvSpPr txBox="1"/>
-          <p:nvPr/>
-        </p:nvSpPr>
-        <p:spPr>
-          <a:xfrm>
-            <a:off x="7726679" y="155448"/>
-            <a:ext cx="914400" cy="274320"/>
-          </a:xfrm>
-          <a:prstGeom prst="rect">
-            <a:avLst/>
-          </a:prstGeom>
-          <a:noFill/>
-        </p:spPr>
-        <p:txBody>
-          <a:bodyPr wrap="none" lIns="0" rIns="0" tIns="0" bIns="0">
-            <a:spAutoFit/>
-          </a:bodyPr>
-          <a:lstStyle/>
-          <a:p>
-            <a:pPr algn="r"/>
-            <a:r>
-              <a:rPr sz="1500" b="1">
-                <a:solidFill>
-                  <a:srgbClr val="005358"/>
-                </a:solidFill>
-              </a:rPr>
-              <a:t>c</a:t>
-            </a:r>
-            <a:r>
-              <a:rPr sz="1500" b="1">
-                <a:solidFill>
-                  <a:srgbClr val="6D71FF"/>
-                </a:solidFill>
-              </a:rPr>
-              <a:t>t</a:t>
-            </a:r>
-            <a:r>
-              <a:rPr sz="1500" b="1">
-                <a:solidFill>
-                  <a:srgbClr val="F33844"/>
-                </a:solidFill>
-              </a:rPr>
-              <a:t>s</a:t>
-            </a:r>
-          </a:p>
-        </p:txBody>
-      </p:sp>
-      <p:sp>
-        <p:nvSpPr>
-          <p:cNvPr id="27" name="cts mark sub"/>
-          <p:cNvSpPr txBox="1"/>
-          <p:nvPr/>
-        </p:nvSpPr>
-        <p:spPr>
-          <a:xfrm>
-            <a:off x="7726679" y="384048"/>
-            <a:ext cx="914400" cy="164592"/>
-          </a:xfrm>
-          <a:prstGeom prst="rect">
-            <a:avLst/>
-          </a:prstGeom>
-          <a:noFill/>
-        </p:spPr>
-        <p:txBody>
-          <a:bodyPr wrap="none" lIns="0" rIns="0" tIns="0" bIns="0">
-            <a:spAutoFit/>
-          </a:bodyPr>
-          <a:lstStyle/>
-          <a:p>
-            <a:pPr algn="r"/>
-            <a:r>
-              <a:rPr sz="650">
-                <a:solidFill>
-                  <a:srgbClr val="6B7585"/>
-                </a:solidFill>
-              </a:rPr>
-              <a:t>Seamless AV</a:t>
-            </a:r>
-          </a:p>
-        </p:txBody>
-      </p:sp>
+      <p:pic>
+        <p:nvPicPr>
+          <p:cNvPr id="26" name="cts logo" descr="cts-logo.png"/>
+          <p:cNvPicPr>
+            <a:picLocks noChangeAspect="1"/>
+          </p:cNvPicPr>
+          <p:nvPr/>
+        </p:nvPicPr>
+        <p:blipFill>
+          <a:blip r:embed="rId4"/>
+          <a:stretch>
+            <a:fillRect/>
+          </a:stretch>
+        </p:blipFill>
+        <p:spPr>
+          <a:xfrm>
+            <a:off x="7680959" y="182880"/>
+            <a:ext cx="960120" cy="539696"/>
+          </a:xfrm>
+          <a:prstGeom prst="rect">
+            <a:avLst/>
+          </a:prstGeom>
+        </p:spPr>
+      </p:pic>
     </p:spTree>
   </p:cSld>
   <p:clrMapOvr>
@@ -6030,90 +5970,30 @@
           </a:p>
         </p:txBody>
       </p:sp>
-      <p:sp>
-        <p:nvSpPr>
-          <p:cNvPr id="26" name="cts mark"/>
-          <p:cNvSpPr txBox="1"/>
-          <p:nvPr/>
-        </p:nvSpPr>
-        <p:spPr>
-          <a:xfrm>
-            <a:off x="7726679" y="155448"/>
-            <a:ext cx="914400" cy="274320"/>
-          </a:xfrm>
-          <a:prstGeom prst="rect">
-            <a:avLst/>
-          </a:prstGeom>
-          <a:noFill/>
-        </p:spPr>
-        <p:txBody>
-          <a:bodyPr wrap="none" lIns="0" rIns="0" tIns="0" bIns="0">
-            <a:spAutoFit/>
-          </a:bodyPr>
-          <a:lstStyle/>
-          <a:p>
-            <a:pPr algn="r"/>
-            <a:r>
-              <a:rPr sz="1500" b="1">
-                <a:solidFill>
-                  <a:srgbClr val="005358"/>
-                </a:solidFill>
-              </a:rPr>
-              <a:t>c</a:t>
-            </a:r>
-            <a:r>
-              <a:rPr sz="1500" b="1">
-                <a:solidFill>
-                  <a:srgbClr val="6D71FF"/>
-                </a:solidFill>
-              </a:rPr>
-              <a:t>t</a:t>
-            </a:r>
-            <a:r>
-              <a:rPr sz="1500" b="1">
-                <a:solidFill>
-                  <a:srgbClr val="F33844"/>
-                </a:solidFill>
-              </a:rPr>
-              <a:t>s</a:t>
-            </a:r>
-          </a:p>
-        </p:txBody>
-      </p:sp>
-      <p:sp>
-        <p:nvSpPr>
-          <p:cNvPr id="27" name="cts mark sub"/>
-          <p:cNvSpPr txBox="1"/>
-          <p:nvPr/>
-        </p:nvSpPr>
-        <p:spPr>
-          <a:xfrm>
-            <a:off x="7726679" y="384048"/>
-            <a:ext cx="914400" cy="164592"/>
-          </a:xfrm>
-          <a:prstGeom prst="rect">
-            <a:avLst/>
-          </a:prstGeom>
-          <a:noFill/>
-        </p:spPr>
-        <p:txBody>
-          <a:bodyPr wrap="none" lIns="0" rIns="0" tIns="0" bIns="0">
-            <a:spAutoFit/>
-          </a:bodyPr>
-          <a:lstStyle/>
-          <a:p>
-            <a:pPr algn="r"/>
-            <a:r>
-              <a:rPr sz="650">
-                <a:solidFill>
-                  <a:srgbClr val="6B7585"/>
-                </a:solidFill>
-              </a:rPr>
-              <a:t>Seamless AV</a:t>
-            </a:r>
-          </a:p>
-        </p:txBody>
-      </p:sp>
+      <p:pic>
+        <p:nvPicPr>
+          <p:cNvPr id="26" name="cts logo" descr="cts-logo.png"/>
+          <p:cNvPicPr>
+            <a:picLocks noChangeAspect="1"/>
+          </p:cNvPicPr>
+          <p:nvPr/>
+        </p:nvPicPr>
+        <p:blipFill>
+          <a:blip r:embed="rId4"/>
+          <a:stretch>
+            <a:fillRect/>
+          </a:stretch>
+        </p:blipFill>
+        <p:spPr>
+          <a:xfrm>
+            <a:off x="7680959" y="182880"/>
+            <a:ext cx="960120" cy="539696"/>
+          </a:xfrm>
+          <a:prstGeom prst="rect">
+            <a:avLst/>
+          </a:prstGeom>
+        </p:spPr>
+      </p:pic>
     </p:spTree>
   </p:cSld>
   <p:clrMapOvr>
@@ -6472,90 +6352,30 @@
           </a:p>
         </p:txBody>
       </p:sp>
-      <p:sp>
-        <p:nvSpPr>
-          <p:cNvPr id="26" name="cts mark"/>
-          <p:cNvSpPr txBox="1"/>
-          <p:nvPr/>
-        </p:nvSpPr>
-        <p:spPr>
-          <a:xfrm>
-            <a:off x="7726679" y="155448"/>
-            <a:ext cx="914400" cy="274320"/>
-          </a:xfrm>
-          <a:prstGeom prst="rect">
-            <a:avLst/>
-          </a:prstGeom>
-          <a:noFill/>
-        </p:spPr>
-        <p:txBody>
-          <a:bodyPr wrap="none" lIns="0" rIns="0" tIns="0" bIns="0">
-            <a:spAutoFit/>
-          </a:bodyPr>
-          <a:lstStyle/>
-          <a:p>
-            <a:pPr algn="r"/>
-            <a:r>
-              <a:rPr sz="1500" b="1">
-                <a:solidFill>
-                  <a:srgbClr val="005358"/>
-                </a:solidFill>
-              </a:rPr>
-              <a:t>c</a:t>
-            </a:r>
-            <a:r>
-              <a:rPr sz="1500" b="1">
-                <a:solidFill>
-                  <a:srgbClr val="6D71FF"/>
-                </a:solidFill>
-              </a:rPr>
-              <a:t>t</a:t>
-            </a:r>
-            <a:r>
-              <a:rPr sz="1500" b="1">
-                <a:solidFill>
-                  <a:srgbClr val="F33844"/>
-                </a:solidFill>
-              </a:rPr>
-              <a:t>s</a:t>
-            </a:r>
-          </a:p>
-        </p:txBody>
-      </p:sp>
-      <p:sp>
-        <p:nvSpPr>
-          <p:cNvPr id="27" name="cts mark sub"/>
-          <p:cNvSpPr txBox="1"/>
-          <p:nvPr/>
-        </p:nvSpPr>
-        <p:spPr>
-          <a:xfrm>
-            <a:off x="7726679" y="384048"/>
-            <a:ext cx="914400" cy="164592"/>
-          </a:xfrm>
-          <a:prstGeom prst="rect">
-            <a:avLst/>
-          </a:prstGeom>
-          <a:noFill/>
-        </p:spPr>
-        <p:txBody>
-          <a:bodyPr wrap="none" lIns="0" rIns="0" tIns="0" bIns="0">
-            <a:spAutoFit/>
-          </a:bodyPr>
-          <a:lstStyle/>
-          <a:p>
-            <a:pPr algn="r"/>
-            <a:r>
-              <a:rPr sz="650">
-                <a:solidFill>
-                  <a:srgbClr val="6B7585"/>
-                </a:solidFill>
-              </a:rPr>
-              <a:t>Seamless AV</a:t>
-            </a:r>
-          </a:p>
-        </p:txBody>
-      </p:sp>
+      <p:pic>
+        <p:nvPicPr>
+          <p:cNvPr id="26" name="cts logo" descr="cts-logo.png"/>
+          <p:cNvPicPr>
+            <a:picLocks noChangeAspect="1"/>
+          </p:cNvPicPr>
+          <p:nvPr/>
+        </p:nvPicPr>
+        <p:blipFill>
+          <a:blip r:embed="rId4"/>
+          <a:stretch>
+            <a:fillRect/>
+          </a:stretch>
+        </p:blipFill>
+        <p:spPr>
+          <a:xfrm>
+            <a:off x="7680959" y="182880"/>
+            <a:ext cx="960120" cy="539696"/>
+          </a:xfrm>
+          <a:prstGeom prst="rect">
+            <a:avLst/>
+          </a:prstGeom>
+        </p:spPr>
+      </p:pic>
     </p:spTree>
   </p:cSld>
   <p:clrMapOvr>
@@ -6914,90 +6734,30 @@
           </a:p>
         </p:txBody>
       </p:sp>
-      <p:sp>
-        <p:nvSpPr>
-          <p:cNvPr id="26" name="cts mark"/>
-          <p:cNvSpPr txBox="1"/>
-          <p:nvPr/>
-        </p:nvSpPr>
-        <p:spPr>
-          <a:xfrm>
-            <a:off x="7726679" y="155448"/>
-            <a:ext cx="914400" cy="274320"/>
-          </a:xfrm>
-          <a:prstGeom prst="rect">
-            <a:avLst/>
-          </a:prstGeom>
-          <a:noFill/>
-        </p:spPr>
-        <p:txBody>
-          <a:bodyPr wrap="none" lIns="0" rIns="0" tIns="0" bIns="0">
-            <a:spAutoFit/>
-          </a:bodyPr>
-          <a:lstStyle/>
-          <a:p>
-            <a:pPr algn="r"/>
-            <a:r>
-              <a:rPr sz="1500" b="1">
-                <a:solidFill>
-                  <a:srgbClr val="005358"/>
-                </a:solidFill>
-              </a:rPr>
-              <a:t>c</a:t>
-            </a:r>
-            <a:r>
-              <a:rPr sz="1500" b="1">
-                <a:solidFill>
-                  <a:srgbClr val="6D71FF"/>
-                </a:solidFill>
-              </a:rPr>
-              <a:t>t</a:t>
-            </a:r>
-            <a:r>
-              <a:rPr sz="1500" b="1">
-                <a:solidFill>
-                  <a:srgbClr val="F33844"/>
-                </a:solidFill>
-              </a:rPr>
-              <a:t>s</a:t>
-            </a:r>
-          </a:p>
-        </p:txBody>
-      </p:sp>
-      <p:sp>
-        <p:nvSpPr>
-          <p:cNvPr id="27" name="cts mark sub"/>
-          <p:cNvSpPr txBox="1"/>
-          <p:nvPr/>
-        </p:nvSpPr>
-        <p:spPr>
-          <a:xfrm>
-            <a:off x="7726679" y="384048"/>
-            <a:ext cx="914400" cy="164592"/>
-          </a:xfrm>
-          <a:prstGeom prst="rect">
-            <a:avLst/>
-          </a:prstGeom>
-          <a:noFill/>
-        </p:spPr>
-        <p:txBody>
-          <a:bodyPr wrap="none" lIns="0" rIns="0" tIns="0" bIns="0">
-            <a:spAutoFit/>
-          </a:bodyPr>
-          <a:lstStyle/>
-          <a:p>
-            <a:pPr algn="r"/>
-            <a:r>
-              <a:rPr sz="650">
-                <a:solidFill>
-                  <a:srgbClr val="6B7585"/>
-                </a:solidFill>
-              </a:rPr>
-              <a:t>Seamless AV</a:t>
-            </a:r>
-          </a:p>
-        </p:txBody>
-      </p:sp>
+      <p:pic>
+        <p:nvPicPr>
+          <p:cNvPr id="26" name="cts logo" descr="cts-logo.png"/>
+          <p:cNvPicPr>
+            <a:picLocks noChangeAspect="1"/>
+          </p:cNvPicPr>
+          <p:nvPr/>
+        </p:nvPicPr>
+        <p:blipFill>
+          <a:blip r:embed="rId4"/>
+          <a:stretch>
+            <a:fillRect/>
+          </a:stretch>
+        </p:blipFill>
+        <p:spPr>
+          <a:xfrm>
+            <a:off x="7680959" y="182880"/>
+            <a:ext cx="960120" cy="539696"/>
+          </a:xfrm>
+          <a:prstGeom prst="rect">
+            <a:avLst/>
+          </a:prstGeom>
+        </p:spPr>
+      </p:pic>
     </p:spTree>
   </p:cSld>
   <p:clrMapOvr>
@@ -7356,90 +7116,30 @@
           </a:p>
         </p:txBody>
       </p:sp>
-      <p:sp>
-        <p:nvSpPr>
-          <p:cNvPr id="26" name="cts mark"/>
-          <p:cNvSpPr txBox="1"/>
-          <p:nvPr/>
-        </p:nvSpPr>
-        <p:spPr>
-          <a:xfrm>
-            <a:off x="7726679" y="155448"/>
-            <a:ext cx="914400" cy="274320"/>
-          </a:xfrm>
-          <a:prstGeom prst="rect">
-            <a:avLst/>
-          </a:prstGeom>
-          <a:noFill/>
-        </p:spPr>
-        <p:txBody>
-          <a:bodyPr wrap="none" lIns="0" rIns="0" tIns="0" bIns="0">
-            <a:spAutoFit/>
-          </a:bodyPr>
-          <a:lstStyle/>
-          <a:p>
-            <a:pPr algn="r"/>
-            <a:r>
-              <a:rPr sz="1500" b="1">
-                <a:solidFill>
-                  <a:srgbClr val="005358"/>
-                </a:solidFill>
-              </a:rPr>
-              <a:t>c</a:t>
-            </a:r>
-            <a:r>
-              <a:rPr sz="1500" b="1">
-                <a:solidFill>
-                  <a:srgbClr val="6D71FF"/>
-                </a:solidFill>
-              </a:rPr>
-              <a:t>t</a:t>
-            </a:r>
-            <a:r>
-              <a:rPr sz="1500" b="1">
-                <a:solidFill>
-                  <a:srgbClr val="F33844"/>
-                </a:solidFill>
-              </a:rPr>
-              <a:t>s</a:t>
-            </a:r>
-          </a:p>
-        </p:txBody>
-      </p:sp>
-      <p:sp>
-        <p:nvSpPr>
-          <p:cNvPr id="27" name="cts mark sub"/>
-          <p:cNvSpPr txBox="1"/>
-          <p:nvPr/>
-        </p:nvSpPr>
-        <p:spPr>
-          <a:xfrm>
-            <a:off x="7726679" y="384048"/>
-            <a:ext cx="914400" cy="164592"/>
-          </a:xfrm>
-          <a:prstGeom prst="rect">
-            <a:avLst/>
-          </a:prstGeom>
-          <a:noFill/>
-        </p:spPr>
-        <p:txBody>
-          <a:bodyPr wrap="none" lIns="0" rIns="0" tIns="0" bIns="0">
-            <a:spAutoFit/>
-          </a:bodyPr>
-          <a:lstStyle/>
-          <a:p>
-            <a:pPr algn="r"/>
-            <a:r>
-              <a:rPr sz="650">
-                <a:solidFill>
-                  <a:srgbClr val="6B7585"/>
-                </a:solidFill>
-              </a:rPr>
-              <a:t>Seamless AV</a:t>
-            </a:r>
-          </a:p>
-        </p:txBody>
-      </p:sp>
+      <p:pic>
+        <p:nvPicPr>
+          <p:cNvPr id="26" name="cts logo" descr="cts-logo.png"/>
+          <p:cNvPicPr>
+            <a:picLocks noChangeAspect="1"/>
+          </p:cNvPicPr>
+          <p:nvPr/>
+        </p:nvPicPr>
+        <p:blipFill>
+          <a:blip r:embed="rId4"/>
+          <a:stretch>
+            <a:fillRect/>
+          </a:stretch>
+        </p:blipFill>
+        <p:spPr>
+          <a:xfrm>
+            <a:off x="7680959" y="182880"/>
+            <a:ext cx="960120" cy="539696"/>
+          </a:xfrm>
+          <a:prstGeom prst="rect">
+            <a:avLst/>
+          </a:prstGeom>
+        </p:spPr>
+      </p:pic>
     </p:spTree>
   </p:cSld>
   <p:clrMapOvr>
@@ -8081,90 +7781,30 @@
           </a:p>
         </p:txBody>
       </p:sp>
-      <p:sp>
-        <p:nvSpPr>
-          <p:cNvPr id="26" name="cts mark"/>
-          <p:cNvSpPr txBox="1"/>
-          <p:nvPr/>
-        </p:nvSpPr>
-        <p:spPr>
-          <a:xfrm>
-            <a:off x="7726679" y="155448"/>
-            <a:ext cx="914400" cy="274320"/>
-          </a:xfrm>
-          <a:prstGeom prst="rect">
-            <a:avLst/>
-          </a:prstGeom>
-          <a:noFill/>
-        </p:spPr>
-        <p:txBody>
-          <a:bodyPr wrap="none" lIns="0" rIns="0" tIns="0" bIns="0">
-            <a:spAutoFit/>
-          </a:bodyPr>
-          <a:lstStyle/>
-          <a:p>
-            <a:pPr algn="r"/>
-            <a:r>
-              <a:rPr sz="1500" b="1">
-                <a:solidFill>
-                  <a:srgbClr val="005358"/>
-                </a:solidFill>
-              </a:rPr>
-              <a:t>c</a:t>
-            </a:r>
-            <a:r>
-              <a:rPr sz="1500" b="1">
-                <a:solidFill>
-                  <a:srgbClr val="6D71FF"/>
-                </a:solidFill>
-              </a:rPr>
-              <a:t>t</a:t>
-            </a:r>
-            <a:r>
-              <a:rPr sz="1500" b="1">
-                <a:solidFill>
-                  <a:srgbClr val="F33844"/>
-                </a:solidFill>
-              </a:rPr>
-              <a:t>s</a:t>
-            </a:r>
-          </a:p>
-        </p:txBody>
-      </p:sp>
-      <p:sp>
-        <p:nvSpPr>
-          <p:cNvPr id="27" name="cts mark sub"/>
-          <p:cNvSpPr txBox="1"/>
-          <p:nvPr/>
-        </p:nvSpPr>
-        <p:spPr>
-          <a:xfrm>
-            <a:off x="7726679" y="384048"/>
-            <a:ext cx="914400" cy="164592"/>
-          </a:xfrm>
-          <a:prstGeom prst="rect">
-            <a:avLst/>
-          </a:prstGeom>
-          <a:noFill/>
-        </p:spPr>
-        <p:txBody>
-          <a:bodyPr wrap="none" lIns="0" rIns="0" tIns="0" bIns="0">
-            <a:spAutoFit/>
-          </a:bodyPr>
-          <a:lstStyle/>
-          <a:p>
-            <a:pPr algn="r"/>
-            <a:r>
-              <a:rPr sz="650">
-                <a:solidFill>
-                  <a:srgbClr val="6B7585"/>
-                </a:solidFill>
-              </a:rPr>
-              <a:t>Seamless AV</a:t>
-            </a:r>
-          </a:p>
-        </p:txBody>
-      </p:sp>
+      <p:pic>
+        <p:nvPicPr>
+          <p:cNvPr id="26" name="cts logo" descr="cts-logo.png"/>
+          <p:cNvPicPr>
+            <a:picLocks noChangeAspect="1"/>
+          </p:cNvPicPr>
+          <p:nvPr/>
+        </p:nvPicPr>
+        <p:blipFill>
+          <a:blip r:embed="rId4"/>
+          <a:stretch>
+            <a:fillRect/>
+          </a:stretch>
+        </p:blipFill>
+        <p:spPr>
+          <a:xfrm>
+            <a:off x="7680959" y="182880"/>
+            <a:ext cx="960120" cy="539696"/>
+          </a:xfrm>
+          <a:prstGeom prst="rect">
+            <a:avLst/>
+          </a:prstGeom>
+        </p:spPr>
+      </p:pic>
     </p:spTree>
   </p:cSld>
   <p:clrMapOvr>
@@ -8523,90 +8163,30 @@
           </a:p>
         </p:txBody>
       </p:sp>
-      <p:sp>
-        <p:nvSpPr>
-          <p:cNvPr id="26" name="cts mark"/>
-          <p:cNvSpPr txBox="1"/>
-          <p:nvPr/>
-        </p:nvSpPr>
-        <p:spPr>
-          <a:xfrm>
-            <a:off x="7726679" y="155448"/>
-            <a:ext cx="914400" cy="274320"/>
-          </a:xfrm>
-          <a:prstGeom prst="rect">
-            <a:avLst/>
-          </a:prstGeom>
-          <a:noFill/>
-        </p:spPr>
-        <p:txBody>
-          <a:bodyPr wrap="none" lIns="0" rIns="0" tIns="0" bIns="0">
-            <a:spAutoFit/>
-          </a:bodyPr>
-          <a:lstStyle/>
-          <a:p>
-            <a:pPr algn="r"/>
-            <a:r>
-              <a:rPr sz="1500" b="1">
-                <a:solidFill>
-                  <a:srgbClr val="005358"/>
-                </a:solidFill>
-              </a:rPr>
-              <a:t>c</a:t>
-            </a:r>
-            <a:r>
-              <a:rPr sz="1500" b="1">
-                <a:solidFill>
-                  <a:srgbClr val="6D71FF"/>
-                </a:solidFill>
-              </a:rPr>
-              <a:t>t</a:t>
-            </a:r>
-            <a:r>
-              <a:rPr sz="1500" b="1">
-                <a:solidFill>
-                  <a:srgbClr val="F33844"/>
-                </a:solidFill>
-              </a:rPr>
-              <a:t>s</a:t>
-            </a:r>
-          </a:p>
-        </p:txBody>
-      </p:sp>
-      <p:sp>
-        <p:nvSpPr>
-          <p:cNvPr id="27" name="cts mark sub"/>
-          <p:cNvSpPr txBox="1"/>
-          <p:nvPr/>
-        </p:nvSpPr>
-        <p:spPr>
-          <a:xfrm>
-            <a:off x="7726679" y="384048"/>
-            <a:ext cx="914400" cy="164592"/>
-          </a:xfrm>
-          <a:prstGeom prst="rect">
-            <a:avLst/>
-          </a:prstGeom>
-          <a:noFill/>
-        </p:spPr>
-        <p:txBody>
-          <a:bodyPr wrap="none" lIns="0" rIns="0" tIns="0" bIns="0">
-            <a:spAutoFit/>
-          </a:bodyPr>
-          <a:lstStyle/>
-          <a:p>
-            <a:pPr algn="r"/>
-            <a:r>
-              <a:rPr sz="650">
-                <a:solidFill>
-                  <a:srgbClr val="6B7585"/>
-                </a:solidFill>
-              </a:rPr>
-              <a:t>Seamless AV</a:t>
-            </a:r>
-          </a:p>
-        </p:txBody>
-      </p:sp>
+      <p:pic>
+        <p:nvPicPr>
+          <p:cNvPr id="26" name="cts logo" descr="cts-logo.png"/>
+          <p:cNvPicPr>
+            <a:picLocks noChangeAspect="1"/>
+          </p:cNvPicPr>
+          <p:nvPr/>
+        </p:nvPicPr>
+        <p:blipFill>
+          <a:blip r:embed="rId4"/>
+          <a:stretch>
+            <a:fillRect/>
+          </a:stretch>
+        </p:blipFill>
+        <p:spPr>
+          <a:xfrm>
+            <a:off x="7680959" y="182880"/>
+            <a:ext cx="960120" cy="539696"/>
+          </a:xfrm>
+          <a:prstGeom prst="rect">
+            <a:avLst/>
+          </a:prstGeom>
+        </p:spPr>
+      </p:pic>
     </p:spTree>
   </p:cSld>
   <p:clrMapOvr>
@@ -8965,90 +8545,30 @@
           </a:p>
         </p:txBody>
       </p:sp>
-      <p:sp>
-        <p:nvSpPr>
-          <p:cNvPr id="26" name="cts mark"/>
-          <p:cNvSpPr txBox="1"/>
-          <p:nvPr/>
-        </p:nvSpPr>
-        <p:spPr>
-          <a:xfrm>
-            <a:off x="7726679" y="155448"/>
-            <a:ext cx="914400" cy="274320"/>
-          </a:xfrm>
-          <a:prstGeom prst="rect">
-            <a:avLst/>
-          </a:prstGeom>
-          <a:noFill/>
-        </p:spPr>
-        <p:txBody>
-          <a:bodyPr wrap="none" lIns="0" rIns="0" tIns="0" bIns="0">
-            <a:spAutoFit/>
-          </a:bodyPr>
-          <a:lstStyle/>
-          <a:p>
-            <a:pPr algn="r"/>
-            <a:r>
-              <a:rPr sz="1500" b="1">
-                <a:solidFill>
-                  <a:srgbClr val="005358"/>
-                </a:solidFill>
-              </a:rPr>
-              <a:t>c</a:t>
-            </a:r>
-            <a:r>
-              <a:rPr sz="1500" b="1">
-                <a:solidFill>
-                  <a:srgbClr val="6D71FF"/>
-                </a:solidFill>
-              </a:rPr>
-              <a:t>t</a:t>
-            </a:r>
-            <a:r>
-              <a:rPr sz="1500" b="1">
-                <a:solidFill>
-                  <a:srgbClr val="F33844"/>
-                </a:solidFill>
-              </a:rPr>
-              <a:t>s</a:t>
-            </a:r>
-          </a:p>
-        </p:txBody>
-      </p:sp>
-      <p:sp>
-        <p:nvSpPr>
-          <p:cNvPr id="27" name="cts mark sub"/>
-          <p:cNvSpPr txBox="1"/>
-          <p:nvPr/>
-        </p:nvSpPr>
-        <p:spPr>
-          <a:xfrm>
-            <a:off x="7726679" y="384048"/>
-            <a:ext cx="914400" cy="164592"/>
-          </a:xfrm>
-          <a:prstGeom prst="rect">
-            <a:avLst/>
-          </a:prstGeom>
-          <a:noFill/>
-        </p:spPr>
-        <p:txBody>
-          <a:bodyPr wrap="none" lIns="0" rIns="0" tIns="0" bIns="0">
-            <a:spAutoFit/>
-          </a:bodyPr>
-          <a:lstStyle/>
-          <a:p>
-            <a:pPr algn="r"/>
-            <a:r>
-              <a:rPr sz="650">
-                <a:solidFill>
-                  <a:srgbClr val="6B7585"/>
-                </a:solidFill>
-              </a:rPr>
-              <a:t>Seamless AV</a:t>
-            </a:r>
-          </a:p>
-        </p:txBody>
-      </p:sp>
+      <p:pic>
+        <p:nvPicPr>
+          <p:cNvPr id="26" name="cts logo" descr="cts-logo.png"/>
+          <p:cNvPicPr>
+            <a:picLocks noChangeAspect="1"/>
+          </p:cNvPicPr>
+          <p:nvPr/>
+        </p:nvPicPr>
+        <p:blipFill>
+          <a:blip r:embed="rId4"/>
+          <a:stretch>
+            <a:fillRect/>
+          </a:stretch>
+        </p:blipFill>
+        <p:spPr>
+          <a:xfrm>
+            <a:off x="7680959" y="182880"/>
+            <a:ext cx="960120" cy="539696"/>
+          </a:xfrm>
+          <a:prstGeom prst="rect">
+            <a:avLst/>
+          </a:prstGeom>
+        </p:spPr>
+      </p:pic>
     </p:spTree>
   </p:cSld>
   <p:clrMapOvr>
@@ -9410,90 +8930,30 @@
           </a:p>
         </p:txBody>
       </p:sp>
-      <p:sp>
-        <p:nvSpPr>
-          <p:cNvPr id="26" name="cts mark"/>
-          <p:cNvSpPr txBox="1"/>
-          <p:nvPr/>
-        </p:nvSpPr>
-        <p:spPr>
-          <a:xfrm>
-            <a:off x="7726679" y="155448"/>
-            <a:ext cx="914400" cy="274320"/>
-          </a:xfrm>
-          <a:prstGeom prst="rect">
-            <a:avLst/>
-          </a:prstGeom>
-          <a:noFill/>
-        </p:spPr>
-        <p:txBody>
-          <a:bodyPr wrap="none" lIns="0" rIns="0" tIns="0" bIns="0">
-            <a:spAutoFit/>
-          </a:bodyPr>
-          <a:lstStyle/>
-          <a:p>
-            <a:pPr algn="r"/>
-            <a:r>
-              <a:rPr sz="1500" b="1">
-                <a:solidFill>
-                  <a:srgbClr val="005358"/>
-                </a:solidFill>
-              </a:rPr>
-              <a:t>c</a:t>
-            </a:r>
-            <a:r>
-              <a:rPr sz="1500" b="1">
-                <a:solidFill>
-                  <a:srgbClr val="6D71FF"/>
-                </a:solidFill>
-              </a:rPr>
-              <a:t>t</a:t>
-            </a:r>
-            <a:r>
-              <a:rPr sz="1500" b="1">
-                <a:solidFill>
-                  <a:srgbClr val="F33844"/>
-                </a:solidFill>
-              </a:rPr>
-              <a:t>s</a:t>
-            </a:r>
-          </a:p>
-        </p:txBody>
-      </p:sp>
-      <p:sp>
-        <p:nvSpPr>
-          <p:cNvPr id="27" name="cts mark sub"/>
-          <p:cNvSpPr txBox="1"/>
-          <p:nvPr/>
-        </p:nvSpPr>
-        <p:spPr>
-          <a:xfrm>
-            <a:off x="7726679" y="384048"/>
-            <a:ext cx="914400" cy="164592"/>
-          </a:xfrm>
-          <a:prstGeom prst="rect">
-            <a:avLst/>
-          </a:prstGeom>
-          <a:noFill/>
-        </p:spPr>
-        <p:txBody>
-          <a:bodyPr wrap="none" lIns="0" rIns="0" tIns="0" bIns="0">
-            <a:spAutoFit/>
-          </a:bodyPr>
-          <a:lstStyle/>
-          <a:p>
-            <a:pPr algn="r"/>
-            <a:r>
-              <a:rPr sz="650">
-                <a:solidFill>
-                  <a:srgbClr val="6B7585"/>
-                </a:solidFill>
-              </a:rPr>
-              <a:t>Seamless AV</a:t>
-            </a:r>
-          </a:p>
-        </p:txBody>
-      </p:sp>
+      <p:pic>
+        <p:nvPicPr>
+          <p:cNvPr id="26" name="cts logo" descr="cts-logo.png"/>
+          <p:cNvPicPr>
+            <a:picLocks noChangeAspect="1"/>
+          </p:cNvPicPr>
+          <p:nvPr/>
+        </p:nvPicPr>
+        <p:blipFill>
+          <a:blip r:embed="rId4"/>
+          <a:stretch>
+            <a:fillRect/>
+          </a:stretch>
+        </p:blipFill>
+        <p:spPr>
+          <a:xfrm>
+            <a:off x="7680959" y="182880"/>
+            <a:ext cx="960120" cy="539696"/>
+          </a:xfrm>
+          <a:prstGeom prst="rect">
+            <a:avLst/>
+          </a:prstGeom>
+        </p:spPr>
+      </p:pic>
     </p:spTree>
   </p:cSld>
   <p:clrMapOvr>
@@ -10311,90 +9771,30 @@
           </a:p>
         </p:txBody>
       </p:sp>
-      <p:sp>
-        <p:nvSpPr>
-          <p:cNvPr id="26" name="cts mark"/>
-          <p:cNvSpPr txBox="1"/>
-          <p:nvPr/>
-        </p:nvSpPr>
-        <p:spPr>
-          <a:xfrm>
-            <a:off x="7726679" y="155448"/>
-            <a:ext cx="914400" cy="274320"/>
-          </a:xfrm>
-          <a:prstGeom prst="rect">
-            <a:avLst/>
-          </a:prstGeom>
-          <a:noFill/>
-        </p:spPr>
-        <p:txBody>
-          <a:bodyPr wrap="none" lIns="0" rIns="0" tIns="0" bIns="0">
-            <a:spAutoFit/>
-          </a:bodyPr>
-          <a:lstStyle/>
-          <a:p>
-            <a:pPr algn="r"/>
-            <a:r>
-              <a:rPr sz="1500" b="1">
-                <a:solidFill>
-                  <a:srgbClr val="005358"/>
-                </a:solidFill>
-              </a:rPr>
-              <a:t>c</a:t>
-            </a:r>
-            <a:r>
-              <a:rPr sz="1500" b="1">
-                <a:solidFill>
-                  <a:srgbClr val="6D71FF"/>
-                </a:solidFill>
-              </a:rPr>
-              <a:t>t</a:t>
-            </a:r>
-            <a:r>
-              <a:rPr sz="1500" b="1">
-                <a:solidFill>
-                  <a:srgbClr val="F33844"/>
-                </a:solidFill>
-              </a:rPr>
-              <a:t>s</a:t>
-            </a:r>
-          </a:p>
-        </p:txBody>
-      </p:sp>
-      <p:sp>
-        <p:nvSpPr>
-          <p:cNvPr id="27" name="cts mark sub"/>
-          <p:cNvSpPr txBox="1"/>
-          <p:nvPr/>
-        </p:nvSpPr>
-        <p:spPr>
-          <a:xfrm>
-            <a:off x="7726679" y="384048"/>
-            <a:ext cx="914400" cy="164592"/>
-          </a:xfrm>
-          <a:prstGeom prst="rect">
-            <a:avLst/>
-          </a:prstGeom>
-          <a:noFill/>
-        </p:spPr>
-        <p:txBody>
-          <a:bodyPr wrap="none" lIns="0" rIns="0" tIns="0" bIns="0">
-            <a:spAutoFit/>
-          </a:bodyPr>
-          <a:lstStyle/>
-          <a:p>
-            <a:pPr algn="r"/>
-            <a:r>
-              <a:rPr sz="650">
-                <a:solidFill>
-                  <a:srgbClr val="6B7585"/>
-                </a:solidFill>
-              </a:rPr>
-              <a:t>Seamless AV</a:t>
-            </a:r>
-          </a:p>
-        </p:txBody>
-      </p:sp>
+      <p:pic>
+        <p:nvPicPr>
+          <p:cNvPr id="26" name="cts logo" descr="cts-logo.png"/>
+          <p:cNvPicPr>
+            <a:picLocks noChangeAspect="1"/>
+          </p:cNvPicPr>
+          <p:nvPr/>
+        </p:nvPicPr>
+        <p:blipFill>
+          <a:blip r:embed="rId3"/>
+          <a:stretch>
+            <a:fillRect/>
+          </a:stretch>
+        </p:blipFill>
+        <p:spPr>
+          <a:xfrm>
+            <a:off x="7680959" y="182880"/>
+            <a:ext cx="960120" cy="539696"/>
+          </a:xfrm>
+          <a:prstGeom prst="rect">
+            <a:avLst/>
+          </a:prstGeom>
+        </p:spPr>
+      </p:pic>
     </p:spTree>
   </p:cSld>
   <p:clrMapOvr>
@@ -11036,90 +10436,30 @@
           </a:p>
         </p:txBody>
       </p:sp>
-      <p:sp>
-        <p:nvSpPr>
-          <p:cNvPr id="26" name="cts mark"/>
-          <p:cNvSpPr txBox="1"/>
-          <p:nvPr/>
-        </p:nvSpPr>
-        <p:spPr>
-          <a:xfrm>
-            <a:off x="7726679" y="155448"/>
-            <a:ext cx="914400" cy="274320"/>
-          </a:xfrm>
-          <a:prstGeom prst="rect">
-            <a:avLst/>
-          </a:prstGeom>
-          <a:noFill/>
-        </p:spPr>
-        <p:txBody>
-          <a:bodyPr wrap="none" lIns="0" rIns="0" tIns="0" bIns="0">
-            <a:spAutoFit/>
-          </a:bodyPr>
-          <a:lstStyle/>
-          <a:p>
-            <a:pPr algn="r"/>
-            <a:r>
-              <a:rPr sz="1500" b="1">
-                <a:solidFill>
-                  <a:srgbClr val="005358"/>
-                </a:solidFill>
-              </a:rPr>
-              <a:t>c</a:t>
-            </a:r>
-            <a:r>
-              <a:rPr sz="1500" b="1">
-                <a:solidFill>
-                  <a:srgbClr val="6D71FF"/>
-                </a:solidFill>
-              </a:rPr>
-              <a:t>t</a:t>
-            </a:r>
-            <a:r>
-              <a:rPr sz="1500" b="1">
-                <a:solidFill>
-                  <a:srgbClr val="F33844"/>
-                </a:solidFill>
-              </a:rPr>
-              <a:t>s</a:t>
-            </a:r>
-          </a:p>
-        </p:txBody>
-      </p:sp>
-      <p:sp>
-        <p:nvSpPr>
-          <p:cNvPr id="27" name="cts mark sub"/>
-          <p:cNvSpPr txBox="1"/>
-          <p:nvPr/>
-        </p:nvSpPr>
-        <p:spPr>
-          <a:xfrm>
-            <a:off x="7726679" y="384048"/>
-            <a:ext cx="914400" cy="164592"/>
-          </a:xfrm>
-          <a:prstGeom prst="rect">
-            <a:avLst/>
-          </a:prstGeom>
-          <a:noFill/>
-        </p:spPr>
-        <p:txBody>
-          <a:bodyPr wrap="none" lIns="0" rIns="0" tIns="0" bIns="0">
-            <a:spAutoFit/>
-          </a:bodyPr>
-          <a:lstStyle/>
-          <a:p>
-            <a:pPr algn="r"/>
-            <a:r>
-              <a:rPr sz="650">
-                <a:solidFill>
-                  <a:srgbClr val="6B7585"/>
-                </a:solidFill>
-              </a:rPr>
-              <a:t>Seamless AV</a:t>
-            </a:r>
-          </a:p>
-        </p:txBody>
-      </p:sp>
+      <p:pic>
+        <p:nvPicPr>
+          <p:cNvPr id="26" name="cts logo" descr="cts-logo.png"/>
+          <p:cNvPicPr>
+            <a:picLocks noChangeAspect="1"/>
+          </p:cNvPicPr>
+          <p:nvPr/>
+        </p:nvPicPr>
+        <p:blipFill>
+          <a:blip r:embed="rId4"/>
+          <a:stretch>
+            <a:fillRect/>
+          </a:stretch>
+        </p:blipFill>
+        <p:spPr>
+          <a:xfrm>
+            <a:off x="7680959" y="182880"/>
+            <a:ext cx="960120" cy="539696"/>
+          </a:xfrm>
+          <a:prstGeom prst="rect">
+            <a:avLst/>
+          </a:prstGeom>
+        </p:spPr>
+      </p:pic>
     </p:spTree>
   </p:cSld>
   <p:clrMapOvr>
@@ -11478,90 +10818,30 @@
           </a:p>
         </p:txBody>
       </p:sp>
-      <p:sp>
-        <p:nvSpPr>
-          <p:cNvPr id="26" name="cts mark"/>
-          <p:cNvSpPr txBox="1"/>
-          <p:nvPr/>
-        </p:nvSpPr>
-        <p:spPr>
-          <a:xfrm>
-            <a:off x="7726679" y="155448"/>
-            <a:ext cx="914400" cy="274320"/>
-          </a:xfrm>
-          <a:prstGeom prst="rect">
-            <a:avLst/>
-          </a:prstGeom>
-          <a:noFill/>
-        </p:spPr>
-        <p:txBody>
-          <a:bodyPr wrap="none" lIns="0" rIns="0" tIns="0" bIns="0">
-            <a:spAutoFit/>
-          </a:bodyPr>
-          <a:lstStyle/>
-          <a:p>
-            <a:pPr algn="r"/>
-            <a:r>
-              <a:rPr sz="1500" b="1">
-                <a:solidFill>
-                  <a:srgbClr val="005358"/>
-                </a:solidFill>
-              </a:rPr>
-              <a:t>c</a:t>
-            </a:r>
-            <a:r>
-              <a:rPr sz="1500" b="1">
-                <a:solidFill>
-                  <a:srgbClr val="6D71FF"/>
-                </a:solidFill>
-              </a:rPr>
-              <a:t>t</a:t>
-            </a:r>
-            <a:r>
-              <a:rPr sz="1500" b="1">
-                <a:solidFill>
-                  <a:srgbClr val="F33844"/>
-                </a:solidFill>
-              </a:rPr>
-              <a:t>s</a:t>
-            </a:r>
-          </a:p>
-        </p:txBody>
-      </p:sp>
-      <p:sp>
-        <p:nvSpPr>
-          <p:cNvPr id="27" name="cts mark sub"/>
-          <p:cNvSpPr txBox="1"/>
-          <p:nvPr/>
-        </p:nvSpPr>
-        <p:spPr>
-          <a:xfrm>
-            <a:off x="7726679" y="384048"/>
-            <a:ext cx="914400" cy="164592"/>
-          </a:xfrm>
-          <a:prstGeom prst="rect">
-            <a:avLst/>
-          </a:prstGeom>
-          <a:noFill/>
-        </p:spPr>
-        <p:txBody>
-          <a:bodyPr wrap="none" lIns="0" rIns="0" tIns="0" bIns="0">
-            <a:spAutoFit/>
-          </a:bodyPr>
-          <a:lstStyle/>
-          <a:p>
-            <a:pPr algn="r"/>
-            <a:r>
-              <a:rPr sz="650">
-                <a:solidFill>
-                  <a:srgbClr val="6B7585"/>
-                </a:solidFill>
-              </a:rPr>
-              <a:t>Seamless AV</a:t>
-            </a:r>
-          </a:p>
-        </p:txBody>
-      </p:sp>
+      <p:pic>
+        <p:nvPicPr>
+          <p:cNvPr id="26" name="cts logo" descr="cts-logo.png"/>
+          <p:cNvPicPr>
+            <a:picLocks noChangeAspect="1"/>
+          </p:cNvPicPr>
+          <p:nvPr/>
+        </p:nvPicPr>
+        <p:blipFill>
+          <a:blip r:embed="rId4"/>
+          <a:stretch>
+            <a:fillRect/>
+          </a:stretch>
+        </p:blipFill>
+        <p:spPr>
+          <a:xfrm>
+            <a:off x="7680959" y="182880"/>
+            <a:ext cx="960120" cy="539696"/>
+          </a:xfrm>
+          <a:prstGeom prst="rect">
+            <a:avLst/>
+          </a:prstGeom>
+        </p:spPr>
+      </p:pic>
     </p:spTree>
   </p:cSld>
   <p:clrMapOvr>
@@ -11920,90 +11200,30 @@
           </a:p>
         </p:txBody>
       </p:sp>
-      <p:sp>
-        <p:nvSpPr>
-          <p:cNvPr id="26" name="cts mark"/>
-          <p:cNvSpPr txBox="1"/>
-          <p:nvPr/>
-        </p:nvSpPr>
-        <p:spPr>
-          <a:xfrm>
-            <a:off x="7726679" y="155448"/>
-            <a:ext cx="914400" cy="274320"/>
-          </a:xfrm>
-          <a:prstGeom prst="rect">
-            <a:avLst/>
-          </a:prstGeom>
-          <a:noFill/>
-        </p:spPr>
-        <p:txBody>
-          <a:bodyPr wrap="none" lIns="0" rIns="0" tIns="0" bIns="0">
-            <a:spAutoFit/>
-          </a:bodyPr>
-          <a:lstStyle/>
-          <a:p>
-            <a:pPr algn="r"/>
-            <a:r>
-              <a:rPr sz="1500" b="1">
-                <a:solidFill>
-                  <a:srgbClr val="005358"/>
-                </a:solidFill>
-              </a:rPr>
-              <a:t>c</a:t>
-            </a:r>
-            <a:r>
-              <a:rPr sz="1500" b="1">
-                <a:solidFill>
-                  <a:srgbClr val="6D71FF"/>
-                </a:solidFill>
-              </a:rPr>
-              <a:t>t</a:t>
-            </a:r>
-            <a:r>
-              <a:rPr sz="1500" b="1">
-                <a:solidFill>
-                  <a:srgbClr val="F33844"/>
-                </a:solidFill>
-              </a:rPr>
-              <a:t>s</a:t>
-            </a:r>
-          </a:p>
-        </p:txBody>
-      </p:sp>
-      <p:sp>
-        <p:nvSpPr>
-          <p:cNvPr id="27" name="cts mark sub"/>
-          <p:cNvSpPr txBox="1"/>
-          <p:nvPr/>
-        </p:nvSpPr>
-        <p:spPr>
-          <a:xfrm>
-            <a:off x="7726679" y="384048"/>
-            <a:ext cx="914400" cy="164592"/>
-          </a:xfrm>
-          <a:prstGeom prst="rect">
-            <a:avLst/>
-          </a:prstGeom>
-          <a:noFill/>
-        </p:spPr>
-        <p:txBody>
-          <a:bodyPr wrap="none" lIns="0" rIns="0" tIns="0" bIns="0">
-            <a:spAutoFit/>
-          </a:bodyPr>
-          <a:lstStyle/>
-          <a:p>
-            <a:pPr algn="r"/>
-            <a:r>
-              <a:rPr sz="650">
-                <a:solidFill>
-                  <a:srgbClr val="6B7585"/>
-                </a:solidFill>
-              </a:rPr>
-              <a:t>Seamless AV</a:t>
-            </a:r>
-          </a:p>
-        </p:txBody>
-      </p:sp>
+      <p:pic>
+        <p:nvPicPr>
+          <p:cNvPr id="26" name="cts logo" descr="cts-logo.png"/>
+          <p:cNvPicPr>
+            <a:picLocks noChangeAspect="1"/>
+          </p:cNvPicPr>
+          <p:nvPr/>
+        </p:nvPicPr>
+        <p:blipFill>
+          <a:blip r:embed="rId4"/>
+          <a:stretch>
+            <a:fillRect/>
+          </a:stretch>
+        </p:blipFill>
+        <p:spPr>
+          <a:xfrm>
+            <a:off x="7680959" y="182880"/>
+            <a:ext cx="960120" cy="539696"/>
+          </a:xfrm>
+          <a:prstGeom prst="rect">
+            <a:avLst/>
+          </a:prstGeom>
+        </p:spPr>
+      </p:pic>
     </p:spTree>
   </p:cSld>
   <p:clrMapOvr>
@@ -12648,90 +11868,30 @@
           </a:p>
         </p:txBody>
       </p:sp>
-      <p:sp>
-        <p:nvSpPr>
-          <p:cNvPr id="26" name="cts mark"/>
-          <p:cNvSpPr txBox="1"/>
-          <p:nvPr/>
-        </p:nvSpPr>
-        <p:spPr>
-          <a:xfrm>
-            <a:off x="7726679" y="155448"/>
-            <a:ext cx="914400" cy="274320"/>
-          </a:xfrm>
-          <a:prstGeom prst="rect">
-            <a:avLst/>
-          </a:prstGeom>
-          <a:noFill/>
-        </p:spPr>
-        <p:txBody>
-          <a:bodyPr wrap="none" lIns="0" rIns="0" tIns="0" bIns="0">
-            <a:spAutoFit/>
-          </a:bodyPr>
-          <a:lstStyle/>
-          <a:p>
-            <a:pPr algn="r"/>
-            <a:r>
-              <a:rPr sz="1500" b="1">
-                <a:solidFill>
-                  <a:srgbClr val="005358"/>
-                </a:solidFill>
-              </a:rPr>
-              <a:t>c</a:t>
-            </a:r>
-            <a:r>
-              <a:rPr sz="1500" b="1">
-                <a:solidFill>
-                  <a:srgbClr val="6D71FF"/>
-                </a:solidFill>
-              </a:rPr>
-              <a:t>t</a:t>
-            </a:r>
-            <a:r>
-              <a:rPr sz="1500" b="1">
-                <a:solidFill>
-                  <a:srgbClr val="F33844"/>
-                </a:solidFill>
-              </a:rPr>
-              <a:t>s</a:t>
-            </a:r>
-          </a:p>
-        </p:txBody>
-      </p:sp>
-      <p:sp>
-        <p:nvSpPr>
-          <p:cNvPr id="27" name="cts mark sub"/>
-          <p:cNvSpPr txBox="1"/>
-          <p:nvPr/>
-        </p:nvSpPr>
-        <p:spPr>
-          <a:xfrm>
-            <a:off x="7726679" y="384048"/>
-            <a:ext cx="914400" cy="164592"/>
-          </a:xfrm>
-          <a:prstGeom prst="rect">
-            <a:avLst/>
-          </a:prstGeom>
-          <a:noFill/>
-        </p:spPr>
-        <p:txBody>
-          <a:bodyPr wrap="none" lIns="0" rIns="0" tIns="0" bIns="0">
-            <a:spAutoFit/>
-          </a:bodyPr>
-          <a:lstStyle/>
-          <a:p>
-            <a:pPr algn="r"/>
-            <a:r>
-              <a:rPr sz="650">
-                <a:solidFill>
-                  <a:srgbClr val="6B7585"/>
-                </a:solidFill>
-              </a:rPr>
-              <a:t>Seamless AV</a:t>
-            </a:r>
-          </a:p>
-        </p:txBody>
-      </p:sp>
+      <p:pic>
+        <p:nvPicPr>
+          <p:cNvPr id="26" name="cts logo" descr="cts-logo.png"/>
+          <p:cNvPicPr>
+            <a:picLocks noChangeAspect="1"/>
+          </p:cNvPicPr>
+          <p:nvPr/>
+        </p:nvPicPr>
+        <p:blipFill>
+          <a:blip r:embed="rId4"/>
+          <a:stretch>
+            <a:fillRect/>
+          </a:stretch>
+        </p:blipFill>
+        <p:spPr>
+          <a:xfrm>
+            <a:off x="7680959" y="182880"/>
+            <a:ext cx="960120" cy="539696"/>
+          </a:xfrm>
+          <a:prstGeom prst="rect">
+            <a:avLst/>
+          </a:prstGeom>
+        </p:spPr>
+      </p:pic>
     </p:spTree>
   </p:cSld>
   <p:clrMapOvr>
@@ -13090,90 +12250,30 @@
           </a:p>
         </p:txBody>
       </p:sp>
-      <p:sp>
-        <p:nvSpPr>
-          <p:cNvPr id="26" name="cts mark"/>
-          <p:cNvSpPr txBox="1"/>
-          <p:nvPr/>
-        </p:nvSpPr>
-        <p:spPr>
-          <a:xfrm>
-            <a:off x="7726679" y="155448"/>
-            <a:ext cx="914400" cy="274320"/>
-          </a:xfrm>
-          <a:prstGeom prst="rect">
-            <a:avLst/>
-          </a:prstGeom>
-          <a:noFill/>
-        </p:spPr>
-        <p:txBody>
-          <a:bodyPr wrap="none" lIns="0" rIns="0" tIns="0" bIns="0">
-            <a:spAutoFit/>
-          </a:bodyPr>
-          <a:lstStyle/>
-          <a:p>
-            <a:pPr algn="r"/>
-            <a:r>
-              <a:rPr sz="1500" b="1">
-                <a:solidFill>
-                  <a:srgbClr val="005358"/>
-                </a:solidFill>
-              </a:rPr>
-              <a:t>c</a:t>
-            </a:r>
-            <a:r>
-              <a:rPr sz="1500" b="1">
-                <a:solidFill>
-                  <a:srgbClr val="6D71FF"/>
-                </a:solidFill>
-              </a:rPr>
-              <a:t>t</a:t>
-            </a:r>
-            <a:r>
-              <a:rPr sz="1500" b="1">
-                <a:solidFill>
-                  <a:srgbClr val="F33844"/>
-                </a:solidFill>
-              </a:rPr>
-              <a:t>s</a:t>
-            </a:r>
-          </a:p>
-        </p:txBody>
-      </p:sp>
-      <p:sp>
-        <p:nvSpPr>
-          <p:cNvPr id="27" name="cts mark sub"/>
-          <p:cNvSpPr txBox="1"/>
-          <p:nvPr/>
-        </p:nvSpPr>
-        <p:spPr>
-          <a:xfrm>
-            <a:off x="7726679" y="384048"/>
-            <a:ext cx="914400" cy="164592"/>
-          </a:xfrm>
-          <a:prstGeom prst="rect">
-            <a:avLst/>
-          </a:prstGeom>
-          <a:noFill/>
-        </p:spPr>
-        <p:txBody>
-          <a:bodyPr wrap="none" lIns="0" rIns="0" tIns="0" bIns="0">
-            <a:spAutoFit/>
-          </a:bodyPr>
-          <a:lstStyle/>
-          <a:p>
-            <a:pPr algn="r"/>
-            <a:r>
-              <a:rPr sz="650">
-                <a:solidFill>
-                  <a:srgbClr val="6B7585"/>
-                </a:solidFill>
-              </a:rPr>
-              <a:t>Seamless AV</a:t>
-            </a:r>
-          </a:p>
-        </p:txBody>
-      </p:sp>
+      <p:pic>
+        <p:nvPicPr>
+          <p:cNvPr id="26" name="cts logo" descr="cts-logo.png"/>
+          <p:cNvPicPr>
+            <a:picLocks noChangeAspect="1"/>
+          </p:cNvPicPr>
+          <p:nvPr/>
+        </p:nvPicPr>
+        <p:blipFill>
+          <a:blip r:embed="rId4"/>
+          <a:stretch>
+            <a:fillRect/>
+          </a:stretch>
+        </p:blipFill>
+        <p:spPr>
+          <a:xfrm>
+            <a:off x="7680959" y="182880"/>
+            <a:ext cx="960120" cy="539696"/>
+          </a:xfrm>
+          <a:prstGeom prst="rect">
+            <a:avLst/>
+          </a:prstGeom>
+        </p:spPr>
+      </p:pic>
     </p:spTree>
   </p:cSld>
   <p:clrMapOvr>
@@ -13532,90 +12632,30 @@
           </a:p>
         </p:txBody>
       </p:sp>
-      <p:sp>
-        <p:nvSpPr>
-          <p:cNvPr id="26" name="cts mark"/>
-          <p:cNvSpPr txBox="1"/>
-          <p:nvPr/>
-        </p:nvSpPr>
-        <p:spPr>
-          <a:xfrm>
-            <a:off x="7726679" y="155448"/>
-            <a:ext cx="914400" cy="274320"/>
-          </a:xfrm>
-          <a:prstGeom prst="rect">
-            <a:avLst/>
-          </a:prstGeom>
-          <a:noFill/>
-        </p:spPr>
-        <p:txBody>
-          <a:bodyPr wrap="none" lIns="0" rIns="0" tIns="0" bIns="0">
-            <a:spAutoFit/>
-          </a:bodyPr>
-          <a:lstStyle/>
-          <a:p>
-            <a:pPr algn="r"/>
-            <a:r>
-              <a:rPr sz="1500" b="1">
-                <a:solidFill>
-                  <a:srgbClr val="005358"/>
-                </a:solidFill>
-              </a:rPr>
-              <a:t>c</a:t>
-            </a:r>
-            <a:r>
-              <a:rPr sz="1500" b="1">
-                <a:solidFill>
-                  <a:srgbClr val="6D71FF"/>
-                </a:solidFill>
-              </a:rPr>
-              <a:t>t</a:t>
-            </a:r>
-            <a:r>
-              <a:rPr sz="1500" b="1">
-                <a:solidFill>
-                  <a:srgbClr val="F33844"/>
-                </a:solidFill>
-              </a:rPr>
-              <a:t>s</a:t>
-            </a:r>
-          </a:p>
-        </p:txBody>
-      </p:sp>
-      <p:sp>
-        <p:nvSpPr>
-          <p:cNvPr id="27" name="cts mark sub"/>
-          <p:cNvSpPr txBox="1"/>
-          <p:nvPr/>
-        </p:nvSpPr>
-        <p:spPr>
-          <a:xfrm>
-            <a:off x="7726679" y="384048"/>
-            <a:ext cx="914400" cy="164592"/>
-          </a:xfrm>
-          <a:prstGeom prst="rect">
-            <a:avLst/>
-          </a:prstGeom>
-          <a:noFill/>
-        </p:spPr>
-        <p:txBody>
-          <a:bodyPr wrap="none" lIns="0" rIns="0" tIns="0" bIns="0">
-            <a:spAutoFit/>
-          </a:bodyPr>
-          <a:lstStyle/>
-          <a:p>
-            <a:pPr algn="r"/>
-            <a:r>
-              <a:rPr sz="650">
-                <a:solidFill>
-                  <a:srgbClr val="6B7585"/>
-                </a:solidFill>
-              </a:rPr>
-              <a:t>Seamless AV</a:t>
-            </a:r>
-          </a:p>
-        </p:txBody>
-      </p:sp>
+      <p:pic>
+        <p:nvPicPr>
+          <p:cNvPr id="26" name="cts logo" descr="cts-logo.png"/>
+          <p:cNvPicPr>
+            <a:picLocks noChangeAspect="1"/>
+          </p:cNvPicPr>
+          <p:nvPr/>
+        </p:nvPicPr>
+        <p:blipFill>
+          <a:blip r:embed="rId4"/>
+          <a:stretch>
+            <a:fillRect/>
+          </a:stretch>
+        </p:blipFill>
+        <p:spPr>
+          <a:xfrm>
+            <a:off x="7680959" y="182880"/>
+            <a:ext cx="960120" cy="539696"/>
+          </a:xfrm>
+          <a:prstGeom prst="rect">
+            <a:avLst/>
+          </a:prstGeom>
+        </p:spPr>
+      </p:pic>
     </p:spTree>
   </p:cSld>
   <p:clrMapOvr>
@@ -14257,90 +13297,30 @@
           </a:p>
         </p:txBody>
       </p:sp>
-      <p:sp>
-        <p:nvSpPr>
-          <p:cNvPr id="26" name="cts mark"/>
-          <p:cNvSpPr txBox="1"/>
-          <p:nvPr/>
-        </p:nvSpPr>
-        <p:spPr>
-          <a:xfrm>
-            <a:off x="7726679" y="155448"/>
-            <a:ext cx="914400" cy="274320"/>
-          </a:xfrm>
-          <a:prstGeom prst="rect">
-            <a:avLst/>
-          </a:prstGeom>
-          <a:noFill/>
-        </p:spPr>
-        <p:txBody>
-          <a:bodyPr wrap="none" lIns="0" rIns="0" tIns="0" bIns="0">
-            <a:spAutoFit/>
-          </a:bodyPr>
-          <a:lstStyle/>
-          <a:p>
-            <a:pPr algn="r"/>
-            <a:r>
-              <a:rPr sz="1500" b="1">
-                <a:solidFill>
-                  <a:srgbClr val="005358"/>
-                </a:solidFill>
-              </a:rPr>
-              <a:t>c</a:t>
-            </a:r>
-            <a:r>
-              <a:rPr sz="1500" b="1">
-                <a:solidFill>
-                  <a:srgbClr val="6D71FF"/>
-                </a:solidFill>
-              </a:rPr>
-              <a:t>t</a:t>
-            </a:r>
-            <a:r>
-              <a:rPr sz="1500" b="1">
-                <a:solidFill>
-                  <a:srgbClr val="F33844"/>
-                </a:solidFill>
-              </a:rPr>
-              <a:t>s</a:t>
-            </a:r>
-          </a:p>
-        </p:txBody>
-      </p:sp>
-      <p:sp>
-        <p:nvSpPr>
-          <p:cNvPr id="27" name="cts mark sub"/>
-          <p:cNvSpPr txBox="1"/>
-          <p:nvPr/>
-        </p:nvSpPr>
-        <p:spPr>
-          <a:xfrm>
-            <a:off x="7726679" y="384048"/>
-            <a:ext cx="914400" cy="164592"/>
-          </a:xfrm>
-          <a:prstGeom prst="rect">
-            <a:avLst/>
-          </a:prstGeom>
-          <a:noFill/>
-        </p:spPr>
-        <p:txBody>
-          <a:bodyPr wrap="none" lIns="0" rIns="0" tIns="0" bIns="0">
-            <a:spAutoFit/>
-          </a:bodyPr>
-          <a:lstStyle/>
-          <a:p>
-            <a:pPr algn="r"/>
-            <a:r>
-              <a:rPr sz="650">
-                <a:solidFill>
-                  <a:srgbClr val="6B7585"/>
-                </a:solidFill>
-              </a:rPr>
-              <a:t>Seamless AV</a:t>
-            </a:r>
-          </a:p>
-        </p:txBody>
-      </p:sp>
+      <p:pic>
+        <p:nvPicPr>
+          <p:cNvPr id="26" name="cts logo" descr="cts-logo.png"/>
+          <p:cNvPicPr>
+            <a:picLocks noChangeAspect="1"/>
+          </p:cNvPicPr>
+          <p:nvPr/>
+        </p:nvPicPr>
+        <p:blipFill>
+          <a:blip r:embed="rId4"/>
+          <a:stretch>
+            <a:fillRect/>
+          </a:stretch>
+        </p:blipFill>
+        <p:spPr>
+          <a:xfrm>
+            <a:off x="7680959" y="182880"/>
+            <a:ext cx="960120" cy="539696"/>
+          </a:xfrm>
+          <a:prstGeom prst="rect">
+            <a:avLst/>
+          </a:prstGeom>
+        </p:spPr>
+      </p:pic>
     </p:spTree>
   </p:cSld>
   <p:clrMapOvr>
@@ -16569,90 +15549,30 @@
           </a:p>
         </p:txBody>
       </p:sp>
-      <p:sp>
-        <p:nvSpPr>
-          <p:cNvPr id="57" name="cts mark"/>
-          <p:cNvSpPr txBox="1"/>
-          <p:nvPr/>
-        </p:nvSpPr>
-        <p:spPr>
-          <a:xfrm>
-            <a:off x="7726679" y="155448"/>
-            <a:ext cx="914400" cy="274320"/>
-          </a:xfrm>
-          <a:prstGeom prst="rect">
-            <a:avLst/>
-          </a:prstGeom>
-          <a:noFill/>
-        </p:spPr>
-        <p:txBody>
-          <a:bodyPr wrap="none" lIns="0" rIns="0" tIns="0" bIns="0">
-            <a:spAutoFit/>
-          </a:bodyPr>
-          <a:lstStyle/>
-          <a:p>
-            <a:pPr algn="r"/>
-            <a:r>
-              <a:rPr sz="1500" b="1">
-                <a:solidFill>
-                  <a:srgbClr val="005358"/>
-                </a:solidFill>
-              </a:rPr>
-              <a:t>c</a:t>
-            </a:r>
-            <a:r>
-              <a:rPr sz="1500" b="1">
-                <a:solidFill>
-                  <a:srgbClr val="6D71FF"/>
-                </a:solidFill>
-              </a:rPr>
-              <a:t>t</a:t>
-            </a:r>
-            <a:r>
-              <a:rPr sz="1500" b="1">
-                <a:solidFill>
-                  <a:srgbClr val="F33844"/>
-                </a:solidFill>
-              </a:rPr>
-              <a:t>s</a:t>
-            </a:r>
-          </a:p>
-        </p:txBody>
-      </p:sp>
-      <p:sp>
-        <p:nvSpPr>
-          <p:cNvPr id="58" name="cts mark sub"/>
-          <p:cNvSpPr txBox="1"/>
-          <p:nvPr/>
-        </p:nvSpPr>
-        <p:spPr>
-          <a:xfrm>
-            <a:off x="7726679" y="384048"/>
-            <a:ext cx="914400" cy="164592"/>
-          </a:xfrm>
-          <a:prstGeom prst="rect">
-            <a:avLst/>
-          </a:prstGeom>
-          <a:noFill/>
-        </p:spPr>
-        <p:txBody>
-          <a:bodyPr wrap="none" lIns="0" rIns="0" tIns="0" bIns="0">
-            <a:spAutoFit/>
-          </a:bodyPr>
-          <a:lstStyle/>
-          <a:p>
-            <a:pPr algn="r"/>
-            <a:r>
-              <a:rPr sz="650">
-                <a:solidFill>
-                  <a:srgbClr val="6B7585"/>
-                </a:solidFill>
-              </a:rPr>
-              <a:t>Seamless AV</a:t>
-            </a:r>
-          </a:p>
-        </p:txBody>
-      </p:sp>
+      <p:pic>
+        <p:nvPicPr>
+          <p:cNvPr id="57" name="cts logo" descr="cts-logo.png"/>
+          <p:cNvPicPr>
+            <a:picLocks noChangeAspect="1"/>
+          </p:cNvPicPr>
+          <p:nvPr/>
+        </p:nvPicPr>
+        <p:blipFill>
+          <a:blip r:embed="rId3"/>
+          <a:stretch>
+            <a:fillRect/>
+          </a:stretch>
+        </p:blipFill>
+        <p:spPr>
+          <a:xfrm>
+            <a:off x="7680959" y="182880"/>
+            <a:ext cx="960120" cy="539696"/>
+          </a:xfrm>
+          <a:prstGeom prst="rect">
+            <a:avLst/>
+          </a:prstGeom>
+        </p:spPr>
+      </p:pic>
     </p:spTree>
   </p:cSld>
   <p:clrMapOvr>
@@ -18775,90 +17695,30 @@
           </a:p>
         </p:txBody>
       </p:sp>
-      <p:sp>
-        <p:nvSpPr>
-          <p:cNvPr id="32" name="cts mark"/>
-          <p:cNvSpPr txBox="1"/>
-          <p:nvPr/>
-        </p:nvSpPr>
-        <p:spPr>
-          <a:xfrm>
-            <a:off x="7726679" y="155448"/>
-            <a:ext cx="914400" cy="274320"/>
-          </a:xfrm>
-          <a:prstGeom prst="rect">
-            <a:avLst/>
-          </a:prstGeom>
-          <a:noFill/>
-        </p:spPr>
-        <p:txBody>
-          <a:bodyPr wrap="none" lIns="0" rIns="0" tIns="0" bIns="0">
-            <a:spAutoFit/>
-          </a:bodyPr>
-          <a:lstStyle/>
-          <a:p>
-            <a:pPr algn="r"/>
-            <a:r>
-              <a:rPr sz="1500" b="1">
-                <a:solidFill>
-                  <a:srgbClr val="005358"/>
-                </a:solidFill>
-              </a:rPr>
-              <a:t>c</a:t>
-            </a:r>
-            <a:r>
-              <a:rPr sz="1500" b="1">
-                <a:solidFill>
-                  <a:srgbClr val="6D71FF"/>
-                </a:solidFill>
-              </a:rPr>
-              <a:t>t</a:t>
-            </a:r>
-            <a:r>
-              <a:rPr sz="1500" b="1">
-                <a:solidFill>
-                  <a:srgbClr val="F33844"/>
-                </a:solidFill>
-              </a:rPr>
-              <a:t>s</a:t>
-            </a:r>
-          </a:p>
-        </p:txBody>
-      </p:sp>
-      <p:sp>
-        <p:nvSpPr>
-          <p:cNvPr id="33" name="cts mark sub"/>
-          <p:cNvSpPr txBox="1"/>
-          <p:nvPr/>
-        </p:nvSpPr>
-        <p:spPr>
-          <a:xfrm>
-            <a:off x="7726679" y="384048"/>
-            <a:ext cx="914400" cy="164592"/>
-          </a:xfrm>
-          <a:prstGeom prst="rect">
-            <a:avLst/>
-          </a:prstGeom>
-          <a:noFill/>
-        </p:spPr>
-        <p:txBody>
-          <a:bodyPr wrap="none" lIns="0" rIns="0" tIns="0" bIns="0">
-            <a:spAutoFit/>
-          </a:bodyPr>
-          <a:lstStyle/>
-          <a:p>
-            <a:pPr algn="r"/>
-            <a:r>
-              <a:rPr sz="650">
-                <a:solidFill>
-                  <a:srgbClr val="6B7585"/>
-                </a:solidFill>
-              </a:rPr>
-              <a:t>Seamless AV</a:t>
-            </a:r>
-          </a:p>
-        </p:txBody>
-      </p:sp>
+      <p:pic>
+        <p:nvPicPr>
+          <p:cNvPr id="32" name="cts logo" descr="cts-logo.png"/>
+          <p:cNvPicPr>
+            <a:picLocks noChangeAspect="1"/>
+          </p:cNvPicPr>
+          <p:nvPr/>
+        </p:nvPicPr>
+        <p:blipFill>
+          <a:blip r:embed="rId3"/>
+          <a:stretch>
+            <a:fillRect/>
+          </a:stretch>
+        </p:blipFill>
+        <p:spPr>
+          <a:xfrm>
+            <a:off x="7680959" y="182880"/>
+            <a:ext cx="960120" cy="539696"/>
+          </a:xfrm>
+          <a:prstGeom prst="rect">
+            <a:avLst/>
+          </a:prstGeom>
+        </p:spPr>
+      </p:pic>
     </p:spTree>
   </p:cSld>
   <p:clrMapOvr>
@@ -20156,90 +19016,30 @@
           </a:p>
         </p:txBody>
       </p:sp>
-      <p:sp>
-        <p:nvSpPr>
-          <p:cNvPr id="27" name="cts mark"/>
-          <p:cNvSpPr txBox="1"/>
-          <p:nvPr/>
-        </p:nvSpPr>
-        <p:spPr>
-          <a:xfrm>
-            <a:off x="7726679" y="155448"/>
-            <a:ext cx="914400" cy="274320"/>
-          </a:xfrm>
-          <a:prstGeom prst="rect">
-            <a:avLst/>
-          </a:prstGeom>
-          <a:noFill/>
-        </p:spPr>
-        <p:txBody>
-          <a:bodyPr wrap="none" lIns="0" rIns="0" tIns="0" bIns="0">
-            <a:spAutoFit/>
-          </a:bodyPr>
-          <a:lstStyle/>
-          <a:p>
-            <a:pPr algn="r"/>
-            <a:r>
-              <a:rPr sz="1500" b="1">
-                <a:solidFill>
-                  <a:srgbClr val="005358"/>
-                </a:solidFill>
-              </a:rPr>
-              <a:t>c</a:t>
-            </a:r>
-            <a:r>
-              <a:rPr sz="1500" b="1">
-                <a:solidFill>
-                  <a:srgbClr val="6D71FF"/>
-                </a:solidFill>
-              </a:rPr>
-              <a:t>t</a:t>
-            </a:r>
-            <a:r>
-              <a:rPr sz="1500" b="1">
-                <a:solidFill>
-                  <a:srgbClr val="F33844"/>
-                </a:solidFill>
-              </a:rPr>
-              <a:t>s</a:t>
-            </a:r>
-          </a:p>
-        </p:txBody>
-      </p:sp>
-      <p:sp>
-        <p:nvSpPr>
-          <p:cNvPr id="28" name="cts mark sub"/>
-          <p:cNvSpPr txBox="1"/>
-          <p:nvPr/>
-        </p:nvSpPr>
-        <p:spPr>
-          <a:xfrm>
-            <a:off x="7726679" y="384048"/>
-            <a:ext cx="914400" cy="164592"/>
-          </a:xfrm>
-          <a:prstGeom prst="rect">
-            <a:avLst/>
-          </a:prstGeom>
-          <a:noFill/>
-        </p:spPr>
-        <p:txBody>
-          <a:bodyPr wrap="none" lIns="0" rIns="0" tIns="0" bIns="0">
-            <a:spAutoFit/>
-          </a:bodyPr>
-          <a:lstStyle/>
-          <a:p>
-            <a:pPr algn="r"/>
-            <a:r>
-              <a:rPr sz="650">
-                <a:solidFill>
-                  <a:srgbClr val="6B7585"/>
-                </a:solidFill>
-              </a:rPr>
-              <a:t>Seamless AV</a:t>
-            </a:r>
-          </a:p>
-        </p:txBody>
-      </p:sp>
+      <p:pic>
+        <p:nvPicPr>
+          <p:cNvPr id="27" name="cts logo" descr="cts-logo.png"/>
+          <p:cNvPicPr>
+            <a:picLocks noChangeAspect="1"/>
+          </p:cNvPicPr>
+          <p:nvPr/>
+        </p:nvPicPr>
+        <p:blipFill>
+          <a:blip r:embed="rId5"/>
+          <a:stretch>
+            <a:fillRect/>
+          </a:stretch>
+        </p:blipFill>
+        <p:spPr>
+          <a:xfrm>
+            <a:off x="7680959" y="182880"/>
+            <a:ext cx="960120" cy="539696"/>
+          </a:xfrm>
+          <a:prstGeom prst="rect">
+            <a:avLst/>
+          </a:prstGeom>
+        </p:spPr>
+      </p:pic>
     </p:spTree>
   </p:cSld>
   <p:clrMapOvr>
@@ -20598,90 +19398,30 @@
           </a:p>
         </p:txBody>
       </p:sp>
-      <p:sp>
-        <p:nvSpPr>
-          <p:cNvPr id="26" name="cts mark"/>
-          <p:cNvSpPr txBox="1"/>
-          <p:nvPr/>
-        </p:nvSpPr>
-        <p:spPr>
-          <a:xfrm>
-            <a:off x="7726679" y="155448"/>
-            <a:ext cx="914400" cy="274320"/>
-          </a:xfrm>
-          <a:prstGeom prst="rect">
-            <a:avLst/>
-          </a:prstGeom>
-          <a:noFill/>
-        </p:spPr>
-        <p:txBody>
-          <a:bodyPr wrap="none" lIns="0" rIns="0" tIns="0" bIns="0">
-            <a:spAutoFit/>
-          </a:bodyPr>
-          <a:lstStyle/>
-          <a:p>
-            <a:pPr algn="r"/>
-            <a:r>
-              <a:rPr sz="1500" b="1">
-                <a:solidFill>
-                  <a:srgbClr val="005358"/>
-                </a:solidFill>
-              </a:rPr>
-              <a:t>c</a:t>
-            </a:r>
-            <a:r>
-              <a:rPr sz="1500" b="1">
-                <a:solidFill>
-                  <a:srgbClr val="6D71FF"/>
-                </a:solidFill>
-              </a:rPr>
-              <a:t>t</a:t>
-            </a:r>
-            <a:r>
-              <a:rPr sz="1500" b="1">
-                <a:solidFill>
-                  <a:srgbClr val="F33844"/>
-                </a:solidFill>
-              </a:rPr>
-              <a:t>s</a:t>
-            </a:r>
-          </a:p>
-        </p:txBody>
-      </p:sp>
-      <p:sp>
-        <p:nvSpPr>
-          <p:cNvPr id="27" name="cts mark sub"/>
-          <p:cNvSpPr txBox="1"/>
-          <p:nvPr/>
-        </p:nvSpPr>
-        <p:spPr>
-          <a:xfrm>
-            <a:off x="7726679" y="384048"/>
-            <a:ext cx="914400" cy="164592"/>
-          </a:xfrm>
-          <a:prstGeom prst="rect">
-            <a:avLst/>
-          </a:prstGeom>
-          <a:noFill/>
-        </p:spPr>
-        <p:txBody>
-          <a:bodyPr wrap="none" lIns="0" rIns="0" tIns="0" bIns="0">
-            <a:spAutoFit/>
-          </a:bodyPr>
-          <a:lstStyle/>
-          <a:p>
-            <a:pPr algn="r"/>
-            <a:r>
-              <a:rPr sz="650">
-                <a:solidFill>
-                  <a:srgbClr val="6B7585"/>
-                </a:solidFill>
-              </a:rPr>
-              <a:t>Seamless AV</a:t>
-            </a:r>
-          </a:p>
-        </p:txBody>
-      </p:sp>
+      <p:pic>
+        <p:nvPicPr>
+          <p:cNvPr id="26" name="cts logo" descr="cts-logo.png"/>
+          <p:cNvPicPr>
+            <a:picLocks noChangeAspect="1"/>
+          </p:cNvPicPr>
+          <p:nvPr/>
+        </p:nvPicPr>
+        <p:blipFill>
+          <a:blip r:embed="rId4"/>
+          <a:stretch>
+            <a:fillRect/>
+          </a:stretch>
+        </p:blipFill>
+        <p:spPr>
+          <a:xfrm>
+            <a:off x="7680959" y="182880"/>
+            <a:ext cx="960120" cy="539696"/>
+          </a:xfrm>
+          <a:prstGeom prst="rect">
+            <a:avLst/>
+          </a:prstGeom>
+        </p:spPr>
+      </p:pic>
     </p:spTree>
   </p:cSld>
   <p:clrMapOvr>
@@ -21043,90 +19783,30 @@
           </a:p>
         </p:txBody>
       </p:sp>
-      <p:sp>
-        <p:nvSpPr>
-          <p:cNvPr id="26" name="cts mark"/>
-          <p:cNvSpPr txBox="1"/>
-          <p:nvPr/>
-        </p:nvSpPr>
-        <p:spPr>
-          <a:xfrm>
-            <a:off x="7726679" y="155448"/>
-            <a:ext cx="914400" cy="274320"/>
-          </a:xfrm>
-          <a:prstGeom prst="rect">
-            <a:avLst/>
-          </a:prstGeom>
-          <a:noFill/>
-        </p:spPr>
-        <p:txBody>
-          <a:bodyPr wrap="none" lIns="0" rIns="0" tIns="0" bIns="0">
-            <a:spAutoFit/>
-          </a:bodyPr>
-          <a:lstStyle/>
-          <a:p>
-            <a:pPr algn="r"/>
-            <a:r>
-              <a:rPr sz="1500" b="1">
-                <a:solidFill>
-                  <a:srgbClr val="005358"/>
-                </a:solidFill>
-              </a:rPr>
-              <a:t>c</a:t>
-            </a:r>
-            <a:r>
-              <a:rPr sz="1500" b="1">
-                <a:solidFill>
-                  <a:srgbClr val="6D71FF"/>
-                </a:solidFill>
-              </a:rPr>
-              <a:t>t</a:t>
-            </a:r>
-            <a:r>
-              <a:rPr sz="1500" b="1">
-                <a:solidFill>
-                  <a:srgbClr val="F33844"/>
-                </a:solidFill>
-              </a:rPr>
-              <a:t>s</a:t>
-            </a:r>
-          </a:p>
-        </p:txBody>
-      </p:sp>
-      <p:sp>
-        <p:nvSpPr>
-          <p:cNvPr id="27" name="cts mark sub"/>
-          <p:cNvSpPr txBox="1"/>
-          <p:nvPr/>
-        </p:nvSpPr>
-        <p:spPr>
-          <a:xfrm>
-            <a:off x="7726679" y="384048"/>
-            <a:ext cx="914400" cy="164592"/>
-          </a:xfrm>
-          <a:prstGeom prst="rect">
-            <a:avLst/>
-          </a:prstGeom>
-          <a:noFill/>
-        </p:spPr>
-        <p:txBody>
-          <a:bodyPr wrap="none" lIns="0" rIns="0" tIns="0" bIns="0">
-            <a:spAutoFit/>
-          </a:bodyPr>
-          <a:lstStyle/>
-          <a:p>
-            <a:pPr algn="r"/>
-            <a:r>
-              <a:rPr sz="650">
-                <a:solidFill>
-                  <a:srgbClr val="6B7585"/>
-                </a:solidFill>
-              </a:rPr>
-              <a:t>Seamless AV</a:t>
-            </a:r>
-          </a:p>
-        </p:txBody>
-      </p:sp>
+      <p:pic>
+        <p:nvPicPr>
+          <p:cNvPr id="26" name="cts logo" descr="cts-logo.png"/>
+          <p:cNvPicPr>
+            <a:picLocks noChangeAspect="1"/>
+          </p:cNvPicPr>
+          <p:nvPr/>
+        </p:nvPicPr>
+        <p:blipFill>
+          <a:blip r:embed="rId4"/>
+          <a:stretch>
+            <a:fillRect/>
+          </a:stretch>
+        </p:blipFill>
+        <p:spPr>
+          <a:xfrm>
+            <a:off x="7680959" y="182880"/>
+            <a:ext cx="960120" cy="539696"/>
+          </a:xfrm>
+          <a:prstGeom prst="rect">
+            <a:avLst/>
+          </a:prstGeom>
+        </p:spPr>
+      </p:pic>
     </p:spTree>
   </p:cSld>
   <p:clrMapOvr>
@@ -21488,90 +20168,30 @@
           </a:p>
         </p:txBody>
       </p:sp>
-      <p:sp>
-        <p:nvSpPr>
-          <p:cNvPr id="26" name="cts mark"/>
-          <p:cNvSpPr txBox="1"/>
-          <p:nvPr/>
-        </p:nvSpPr>
-        <p:spPr>
-          <a:xfrm>
-            <a:off x="7726679" y="155448"/>
-            <a:ext cx="914400" cy="274320"/>
-          </a:xfrm>
-          <a:prstGeom prst="rect">
-            <a:avLst/>
-          </a:prstGeom>
-          <a:noFill/>
-        </p:spPr>
-        <p:txBody>
-          <a:bodyPr wrap="none" lIns="0" rIns="0" tIns="0" bIns="0">
-            <a:spAutoFit/>
-          </a:bodyPr>
-          <a:lstStyle/>
-          <a:p>
-            <a:pPr algn="r"/>
-            <a:r>
-              <a:rPr sz="1500" b="1">
-                <a:solidFill>
-                  <a:srgbClr val="005358"/>
-                </a:solidFill>
-              </a:rPr>
-              <a:t>c</a:t>
-            </a:r>
-            <a:r>
-              <a:rPr sz="1500" b="1">
-                <a:solidFill>
-                  <a:srgbClr val="6D71FF"/>
-                </a:solidFill>
-              </a:rPr>
-              <a:t>t</a:t>
-            </a:r>
-            <a:r>
-              <a:rPr sz="1500" b="1">
-                <a:solidFill>
-                  <a:srgbClr val="F33844"/>
-                </a:solidFill>
-              </a:rPr>
-              <a:t>s</a:t>
-            </a:r>
-          </a:p>
-        </p:txBody>
-      </p:sp>
-      <p:sp>
-        <p:nvSpPr>
-          <p:cNvPr id="27" name="cts mark sub"/>
-          <p:cNvSpPr txBox="1"/>
-          <p:nvPr/>
-        </p:nvSpPr>
-        <p:spPr>
-          <a:xfrm>
-            <a:off x="7726679" y="384048"/>
-            <a:ext cx="914400" cy="164592"/>
-          </a:xfrm>
-          <a:prstGeom prst="rect">
-            <a:avLst/>
-          </a:prstGeom>
-          <a:noFill/>
-        </p:spPr>
-        <p:txBody>
-          <a:bodyPr wrap="none" lIns="0" rIns="0" tIns="0" bIns="0">
-            <a:spAutoFit/>
-          </a:bodyPr>
-          <a:lstStyle/>
-          <a:p>
-            <a:pPr algn="r"/>
-            <a:r>
-              <a:rPr sz="650">
-                <a:solidFill>
-                  <a:srgbClr val="6B7585"/>
-                </a:solidFill>
-              </a:rPr>
-              <a:t>Seamless AV</a:t>
-            </a:r>
-          </a:p>
-        </p:txBody>
-      </p:sp>
+      <p:pic>
+        <p:nvPicPr>
+          <p:cNvPr id="26" name="cts logo" descr="cts-logo.png"/>
+          <p:cNvPicPr>
+            <a:picLocks noChangeAspect="1"/>
+          </p:cNvPicPr>
+          <p:nvPr/>
+        </p:nvPicPr>
+        <p:blipFill>
+          <a:blip r:embed="rId4"/>
+          <a:stretch>
+            <a:fillRect/>
+          </a:stretch>
+        </p:blipFill>
+        <p:spPr>
+          <a:xfrm>
+            <a:off x="7680959" y="182880"/>
+            <a:ext cx="960120" cy="539696"/>
+          </a:xfrm>
+          <a:prstGeom prst="rect">
+            <a:avLst/>
+          </a:prstGeom>
+        </p:spPr>
+      </p:pic>
     </p:spTree>
   </p:cSld>
   <p:clrMapOvr>
@@ -21930,90 +20550,30 @@
           </a:p>
         </p:txBody>
       </p:sp>
-      <p:sp>
-        <p:nvSpPr>
-          <p:cNvPr id="26" name="cts mark"/>
-          <p:cNvSpPr txBox="1"/>
-          <p:nvPr/>
-        </p:nvSpPr>
-        <p:spPr>
-          <a:xfrm>
-            <a:off x="7726679" y="155448"/>
-            <a:ext cx="914400" cy="274320"/>
-          </a:xfrm>
-          <a:prstGeom prst="rect">
-            <a:avLst/>
-          </a:prstGeom>
-          <a:noFill/>
-        </p:spPr>
-        <p:txBody>
-          <a:bodyPr wrap="none" lIns="0" rIns="0" tIns="0" bIns="0">
-            <a:spAutoFit/>
-          </a:bodyPr>
-          <a:lstStyle/>
-          <a:p>
-            <a:pPr algn="r"/>
-            <a:r>
-              <a:rPr sz="1500" b="1">
-                <a:solidFill>
-                  <a:srgbClr val="005358"/>
-                </a:solidFill>
-              </a:rPr>
-              <a:t>c</a:t>
-            </a:r>
-            <a:r>
-              <a:rPr sz="1500" b="1">
-                <a:solidFill>
-                  <a:srgbClr val="6D71FF"/>
-                </a:solidFill>
-              </a:rPr>
-              <a:t>t</a:t>
-            </a:r>
-            <a:r>
-              <a:rPr sz="1500" b="1">
-                <a:solidFill>
-                  <a:srgbClr val="F33844"/>
-                </a:solidFill>
-              </a:rPr>
-              <a:t>s</a:t>
-            </a:r>
-          </a:p>
-        </p:txBody>
-      </p:sp>
-      <p:sp>
-        <p:nvSpPr>
-          <p:cNvPr id="27" name="cts mark sub"/>
-          <p:cNvSpPr txBox="1"/>
-          <p:nvPr/>
-        </p:nvSpPr>
-        <p:spPr>
-          <a:xfrm>
-            <a:off x="7726679" y="384048"/>
-            <a:ext cx="914400" cy="164592"/>
-          </a:xfrm>
-          <a:prstGeom prst="rect">
-            <a:avLst/>
-          </a:prstGeom>
-          <a:noFill/>
-        </p:spPr>
-        <p:txBody>
-          <a:bodyPr wrap="none" lIns="0" rIns="0" tIns="0" bIns="0">
-            <a:spAutoFit/>
-          </a:bodyPr>
-          <a:lstStyle/>
-          <a:p>
-            <a:pPr algn="r"/>
-            <a:r>
-              <a:rPr sz="650">
-                <a:solidFill>
-                  <a:srgbClr val="6B7585"/>
-                </a:solidFill>
-              </a:rPr>
-              <a:t>Seamless AV</a:t>
-            </a:r>
-          </a:p>
-        </p:txBody>
-      </p:sp>
+      <p:pic>
+        <p:nvPicPr>
+          <p:cNvPr id="26" name="cts logo" descr="cts-logo.png"/>
+          <p:cNvPicPr>
+            <a:picLocks noChangeAspect="1"/>
+          </p:cNvPicPr>
+          <p:nvPr/>
+        </p:nvPicPr>
+        <p:blipFill>
+          <a:blip r:embed="rId4"/>
+          <a:stretch>
+            <a:fillRect/>
+          </a:stretch>
+        </p:blipFill>
+        <p:spPr>
+          <a:xfrm>
+            <a:off x="7680959" y="182880"/>
+            <a:ext cx="960120" cy="539696"/>
+          </a:xfrm>
+          <a:prstGeom prst="rect">
+            <a:avLst/>
+          </a:prstGeom>
+        </p:spPr>
+      </p:pic>
     </p:spTree>
   </p:cSld>
   <p:clrMapOvr>

</xml_diff>

<commit_message>
Page 11 is the cumulative chart against budget, not the rolling twelve months
The rolling line was the better statistic and the worse slide. Cumulative year
to date carries more on one picture: the year is ahead of both completed years,
it is behind the plan set for it, and the plan itself is 10% below what FY25
actually billed.

A cumulative FY27 budget column added to the Xero History tab, drawn as a red
dashed line. Grey was too pale to read against white as a thin line.

The rolling twelve month block and chart stay on the Xero History tab. Useful
working, not a board slide.

Co-Authored-By: Claude Opus 5 <noreply@anthropic.com>
Claude-Session: https://claude.ai/code/session_01CVBAFohBCYXt1ufjTVDiZj
</commit_message>
<xml_diff>
--- a/deck/CTS Monthly Business Review - 30092026.pptx
+++ b/deck/CTS Monthly Business Review - 30092026.pptx
@@ -4127,55 +4127,49 @@
           <a:lstStyle/>
           <a:p>
             <a:r>
-              <a:t>Revenue on a rolling twelve month basis, taken from the Xero History tab. Each point is the total of that month and the eleven before it.</a:t>
+              <a:t>Revenue year to date on a cumulative basis, three years against the FY27 budget, taken from the Xero History tab.</a:t>
             </a:r>
           </a:p>
           <a:p/>
           <a:p>
             <a:r>
-              <a:t>This is the chart that takes the seasonality out. For a business where October can be a seven figure month and January can be a quarter of that, the month by month picture and the quarterly picture both move for reasons that have nothing to do with how the business is actually travelling. The rolling twelve months does not.</a:t>
+              <a:t>At September: FY27 $1,624,460, FY26 $1,228,582, FY25 $1,380,102, and the FY27 budget $1,996,110.</a:t>
             </a:r>
           </a:p>
           <a:p/>
           <a:p>
             <a:r>
-              <a:t>The peak was $7,000,357 at June 2025, which is the FY25 full year.</a:t>
+              <a:t>The year is ahead of both completed years at this point. It is $371,650 or 18.6% behind the budget set for it.</a:t>
             </a:r>
           </a:p>
           <a:p/>
           <a:p>
             <a:r>
-              <a:t>It fell from there for seven straight months to $5,817,190 at January 2026, a fall of $1,183,167 or 16.9%. January 2026 is the single worst month in the three years at $268,631 against $918,289 the year before, and it drags the rolling figure down the moment it enters the window.</a:t>
+              <a:t>Where that gap came from, month by month. July was $150,228 behind budget. August was $369,702 behind, which is where almost all of it opened. September was $148,280 ahead of budget, which closed part of it back. August was budgeted at $973,168, the second largest month of the FY27 budget, and billed $603,467.</a:t>
             </a:r>
           </a:p>
           <a:p/>
           <a:p>
             <a:r>
-              <a:t>Since January the line has turned up. It now stands at $6,509,064 at September 2026, which is $691,874 or 11.9% above the trough.</a:t>
+              <a:t>What the two completed lines show is where a year gets lost. FY25 and FY26 track each other almost exactly from July to November. They separate in December and January. December was $395,542 behind and January $649,658 behind, $1,045,200 across the two months, against a full year gap of $887,171. Every other month of FY26 combined was ahead of FY25.</a:t>
             </a:r>
           </a:p>
           <a:p/>
           <a:p>
             <a:r>
-              <a:t>It is still $491,293 or 7.0% below the peak.</a:t>
+              <a:t>That matters now because FY27 is about to enter the same two months, and the budget has December at $344,970 and January at $353,969, both well below what FY25 billed in them.</a:t>
             </a:r>
           </a:p>
           <a:p/>
           <a:p>
             <a:r>
-              <a:t>That is the honest position. The business is recovering and the direction is right, but it has not yet got back to where it was fifteen months ago. Quarterly growth of 32% measured off the weakest quarter of the three years does not describe a business at a record. This line does.</a:t>
+              <a:t>The last point is the budget itself. The full year FY27 budget is $6,304,601. FY25 actually billed $7,000,357. The plan for this year is $695,756 or 9.9% below what the business delivered two years ago, and $191,415 or 3.1% above FY26. Being 18.6% behind that budget is the gap against a plan that was already set below the FY25 result.</a:t>
             </a:r>
           </a:p>
           <a:p/>
           <a:p>
             <a:r>
-              <a:t>The line begins at June 2025 because that is the first month with twelve months of Xero history behind it, and it stops at September 2026 because that is the last closed month.</a:t>
-            </a:r>
-          </a:p>
-          <a:p/>
-          <a:p>
-            <a:r>
-              <a:t>One note on the chart itself. The scale starts at five million rather than at zero. This series only moves between $5.8 million and $7.0 million, and drawn from zero it is a flat line with a 17% fall invisible in it. The axis labels show where the scale starts.</a:t>
+              <a:t>The FY27 line stops at September because the months beyond it hold budget rather than actuals. The budget line runs the full year because a budget is set for the whole year.</a:t>
             </a:r>
           </a:p>
         </p:txBody>
@@ -6170,6 +6164,384 @@
 </file>
 
 <file path=ppt/slides/slide11.xml><?xml version="1.0" encoding="utf-8"?>
+<p:sld xmlns:a="http://schemas.openxmlformats.org/drawingml/2006/main" xmlns:p="http://schemas.openxmlformats.org/presentationml/2006/main" xmlns:r="http://schemas.openxmlformats.org/officeDocument/2006/relationships">
+  <p:cSld>
+    <p:spTree>
+      <p:nvGrpSpPr>
+        <p:cNvPr id="1" name=""/>
+        <p:cNvGrpSpPr/>
+        <p:nvPr/>
+      </p:nvGrpSpPr>
+      <p:grpSpPr/>
+      <p:pic>
+        <p:nvPicPr>
+          <p:cNvPr id="27" name="snip xero_cum" descr="xero_cum.png"/>
+          <p:cNvPicPr>
+            <a:picLocks noChangeAspect="1"/>
+          </p:cNvPicPr>
+          <p:nvPr/>
+        </p:nvPicPr>
+        <p:blipFill>
+          <a:blip r:embed="rId5"/>
+          <a:stretch>
+            <a:fillRect/>
+          </a:stretch>
+        </p:blipFill>
+        <p:spPr>
+          <a:xfrm>
+            <a:off x="1362886" y="1115568"/>
+            <a:ext cx="6418226" cy="2397673"/>
+          </a:xfrm>
+          <a:prstGeom prst="rect">
+            <a:avLst/>
+          </a:prstGeom>
+        </p:spPr>
+      </p:pic>
+      <p:sp>
+        <p:nvSpPr>
+          <p:cNvPr id="2" name="Text 0"/>
+          <p:cNvSpPr txBox="1"/>
+          <p:nvPr/>
+        </p:nvSpPr>
+        <p:spPr>
+          <a:xfrm>
+            <a:off x="502920" y="365760"/>
+            <a:ext cx="6400800" cy="274320"/>
+          </a:xfrm>
+          <a:prstGeom prst="rect">
+            <a:avLst/>
+          </a:prstGeom>
+          <a:noFill/>
+          <a:ln/>
+        </p:spPr>
+        <p:txBody>
+          <a:bodyPr wrap="square" lIns="0" tIns="0" rIns="0" bIns="0" rtlCol="0" anchor="ctr"/>
+          <a:lstStyle/>
+          <a:p>
+            <a:pPr marL="0" indent="0">
+              <a:buNone/>
+            </a:pPr>
+            <a:r>
+              <a:rPr lang="en-US" sz="950" b="1" kern="0" spc="220">
+                <a:solidFill>
+                  <a:srgbClr val="122B82"/>
+                </a:solidFill>
+              </a:rPr>
+              <a:t>FINANCIAL PERFORMANCE</a:t>
+            </a:r>
+            <a:endParaRPr lang="en-US" sz="950"/>
+          </a:p>
+        </p:txBody>
+      </p:sp>
+      <p:sp>
+        <p:nvSpPr>
+          <p:cNvPr id="3" name="Text 1"/>
+          <p:cNvSpPr txBox="1"/>
+          <p:nvPr/>
+        </p:nvSpPr>
+        <p:spPr>
+          <a:xfrm>
+            <a:off x="502920" y="640080"/>
+            <a:ext cx="7315200" cy="685800"/>
+          </a:xfrm>
+          <a:prstGeom prst="rect">
+            <a:avLst/>
+          </a:prstGeom>
+          <a:noFill/>
+          <a:ln/>
+        </p:spPr>
+        <p:txBody>
+          <a:bodyPr wrap="square" lIns="0" tIns="0" rIns="0" bIns="0" rtlCol="0" anchor="ctr"/>
+          <a:lstStyle/>
+          <a:p>
+            <a:pPr marL="0" indent="0">
+              <a:buNone/>
+            </a:pPr>
+            <a:r>
+              <a:rPr lang="en-US" sz="2200" b="1">
+                <a:solidFill>
+                  <a:srgbClr val="242C39"/>
+                </a:solidFill>
+              </a:rPr>
+              <a:t>Revenue year to date, against budget</a:t>
+            </a:r>
+            <a:endParaRPr lang="en-US" sz="2700"/>
+          </a:p>
+        </p:txBody>
+      </p:sp>
+      <p:sp>
+        <p:nvSpPr>
+          <p:cNvPr id="6" name="commentary panel"/>
+          <p:cNvSpPr/>
+          <p:nvPr/>
+        </p:nvSpPr>
+        <p:spPr>
+          <a:xfrm>
+            <a:off x="502920" y="3622969"/>
+            <a:ext cx="8138160" cy="1003894"/>
+          </a:xfrm>
+          <a:prstGeom prst="rect">
+            <a:avLst/>
+          </a:prstGeom>
+          <a:solidFill>
+            <a:srgbClr val="E8F9F8"/>
+          </a:solidFill>
+          <a:ln/>
+        </p:spPr>
+        <p:txBody>
+          <a:bodyPr/>
+          <a:lstStyle/>
+          <a:p>
+            <a:endParaRPr lang="en-AU"/>
+          </a:p>
+        </p:txBody>
+      </p:sp>
+      <p:sp>
+        <p:nvSpPr>
+          <p:cNvPr id="7" name="Text 4"/>
+          <p:cNvSpPr txBox="1"/>
+          <p:nvPr/>
+        </p:nvSpPr>
+        <p:spPr>
+          <a:xfrm>
+            <a:off x="685800" y="3696121"/>
+            <a:ext cx="2743200" cy="228600"/>
+          </a:xfrm>
+          <a:prstGeom prst="rect">
+            <a:avLst/>
+          </a:prstGeom>
+          <a:noFill/>
+          <a:ln/>
+        </p:spPr>
+        <p:txBody>
+          <a:bodyPr wrap="square" lIns="0" tIns="0" rIns="0" bIns="0" rtlCol="0" anchor="ctr"/>
+          <a:lstStyle/>
+          <a:p>
+            <a:pPr marL="0" indent="0">
+              <a:buNone/>
+            </a:pPr>
+            <a:r>
+              <a:rPr lang="en-US" sz="900" b="1" kern="0" spc="180">
+                <a:solidFill>
+                  <a:srgbClr val="005358"/>
+                </a:solidFill>
+              </a:rPr>
+              <a:t>COMMENTARY</a:t>
+            </a:r>
+            <a:endParaRPr lang="en-US" sz="900"/>
+          </a:p>
+        </p:txBody>
+      </p:sp>
+      <p:sp>
+        <p:nvSpPr>
+          <p:cNvPr id="8" name="Text 5"/>
+          <p:cNvSpPr txBox="1"/>
+          <p:nvPr/>
+        </p:nvSpPr>
+        <p:spPr>
+          <a:xfrm>
+            <a:off x="685800" y="3869857"/>
+            <a:ext cx="3703320" cy="729574"/>
+          </a:xfrm>
+          <a:prstGeom prst="rect">
+            <a:avLst/>
+          </a:prstGeom>
+          <a:noFill/>
+          <a:ln/>
+        </p:spPr>
+        <p:txBody>
+          <a:bodyPr wrap="square" lIns="0" tIns="0" rIns="0" bIns="0" rtlCol="0" anchor="t">
+            <a:normAutofit fontScale="85000" lnSpcReduction="10000"/>
+          </a:bodyPr>
+          <a:lstStyle/>
+          <a:p>
+            <a:pPr marL="342900" indent="-342900">
+              <a:lnSpc>
+                <a:spcPts val="1050"/>
+              </a:lnSpc>
+              <a:spcAft>
+                <a:spcPts val="400"/>
+              </a:spcAft>
+              <a:buSzPct val="100000"/>
+              <a:buChar char="•"/>
+            </a:pPr>
+            <a:r>
+              <a:rPr lang="en-US" sz="1000">
+                <a:solidFill>
+                  <a:srgbClr val="3A4453"/>
+                </a:solidFill>
+              </a:rPr>
+              <a:t>Year to date revenue is $1,624k, ahead of both completed years at this point in the year.</a:t>
+            </a:r>
+            <a:endParaRPr lang="en-US" sz="850"/>
+          </a:p>
+          <a:p>
+            <a:pPr marL="342900" indent="-342900">
+              <a:lnSpc>
+                <a:spcPts val="1050"/>
+              </a:lnSpc>
+              <a:spcAft>
+                <a:spcPts val="400"/>
+              </a:spcAft>
+              <a:buSzPct val="100000"/>
+              <a:buChar char="•"/>
+            </a:pPr>
+            <a:r>
+              <a:rPr lang="en-US" sz="1000">
+                <a:solidFill>
+                  <a:srgbClr val="3A4453"/>
+                </a:solidFill>
+              </a:rPr>
+              <a:t>It is $372k or 19% behind budget. Almost all of that opened in August, and September closed $148k of it back.</a:t>
+            </a:r>
+            <a:endParaRPr lang="en-US" sz="850"/>
+          </a:p>
+        </p:txBody>
+      </p:sp>
+      <p:sp>
+        <p:nvSpPr>
+          <p:cNvPr id="25" name="Slide Number Placeholder 0"/>
+          <p:cNvSpPr>
+            <a:spLocks noGrp="1"/>
+          </p:cNvSpPr>
+          <p:nvPr>
+            <p:ph type="sldNum" sz="quarter" idx="4294967295"/>
+          </p:nvPr>
+        </p:nvSpPr>
+        <p:spPr>
+          <a:xfrm>
+            <a:off x="8092440" y="4736592"/>
+            <a:ext cx="548640" cy="228600"/>
+          </a:xfrm>
+          <a:prstGeom prst="rect">
+            <a:avLst/>
+          </a:prstGeom>
+          <a:extLst>
+            <a:ext uri="{C572A759-6A51-4108-AA02-DFA0A04FC94B}">
+              <ma14:wrappingTextBoxFlag xmlns:ma14="http://schemas.microsoft.com/office/mac/drawingml/2011/main" xmlns="" val="0"/>
+            </a:ext>
+          </a:extLst>
+        </p:spPr>
+        <p:txBody>
+          <a:bodyPr/>
+          <a:lstStyle>
+            <a:lvl1pPr>
+              <a:defRPr sz="800">
+                <a:solidFill>
+                  <a:srgbClr val="6B7585"/>
+                </a:solidFill>
+              </a:defRPr>
+            </a:lvl1pPr>
+          </a:lstStyle>
+          <a:p>
+            <a:pPr algn="r"/>
+            <a:fld id="{F7021451-1387-4CA6-816F-3879F97B5CBC}" type="slidenum">
+              <a:rPr lang="en-US" b="0"/>
+              <a:t>16</a:t>
+            </a:fld>
+            <a:endParaRPr lang="en-US"/>
+          </a:p>
+        </p:txBody>
+      </p:sp>
+      <p:sp>
+        <p:nvSpPr>
+          <p:cNvPr id="8" name="Text 5b"/>
+          <p:cNvSpPr txBox="1"/>
+          <p:nvPr/>
+        </p:nvSpPr>
+        <p:spPr>
+          <a:xfrm>
+            <a:off x="4663440" y="3869857"/>
+            <a:ext cx="3703320" cy="729574"/>
+          </a:xfrm>
+          <a:prstGeom prst="rect">
+            <a:avLst/>
+          </a:prstGeom>
+          <a:noFill/>
+          <a:ln/>
+        </p:spPr>
+        <p:txBody>
+          <a:bodyPr wrap="square" lIns="0" tIns="0" rIns="0" bIns="0" rtlCol="0" anchor="t">
+            <a:normAutofit fontScale="85000" lnSpcReduction="10000"/>
+          </a:bodyPr>
+          <a:lstStyle/>
+          <a:p>
+            <a:pPr marL="342900" indent="-342900">
+              <a:lnSpc>
+                <a:spcPts val="1050"/>
+              </a:lnSpc>
+              <a:spcAft>
+                <a:spcPts val="400"/>
+              </a:spcAft>
+              <a:buSzPct val="100000"/>
+              <a:buChar char="•"/>
+            </a:pPr>
+            <a:r>
+              <a:rPr lang="en-US" sz="1000">
+                <a:solidFill>
+                  <a:srgbClr val="3A4453"/>
+                </a:solidFill>
+              </a:rPr>
+              <a:t>FY26 lost its year in December and January, $1,045k behind FY25 across those two months.</a:t>
+            </a:r>
+            <a:endParaRPr lang="en-US" sz="850"/>
+          </a:p>
+          <a:p>
+            <a:pPr marL="342900" indent="-342900">
+              <a:lnSpc>
+                <a:spcPts val="1050"/>
+              </a:lnSpc>
+              <a:spcAft>
+                <a:spcPts val="400"/>
+              </a:spcAft>
+              <a:buSzPct val="100000"/>
+              <a:buChar char="•"/>
+            </a:pPr>
+            <a:r>
+              <a:rPr lang="en-US" sz="1000">
+                <a:solidFill>
+                  <a:srgbClr val="3A4453"/>
+                </a:solidFill>
+              </a:rPr>
+              <a:t>The full year budget of $6,305k is itself 10% below what FY25 actually billed.</a:t>
+            </a:r>
+            <a:endParaRPr lang="en-US" sz="850"/>
+          </a:p>
+        </p:txBody>
+      </p:sp>
+      <p:pic>
+        <p:nvPicPr>
+          <p:cNvPr id="26" name="cts logo" descr="image.png"/>
+          <p:cNvPicPr>
+            <a:picLocks noChangeAspect="1"/>
+          </p:cNvPicPr>
+          <p:nvPr/>
+        </p:nvPicPr>
+        <p:blipFill>
+          <a:blip r:embed="rId2"/>
+          <a:stretch>
+            <a:fillRect/>
+          </a:stretch>
+        </p:blipFill>
+        <p:spPr>
+          <a:xfrm>
+            <a:off x="7680959" y="182880"/>
+            <a:ext cx="960120" cy="539696"/>
+          </a:xfrm>
+          <a:prstGeom prst="rect">
+            <a:avLst/>
+          </a:prstGeom>
+        </p:spPr>
+      </p:pic>
+    </p:spTree>
+  </p:cSld>
+  <p:clrMapOvr>
+    <a:masterClrMapping/>
+  </p:clrMapOvr>
+</p:sld>
+</file>
+
+<file path=ppt/slides/slide12.xml><?xml version="1.0" encoding="utf-8"?>
 <p:sld xmlns:a="http://schemas.openxmlformats.org/drawingml/2006/main" xmlns:r="http://schemas.openxmlformats.org/officeDocument/2006/relationships" xmlns:p="http://schemas.openxmlformats.org/presentationml/2006/main">
   <p:cSld name="Slide 6">
     <p:spTree>
@@ -6575,7 +6947,7 @@
 </p:sld>
 </file>
 
-<file path=ppt/slides/slide12.xml><?xml version="1.0" encoding="utf-8"?>
+<file path=ppt/slides/slide13.xml><?xml version="1.0" encoding="utf-8"?>
 <p:sld xmlns:a="http://schemas.openxmlformats.org/drawingml/2006/main" xmlns:r="http://schemas.openxmlformats.org/officeDocument/2006/relationships" xmlns:p="http://schemas.openxmlformats.org/presentationml/2006/main">
   <p:cSld name="Slide 7">
     <p:spTree>
@@ -6960,7 +7332,7 @@
 </p:sld>
 </file>
 
-<file path=ppt/slides/slide13.xml><?xml version="1.0" encoding="utf-8"?>
+<file path=ppt/slides/slide14.xml><?xml version="1.0" encoding="utf-8"?>
 <p:sld xmlns:a="http://schemas.openxmlformats.org/drawingml/2006/main" xmlns:r="http://schemas.openxmlformats.org/officeDocument/2006/relationships" xmlns:p="http://schemas.openxmlformats.org/presentationml/2006/main">
   <p:cSld name="Slide 8">
     <p:spTree>
@@ -7345,7 +7717,7 @@
 </p:sld>
 </file>
 
-<file path=ppt/slides/slide14.xml><?xml version="1.0" encoding="utf-8"?>
+<file path=ppt/slides/slide15.xml><?xml version="1.0" encoding="utf-8"?>
 <p:sld xmlns:a="http://schemas.openxmlformats.org/drawingml/2006/main" xmlns:r="http://schemas.openxmlformats.org/officeDocument/2006/relationships" xmlns:p="http://schemas.openxmlformats.org/presentationml/2006/main">
   <p:cSld name="Slide 9">
     <p:spTree>
@@ -7751,7 +8123,7 @@
 </p:sld>
 </file>
 
-<file path=ppt/slides/slide15.xml><?xml version="1.0" encoding="utf-8"?>
+<file path=ppt/slides/slide16.xml><?xml version="1.0" encoding="utf-8"?>
 <p:sld xmlns:a="http://schemas.openxmlformats.org/drawingml/2006/main" xmlns:r="http://schemas.openxmlformats.org/officeDocument/2006/relationships" xmlns:p="http://schemas.openxmlformats.org/presentationml/2006/main">
   <p:cSld name="Slide 10">
     <p:spTree>
@@ -8157,7 +8529,7 @@
 </p:sld>
 </file>
 
-<file path=ppt/slides/slide16.xml><?xml version="1.0" encoding="utf-8"?>
+<file path=ppt/slides/slide17.xml><?xml version="1.0" encoding="utf-8"?>
 <p:sld xmlns:a="http://schemas.openxmlformats.org/drawingml/2006/main" xmlns:r="http://schemas.openxmlformats.org/officeDocument/2006/relationships" xmlns:p="http://schemas.openxmlformats.org/presentationml/2006/main">
   <p:cSld name="Slide 11">
     <p:spTree>
@@ -8563,7 +8935,7 @@
 </p:sld>
 </file>
 
-<file path=ppt/slides/slide17.xml><?xml version="1.0" encoding="utf-8"?>
+<file path=ppt/slides/slide18.xml><?xml version="1.0" encoding="utf-8"?>
 <p:sld xmlns:a="http://schemas.openxmlformats.org/drawingml/2006/main" xmlns:r="http://schemas.openxmlformats.org/officeDocument/2006/relationships" xmlns:p="http://schemas.openxmlformats.org/presentationml/2006/main">
   <p:cSld name="Slide 12">
     <p:spTree>
@@ -8969,7 +9341,7 @@
 </p:sld>
 </file>
 
-<file path=ppt/slides/slide18.xml><?xml version="1.0" encoding="utf-8"?>
+<file path=ppt/slides/slide19.xml><?xml version="1.0" encoding="utf-8"?>
 <p:sld xmlns:a="http://schemas.openxmlformats.org/drawingml/2006/main" xmlns:r="http://schemas.openxmlformats.org/officeDocument/2006/relationships" xmlns:p="http://schemas.openxmlformats.org/presentationml/2006/main">
   <p:cSld name="Slide 13">
     <p:spTree>
@@ -9364,412 +9736,6 @@
               <a:t>Management should review the department's future structure, capacity and commercial viability, including whether to rebuild or combine its activities.</a:t>
             </a:r>
             <a:endParaRPr lang="en-US" sz="950"/>
-          </a:p>
-        </p:txBody>
-      </p:sp>
-    </p:spTree>
-  </p:cSld>
-  <p:clrMapOvr>
-    <a:masterClrMapping/>
-  </p:clrMapOvr>
-</p:sld>
-</file>
-
-<file path=ppt/slides/slide19.xml><?xml version="1.0" encoding="utf-8"?>
-<p:sld xmlns:a="http://schemas.openxmlformats.org/drawingml/2006/main" xmlns:r="http://schemas.openxmlformats.org/officeDocument/2006/relationships" xmlns:p="http://schemas.openxmlformats.org/presentationml/2006/main">
-  <p:cSld name="Slide 14">
-    <p:spTree>
-      <p:nvGrpSpPr>
-        <p:cNvPr id="1" name=""/>
-        <p:cNvGrpSpPr/>
-        <p:nvPr/>
-      </p:nvGrpSpPr>
-      <p:grpSpPr>
-        <a:xfrm>
-          <a:off x="0" y="0"/>
-          <a:ext cx="0" cy="0"/>
-          <a:chOff x="0" y="0"/>
-          <a:chExt cx="0" cy="0"/>
-        </a:xfrm>
-      </p:grpSpPr>
-      <p:pic>
-        <p:nvPicPr>
-          <p:cNvPr id="27" name="snip rev_by_dept" descr="image.png"/>
-          <p:cNvPicPr>
-            <a:picLocks noChangeAspect="1"/>
-          </p:cNvPicPr>
-          <p:nvPr/>
-        </p:nvPicPr>
-        <p:blipFill>
-          <a:blip r:embed="rId3"/>
-          <a:stretch>
-            <a:fillRect/>
-          </a:stretch>
-        </p:blipFill>
-        <p:spPr>
-          <a:xfrm>
-            <a:off x="2234229" y="1115568"/>
-            <a:ext cx="4675541" cy="2005865"/>
-          </a:xfrm>
-          <a:prstGeom prst="rect">
-            <a:avLst/>
-          </a:prstGeom>
-        </p:spPr>
-      </p:pic>
-      <p:sp>
-        <p:nvSpPr>
-          <p:cNvPr id="2" name="Text 0"/>
-          <p:cNvSpPr txBox="1"/>
-          <p:nvPr/>
-        </p:nvSpPr>
-        <p:spPr>
-          <a:xfrm>
-            <a:off x="502920" y="365760"/>
-            <a:ext cx="6400800" cy="274320"/>
-          </a:xfrm>
-          <a:prstGeom prst="rect">
-            <a:avLst/>
-          </a:prstGeom>
-          <a:noFill/>
-          <a:ln/>
-        </p:spPr>
-        <p:txBody>
-          <a:bodyPr wrap="square" lIns="0" tIns="0" rIns="0" bIns="0" rtlCol="0" anchor="ctr"/>
-          <a:lstStyle/>
-          <a:p>
-            <a:pPr marL="0" indent="0">
-              <a:buNone/>
-            </a:pPr>
-            <a:r>
-              <a:rPr lang="en-US" sz="950" b="1" kern="0" spc="220">
-                <a:solidFill>
-                  <a:srgbClr val="122B82"/>
-                </a:solidFill>
-              </a:rPr>
-              <a:t>FINANCIAL PERFORMANCE</a:t>
-            </a:r>
-            <a:endParaRPr lang="en-US" sz="950"/>
-          </a:p>
-        </p:txBody>
-      </p:sp>
-      <p:sp>
-        <p:nvSpPr>
-          <p:cNvPr id="3" name="Text 1"/>
-          <p:cNvSpPr txBox="1"/>
-          <p:nvPr/>
-        </p:nvSpPr>
-        <p:spPr>
-          <a:xfrm>
-            <a:off x="502920" y="640080"/>
-            <a:ext cx="7315200" cy="685800"/>
-          </a:xfrm>
-          <a:prstGeom prst="rect">
-            <a:avLst/>
-          </a:prstGeom>
-          <a:noFill/>
-          <a:ln/>
-        </p:spPr>
-        <p:txBody>
-          <a:bodyPr wrap="square" lIns="0" tIns="0" rIns="0" bIns="0" rtlCol="0" anchor="ctr"/>
-          <a:lstStyle/>
-          <a:p>
-            <a:pPr marL="0" indent="0">
-              <a:buNone/>
-            </a:pPr>
-            <a:r>
-              <a:rPr lang="en-US" sz="2200" b="1">
-                <a:solidFill>
-                  <a:srgbClr val="242C39"/>
-                </a:solidFill>
-              </a:rPr>
-              <a:t>Revenue against budget and last year</a:t>
-            </a:r>
-            <a:endParaRPr lang="en-US" sz="2700"/>
-          </a:p>
-        </p:txBody>
-      </p:sp>
-      <p:sp>
-        <p:nvSpPr>
-          <p:cNvPr id="6" name="commentary panel"/>
-          <p:cNvSpPr/>
-          <p:nvPr/>
-        </p:nvSpPr>
-        <p:spPr>
-          <a:xfrm>
-            <a:off x="502920" y="3231161"/>
-            <a:ext cx="8138160" cy="1395702"/>
-          </a:xfrm>
-          <a:prstGeom prst="rect">
-            <a:avLst/>
-          </a:prstGeom>
-          <a:solidFill>
-            <a:srgbClr val="E8F9F8"/>
-          </a:solidFill>
-          <a:ln/>
-        </p:spPr>
-        <p:txBody>
-          <a:bodyPr/>
-          <a:lstStyle/>
-          <a:p>
-            <a:endParaRPr lang="en-AU"/>
-          </a:p>
-        </p:txBody>
-      </p:sp>
-      <p:sp>
-        <p:nvSpPr>
-          <p:cNvPr id="7" name="Text 4"/>
-          <p:cNvSpPr txBox="1"/>
-          <p:nvPr/>
-        </p:nvSpPr>
-        <p:spPr>
-          <a:xfrm>
-            <a:off x="685800" y="3304313"/>
-            <a:ext cx="2743200" cy="228600"/>
-          </a:xfrm>
-          <a:prstGeom prst="rect">
-            <a:avLst/>
-          </a:prstGeom>
-          <a:noFill/>
-          <a:ln/>
-        </p:spPr>
-        <p:txBody>
-          <a:bodyPr wrap="square" lIns="0" tIns="0" rIns="0" bIns="0" rtlCol="0" anchor="ctr"/>
-          <a:lstStyle/>
-          <a:p>
-            <a:pPr marL="0" indent="0">
-              <a:buNone/>
-            </a:pPr>
-            <a:r>
-              <a:rPr lang="en-US" sz="900" b="1" kern="0" spc="180">
-                <a:solidFill>
-                  <a:srgbClr val="005358"/>
-                </a:solidFill>
-              </a:rPr>
-              <a:t>COMMENTARY</a:t>
-            </a:r>
-            <a:endParaRPr lang="en-US" sz="900"/>
-          </a:p>
-        </p:txBody>
-      </p:sp>
-      <p:sp>
-        <p:nvSpPr>
-          <p:cNvPr id="8" name="Text 5"/>
-          <p:cNvSpPr txBox="1"/>
-          <p:nvPr/>
-        </p:nvSpPr>
-        <p:spPr>
-          <a:xfrm>
-            <a:off x="685800" y="3478049"/>
-            <a:ext cx="3703320" cy="1121382"/>
-          </a:xfrm>
-          <a:prstGeom prst="rect">
-            <a:avLst/>
-          </a:prstGeom>
-          <a:noFill/>
-          <a:ln/>
-        </p:spPr>
-        <p:txBody>
-          <a:bodyPr wrap="square" lIns="0" tIns="0" rIns="0" bIns="0" rtlCol="0" anchor="t">
-            <a:normAutofit fontScale="92500"/>
-          </a:bodyPr>
-          <a:lstStyle/>
-          <a:p>
-            <a:pPr marL="342900" indent="-342900">
-              <a:lnSpc>
-                <a:spcPts val="1050"/>
-              </a:lnSpc>
-              <a:spcAft>
-                <a:spcPts val="400"/>
-              </a:spcAft>
-              <a:buSzPct val="100000"/>
-              <a:buChar char="•"/>
-            </a:pPr>
-            <a:r>
-              <a:rPr lang="en-US" sz="1000">
-                <a:solidFill>
-                  <a:srgbClr val="3A4453"/>
-                </a:solidFill>
-              </a:rPr>
-              <a:t>Integration generated $235k revenue against a $59k budget, mainly from a completed installation project. This result may not recur in October.</a:t>
-            </a:r>
-            <a:endParaRPr lang="en-US" sz="850"/>
-          </a:p>
-          <a:p>
-            <a:pPr marL="342900" indent="-342900">
-              <a:lnSpc>
-                <a:spcPts val="1050"/>
-              </a:lnSpc>
-              <a:spcAft>
-                <a:spcPts val="400"/>
-              </a:spcAft>
-              <a:buSzPct val="100000"/>
-              <a:buChar char="•"/>
-            </a:pPr>
-            <a:r>
-              <a:rPr lang="en-US" sz="1000">
-                <a:solidFill>
-                  <a:srgbClr val="3A4453"/>
-                </a:solidFill>
-              </a:rPr>
-              <a:t>Support recorded $243k revenue against a $248k budget, remaining broadly in line with recurring contracts.</a:t>
-            </a:r>
-            <a:endParaRPr lang="en-US" sz="850"/>
-          </a:p>
-        </p:txBody>
-      </p:sp>
-      <p:sp>
-        <p:nvSpPr>
-          <p:cNvPr id="25" name="Slide Number Placeholder 0"/>
-          <p:cNvSpPr>
-            <a:spLocks noGrp="1"/>
-          </p:cNvSpPr>
-          <p:nvPr>
-            <p:ph type="sldNum" sz="quarter" idx="4294967295"/>
-          </p:nvPr>
-        </p:nvSpPr>
-        <p:spPr>
-          <a:xfrm>
-            <a:off x="8092440" y="4736592"/>
-            <a:ext cx="548640" cy="228600"/>
-          </a:xfrm>
-          <a:prstGeom prst="rect">
-            <a:avLst/>
-          </a:prstGeom>
-          <a:extLst>
-            <a:ext uri="{C572A759-6A51-4108-AA02-DFA0A04FC94B}">
-              <ma14:wrappingTextBoxFlag xmlns:ma14="http://schemas.microsoft.com/office/mac/drawingml/2011/main" xmlns="" val="0"/>
-            </a:ext>
-          </a:extLst>
-        </p:spPr>
-        <p:txBody>
-          <a:bodyPr/>
-          <a:lstStyle>
-            <a:lvl1pPr>
-              <a:defRPr sz="800">
-                <a:solidFill>
-                  <a:srgbClr val="6B7585"/>
-                </a:solidFill>
-              </a:defRPr>
-            </a:lvl1pPr>
-          </a:lstStyle>
-          <a:p>
-            <a:pPr algn="r"/>
-            <a:fld id="{F7021451-1387-4CA6-816F-3879F97B5CBC}" type="slidenum">
-              <a:rPr lang="en-US" b="0"/>
-              <a:t>14</a:t>
-            </a:fld>
-            <a:endParaRPr lang="en-US"/>
-          </a:p>
-        </p:txBody>
-      </p:sp>
-      <p:pic>
-        <p:nvPicPr>
-          <p:cNvPr id="26" name="cts logo" descr="cts-logo.png"/>
-          <p:cNvPicPr>
-            <a:picLocks noChangeAspect="1"/>
-          </p:cNvPicPr>
-          <p:nvPr/>
-        </p:nvPicPr>
-        <p:blipFill>
-          <a:blip r:embed="rId4"/>
-          <a:stretch>
-            <a:fillRect/>
-          </a:stretch>
-        </p:blipFill>
-        <p:spPr>
-          <a:xfrm>
-            <a:off x="7680959" y="182880"/>
-            <a:ext cx="960120" cy="539696"/>
-          </a:xfrm>
-          <a:prstGeom prst="rect">
-            <a:avLst/>
-          </a:prstGeom>
-        </p:spPr>
-      </p:pic>
-      <p:sp>
-        <p:nvSpPr>
-          <p:cNvPr id="8" name="Text 5b"/>
-          <p:cNvSpPr txBox="1"/>
-          <p:nvPr/>
-        </p:nvSpPr>
-        <p:spPr>
-          <a:xfrm>
-            <a:off x="4663440" y="3478049"/>
-            <a:ext cx="3703320" cy="1121382"/>
-          </a:xfrm>
-          <a:prstGeom prst="rect">
-            <a:avLst/>
-          </a:prstGeom>
-          <a:noFill/>
-          <a:ln/>
-        </p:spPr>
-        <p:txBody>
-          <a:bodyPr wrap="square" lIns="0" tIns="0" rIns="0" bIns="0" rtlCol="0" anchor="t">
-            <a:normAutofit fontScale="92500"/>
-          </a:bodyPr>
-          <a:lstStyle/>
-          <a:p>
-            <a:pPr marL="342900" indent="-342900">
-              <a:lnSpc>
-                <a:spcPts val="1050"/>
-              </a:lnSpc>
-              <a:spcAft>
-                <a:spcPts val="400"/>
-              </a:spcAft>
-              <a:buSzPct val="100000"/>
-              <a:buChar char="•"/>
-            </a:pPr>
-            <a:r>
-              <a:rPr lang="en-US" sz="1000">
-                <a:solidFill>
-                  <a:srgbClr val="3A4453"/>
-                </a:solidFill>
-              </a:rPr>
-              <a:t>Events delivered $73k revenue against a $66k budget.</a:t>
-            </a:r>
-            <a:endParaRPr lang="en-US" sz="850"/>
-          </a:p>
-          <a:p>
-            <a:pPr marL="342900" indent="-342900">
-              <a:lnSpc>
-                <a:spcPts val="1050"/>
-              </a:lnSpc>
-              <a:spcAft>
-                <a:spcPts val="400"/>
-              </a:spcAft>
-              <a:buSzPct val="100000"/>
-              <a:buChar char="•"/>
-            </a:pPr>
-            <a:r>
-              <a:rPr lang="en-US" sz="1000">
-                <a:solidFill>
-                  <a:srgbClr val="3A4453"/>
-                </a:solidFill>
-              </a:rPr>
-              <a:t>Video recorded $7k against $17k, and Consulting $4k against $23k. Both remain below budget for the third consecutive month.</a:t>
-            </a:r>
-            <a:endParaRPr lang="en-US" sz="850"/>
-          </a:p>
-          <a:p>
-            <a:pPr marL="342900" indent="-342900">
-              <a:lnSpc>
-                <a:spcPts val="1050"/>
-              </a:lnSpc>
-              <a:spcAft>
-                <a:spcPts val="400"/>
-              </a:spcAft>
-              <a:buSzPct val="100000"/>
-              <a:buChar char="•"/>
-            </a:pPr>
-            <a:r>
-              <a:rPr lang="en-US" sz="1000">
-                <a:solidFill>
-                  <a:srgbClr val="3A4453"/>
-                </a:solidFill>
-              </a:rPr>
-              <a:t>Total revenue increased 58% against September last year, although the gross margin percentage declined.</a:t>
-            </a:r>
-            <a:endParaRPr lang="en-US" sz="850"/>
           </a:p>
         </p:txBody>
       </p:sp>
@@ -10624,6 +10590,412 @@
 
 <file path=ppt/slides/slide20.xml><?xml version="1.0" encoding="utf-8"?>
 <p:sld xmlns:a="http://schemas.openxmlformats.org/drawingml/2006/main" xmlns:r="http://schemas.openxmlformats.org/officeDocument/2006/relationships" xmlns:p="http://schemas.openxmlformats.org/presentationml/2006/main">
+  <p:cSld name="Slide 14">
+    <p:spTree>
+      <p:nvGrpSpPr>
+        <p:cNvPr id="1" name=""/>
+        <p:cNvGrpSpPr/>
+        <p:nvPr/>
+      </p:nvGrpSpPr>
+      <p:grpSpPr>
+        <a:xfrm>
+          <a:off x="0" y="0"/>
+          <a:ext cx="0" cy="0"/>
+          <a:chOff x="0" y="0"/>
+          <a:chExt cx="0" cy="0"/>
+        </a:xfrm>
+      </p:grpSpPr>
+      <p:pic>
+        <p:nvPicPr>
+          <p:cNvPr id="27" name="snip rev_by_dept" descr="image.png"/>
+          <p:cNvPicPr>
+            <a:picLocks noChangeAspect="1"/>
+          </p:cNvPicPr>
+          <p:nvPr/>
+        </p:nvPicPr>
+        <p:blipFill>
+          <a:blip r:embed="rId3"/>
+          <a:stretch>
+            <a:fillRect/>
+          </a:stretch>
+        </p:blipFill>
+        <p:spPr>
+          <a:xfrm>
+            <a:off x="2234229" y="1115568"/>
+            <a:ext cx="4675541" cy="2005865"/>
+          </a:xfrm>
+          <a:prstGeom prst="rect">
+            <a:avLst/>
+          </a:prstGeom>
+        </p:spPr>
+      </p:pic>
+      <p:sp>
+        <p:nvSpPr>
+          <p:cNvPr id="2" name="Text 0"/>
+          <p:cNvSpPr txBox="1"/>
+          <p:nvPr/>
+        </p:nvSpPr>
+        <p:spPr>
+          <a:xfrm>
+            <a:off x="502920" y="365760"/>
+            <a:ext cx="6400800" cy="274320"/>
+          </a:xfrm>
+          <a:prstGeom prst="rect">
+            <a:avLst/>
+          </a:prstGeom>
+          <a:noFill/>
+          <a:ln/>
+        </p:spPr>
+        <p:txBody>
+          <a:bodyPr wrap="square" lIns="0" tIns="0" rIns="0" bIns="0" rtlCol="0" anchor="ctr"/>
+          <a:lstStyle/>
+          <a:p>
+            <a:pPr marL="0" indent="0">
+              <a:buNone/>
+            </a:pPr>
+            <a:r>
+              <a:rPr lang="en-US" sz="950" b="1" kern="0" spc="220">
+                <a:solidFill>
+                  <a:srgbClr val="122B82"/>
+                </a:solidFill>
+              </a:rPr>
+              <a:t>FINANCIAL PERFORMANCE</a:t>
+            </a:r>
+            <a:endParaRPr lang="en-US" sz="950"/>
+          </a:p>
+        </p:txBody>
+      </p:sp>
+      <p:sp>
+        <p:nvSpPr>
+          <p:cNvPr id="3" name="Text 1"/>
+          <p:cNvSpPr txBox="1"/>
+          <p:nvPr/>
+        </p:nvSpPr>
+        <p:spPr>
+          <a:xfrm>
+            <a:off x="502920" y="640080"/>
+            <a:ext cx="7315200" cy="685800"/>
+          </a:xfrm>
+          <a:prstGeom prst="rect">
+            <a:avLst/>
+          </a:prstGeom>
+          <a:noFill/>
+          <a:ln/>
+        </p:spPr>
+        <p:txBody>
+          <a:bodyPr wrap="square" lIns="0" tIns="0" rIns="0" bIns="0" rtlCol="0" anchor="ctr"/>
+          <a:lstStyle/>
+          <a:p>
+            <a:pPr marL="0" indent="0">
+              <a:buNone/>
+            </a:pPr>
+            <a:r>
+              <a:rPr lang="en-US" sz="2200" b="1">
+                <a:solidFill>
+                  <a:srgbClr val="242C39"/>
+                </a:solidFill>
+              </a:rPr>
+              <a:t>Revenue against budget and last year</a:t>
+            </a:r>
+            <a:endParaRPr lang="en-US" sz="2700"/>
+          </a:p>
+        </p:txBody>
+      </p:sp>
+      <p:sp>
+        <p:nvSpPr>
+          <p:cNvPr id="6" name="commentary panel"/>
+          <p:cNvSpPr/>
+          <p:nvPr/>
+        </p:nvSpPr>
+        <p:spPr>
+          <a:xfrm>
+            <a:off x="502920" y="3231161"/>
+            <a:ext cx="8138160" cy="1395702"/>
+          </a:xfrm>
+          <a:prstGeom prst="rect">
+            <a:avLst/>
+          </a:prstGeom>
+          <a:solidFill>
+            <a:srgbClr val="E8F9F8"/>
+          </a:solidFill>
+          <a:ln/>
+        </p:spPr>
+        <p:txBody>
+          <a:bodyPr/>
+          <a:lstStyle/>
+          <a:p>
+            <a:endParaRPr lang="en-AU"/>
+          </a:p>
+        </p:txBody>
+      </p:sp>
+      <p:sp>
+        <p:nvSpPr>
+          <p:cNvPr id="7" name="Text 4"/>
+          <p:cNvSpPr txBox="1"/>
+          <p:nvPr/>
+        </p:nvSpPr>
+        <p:spPr>
+          <a:xfrm>
+            <a:off x="685800" y="3304313"/>
+            <a:ext cx="2743200" cy="228600"/>
+          </a:xfrm>
+          <a:prstGeom prst="rect">
+            <a:avLst/>
+          </a:prstGeom>
+          <a:noFill/>
+          <a:ln/>
+        </p:spPr>
+        <p:txBody>
+          <a:bodyPr wrap="square" lIns="0" tIns="0" rIns="0" bIns="0" rtlCol="0" anchor="ctr"/>
+          <a:lstStyle/>
+          <a:p>
+            <a:pPr marL="0" indent="0">
+              <a:buNone/>
+            </a:pPr>
+            <a:r>
+              <a:rPr lang="en-US" sz="900" b="1" kern="0" spc="180">
+                <a:solidFill>
+                  <a:srgbClr val="005358"/>
+                </a:solidFill>
+              </a:rPr>
+              <a:t>COMMENTARY</a:t>
+            </a:r>
+            <a:endParaRPr lang="en-US" sz="900"/>
+          </a:p>
+        </p:txBody>
+      </p:sp>
+      <p:sp>
+        <p:nvSpPr>
+          <p:cNvPr id="8" name="Text 5"/>
+          <p:cNvSpPr txBox="1"/>
+          <p:nvPr/>
+        </p:nvSpPr>
+        <p:spPr>
+          <a:xfrm>
+            <a:off x="685800" y="3478049"/>
+            <a:ext cx="3703320" cy="1121382"/>
+          </a:xfrm>
+          <a:prstGeom prst="rect">
+            <a:avLst/>
+          </a:prstGeom>
+          <a:noFill/>
+          <a:ln/>
+        </p:spPr>
+        <p:txBody>
+          <a:bodyPr wrap="square" lIns="0" tIns="0" rIns="0" bIns="0" rtlCol="0" anchor="t">
+            <a:normAutofit fontScale="92500"/>
+          </a:bodyPr>
+          <a:lstStyle/>
+          <a:p>
+            <a:pPr marL="342900" indent="-342900">
+              <a:lnSpc>
+                <a:spcPts val="1050"/>
+              </a:lnSpc>
+              <a:spcAft>
+                <a:spcPts val="400"/>
+              </a:spcAft>
+              <a:buSzPct val="100000"/>
+              <a:buChar char="•"/>
+            </a:pPr>
+            <a:r>
+              <a:rPr lang="en-US" sz="1000">
+                <a:solidFill>
+                  <a:srgbClr val="3A4453"/>
+                </a:solidFill>
+              </a:rPr>
+              <a:t>Integration generated $235k revenue against a $59k budget, mainly from a completed installation project. This result may not recur in October.</a:t>
+            </a:r>
+            <a:endParaRPr lang="en-US" sz="850"/>
+          </a:p>
+          <a:p>
+            <a:pPr marL="342900" indent="-342900">
+              <a:lnSpc>
+                <a:spcPts val="1050"/>
+              </a:lnSpc>
+              <a:spcAft>
+                <a:spcPts val="400"/>
+              </a:spcAft>
+              <a:buSzPct val="100000"/>
+              <a:buChar char="•"/>
+            </a:pPr>
+            <a:r>
+              <a:rPr lang="en-US" sz="1000">
+                <a:solidFill>
+                  <a:srgbClr val="3A4453"/>
+                </a:solidFill>
+              </a:rPr>
+              <a:t>Support recorded $243k revenue against a $248k budget, remaining broadly in line with recurring contracts.</a:t>
+            </a:r>
+            <a:endParaRPr lang="en-US" sz="850"/>
+          </a:p>
+        </p:txBody>
+      </p:sp>
+      <p:sp>
+        <p:nvSpPr>
+          <p:cNvPr id="25" name="Slide Number Placeholder 0"/>
+          <p:cNvSpPr>
+            <a:spLocks noGrp="1"/>
+          </p:cNvSpPr>
+          <p:nvPr>
+            <p:ph type="sldNum" sz="quarter" idx="4294967295"/>
+          </p:nvPr>
+        </p:nvSpPr>
+        <p:spPr>
+          <a:xfrm>
+            <a:off x="8092440" y="4736592"/>
+            <a:ext cx="548640" cy="228600"/>
+          </a:xfrm>
+          <a:prstGeom prst="rect">
+            <a:avLst/>
+          </a:prstGeom>
+          <a:extLst>
+            <a:ext uri="{C572A759-6A51-4108-AA02-DFA0A04FC94B}">
+              <ma14:wrappingTextBoxFlag xmlns:ma14="http://schemas.microsoft.com/office/mac/drawingml/2011/main" xmlns="" val="0"/>
+            </a:ext>
+          </a:extLst>
+        </p:spPr>
+        <p:txBody>
+          <a:bodyPr/>
+          <a:lstStyle>
+            <a:lvl1pPr>
+              <a:defRPr sz="800">
+                <a:solidFill>
+                  <a:srgbClr val="6B7585"/>
+                </a:solidFill>
+              </a:defRPr>
+            </a:lvl1pPr>
+          </a:lstStyle>
+          <a:p>
+            <a:pPr algn="r"/>
+            <a:fld id="{F7021451-1387-4CA6-816F-3879F97B5CBC}" type="slidenum">
+              <a:rPr lang="en-US" b="0"/>
+              <a:t>14</a:t>
+            </a:fld>
+            <a:endParaRPr lang="en-US"/>
+          </a:p>
+        </p:txBody>
+      </p:sp>
+      <p:pic>
+        <p:nvPicPr>
+          <p:cNvPr id="26" name="cts logo" descr="cts-logo.png"/>
+          <p:cNvPicPr>
+            <a:picLocks noChangeAspect="1"/>
+          </p:cNvPicPr>
+          <p:nvPr/>
+        </p:nvPicPr>
+        <p:blipFill>
+          <a:blip r:embed="rId4"/>
+          <a:stretch>
+            <a:fillRect/>
+          </a:stretch>
+        </p:blipFill>
+        <p:spPr>
+          <a:xfrm>
+            <a:off x="7680959" y="182880"/>
+            <a:ext cx="960120" cy="539696"/>
+          </a:xfrm>
+          <a:prstGeom prst="rect">
+            <a:avLst/>
+          </a:prstGeom>
+        </p:spPr>
+      </p:pic>
+      <p:sp>
+        <p:nvSpPr>
+          <p:cNvPr id="8" name="Text 5b"/>
+          <p:cNvSpPr txBox="1"/>
+          <p:nvPr/>
+        </p:nvSpPr>
+        <p:spPr>
+          <a:xfrm>
+            <a:off x="4663440" y="3478049"/>
+            <a:ext cx="3703320" cy="1121382"/>
+          </a:xfrm>
+          <a:prstGeom prst="rect">
+            <a:avLst/>
+          </a:prstGeom>
+          <a:noFill/>
+          <a:ln/>
+        </p:spPr>
+        <p:txBody>
+          <a:bodyPr wrap="square" lIns="0" tIns="0" rIns="0" bIns="0" rtlCol="0" anchor="t">
+            <a:normAutofit fontScale="92500"/>
+          </a:bodyPr>
+          <a:lstStyle/>
+          <a:p>
+            <a:pPr marL="342900" indent="-342900">
+              <a:lnSpc>
+                <a:spcPts val="1050"/>
+              </a:lnSpc>
+              <a:spcAft>
+                <a:spcPts val="400"/>
+              </a:spcAft>
+              <a:buSzPct val="100000"/>
+              <a:buChar char="•"/>
+            </a:pPr>
+            <a:r>
+              <a:rPr lang="en-US" sz="1000">
+                <a:solidFill>
+                  <a:srgbClr val="3A4453"/>
+                </a:solidFill>
+              </a:rPr>
+              <a:t>Events delivered $73k revenue against a $66k budget.</a:t>
+            </a:r>
+            <a:endParaRPr lang="en-US" sz="850"/>
+          </a:p>
+          <a:p>
+            <a:pPr marL="342900" indent="-342900">
+              <a:lnSpc>
+                <a:spcPts val="1050"/>
+              </a:lnSpc>
+              <a:spcAft>
+                <a:spcPts val="400"/>
+              </a:spcAft>
+              <a:buSzPct val="100000"/>
+              <a:buChar char="•"/>
+            </a:pPr>
+            <a:r>
+              <a:rPr lang="en-US" sz="1000">
+                <a:solidFill>
+                  <a:srgbClr val="3A4453"/>
+                </a:solidFill>
+              </a:rPr>
+              <a:t>Video recorded $7k against $17k, and Consulting $4k against $23k. Both remain below budget for the third consecutive month.</a:t>
+            </a:r>
+            <a:endParaRPr lang="en-US" sz="850"/>
+          </a:p>
+          <a:p>
+            <a:pPr marL="342900" indent="-342900">
+              <a:lnSpc>
+                <a:spcPts val="1050"/>
+              </a:lnSpc>
+              <a:spcAft>
+                <a:spcPts val="400"/>
+              </a:spcAft>
+              <a:buSzPct val="100000"/>
+              <a:buChar char="•"/>
+            </a:pPr>
+            <a:r>
+              <a:rPr lang="en-US" sz="1000">
+                <a:solidFill>
+                  <a:srgbClr val="3A4453"/>
+                </a:solidFill>
+              </a:rPr>
+              <a:t>Total revenue increased 58% against September last year, although the gross margin percentage declined.</a:t>
+            </a:r>
+            <a:endParaRPr lang="en-US" sz="850"/>
+          </a:p>
+        </p:txBody>
+      </p:sp>
+    </p:spTree>
+  </p:cSld>
+  <p:clrMapOvr>
+    <a:masterClrMapping/>
+  </p:clrMapOvr>
+</p:sld>
+</file>
+
+<file path=ppt/slides/slide21.xml><?xml version="1.0" encoding="utf-8"?>
+<p:sld xmlns:a="http://schemas.openxmlformats.org/drawingml/2006/main" xmlns:r="http://schemas.openxmlformats.org/officeDocument/2006/relationships" xmlns:p="http://schemas.openxmlformats.org/presentationml/2006/main">
   <p:cSld name="Slide 15">
     <p:spTree>
       <p:nvGrpSpPr>
@@ -10905,7 +11277,7 @@
 </p:sld>
 </file>
 
-<file path=ppt/slides/slide21.xml><?xml version="1.0" encoding="utf-8"?>
+<file path=ppt/slides/slide22.xml><?xml version="1.0" encoding="utf-8"?>
 <p:sld xmlns:a="http://schemas.openxmlformats.org/drawingml/2006/main" xmlns:r="http://schemas.openxmlformats.org/officeDocument/2006/relationships" xmlns:p="http://schemas.openxmlformats.org/presentationml/2006/main">
   <p:cSld name="Slide 16">
     <p:spTree>
@@ -11287,7 +11659,7 @@
 </p:sld>
 </file>
 
-<file path=ppt/slides/slide22.xml><?xml version="1.0" encoding="utf-8"?>
+<file path=ppt/slides/slide23.xml><?xml version="1.0" encoding="utf-8"?>
 <p:sld xmlns:a="http://schemas.openxmlformats.org/drawingml/2006/main" xmlns:r="http://schemas.openxmlformats.org/officeDocument/2006/relationships" xmlns:p="http://schemas.openxmlformats.org/presentationml/2006/main">
   <p:cSld name="Slide 17">
     <p:spTree>
@@ -11669,7 +12041,7 @@
 </p:sld>
 </file>
 
-<file path=ppt/slides/slide23.xml><?xml version="1.0" encoding="utf-8"?>
+<file path=ppt/slides/slide24.xml><?xml version="1.0" encoding="utf-8"?>
 <p:sld xmlns:a="http://schemas.openxmlformats.org/drawingml/2006/main" xmlns:r="http://schemas.openxmlformats.org/officeDocument/2006/relationships" xmlns:p="http://schemas.openxmlformats.org/presentationml/2006/main">
   <p:cSld name="Slide 18">
     <p:spTree>
@@ -12051,7 +12423,7 @@
 </p:sld>
 </file>
 
-<file path=ppt/slides/slide24.xml><?xml version="1.0" encoding="utf-8"?>
+<file path=ppt/slides/slide25.xml><?xml version="1.0" encoding="utf-8"?>
 <p:sld xmlns:a="http://schemas.openxmlformats.org/drawingml/2006/main" xmlns:r="http://schemas.openxmlformats.org/officeDocument/2006/relationships" xmlns:p="http://schemas.openxmlformats.org/presentationml/2006/main">
   <p:cSld name="Slide 19">
     <p:spTree>
@@ -12436,7 +12808,7 @@
 </p:sld>
 </file>
 
-<file path=ppt/slides/slide25.xml><?xml version="1.0" encoding="utf-8"?>
+<file path=ppt/slides/slide26.xml><?xml version="1.0" encoding="utf-8"?>
 <p:sld xmlns:a="http://schemas.openxmlformats.org/drawingml/2006/main" xmlns:r="http://schemas.openxmlformats.org/officeDocument/2006/relationships" xmlns:p="http://schemas.openxmlformats.org/presentationml/2006/main">
   <p:cSld name="Slide 20">
     <p:spTree>
@@ -12719,7 +13091,7 @@
 </p:sld>
 </file>
 
-<file path=ppt/slides/slide26.xml><?xml version="1.0" encoding="utf-8"?>
+<file path=ppt/slides/slide27.xml><?xml version="1.0" encoding="utf-8"?>
 <p:sld xmlns:a="http://schemas.openxmlformats.org/drawingml/2006/main" xmlns:r="http://schemas.openxmlformats.org/officeDocument/2006/relationships" xmlns:p="http://schemas.openxmlformats.org/presentationml/2006/main">
   <p:cSld name="Slide 21">
     <p:spTree>
@@ -13101,7 +13473,7 @@
 </p:sld>
 </file>
 
-<file path=ppt/slides/slide27.xml><?xml version="1.0" encoding="utf-8"?>
+<file path=ppt/slides/slide28.xml><?xml version="1.0" encoding="utf-8"?>
 <p:sld xmlns:a="http://schemas.openxmlformats.org/drawingml/2006/main" xmlns:r="http://schemas.openxmlformats.org/officeDocument/2006/relationships" xmlns:p="http://schemas.openxmlformats.org/presentationml/2006/main">
   <p:cSld name="Slide 22">
     <p:spTree>
@@ -13483,7 +13855,7 @@
 </p:sld>
 </file>
 
-<file path=ppt/slides/slide28.xml><?xml version="1.0" encoding="utf-8"?>
+<file path=ppt/slides/slide29.xml><?xml version="1.0" encoding="utf-8"?>
 <p:sld xmlns:a="http://schemas.openxmlformats.org/drawingml/2006/main" xmlns:r="http://schemas.openxmlformats.org/officeDocument/2006/relationships" xmlns:p="http://schemas.openxmlformats.org/presentationml/2006/main">
   <p:cSld name="Slide 23">
     <p:spTree>
@@ -13857,289 +14229,6 @@
           </a:prstGeom>
         </p:spPr>
       </p:pic>
-    </p:spTree>
-  </p:cSld>
-  <p:clrMapOvr>
-    <a:masterClrMapping/>
-  </p:clrMapOvr>
-</p:sld>
-</file>
-
-<file path=ppt/slides/slide29.xml><?xml version="1.0" encoding="utf-8"?>
-<p:sld xmlns:a="http://schemas.openxmlformats.org/drawingml/2006/main" xmlns:r="http://schemas.openxmlformats.org/officeDocument/2006/relationships" xmlns:p="http://schemas.openxmlformats.org/presentationml/2006/main">
-  <p:cSld name="Slide 24">
-    <p:spTree>
-      <p:nvGrpSpPr>
-        <p:cNvPr id="1" name=""/>
-        <p:cNvGrpSpPr/>
-        <p:nvPr/>
-      </p:nvGrpSpPr>
-      <p:grpSpPr>
-        <a:xfrm>
-          <a:off x="0" y="0"/>
-          <a:ext cx="0" cy="0"/>
-          <a:chOff x="0" y="0"/>
-          <a:chExt cx="0" cy="0"/>
-        </a:xfrm>
-      </p:grpSpPr>
-      <p:sp>
-        <p:nvSpPr>
-          <p:cNvPr id="2" name="dot 2"/>
-          <p:cNvSpPr/>
-          <p:nvPr/>
-        </p:nvSpPr>
-        <p:spPr>
-          <a:xfrm>
-            <a:off x="7178040" y="2057400"/>
-            <a:ext cx="2240280" cy="2240280"/>
-          </a:xfrm>
-          <a:prstGeom prst="ellipse">
-            <a:avLst/>
-          </a:prstGeom>
-          <a:solidFill>
-            <a:srgbClr val="F33844">
-              <a:alpha val="55000"/>
-            </a:srgbClr>
-          </a:solidFill>
-          <a:ln/>
-        </p:spPr>
-        <p:txBody>
-          <a:bodyPr/>
-          <a:lstStyle/>
-          <a:p>
-            <a:endParaRPr lang="en-AU"/>
-          </a:p>
-        </p:txBody>
-      </p:sp>
-      <p:sp>
-        <p:nvSpPr>
-          <p:cNvPr id="2" name="dot 1"/>
-          <p:cNvSpPr/>
-          <p:nvPr/>
-        </p:nvSpPr>
-        <p:spPr>
-          <a:xfrm>
-            <a:off x="7909560" y="1188720"/>
-            <a:ext cx="1783080" cy="1783080"/>
-          </a:xfrm>
-          <a:prstGeom prst="ellipse">
-            <a:avLst/>
-          </a:prstGeom>
-          <a:solidFill>
-            <a:srgbClr val="6D71FF">
-              <a:alpha val="55000"/>
-            </a:srgbClr>
-          </a:solidFill>
-          <a:ln/>
-        </p:spPr>
-        <p:txBody>
-          <a:bodyPr/>
-          <a:lstStyle/>
-          <a:p>
-            <a:endParaRPr lang="en-AU"/>
-          </a:p>
-        </p:txBody>
-      </p:sp>
-      <p:sp>
-        <p:nvSpPr>
-          <p:cNvPr id="2" name="dot 0"/>
-          <p:cNvSpPr/>
-          <p:nvPr/>
-        </p:nvSpPr>
-        <p:spPr>
-          <a:xfrm>
-            <a:off x="6949440" y="274320"/>
-            <a:ext cx="2148840" cy="2148840"/>
-          </a:xfrm>
-          <a:prstGeom prst="ellipse">
-            <a:avLst/>
-          </a:prstGeom>
-          <a:solidFill>
-            <a:srgbClr val="3FD0C9">
-              <a:alpha val="55000"/>
-            </a:srgbClr>
-          </a:solidFill>
-          <a:ln/>
-        </p:spPr>
-        <p:txBody>
-          <a:bodyPr/>
-          <a:lstStyle/>
-          <a:p>
-            <a:endParaRPr lang="en-AU"/>
-          </a:p>
-        </p:txBody>
-      </p:sp>
-      <p:sp>
-        <p:nvSpPr>
-          <p:cNvPr id="3" name="Shape 1"/>
-          <p:cNvSpPr/>
-          <p:nvPr/>
-        </p:nvSpPr>
-        <p:spPr>
-          <a:xfrm>
-            <a:off x="502920" y="1874520"/>
-            <a:ext cx="868680" cy="868680"/>
-          </a:xfrm>
-          <a:prstGeom prst="rect">
-            <a:avLst/>
-          </a:prstGeom>
-          <a:solidFill>
-            <a:srgbClr val="3FD0C9"/>
-          </a:solidFill>
-          <a:ln/>
-        </p:spPr>
-        <p:txBody>
-          <a:bodyPr/>
-          <a:lstStyle/>
-          <a:p>
-            <a:endParaRPr lang="en-AU"/>
-          </a:p>
-        </p:txBody>
-      </p:sp>
-      <p:sp>
-        <p:nvSpPr>
-          <p:cNvPr id="4" name="Text 2"/>
-          <p:cNvSpPr txBox="1"/>
-          <p:nvPr/>
-        </p:nvSpPr>
-        <p:spPr>
-          <a:xfrm>
-            <a:off x="502920" y="1874520"/>
-            <a:ext cx="868680" cy="868680"/>
-          </a:xfrm>
-          <a:prstGeom prst="rect">
-            <a:avLst/>
-          </a:prstGeom>
-          <a:noFill/>
-          <a:ln/>
-        </p:spPr>
-        <p:txBody>
-          <a:bodyPr wrap="square" lIns="0" tIns="0" rIns="0" bIns="0" rtlCol="0" anchor="ctr"/>
-          <a:lstStyle/>
-          <a:p>
-            <a:pPr marL="0" indent="0" algn="ctr">
-              <a:buNone/>
-            </a:pPr>
-            <a:r>
-              <a:rPr lang="en-US" sz="2200" b="1">
-                <a:solidFill>
-                  <a:srgbClr val="242C39"/>
-                </a:solidFill>
-              </a:rPr>
-              <a:t>04</a:t>
-            </a:r>
-            <a:endParaRPr lang="en-US" sz="2600"/>
-          </a:p>
-        </p:txBody>
-      </p:sp>
-      <p:sp>
-        <p:nvSpPr>
-          <p:cNvPr id="5" name="Text 3"/>
-          <p:cNvSpPr txBox="1"/>
-          <p:nvPr/>
-        </p:nvSpPr>
-        <p:spPr>
-          <a:xfrm>
-            <a:off x="502920" y="411480"/>
-            <a:ext cx="3657600" cy="274320"/>
-          </a:xfrm>
-          <a:prstGeom prst="rect">
-            <a:avLst/>
-          </a:prstGeom>
-          <a:noFill/>
-          <a:ln/>
-        </p:spPr>
-        <p:txBody>
-          <a:bodyPr wrap="square" lIns="0" tIns="0" rIns="0" bIns="0" rtlCol="0" anchor="ctr"/>
-          <a:lstStyle/>
-          <a:p>
-            <a:pPr marL="0" indent="0">
-              <a:buNone/>
-            </a:pPr>
-            <a:r>
-              <a:rPr lang="en-US" sz="950" b="1" kern="0" spc="220">
-                <a:solidFill>
-                  <a:srgbClr val="3FD0C9"/>
-                </a:solidFill>
-              </a:rPr>
-              <a:t>SECTION</a:t>
-            </a:r>
-            <a:endParaRPr lang="en-US" sz="950"/>
-          </a:p>
-        </p:txBody>
-      </p:sp>
-      <p:sp>
-        <p:nvSpPr>
-          <p:cNvPr id="6" name="Text 4"/>
-          <p:cNvSpPr txBox="1"/>
-          <p:nvPr/>
-        </p:nvSpPr>
-        <p:spPr>
-          <a:xfrm>
-            <a:off x="1600200" y="1874520"/>
-            <a:ext cx="5943600" cy="502920"/>
-          </a:xfrm>
-          <a:prstGeom prst="rect">
-            <a:avLst/>
-          </a:prstGeom>
-          <a:noFill/>
-          <a:ln/>
-        </p:spPr>
-        <p:txBody>
-          <a:bodyPr wrap="square" lIns="0" tIns="0" rIns="0" bIns="0" rtlCol="0" anchor="ctr"/>
-          <a:lstStyle/>
-          <a:p>
-            <a:pPr marL="0" indent="0">
-              <a:buNone/>
-            </a:pPr>
-            <a:r>
-              <a:rPr lang="en-US" sz="2300" b="1">
-                <a:solidFill>
-                  <a:srgbClr val="FFFFFF"/>
-                </a:solidFill>
-              </a:rPr>
-              <a:t>People and utilisation</a:t>
-            </a:r>
-            <a:endParaRPr lang="en-US" sz="2800"/>
-          </a:p>
-        </p:txBody>
-      </p:sp>
-      <p:sp>
-        <p:nvSpPr>
-          <p:cNvPr id="7" name="Text 5"/>
-          <p:cNvSpPr txBox="1"/>
-          <p:nvPr/>
-        </p:nvSpPr>
-        <p:spPr>
-          <a:xfrm>
-            <a:off x="1600200" y="2395728"/>
-            <a:ext cx="5943600" cy="347472"/>
-          </a:xfrm>
-          <a:prstGeom prst="rect">
-            <a:avLst/>
-          </a:prstGeom>
-          <a:noFill/>
-          <a:ln/>
-        </p:spPr>
-        <p:txBody>
-          <a:bodyPr wrap="square" lIns="0" tIns="0" rIns="0" bIns="0" rtlCol="0" anchor="ctr"/>
-          <a:lstStyle/>
-          <a:p>
-            <a:pPr marL="0" indent="0">
-              <a:buNone/>
-            </a:pPr>
-            <a:r>
-              <a:rPr lang="en-US" sz="1200">
-                <a:solidFill>
-                  <a:srgbClr val="C9CED6"/>
-                </a:solidFill>
-              </a:rPr>
-              <a:t>Chargeable hours and the profit they produce</a:t>
-            </a:r>
-            <a:endParaRPr lang="en-US" sz="1200"/>
-          </a:p>
-        </p:txBody>
-      </p:sp>
     </p:spTree>
   </p:cSld>
   <p:clrMapOvr>
@@ -16402,6 +16491,289 @@
 
 <file path=ppt/slides/slide30.xml><?xml version="1.0" encoding="utf-8"?>
 <p:sld xmlns:a="http://schemas.openxmlformats.org/drawingml/2006/main" xmlns:r="http://schemas.openxmlformats.org/officeDocument/2006/relationships" xmlns:p="http://schemas.openxmlformats.org/presentationml/2006/main">
+  <p:cSld name="Slide 24">
+    <p:spTree>
+      <p:nvGrpSpPr>
+        <p:cNvPr id="1" name=""/>
+        <p:cNvGrpSpPr/>
+        <p:nvPr/>
+      </p:nvGrpSpPr>
+      <p:grpSpPr>
+        <a:xfrm>
+          <a:off x="0" y="0"/>
+          <a:ext cx="0" cy="0"/>
+          <a:chOff x="0" y="0"/>
+          <a:chExt cx="0" cy="0"/>
+        </a:xfrm>
+      </p:grpSpPr>
+      <p:sp>
+        <p:nvSpPr>
+          <p:cNvPr id="2" name="dot 2"/>
+          <p:cNvSpPr/>
+          <p:nvPr/>
+        </p:nvSpPr>
+        <p:spPr>
+          <a:xfrm>
+            <a:off x="7178040" y="2057400"/>
+            <a:ext cx="2240280" cy="2240280"/>
+          </a:xfrm>
+          <a:prstGeom prst="ellipse">
+            <a:avLst/>
+          </a:prstGeom>
+          <a:solidFill>
+            <a:srgbClr val="F33844">
+              <a:alpha val="55000"/>
+            </a:srgbClr>
+          </a:solidFill>
+          <a:ln/>
+        </p:spPr>
+        <p:txBody>
+          <a:bodyPr/>
+          <a:lstStyle/>
+          <a:p>
+            <a:endParaRPr lang="en-AU"/>
+          </a:p>
+        </p:txBody>
+      </p:sp>
+      <p:sp>
+        <p:nvSpPr>
+          <p:cNvPr id="2" name="dot 1"/>
+          <p:cNvSpPr/>
+          <p:nvPr/>
+        </p:nvSpPr>
+        <p:spPr>
+          <a:xfrm>
+            <a:off x="7909560" y="1188720"/>
+            <a:ext cx="1783080" cy="1783080"/>
+          </a:xfrm>
+          <a:prstGeom prst="ellipse">
+            <a:avLst/>
+          </a:prstGeom>
+          <a:solidFill>
+            <a:srgbClr val="6D71FF">
+              <a:alpha val="55000"/>
+            </a:srgbClr>
+          </a:solidFill>
+          <a:ln/>
+        </p:spPr>
+        <p:txBody>
+          <a:bodyPr/>
+          <a:lstStyle/>
+          <a:p>
+            <a:endParaRPr lang="en-AU"/>
+          </a:p>
+        </p:txBody>
+      </p:sp>
+      <p:sp>
+        <p:nvSpPr>
+          <p:cNvPr id="2" name="dot 0"/>
+          <p:cNvSpPr/>
+          <p:nvPr/>
+        </p:nvSpPr>
+        <p:spPr>
+          <a:xfrm>
+            <a:off x="6949440" y="274320"/>
+            <a:ext cx="2148840" cy="2148840"/>
+          </a:xfrm>
+          <a:prstGeom prst="ellipse">
+            <a:avLst/>
+          </a:prstGeom>
+          <a:solidFill>
+            <a:srgbClr val="3FD0C9">
+              <a:alpha val="55000"/>
+            </a:srgbClr>
+          </a:solidFill>
+          <a:ln/>
+        </p:spPr>
+        <p:txBody>
+          <a:bodyPr/>
+          <a:lstStyle/>
+          <a:p>
+            <a:endParaRPr lang="en-AU"/>
+          </a:p>
+        </p:txBody>
+      </p:sp>
+      <p:sp>
+        <p:nvSpPr>
+          <p:cNvPr id="3" name="Shape 1"/>
+          <p:cNvSpPr/>
+          <p:nvPr/>
+        </p:nvSpPr>
+        <p:spPr>
+          <a:xfrm>
+            <a:off x="502920" y="1874520"/>
+            <a:ext cx="868680" cy="868680"/>
+          </a:xfrm>
+          <a:prstGeom prst="rect">
+            <a:avLst/>
+          </a:prstGeom>
+          <a:solidFill>
+            <a:srgbClr val="3FD0C9"/>
+          </a:solidFill>
+          <a:ln/>
+        </p:spPr>
+        <p:txBody>
+          <a:bodyPr/>
+          <a:lstStyle/>
+          <a:p>
+            <a:endParaRPr lang="en-AU"/>
+          </a:p>
+        </p:txBody>
+      </p:sp>
+      <p:sp>
+        <p:nvSpPr>
+          <p:cNvPr id="4" name="Text 2"/>
+          <p:cNvSpPr txBox="1"/>
+          <p:nvPr/>
+        </p:nvSpPr>
+        <p:spPr>
+          <a:xfrm>
+            <a:off x="502920" y="1874520"/>
+            <a:ext cx="868680" cy="868680"/>
+          </a:xfrm>
+          <a:prstGeom prst="rect">
+            <a:avLst/>
+          </a:prstGeom>
+          <a:noFill/>
+          <a:ln/>
+        </p:spPr>
+        <p:txBody>
+          <a:bodyPr wrap="square" lIns="0" tIns="0" rIns="0" bIns="0" rtlCol="0" anchor="ctr"/>
+          <a:lstStyle/>
+          <a:p>
+            <a:pPr marL="0" indent="0" algn="ctr">
+              <a:buNone/>
+            </a:pPr>
+            <a:r>
+              <a:rPr lang="en-US" sz="2200" b="1">
+                <a:solidFill>
+                  <a:srgbClr val="242C39"/>
+                </a:solidFill>
+              </a:rPr>
+              <a:t>04</a:t>
+            </a:r>
+            <a:endParaRPr lang="en-US" sz="2600"/>
+          </a:p>
+        </p:txBody>
+      </p:sp>
+      <p:sp>
+        <p:nvSpPr>
+          <p:cNvPr id="5" name="Text 3"/>
+          <p:cNvSpPr txBox="1"/>
+          <p:nvPr/>
+        </p:nvSpPr>
+        <p:spPr>
+          <a:xfrm>
+            <a:off x="502920" y="411480"/>
+            <a:ext cx="3657600" cy="274320"/>
+          </a:xfrm>
+          <a:prstGeom prst="rect">
+            <a:avLst/>
+          </a:prstGeom>
+          <a:noFill/>
+          <a:ln/>
+        </p:spPr>
+        <p:txBody>
+          <a:bodyPr wrap="square" lIns="0" tIns="0" rIns="0" bIns="0" rtlCol="0" anchor="ctr"/>
+          <a:lstStyle/>
+          <a:p>
+            <a:pPr marL="0" indent="0">
+              <a:buNone/>
+            </a:pPr>
+            <a:r>
+              <a:rPr lang="en-US" sz="950" b="1" kern="0" spc="220">
+                <a:solidFill>
+                  <a:srgbClr val="3FD0C9"/>
+                </a:solidFill>
+              </a:rPr>
+              <a:t>SECTION</a:t>
+            </a:r>
+            <a:endParaRPr lang="en-US" sz="950"/>
+          </a:p>
+        </p:txBody>
+      </p:sp>
+      <p:sp>
+        <p:nvSpPr>
+          <p:cNvPr id="6" name="Text 4"/>
+          <p:cNvSpPr txBox="1"/>
+          <p:nvPr/>
+        </p:nvSpPr>
+        <p:spPr>
+          <a:xfrm>
+            <a:off x="1600200" y="1874520"/>
+            <a:ext cx="5943600" cy="502920"/>
+          </a:xfrm>
+          <a:prstGeom prst="rect">
+            <a:avLst/>
+          </a:prstGeom>
+          <a:noFill/>
+          <a:ln/>
+        </p:spPr>
+        <p:txBody>
+          <a:bodyPr wrap="square" lIns="0" tIns="0" rIns="0" bIns="0" rtlCol="0" anchor="ctr"/>
+          <a:lstStyle/>
+          <a:p>
+            <a:pPr marL="0" indent="0">
+              <a:buNone/>
+            </a:pPr>
+            <a:r>
+              <a:rPr lang="en-US" sz="2300" b="1">
+                <a:solidFill>
+                  <a:srgbClr val="FFFFFF"/>
+                </a:solidFill>
+              </a:rPr>
+              <a:t>People and utilisation</a:t>
+            </a:r>
+            <a:endParaRPr lang="en-US" sz="2800"/>
+          </a:p>
+        </p:txBody>
+      </p:sp>
+      <p:sp>
+        <p:nvSpPr>
+          <p:cNvPr id="7" name="Text 5"/>
+          <p:cNvSpPr txBox="1"/>
+          <p:nvPr/>
+        </p:nvSpPr>
+        <p:spPr>
+          <a:xfrm>
+            <a:off x="1600200" y="2395728"/>
+            <a:ext cx="5943600" cy="347472"/>
+          </a:xfrm>
+          <a:prstGeom prst="rect">
+            <a:avLst/>
+          </a:prstGeom>
+          <a:noFill/>
+          <a:ln/>
+        </p:spPr>
+        <p:txBody>
+          <a:bodyPr wrap="square" lIns="0" tIns="0" rIns="0" bIns="0" rtlCol="0" anchor="ctr"/>
+          <a:lstStyle/>
+          <a:p>
+            <a:pPr marL="0" indent="0">
+              <a:buNone/>
+            </a:pPr>
+            <a:r>
+              <a:rPr lang="en-US" sz="1200">
+                <a:solidFill>
+                  <a:srgbClr val="C9CED6"/>
+                </a:solidFill>
+              </a:rPr>
+              <a:t>Chargeable hours and the profit they produce</a:t>
+            </a:r>
+            <a:endParaRPr lang="en-US" sz="1200"/>
+          </a:p>
+        </p:txBody>
+      </p:sp>
+    </p:spTree>
+  </p:cSld>
+  <p:clrMapOvr>
+    <a:masterClrMapping/>
+  </p:clrMapOvr>
+</p:sld>
+</file>
+
+<file path=ppt/slides/slide31.xml><?xml version="1.0" encoding="utf-8"?>
+<p:sld xmlns:a="http://schemas.openxmlformats.org/drawingml/2006/main" xmlns:r="http://schemas.openxmlformats.org/officeDocument/2006/relationships" xmlns:p="http://schemas.openxmlformats.org/presentationml/2006/main">
   <p:cSld name="Slide 25">
     <p:spTree>
       <p:nvGrpSpPr>
@@ -16785,7 +17157,7 @@
 </p:sld>
 </file>
 
-<file path=ppt/slides/slide31.xml><?xml version="1.0" encoding="utf-8"?>
+<file path=ppt/slides/slide32.xml><?xml version="1.0" encoding="utf-8"?>
 <p:sld xmlns:a="http://schemas.openxmlformats.org/drawingml/2006/main" xmlns:r="http://schemas.openxmlformats.org/officeDocument/2006/relationships" xmlns:p="http://schemas.openxmlformats.org/presentationml/2006/main">
   <p:cSld name="Slide 26">
     <p:spTree>
@@ -17167,7 +17539,7 @@
 </p:sld>
 </file>
 
-<file path=ppt/slides/slide32.xml><?xml version="1.0" encoding="utf-8"?>
+<file path=ppt/slides/slide33.xml><?xml version="1.0" encoding="utf-8"?>
 <p:sld xmlns:a="http://schemas.openxmlformats.org/drawingml/2006/main" xmlns:r="http://schemas.openxmlformats.org/officeDocument/2006/relationships" xmlns:p="http://schemas.openxmlformats.org/presentationml/2006/main">
   <p:cSld name="Slide 27">
     <p:spTree>
@@ -17549,7 +17921,7 @@
 </p:sld>
 </file>
 
-<file path=ppt/slides/slide33.xml><?xml version="1.0" encoding="utf-8"?>
+<file path=ppt/slides/slide34.xml><?xml version="1.0" encoding="utf-8"?>
 <p:sld xmlns:a="http://schemas.openxmlformats.org/drawingml/2006/main" xmlns:r="http://schemas.openxmlformats.org/officeDocument/2006/relationships" xmlns:p="http://schemas.openxmlformats.org/presentationml/2006/main">
   <p:cSld name="Slide 28">
     <p:spTree>
@@ -17832,7 +18204,7 @@
 </p:sld>
 </file>
 
-<file path=ppt/slides/slide34.xml><?xml version="1.0" encoding="utf-8"?>
+<file path=ppt/slides/slide35.xml><?xml version="1.0" encoding="utf-8"?>
 <p:sld xmlns:a="http://schemas.openxmlformats.org/drawingml/2006/main" xmlns:r="http://schemas.openxmlformats.org/officeDocument/2006/relationships" xmlns:p="http://schemas.openxmlformats.org/presentationml/2006/main">
   <p:cSld name="Slide 29">
     <p:spTree>
@@ -18214,7 +18586,7 @@
 </p:sld>
 </file>
 
-<file path=ppt/slides/slide35.xml><?xml version="1.0" encoding="utf-8"?>
+<file path=ppt/slides/slide36.xml><?xml version="1.0" encoding="utf-8"?>
 <p:sld xmlns:a="http://schemas.openxmlformats.org/drawingml/2006/main" xmlns:r="http://schemas.openxmlformats.org/officeDocument/2006/relationships" xmlns:p="http://schemas.openxmlformats.org/presentationml/2006/main">
   <p:cSld name="Slide 30">
     <p:spTree>
@@ -20360,7 +20732,7 @@
 </p:sld>
 </file>
 
-<file path=ppt/slides/slide36.xml><?xml version="1.0" encoding="utf-8"?>
+<file path=ppt/slides/slide37.xml><?xml version="1.0" encoding="utf-8"?>
 <p:sld xmlns:a="http://schemas.openxmlformats.org/drawingml/2006/main" xmlns:r="http://schemas.openxmlformats.org/officeDocument/2006/relationships" xmlns:p="http://schemas.openxmlformats.org/presentationml/2006/main">
   <p:cSld>
     <p:bg>
@@ -20736,7 +21108,7 @@
 </p:sld>
 </file>
 
-<file path=ppt/slides/slide37.xml><?xml version="1.0" encoding="utf-8"?>
+<file path=ppt/slides/slide38.xml><?xml version="1.0" encoding="utf-8"?>
 <p:sld xmlns:a="http://schemas.openxmlformats.org/drawingml/2006/main" xmlns:r="http://schemas.openxmlformats.org/officeDocument/2006/relationships" xmlns:p="http://schemas.openxmlformats.org/presentationml/2006/main">
   <p:cSld name="Slide 31">
     <p:spTree>
@@ -20984,384 +21356,6 @@
           </a:p>
         </p:txBody>
       </p:sp>
-    </p:spTree>
-  </p:cSld>
-  <p:clrMapOvr>
-    <a:masterClrMapping/>
-  </p:clrMapOvr>
-</p:sld>
-</file>
-
-<file path=ppt/slides/slide38.xml><?xml version="1.0" encoding="utf-8"?>
-<p:sld xmlns:a="http://schemas.openxmlformats.org/drawingml/2006/main" xmlns:p="http://schemas.openxmlformats.org/presentationml/2006/main" xmlns:r="http://schemas.openxmlformats.org/officeDocument/2006/relationships">
-  <p:cSld>
-    <p:spTree>
-      <p:nvGrpSpPr>
-        <p:cNvPr id="1" name=""/>
-        <p:cNvGrpSpPr/>
-        <p:nvPr/>
-      </p:nvGrpSpPr>
-      <p:grpSpPr/>
-      <p:pic>
-        <p:nvPicPr>
-          <p:cNvPr id="27" name="snip xero_roll" descr="xero_roll.png"/>
-          <p:cNvPicPr>
-            <a:picLocks noChangeAspect="1"/>
-          </p:cNvPicPr>
-          <p:nvPr/>
-        </p:nvPicPr>
-        <p:blipFill>
-          <a:blip r:embed="rId3"/>
-          <a:stretch>
-            <a:fillRect/>
-          </a:stretch>
-        </p:blipFill>
-        <p:spPr>
-          <a:xfrm>
-            <a:off x="1362886" y="1115568"/>
-            <a:ext cx="6418226" cy="2397673"/>
-          </a:xfrm>
-          <a:prstGeom prst="rect">
-            <a:avLst/>
-          </a:prstGeom>
-        </p:spPr>
-      </p:pic>
-      <p:sp>
-        <p:nvSpPr>
-          <p:cNvPr id="2" name="Text 0"/>
-          <p:cNvSpPr txBox="1"/>
-          <p:nvPr/>
-        </p:nvSpPr>
-        <p:spPr>
-          <a:xfrm>
-            <a:off x="502920" y="365760"/>
-            <a:ext cx="6400800" cy="274320"/>
-          </a:xfrm>
-          <a:prstGeom prst="rect">
-            <a:avLst/>
-          </a:prstGeom>
-          <a:noFill/>
-          <a:ln/>
-        </p:spPr>
-        <p:txBody>
-          <a:bodyPr wrap="square" lIns="0" tIns="0" rIns="0" bIns="0" rtlCol="0" anchor="ctr"/>
-          <a:lstStyle/>
-          <a:p>
-            <a:pPr marL="0" indent="0">
-              <a:buNone/>
-            </a:pPr>
-            <a:r>
-              <a:rPr lang="en-US" sz="950" b="1" kern="0" spc="220">
-                <a:solidFill>
-                  <a:srgbClr val="122B82"/>
-                </a:solidFill>
-              </a:rPr>
-              <a:t>FINANCIAL PERFORMANCE</a:t>
-            </a:r>
-            <a:endParaRPr lang="en-US" sz="950"/>
-          </a:p>
-        </p:txBody>
-      </p:sp>
-      <p:sp>
-        <p:nvSpPr>
-          <p:cNvPr id="3" name="Text 1"/>
-          <p:cNvSpPr txBox="1"/>
-          <p:nvPr/>
-        </p:nvSpPr>
-        <p:spPr>
-          <a:xfrm>
-            <a:off x="502920" y="640080"/>
-            <a:ext cx="7315200" cy="685800"/>
-          </a:xfrm>
-          <a:prstGeom prst="rect">
-            <a:avLst/>
-          </a:prstGeom>
-          <a:noFill/>
-          <a:ln/>
-        </p:spPr>
-        <p:txBody>
-          <a:bodyPr wrap="square" lIns="0" tIns="0" rIns="0" bIns="0" rtlCol="0" anchor="ctr"/>
-          <a:lstStyle/>
-          <a:p>
-            <a:pPr marL="0" indent="0">
-              <a:buNone/>
-            </a:pPr>
-            <a:r>
-              <a:rPr lang="en-US" sz="2200" b="1">
-                <a:solidFill>
-                  <a:srgbClr val="242C39"/>
-                </a:solidFill>
-              </a:rPr>
-              <a:t>Revenue, rolling twelve months</a:t>
-            </a:r>
-            <a:endParaRPr lang="en-US" sz="2700"/>
-          </a:p>
-        </p:txBody>
-      </p:sp>
-      <p:sp>
-        <p:nvSpPr>
-          <p:cNvPr id="6" name="commentary panel"/>
-          <p:cNvSpPr/>
-          <p:nvPr/>
-        </p:nvSpPr>
-        <p:spPr>
-          <a:xfrm>
-            <a:off x="502920" y="3622969"/>
-            <a:ext cx="8138160" cy="1003894"/>
-          </a:xfrm>
-          <a:prstGeom prst="rect">
-            <a:avLst/>
-          </a:prstGeom>
-          <a:solidFill>
-            <a:srgbClr val="E8F9F8"/>
-          </a:solidFill>
-          <a:ln/>
-        </p:spPr>
-        <p:txBody>
-          <a:bodyPr/>
-          <a:lstStyle/>
-          <a:p>
-            <a:endParaRPr lang="en-AU"/>
-          </a:p>
-        </p:txBody>
-      </p:sp>
-      <p:sp>
-        <p:nvSpPr>
-          <p:cNvPr id="7" name="Text 4"/>
-          <p:cNvSpPr txBox="1"/>
-          <p:nvPr/>
-        </p:nvSpPr>
-        <p:spPr>
-          <a:xfrm>
-            <a:off x="685800" y="3696121"/>
-            <a:ext cx="2743200" cy="228600"/>
-          </a:xfrm>
-          <a:prstGeom prst="rect">
-            <a:avLst/>
-          </a:prstGeom>
-          <a:noFill/>
-          <a:ln/>
-        </p:spPr>
-        <p:txBody>
-          <a:bodyPr wrap="square" lIns="0" tIns="0" rIns="0" bIns="0" rtlCol="0" anchor="ctr"/>
-          <a:lstStyle/>
-          <a:p>
-            <a:pPr marL="0" indent="0">
-              <a:buNone/>
-            </a:pPr>
-            <a:r>
-              <a:rPr lang="en-US" sz="900" b="1" kern="0" spc="180">
-                <a:solidFill>
-                  <a:srgbClr val="005358"/>
-                </a:solidFill>
-              </a:rPr>
-              <a:t>COMMENTARY</a:t>
-            </a:r>
-            <a:endParaRPr lang="en-US" sz="900"/>
-          </a:p>
-        </p:txBody>
-      </p:sp>
-      <p:sp>
-        <p:nvSpPr>
-          <p:cNvPr id="8" name="Text 5"/>
-          <p:cNvSpPr txBox="1"/>
-          <p:nvPr/>
-        </p:nvSpPr>
-        <p:spPr>
-          <a:xfrm>
-            <a:off x="685800" y="3869857"/>
-            <a:ext cx="3703320" cy="729574"/>
-          </a:xfrm>
-          <a:prstGeom prst="rect">
-            <a:avLst/>
-          </a:prstGeom>
-          <a:noFill/>
-          <a:ln/>
-        </p:spPr>
-        <p:txBody>
-          <a:bodyPr wrap="square" lIns="0" tIns="0" rIns="0" bIns="0" rtlCol="0" anchor="t">
-            <a:normAutofit fontScale="85000" lnSpcReduction="10000"/>
-          </a:bodyPr>
-          <a:lstStyle/>
-          <a:p>
-            <a:pPr marL="342900" indent="-342900">
-              <a:lnSpc>
-                <a:spcPts val="1050"/>
-              </a:lnSpc>
-              <a:spcAft>
-                <a:spcPts val="400"/>
-              </a:spcAft>
-              <a:buSzPct val="100000"/>
-              <a:buChar char="•"/>
-            </a:pPr>
-            <a:r>
-              <a:rPr lang="en-US" sz="1000">
-                <a:solidFill>
-                  <a:srgbClr val="3A4453"/>
-                </a:solidFill>
-              </a:rPr>
-              <a:t>The twelve months to September 2026 billed $6,509k.</a:t>
-            </a:r>
-            <a:endParaRPr lang="en-US" sz="850"/>
-          </a:p>
-          <a:p>
-            <a:pPr marL="342900" indent="-342900">
-              <a:lnSpc>
-                <a:spcPts val="1050"/>
-              </a:lnSpc>
-              <a:spcAft>
-                <a:spcPts val="400"/>
-              </a:spcAft>
-              <a:buSzPct val="100000"/>
-              <a:buChar char="•"/>
-            </a:pPr>
-            <a:r>
-              <a:rPr lang="en-US" sz="1000">
-                <a:solidFill>
-                  <a:srgbClr val="3A4453"/>
-                </a:solidFill>
-              </a:rPr>
-              <a:t>The peak was $7,000k in June 2025. The trough was $5,817k in January 2026, a fall of 17%.</a:t>
-            </a:r>
-            <a:endParaRPr lang="en-US" sz="850"/>
-          </a:p>
-        </p:txBody>
-      </p:sp>
-      <p:sp>
-        <p:nvSpPr>
-          <p:cNvPr id="25" name="Slide Number Placeholder 0"/>
-          <p:cNvSpPr>
-            <a:spLocks noGrp="1"/>
-          </p:cNvSpPr>
-          <p:nvPr>
-            <p:ph type="sldNum" sz="quarter" idx="4294967295"/>
-          </p:nvPr>
-        </p:nvSpPr>
-        <p:spPr>
-          <a:xfrm>
-            <a:off x="8092440" y="4736592"/>
-            <a:ext cx="548640" cy="228600"/>
-          </a:xfrm>
-          <a:prstGeom prst="rect">
-            <a:avLst/>
-          </a:prstGeom>
-          <a:extLst>
-            <a:ext uri="{C572A759-6A51-4108-AA02-DFA0A04FC94B}">
-              <ma14:wrappingTextBoxFlag xmlns:ma14="http://schemas.microsoft.com/office/mac/drawingml/2011/main" xmlns="" val="0"/>
-            </a:ext>
-          </a:extLst>
-        </p:spPr>
-        <p:txBody>
-          <a:bodyPr/>
-          <a:lstStyle>
-            <a:lvl1pPr>
-              <a:defRPr sz="800">
-                <a:solidFill>
-                  <a:srgbClr val="6B7585"/>
-                </a:solidFill>
-              </a:defRPr>
-            </a:lvl1pPr>
-          </a:lstStyle>
-          <a:p>
-            <a:pPr algn="r"/>
-            <a:fld id="{F7021451-1387-4CA6-816F-3879F97B5CBC}" type="slidenum">
-              <a:rPr lang="en-US" b="0"/>
-              <a:t>16</a:t>
-            </a:fld>
-            <a:endParaRPr lang="en-US"/>
-          </a:p>
-        </p:txBody>
-      </p:sp>
-      <p:sp>
-        <p:nvSpPr>
-          <p:cNvPr id="8" name="Text 5b"/>
-          <p:cNvSpPr txBox="1"/>
-          <p:nvPr/>
-        </p:nvSpPr>
-        <p:spPr>
-          <a:xfrm>
-            <a:off x="4663440" y="3869857"/>
-            <a:ext cx="3703320" cy="729574"/>
-          </a:xfrm>
-          <a:prstGeom prst="rect">
-            <a:avLst/>
-          </a:prstGeom>
-          <a:noFill/>
-          <a:ln/>
-        </p:spPr>
-        <p:txBody>
-          <a:bodyPr wrap="square" lIns="0" tIns="0" rIns="0" bIns="0" rtlCol="0" anchor="t">
-            <a:normAutofit fontScale="85000" lnSpcReduction="10000"/>
-          </a:bodyPr>
-          <a:lstStyle/>
-          <a:p>
-            <a:pPr marL="342900" indent="-342900">
-              <a:lnSpc>
-                <a:spcPts val="1050"/>
-              </a:lnSpc>
-              <a:spcAft>
-                <a:spcPts val="400"/>
-              </a:spcAft>
-              <a:buSzPct val="100000"/>
-              <a:buChar char="•"/>
-            </a:pPr>
-            <a:r>
-              <a:rPr lang="en-US" sz="1000">
-                <a:solidFill>
-                  <a:srgbClr val="3A4453"/>
-                </a:solidFill>
-              </a:rPr>
-              <a:t>The trend has turned up since January and has recovered $692k of that, about 12%.</a:t>
-            </a:r>
-            <a:endParaRPr lang="en-US" sz="850"/>
-          </a:p>
-          <a:p>
-            <a:pPr marL="342900" indent="-342900">
-              <a:lnSpc>
-                <a:spcPts val="1050"/>
-              </a:lnSpc>
-              <a:spcAft>
-                <a:spcPts val="400"/>
-              </a:spcAft>
-              <a:buSzPct val="100000"/>
-              <a:buChar char="•"/>
-            </a:pPr>
-            <a:r>
-              <a:rPr lang="en-US" sz="1000">
-                <a:solidFill>
-                  <a:srgbClr val="3A4453"/>
-                </a:solidFill>
-              </a:rPr>
-              <a:t>It is still $491k or 7% below the peak. The recovery is real but it is not finished.</a:t>
-            </a:r>
-            <a:endParaRPr lang="en-US" sz="850"/>
-          </a:p>
-        </p:txBody>
-      </p:sp>
-      <p:pic>
-        <p:nvPicPr>
-          <p:cNvPr id="26" name="cts logo" descr="image.png"/>
-          <p:cNvPicPr>
-            <a:picLocks noChangeAspect="1"/>
-          </p:cNvPicPr>
-          <p:nvPr/>
-        </p:nvPicPr>
-        <p:blipFill>
-          <a:blip r:embed="rId2"/>
-          <a:stretch>
-            <a:fillRect/>
-          </a:stretch>
-        </p:blipFill>
-        <p:spPr>
-          <a:xfrm>
-            <a:off x="7680959" y="182880"/>
-            <a:ext cx="960120" cy="539696"/>
-          </a:xfrm>
-          <a:prstGeom prst="rect">
-            <a:avLst/>
-          </a:prstGeom>
-        </p:spPr>
-      </p:pic>
     </p:spTree>
   </p:cSld>
   <p:clrMapOvr>

</xml_diff>

<commit_message>
Monthly and quarterly never share a slide, and the rule is in CLAUDE.md
The deck is one file serving both the monthly and the quarterly review, with the
slides that do not apply hidden. So a chart may never carry the month and the
quarter together, or hiding one review breaks the other.

The profit page had three Septembers and three first quarters on one chart. It is
now two pages: net profit and net loss for the month, then the same for the
quarter. The commentary and the speaker notes split with it, and neither refers
across to the other, because either one may be the page on screen.

The pack follows: the net profit block is two blocks and two charts rather than
one of each.

The rule is written into CLAUDE.md so it holds for anything added later.

Co-Authored-By: Claude Opus 5 <noreply@anthropic.com>
Claude-Session: https://claude.ai/code/session_01CVBAFohBCYXt1ufjTVDiZj
</commit_message>
<xml_diff>
--- a/deck/CTS Monthly Business Review - 30092026.pptx
+++ b/deck/CTS Monthly Business Review - 30092026.pptx
@@ -22,6 +22,7 @@
     <p:sldId id="295" r:id="rId49"/>
     <p:sldId id="296" r:id="rId50"/>
     <p:sldId id="297" r:id="rId51"/>
+    <p:sldId id="298" r:id="rId52"/>
     <p:sldId id="262" r:id="rId16"/>
     <p:sldId id="263" r:id="rId17"/>
     <p:sldId id="264" r:id="rId18"/>
@@ -4780,49 +4781,125 @@
           <a:lstStyle/>
           <a:p>
             <a:r>
-              <a:t>Net profit above and below the line, the reporting month and the first quarter across three years, taken from the Xero History tab. Net profit is the pack's own figure and includes other income.</a:t>
+              <a:t>Net profit and net loss for September across three years, taken from the Xero History tab. Net profit is the pack's own figure and includes other income.</a:t>
             </a:r>
           </a:p>
           <a:p/>
           <a:p>
             <a:r>
-              <a:t>The month: September 2026 a loss of $41,464, September 2025 a loss of $52,615, September 2024 a profit of $20,737.</a:t>
+              <a:t>September 2026 a loss of $41,464. September 2025 a loss of $52,615. September 2024 a profit of $20,737.</a:t>
             </a:r>
           </a:p>
           <a:p/>
           <a:p>
             <a:r>
-              <a:t>The quarter: Q1 2026 a loss of $5,808, Q1 2025 a loss of $85,404, Q1 2024 a profit of $34,595.</a:t>
+              <a:t>This September is $11,152 better than the same month last year, and $62,201 worse than the September before that.</a:t>
             </a:r>
           </a:p>
           <a:p/>
           <a:p>
             <a:r>
-              <a:t>Two readings come out of this and they point in opposite directions.</a:t>
+              <a:t>The thing worth drawing out is that the loss is not a revenue failure. September 2026 billed $561,945, which is the highest of the three Septembers, ahead of $356,323 last year and $440,243 the year before. The month earned more than either comparison and still finished below the line.</a:t>
             </a:r>
           </a:p>
           <a:p/>
           <a:p>
             <a:r>
-              <a:t>The first is that the business has been below the line for two years. Five of the six bars on this chart are losses or near enough, and the only two profits are both FY25. Whatever else the numbers say, September and the first quarter have not made money since FY25.</a:t>
+              <a:t>What changed is the cost of earning it. Cost of sales was $374,130 against $216,749 in September 2024 on revenue only $121,701 higher. The gross margin on the month was 33.4%, against 50.8% in September 2024.</a:t>
             </a:r>
           </a:p>
           <a:p/>
           <a:p>
             <a:r>
-              <a:t>The second is that the direction is right. The quarter has improved $79,596 on last year and is within $5,808 of breaking even. The month is $11,152 better than the same month last year. On revenue alone the business is billing a third more than it did a year ago.</a:t>
+              <a:t>So the question this chart puts to the board is about pricing and delivery cost on the work being won, not about the volume of work being won.</a:t>
             </a:r>
           </a:p>
           <a:p/>
           <a:p>
             <a:r>
-              <a:t>What stops that being good news is the plan. The budget had the first quarter at a $222,700 profit. Coming in at a $5,808 loss is $228,508 below it. The business has recovered most of the ground it lost in FY26 and is still a long way from the year it was asked to deliver.</a:t>
+              <a:t>FY25 was pulled from Xero on 22 October 2026. FY26 is the Actual FY26 tab and FY27 the P&amp;L FY27 tab. The month follows the reporting month on Setup, so in October this becomes October. Only the first quarter of FY25 was pulled, so the FY25 bar is blank from October until the rest is pulled.</a:t>
+            </a:r>
+          </a:p>
+        </p:txBody>
+      </p:sp>
+    </p:spTree>
+  </p:cSld>
+  <p:clrMapOvr>
+    <a:masterClrMapping/>
+  </p:clrMapOvr>
+</p:notes>
+</file>
+
+<file path=ppt/notesSlides/notesSlide41.xml><?xml version="1.0" encoding="utf-8"?>
+<p:notes xmlns:a="http://schemas.openxmlformats.org/drawingml/2006/main" xmlns:p="http://schemas.openxmlformats.org/presentationml/2006/main" xmlns:r="http://schemas.openxmlformats.org/officeDocument/2006/relationships">
+  <p:cSld>
+    <p:spTree>
+      <p:nvGrpSpPr>
+        <p:cNvPr id="1" name=""/>
+        <p:cNvGrpSpPr/>
+        <p:nvPr/>
+      </p:nvGrpSpPr>
+      <p:grpSpPr>
+        <a:xfrm>
+          <a:off x="0" y="0"/>
+          <a:ext cx="0" cy="0"/>
+          <a:chOff x="0" y="0"/>
+          <a:chExt cx="0" cy="0"/>
+        </a:xfrm>
+      </p:grpSpPr>
+      <p:sp>
+        <p:nvSpPr>
+          <p:cNvPr id="3" name="Notes Placeholder 2"/>
+          <p:cNvSpPr>
+            <a:spLocks noGrp="1"/>
+          </p:cNvSpPr>
+          <p:nvPr>
+            <p:ph type="body" idx="1"/>
+          </p:nvPr>
+        </p:nvSpPr>
+        <p:spPr/>
+        <p:txBody>
+          <a:bodyPr lIns="107095" tIns="53547" rIns="107095" bIns="53547"/>
+          <a:lstStyle/>
+          <a:p>
+            <a:r>
+              <a:t>Net profit and net loss for the first quarter across three years, taken from the Xero History tab. Net profit is the pack's own figure and includes other income.</a:t>
             </a:r>
           </a:p>
           <a:p/>
           <a:p>
             <a:r>
-              <a:t>FY25 was pulled from Xero on 22 October 2026. Only the first quarter of FY25 was pulled, so the FY25 bar on the monthly side is blank from October onward until the rest is pulled.</a:t>
+              <a:t>Q1 2026 a loss of $5,808. Q1 2025 a loss of $85,404. Q1 2024 a profit of $34,595.</a:t>
+            </a:r>
+          </a:p>
+          <a:p/>
+          <a:p>
+            <a:r>
+              <a:t>The quarter has improved $79,596 on last year and is within $5,808 of breaking even. On that reading the recovery is real and the direction is right.</a:t>
+            </a:r>
+          </a:p>
+          <a:p/>
+          <a:p>
+            <a:r>
+              <a:t>Against the plan it reads differently. The budget had the first quarter at a $222,700 profit. Coming in at a $5,808 loss is $228,508 below it.</a:t>
+            </a:r>
+          </a:p>
+          <a:p/>
+          <a:p>
+            <a:r>
+              <a:t>As with the month, this is not a revenue failure. The quarter billed $1,624,460, which is the highest first quarter of the three, ahead of $1,228,582 last year and $1,380,102 the year before. It earned more than either comparison and still finished below the line.</a:t>
+            </a:r>
+          </a:p>
+          <a:p/>
+          <a:p>
+            <a:r>
+              <a:t>The cost of earning it is where the quarter went. Cost of sales was $992,160 against $708,478 in Q1 2024, which is $283,682 more on revenue $244,358 higher. Overheads were almost unchanged at $641,508 against $638,615. The overhead base is not the problem and has not been for three years. The margin on the work is.</a:t>
+            </a:r>
+          </a:p>
+          <a:p/>
+          <a:p>
+            <a:r>
+              <a:t>FY25 was pulled from Xero on 22 October 2026. The quarter is July to September, so it is fixed rather than following Setup.</a:t>
             </a:r>
           </a:p>
         </p:txBody>
@@ -7822,22 +7899,22 @@
       <p:grpSpPr/>
       <p:pic>
         <p:nvPicPr>
-          <p:cNvPr id="27" name="snip profit_line" descr="profit_line.png"/>
+          <p:cNvPr id="27" name="snip profit_month" descr="profit_month.png"/>
           <p:cNvPicPr>
             <a:picLocks noChangeAspect="1"/>
           </p:cNvPicPr>
           <p:nvPr/>
         </p:nvPicPr>
         <p:blipFill>
-          <a:blip r:embed="rId3"/>
+          <a:blip r:embed="rId5"/>
           <a:stretch>
             <a:fillRect/>
           </a:stretch>
         </p:blipFill>
         <p:spPr>
           <a:xfrm>
-            <a:off x="522419" y="1005840"/>
-            <a:ext cx="8099161" cy="2525689"/>
+            <a:off x="793198" y="1005840"/>
+            <a:ext cx="7557602" cy="2356806"/>
           </a:xfrm>
           <a:prstGeom prst="rect">
             <a:avLst/>
@@ -7910,7 +7987,7 @@
                   <a:srgbClr val="242C39"/>
                 </a:solidFill>
               </a:rPr>
-              <a:t>Net profit above and below the line</a:t>
+              <a:t>Net profit and net loss, the month</a:t>
             </a:r>
             <a:endParaRPr lang="en-US" sz="2700" dirty="0"/>
           </a:p>
@@ -7924,8 +8001,8 @@
         </p:nvSpPr>
         <p:spPr>
           <a:xfrm>
-            <a:off x="502920" y="3622969"/>
-            <a:ext cx="8138160" cy="1003894"/>
+            <a:off x="502920" y="3454086"/>
+            <a:ext cx="8138160" cy="1172777"/>
           </a:xfrm>
           <a:prstGeom prst="rect">
             <a:avLst/>
@@ -7951,7 +8028,7 @@
         </p:nvSpPr>
         <p:spPr>
           <a:xfrm>
-            <a:off x="685800" y="3696121"/>
+            <a:off x="685800" y="3527238"/>
             <a:ext cx="2743200" cy="228600"/>
           </a:xfrm>
           <a:prstGeom prst="rect">
@@ -7987,8 +8064,8 @@
         </p:nvSpPr>
         <p:spPr>
           <a:xfrm>
-            <a:off x="685800" y="3869857"/>
-            <a:ext cx="3703320" cy="729574"/>
+            <a:off x="685800" y="3700974"/>
+            <a:ext cx="3703320" cy="898457"/>
           </a:xfrm>
           <a:prstGeom prst="rect">
             <a:avLst/>
@@ -8018,7 +8095,7 @@
                   <a:srgbClr val="3A4453"/>
                 </a:solidFill>
               </a:rPr>
-              <a:t>September lost $41k. Last September lost $53k. The September before made $21k.</a:t>
+              <a:t>September lost $41k, against a $53k loss last September and a $21k profit the September before.</a:t>
             </a:r>
             <a:endParaRPr lang="en-US" sz="850"/>
           </a:p>
@@ -8039,7 +8116,7 @@
                   <a:srgbClr val="3A4453"/>
                 </a:solidFill>
               </a:rPr>
-              <a:t>The quarter lost $6k, against a $85k loss last year and a $35k profit the year before.</a:t>
+              <a:t>This September is $11k better than the same month last year.</a:t>
             </a:r>
             <a:endParaRPr lang="en-US" sz="850"/>
           </a:p>
@@ -8098,8 +8175,8 @@
         </p:nvSpPr>
         <p:spPr>
           <a:xfrm>
-            <a:off x="4663440" y="3869857"/>
-            <a:ext cx="3703320" cy="729574"/>
+            <a:off x="4663440" y="3700974"/>
+            <a:ext cx="3703320" cy="898457"/>
           </a:xfrm>
           <a:prstGeom prst="rect">
             <a:avLst/>
@@ -8129,7 +8206,7 @@
                   <a:srgbClr val="3A4453"/>
                 </a:solidFill>
               </a:rPr>
-              <a:t>The quarter is $80k better than last year and close to breakeven.</a:t>
+              <a:t>Three Septembers and only one above the line, which is FY25.</a:t>
             </a:r>
             <a:endParaRPr lang="en-US" sz="850"/>
           </a:p>
@@ -8150,7 +8227,7 @@
                   <a:srgbClr val="3A4453"/>
                 </a:solidFill>
               </a:rPr>
-              <a:t>It is still $229k below budget, which had the quarter at a $223k profit.</a:t>
+              <a:t>September revenue was the highest of the three at $562k, so the loss is a margin problem rather than a revenue problem.</a:t>
             </a:r>
             <a:endParaRPr lang="en-US" sz="850"/>
           </a:p>
@@ -8189,6 +8266,384 @@
 </file>
 
 <file path=ppt/slides/slide15.xml><?xml version="1.0" encoding="utf-8"?>
+<p:sld xmlns:a="http://schemas.openxmlformats.org/drawingml/2006/main" xmlns:p="http://schemas.openxmlformats.org/presentationml/2006/main" xmlns:r="http://schemas.openxmlformats.org/officeDocument/2006/relationships">
+  <p:cSld>
+    <p:spTree>
+      <p:nvGrpSpPr>
+        <p:cNvPr id="1" name=""/>
+        <p:cNvGrpSpPr/>
+        <p:nvPr/>
+      </p:nvGrpSpPr>
+      <p:grpSpPr/>
+      <p:pic>
+        <p:nvPicPr>
+          <p:cNvPr id="27" name="snip profit_qtr" descr="profit_qtr.png"/>
+          <p:cNvPicPr>
+            <a:picLocks noChangeAspect="1"/>
+          </p:cNvPicPr>
+          <p:nvPr/>
+        </p:nvPicPr>
+        <p:blipFill>
+          <a:blip r:embed="rId3"/>
+          <a:stretch>
+            <a:fillRect/>
+          </a:stretch>
+        </p:blipFill>
+        <p:spPr>
+          <a:xfrm>
+            <a:off x="522419" y="1005840"/>
+            <a:ext cx="8099161" cy="2525689"/>
+          </a:xfrm>
+          <a:prstGeom prst="rect">
+            <a:avLst/>
+          </a:prstGeom>
+        </p:spPr>
+      </p:pic>
+      <p:sp>
+        <p:nvSpPr>
+          <p:cNvPr id="2" name="Text 0"/>
+          <p:cNvSpPr txBox="1"/>
+          <p:nvPr/>
+        </p:nvSpPr>
+        <p:spPr>
+          <a:xfrm>
+            <a:off x="502920" y="365760"/>
+            <a:ext cx="6400800" cy="274320"/>
+          </a:xfrm>
+          <a:prstGeom prst="rect">
+            <a:avLst/>
+          </a:prstGeom>
+          <a:noFill/>
+          <a:ln/>
+        </p:spPr>
+        <p:txBody>
+          <a:bodyPr wrap="square" lIns="0" tIns="0" rIns="0" bIns="0" rtlCol="0" anchor="ctr"/>
+          <a:lstStyle/>
+          <a:p>
+            <a:pPr marL="0" indent="0">
+              <a:buNone/>
+            </a:pPr>
+            <a:r>
+              <a:rPr lang="en-US" sz="950" b="1" kern="0" spc="220">
+                <a:solidFill>
+                  <a:srgbClr val="122B82"/>
+                </a:solidFill>
+              </a:rPr>
+              <a:t>FINANCIAL PERFORMANCE</a:t>
+            </a:r>
+            <a:endParaRPr lang="en-US" sz="950"/>
+          </a:p>
+        </p:txBody>
+      </p:sp>
+      <p:sp>
+        <p:nvSpPr>
+          <p:cNvPr id="3" name="Text 1"/>
+          <p:cNvSpPr txBox="1"/>
+          <p:nvPr/>
+        </p:nvSpPr>
+        <p:spPr>
+          <a:xfrm>
+            <a:off x="502920" y="640080"/>
+            <a:ext cx="7315200" cy="365760"/>
+          </a:xfrm>
+          <a:prstGeom prst="rect">
+            <a:avLst/>
+          </a:prstGeom>
+          <a:noFill/>
+          <a:ln/>
+        </p:spPr>
+        <p:txBody>
+          <a:bodyPr wrap="square" lIns="0" tIns="0" rIns="0" bIns="0" rtlCol="0" anchor="ctr"/>
+          <a:lstStyle/>
+          <a:p>
+            <a:pPr marL="0" indent="0" algn="ctr">
+              <a:buNone/>
+            </a:pPr>
+            <a:r>
+              <a:rPr lang="en-US" sz="2200" b="1" dirty="0">
+                <a:solidFill>
+                  <a:srgbClr val="242C39"/>
+                </a:solidFill>
+              </a:rPr>
+              <a:t>Net profit and net loss, the quarter</a:t>
+            </a:r>
+            <a:endParaRPr lang="en-US" sz="2700" dirty="0"/>
+          </a:p>
+        </p:txBody>
+      </p:sp>
+      <p:sp>
+        <p:nvSpPr>
+          <p:cNvPr id="6" name="commentary panel"/>
+          <p:cNvSpPr/>
+          <p:nvPr/>
+        </p:nvSpPr>
+        <p:spPr>
+          <a:xfrm>
+            <a:off x="502920" y="3622969"/>
+            <a:ext cx="8138160" cy="1003894"/>
+          </a:xfrm>
+          <a:prstGeom prst="rect">
+            <a:avLst/>
+          </a:prstGeom>
+          <a:solidFill>
+            <a:srgbClr val="E8F9F8"/>
+          </a:solidFill>
+          <a:ln/>
+        </p:spPr>
+        <p:txBody>
+          <a:bodyPr/>
+          <a:lstStyle/>
+          <a:p>
+            <a:endParaRPr lang="en-AU"/>
+          </a:p>
+        </p:txBody>
+      </p:sp>
+      <p:sp>
+        <p:nvSpPr>
+          <p:cNvPr id="7" name="Text 4"/>
+          <p:cNvSpPr txBox="1"/>
+          <p:nvPr/>
+        </p:nvSpPr>
+        <p:spPr>
+          <a:xfrm>
+            <a:off x="685800" y="3696121"/>
+            <a:ext cx="2743200" cy="228600"/>
+          </a:xfrm>
+          <a:prstGeom prst="rect">
+            <a:avLst/>
+          </a:prstGeom>
+          <a:noFill/>
+          <a:ln/>
+        </p:spPr>
+        <p:txBody>
+          <a:bodyPr wrap="square" lIns="0" tIns="0" rIns="0" bIns="0" rtlCol="0" anchor="ctr"/>
+          <a:lstStyle/>
+          <a:p>
+            <a:pPr marL="0" indent="0">
+              <a:buNone/>
+            </a:pPr>
+            <a:r>
+              <a:rPr lang="en-US" sz="900" b="1" kern="0" spc="180">
+                <a:solidFill>
+                  <a:srgbClr val="005358"/>
+                </a:solidFill>
+              </a:rPr>
+              <a:t>COMMENTARY</a:t>
+            </a:r>
+            <a:endParaRPr lang="en-US" sz="900"/>
+          </a:p>
+        </p:txBody>
+      </p:sp>
+      <p:sp>
+        <p:nvSpPr>
+          <p:cNvPr id="8" name="Text 5"/>
+          <p:cNvSpPr txBox="1"/>
+          <p:nvPr/>
+        </p:nvSpPr>
+        <p:spPr>
+          <a:xfrm>
+            <a:off x="685800" y="3869857"/>
+            <a:ext cx="3703320" cy="729574"/>
+          </a:xfrm>
+          <a:prstGeom prst="rect">
+            <a:avLst/>
+          </a:prstGeom>
+          <a:noFill/>
+          <a:ln/>
+        </p:spPr>
+        <p:txBody>
+          <a:bodyPr wrap="square" lIns="0" tIns="0" rIns="0" bIns="0" rtlCol="0" anchor="t">
+            <a:normAutofit fontScale="85000" lnSpcReduction="10000"/>
+          </a:bodyPr>
+          <a:lstStyle/>
+          <a:p>
+            <a:pPr marL="342900" indent="-342900">
+              <a:lnSpc>
+                <a:spcPts val="1050"/>
+              </a:lnSpc>
+              <a:spcAft>
+                <a:spcPts val="400"/>
+              </a:spcAft>
+              <a:buSzPct val="100000"/>
+              <a:buChar char="•"/>
+            </a:pPr>
+            <a:r>
+              <a:rPr lang="en-US" sz="1000">
+                <a:solidFill>
+                  <a:srgbClr val="3A4453"/>
+                </a:solidFill>
+              </a:rPr>
+              <a:t>The quarter lost $6k, against a $85k loss last year and a $35k profit the year before.</a:t>
+            </a:r>
+            <a:endParaRPr lang="en-US" sz="850"/>
+          </a:p>
+          <a:p>
+            <a:pPr marL="342900" indent="-342900">
+              <a:lnSpc>
+                <a:spcPts val="1050"/>
+              </a:lnSpc>
+              <a:spcAft>
+                <a:spcPts val="400"/>
+              </a:spcAft>
+              <a:buSzPct val="100000"/>
+              <a:buChar char="•"/>
+            </a:pPr>
+            <a:r>
+              <a:rPr lang="en-US" sz="1000">
+                <a:solidFill>
+                  <a:srgbClr val="3A4453"/>
+                </a:solidFill>
+              </a:rPr>
+              <a:t>That is $80k better than last year and within $6k of breaking even.</a:t>
+            </a:r>
+            <a:endParaRPr lang="en-US" sz="850"/>
+          </a:p>
+        </p:txBody>
+      </p:sp>
+      <p:sp>
+        <p:nvSpPr>
+          <p:cNvPr id="25" name="Slide Number Placeholder 0"/>
+          <p:cNvSpPr>
+            <a:spLocks noGrp="1"/>
+          </p:cNvSpPr>
+          <p:nvPr>
+            <p:ph type="sldNum" sz="quarter" idx="4294967295"/>
+          </p:nvPr>
+        </p:nvSpPr>
+        <p:spPr>
+          <a:xfrm>
+            <a:off x="8092440" y="4736592"/>
+            <a:ext cx="548640" cy="228600"/>
+          </a:xfrm>
+          <a:prstGeom prst="rect">
+            <a:avLst/>
+          </a:prstGeom>
+          <a:extLst>
+            <a:ext uri="{C572A759-6A51-4108-AA02-DFA0A04FC94B}">
+              <ma14:wrappingTextBoxFlag xmlns="" xmlns:ma14="http://schemas.microsoft.com/office/mac/drawingml/2011/main" val="0"/>
+            </a:ext>
+          </a:extLst>
+        </p:spPr>
+        <p:txBody>
+          <a:bodyPr/>
+          <a:lstStyle>
+            <a:lvl1pPr>
+              <a:defRPr sz="800">
+                <a:solidFill>
+                  <a:srgbClr val="6B7585"/>
+                </a:solidFill>
+              </a:defRPr>
+            </a:lvl1pPr>
+          </a:lstStyle>
+          <a:p>
+            <a:pPr algn="r"/>
+            <a:fld id="{F7021451-1387-4CA6-816F-3879F97B5CBC}" type="slidenum">
+              <a:rPr lang="en-US" b="0"/>
+              <a:t>9</a:t>
+            </a:fld>
+            <a:endParaRPr lang="en-US"/>
+          </a:p>
+        </p:txBody>
+      </p:sp>
+      <p:sp>
+        <p:nvSpPr>
+          <p:cNvPr id="4" name="Text 5b"/>
+          <p:cNvSpPr txBox="1"/>
+          <p:nvPr/>
+        </p:nvSpPr>
+        <p:spPr>
+          <a:xfrm>
+            <a:off x="4663440" y="3869857"/>
+            <a:ext cx="3703320" cy="729574"/>
+          </a:xfrm>
+          <a:prstGeom prst="rect">
+            <a:avLst/>
+          </a:prstGeom>
+          <a:noFill/>
+          <a:ln/>
+        </p:spPr>
+        <p:txBody>
+          <a:bodyPr wrap="square" lIns="0" tIns="0" rIns="0" bIns="0" rtlCol="0" anchor="t">
+            <a:normAutofit fontScale="85000" lnSpcReduction="10000"/>
+          </a:bodyPr>
+          <a:lstStyle/>
+          <a:p>
+            <a:pPr marL="342900" indent="-342900">
+              <a:lnSpc>
+                <a:spcPts val="1050"/>
+              </a:lnSpc>
+              <a:spcAft>
+                <a:spcPts val="400"/>
+              </a:spcAft>
+              <a:buSzPct val="100000"/>
+              <a:buChar char="•"/>
+            </a:pPr>
+            <a:r>
+              <a:rPr lang="en-US" sz="1000">
+                <a:solidFill>
+                  <a:srgbClr val="3A4453"/>
+                </a:solidFill>
+              </a:rPr>
+              <a:t>It is still $229k below the budget, which had the quarter at a $223k profit.</a:t>
+            </a:r>
+            <a:endParaRPr lang="en-US" sz="850"/>
+          </a:p>
+          <a:p>
+            <a:pPr marL="342900" indent="-342900">
+              <a:lnSpc>
+                <a:spcPts val="1050"/>
+              </a:lnSpc>
+              <a:spcAft>
+                <a:spcPts val="400"/>
+              </a:spcAft>
+              <a:buSzPct val="100000"/>
+              <a:buChar char="•"/>
+            </a:pPr>
+            <a:r>
+              <a:rPr lang="en-US" sz="1000">
+                <a:solidFill>
+                  <a:srgbClr val="3A4453"/>
+                </a:solidFill>
+              </a:rPr>
+              <a:t>Quarter revenue was the highest of the three at $1,624k, so again the gap is margin.</a:t>
+            </a:r>
+            <a:endParaRPr lang="en-US" sz="850"/>
+          </a:p>
+        </p:txBody>
+      </p:sp>
+      <p:pic>
+        <p:nvPicPr>
+          <p:cNvPr id="26" name="cts logo" descr="image.png"/>
+          <p:cNvPicPr>
+            <a:picLocks noChangeAspect="1"/>
+          </p:cNvPicPr>
+          <p:nvPr/>
+        </p:nvPicPr>
+        <p:blipFill>
+          <a:blip r:embed="rId2"/>
+          <a:stretch>
+            <a:fillRect/>
+          </a:stretch>
+        </p:blipFill>
+        <p:spPr>
+          <a:xfrm>
+            <a:off x="7680959" y="182880"/>
+            <a:ext cx="960120" cy="539696"/>
+          </a:xfrm>
+          <a:prstGeom prst="rect">
+            <a:avLst/>
+          </a:prstGeom>
+        </p:spPr>
+      </p:pic>
+    </p:spTree>
+  </p:cSld>
+  <p:clrMapOvr>
+    <a:masterClrMapping/>
+  </p:clrMapOvr>
+</p:sld>
+</file>
+
+<file path=ppt/slides/slide16.xml><?xml version="1.0" encoding="utf-8"?>
 <p:sld xmlns:a="http://schemas.openxmlformats.org/drawingml/2006/main" xmlns:r="http://schemas.openxmlformats.org/officeDocument/2006/relationships" xmlns:p="http://schemas.openxmlformats.org/presentationml/2006/main">
   <p:cSld name="Slide 7">
     <p:spTree>
@@ -8573,7 +9028,7 @@
 </p:sld>
 </file>
 
-<file path=ppt/slides/slide16.xml><?xml version="1.0" encoding="utf-8"?>
+<file path=ppt/slides/slide17.xml><?xml version="1.0" encoding="utf-8"?>
 <p:sld xmlns:a="http://schemas.openxmlformats.org/drawingml/2006/main" xmlns:r="http://schemas.openxmlformats.org/officeDocument/2006/relationships" xmlns:p="http://schemas.openxmlformats.org/presentationml/2006/main">
   <p:cSld name="Slide 8">
     <p:spTree>
@@ -8958,7 +9413,7 @@
 </p:sld>
 </file>
 
-<file path=ppt/slides/slide17.xml><?xml version="1.0" encoding="utf-8"?>
+<file path=ppt/slides/slide18.xml><?xml version="1.0" encoding="utf-8"?>
 <p:sld xmlns:a="http://schemas.openxmlformats.org/drawingml/2006/main" xmlns:r="http://schemas.openxmlformats.org/officeDocument/2006/relationships" xmlns:p="http://schemas.openxmlformats.org/presentationml/2006/main">
   <p:cSld name="Slide 9">
     <p:spTree>
@@ -9364,7 +9819,7 @@
 </p:sld>
 </file>
 
-<file path=ppt/slides/slide18.xml><?xml version="1.0" encoding="utf-8"?>
+<file path=ppt/slides/slide19.xml><?xml version="1.0" encoding="utf-8"?>
 <p:sld xmlns:a="http://schemas.openxmlformats.org/drawingml/2006/main" xmlns:r="http://schemas.openxmlformats.org/officeDocument/2006/relationships" xmlns:p="http://schemas.openxmlformats.org/presentationml/2006/main">
   <p:cSld name="Slide 10">
     <p:spTree>
@@ -9759,412 +10214,6 @@
               <a:t>The team recorded 333 hours of leave and 241 billable hours, highlighting reduced available delivery capacity.</a:t>
             </a:r>
             <a:endParaRPr lang="en-US" sz="900"/>
-          </a:p>
-        </p:txBody>
-      </p:sp>
-    </p:spTree>
-  </p:cSld>
-  <p:clrMapOvr>
-    <a:masterClrMapping/>
-  </p:clrMapOvr>
-</p:sld>
-</file>
-
-<file path=ppt/slides/slide19.xml><?xml version="1.0" encoding="utf-8"?>
-<p:sld xmlns:a="http://schemas.openxmlformats.org/drawingml/2006/main" xmlns:r="http://schemas.openxmlformats.org/officeDocument/2006/relationships" xmlns:p="http://schemas.openxmlformats.org/presentationml/2006/main">
-  <p:cSld name="Slide 11">
-    <p:spTree>
-      <p:nvGrpSpPr>
-        <p:cNvPr id="1" name=""/>
-        <p:cNvGrpSpPr/>
-        <p:nvPr/>
-      </p:nvGrpSpPr>
-      <p:grpSpPr>
-        <a:xfrm>
-          <a:off x="0" y="0"/>
-          <a:ext cx="0" cy="0"/>
-          <a:chOff x="0" y="0"/>
-          <a:chExt cx="0" cy="0"/>
-        </a:xfrm>
-      </p:grpSpPr>
-      <p:pic>
-        <p:nvPicPr>
-          <p:cNvPr id="27" name="snip dept_Video" descr="dept_Video.png"/>
-          <p:cNvPicPr>
-            <a:picLocks noChangeAspect="1"/>
-          </p:cNvPicPr>
-          <p:nvPr/>
-        </p:nvPicPr>
-        <p:blipFill>
-          <a:blip r:embed="rId3"/>
-          <a:stretch>
-            <a:fillRect/>
-          </a:stretch>
-        </p:blipFill>
-        <p:spPr>
-          <a:xfrm>
-            <a:off x="683582" y="1005840"/>
-            <a:ext cx="7776835" cy="2302763"/>
-          </a:xfrm>
-          <a:prstGeom prst="rect">
-            <a:avLst/>
-          </a:prstGeom>
-        </p:spPr>
-      </p:pic>
-      <p:sp>
-        <p:nvSpPr>
-          <p:cNvPr id="2" name="Text 0"/>
-          <p:cNvSpPr txBox="1"/>
-          <p:nvPr/>
-        </p:nvSpPr>
-        <p:spPr>
-          <a:xfrm>
-            <a:off x="502920" y="365760"/>
-            <a:ext cx="6400800" cy="274320"/>
-          </a:xfrm>
-          <a:prstGeom prst="rect">
-            <a:avLst/>
-          </a:prstGeom>
-          <a:noFill/>
-          <a:ln/>
-        </p:spPr>
-        <p:txBody>
-          <a:bodyPr wrap="square" lIns="0" tIns="0" rIns="0" bIns="0" rtlCol="0" anchor="ctr"/>
-          <a:lstStyle/>
-          <a:p>
-            <a:pPr marL="0" indent="0">
-              <a:buNone/>
-            </a:pPr>
-            <a:r>
-              <a:rPr lang="en-US" sz="950" b="1" kern="0" spc="220">
-                <a:solidFill>
-                  <a:srgbClr val="122B82"/>
-                </a:solidFill>
-              </a:rPr>
-              <a:t>FINANCIAL PERFORMANCE</a:t>
-            </a:r>
-            <a:endParaRPr lang="en-US" sz="950"/>
-          </a:p>
-        </p:txBody>
-      </p:sp>
-      <p:sp>
-        <p:nvSpPr>
-          <p:cNvPr id="3" name="Text 1"/>
-          <p:cNvSpPr txBox="1"/>
-          <p:nvPr/>
-        </p:nvSpPr>
-        <p:spPr>
-          <a:xfrm>
-            <a:off x="502920" y="640080"/>
-            <a:ext cx="7315200" cy="365760"/>
-          </a:xfrm>
-          <a:prstGeom prst="rect">
-            <a:avLst/>
-          </a:prstGeom>
-          <a:noFill/>
-          <a:ln/>
-        </p:spPr>
-        <p:txBody>
-          <a:bodyPr wrap="square" lIns="0" tIns="0" rIns="0" bIns="0" rtlCol="0" anchor="ctr"/>
-          <a:lstStyle/>
-          <a:p>
-            <a:pPr marL="0" indent="0" algn="ctr">
-              <a:buNone/>
-            </a:pPr>
-            <a:r>
-              <a:rPr lang="en-US" sz="2200" b="1">
-                <a:solidFill>
-                  <a:srgbClr val="242C39"/>
-                </a:solidFill>
-              </a:rPr>
-              <a:t>Video, Sep 26</a:t>
-            </a:r>
-            <a:endParaRPr lang="en-US" sz="2700"/>
-          </a:p>
-        </p:txBody>
-      </p:sp>
-      <p:sp>
-        <p:nvSpPr>
-          <p:cNvPr id="6" name="commentary panel"/>
-          <p:cNvSpPr/>
-          <p:nvPr/>
-        </p:nvSpPr>
-        <p:spPr>
-          <a:xfrm>
-            <a:off x="502920" y="3400043"/>
-            <a:ext cx="8138160" cy="1226820"/>
-          </a:xfrm>
-          <a:prstGeom prst="rect">
-            <a:avLst/>
-          </a:prstGeom>
-          <a:solidFill>
-            <a:srgbClr val="E8F9F8"/>
-          </a:solidFill>
-          <a:ln/>
-        </p:spPr>
-        <p:txBody>
-          <a:bodyPr/>
-          <a:lstStyle/>
-          <a:p>
-            <a:endParaRPr lang="en-AU"/>
-          </a:p>
-        </p:txBody>
-      </p:sp>
-      <p:sp>
-        <p:nvSpPr>
-          <p:cNvPr id="7" name="Text 4"/>
-          <p:cNvSpPr txBox="1"/>
-          <p:nvPr/>
-        </p:nvSpPr>
-        <p:spPr>
-          <a:xfrm>
-            <a:off x="685800" y="3473195"/>
-            <a:ext cx="2743200" cy="228600"/>
-          </a:xfrm>
-          <a:prstGeom prst="rect">
-            <a:avLst/>
-          </a:prstGeom>
-          <a:noFill/>
-          <a:ln/>
-        </p:spPr>
-        <p:txBody>
-          <a:bodyPr wrap="square" lIns="0" tIns="0" rIns="0" bIns="0" rtlCol="0" anchor="ctr"/>
-          <a:lstStyle/>
-          <a:p>
-            <a:pPr marL="0" indent="0">
-              <a:buNone/>
-            </a:pPr>
-            <a:r>
-              <a:rPr lang="en-US" sz="900" b="1" kern="0" spc="180">
-                <a:solidFill>
-                  <a:srgbClr val="005358"/>
-                </a:solidFill>
-              </a:rPr>
-              <a:t>COMMENTARY</a:t>
-            </a:r>
-            <a:endParaRPr lang="en-US" sz="900"/>
-          </a:p>
-        </p:txBody>
-      </p:sp>
-      <p:sp>
-        <p:nvSpPr>
-          <p:cNvPr id="8" name="Text 5"/>
-          <p:cNvSpPr txBox="1"/>
-          <p:nvPr/>
-        </p:nvSpPr>
-        <p:spPr>
-          <a:xfrm>
-            <a:off x="685800" y="3646931"/>
-            <a:ext cx="3703320" cy="952500"/>
-          </a:xfrm>
-          <a:prstGeom prst="rect">
-            <a:avLst/>
-          </a:prstGeom>
-          <a:noFill/>
-          <a:ln/>
-        </p:spPr>
-        <p:txBody>
-          <a:bodyPr wrap="square" lIns="0" tIns="0" rIns="0" bIns="0" rtlCol="0" anchor="t">
-            <a:normAutofit/>
-          </a:bodyPr>
-          <a:lstStyle/>
-          <a:p>
-            <a:pPr marL="342900" indent="-342900">
-              <a:lnSpc>
-                <a:spcPts val="1200"/>
-              </a:lnSpc>
-              <a:spcAft>
-                <a:spcPts val="400"/>
-              </a:spcAft>
-              <a:buSzPct val="100000"/>
-              <a:buChar char="•"/>
-            </a:pPr>
-            <a:r>
-              <a:rPr lang="en-US" sz="1000">
-                <a:solidFill>
-                  <a:srgbClr val="3A4453"/>
-                </a:solidFill>
-              </a:rPr>
-              <a:t>Video generated $7k revenue against a $17k budget, marking a third consecutive month below plan.</a:t>
-            </a:r>
-            <a:endParaRPr lang="en-US" sz="950"/>
-          </a:p>
-          <a:p>
-            <a:pPr marL="342900" indent="-342900">
-              <a:lnSpc>
-                <a:spcPts val="1200"/>
-              </a:lnSpc>
-              <a:spcAft>
-                <a:spcPts val="400"/>
-              </a:spcAft>
-              <a:buSzPct val="100000"/>
-              <a:buChar char="•"/>
-            </a:pPr>
-            <a:r>
-              <a:rPr lang="en-US" sz="1000">
-                <a:solidFill>
-                  <a:srgbClr val="3A4453"/>
-                </a:solidFill>
-              </a:rPr>
-              <a:t>Gross margin was 79.6%, the highest of the departments.</a:t>
-            </a:r>
-            <a:endParaRPr lang="en-US" sz="950"/>
-          </a:p>
-          <a:p>
-            <a:pPr marL="342900" indent="-342900">
-              <a:lnSpc>
-                <a:spcPts val="1200"/>
-              </a:lnSpc>
-              <a:spcAft>
-                <a:spcPts val="400"/>
-              </a:spcAft>
-              <a:buSzPct val="100000"/>
-              <a:buChar char="•"/>
-            </a:pPr>
-            <a:r>
-              <a:rPr lang="en-US" sz="1000">
-                <a:solidFill>
-                  <a:srgbClr val="3A4453"/>
-                </a:solidFill>
-              </a:rPr>
-              <a:t>However, this produced only $6k in gross profit against approximately $13k of overheads.</a:t>
-            </a:r>
-            <a:endParaRPr lang="en-US" sz="950"/>
-          </a:p>
-        </p:txBody>
-      </p:sp>
-      <p:sp>
-        <p:nvSpPr>
-          <p:cNvPr id="25" name="Slide Number Placeholder 0"/>
-          <p:cNvSpPr>
-            <a:spLocks noGrp="1"/>
-          </p:cNvSpPr>
-          <p:nvPr>
-            <p:ph type="sldNum" sz="quarter" idx="4294967295"/>
-          </p:nvPr>
-        </p:nvSpPr>
-        <p:spPr>
-          <a:xfrm>
-            <a:off x="8092440" y="4736592"/>
-            <a:ext cx="548640" cy="228600"/>
-          </a:xfrm>
-          <a:prstGeom prst="rect">
-            <a:avLst/>
-          </a:prstGeom>
-          <a:extLst>
-            <a:ext uri="{C572A759-6A51-4108-AA02-DFA0A04FC94B}">
-              <ma14:wrappingTextBoxFlag xmlns="" xmlns:ma14="http://schemas.microsoft.com/office/mac/drawingml/2011/main" val="0"/>
-            </a:ext>
-          </a:extLst>
-        </p:spPr>
-        <p:txBody>
-          <a:bodyPr/>
-          <a:lstStyle>
-            <a:lvl1pPr>
-              <a:defRPr sz="800">
-                <a:solidFill>
-                  <a:srgbClr val="6B7585"/>
-                </a:solidFill>
-              </a:defRPr>
-            </a:lvl1pPr>
-          </a:lstStyle>
-          <a:p>
-            <a:pPr algn="r"/>
-            <a:fld id="{F7021451-1387-4CA6-816F-3879F97B5CBC}" type="slidenum">
-              <a:rPr lang="en-US" b="0"/>
-              <a:t>16</a:t>
-            </a:fld>
-            <a:endParaRPr lang="en-US"/>
-          </a:p>
-        </p:txBody>
-      </p:sp>
-      <p:pic>
-        <p:nvPicPr>
-          <p:cNvPr id="26" name="cts logo" descr="cts-logo.png"/>
-          <p:cNvPicPr>
-            <a:picLocks noChangeAspect="1"/>
-          </p:cNvPicPr>
-          <p:nvPr/>
-        </p:nvPicPr>
-        <p:blipFill>
-          <a:blip r:embed="rId4"/>
-          <a:stretch>
-            <a:fillRect/>
-          </a:stretch>
-        </p:blipFill>
-        <p:spPr>
-          <a:xfrm>
-            <a:off x="7680959" y="182880"/>
-            <a:ext cx="960120" cy="539696"/>
-          </a:xfrm>
-          <a:prstGeom prst="rect">
-            <a:avLst/>
-          </a:prstGeom>
-        </p:spPr>
-      </p:pic>
-      <p:sp>
-        <p:nvSpPr>
-          <p:cNvPr id="4" name="Text 5b"/>
-          <p:cNvSpPr txBox="1"/>
-          <p:nvPr/>
-        </p:nvSpPr>
-        <p:spPr>
-          <a:xfrm>
-            <a:off x="4663440" y="3646931"/>
-            <a:ext cx="3703320" cy="952500"/>
-          </a:xfrm>
-          <a:prstGeom prst="rect">
-            <a:avLst/>
-          </a:prstGeom>
-          <a:noFill/>
-          <a:ln/>
-        </p:spPr>
-        <p:txBody>
-          <a:bodyPr wrap="square" lIns="0" tIns="0" rIns="0" bIns="0" rtlCol="0" anchor="t">
-            <a:normAutofit/>
-          </a:bodyPr>
-          <a:lstStyle/>
-          <a:p>
-            <a:pPr marL="342900" indent="-342900">
-              <a:lnSpc>
-                <a:spcPts val="1200"/>
-              </a:lnSpc>
-              <a:spcAft>
-                <a:spcPts val="400"/>
-              </a:spcAft>
-              <a:buSzPct val="100000"/>
-              <a:buChar char="•"/>
-            </a:pPr>
-            <a:r>
-              <a:rPr lang="en-US" sz="1000">
-                <a:solidFill>
-                  <a:srgbClr val="3A4453"/>
-                </a:solidFill>
-              </a:rPr>
-              <a:t>The main challenge is the volume of billable work rather than the gross margin percentage.</a:t>
-            </a:r>
-            <a:endParaRPr lang="en-US" sz="950"/>
-          </a:p>
-          <a:p>
-            <a:pPr marL="342900" indent="-342900">
-              <a:lnSpc>
-                <a:spcPts val="1200"/>
-              </a:lnSpc>
-              <a:spcAft>
-                <a:spcPts val="400"/>
-              </a:spcAft>
-              <a:buSzPct val="100000"/>
-              <a:buChar char="•"/>
-            </a:pPr>
-            <a:r>
-              <a:rPr lang="en-US" sz="1000">
-                <a:solidFill>
-                  <a:srgbClr val="3A4453"/>
-                </a:solidFill>
-              </a:rPr>
-              <a:t>Only 24.5 billable hours were recorded for September, indicating limited activity.</a:t>
-            </a:r>
-            <a:endParaRPr lang="en-US" sz="950"/>
           </a:p>
         </p:txBody>
       </p:sp>
@@ -11019,6 +11068,412 @@
 
 <file path=ppt/slides/slide20.xml><?xml version="1.0" encoding="utf-8"?>
 <p:sld xmlns:a="http://schemas.openxmlformats.org/drawingml/2006/main" xmlns:r="http://schemas.openxmlformats.org/officeDocument/2006/relationships" xmlns:p="http://schemas.openxmlformats.org/presentationml/2006/main">
+  <p:cSld name="Slide 11">
+    <p:spTree>
+      <p:nvGrpSpPr>
+        <p:cNvPr id="1" name=""/>
+        <p:cNvGrpSpPr/>
+        <p:nvPr/>
+      </p:nvGrpSpPr>
+      <p:grpSpPr>
+        <a:xfrm>
+          <a:off x="0" y="0"/>
+          <a:ext cx="0" cy="0"/>
+          <a:chOff x="0" y="0"/>
+          <a:chExt cx="0" cy="0"/>
+        </a:xfrm>
+      </p:grpSpPr>
+      <p:pic>
+        <p:nvPicPr>
+          <p:cNvPr id="27" name="snip dept_Video" descr="dept_Video.png"/>
+          <p:cNvPicPr>
+            <a:picLocks noChangeAspect="1"/>
+          </p:cNvPicPr>
+          <p:nvPr/>
+        </p:nvPicPr>
+        <p:blipFill>
+          <a:blip r:embed="rId3"/>
+          <a:stretch>
+            <a:fillRect/>
+          </a:stretch>
+        </p:blipFill>
+        <p:spPr>
+          <a:xfrm>
+            <a:off x="683582" y="1005840"/>
+            <a:ext cx="7776835" cy="2302763"/>
+          </a:xfrm>
+          <a:prstGeom prst="rect">
+            <a:avLst/>
+          </a:prstGeom>
+        </p:spPr>
+      </p:pic>
+      <p:sp>
+        <p:nvSpPr>
+          <p:cNvPr id="2" name="Text 0"/>
+          <p:cNvSpPr txBox="1"/>
+          <p:nvPr/>
+        </p:nvSpPr>
+        <p:spPr>
+          <a:xfrm>
+            <a:off x="502920" y="365760"/>
+            <a:ext cx="6400800" cy="274320"/>
+          </a:xfrm>
+          <a:prstGeom prst="rect">
+            <a:avLst/>
+          </a:prstGeom>
+          <a:noFill/>
+          <a:ln/>
+        </p:spPr>
+        <p:txBody>
+          <a:bodyPr wrap="square" lIns="0" tIns="0" rIns="0" bIns="0" rtlCol="0" anchor="ctr"/>
+          <a:lstStyle/>
+          <a:p>
+            <a:pPr marL="0" indent="0">
+              <a:buNone/>
+            </a:pPr>
+            <a:r>
+              <a:rPr lang="en-US" sz="950" b="1" kern="0" spc="220">
+                <a:solidFill>
+                  <a:srgbClr val="122B82"/>
+                </a:solidFill>
+              </a:rPr>
+              <a:t>FINANCIAL PERFORMANCE</a:t>
+            </a:r>
+            <a:endParaRPr lang="en-US" sz="950"/>
+          </a:p>
+        </p:txBody>
+      </p:sp>
+      <p:sp>
+        <p:nvSpPr>
+          <p:cNvPr id="3" name="Text 1"/>
+          <p:cNvSpPr txBox="1"/>
+          <p:nvPr/>
+        </p:nvSpPr>
+        <p:spPr>
+          <a:xfrm>
+            <a:off x="502920" y="640080"/>
+            <a:ext cx="7315200" cy="365760"/>
+          </a:xfrm>
+          <a:prstGeom prst="rect">
+            <a:avLst/>
+          </a:prstGeom>
+          <a:noFill/>
+          <a:ln/>
+        </p:spPr>
+        <p:txBody>
+          <a:bodyPr wrap="square" lIns="0" tIns="0" rIns="0" bIns="0" rtlCol="0" anchor="ctr"/>
+          <a:lstStyle/>
+          <a:p>
+            <a:pPr marL="0" indent="0" algn="ctr">
+              <a:buNone/>
+            </a:pPr>
+            <a:r>
+              <a:rPr lang="en-US" sz="2200" b="1">
+                <a:solidFill>
+                  <a:srgbClr val="242C39"/>
+                </a:solidFill>
+              </a:rPr>
+              <a:t>Video, Sep 26</a:t>
+            </a:r>
+            <a:endParaRPr lang="en-US" sz="2700"/>
+          </a:p>
+        </p:txBody>
+      </p:sp>
+      <p:sp>
+        <p:nvSpPr>
+          <p:cNvPr id="6" name="commentary panel"/>
+          <p:cNvSpPr/>
+          <p:nvPr/>
+        </p:nvSpPr>
+        <p:spPr>
+          <a:xfrm>
+            <a:off x="502920" y="3400043"/>
+            <a:ext cx="8138160" cy="1226820"/>
+          </a:xfrm>
+          <a:prstGeom prst="rect">
+            <a:avLst/>
+          </a:prstGeom>
+          <a:solidFill>
+            <a:srgbClr val="E8F9F8"/>
+          </a:solidFill>
+          <a:ln/>
+        </p:spPr>
+        <p:txBody>
+          <a:bodyPr/>
+          <a:lstStyle/>
+          <a:p>
+            <a:endParaRPr lang="en-AU"/>
+          </a:p>
+        </p:txBody>
+      </p:sp>
+      <p:sp>
+        <p:nvSpPr>
+          <p:cNvPr id="7" name="Text 4"/>
+          <p:cNvSpPr txBox="1"/>
+          <p:nvPr/>
+        </p:nvSpPr>
+        <p:spPr>
+          <a:xfrm>
+            <a:off x="685800" y="3473195"/>
+            <a:ext cx="2743200" cy="228600"/>
+          </a:xfrm>
+          <a:prstGeom prst="rect">
+            <a:avLst/>
+          </a:prstGeom>
+          <a:noFill/>
+          <a:ln/>
+        </p:spPr>
+        <p:txBody>
+          <a:bodyPr wrap="square" lIns="0" tIns="0" rIns="0" bIns="0" rtlCol="0" anchor="ctr"/>
+          <a:lstStyle/>
+          <a:p>
+            <a:pPr marL="0" indent="0">
+              <a:buNone/>
+            </a:pPr>
+            <a:r>
+              <a:rPr lang="en-US" sz="900" b="1" kern="0" spc="180">
+                <a:solidFill>
+                  <a:srgbClr val="005358"/>
+                </a:solidFill>
+              </a:rPr>
+              <a:t>COMMENTARY</a:t>
+            </a:r>
+            <a:endParaRPr lang="en-US" sz="900"/>
+          </a:p>
+        </p:txBody>
+      </p:sp>
+      <p:sp>
+        <p:nvSpPr>
+          <p:cNvPr id="8" name="Text 5"/>
+          <p:cNvSpPr txBox="1"/>
+          <p:nvPr/>
+        </p:nvSpPr>
+        <p:spPr>
+          <a:xfrm>
+            <a:off x="685800" y="3646931"/>
+            <a:ext cx="3703320" cy="952500"/>
+          </a:xfrm>
+          <a:prstGeom prst="rect">
+            <a:avLst/>
+          </a:prstGeom>
+          <a:noFill/>
+          <a:ln/>
+        </p:spPr>
+        <p:txBody>
+          <a:bodyPr wrap="square" lIns="0" tIns="0" rIns="0" bIns="0" rtlCol="0" anchor="t">
+            <a:normAutofit/>
+          </a:bodyPr>
+          <a:lstStyle/>
+          <a:p>
+            <a:pPr marL="342900" indent="-342900">
+              <a:lnSpc>
+                <a:spcPts val="1200"/>
+              </a:lnSpc>
+              <a:spcAft>
+                <a:spcPts val="400"/>
+              </a:spcAft>
+              <a:buSzPct val="100000"/>
+              <a:buChar char="•"/>
+            </a:pPr>
+            <a:r>
+              <a:rPr lang="en-US" sz="1000">
+                <a:solidFill>
+                  <a:srgbClr val="3A4453"/>
+                </a:solidFill>
+              </a:rPr>
+              <a:t>Video generated $7k revenue against a $17k budget, marking a third consecutive month below plan.</a:t>
+            </a:r>
+            <a:endParaRPr lang="en-US" sz="950"/>
+          </a:p>
+          <a:p>
+            <a:pPr marL="342900" indent="-342900">
+              <a:lnSpc>
+                <a:spcPts val="1200"/>
+              </a:lnSpc>
+              <a:spcAft>
+                <a:spcPts val="400"/>
+              </a:spcAft>
+              <a:buSzPct val="100000"/>
+              <a:buChar char="•"/>
+            </a:pPr>
+            <a:r>
+              <a:rPr lang="en-US" sz="1000">
+                <a:solidFill>
+                  <a:srgbClr val="3A4453"/>
+                </a:solidFill>
+              </a:rPr>
+              <a:t>Gross margin was 79.6%, the highest of the departments.</a:t>
+            </a:r>
+            <a:endParaRPr lang="en-US" sz="950"/>
+          </a:p>
+          <a:p>
+            <a:pPr marL="342900" indent="-342900">
+              <a:lnSpc>
+                <a:spcPts val="1200"/>
+              </a:lnSpc>
+              <a:spcAft>
+                <a:spcPts val="400"/>
+              </a:spcAft>
+              <a:buSzPct val="100000"/>
+              <a:buChar char="•"/>
+            </a:pPr>
+            <a:r>
+              <a:rPr lang="en-US" sz="1000">
+                <a:solidFill>
+                  <a:srgbClr val="3A4453"/>
+                </a:solidFill>
+              </a:rPr>
+              <a:t>However, this produced only $6k in gross profit against approximately $13k of overheads.</a:t>
+            </a:r>
+            <a:endParaRPr lang="en-US" sz="950"/>
+          </a:p>
+        </p:txBody>
+      </p:sp>
+      <p:sp>
+        <p:nvSpPr>
+          <p:cNvPr id="25" name="Slide Number Placeholder 0"/>
+          <p:cNvSpPr>
+            <a:spLocks noGrp="1"/>
+          </p:cNvSpPr>
+          <p:nvPr>
+            <p:ph type="sldNum" sz="quarter" idx="4294967295"/>
+          </p:nvPr>
+        </p:nvSpPr>
+        <p:spPr>
+          <a:xfrm>
+            <a:off x="8092440" y="4736592"/>
+            <a:ext cx="548640" cy="228600"/>
+          </a:xfrm>
+          <a:prstGeom prst="rect">
+            <a:avLst/>
+          </a:prstGeom>
+          <a:extLst>
+            <a:ext uri="{C572A759-6A51-4108-AA02-DFA0A04FC94B}">
+              <ma14:wrappingTextBoxFlag xmlns="" xmlns:ma14="http://schemas.microsoft.com/office/mac/drawingml/2011/main" val="0"/>
+            </a:ext>
+          </a:extLst>
+        </p:spPr>
+        <p:txBody>
+          <a:bodyPr/>
+          <a:lstStyle>
+            <a:lvl1pPr>
+              <a:defRPr sz="800">
+                <a:solidFill>
+                  <a:srgbClr val="6B7585"/>
+                </a:solidFill>
+              </a:defRPr>
+            </a:lvl1pPr>
+          </a:lstStyle>
+          <a:p>
+            <a:pPr algn="r"/>
+            <a:fld id="{F7021451-1387-4CA6-816F-3879F97B5CBC}" type="slidenum">
+              <a:rPr lang="en-US" b="0"/>
+              <a:t>16</a:t>
+            </a:fld>
+            <a:endParaRPr lang="en-US"/>
+          </a:p>
+        </p:txBody>
+      </p:sp>
+      <p:pic>
+        <p:nvPicPr>
+          <p:cNvPr id="26" name="cts logo" descr="cts-logo.png"/>
+          <p:cNvPicPr>
+            <a:picLocks noChangeAspect="1"/>
+          </p:cNvPicPr>
+          <p:nvPr/>
+        </p:nvPicPr>
+        <p:blipFill>
+          <a:blip r:embed="rId4"/>
+          <a:stretch>
+            <a:fillRect/>
+          </a:stretch>
+        </p:blipFill>
+        <p:spPr>
+          <a:xfrm>
+            <a:off x="7680959" y="182880"/>
+            <a:ext cx="960120" cy="539696"/>
+          </a:xfrm>
+          <a:prstGeom prst="rect">
+            <a:avLst/>
+          </a:prstGeom>
+        </p:spPr>
+      </p:pic>
+      <p:sp>
+        <p:nvSpPr>
+          <p:cNvPr id="4" name="Text 5b"/>
+          <p:cNvSpPr txBox="1"/>
+          <p:nvPr/>
+        </p:nvSpPr>
+        <p:spPr>
+          <a:xfrm>
+            <a:off x="4663440" y="3646931"/>
+            <a:ext cx="3703320" cy="952500"/>
+          </a:xfrm>
+          <a:prstGeom prst="rect">
+            <a:avLst/>
+          </a:prstGeom>
+          <a:noFill/>
+          <a:ln/>
+        </p:spPr>
+        <p:txBody>
+          <a:bodyPr wrap="square" lIns="0" tIns="0" rIns="0" bIns="0" rtlCol="0" anchor="t">
+            <a:normAutofit/>
+          </a:bodyPr>
+          <a:lstStyle/>
+          <a:p>
+            <a:pPr marL="342900" indent="-342900">
+              <a:lnSpc>
+                <a:spcPts val="1200"/>
+              </a:lnSpc>
+              <a:spcAft>
+                <a:spcPts val="400"/>
+              </a:spcAft>
+              <a:buSzPct val="100000"/>
+              <a:buChar char="•"/>
+            </a:pPr>
+            <a:r>
+              <a:rPr lang="en-US" sz="1000">
+                <a:solidFill>
+                  <a:srgbClr val="3A4453"/>
+                </a:solidFill>
+              </a:rPr>
+              <a:t>The main challenge is the volume of billable work rather than the gross margin percentage.</a:t>
+            </a:r>
+            <a:endParaRPr lang="en-US" sz="950"/>
+          </a:p>
+          <a:p>
+            <a:pPr marL="342900" indent="-342900">
+              <a:lnSpc>
+                <a:spcPts val="1200"/>
+              </a:lnSpc>
+              <a:spcAft>
+                <a:spcPts val="400"/>
+              </a:spcAft>
+              <a:buSzPct val="100000"/>
+              <a:buChar char="•"/>
+            </a:pPr>
+            <a:r>
+              <a:rPr lang="en-US" sz="1000">
+                <a:solidFill>
+                  <a:srgbClr val="3A4453"/>
+                </a:solidFill>
+              </a:rPr>
+              <a:t>Only 24.5 billable hours were recorded for September, indicating limited activity.</a:t>
+            </a:r>
+            <a:endParaRPr lang="en-US" sz="950"/>
+          </a:p>
+        </p:txBody>
+      </p:sp>
+    </p:spTree>
+  </p:cSld>
+  <p:clrMapOvr>
+    <a:masterClrMapping/>
+  </p:clrMapOvr>
+</p:sld>
+</file>
+
+<file path=ppt/slides/slide21.xml><?xml version="1.0" encoding="utf-8"?>
+<p:sld xmlns:a="http://schemas.openxmlformats.org/drawingml/2006/main" xmlns:r="http://schemas.openxmlformats.org/officeDocument/2006/relationships" xmlns:p="http://schemas.openxmlformats.org/presentationml/2006/main">
   <p:cSld name="Slide 12">
     <p:spTree>
       <p:nvGrpSpPr>
@@ -11423,7 +11878,7 @@
 </p:sld>
 </file>
 
-<file path=ppt/slides/slide21.xml><?xml version="1.0" encoding="utf-8"?>
+<file path=ppt/slides/slide22.xml><?xml version="1.0" encoding="utf-8"?>
 <p:sld xmlns:a="http://schemas.openxmlformats.org/drawingml/2006/main" xmlns:r="http://schemas.openxmlformats.org/officeDocument/2006/relationships" xmlns:p="http://schemas.openxmlformats.org/presentationml/2006/main">
   <p:cSld name="Slide 13">
     <p:spTree>
@@ -11829,7 +12284,7 @@
 </p:sld>
 </file>
 
-<file path=ppt/slides/slide22.xml><?xml version="1.0" encoding="utf-8"?>
+<file path=ppt/slides/slide23.xml><?xml version="1.0" encoding="utf-8"?>
 <p:sld xmlns:a="http://schemas.openxmlformats.org/drawingml/2006/main" xmlns:r="http://schemas.openxmlformats.org/officeDocument/2006/relationships" xmlns:p="http://schemas.openxmlformats.org/presentationml/2006/main">
   <p:cSld name="Slide 14">
     <p:spTree>
@@ -12235,7 +12690,7 @@
 </p:sld>
 </file>
 
-<file path=ppt/slides/slide23.xml><?xml version="1.0" encoding="utf-8"?>
+<file path=ppt/slides/slide24.xml><?xml version="1.0" encoding="utf-8"?>
 <p:sld xmlns:a="http://schemas.openxmlformats.org/drawingml/2006/main" xmlns:r="http://schemas.openxmlformats.org/officeDocument/2006/relationships" xmlns:p="http://schemas.openxmlformats.org/presentationml/2006/main">
   <p:cSld name="Slide 15">
     <p:spTree>
@@ -12518,7 +12973,7 @@
 </p:sld>
 </file>
 
-<file path=ppt/slides/slide24.xml><?xml version="1.0" encoding="utf-8"?>
+<file path=ppt/slides/slide25.xml><?xml version="1.0" encoding="utf-8"?>
 <p:sld xmlns:a="http://schemas.openxmlformats.org/drawingml/2006/main" xmlns:r="http://schemas.openxmlformats.org/officeDocument/2006/relationships" xmlns:p="http://schemas.openxmlformats.org/presentationml/2006/main">
   <p:cSld name="Slide 16">
     <p:spTree>
@@ -12924,7 +13379,7 @@
 </p:sld>
 </file>
 
-<file path=ppt/slides/slide25.xml><?xml version="1.0" encoding="utf-8"?>
+<file path=ppt/slides/slide26.xml><?xml version="1.0" encoding="utf-8"?>
 <p:sld xmlns:a="http://schemas.openxmlformats.org/drawingml/2006/main" xmlns:r="http://schemas.openxmlformats.org/officeDocument/2006/relationships" xmlns:p="http://schemas.openxmlformats.org/presentationml/2006/main">
   <p:cSld name="Slide 17">
     <p:spTree>
@@ -13330,7 +13785,7 @@
 </p:sld>
 </file>
 
-<file path=ppt/slides/slide26.xml><?xml version="1.0" encoding="utf-8"?>
+<file path=ppt/slides/slide27.xml><?xml version="1.0" encoding="utf-8"?>
 <p:sld xmlns:a="http://schemas.openxmlformats.org/drawingml/2006/main" xmlns:r="http://schemas.openxmlformats.org/officeDocument/2006/relationships" xmlns:p="http://schemas.openxmlformats.org/presentationml/2006/main">
   <p:cSld name="Slide 18">
     <p:spTree>
@@ -13736,7 +14191,7 @@
 </p:sld>
 </file>
 
-<file path=ppt/slides/slide27.xml><?xml version="1.0" encoding="utf-8"?>
+<file path=ppt/slides/slide28.xml><?xml version="1.0" encoding="utf-8"?>
 <p:sld xmlns:a="http://schemas.openxmlformats.org/drawingml/2006/main" xmlns:r="http://schemas.openxmlformats.org/officeDocument/2006/relationships" xmlns:p="http://schemas.openxmlformats.org/presentationml/2006/main">
   <p:cSld name="Slide 19">
     <p:spTree>
@@ -14121,7 +14576,7 @@
 </p:sld>
 </file>
 
-<file path=ppt/slides/slide28.xml><?xml version="1.0" encoding="utf-8"?>
+<file path=ppt/slides/slide29.xml><?xml version="1.0" encoding="utf-8"?>
 <p:sld xmlns:a="http://schemas.openxmlformats.org/drawingml/2006/main" xmlns:r="http://schemas.openxmlformats.org/officeDocument/2006/relationships" xmlns:p="http://schemas.openxmlformats.org/presentationml/2006/main">
   <p:cSld name="Slide 20">
     <p:spTree>
@@ -14393,412 +14848,6 @@
               <a:t>Who pays us, how much, and how slowly</a:t>
             </a:r>
             <a:endParaRPr lang="en-US" sz="1200"/>
-          </a:p>
-        </p:txBody>
-      </p:sp>
-    </p:spTree>
-  </p:cSld>
-  <p:clrMapOvr>
-    <a:masterClrMapping/>
-  </p:clrMapOvr>
-</p:sld>
-</file>
-
-<file path=ppt/slides/slide29.xml><?xml version="1.0" encoding="utf-8"?>
-<p:sld xmlns:a="http://schemas.openxmlformats.org/drawingml/2006/main" xmlns:r="http://schemas.openxmlformats.org/officeDocument/2006/relationships" xmlns:p="http://schemas.openxmlformats.org/presentationml/2006/main">
-  <p:cSld name="Slide 21">
-    <p:spTree>
-      <p:nvGrpSpPr>
-        <p:cNvPr id="1" name=""/>
-        <p:cNvGrpSpPr/>
-        <p:nvPr/>
-      </p:nvGrpSpPr>
-      <p:grpSpPr>
-        <a:xfrm>
-          <a:off x="0" y="0"/>
-          <a:ext cx="0" cy="0"/>
-          <a:chOff x="0" y="0"/>
-          <a:chExt cx="0" cy="0"/>
-        </a:xfrm>
-      </p:grpSpPr>
-      <p:pic>
-        <p:nvPicPr>
-          <p:cNvPr id="27" name="snip top10" descr="top10.png"/>
-          <p:cNvPicPr>
-            <a:picLocks noChangeAspect="1"/>
-          </p:cNvPicPr>
-          <p:nvPr/>
-        </p:nvPicPr>
-        <p:blipFill>
-          <a:blip r:embed="rId5"/>
-          <a:stretch>
-            <a:fillRect/>
-          </a:stretch>
-        </p:blipFill>
-        <p:spPr>
-          <a:xfrm>
-            <a:off x="2639119" y="1005840"/>
-            <a:ext cx="3865761" cy="1964997"/>
-          </a:xfrm>
-          <a:prstGeom prst="rect">
-            <a:avLst/>
-          </a:prstGeom>
-        </p:spPr>
-      </p:pic>
-      <p:sp>
-        <p:nvSpPr>
-          <p:cNvPr id="2" name="Text 0"/>
-          <p:cNvSpPr txBox="1"/>
-          <p:nvPr/>
-        </p:nvSpPr>
-        <p:spPr>
-          <a:xfrm>
-            <a:off x="502920" y="365760"/>
-            <a:ext cx="6400800" cy="274320"/>
-          </a:xfrm>
-          <a:prstGeom prst="rect">
-            <a:avLst/>
-          </a:prstGeom>
-          <a:noFill/>
-          <a:ln/>
-        </p:spPr>
-        <p:txBody>
-          <a:bodyPr wrap="square" lIns="0" tIns="0" rIns="0" bIns="0" rtlCol="0" anchor="ctr"/>
-          <a:lstStyle/>
-          <a:p>
-            <a:pPr marL="0" indent="0">
-              <a:buNone/>
-            </a:pPr>
-            <a:r>
-              <a:rPr lang="en-US" sz="950" b="1" kern="0" spc="220">
-                <a:solidFill>
-                  <a:srgbClr val="122B82"/>
-                </a:solidFill>
-              </a:rPr>
-              <a:t>CUSTOMERS AND CASH</a:t>
-            </a:r>
-            <a:endParaRPr lang="en-US" sz="950"/>
-          </a:p>
-        </p:txBody>
-      </p:sp>
-      <p:sp>
-        <p:nvSpPr>
-          <p:cNvPr id="3" name="Text 1"/>
-          <p:cNvSpPr txBox="1"/>
-          <p:nvPr/>
-        </p:nvSpPr>
-        <p:spPr>
-          <a:xfrm>
-            <a:off x="502920" y="640080"/>
-            <a:ext cx="7315200" cy="365760"/>
-          </a:xfrm>
-          <a:prstGeom prst="rect">
-            <a:avLst/>
-          </a:prstGeom>
-          <a:noFill/>
-          <a:ln/>
-        </p:spPr>
-        <p:txBody>
-          <a:bodyPr wrap="square" lIns="0" tIns="0" rIns="0" bIns="0" rtlCol="0" anchor="ctr"/>
-          <a:lstStyle/>
-          <a:p>
-            <a:pPr marL="0" indent="0" algn="ctr">
-              <a:buNone/>
-            </a:pPr>
-            <a:r>
-              <a:rPr lang="en-US" sz="2200" b="1">
-                <a:solidFill>
-                  <a:srgbClr val="242C39"/>
-                </a:solidFill>
-              </a:rPr>
-              <a:t>Top ten customers, year to date</a:t>
-            </a:r>
-            <a:endParaRPr lang="en-US" sz="2700"/>
-          </a:p>
-        </p:txBody>
-      </p:sp>
-      <p:sp>
-        <p:nvSpPr>
-          <p:cNvPr id="6" name="commentary panel"/>
-          <p:cNvSpPr/>
-          <p:nvPr/>
-        </p:nvSpPr>
-        <p:spPr>
-          <a:xfrm>
-            <a:off x="502920" y="3062278"/>
-            <a:ext cx="8138160" cy="1564585"/>
-          </a:xfrm>
-          <a:prstGeom prst="rect">
-            <a:avLst/>
-          </a:prstGeom>
-          <a:solidFill>
-            <a:srgbClr val="E8F9F8"/>
-          </a:solidFill>
-          <a:ln/>
-        </p:spPr>
-        <p:txBody>
-          <a:bodyPr/>
-          <a:lstStyle/>
-          <a:p>
-            <a:endParaRPr lang="en-AU"/>
-          </a:p>
-        </p:txBody>
-      </p:sp>
-      <p:sp>
-        <p:nvSpPr>
-          <p:cNvPr id="7" name="Text 4"/>
-          <p:cNvSpPr txBox="1"/>
-          <p:nvPr/>
-        </p:nvSpPr>
-        <p:spPr>
-          <a:xfrm>
-            <a:off x="685800" y="3135430"/>
-            <a:ext cx="2743200" cy="228600"/>
-          </a:xfrm>
-          <a:prstGeom prst="rect">
-            <a:avLst/>
-          </a:prstGeom>
-          <a:noFill/>
-          <a:ln/>
-        </p:spPr>
-        <p:txBody>
-          <a:bodyPr wrap="square" lIns="0" tIns="0" rIns="0" bIns="0" rtlCol="0" anchor="ctr"/>
-          <a:lstStyle/>
-          <a:p>
-            <a:pPr marL="0" indent="0">
-              <a:buNone/>
-            </a:pPr>
-            <a:r>
-              <a:rPr lang="en-US" sz="900" b="1" kern="0" spc="180">
-                <a:solidFill>
-                  <a:srgbClr val="005358"/>
-                </a:solidFill>
-              </a:rPr>
-              <a:t>COMMENTARY</a:t>
-            </a:r>
-            <a:endParaRPr lang="en-US" sz="900"/>
-          </a:p>
-        </p:txBody>
-      </p:sp>
-      <p:sp>
-        <p:nvSpPr>
-          <p:cNvPr id="8" name="Text 5"/>
-          <p:cNvSpPr txBox="1"/>
-          <p:nvPr/>
-        </p:nvSpPr>
-        <p:spPr>
-          <a:xfrm>
-            <a:off x="685800" y="3309166"/>
-            <a:ext cx="3703320" cy="1290265"/>
-          </a:xfrm>
-          <a:prstGeom prst="rect">
-            <a:avLst/>
-          </a:prstGeom>
-          <a:noFill/>
-          <a:ln/>
-        </p:spPr>
-        <p:txBody>
-          <a:bodyPr wrap="square" lIns="0" tIns="0" rIns="0" bIns="0" rtlCol="0" anchor="t">
-            <a:normAutofit fontScale="77500" lnSpcReduction="20000"/>
-          </a:bodyPr>
-          <a:lstStyle/>
-          <a:p>
-            <a:pPr marL="342900" indent="-342900">
-              <a:lnSpc>
-                <a:spcPts val="1150"/>
-              </a:lnSpc>
-              <a:spcAft>
-                <a:spcPts val="400"/>
-              </a:spcAft>
-              <a:buSzPct val="100000"/>
-              <a:buChar char="•"/>
-            </a:pPr>
-            <a:r>
-              <a:rPr lang="en-US" sz="1000">
-                <a:solidFill>
-                  <a:srgbClr val="3A4453"/>
-                </a:solidFill>
-              </a:rPr>
-              <a:t>The top three customers account for approximately 49% of year-to-date revenue.</a:t>
-            </a:r>
-            <a:endParaRPr lang="en-US" sz="900"/>
-          </a:p>
-          <a:p>
-            <a:pPr marL="342900" indent="-342900">
-              <a:lnSpc>
-                <a:spcPts val="1150"/>
-              </a:lnSpc>
-              <a:spcAft>
-                <a:spcPts val="400"/>
-              </a:spcAft>
-              <a:buSzPct val="100000"/>
-              <a:buChar char="•"/>
-            </a:pPr>
-            <a:r>
-              <a:rPr lang="en-US" sz="1000">
-                <a:solidFill>
-                  <a:srgbClr val="3A4453"/>
-                </a:solidFill>
-              </a:rPr>
-              <a:t>The top ten contribute 76%, leaving 24% from all other customers combined.</a:t>
-            </a:r>
-            <a:endParaRPr lang="en-US" sz="900"/>
-          </a:p>
-          <a:p>
-            <a:pPr marL="342900" indent="-342900">
-              <a:lnSpc>
-                <a:spcPts val="1150"/>
-              </a:lnSpc>
-              <a:spcAft>
-                <a:spcPts val="400"/>
-              </a:spcAft>
-              <a:buSzPct val="100000"/>
-              <a:buChar char="•"/>
-            </a:pPr>
-            <a:r>
-              <a:rPr lang="en-US" sz="1000">
-                <a:solidFill>
-                  <a:srgbClr val="3A4453"/>
-                </a:solidFill>
-              </a:rPr>
-              <a:t>Deloitte Services represents approximately 25% of revenue at $402k, creating significant customer concentration risk.</a:t>
-            </a:r>
-            <a:endParaRPr lang="en-US" sz="900"/>
-          </a:p>
-        </p:txBody>
-      </p:sp>
-      <p:sp>
-        <p:nvSpPr>
-          <p:cNvPr id="25" name="Slide Number Placeholder 0"/>
-          <p:cNvSpPr>
-            <a:spLocks noGrp="1"/>
-          </p:cNvSpPr>
-          <p:nvPr>
-            <p:ph type="sldNum" sz="quarter" idx="4294967295"/>
-          </p:nvPr>
-        </p:nvSpPr>
-        <p:spPr>
-          <a:xfrm>
-            <a:off x="8092440" y="4736592"/>
-            <a:ext cx="548640" cy="228600"/>
-          </a:xfrm>
-          <a:prstGeom prst="rect">
-            <a:avLst/>
-          </a:prstGeom>
-          <a:extLst>
-            <a:ext uri="{C572A759-6A51-4108-AA02-DFA0A04FC94B}">
-              <ma14:wrappingTextBoxFlag xmlns="" xmlns:ma14="http://schemas.microsoft.com/office/mac/drawingml/2011/main" val="0"/>
-            </a:ext>
-          </a:extLst>
-        </p:spPr>
-        <p:txBody>
-          <a:bodyPr/>
-          <a:lstStyle>
-            <a:lvl1pPr>
-              <a:defRPr sz="800">
-                <a:solidFill>
-                  <a:srgbClr val="6B7585"/>
-                </a:solidFill>
-              </a:defRPr>
-            </a:lvl1pPr>
-          </a:lstStyle>
-          <a:p>
-            <a:pPr algn="r"/>
-            <a:fld id="{F7021451-1387-4CA6-816F-3879F97B5CBC}" type="slidenum">
-              <a:rPr lang="en-US" b="0"/>
-              <a:t>26</a:t>
-            </a:fld>
-            <a:endParaRPr lang="en-US"/>
-          </a:p>
-        </p:txBody>
-      </p:sp>
-      <p:pic>
-        <p:nvPicPr>
-          <p:cNvPr id="26" name="cts logo" descr="cts-logo.png"/>
-          <p:cNvPicPr>
-            <a:picLocks noChangeAspect="1"/>
-          </p:cNvPicPr>
-          <p:nvPr/>
-        </p:nvPicPr>
-        <p:blipFill>
-          <a:blip r:embed="rId4"/>
-          <a:stretch>
-            <a:fillRect/>
-          </a:stretch>
-        </p:blipFill>
-        <p:spPr>
-          <a:xfrm>
-            <a:off x="7680959" y="182880"/>
-            <a:ext cx="960120" cy="539696"/>
-          </a:xfrm>
-          <a:prstGeom prst="rect">
-            <a:avLst/>
-          </a:prstGeom>
-        </p:spPr>
-      </p:pic>
-      <p:sp>
-        <p:nvSpPr>
-          <p:cNvPr id="8" name="Text 5b"/>
-          <p:cNvSpPr txBox="1"/>
-          <p:nvPr/>
-        </p:nvSpPr>
-        <p:spPr>
-          <a:xfrm>
-            <a:off x="4663440" y="3309166"/>
-            <a:ext cx="3703320" cy="1290265"/>
-          </a:xfrm>
-          <a:prstGeom prst="rect">
-            <a:avLst/>
-          </a:prstGeom>
-          <a:noFill/>
-          <a:ln/>
-        </p:spPr>
-        <p:txBody>
-          <a:bodyPr wrap="square" lIns="0" tIns="0" rIns="0" bIns="0" rtlCol="0" anchor="t">
-            <a:normAutofit fontScale="77500" lnSpcReduction="20000"/>
-          </a:bodyPr>
-          <a:lstStyle/>
-          <a:p>
-            <a:pPr marL="342900" indent="-342900">
-              <a:lnSpc>
-                <a:spcPts val="1150"/>
-              </a:lnSpc>
-              <a:spcAft>
-                <a:spcPts val="400"/>
-              </a:spcAft>
-              <a:buSzPct val="100000"/>
-              <a:buChar char="•"/>
-            </a:pPr>
-            <a:r>
-              <a:rPr lang="en-US" sz="1000">
-                <a:solidFill>
-                  <a:srgbClr val="3A4453"/>
-                </a:solidFill>
-              </a:rPr>
-              <a:t>Aware Super contributed $285k during the quarter, mainly from a one-off September project.</a:t>
-            </a:r>
-            <a:endParaRPr lang="en-US" sz="900"/>
-          </a:p>
-          <a:p>
-            <a:pPr marL="342900" indent="-342900">
-              <a:lnSpc>
-                <a:spcPts val="1150"/>
-              </a:lnSpc>
-              <a:spcAft>
-                <a:spcPts val="400"/>
-              </a:spcAft>
-              <a:buSzPct val="100000"/>
-              <a:buChar char="•"/>
-            </a:pPr>
-            <a:r>
-              <a:rPr lang="en-US" sz="1000">
-                <a:solidFill>
-                  <a:srgbClr val="3A4453"/>
-                </a:solidFill>
-              </a:rPr>
-              <a:t>Revenue drops considerably beyond the largest customers, highlighting the importance of growing the wider customer base.</a:t>
-            </a:r>
-            <a:endParaRPr lang="en-US" sz="900"/>
           </a:p>
         </p:txBody>
       </p:sp>
@@ -17064,6 +17113,412 @@
 
 <file path=ppt/slides/slide30.xml><?xml version="1.0" encoding="utf-8"?>
 <p:sld xmlns:a="http://schemas.openxmlformats.org/drawingml/2006/main" xmlns:r="http://schemas.openxmlformats.org/officeDocument/2006/relationships" xmlns:p="http://schemas.openxmlformats.org/presentationml/2006/main">
+  <p:cSld name="Slide 21">
+    <p:spTree>
+      <p:nvGrpSpPr>
+        <p:cNvPr id="1" name=""/>
+        <p:cNvGrpSpPr/>
+        <p:nvPr/>
+      </p:nvGrpSpPr>
+      <p:grpSpPr>
+        <a:xfrm>
+          <a:off x="0" y="0"/>
+          <a:ext cx="0" cy="0"/>
+          <a:chOff x="0" y="0"/>
+          <a:chExt cx="0" cy="0"/>
+        </a:xfrm>
+      </p:grpSpPr>
+      <p:pic>
+        <p:nvPicPr>
+          <p:cNvPr id="27" name="snip top10" descr="top10.png"/>
+          <p:cNvPicPr>
+            <a:picLocks noChangeAspect="1"/>
+          </p:cNvPicPr>
+          <p:nvPr/>
+        </p:nvPicPr>
+        <p:blipFill>
+          <a:blip r:embed="rId5"/>
+          <a:stretch>
+            <a:fillRect/>
+          </a:stretch>
+        </p:blipFill>
+        <p:spPr>
+          <a:xfrm>
+            <a:off x="2639119" y="1005840"/>
+            <a:ext cx="3865761" cy="1964997"/>
+          </a:xfrm>
+          <a:prstGeom prst="rect">
+            <a:avLst/>
+          </a:prstGeom>
+        </p:spPr>
+      </p:pic>
+      <p:sp>
+        <p:nvSpPr>
+          <p:cNvPr id="2" name="Text 0"/>
+          <p:cNvSpPr txBox="1"/>
+          <p:nvPr/>
+        </p:nvSpPr>
+        <p:spPr>
+          <a:xfrm>
+            <a:off x="502920" y="365760"/>
+            <a:ext cx="6400800" cy="274320"/>
+          </a:xfrm>
+          <a:prstGeom prst="rect">
+            <a:avLst/>
+          </a:prstGeom>
+          <a:noFill/>
+          <a:ln/>
+        </p:spPr>
+        <p:txBody>
+          <a:bodyPr wrap="square" lIns="0" tIns="0" rIns="0" bIns="0" rtlCol="0" anchor="ctr"/>
+          <a:lstStyle/>
+          <a:p>
+            <a:pPr marL="0" indent="0">
+              <a:buNone/>
+            </a:pPr>
+            <a:r>
+              <a:rPr lang="en-US" sz="950" b="1" kern="0" spc="220">
+                <a:solidFill>
+                  <a:srgbClr val="122B82"/>
+                </a:solidFill>
+              </a:rPr>
+              <a:t>CUSTOMERS AND CASH</a:t>
+            </a:r>
+            <a:endParaRPr lang="en-US" sz="950"/>
+          </a:p>
+        </p:txBody>
+      </p:sp>
+      <p:sp>
+        <p:nvSpPr>
+          <p:cNvPr id="3" name="Text 1"/>
+          <p:cNvSpPr txBox="1"/>
+          <p:nvPr/>
+        </p:nvSpPr>
+        <p:spPr>
+          <a:xfrm>
+            <a:off x="502920" y="640080"/>
+            <a:ext cx="7315200" cy="365760"/>
+          </a:xfrm>
+          <a:prstGeom prst="rect">
+            <a:avLst/>
+          </a:prstGeom>
+          <a:noFill/>
+          <a:ln/>
+        </p:spPr>
+        <p:txBody>
+          <a:bodyPr wrap="square" lIns="0" tIns="0" rIns="0" bIns="0" rtlCol="0" anchor="ctr"/>
+          <a:lstStyle/>
+          <a:p>
+            <a:pPr marL="0" indent="0" algn="ctr">
+              <a:buNone/>
+            </a:pPr>
+            <a:r>
+              <a:rPr lang="en-US" sz="2200" b="1">
+                <a:solidFill>
+                  <a:srgbClr val="242C39"/>
+                </a:solidFill>
+              </a:rPr>
+              <a:t>Top ten customers, year to date</a:t>
+            </a:r>
+            <a:endParaRPr lang="en-US" sz="2700"/>
+          </a:p>
+        </p:txBody>
+      </p:sp>
+      <p:sp>
+        <p:nvSpPr>
+          <p:cNvPr id="6" name="commentary panel"/>
+          <p:cNvSpPr/>
+          <p:nvPr/>
+        </p:nvSpPr>
+        <p:spPr>
+          <a:xfrm>
+            <a:off x="502920" y="3062278"/>
+            <a:ext cx="8138160" cy="1564585"/>
+          </a:xfrm>
+          <a:prstGeom prst="rect">
+            <a:avLst/>
+          </a:prstGeom>
+          <a:solidFill>
+            <a:srgbClr val="E8F9F8"/>
+          </a:solidFill>
+          <a:ln/>
+        </p:spPr>
+        <p:txBody>
+          <a:bodyPr/>
+          <a:lstStyle/>
+          <a:p>
+            <a:endParaRPr lang="en-AU"/>
+          </a:p>
+        </p:txBody>
+      </p:sp>
+      <p:sp>
+        <p:nvSpPr>
+          <p:cNvPr id="7" name="Text 4"/>
+          <p:cNvSpPr txBox="1"/>
+          <p:nvPr/>
+        </p:nvSpPr>
+        <p:spPr>
+          <a:xfrm>
+            <a:off x="685800" y="3135430"/>
+            <a:ext cx="2743200" cy="228600"/>
+          </a:xfrm>
+          <a:prstGeom prst="rect">
+            <a:avLst/>
+          </a:prstGeom>
+          <a:noFill/>
+          <a:ln/>
+        </p:spPr>
+        <p:txBody>
+          <a:bodyPr wrap="square" lIns="0" tIns="0" rIns="0" bIns="0" rtlCol="0" anchor="ctr"/>
+          <a:lstStyle/>
+          <a:p>
+            <a:pPr marL="0" indent="0">
+              <a:buNone/>
+            </a:pPr>
+            <a:r>
+              <a:rPr lang="en-US" sz="900" b="1" kern="0" spc="180">
+                <a:solidFill>
+                  <a:srgbClr val="005358"/>
+                </a:solidFill>
+              </a:rPr>
+              <a:t>COMMENTARY</a:t>
+            </a:r>
+            <a:endParaRPr lang="en-US" sz="900"/>
+          </a:p>
+        </p:txBody>
+      </p:sp>
+      <p:sp>
+        <p:nvSpPr>
+          <p:cNvPr id="8" name="Text 5"/>
+          <p:cNvSpPr txBox="1"/>
+          <p:nvPr/>
+        </p:nvSpPr>
+        <p:spPr>
+          <a:xfrm>
+            <a:off x="685800" y="3309166"/>
+            <a:ext cx="3703320" cy="1290265"/>
+          </a:xfrm>
+          <a:prstGeom prst="rect">
+            <a:avLst/>
+          </a:prstGeom>
+          <a:noFill/>
+          <a:ln/>
+        </p:spPr>
+        <p:txBody>
+          <a:bodyPr wrap="square" lIns="0" tIns="0" rIns="0" bIns="0" rtlCol="0" anchor="t">
+            <a:normAutofit fontScale="77500" lnSpcReduction="20000"/>
+          </a:bodyPr>
+          <a:lstStyle/>
+          <a:p>
+            <a:pPr marL="342900" indent="-342900">
+              <a:lnSpc>
+                <a:spcPts val="1150"/>
+              </a:lnSpc>
+              <a:spcAft>
+                <a:spcPts val="400"/>
+              </a:spcAft>
+              <a:buSzPct val="100000"/>
+              <a:buChar char="•"/>
+            </a:pPr>
+            <a:r>
+              <a:rPr lang="en-US" sz="1000">
+                <a:solidFill>
+                  <a:srgbClr val="3A4453"/>
+                </a:solidFill>
+              </a:rPr>
+              <a:t>The top three customers account for approximately 49% of year-to-date revenue.</a:t>
+            </a:r>
+            <a:endParaRPr lang="en-US" sz="900"/>
+          </a:p>
+          <a:p>
+            <a:pPr marL="342900" indent="-342900">
+              <a:lnSpc>
+                <a:spcPts val="1150"/>
+              </a:lnSpc>
+              <a:spcAft>
+                <a:spcPts val="400"/>
+              </a:spcAft>
+              <a:buSzPct val="100000"/>
+              <a:buChar char="•"/>
+            </a:pPr>
+            <a:r>
+              <a:rPr lang="en-US" sz="1000">
+                <a:solidFill>
+                  <a:srgbClr val="3A4453"/>
+                </a:solidFill>
+              </a:rPr>
+              <a:t>The top ten contribute 76%, leaving 24% from all other customers combined.</a:t>
+            </a:r>
+            <a:endParaRPr lang="en-US" sz="900"/>
+          </a:p>
+          <a:p>
+            <a:pPr marL="342900" indent="-342900">
+              <a:lnSpc>
+                <a:spcPts val="1150"/>
+              </a:lnSpc>
+              <a:spcAft>
+                <a:spcPts val="400"/>
+              </a:spcAft>
+              <a:buSzPct val="100000"/>
+              <a:buChar char="•"/>
+            </a:pPr>
+            <a:r>
+              <a:rPr lang="en-US" sz="1000">
+                <a:solidFill>
+                  <a:srgbClr val="3A4453"/>
+                </a:solidFill>
+              </a:rPr>
+              <a:t>Deloitte Services represents approximately 25% of revenue at $402k, creating significant customer concentration risk.</a:t>
+            </a:r>
+            <a:endParaRPr lang="en-US" sz="900"/>
+          </a:p>
+        </p:txBody>
+      </p:sp>
+      <p:sp>
+        <p:nvSpPr>
+          <p:cNvPr id="25" name="Slide Number Placeholder 0"/>
+          <p:cNvSpPr>
+            <a:spLocks noGrp="1"/>
+          </p:cNvSpPr>
+          <p:nvPr>
+            <p:ph type="sldNum" sz="quarter" idx="4294967295"/>
+          </p:nvPr>
+        </p:nvSpPr>
+        <p:spPr>
+          <a:xfrm>
+            <a:off x="8092440" y="4736592"/>
+            <a:ext cx="548640" cy="228600"/>
+          </a:xfrm>
+          <a:prstGeom prst="rect">
+            <a:avLst/>
+          </a:prstGeom>
+          <a:extLst>
+            <a:ext uri="{C572A759-6A51-4108-AA02-DFA0A04FC94B}">
+              <ma14:wrappingTextBoxFlag xmlns="" xmlns:ma14="http://schemas.microsoft.com/office/mac/drawingml/2011/main" val="0"/>
+            </a:ext>
+          </a:extLst>
+        </p:spPr>
+        <p:txBody>
+          <a:bodyPr/>
+          <a:lstStyle>
+            <a:lvl1pPr>
+              <a:defRPr sz="800">
+                <a:solidFill>
+                  <a:srgbClr val="6B7585"/>
+                </a:solidFill>
+              </a:defRPr>
+            </a:lvl1pPr>
+          </a:lstStyle>
+          <a:p>
+            <a:pPr algn="r"/>
+            <a:fld id="{F7021451-1387-4CA6-816F-3879F97B5CBC}" type="slidenum">
+              <a:rPr lang="en-US" b="0"/>
+              <a:t>26</a:t>
+            </a:fld>
+            <a:endParaRPr lang="en-US"/>
+          </a:p>
+        </p:txBody>
+      </p:sp>
+      <p:pic>
+        <p:nvPicPr>
+          <p:cNvPr id="26" name="cts logo" descr="cts-logo.png"/>
+          <p:cNvPicPr>
+            <a:picLocks noChangeAspect="1"/>
+          </p:cNvPicPr>
+          <p:nvPr/>
+        </p:nvPicPr>
+        <p:blipFill>
+          <a:blip r:embed="rId4"/>
+          <a:stretch>
+            <a:fillRect/>
+          </a:stretch>
+        </p:blipFill>
+        <p:spPr>
+          <a:xfrm>
+            <a:off x="7680959" y="182880"/>
+            <a:ext cx="960120" cy="539696"/>
+          </a:xfrm>
+          <a:prstGeom prst="rect">
+            <a:avLst/>
+          </a:prstGeom>
+        </p:spPr>
+      </p:pic>
+      <p:sp>
+        <p:nvSpPr>
+          <p:cNvPr id="8" name="Text 5b"/>
+          <p:cNvSpPr txBox="1"/>
+          <p:nvPr/>
+        </p:nvSpPr>
+        <p:spPr>
+          <a:xfrm>
+            <a:off x="4663440" y="3309166"/>
+            <a:ext cx="3703320" cy="1290265"/>
+          </a:xfrm>
+          <a:prstGeom prst="rect">
+            <a:avLst/>
+          </a:prstGeom>
+          <a:noFill/>
+          <a:ln/>
+        </p:spPr>
+        <p:txBody>
+          <a:bodyPr wrap="square" lIns="0" tIns="0" rIns="0" bIns="0" rtlCol="0" anchor="t">
+            <a:normAutofit fontScale="77500" lnSpcReduction="20000"/>
+          </a:bodyPr>
+          <a:lstStyle/>
+          <a:p>
+            <a:pPr marL="342900" indent="-342900">
+              <a:lnSpc>
+                <a:spcPts val="1150"/>
+              </a:lnSpc>
+              <a:spcAft>
+                <a:spcPts val="400"/>
+              </a:spcAft>
+              <a:buSzPct val="100000"/>
+              <a:buChar char="•"/>
+            </a:pPr>
+            <a:r>
+              <a:rPr lang="en-US" sz="1000">
+                <a:solidFill>
+                  <a:srgbClr val="3A4453"/>
+                </a:solidFill>
+              </a:rPr>
+              <a:t>Aware Super contributed $285k during the quarter, mainly from a one-off September project.</a:t>
+            </a:r>
+            <a:endParaRPr lang="en-US" sz="900"/>
+          </a:p>
+          <a:p>
+            <a:pPr marL="342900" indent="-342900">
+              <a:lnSpc>
+                <a:spcPts val="1150"/>
+              </a:lnSpc>
+              <a:spcAft>
+                <a:spcPts val="400"/>
+              </a:spcAft>
+              <a:buSzPct val="100000"/>
+              <a:buChar char="•"/>
+            </a:pPr>
+            <a:r>
+              <a:rPr lang="en-US" sz="1000">
+                <a:solidFill>
+                  <a:srgbClr val="3A4453"/>
+                </a:solidFill>
+              </a:rPr>
+              <a:t>Revenue drops considerably beyond the largest customers, highlighting the importance of growing the wider customer base.</a:t>
+            </a:r>
+            <a:endParaRPr lang="en-US" sz="900"/>
+          </a:p>
+        </p:txBody>
+      </p:sp>
+    </p:spTree>
+  </p:cSld>
+  <p:clrMapOvr>
+    <a:masterClrMapping/>
+  </p:clrMapOvr>
+</p:sld>
+</file>
+
+<file path=ppt/slides/slide31.xml><?xml version="1.0" encoding="utf-8"?>
+<p:sld xmlns:a="http://schemas.openxmlformats.org/drawingml/2006/main" xmlns:r="http://schemas.openxmlformats.org/officeDocument/2006/relationships" xmlns:p="http://schemas.openxmlformats.org/presentationml/2006/main">
   <p:cSld name="Slide 22">
     <p:spTree>
       <p:nvGrpSpPr>
@@ -17468,7 +17923,7 @@
 </p:sld>
 </file>
 
-<file path=ppt/slides/slide31.xml><?xml version="1.0" encoding="utf-8"?>
+<file path=ppt/slides/slide32.xml><?xml version="1.0" encoding="utf-8"?>
 <p:sld xmlns:a="http://schemas.openxmlformats.org/drawingml/2006/main" xmlns:r="http://schemas.openxmlformats.org/officeDocument/2006/relationships" xmlns:p="http://schemas.openxmlformats.org/presentationml/2006/main">
   <p:cSld name="Slide 23">
     <p:spTree>
@@ -17874,7 +18329,7 @@
 </p:sld>
 </file>
 
-<file path=ppt/slides/slide32.xml><?xml version="1.0" encoding="utf-8"?>
+<file path=ppt/slides/slide33.xml><?xml version="1.0" encoding="utf-8"?>
 <p:sld xmlns:a="http://schemas.openxmlformats.org/drawingml/2006/main" xmlns:r="http://schemas.openxmlformats.org/officeDocument/2006/relationships" xmlns:p="http://schemas.openxmlformats.org/presentationml/2006/main">
   <p:cSld name="Slide 24">
     <p:spTree>
@@ -18157,7 +18612,7 @@
 </p:sld>
 </file>
 
-<file path=ppt/slides/slide33.xml><?xml version="1.0" encoding="utf-8"?>
+<file path=ppt/slides/slide34.xml><?xml version="1.0" encoding="utf-8"?>
 <p:sld xmlns:a="http://schemas.openxmlformats.org/drawingml/2006/main" xmlns:r="http://schemas.openxmlformats.org/officeDocument/2006/relationships" xmlns:p="http://schemas.openxmlformats.org/presentationml/2006/main">
   <p:cSld name="Slide 25">
     <p:spTree>
@@ -18542,7 +18997,7 @@
 </p:sld>
 </file>
 
-<file path=ppt/slides/slide34.xml><?xml version="1.0" encoding="utf-8"?>
+<file path=ppt/slides/slide35.xml><?xml version="1.0" encoding="utf-8"?>
 <p:sld xmlns:a="http://schemas.openxmlformats.org/drawingml/2006/main" xmlns:r="http://schemas.openxmlformats.org/officeDocument/2006/relationships" xmlns:p="http://schemas.openxmlformats.org/presentationml/2006/main">
   <p:cSld name="Slide 26">
     <p:spTree>
@@ -18948,7 +19403,7 @@
 </p:sld>
 </file>
 
-<file path=ppt/slides/slide35.xml><?xml version="1.0" encoding="utf-8"?>
+<file path=ppt/slides/slide36.xml><?xml version="1.0" encoding="utf-8"?>
 <p:sld xmlns:a="http://schemas.openxmlformats.org/drawingml/2006/main" xmlns:r="http://schemas.openxmlformats.org/officeDocument/2006/relationships" xmlns:p="http://schemas.openxmlformats.org/presentationml/2006/main">
   <p:cSld name="Slide 27">
     <p:spTree>
@@ -19354,7 +19809,7 @@
 </p:sld>
 </file>
 
-<file path=ppt/slides/slide36.xml><?xml version="1.0" encoding="utf-8"?>
+<file path=ppt/slides/slide37.xml><?xml version="1.0" encoding="utf-8"?>
 <p:sld xmlns:a="http://schemas.openxmlformats.org/drawingml/2006/main" xmlns:r="http://schemas.openxmlformats.org/officeDocument/2006/relationships" xmlns:p="http://schemas.openxmlformats.org/presentationml/2006/main">
   <p:cSld name="Slide 28">
     <p:spTree>
@@ -19637,7 +20092,7 @@
 </p:sld>
 </file>
 
-<file path=ppt/slides/slide37.xml><?xml version="1.0" encoding="utf-8"?>
+<file path=ppt/slides/slide38.xml><?xml version="1.0" encoding="utf-8"?>
 <p:sld xmlns:a="http://schemas.openxmlformats.org/drawingml/2006/main" xmlns:r="http://schemas.openxmlformats.org/officeDocument/2006/relationships" xmlns:p="http://schemas.openxmlformats.org/presentationml/2006/main">
   <p:cSld name="Slide 29">
     <p:spTree>
@@ -20043,7 +20498,7 @@
 </p:sld>
 </file>
 
-<file path=ppt/slides/slide38.xml><?xml version="1.0" encoding="utf-8"?>
+<file path=ppt/slides/slide39.xml><?xml version="1.0" encoding="utf-8"?>
 <p:sld xmlns:a="http://schemas.openxmlformats.org/drawingml/2006/main" xmlns:r="http://schemas.openxmlformats.org/officeDocument/2006/relationships" xmlns:p="http://schemas.openxmlformats.org/presentationml/2006/main">
   <p:cSld name="Slide 30">
     <p:spTree>
@@ -22189,7 +22644,290 @@
 </p:sld>
 </file>
 
-<file path=ppt/slides/slide39.xml><?xml version="1.0" encoding="utf-8"?>
+<file path=ppt/slides/slide4.xml><?xml version="1.0" encoding="utf-8"?>
+<p:sld xmlns:a="http://schemas.openxmlformats.org/drawingml/2006/main" xmlns:r="http://schemas.openxmlformats.org/officeDocument/2006/relationships" xmlns:p="http://schemas.openxmlformats.org/presentationml/2006/main">
+  <p:cSld name="Slide 4">
+    <p:spTree>
+      <p:nvGrpSpPr>
+        <p:cNvPr id="1" name=""/>
+        <p:cNvGrpSpPr/>
+        <p:nvPr/>
+      </p:nvGrpSpPr>
+      <p:grpSpPr>
+        <a:xfrm>
+          <a:off x="0" y="0"/>
+          <a:ext cx="0" cy="0"/>
+          <a:chOff x="0" y="0"/>
+          <a:chExt cx="0" cy="0"/>
+        </a:xfrm>
+      </p:grpSpPr>
+      <p:sp>
+        <p:nvSpPr>
+          <p:cNvPr id="2" name="dot 2"/>
+          <p:cNvSpPr/>
+          <p:nvPr/>
+        </p:nvSpPr>
+        <p:spPr>
+          <a:xfrm>
+            <a:off x="6537960" y="1965960"/>
+            <a:ext cx="2240280" cy="2240280"/>
+          </a:xfrm>
+          <a:prstGeom prst="ellipse">
+            <a:avLst/>
+          </a:prstGeom>
+          <a:solidFill>
+            <a:srgbClr val="F33844">
+              <a:alpha val="55000"/>
+            </a:srgbClr>
+          </a:solidFill>
+          <a:ln/>
+        </p:spPr>
+        <p:txBody>
+          <a:bodyPr/>
+          <a:lstStyle/>
+          <a:p>
+            <a:endParaRPr lang="en-AU"/>
+          </a:p>
+        </p:txBody>
+      </p:sp>
+      <p:sp>
+        <p:nvSpPr>
+          <p:cNvPr id="8" name="dot 1"/>
+          <p:cNvSpPr/>
+          <p:nvPr/>
+        </p:nvSpPr>
+        <p:spPr>
+          <a:xfrm>
+            <a:off x="7269480" y="1097280"/>
+            <a:ext cx="1783080" cy="1783080"/>
+          </a:xfrm>
+          <a:prstGeom prst="ellipse">
+            <a:avLst/>
+          </a:prstGeom>
+          <a:solidFill>
+            <a:srgbClr val="6D71FF">
+              <a:alpha val="55000"/>
+            </a:srgbClr>
+          </a:solidFill>
+          <a:ln/>
+        </p:spPr>
+        <p:txBody>
+          <a:bodyPr/>
+          <a:lstStyle/>
+          <a:p>
+            <a:endParaRPr lang="en-AU"/>
+          </a:p>
+        </p:txBody>
+      </p:sp>
+      <p:sp>
+        <p:nvSpPr>
+          <p:cNvPr id="9" name="dot 0"/>
+          <p:cNvSpPr/>
+          <p:nvPr/>
+        </p:nvSpPr>
+        <p:spPr>
+          <a:xfrm>
+            <a:off x="6309360" y="182880"/>
+            <a:ext cx="2148840" cy="2148840"/>
+          </a:xfrm>
+          <a:prstGeom prst="ellipse">
+            <a:avLst/>
+          </a:prstGeom>
+          <a:solidFill>
+            <a:srgbClr val="3FD0C9">
+              <a:alpha val="55000"/>
+            </a:srgbClr>
+          </a:solidFill>
+          <a:ln/>
+        </p:spPr>
+        <p:txBody>
+          <a:bodyPr/>
+          <a:lstStyle/>
+          <a:p>
+            <a:endParaRPr lang="en-AU"/>
+          </a:p>
+        </p:txBody>
+      </p:sp>
+      <p:sp>
+        <p:nvSpPr>
+          <p:cNvPr id="3" name="Shape 1"/>
+          <p:cNvSpPr/>
+          <p:nvPr/>
+        </p:nvSpPr>
+        <p:spPr>
+          <a:xfrm>
+            <a:off x="502920" y="1874520"/>
+            <a:ext cx="868680" cy="868680"/>
+          </a:xfrm>
+          <a:prstGeom prst="rect">
+            <a:avLst/>
+          </a:prstGeom>
+          <a:solidFill>
+            <a:srgbClr val="3FD0C9"/>
+          </a:solidFill>
+          <a:ln/>
+        </p:spPr>
+        <p:txBody>
+          <a:bodyPr/>
+          <a:lstStyle/>
+          <a:p>
+            <a:endParaRPr lang="en-AU"/>
+          </a:p>
+        </p:txBody>
+      </p:sp>
+      <p:sp>
+        <p:nvSpPr>
+          <p:cNvPr id="4" name="Text 2"/>
+          <p:cNvSpPr txBox="1"/>
+          <p:nvPr/>
+        </p:nvSpPr>
+        <p:spPr>
+          <a:xfrm>
+            <a:off x="502920" y="1874520"/>
+            <a:ext cx="868680" cy="868680"/>
+          </a:xfrm>
+          <a:prstGeom prst="rect">
+            <a:avLst/>
+          </a:prstGeom>
+          <a:noFill/>
+          <a:ln/>
+        </p:spPr>
+        <p:txBody>
+          <a:bodyPr wrap="square" lIns="0" tIns="0" rIns="0" bIns="0" rtlCol="0" anchor="ctr"/>
+          <a:lstStyle/>
+          <a:p>
+            <a:pPr marL="0" indent="0" algn="ctr">
+              <a:buNone/>
+            </a:pPr>
+            <a:r>
+              <a:rPr lang="en-US" sz="2200" b="1">
+                <a:solidFill>
+                  <a:srgbClr val="242C39"/>
+                </a:solidFill>
+              </a:rPr>
+              <a:t>01</a:t>
+            </a:r>
+            <a:endParaRPr lang="en-US" sz="2600"/>
+          </a:p>
+        </p:txBody>
+      </p:sp>
+      <p:sp>
+        <p:nvSpPr>
+          <p:cNvPr id="5" name="Text 3"/>
+          <p:cNvSpPr txBox="1"/>
+          <p:nvPr/>
+        </p:nvSpPr>
+        <p:spPr>
+          <a:xfrm>
+            <a:off x="502920" y="411480"/>
+            <a:ext cx="3657600" cy="274320"/>
+          </a:xfrm>
+          <a:prstGeom prst="rect">
+            <a:avLst/>
+          </a:prstGeom>
+          <a:noFill/>
+          <a:ln/>
+        </p:spPr>
+        <p:txBody>
+          <a:bodyPr wrap="square" lIns="0" tIns="0" rIns="0" bIns="0" rtlCol="0" anchor="ctr"/>
+          <a:lstStyle/>
+          <a:p>
+            <a:pPr marL="0" indent="0">
+              <a:buNone/>
+            </a:pPr>
+            <a:r>
+              <a:rPr lang="en-US" sz="950" b="1" kern="0" spc="220">
+                <a:solidFill>
+                  <a:srgbClr val="3FD0C9"/>
+                </a:solidFill>
+              </a:rPr>
+              <a:t>SECTION</a:t>
+            </a:r>
+            <a:endParaRPr lang="en-US" sz="950"/>
+          </a:p>
+        </p:txBody>
+      </p:sp>
+      <p:sp>
+        <p:nvSpPr>
+          <p:cNvPr id="6" name="Text 4"/>
+          <p:cNvSpPr txBox="1"/>
+          <p:nvPr/>
+        </p:nvSpPr>
+        <p:spPr>
+          <a:xfrm>
+            <a:off x="1600200" y="1874520"/>
+            <a:ext cx="5943600" cy="502920"/>
+          </a:xfrm>
+          <a:prstGeom prst="rect">
+            <a:avLst/>
+          </a:prstGeom>
+          <a:noFill/>
+          <a:ln/>
+        </p:spPr>
+        <p:txBody>
+          <a:bodyPr wrap="square" lIns="0" tIns="0" rIns="0" bIns="0" rtlCol="0" anchor="ctr"/>
+          <a:lstStyle/>
+          <a:p>
+            <a:pPr marL="0" indent="0">
+              <a:buNone/>
+            </a:pPr>
+            <a:r>
+              <a:rPr lang="en-US" sz="2300" b="1">
+                <a:solidFill>
+                  <a:srgbClr val="FFFFFF"/>
+                </a:solidFill>
+              </a:rPr>
+              <a:t>Financial performance</a:t>
+            </a:r>
+            <a:endParaRPr lang="en-US" sz="2800"/>
+          </a:p>
+        </p:txBody>
+      </p:sp>
+      <p:sp>
+        <p:nvSpPr>
+          <p:cNvPr id="7" name="Text 5"/>
+          <p:cNvSpPr txBox="1"/>
+          <p:nvPr/>
+        </p:nvSpPr>
+        <p:spPr>
+          <a:xfrm>
+            <a:off x="1600200" y="2395728"/>
+            <a:ext cx="5943600" cy="347472"/>
+          </a:xfrm>
+          <a:prstGeom prst="rect">
+            <a:avLst/>
+          </a:prstGeom>
+          <a:noFill/>
+          <a:ln/>
+        </p:spPr>
+        <p:txBody>
+          <a:bodyPr wrap="square" lIns="0" tIns="0" rIns="0" bIns="0" rtlCol="0" anchor="ctr"/>
+          <a:lstStyle/>
+          <a:p>
+            <a:pPr marL="0" indent="0">
+              <a:buNone/>
+            </a:pPr>
+            <a:r>
+              <a:rPr lang="en-US" sz="1200">
+                <a:solidFill>
+                  <a:srgbClr val="C9CED6"/>
+                </a:solidFill>
+              </a:rPr>
+              <a:t>The P&amp;L for September 2026 and the year to date</a:t>
+            </a:r>
+            <a:endParaRPr lang="en-US" sz="1200"/>
+          </a:p>
+        </p:txBody>
+      </p:sp>
+    </p:spTree>
+  </p:cSld>
+  <p:clrMapOvr>
+    <a:masterClrMapping/>
+  </p:clrMapOvr>
+</p:sld>
+</file>
+
+<file path=ppt/slides/slide40.xml><?xml version="1.0" encoding="utf-8"?>
 <p:sld xmlns:a="http://schemas.openxmlformats.org/drawingml/2006/main" xmlns:r="http://schemas.openxmlformats.org/officeDocument/2006/relationships" xmlns:p="http://schemas.openxmlformats.org/presentationml/2006/main">
   <p:cSld>
     <p:bg>
@@ -22565,290 +23303,7 @@
 </p:sld>
 </file>
 
-<file path=ppt/slides/slide4.xml><?xml version="1.0" encoding="utf-8"?>
-<p:sld xmlns:a="http://schemas.openxmlformats.org/drawingml/2006/main" xmlns:r="http://schemas.openxmlformats.org/officeDocument/2006/relationships" xmlns:p="http://schemas.openxmlformats.org/presentationml/2006/main">
-  <p:cSld name="Slide 4">
-    <p:spTree>
-      <p:nvGrpSpPr>
-        <p:cNvPr id="1" name=""/>
-        <p:cNvGrpSpPr/>
-        <p:nvPr/>
-      </p:nvGrpSpPr>
-      <p:grpSpPr>
-        <a:xfrm>
-          <a:off x="0" y="0"/>
-          <a:ext cx="0" cy="0"/>
-          <a:chOff x="0" y="0"/>
-          <a:chExt cx="0" cy="0"/>
-        </a:xfrm>
-      </p:grpSpPr>
-      <p:sp>
-        <p:nvSpPr>
-          <p:cNvPr id="2" name="dot 2"/>
-          <p:cNvSpPr/>
-          <p:nvPr/>
-        </p:nvSpPr>
-        <p:spPr>
-          <a:xfrm>
-            <a:off x="6537960" y="1965960"/>
-            <a:ext cx="2240280" cy="2240280"/>
-          </a:xfrm>
-          <a:prstGeom prst="ellipse">
-            <a:avLst/>
-          </a:prstGeom>
-          <a:solidFill>
-            <a:srgbClr val="F33844">
-              <a:alpha val="55000"/>
-            </a:srgbClr>
-          </a:solidFill>
-          <a:ln/>
-        </p:spPr>
-        <p:txBody>
-          <a:bodyPr/>
-          <a:lstStyle/>
-          <a:p>
-            <a:endParaRPr lang="en-AU"/>
-          </a:p>
-        </p:txBody>
-      </p:sp>
-      <p:sp>
-        <p:nvSpPr>
-          <p:cNvPr id="8" name="dot 1"/>
-          <p:cNvSpPr/>
-          <p:nvPr/>
-        </p:nvSpPr>
-        <p:spPr>
-          <a:xfrm>
-            <a:off x="7269480" y="1097280"/>
-            <a:ext cx="1783080" cy="1783080"/>
-          </a:xfrm>
-          <a:prstGeom prst="ellipse">
-            <a:avLst/>
-          </a:prstGeom>
-          <a:solidFill>
-            <a:srgbClr val="6D71FF">
-              <a:alpha val="55000"/>
-            </a:srgbClr>
-          </a:solidFill>
-          <a:ln/>
-        </p:spPr>
-        <p:txBody>
-          <a:bodyPr/>
-          <a:lstStyle/>
-          <a:p>
-            <a:endParaRPr lang="en-AU"/>
-          </a:p>
-        </p:txBody>
-      </p:sp>
-      <p:sp>
-        <p:nvSpPr>
-          <p:cNvPr id="9" name="dot 0"/>
-          <p:cNvSpPr/>
-          <p:nvPr/>
-        </p:nvSpPr>
-        <p:spPr>
-          <a:xfrm>
-            <a:off x="6309360" y="182880"/>
-            <a:ext cx="2148840" cy="2148840"/>
-          </a:xfrm>
-          <a:prstGeom prst="ellipse">
-            <a:avLst/>
-          </a:prstGeom>
-          <a:solidFill>
-            <a:srgbClr val="3FD0C9">
-              <a:alpha val="55000"/>
-            </a:srgbClr>
-          </a:solidFill>
-          <a:ln/>
-        </p:spPr>
-        <p:txBody>
-          <a:bodyPr/>
-          <a:lstStyle/>
-          <a:p>
-            <a:endParaRPr lang="en-AU"/>
-          </a:p>
-        </p:txBody>
-      </p:sp>
-      <p:sp>
-        <p:nvSpPr>
-          <p:cNvPr id="3" name="Shape 1"/>
-          <p:cNvSpPr/>
-          <p:nvPr/>
-        </p:nvSpPr>
-        <p:spPr>
-          <a:xfrm>
-            <a:off x="502920" y="1874520"/>
-            <a:ext cx="868680" cy="868680"/>
-          </a:xfrm>
-          <a:prstGeom prst="rect">
-            <a:avLst/>
-          </a:prstGeom>
-          <a:solidFill>
-            <a:srgbClr val="3FD0C9"/>
-          </a:solidFill>
-          <a:ln/>
-        </p:spPr>
-        <p:txBody>
-          <a:bodyPr/>
-          <a:lstStyle/>
-          <a:p>
-            <a:endParaRPr lang="en-AU"/>
-          </a:p>
-        </p:txBody>
-      </p:sp>
-      <p:sp>
-        <p:nvSpPr>
-          <p:cNvPr id="4" name="Text 2"/>
-          <p:cNvSpPr txBox="1"/>
-          <p:nvPr/>
-        </p:nvSpPr>
-        <p:spPr>
-          <a:xfrm>
-            <a:off x="502920" y="1874520"/>
-            <a:ext cx="868680" cy="868680"/>
-          </a:xfrm>
-          <a:prstGeom prst="rect">
-            <a:avLst/>
-          </a:prstGeom>
-          <a:noFill/>
-          <a:ln/>
-        </p:spPr>
-        <p:txBody>
-          <a:bodyPr wrap="square" lIns="0" tIns="0" rIns="0" bIns="0" rtlCol="0" anchor="ctr"/>
-          <a:lstStyle/>
-          <a:p>
-            <a:pPr marL="0" indent="0" algn="ctr">
-              <a:buNone/>
-            </a:pPr>
-            <a:r>
-              <a:rPr lang="en-US" sz="2200" b="1">
-                <a:solidFill>
-                  <a:srgbClr val="242C39"/>
-                </a:solidFill>
-              </a:rPr>
-              <a:t>01</a:t>
-            </a:r>
-            <a:endParaRPr lang="en-US" sz="2600"/>
-          </a:p>
-        </p:txBody>
-      </p:sp>
-      <p:sp>
-        <p:nvSpPr>
-          <p:cNvPr id="5" name="Text 3"/>
-          <p:cNvSpPr txBox="1"/>
-          <p:nvPr/>
-        </p:nvSpPr>
-        <p:spPr>
-          <a:xfrm>
-            <a:off x="502920" y="411480"/>
-            <a:ext cx="3657600" cy="274320"/>
-          </a:xfrm>
-          <a:prstGeom prst="rect">
-            <a:avLst/>
-          </a:prstGeom>
-          <a:noFill/>
-          <a:ln/>
-        </p:spPr>
-        <p:txBody>
-          <a:bodyPr wrap="square" lIns="0" tIns="0" rIns="0" bIns="0" rtlCol="0" anchor="ctr"/>
-          <a:lstStyle/>
-          <a:p>
-            <a:pPr marL="0" indent="0">
-              <a:buNone/>
-            </a:pPr>
-            <a:r>
-              <a:rPr lang="en-US" sz="950" b="1" kern="0" spc="220">
-                <a:solidFill>
-                  <a:srgbClr val="3FD0C9"/>
-                </a:solidFill>
-              </a:rPr>
-              <a:t>SECTION</a:t>
-            </a:r>
-            <a:endParaRPr lang="en-US" sz="950"/>
-          </a:p>
-        </p:txBody>
-      </p:sp>
-      <p:sp>
-        <p:nvSpPr>
-          <p:cNvPr id="6" name="Text 4"/>
-          <p:cNvSpPr txBox="1"/>
-          <p:nvPr/>
-        </p:nvSpPr>
-        <p:spPr>
-          <a:xfrm>
-            <a:off x="1600200" y="1874520"/>
-            <a:ext cx="5943600" cy="502920"/>
-          </a:xfrm>
-          <a:prstGeom prst="rect">
-            <a:avLst/>
-          </a:prstGeom>
-          <a:noFill/>
-          <a:ln/>
-        </p:spPr>
-        <p:txBody>
-          <a:bodyPr wrap="square" lIns="0" tIns="0" rIns="0" bIns="0" rtlCol="0" anchor="ctr"/>
-          <a:lstStyle/>
-          <a:p>
-            <a:pPr marL="0" indent="0">
-              <a:buNone/>
-            </a:pPr>
-            <a:r>
-              <a:rPr lang="en-US" sz="2300" b="1">
-                <a:solidFill>
-                  <a:srgbClr val="FFFFFF"/>
-                </a:solidFill>
-              </a:rPr>
-              <a:t>Financial performance</a:t>
-            </a:r>
-            <a:endParaRPr lang="en-US" sz="2800"/>
-          </a:p>
-        </p:txBody>
-      </p:sp>
-      <p:sp>
-        <p:nvSpPr>
-          <p:cNvPr id="7" name="Text 5"/>
-          <p:cNvSpPr txBox="1"/>
-          <p:nvPr/>
-        </p:nvSpPr>
-        <p:spPr>
-          <a:xfrm>
-            <a:off x="1600200" y="2395728"/>
-            <a:ext cx="5943600" cy="347472"/>
-          </a:xfrm>
-          <a:prstGeom prst="rect">
-            <a:avLst/>
-          </a:prstGeom>
-          <a:noFill/>
-          <a:ln/>
-        </p:spPr>
-        <p:txBody>
-          <a:bodyPr wrap="square" lIns="0" tIns="0" rIns="0" bIns="0" rtlCol="0" anchor="ctr"/>
-          <a:lstStyle/>
-          <a:p>
-            <a:pPr marL="0" indent="0">
-              <a:buNone/>
-            </a:pPr>
-            <a:r>
-              <a:rPr lang="en-US" sz="1200">
-                <a:solidFill>
-                  <a:srgbClr val="C9CED6"/>
-                </a:solidFill>
-              </a:rPr>
-              <a:t>The P&amp;L for September 2026 and the year to date</a:t>
-            </a:r>
-            <a:endParaRPr lang="en-US" sz="1200"/>
-          </a:p>
-        </p:txBody>
-      </p:sp>
-    </p:spTree>
-  </p:cSld>
-  <p:clrMapOvr>
-    <a:masterClrMapping/>
-  </p:clrMapOvr>
-</p:sld>
-</file>
-
-<file path=ppt/slides/slide40.xml><?xml version="1.0" encoding="utf-8"?>
+<file path=ppt/slides/slide41.xml><?xml version="1.0" encoding="utf-8"?>
 <p:sld xmlns:a="http://schemas.openxmlformats.org/drawingml/2006/main" xmlns:r="http://schemas.openxmlformats.org/officeDocument/2006/relationships" xmlns:p="http://schemas.openxmlformats.org/presentationml/2006/main">
   <p:cSld name="Slide 31">
     <p:spTree>

</xml_diff>

<commit_message>
A section divider for the departmental pages, in the department colours
The departmental pages sat inside Financial performance with no break in front of
them. They now open their own section, and its dots are the five department
colours in P&L order rather than the three from the palette: Support red, Events
dark teal, Video bright teal, Integration blue, Consulting purple.

Adding a section moves everything after it, so the five later dividers renumber,
the departmental pages carry their own eyebrow, and the agenda gains a line. The
agenda rows are respaced from a 0.70 step to 0.60 so six fit without the last one
running into the footer.

A cloned slide starts with no notes placeholder, so the divider's speaker note
needed the placeholder copied across from the slide it was cloned from.

Co-Authored-By: Claude Opus 5 <noreply@anthropic.com>
Claude-Session: https://claude.ai/code/session_01CVBAFohBCYXt1ufjTVDiZj
</commit_message>
<xml_diff>
--- a/deck/CTS Monthly Business Review - 30092026.pptx
+++ b/deck/CTS Monthly Business Review - 30092026.pptx
@@ -23,6 +23,7 @@
     <p:sldId id="296" r:id="rId17"/>
     <p:sldId id="297" r:id="rId18"/>
     <p:sldId id="298" r:id="rId52"/>
+    <p:sldId id="299" r:id="rId53"/>
     <p:sldId id="262" r:id="rId19"/>
     <p:sldId id="263" r:id="rId20"/>
     <p:sldId id="264" r:id="rId21"/>
@@ -4943,6 +4944,58 @@
 </p:notes>
 </file>
 
+<file path=ppt/notesSlides/notesSlide42.xml><?xml version="1.0" encoding="utf-8"?>
+<p:notes xmlns:a="http://schemas.openxmlformats.org/drawingml/2006/main" xmlns:p="http://schemas.openxmlformats.org/presentationml/2006/main" xmlns:r="http://schemas.openxmlformats.org/officeDocument/2006/relationships">
+  <p:cSld>
+    <p:spTree>
+      <p:nvGrpSpPr>
+        <p:cNvPr id="1" name=""/>
+        <p:cNvGrpSpPr/>
+        <p:nvPr/>
+      </p:nvGrpSpPr>
+      <p:grpSpPr>
+        <a:xfrm>
+          <a:off x="0" y="0"/>
+          <a:ext cx="0" cy="0"/>
+          <a:chOff x="0" y="0"/>
+          <a:chExt cx="0" cy="0"/>
+        </a:xfrm>
+      </p:grpSpPr>
+      <p:sp>
+        <p:nvSpPr>
+          <p:cNvPr id="3" name="Notes Placeholder 2"/>
+          <p:cNvSpPr>
+            <a:spLocks noGrp="1"/>
+          </p:cNvSpPr>
+          <p:nvPr>
+            <p:ph type="body" idx="1"/>
+          </p:nvPr>
+        </p:nvSpPr>
+        <p:spPr/>
+        <p:txBody>
+          <a:bodyPr lIns="107095" tIns="53547" rIns="107095" bIns="53547"/>
+          <a:lstStyle/>
+          <a:p>
+            <a:r>
+              <a:t>Departmental performance for September 2026.</a:t>
+            </a:r>
+          </a:p>
+          <a:p/>
+          <a:p>
+            <a:r>
+              <a:t>The pages that follow give the company result by department, the same result rolled up the way the P&amp;L groups the business, then a page for each of the five departments, and finally departmental revenue against budget and against the same month last year.</a:t>
+            </a:r>
+          </a:p>
+        </p:txBody>
+      </p:sp>
+    </p:spTree>
+  </p:cSld>
+  <p:clrMapOvr>
+    <a:masterClrMapping/>
+  </p:clrMapOvr>
+</p:notes>
+</file>
+
 <file path=ppt/notesSlides/notesSlide5.xml><?xml version="1.0" encoding="utf-8"?>
 <p:notes xmlns:a="http://schemas.openxmlformats.org/drawingml/2006/main" xmlns:r="http://schemas.openxmlformats.org/officeDocument/2006/relationships" xmlns:p="http://schemas.openxmlformats.org/presentationml/2006/main">
   <p:cSld>
@@ -8696,6 +8749,415 @@
 </file>
 
 <file path=ppt/slides/slide16.xml><?xml version="1.0" encoding="utf-8"?>
+<p:sld xmlns:a="http://schemas.openxmlformats.org/drawingml/2006/main" xmlns:p="http://schemas.openxmlformats.org/presentationml/2006/main" xmlns:r="http://schemas.openxmlformats.org/officeDocument/2006/relationships">
+  <p:cSld>
+    <p:spTree>
+      <p:nvGrpSpPr>
+        <p:cNvPr id="1" name=""/>
+        <p:cNvGrpSpPr/>
+        <p:nvPr/>
+      </p:nvGrpSpPr>
+      <p:grpSpPr/>
+      <p:sp>
+        <p:nvSpPr>
+          <p:cNvPr id="12" name="dot 4"/>
+          <p:cNvSpPr/>
+          <p:nvPr/>
+        </p:nvSpPr>
+        <p:spPr>
+          <a:xfrm>
+            <a:off x="5897880" y="3154680"/>
+            <a:ext cx="1371600" cy="1371600"/>
+          </a:xfrm>
+          <a:prstGeom prst="ellipse">
+            <a:avLst/>
+          </a:prstGeom>
+          <a:solidFill>
+            <a:srgbClr val="8F4AFA"/>
+          </a:solidFill>
+          <a:ln>
+            <a:noFill/>
+          </a:ln>
+          <a:effectLst/>
+        </p:spPr>
+        <p:style>
+          <a:lnRef idx="1">
+            <a:schemeClr val="accent1"/>
+          </a:lnRef>
+          <a:fillRef idx="3">
+            <a:schemeClr val="accent1"/>
+          </a:fillRef>
+          <a:effectRef idx="2">
+            <a:schemeClr val="accent1"/>
+          </a:effectRef>
+          <a:fontRef idx="minor">
+            <a:schemeClr val="lt1"/>
+          </a:fontRef>
+        </p:style>
+        <p:txBody>
+          <a:bodyPr rtlCol="0" anchor="ctr"/>
+          <a:lstStyle/>
+          <a:p>
+            <a:pPr algn="ctr"/>
+          </a:p>
+        </p:txBody>
+      </p:sp>
+      <p:sp>
+        <p:nvSpPr>
+          <p:cNvPr id="11" name="dot 3"/>
+          <p:cNvSpPr/>
+          <p:nvPr/>
+        </p:nvSpPr>
+        <p:spPr>
+          <a:xfrm>
+            <a:off x="7040880" y="2468880"/>
+            <a:ext cx="2057400" cy="2057400"/>
+          </a:xfrm>
+          <a:prstGeom prst="ellipse">
+            <a:avLst/>
+          </a:prstGeom>
+          <a:solidFill>
+            <a:srgbClr val="6D71FF"/>
+          </a:solidFill>
+          <a:ln>
+            <a:noFill/>
+          </a:ln>
+          <a:effectLst/>
+        </p:spPr>
+        <p:style>
+          <a:lnRef idx="1">
+            <a:schemeClr val="accent1"/>
+          </a:lnRef>
+          <a:fillRef idx="3">
+            <a:schemeClr val="accent1"/>
+          </a:fillRef>
+          <a:effectRef idx="2">
+            <a:schemeClr val="accent1"/>
+          </a:effectRef>
+          <a:fontRef idx="minor">
+            <a:schemeClr val="lt1"/>
+          </a:fontRef>
+        </p:style>
+        <p:txBody>
+          <a:bodyPr rtlCol="0" anchor="ctr"/>
+          <a:lstStyle/>
+          <a:p>
+            <a:pPr algn="ctr"/>
+          </a:p>
+        </p:txBody>
+      </p:sp>
+      <p:sp>
+        <p:nvSpPr>
+          <p:cNvPr id="10" name="dot 2"/>
+          <p:cNvSpPr/>
+          <p:nvPr/>
+        </p:nvSpPr>
+        <p:spPr>
+          <a:xfrm>
+            <a:off x="6629400" y="2057400"/>
+            <a:ext cx="1554480" cy="1554480"/>
+          </a:xfrm>
+          <a:prstGeom prst="ellipse">
+            <a:avLst/>
+          </a:prstGeom>
+          <a:solidFill>
+            <a:srgbClr val="3FD0C9"/>
+          </a:solidFill>
+          <a:ln>
+            <a:noFill/>
+          </a:ln>
+          <a:effectLst/>
+        </p:spPr>
+        <p:style>
+          <a:lnRef idx="1">
+            <a:schemeClr val="accent1"/>
+          </a:lnRef>
+          <a:fillRef idx="3">
+            <a:schemeClr val="accent1"/>
+          </a:fillRef>
+          <a:effectRef idx="2">
+            <a:schemeClr val="accent1"/>
+          </a:effectRef>
+          <a:fontRef idx="minor">
+            <a:schemeClr val="lt1"/>
+          </a:fontRef>
+        </p:style>
+        <p:txBody>
+          <a:bodyPr rtlCol="0" anchor="ctr"/>
+          <a:lstStyle/>
+          <a:p>
+            <a:pPr algn="ctr"/>
+          </a:p>
+        </p:txBody>
+      </p:sp>
+      <p:sp>
+        <p:nvSpPr>
+          <p:cNvPr id="9" name="dot 1"/>
+          <p:cNvSpPr/>
+          <p:nvPr/>
+        </p:nvSpPr>
+        <p:spPr>
+          <a:xfrm>
+            <a:off x="7132320" y="868680"/>
+            <a:ext cx="1874519" cy="1874519"/>
+          </a:xfrm>
+          <a:prstGeom prst="ellipse">
+            <a:avLst/>
+          </a:prstGeom>
+          <a:solidFill>
+            <a:srgbClr val="005358"/>
+          </a:solidFill>
+          <a:ln>
+            <a:noFill/>
+          </a:ln>
+          <a:effectLst/>
+        </p:spPr>
+        <p:style>
+          <a:lnRef idx="1">
+            <a:schemeClr val="accent1"/>
+          </a:lnRef>
+          <a:fillRef idx="3">
+            <a:schemeClr val="accent1"/>
+          </a:fillRef>
+          <a:effectRef idx="2">
+            <a:schemeClr val="accent1"/>
+          </a:effectRef>
+          <a:fontRef idx="minor">
+            <a:schemeClr val="lt1"/>
+          </a:fontRef>
+        </p:style>
+        <p:txBody>
+          <a:bodyPr rtlCol="0" anchor="ctr"/>
+          <a:lstStyle/>
+          <a:p>
+            <a:pPr algn="ctr"/>
+          </a:p>
+        </p:txBody>
+      </p:sp>
+      <p:sp>
+        <p:nvSpPr>
+          <p:cNvPr id="8" name="dot 0"/>
+          <p:cNvSpPr/>
+          <p:nvPr/>
+        </p:nvSpPr>
+        <p:spPr>
+          <a:xfrm>
+            <a:off x="5897880" y="91440"/>
+            <a:ext cx="2240280" cy="2240280"/>
+          </a:xfrm>
+          <a:prstGeom prst="ellipse">
+            <a:avLst/>
+          </a:prstGeom>
+          <a:solidFill>
+            <a:srgbClr val="F33844"/>
+          </a:solidFill>
+          <a:ln>
+            <a:noFill/>
+          </a:ln>
+          <a:effectLst/>
+        </p:spPr>
+        <p:style>
+          <a:lnRef idx="1">
+            <a:schemeClr val="accent1"/>
+          </a:lnRef>
+          <a:fillRef idx="3">
+            <a:schemeClr val="accent1"/>
+          </a:fillRef>
+          <a:effectRef idx="2">
+            <a:schemeClr val="accent1"/>
+          </a:effectRef>
+          <a:fontRef idx="minor">
+            <a:schemeClr val="lt1"/>
+          </a:fontRef>
+        </p:style>
+        <p:txBody>
+          <a:bodyPr rtlCol="0" anchor="ctr"/>
+          <a:lstStyle/>
+          <a:p>
+            <a:pPr algn="ctr"/>
+          </a:p>
+        </p:txBody>
+      </p:sp>
+      <p:sp>
+        <p:nvSpPr>
+          <p:cNvPr id="3" name="Shape 1"/>
+          <p:cNvSpPr/>
+          <p:nvPr/>
+        </p:nvSpPr>
+        <p:spPr>
+          <a:xfrm>
+            <a:off x="502920" y="1874520"/>
+            <a:ext cx="868680" cy="868680"/>
+          </a:xfrm>
+          <a:prstGeom prst="rect">
+            <a:avLst/>
+          </a:prstGeom>
+          <a:solidFill>
+            <a:srgbClr val="3FD0C9"/>
+          </a:solidFill>
+          <a:ln/>
+        </p:spPr>
+        <p:txBody>
+          <a:bodyPr/>
+          <a:lstStyle/>
+          <a:p>
+            <a:endParaRPr lang="en-AU"/>
+          </a:p>
+        </p:txBody>
+      </p:sp>
+      <p:sp>
+        <p:nvSpPr>
+          <p:cNvPr id="4" name="Text 2"/>
+          <p:cNvSpPr txBox="1"/>
+          <p:nvPr/>
+        </p:nvSpPr>
+        <p:spPr>
+          <a:xfrm>
+            <a:off x="502920" y="1874520"/>
+            <a:ext cx="868680" cy="868680"/>
+          </a:xfrm>
+          <a:prstGeom prst="rect">
+            <a:avLst/>
+          </a:prstGeom>
+          <a:noFill/>
+          <a:ln/>
+        </p:spPr>
+        <p:txBody>
+          <a:bodyPr wrap="square" lIns="0" tIns="0" rIns="0" bIns="0" rtlCol="0" anchor="ctr"/>
+          <a:lstStyle/>
+          <a:p>
+            <a:pPr marL="0" indent="0" algn="ctr">
+              <a:buNone/>
+            </a:pPr>
+            <a:r>
+              <a:rPr lang="en-US" sz="2200" b="1">
+                <a:solidFill>
+                  <a:srgbClr val="242C39"/>
+                </a:solidFill>
+              </a:rPr>
+              <a:t>02</a:t>
+            </a:r>
+            <a:endParaRPr lang="en-US" sz="2600"/>
+          </a:p>
+        </p:txBody>
+      </p:sp>
+      <p:sp>
+        <p:nvSpPr>
+          <p:cNvPr id="5" name="Text 3"/>
+          <p:cNvSpPr txBox="1"/>
+          <p:nvPr/>
+        </p:nvSpPr>
+        <p:spPr>
+          <a:xfrm>
+            <a:off x="502920" y="411480"/>
+            <a:ext cx="3657600" cy="274320"/>
+          </a:xfrm>
+          <a:prstGeom prst="rect">
+            <a:avLst/>
+          </a:prstGeom>
+          <a:noFill/>
+          <a:ln/>
+        </p:spPr>
+        <p:txBody>
+          <a:bodyPr wrap="square" lIns="0" tIns="0" rIns="0" bIns="0" rtlCol="0" anchor="ctr"/>
+          <a:lstStyle/>
+          <a:p>
+            <a:pPr marL="0" indent="0">
+              <a:buNone/>
+            </a:pPr>
+            <a:r>
+              <a:rPr lang="en-US" sz="950" b="1" kern="0" spc="220">
+                <a:solidFill>
+                  <a:srgbClr val="3FD0C9"/>
+                </a:solidFill>
+              </a:rPr>
+              <a:t>SECTION</a:t>
+            </a:r>
+            <a:endParaRPr lang="en-US" sz="950"/>
+          </a:p>
+        </p:txBody>
+      </p:sp>
+      <p:sp>
+        <p:nvSpPr>
+          <p:cNvPr id="6" name="Text 4"/>
+          <p:cNvSpPr txBox="1"/>
+          <p:nvPr/>
+        </p:nvSpPr>
+        <p:spPr>
+          <a:xfrm>
+            <a:off x="1600200" y="1874519"/>
+            <a:ext cx="5943600" cy="502920"/>
+          </a:xfrm>
+          <a:prstGeom prst="rect">
+            <a:avLst/>
+          </a:prstGeom>
+          <a:noFill/>
+          <a:ln/>
+        </p:spPr>
+        <p:txBody>
+          <a:bodyPr wrap="square" lIns="0" tIns="0" rIns="0" bIns="0" rtlCol="0" anchor="ctr"/>
+          <a:lstStyle/>
+          <a:p>
+            <a:pPr marL="0" indent="0">
+              <a:buNone/>
+            </a:pPr>
+            <a:r>
+              <a:rPr lang="en-US" sz="2300" b="1">
+                <a:solidFill>
+                  <a:srgbClr val="FFFFFF"/>
+                </a:solidFill>
+              </a:rPr>
+              <a:t>Departmental performance</a:t>
+            </a:r>
+            <a:endParaRPr lang="en-US" sz="2800"/>
+          </a:p>
+        </p:txBody>
+      </p:sp>
+      <p:sp>
+        <p:nvSpPr>
+          <p:cNvPr id="7" name="Text 5"/>
+          <p:cNvSpPr txBox="1"/>
+          <p:nvPr/>
+        </p:nvSpPr>
+        <p:spPr>
+          <a:xfrm>
+            <a:off x="1600200" y="2395728"/>
+            <a:ext cx="5943600" cy="347472"/>
+          </a:xfrm>
+          <a:prstGeom prst="rect">
+            <a:avLst/>
+          </a:prstGeom>
+          <a:noFill/>
+          <a:ln/>
+        </p:spPr>
+        <p:txBody>
+          <a:bodyPr wrap="square" lIns="0" tIns="0" rIns="0" bIns="0" rtlCol="0" anchor="ctr"/>
+          <a:lstStyle/>
+          <a:p>
+            <a:pPr marL="0" indent="0">
+              <a:buNone/>
+            </a:pPr>
+            <a:r>
+              <a:rPr lang="en-US" sz="1200">
+                <a:solidFill>
+                  <a:srgbClr val="C9CED6"/>
+                </a:solidFill>
+              </a:rPr>
+              <a:t>Every department's result for September 2026 and how it was made</a:t>
+            </a:r>
+            <a:endParaRPr lang="en-US" sz="1200"/>
+          </a:p>
+        </p:txBody>
+      </p:sp>
+    </p:spTree>
+  </p:cSld>
+  <p:clrMapOvr>
+    <a:masterClrMapping/>
+  </p:clrMapOvr>
+</p:sld>
+</file>
+
+<file path=ppt/slides/slide17.xml><?xml version="1.0" encoding="utf-8"?>
 <p:sld xmlns:a="http://schemas.openxmlformats.org/drawingml/2006/main" xmlns:r="http://schemas.openxmlformats.org/officeDocument/2006/relationships" xmlns:p="http://schemas.openxmlformats.org/presentationml/2006/main">
   <p:cSld name="Slide 7">
     <p:spTree>
@@ -8742,7 +9204,7 @@
                   <a:srgbClr val="122B82"/>
                 </a:solidFill>
               </a:rPr>
-              <a:t>FINANCIAL PERFORMANCE</a:t>
+              <a:t>DEPARTMENTAL PERFORMANCE</a:t>
             </a:r>
             <a:endParaRPr lang="en-US" sz="950"/>
           </a:p>
@@ -9080,7 +9542,7 @@
 </p:sld>
 </file>
 
-<file path=ppt/slides/slide17.xml><?xml version="1.0" encoding="utf-8"?>
+<file path=ppt/slides/slide18.xml><?xml version="1.0" encoding="utf-8"?>
 <p:sld xmlns:a="http://schemas.openxmlformats.org/drawingml/2006/main" xmlns:r="http://schemas.openxmlformats.org/officeDocument/2006/relationships" xmlns:p="http://schemas.openxmlformats.org/presentationml/2006/main">
   <p:cSld name="Slide 8">
     <p:spTree>
@@ -9127,7 +9589,7 @@
                   <a:srgbClr val="122B82"/>
                 </a:solidFill>
               </a:rPr>
-              <a:t>FINANCIAL PERFORMANCE</a:t>
+              <a:t>DEPARTMENTAL PERFORMANCE</a:t>
             </a:r>
             <a:endParaRPr lang="en-US" sz="950"/>
           </a:p>
@@ -9465,7 +9927,7 @@
 </p:sld>
 </file>
 
-<file path=ppt/slides/slide18.xml><?xml version="1.0" encoding="utf-8"?>
+<file path=ppt/slides/slide19.xml><?xml version="1.0" encoding="utf-8"?>
 <p:sld xmlns:a="http://schemas.openxmlformats.org/drawingml/2006/main" xmlns:r="http://schemas.openxmlformats.org/officeDocument/2006/relationships" xmlns:p="http://schemas.openxmlformats.org/presentationml/2006/main">
   <p:cSld name="Slide 9">
     <p:spTree>
@@ -9536,7 +9998,7 @@
                   <a:srgbClr val="122B82"/>
                 </a:solidFill>
               </a:rPr>
-              <a:t>FINANCIAL PERFORMANCE</a:t>
+              <a:t>DEPARTMENTAL PERFORMANCE</a:t>
             </a:r>
             <a:endParaRPr lang="en-US" sz="950"/>
           </a:p>
@@ -9860,412 +10322,6 @@
               <a:t>Chargeable utilisation reached 91.2%, above the 88% target and the strongest result across the groups.</a:t>
             </a:r>
             <a:endParaRPr lang="en-US" sz="850"/>
-          </a:p>
-        </p:txBody>
-      </p:sp>
-    </p:spTree>
-  </p:cSld>
-  <p:clrMapOvr>
-    <a:masterClrMapping/>
-  </p:clrMapOvr>
-</p:sld>
-</file>
-
-<file path=ppt/slides/slide19.xml><?xml version="1.0" encoding="utf-8"?>
-<p:sld xmlns:a="http://schemas.openxmlformats.org/drawingml/2006/main" xmlns:r="http://schemas.openxmlformats.org/officeDocument/2006/relationships" xmlns:p="http://schemas.openxmlformats.org/presentationml/2006/main">
-  <p:cSld name="Slide 10">
-    <p:spTree>
-      <p:nvGrpSpPr>
-        <p:cNvPr id="1" name=""/>
-        <p:cNvGrpSpPr/>
-        <p:nvPr/>
-      </p:nvGrpSpPr>
-      <p:grpSpPr>
-        <a:xfrm>
-          <a:off x="0" y="0"/>
-          <a:ext cx="0" cy="0"/>
-          <a:chOff x="0" y="0"/>
-          <a:chExt cx="0" cy="0"/>
-        </a:xfrm>
-      </p:grpSpPr>
-      <p:pic>
-        <p:nvPicPr>
-          <p:cNvPr id="27" name="snip dept_Events" descr="dept_Events.png"/>
-          <p:cNvPicPr>
-            <a:picLocks noChangeAspect="1"/>
-          </p:cNvPicPr>
-          <p:nvPr/>
-        </p:nvPicPr>
-        <p:blipFill>
-          <a:blip r:embed="rId3"/>
-          <a:stretch>
-            <a:fillRect/>
-          </a:stretch>
-        </p:blipFill>
-        <p:spPr>
-          <a:xfrm>
-            <a:off x="974377" y="1005840"/>
-            <a:ext cx="7195245" cy="2130551"/>
-          </a:xfrm>
-          <a:prstGeom prst="rect">
-            <a:avLst/>
-          </a:prstGeom>
-        </p:spPr>
-      </p:pic>
-      <p:sp>
-        <p:nvSpPr>
-          <p:cNvPr id="2" name="Text 0"/>
-          <p:cNvSpPr txBox="1"/>
-          <p:nvPr/>
-        </p:nvSpPr>
-        <p:spPr>
-          <a:xfrm>
-            <a:off x="502920" y="365760"/>
-            <a:ext cx="6400800" cy="274320"/>
-          </a:xfrm>
-          <a:prstGeom prst="rect">
-            <a:avLst/>
-          </a:prstGeom>
-          <a:noFill/>
-          <a:ln/>
-        </p:spPr>
-        <p:txBody>
-          <a:bodyPr wrap="square" lIns="0" tIns="0" rIns="0" bIns="0" rtlCol="0" anchor="ctr"/>
-          <a:lstStyle/>
-          <a:p>
-            <a:pPr marL="0" indent="0">
-              <a:buNone/>
-            </a:pPr>
-            <a:r>
-              <a:rPr lang="en-US" sz="950" b="1" kern="0" spc="220">
-                <a:solidFill>
-                  <a:srgbClr val="122B82"/>
-                </a:solidFill>
-              </a:rPr>
-              <a:t>FINANCIAL PERFORMANCE</a:t>
-            </a:r>
-            <a:endParaRPr lang="en-US" sz="950"/>
-          </a:p>
-        </p:txBody>
-      </p:sp>
-      <p:sp>
-        <p:nvSpPr>
-          <p:cNvPr id="3" name="Text 1"/>
-          <p:cNvSpPr txBox="1"/>
-          <p:nvPr/>
-        </p:nvSpPr>
-        <p:spPr>
-          <a:xfrm>
-            <a:off x="502920" y="640080"/>
-            <a:ext cx="7315200" cy="365760"/>
-          </a:xfrm>
-          <a:prstGeom prst="rect">
-            <a:avLst/>
-          </a:prstGeom>
-          <a:noFill/>
-          <a:ln/>
-        </p:spPr>
-        <p:txBody>
-          <a:bodyPr wrap="square" lIns="0" tIns="0" rIns="0" bIns="0" rtlCol="0" anchor="ctr"/>
-          <a:lstStyle/>
-          <a:p>
-            <a:pPr marL="0" indent="0" algn="ctr">
-              <a:buNone/>
-            </a:pPr>
-            <a:r>
-              <a:rPr lang="en-US" sz="2200" b="1">
-                <a:solidFill>
-                  <a:srgbClr val="242C39"/>
-                </a:solidFill>
-              </a:rPr>
-              <a:t>Events, September 2026</a:t>
-            </a:r>
-            <a:endParaRPr lang="en-US" sz="2700"/>
-          </a:p>
-        </p:txBody>
-      </p:sp>
-      <p:sp>
-        <p:nvSpPr>
-          <p:cNvPr id="6" name="commentary panel"/>
-          <p:cNvSpPr/>
-          <p:nvPr/>
-        </p:nvSpPr>
-        <p:spPr>
-          <a:xfrm>
-            <a:off x="502920" y="3227831"/>
-            <a:ext cx="8138160" cy="1399032"/>
-          </a:xfrm>
-          <a:prstGeom prst="rect">
-            <a:avLst/>
-          </a:prstGeom>
-          <a:solidFill>
-            <a:srgbClr val="E8F9F8"/>
-          </a:solidFill>
-          <a:ln/>
-        </p:spPr>
-        <p:txBody>
-          <a:bodyPr/>
-          <a:lstStyle/>
-          <a:p>
-            <a:endParaRPr lang="en-AU"/>
-          </a:p>
-        </p:txBody>
-      </p:sp>
-      <p:sp>
-        <p:nvSpPr>
-          <p:cNvPr id="7" name="Text 4"/>
-          <p:cNvSpPr txBox="1"/>
-          <p:nvPr/>
-        </p:nvSpPr>
-        <p:spPr>
-          <a:xfrm>
-            <a:off x="685800" y="3300983"/>
-            <a:ext cx="2743200" cy="228600"/>
-          </a:xfrm>
-          <a:prstGeom prst="rect">
-            <a:avLst/>
-          </a:prstGeom>
-          <a:noFill/>
-          <a:ln/>
-        </p:spPr>
-        <p:txBody>
-          <a:bodyPr wrap="square" lIns="0" tIns="0" rIns="0" bIns="0" rtlCol="0" anchor="ctr"/>
-          <a:lstStyle/>
-          <a:p>
-            <a:pPr marL="0" indent="0">
-              <a:buNone/>
-            </a:pPr>
-            <a:r>
-              <a:rPr lang="en-US" sz="900" b="1" kern="0" spc="180">
-                <a:solidFill>
-                  <a:srgbClr val="005358"/>
-                </a:solidFill>
-              </a:rPr>
-              <a:t>COMMENTARY</a:t>
-            </a:r>
-            <a:endParaRPr lang="en-US" sz="900"/>
-          </a:p>
-        </p:txBody>
-      </p:sp>
-      <p:sp>
-        <p:nvSpPr>
-          <p:cNvPr id="8" name="Text 5"/>
-          <p:cNvSpPr txBox="1"/>
-          <p:nvPr/>
-        </p:nvSpPr>
-        <p:spPr>
-          <a:xfrm>
-            <a:off x="685800" y="3474719"/>
-            <a:ext cx="3703320" cy="1124712"/>
-          </a:xfrm>
-          <a:prstGeom prst="rect">
-            <a:avLst/>
-          </a:prstGeom>
-          <a:noFill/>
-          <a:ln/>
-        </p:spPr>
-        <p:txBody>
-          <a:bodyPr wrap="square" lIns="0" tIns="0" rIns="0" bIns="0" rtlCol="0" anchor="t">
-            <a:normAutofit fontScale="92500"/>
-          </a:bodyPr>
-          <a:lstStyle/>
-          <a:p>
-            <a:pPr marL="342900" indent="-342900">
-              <a:lnSpc>
-                <a:spcPts val="1150"/>
-              </a:lnSpc>
-              <a:spcAft>
-                <a:spcPts val="400"/>
-              </a:spcAft>
-              <a:buSzPct val="100000"/>
-              <a:buChar char="•"/>
-            </a:pPr>
-            <a:r>
-              <a:rPr lang="en-US" sz="1000">
-                <a:solidFill>
-                  <a:srgbClr val="3A4453"/>
-                </a:solidFill>
-              </a:rPr>
-              <a:t>Events generated $73k revenue against a $66k budget for September.</a:t>
-            </a:r>
-            <a:endParaRPr lang="en-US" sz="900"/>
-          </a:p>
-          <a:p>
-            <a:pPr marL="342900" indent="-342900">
-              <a:lnSpc>
-                <a:spcPts val="1150"/>
-              </a:lnSpc>
-              <a:spcAft>
-                <a:spcPts val="400"/>
-              </a:spcAft>
-              <a:buSzPct val="100000"/>
-              <a:buChar char="•"/>
-            </a:pPr>
-            <a:r>
-              <a:rPr lang="en-US" sz="1000">
-                <a:solidFill>
-                  <a:srgbClr val="3A4453"/>
-                </a:solidFill>
-              </a:rPr>
-              <a:t>Gross margin was 77.6%, a strong result compared with other departments.</a:t>
-            </a:r>
-            <a:endParaRPr lang="en-US" sz="900"/>
-          </a:p>
-          <a:p>
-            <a:pPr marL="342900" indent="-342900">
-              <a:lnSpc>
-                <a:spcPts val="1150"/>
-              </a:lnSpc>
-              <a:spcAft>
-                <a:spcPts val="400"/>
-              </a:spcAft>
-              <a:buSzPct val="100000"/>
-              <a:buChar char="•"/>
-            </a:pPr>
-            <a:r>
-              <a:rPr lang="en-US" sz="1000">
-                <a:solidFill>
-                  <a:srgbClr val="3A4453"/>
-                </a:solidFill>
-              </a:rPr>
-              <a:t>Despite this, Events recorded a $54k loss after $111k of allocated overheads.</a:t>
-            </a:r>
-            <a:endParaRPr lang="en-US" sz="900"/>
-          </a:p>
-        </p:txBody>
-      </p:sp>
-      <p:sp>
-        <p:nvSpPr>
-          <p:cNvPr id="25" name="Slide Number Placeholder 0"/>
-          <p:cNvSpPr>
-            <a:spLocks noGrp="1"/>
-          </p:cNvSpPr>
-          <p:nvPr>
-            <p:ph type="sldNum" sz="quarter" idx="4294967295"/>
-          </p:nvPr>
-        </p:nvSpPr>
-        <p:spPr>
-          <a:xfrm>
-            <a:off x="8092440" y="4736592"/>
-            <a:ext cx="548640" cy="228600"/>
-          </a:xfrm>
-          <a:prstGeom prst="rect">
-            <a:avLst/>
-          </a:prstGeom>
-          <a:extLst>
-            <a:ext uri="{C572A759-6A51-4108-AA02-DFA0A04FC94B}">
-              <ma14:wrappingTextBoxFlag xmlns:ma14="http://schemas.microsoft.com/office/mac/drawingml/2011/main" xmlns="" val="0"/>
-            </a:ext>
-          </a:extLst>
-        </p:spPr>
-        <p:txBody>
-          <a:bodyPr/>
-          <a:lstStyle>
-            <a:lvl1pPr>
-              <a:defRPr sz="800">
-                <a:solidFill>
-                  <a:srgbClr val="6B7585"/>
-                </a:solidFill>
-              </a:defRPr>
-            </a:lvl1pPr>
-          </a:lstStyle>
-          <a:p>
-            <a:pPr algn="r"/>
-            <a:fld id="{F7021451-1387-4CA6-816F-3879F97B5CBC}" type="slidenum">
-              <a:rPr lang="en-US" b="0"/>
-              <a:t>18</a:t>
-            </a:fld>
-            <a:endParaRPr lang="en-US"/>
-          </a:p>
-        </p:txBody>
-      </p:sp>
-      <p:pic>
-        <p:nvPicPr>
-          <p:cNvPr id="26" name="cts logo" descr="cts-logo.png"/>
-          <p:cNvPicPr>
-            <a:picLocks noChangeAspect="1"/>
-          </p:cNvPicPr>
-          <p:nvPr/>
-        </p:nvPicPr>
-        <p:blipFill>
-          <a:blip r:embed="rId4"/>
-          <a:stretch>
-            <a:fillRect/>
-          </a:stretch>
-        </p:blipFill>
-        <p:spPr>
-          <a:xfrm>
-            <a:off x="7680959" y="182880"/>
-            <a:ext cx="960120" cy="539696"/>
-          </a:xfrm>
-          <a:prstGeom prst="rect">
-            <a:avLst/>
-          </a:prstGeom>
-        </p:spPr>
-      </p:pic>
-      <p:sp>
-        <p:nvSpPr>
-          <p:cNvPr id="4" name="Text 5b"/>
-          <p:cNvSpPr txBox="1"/>
-          <p:nvPr/>
-        </p:nvSpPr>
-        <p:spPr>
-          <a:xfrm>
-            <a:off x="4663440" y="3474719"/>
-            <a:ext cx="3703320" cy="1124712"/>
-          </a:xfrm>
-          <a:prstGeom prst="rect">
-            <a:avLst/>
-          </a:prstGeom>
-          <a:noFill/>
-          <a:ln/>
-        </p:spPr>
-        <p:txBody>
-          <a:bodyPr wrap="square" lIns="0" tIns="0" rIns="0" bIns="0" rtlCol="0" anchor="t">
-            <a:normAutofit fontScale="92500"/>
-          </a:bodyPr>
-          <a:lstStyle/>
-          <a:p>
-            <a:pPr marL="342900" indent="-342900">
-              <a:lnSpc>
-                <a:spcPts val="1150"/>
-              </a:lnSpc>
-              <a:spcAft>
-                <a:spcPts val="400"/>
-              </a:spcAft>
-              <a:buSzPct val="100000"/>
-              <a:buChar char="•"/>
-            </a:pPr>
-            <a:r>
-              <a:rPr lang="en-US" sz="1000">
-                <a:solidFill>
-                  <a:srgbClr val="3A4453"/>
-                </a:solidFill>
-              </a:rPr>
-              <a:t>Approximately $72k relates to shared overhead allocations. The allocation basis should be reviewed to confirm it appropriately reflects departmental activity.</a:t>
-            </a:r>
-            <a:endParaRPr lang="en-US" sz="900"/>
-          </a:p>
-          <a:p>
-            <a:pPr marL="342900" indent="-342900">
-              <a:lnSpc>
-                <a:spcPts val="1150"/>
-              </a:lnSpc>
-              <a:spcAft>
-                <a:spcPts val="400"/>
-              </a:spcAft>
-              <a:buSzPct val="100000"/>
-              <a:buChar char="•"/>
-            </a:pPr>
-            <a:r>
-              <a:rPr lang="en-US" sz="1000">
-                <a:solidFill>
-                  <a:srgbClr val="3A4453"/>
-                </a:solidFill>
-              </a:rPr>
-              <a:t>The team recorded 333 hours of leave and 241 billable hours, highlighting reduced available delivery capacity.</a:t>
-            </a:r>
-            <a:endParaRPr lang="en-US" sz="900"/>
           </a:p>
         </p:txBody>
       </p:sp>
@@ -10495,7 +10551,7 @@
                   <a:srgbClr val="6B7585"/>
                 </a:solidFill>
               </a:rPr>
-              <a:t>P&amp;L summary, the three months to date, and every department against budget</a:t>
+              <a:t>Profit and loss summary, revenue against budget, and the three year comparisons</a:t>
             </a:r>
             <a:endParaRPr lang="en-US" sz="1000"/>
           </a:p>
@@ -10509,7 +10565,7 @@
         </p:nvSpPr>
         <p:spPr>
           <a:xfrm>
-            <a:off x="502920" y="2057400"/>
+            <a:off x="502920" y="1965960"/>
             <a:ext cx="384048" cy="384048"/>
           </a:xfrm>
           <a:prstGeom prst="rect">
@@ -10536,7 +10592,7 @@
         </p:nvSpPr>
         <p:spPr>
           <a:xfrm>
-            <a:off x="502920" y="2057400"/>
+            <a:off x="502920" y="1965960"/>
             <a:ext cx="384048" cy="384048"/>
           </a:xfrm>
           <a:prstGeom prst="rect">
@@ -10572,7 +10628,7 @@
         </p:nvSpPr>
         <p:spPr>
           <a:xfrm>
-            <a:off x="1051560" y="2039112"/>
+            <a:off x="1051560" y="1947672"/>
             <a:ext cx="7589520" cy="237744"/>
           </a:xfrm>
           <a:prstGeom prst="rect">
@@ -10594,7 +10650,7 @@
                   <a:srgbClr val="242C39"/>
                 </a:solidFill>
               </a:rPr>
-              <a:t>Operating expenditure</a:t>
+              <a:t>Departmental performance</a:t>
             </a:r>
             <a:endParaRPr lang="en-US" sz="1300"/>
           </a:p>
@@ -10608,7 +10664,7 @@
         </p:nvSpPr>
         <p:spPr>
           <a:xfrm>
-            <a:off x="1051560" y="2258568"/>
+            <a:off x="1051560" y="2167128"/>
             <a:ext cx="7589520" cy="219456"/>
           </a:xfrm>
           <a:prstGeom prst="rect">
@@ -10630,7 +10686,7 @@
                   <a:srgbClr val="6B7585"/>
                 </a:solidFill>
               </a:rPr>
-              <a:t>Where the money goes: cost distribution, operating expense, labour and employment</a:t>
+              <a:t>Every department's result for September 2026 and how it was made</a:t>
             </a:r>
             <a:endParaRPr lang="en-US" sz="1000"/>
           </a:p>
@@ -10644,7 +10700,7 @@
         </p:nvSpPr>
         <p:spPr>
           <a:xfrm>
-            <a:off x="502920" y="2697480"/>
+            <a:off x="502920" y="2514600"/>
             <a:ext cx="384048" cy="384048"/>
           </a:xfrm>
           <a:prstGeom prst="rect">
@@ -10671,7 +10727,7 @@
         </p:nvSpPr>
         <p:spPr>
           <a:xfrm>
-            <a:off x="502920" y="2697480"/>
+            <a:off x="502920" y="2514600"/>
             <a:ext cx="384048" cy="384048"/>
           </a:xfrm>
           <a:prstGeom prst="rect">
@@ -10707,7 +10763,7 @@
         </p:nvSpPr>
         <p:spPr>
           <a:xfrm>
-            <a:off x="1051560" y="2679192"/>
+            <a:off x="1051560" y="2496312"/>
             <a:ext cx="7589520" cy="237744"/>
           </a:xfrm>
           <a:prstGeom prst="rect">
@@ -10729,7 +10785,7 @@
                   <a:srgbClr val="242C39"/>
                 </a:solidFill>
               </a:rPr>
-              <a:t>Customers and receivables</a:t>
+              <a:t>Operating expenditure</a:t>
             </a:r>
             <a:endParaRPr lang="en-US" sz="1300"/>
           </a:p>
@@ -10743,7 +10799,7 @@
         </p:nvSpPr>
         <p:spPr>
           <a:xfrm>
-            <a:off x="1051560" y="2898648"/>
+            <a:off x="1051560" y="2715768"/>
             <a:ext cx="7589520" cy="219456"/>
           </a:xfrm>
           <a:prstGeom prst="rect">
@@ -10765,7 +10821,7 @@
                   <a:srgbClr val="6B7585"/>
                 </a:solidFill>
               </a:rPr>
-              <a:t>Top ten customers, receivables and days sales outstanding</a:t>
+              <a:t>Where the money goes: cost distribution, operating expense, labour and employment</a:t>
             </a:r>
             <a:endParaRPr lang="en-US" sz="1000"/>
           </a:p>
@@ -10779,7 +10835,7 @@
         </p:nvSpPr>
         <p:spPr>
           <a:xfrm>
-            <a:off x="502920" y="3337560"/>
+            <a:off x="502920" y="3063239"/>
             <a:ext cx="384048" cy="384048"/>
           </a:xfrm>
           <a:prstGeom prst="rect">
@@ -10806,7 +10862,7 @@
         </p:nvSpPr>
         <p:spPr>
           <a:xfrm>
-            <a:off x="502920" y="3337560"/>
+            <a:off x="502920" y="3063239"/>
             <a:ext cx="384048" cy="384048"/>
           </a:xfrm>
           <a:prstGeom prst="rect">
@@ -10842,7 +10898,7 @@
         </p:nvSpPr>
         <p:spPr>
           <a:xfrm>
-            <a:off x="1051560" y="3319272"/>
+            <a:off x="1051560" y="3044951"/>
             <a:ext cx="7589520" cy="237744"/>
           </a:xfrm>
           <a:prstGeom prst="rect">
@@ -10864,7 +10920,7 @@
                   <a:srgbClr val="242C39"/>
                 </a:solidFill>
               </a:rPr>
-              <a:t>People and utilisation</a:t>
+              <a:t>Customers and receivables</a:t>
             </a:r>
             <a:endParaRPr lang="en-US" sz="1300"/>
           </a:p>
@@ -10878,7 +10934,7 @@
         </p:nvSpPr>
         <p:spPr>
           <a:xfrm>
-            <a:off x="1051560" y="3538728"/>
+            <a:off x="1051560" y="3264408"/>
             <a:ext cx="7589520" cy="219456"/>
           </a:xfrm>
           <a:prstGeom prst="rect">
@@ -10900,7 +10956,7 @@
                   <a:srgbClr val="6B7585"/>
                 </a:solidFill>
               </a:rPr>
-              <a:t>Chargeable hours by department and the profit they produce</a:t>
+              <a:t>Top ten customers, receivables and days sales outstanding</a:t>
             </a:r>
             <a:endParaRPr lang="en-US" sz="1000"/>
           </a:p>
@@ -10914,7 +10970,7 @@
         </p:nvSpPr>
         <p:spPr>
           <a:xfrm>
-            <a:off x="502920" y="3977640"/>
+            <a:off x="502920" y="3611880"/>
             <a:ext cx="384048" cy="384048"/>
           </a:xfrm>
           <a:prstGeom prst="rect">
@@ -10941,7 +10997,7 @@
         </p:nvSpPr>
         <p:spPr>
           <a:xfrm>
-            <a:off x="502920" y="3977640"/>
+            <a:off x="502920" y="3611880"/>
             <a:ext cx="384048" cy="384048"/>
           </a:xfrm>
           <a:prstGeom prst="rect">
@@ -10977,7 +11033,7 @@
         </p:nvSpPr>
         <p:spPr>
           <a:xfrm>
-            <a:off x="1051560" y="3959352"/>
+            <a:off x="1051560" y="3593592"/>
             <a:ext cx="7589520" cy="237744"/>
           </a:xfrm>
           <a:prstGeom prst="rect">
@@ -10999,7 +11055,7 @@
                   <a:srgbClr val="242C39"/>
                 </a:solidFill>
               </a:rPr>
-              <a:t>Budget and outlook</a:t>
+              <a:t>People and utilisation</a:t>
             </a:r>
             <a:endParaRPr lang="en-US" sz="1300"/>
           </a:p>
@@ -11013,7 +11069,7 @@
         </p:nvSpPr>
         <p:spPr>
           <a:xfrm>
-            <a:off x="1051560" y="4178808"/>
+            <a:off x="1051560" y="3813048"/>
             <a:ext cx="7589520" cy="219456"/>
           </a:xfrm>
           <a:prstGeom prst="rect">
@@ -11035,7 +11091,7 @@
                   <a:srgbClr val="6B7585"/>
                 </a:solidFill>
               </a:rPr>
-              <a:t>Revenue by month against budget, and what we do about it</a:t>
+              <a:t>Chargeable hours by department and the profit they produce</a:t>
             </a:r>
             <a:endParaRPr lang="en-US" sz="1000"/>
           </a:p>
@@ -11110,6 +11166,141 @@
           </a:prstGeom>
         </p:spPr>
       </p:pic>
+      <p:sp>
+        <p:nvSpPr>
+          <p:cNvPr id="20" name="Shape 22"/>
+          <p:cNvSpPr/>
+          <p:nvPr/>
+        </p:nvSpPr>
+        <p:spPr>
+          <a:xfrm>
+            <a:off x="502920" y="4160520"/>
+            <a:ext cx="384048" cy="384048"/>
+          </a:xfrm>
+          <a:prstGeom prst="rect">
+            <a:avLst/>
+          </a:prstGeom>
+          <a:solidFill>
+            <a:srgbClr val="242C39"/>
+          </a:solidFill>
+          <a:ln/>
+        </p:spPr>
+        <p:txBody>
+          <a:bodyPr/>
+          <a:lstStyle/>
+          <a:p>
+            <a:endParaRPr lang="en-AU"/>
+          </a:p>
+        </p:txBody>
+      </p:sp>
+      <p:sp>
+        <p:nvSpPr>
+          <p:cNvPr id="21" name="Text 23"/>
+          <p:cNvSpPr txBox="1"/>
+          <p:nvPr/>
+        </p:nvSpPr>
+        <p:spPr>
+          <a:xfrm>
+            <a:off x="502920" y="4160520"/>
+            <a:ext cx="384048" cy="384048"/>
+          </a:xfrm>
+          <a:prstGeom prst="rect">
+            <a:avLst/>
+          </a:prstGeom>
+          <a:noFill/>
+          <a:ln/>
+        </p:spPr>
+        <p:txBody>
+          <a:bodyPr wrap="square" lIns="0" tIns="0" rIns="0" bIns="0" rtlCol="0" anchor="ctr"/>
+          <a:lstStyle/>
+          <a:p>
+            <a:pPr marL="0" indent="0" algn="ctr">
+              <a:buNone/>
+            </a:pPr>
+            <a:r>
+              <a:rPr lang="en-US" sz="1100" b="1">
+                <a:solidFill>
+                  <a:srgbClr val="FFFFFF"/>
+                </a:solidFill>
+              </a:rPr>
+              <a:t>06</a:t>
+            </a:r>
+            <a:endParaRPr lang="en-US" sz="1100"/>
+          </a:p>
+        </p:txBody>
+      </p:sp>
+      <p:sp>
+        <p:nvSpPr>
+          <p:cNvPr id="22" name="Text 24"/>
+          <p:cNvSpPr txBox="1"/>
+          <p:nvPr/>
+        </p:nvSpPr>
+        <p:spPr>
+          <a:xfrm>
+            <a:off x="1051560" y="4142232"/>
+            <a:ext cx="7589520" cy="237744"/>
+          </a:xfrm>
+          <a:prstGeom prst="rect">
+            <a:avLst/>
+          </a:prstGeom>
+          <a:noFill/>
+          <a:ln/>
+        </p:spPr>
+        <p:txBody>
+          <a:bodyPr wrap="square" lIns="0" tIns="0" rIns="0" bIns="0" rtlCol="0" anchor="ctr"/>
+          <a:lstStyle/>
+          <a:p>
+            <a:pPr marL="0" indent="0">
+              <a:buNone/>
+            </a:pPr>
+            <a:r>
+              <a:rPr lang="en-US" sz="1300" b="1">
+                <a:solidFill>
+                  <a:srgbClr val="242C39"/>
+                </a:solidFill>
+              </a:rPr>
+              <a:t>Budget and outlook</a:t>
+            </a:r>
+            <a:endParaRPr lang="en-US" sz="1300"/>
+          </a:p>
+        </p:txBody>
+      </p:sp>
+      <p:sp>
+        <p:nvSpPr>
+          <p:cNvPr id="23" name="Text 25"/>
+          <p:cNvSpPr txBox="1"/>
+          <p:nvPr/>
+        </p:nvSpPr>
+        <p:spPr>
+          <a:xfrm>
+            <a:off x="1051560" y="4361688"/>
+            <a:ext cx="7589520" cy="219456"/>
+          </a:xfrm>
+          <a:prstGeom prst="rect">
+            <a:avLst/>
+          </a:prstGeom>
+          <a:noFill/>
+          <a:ln/>
+        </p:spPr>
+        <p:txBody>
+          <a:bodyPr wrap="square" lIns="0" tIns="0" rIns="0" bIns="0" rtlCol="0" anchor="ctr"/>
+          <a:lstStyle/>
+          <a:p>
+            <a:pPr marL="0" indent="0">
+              <a:buNone/>
+            </a:pPr>
+            <a:r>
+              <a:rPr lang="en-US" sz="1000">
+                <a:solidFill>
+                  <a:srgbClr val="6B7585"/>
+                </a:solidFill>
+              </a:rPr>
+              <a:t>Revenue by month against budget, and what we do about it</a:t>
+            </a:r>
+            <a:endParaRPr lang="en-US" sz="1000"/>
+          </a:p>
+        </p:txBody>
+      </p:sp>
     </p:spTree>
   </p:cSld>
   <p:clrMapOvr>
@@ -11119,6 +11310,412 @@
 </file>
 
 <file path=ppt/slides/slide20.xml><?xml version="1.0" encoding="utf-8"?>
+<p:sld xmlns:a="http://schemas.openxmlformats.org/drawingml/2006/main" xmlns:r="http://schemas.openxmlformats.org/officeDocument/2006/relationships" xmlns:p="http://schemas.openxmlformats.org/presentationml/2006/main">
+  <p:cSld name="Slide 10">
+    <p:spTree>
+      <p:nvGrpSpPr>
+        <p:cNvPr id="1" name=""/>
+        <p:cNvGrpSpPr/>
+        <p:nvPr/>
+      </p:nvGrpSpPr>
+      <p:grpSpPr>
+        <a:xfrm>
+          <a:off x="0" y="0"/>
+          <a:ext cx="0" cy="0"/>
+          <a:chOff x="0" y="0"/>
+          <a:chExt cx="0" cy="0"/>
+        </a:xfrm>
+      </p:grpSpPr>
+      <p:pic>
+        <p:nvPicPr>
+          <p:cNvPr id="27" name="snip dept_Events" descr="dept_Events.png"/>
+          <p:cNvPicPr>
+            <a:picLocks noChangeAspect="1"/>
+          </p:cNvPicPr>
+          <p:nvPr/>
+        </p:nvPicPr>
+        <p:blipFill>
+          <a:blip r:embed="rId3"/>
+          <a:stretch>
+            <a:fillRect/>
+          </a:stretch>
+        </p:blipFill>
+        <p:spPr>
+          <a:xfrm>
+            <a:off x="974377" y="1005840"/>
+            <a:ext cx="7195245" cy="2130551"/>
+          </a:xfrm>
+          <a:prstGeom prst="rect">
+            <a:avLst/>
+          </a:prstGeom>
+        </p:spPr>
+      </p:pic>
+      <p:sp>
+        <p:nvSpPr>
+          <p:cNvPr id="2" name="Text 0"/>
+          <p:cNvSpPr txBox="1"/>
+          <p:nvPr/>
+        </p:nvSpPr>
+        <p:spPr>
+          <a:xfrm>
+            <a:off x="502920" y="365760"/>
+            <a:ext cx="6400800" cy="274320"/>
+          </a:xfrm>
+          <a:prstGeom prst="rect">
+            <a:avLst/>
+          </a:prstGeom>
+          <a:noFill/>
+          <a:ln/>
+        </p:spPr>
+        <p:txBody>
+          <a:bodyPr wrap="square" lIns="0" tIns="0" rIns="0" bIns="0" rtlCol="0" anchor="ctr"/>
+          <a:lstStyle/>
+          <a:p>
+            <a:pPr marL="0" indent="0">
+              <a:buNone/>
+            </a:pPr>
+            <a:r>
+              <a:rPr lang="en-US" sz="950" b="1" kern="0" spc="220">
+                <a:solidFill>
+                  <a:srgbClr val="122B82"/>
+                </a:solidFill>
+              </a:rPr>
+              <a:t>DEPARTMENTAL PERFORMANCE</a:t>
+            </a:r>
+            <a:endParaRPr lang="en-US" sz="950"/>
+          </a:p>
+        </p:txBody>
+      </p:sp>
+      <p:sp>
+        <p:nvSpPr>
+          <p:cNvPr id="3" name="Text 1"/>
+          <p:cNvSpPr txBox="1"/>
+          <p:nvPr/>
+        </p:nvSpPr>
+        <p:spPr>
+          <a:xfrm>
+            <a:off x="502920" y="640080"/>
+            <a:ext cx="7315200" cy="365760"/>
+          </a:xfrm>
+          <a:prstGeom prst="rect">
+            <a:avLst/>
+          </a:prstGeom>
+          <a:noFill/>
+          <a:ln/>
+        </p:spPr>
+        <p:txBody>
+          <a:bodyPr wrap="square" lIns="0" tIns="0" rIns="0" bIns="0" rtlCol="0" anchor="ctr"/>
+          <a:lstStyle/>
+          <a:p>
+            <a:pPr marL="0" indent="0" algn="ctr">
+              <a:buNone/>
+            </a:pPr>
+            <a:r>
+              <a:rPr lang="en-US" sz="2200" b="1">
+                <a:solidFill>
+                  <a:srgbClr val="242C39"/>
+                </a:solidFill>
+              </a:rPr>
+              <a:t>Events, September 2026</a:t>
+            </a:r>
+            <a:endParaRPr lang="en-US" sz="2700"/>
+          </a:p>
+        </p:txBody>
+      </p:sp>
+      <p:sp>
+        <p:nvSpPr>
+          <p:cNvPr id="6" name="commentary panel"/>
+          <p:cNvSpPr/>
+          <p:nvPr/>
+        </p:nvSpPr>
+        <p:spPr>
+          <a:xfrm>
+            <a:off x="502920" y="3227831"/>
+            <a:ext cx="8138160" cy="1399032"/>
+          </a:xfrm>
+          <a:prstGeom prst="rect">
+            <a:avLst/>
+          </a:prstGeom>
+          <a:solidFill>
+            <a:srgbClr val="E8F9F8"/>
+          </a:solidFill>
+          <a:ln/>
+        </p:spPr>
+        <p:txBody>
+          <a:bodyPr/>
+          <a:lstStyle/>
+          <a:p>
+            <a:endParaRPr lang="en-AU"/>
+          </a:p>
+        </p:txBody>
+      </p:sp>
+      <p:sp>
+        <p:nvSpPr>
+          <p:cNvPr id="7" name="Text 4"/>
+          <p:cNvSpPr txBox="1"/>
+          <p:nvPr/>
+        </p:nvSpPr>
+        <p:spPr>
+          <a:xfrm>
+            <a:off x="685800" y="3300983"/>
+            <a:ext cx="2743200" cy="228600"/>
+          </a:xfrm>
+          <a:prstGeom prst="rect">
+            <a:avLst/>
+          </a:prstGeom>
+          <a:noFill/>
+          <a:ln/>
+        </p:spPr>
+        <p:txBody>
+          <a:bodyPr wrap="square" lIns="0" tIns="0" rIns="0" bIns="0" rtlCol="0" anchor="ctr"/>
+          <a:lstStyle/>
+          <a:p>
+            <a:pPr marL="0" indent="0">
+              <a:buNone/>
+            </a:pPr>
+            <a:r>
+              <a:rPr lang="en-US" sz="900" b="1" kern="0" spc="180">
+                <a:solidFill>
+                  <a:srgbClr val="005358"/>
+                </a:solidFill>
+              </a:rPr>
+              <a:t>COMMENTARY</a:t>
+            </a:r>
+            <a:endParaRPr lang="en-US" sz="900"/>
+          </a:p>
+        </p:txBody>
+      </p:sp>
+      <p:sp>
+        <p:nvSpPr>
+          <p:cNvPr id="8" name="Text 5"/>
+          <p:cNvSpPr txBox="1"/>
+          <p:nvPr/>
+        </p:nvSpPr>
+        <p:spPr>
+          <a:xfrm>
+            <a:off x="685800" y="3474719"/>
+            <a:ext cx="3703320" cy="1124712"/>
+          </a:xfrm>
+          <a:prstGeom prst="rect">
+            <a:avLst/>
+          </a:prstGeom>
+          <a:noFill/>
+          <a:ln/>
+        </p:spPr>
+        <p:txBody>
+          <a:bodyPr wrap="square" lIns="0" tIns="0" rIns="0" bIns="0" rtlCol="0" anchor="t">
+            <a:normAutofit fontScale="92500"/>
+          </a:bodyPr>
+          <a:lstStyle/>
+          <a:p>
+            <a:pPr marL="342900" indent="-342900">
+              <a:lnSpc>
+                <a:spcPts val="1150"/>
+              </a:lnSpc>
+              <a:spcAft>
+                <a:spcPts val="400"/>
+              </a:spcAft>
+              <a:buSzPct val="100000"/>
+              <a:buChar char="•"/>
+            </a:pPr>
+            <a:r>
+              <a:rPr lang="en-US" sz="1000">
+                <a:solidFill>
+                  <a:srgbClr val="3A4453"/>
+                </a:solidFill>
+              </a:rPr>
+              <a:t>Events generated $73k revenue against a $66k budget for September.</a:t>
+            </a:r>
+            <a:endParaRPr lang="en-US" sz="900"/>
+          </a:p>
+          <a:p>
+            <a:pPr marL="342900" indent="-342900">
+              <a:lnSpc>
+                <a:spcPts val="1150"/>
+              </a:lnSpc>
+              <a:spcAft>
+                <a:spcPts val="400"/>
+              </a:spcAft>
+              <a:buSzPct val="100000"/>
+              <a:buChar char="•"/>
+            </a:pPr>
+            <a:r>
+              <a:rPr lang="en-US" sz="1000">
+                <a:solidFill>
+                  <a:srgbClr val="3A4453"/>
+                </a:solidFill>
+              </a:rPr>
+              <a:t>Gross margin was 77.6%, a strong result compared with other departments.</a:t>
+            </a:r>
+            <a:endParaRPr lang="en-US" sz="900"/>
+          </a:p>
+          <a:p>
+            <a:pPr marL="342900" indent="-342900">
+              <a:lnSpc>
+                <a:spcPts val="1150"/>
+              </a:lnSpc>
+              <a:spcAft>
+                <a:spcPts val="400"/>
+              </a:spcAft>
+              <a:buSzPct val="100000"/>
+              <a:buChar char="•"/>
+            </a:pPr>
+            <a:r>
+              <a:rPr lang="en-US" sz="1000">
+                <a:solidFill>
+                  <a:srgbClr val="3A4453"/>
+                </a:solidFill>
+              </a:rPr>
+              <a:t>Despite this, Events recorded a $54k loss after $111k of allocated overheads.</a:t>
+            </a:r>
+            <a:endParaRPr lang="en-US" sz="900"/>
+          </a:p>
+        </p:txBody>
+      </p:sp>
+      <p:sp>
+        <p:nvSpPr>
+          <p:cNvPr id="25" name="Slide Number Placeholder 0"/>
+          <p:cNvSpPr>
+            <a:spLocks noGrp="1"/>
+          </p:cNvSpPr>
+          <p:nvPr>
+            <p:ph type="sldNum" sz="quarter" idx="4294967295"/>
+          </p:nvPr>
+        </p:nvSpPr>
+        <p:spPr>
+          <a:xfrm>
+            <a:off x="8092440" y="4736592"/>
+            <a:ext cx="548640" cy="228600"/>
+          </a:xfrm>
+          <a:prstGeom prst="rect">
+            <a:avLst/>
+          </a:prstGeom>
+          <a:extLst>
+            <a:ext uri="{C572A759-6A51-4108-AA02-DFA0A04FC94B}">
+              <ma14:wrappingTextBoxFlag xmlns:ma14="http://schemas.microsoft.com/office/mac/drawingml/2011/main" xmlns="" val="0"/>
+            </a:ext>
+          </a:extLst>
+        </p:spPr>
+        <p:txBody>
+          <a:bodyPr/>
+          <a:lstStyle>
+            <a:lvl1pPr>
+              <a:defRPr sz="800">
+                <a:solidFill>
+                  <a:srgbClr val="6B7585"/>
+                </a:solidFill>
+              </a:defRPr>
+            </a:lvl1pPr>
+          </a:lstStyle>
+          <a:p>
+            <a:pPr algn="r"/>
+            <a:fld id="{F7021451-1387-4CA6-816F-3879F97B5CBC}" type="slidenum">
+              <a:rPr lang="en-US" b="0"/>
+              <a:t>18</a:t>
+            </a:fld>
+            <a:endParaRPr lang="en-US"/>
+          </a:p>
+        </p:txBody>
+      </p:sp>
+      <p:pic>
+        <p:nvPicPr>
+          <p:cNvPr id="26" name="cts logo" descr="cts-logo.png"/>
+          <p:cNvPicPr>
+            <a:picLocks noChangeAspect="1"/>
+          </p:cNvPicPr>
+          <p:nvPr/>
+        </p:nvPicPr>
+        <p:blipFill>
+          <a:blip r:embed="rId4"/>
+          <a:stretch>
+            <a:fillRect/>
+          </a:stretch>
+        </p:blipFill>
+        <p:spPr>
+          <a:xfrm>
+            <a:off x="7680959" y="182880"/>
+            <a:ext cx="960120" cy="539696"/>
+          </a:xfrm>
+          <a:prstGeom prst="rect">
+            <a:avLst/>
+          </a:prstGeom>
+        </p:spPr>
+      </p:pic>
+      <p:sp>
+        <p:nvSpPr>
+          <p:cNvPr id="4" name="Text 5b"/>
+          <p:cNvSpPr txBox="1"/>
+          <p:nvPr/>
+        </p:nvSpPr>
+        <p:spPr>
+          <a:xfrm>
+            <a:off x="4663440" y="3474719"/>
+            <a:ext cx="3703320" cy="1124712"/>
+          </a:xfrm>
+          <a:prstGeom prst="rect">
+            <a:avLst/>
+          </a:prstGeom>
+          <a:noFill/>
+          <a:ln/>
+        </p:spPr>
+        <p:txBody>
+          <a:bodyPr wrap="square" lIns="0" tIns="0" rIns="0" bIns="0" rtlCol="0" anchor="t">
+            <a:normAutofit fontScale="92500"/>
+          </a:bodyPr>
+          <a:lstStyle/>
+          <a:p>
+            <a:pPr marL="342900" indent="-342900">
+              <a:lnSpc>
+                <a:spcPts val="1150"/>
+              </a:lnSpc>
+              <a:spcAft>
+                <a:spcPts val="400"/>
+              </a:spcAft>
+              <a:buSzPct val="100000"/>
+              <a:buChar char="•"/>
+            </a:pPr>
+            <a:r>
+              <a:rPr lang="en-US" sz="1000">
+                <a:solidFill>
+                  <a:srgbClr val="3A4453"/>
+                </a:solidFill>
+              </a:rPr>
+              <a:t>Approximately $72k relates to shared overhead allocations. The allocation basis should be reviewed to confirm it appropriately reflects departmental activity.</a:t>
+            </a:r>
+            <a:endParaRPr lang="en-US" sz="900"/>
+          </a:p>
+          <a:p>
+            <a:pPr marL="342900" indent="-342900">
+              <a:lnSpc>
+                <a:spcPts val="1150"/>
+              </a:lnSpc>
+              <a:spcAft>
+                <a:spcPts val="400"/>
+              </a:spcAft>
+              <a:buSzPct val="100000"/>
+              <a:buChar char="•"/>
+            </a:pPr>
+            <a:r>
+              <a:rPr lang="en-US" sz="1000">
+                <a:solidFill>
+                  <a:srgbClr val="3A4453"/>
+                </a:solidFill>
+              </a:rPr>
+              <a:t>The team recorded 333 hours of leave and 241 billable hours, highlighting reduced available delivery capacity.</a:t>
+            </a:r>
+            <a:endParaRPr lang="en-US" sz="900"/>
+          </a:p>
+        </p:txBody>
+      </p:sp>
+    </p:spTree>
+  </p:cSld>
+  <p:clrMapOvr>
+    <a:masterClrMapping/>
+  </p:clrMapOvr>
+</p:sld>
+</file>
+
+<file path=ppt/slides/slide21.xml><?xml version="1.0" encoding="utf-8"?>
 <p:sld xmlns:a="http://schemas.openxmlformats.org/drawingml/2006/main" xmlns:r="http://schemas.openxmlformats.org/officeDocument/2006/relationships" xmlns:p="http://schemas.openxmlformats.org/presentationml/2006/main">
   <p:cSld name="Slide 11">
     <p:spTree>
@@ -11189,7 +11786,7 @@
                   <a:srgbClr val="122B82"/>
                 </a:solidFill>
               </a:rPr>
-              <a:t>FINANCIAL PERFORMANCE</a:t>
+              <a:t>DEPARTMENTAL PERFORMANCE</a:t>
             </a:r>
             <a:endParaRPr lang="en-US" sz="950"/>
           </a:p>
@@ -11524,7 +12121,7 @@
 </p:sld>
 </file>
 
-<file path=ppt/slides/slide21.xml><?xml version="1.0" encoding="utf-8"?>
+<file path=ppt/slides/slide22.xml><?xml version="1.0" encoding="utf-8"?>
 <p:sld xmlns:a="http://schemas.openxmlformats.org/drawingml/2006/main" xmlns:r="http://schemas.openxmlformats.org/officeDocument/2006/relationships" xmlns:p="http://schemas.openxmlformats.org/presentationml/2006/main">
   <p:cSld name="Slide 12">
     <p:spTree>
@@ -11595,7 +12192,7 @@
                   <a:srgbClr val="122B82"/>
                 </a:solidFill>
               </a:rPr>
-              <a:t>FINANCIAL PERFORMANCE</a:t>
+              <a:t>DEPARTMENTAL PERFORMANCE</a:t>
             </a:r>
             <a:endParaRPr lang="en-US" sz="950"/>
           </a:p>
@@ -11930,7 +12527,7 @@
 </p:sld>
 </file>
 
-<file path=ppt/slides/slide22.xml><?xml version="1.0" encoding="utf-8"?>
+<file path=ppt/slides/slide23.xml><?xml version="1.0" encoding="utf-8"?>
 <p:sld xmlns:a="http://schemas.openxmlformats.org/drawingml/2006/main" xmlns:r="http://schemas.openxmlformats.org/officeDocument/2006/relationships" xmlns:p="http://schemas.openxmlformats.org/presentationml/2006/main">
   <p:cSld name="Slide 13">
     <p:spTree>
@@ -12001,7 +12598,7 @@
                   <a:srgbClr val="122B82"/>
                 </a:solidFill>
               </a:rPr>
-              <a:t>FINANCIAL PERFORMANCE</a:t>
+              <a:t>DEPARTMENTAL PERFORMANCE</a:t>
             </a:r>
             <a:endParaRPr lang="en-US" sz="950"/>
           </a:p>
@@ -12336,7 +12933,7 @@
 </p:sld>
 </file>
 
-<file path=ppt/slides/slide23.xml><?xml version="1.0" encoding="utf-8"?>
+<file path=ppt/slides/slide24.xml><?xml version="1.0" encoding="utf-8"?>
 <p:sld xmlns:a="http://schemas.openxmlformats.org/drawingml/2006/main" xmlns:r="http://schemas.openxmlformats.org/officeDocument/2006/relationships" xmlns:p="http://schemas.openxmlformats.org/presentationml/2006/main">
   <p:cSld name="Slide 14">
     <p:spTree>
@@ -12407,7 +13004,7 @@
                   <a:srgbClr val="122B82"/>
                 </a:solidFill>
               </a:rPr>
-              <a:t>FINANCIAL PERFORMANCE</a:t>
+              <a:t>DEPARTMENTAL PERFORMANCE</a:t>
             </a:r>
             <a:endParaRPr lang="en-US" sz="950"/>
           </a:p>
@@ -12742,7 +13339,7 @@
 </p:sld>
 </file>
 
-<file path=ppt/slides/slide24.xml><?xml version="1.0" encoding="utf-8"?>
+<file path=ppt/slides/slide25.xml><?xml version="1.0" encoding="utf-8"?>
 <p:sld xmlns:a="http://schemas.openxmlformats.org/drawingml/2006/main" xmlns:r="http://schemas.openxmlformats.org/officeDocument/2006/relationships" xmlns:p="http://schemas.openxmlformats.org/presentationml/2006/main">
   <p:cSld name="Slide 15">
     <p:spTree>
@@ -12903,7 +13500,7 @@
                   <a:srgbClr val="242C39"/>
                 </a:solidFill>
               </a:rPr>
-              <a:t>02</a:t>
+              <a:t>03</a:t>
             </a:r>
             <a:endParaRPr lang="en-US" sz="2600"/>
           </a:p>
@@ -13025,7 +13622,7 @@
 </p:sld>
 </file>
 
-<file path=ppt/slides/slide25.xml><?xml version="1.0" encoding="utf-8"?>
+<file path=ppt/slides/slide26.xml><?xml version="1.0" encoding="utf-8"?>
 <p:sld xmlns:a="http://schemas.openxmlformats.org/drawingml/2006/main" xmlns:r="http://schemas.openxmlformats.org/officeDocument/2006/relationships" xmlns:p="http://schemas.openxmlformats.org/presentationml/2006/main">
   <p:cSld name="Slide 16">
     <p:spTree>
@@ -13431,7 +14028,7 @@
 </p:sld>
 </file>
 
-<file path=ppt/slides/slide26.xml><?xml version="1.0" encoding="utf-8"?>
+<file path=ppt/slides/slide27.xml><?xml version="1.0" encoding="utf-8"?>
 <p:sld xmlns:a="http://schemas.openxmlformats.org/drawingml/2006/main" xmlns:r="http://schemas.openxmlformats.org/officeDocument/2006/relationships" xmlns:p="http://schemas.openxmlformats.org/presentationml/2006/main">
   <p:cSld name="Slide 17">
     <p:spTree>
@@ -13837,7 +14434,7 @@
 </p:sld>
 </file>
 
-<file path=ppt/slides/slide27.xml><?xml version="1.0" encoding="utf-8"?>
+<file path=ppt/slides/slide28.xml><?xml version="1.0" encoding="utf-8"?>
 <p:sld xmlns:a="http://schemas.openxmlformats.org/drawingml/2006/main" xmlns:r="http://schemas.openxmlformats.org/officeDocument/2006/relationships" xmlns:p="http://schemas.openxmlformats.org/presentationml/2006/main">
   <p:cSld name="Slide 18">
     <p:spTree>
@@ -14243,7 +14840,7 @@
 </p:sld>
 </file>
 
-<file path=ppt/slides/slide28.xml><?xml version="1.0" encoding="utf-8"?>
+<file path=ppt/slides/slide29.xml><?xml version="1.0" encoding="utf-8"?>
 <p:sld xmlns:a="http://schemas.openxmlformats.org/drawingml/2006/main" xmlns:r="http://schemas.openxmlformats.org/officeDocument/2006/relationships" xmlns:p="http://schemas.openxmlformats.org/presentationml/2006/main">
   <p:cSld name="Slide 19">
     <p:spTree>
@@ -14620,289 +15217,6 @@
           </a:prstGeom>
         </p:spPr>
       </p:pic>
-    </p:spTree>
-  </p:cSld>
-  <p:clrMapOvr>
-    <a:masterClrMapping/>
-  </p:clrMapOvr>
-</p:sld>
-</file>
-
-<file path=ppt/slides/slide29.xml><?xml version="1.0" encoding="utf-8"?>
-<p:sld xmlns:a="http://schemas.openxmlformats.org/drawingml/2006/main" xmlns:r="http://schemas.openxmlformats.org/officeDocument/2006/relationships" xmlns:p="http://schemas.openxmlformats.org/presentationml/2006/main">
-  <p:cSld name="Slide 20">
-    <p:spTree>
-      <p:nvGrpSpPr>
-        <p:cNvPr id="1" name=""/>
-        <p:cNvGrpSpPr/>
-        <p:nvPr/>
-      </p:nvGrpSpPr>
-      <p:grpSpPr>
-        <a:xfrm>
-          <a:off x="0" y="0"/>
-          <a:ext cx="0" cy="0"/>
-          <a:chOff x="0" y="0"/>
-          <a:chExt cx="0" cy="0"/>
-        </a:xfrm>
-      </p:grpSpPr>
-      <p:sp>
-        <p:nvSpPr>
-          <p:cNvPr id="2" name="dot 2"/>
-          <p:cNvSpPr/>
-          <p:nvPr/>
-        </p:nvSpPr>
-        <p:spPr>
-          <a:xfrm>
-            <a:off x="6355080" y="2697480"/>
-            <a:ext cx="2240280" cy="2240280"/>
-          </a:xfrm>
-          <a:prstGeom prst="ellipse">
-            <a:avLst/>
-          </a:prstGeom>
-          <a:solidFill>
-            <a:srgbClr val="F33844">
-              <a:alpha val="55000"/>
-            </a:srgbClr>
-          </a:solidFill>
-          <a:ln/>
-        </p:spPr>
-        <p:txBody>
-          <a:bodyPr/>
-          <a:lstStyle/>
-          <a:p>
-            <a:endParaRPr lang="en-AU"/>
-          </a:p>
-        </p:txBody>
-      </p:sp>
-      <p:sp>
-        <p:nvSpPr>
-          <p:cNvPr id="8" name="dot 1"/>
-          <p:cNvSpPr/>
-          <p:nvPr/>
-        </p:nvSpPr>
-        <p:spPr>
-          <a:xfrm>
-            <a:off x="7086600" y="1828800"/>
-            <a:ext cx="1783080" cy="1783080"/>
-          </a:xfrm>
-          <a:prstGeom prst="ellipse">
-            <a:avLst/>
-          </a:prstGeom>
-          <a:solidFill>
-            <a:srgbClr val="6D71FF">
-              <a:alpha val="55000"/>
-            </a:srgbClr>
-          </a:solidFill>
-          <a:ln/>
-        </p:spPr>
-        <p:txBody>
-          <a:bodyPr/>
-          <a:lstStyle/>
-          <a:p>
-            <a:endParaRPr lang="en-AU"/>
-          </a:p>
-        </p:txBody>
-      </p:sp>
-      <p:sp>
-        <p:nvSpPr>
-          <p:cNvPr id="9" name="dot 0"/>
-          <p:cNvSpPr/>
-          <p:nvPr/>
-        </p:nvSpPr>
-        <p:spPr>
-          <a:xfrm>
-            <a:off x="6126480" y="914400"/>
-            <a:ext cx="2148840" cy="2148840"/>
-          </a:xfrm>
-          <a:prstGeom prst="ellipse">
-            <a:avLst/>
-          </a:prstGeom>
-          <a:solidFill>
-            <a:srgbClr val="3FD0C9">
-              <a:alpha val="55000"/>
-            </a:srgbClr>
-          </a:solidFill>
-          <a:ln/>
-        </p:spPr>
-        <p:txBody>
-          <a:bodyPr/>
-          <a:lstStyle/>
-          <a:p>
-            <a:endParaRPr lang="en-AU"/>
-          </a:p>
-        </p:txBody>
-      </p:sp>
-      <p:sp>
-        <p:nvSpPr>
-          <p:cNvPr id="3" name="Shape 1"/>
-          <p:cNvSpPr/>
-          <p:nvPr/>
-        </p:nvSpPr>
-        <p:spPr>
-          <a:xfrm>
-            <a:off x="502920" y="1874520"/>
-            <a:ext cx="868680" cy="868680"/>
-          </a:xfrm>
-          <a:prstGeom prst="rect">
-            <a:avLst/>
-          </a:prstGeom>
-          <a:solidFill>
-            <a:srgbClr val="3FD0C9"/>
-          </a:solidFill>
-          <a:ln/>
-        </p:spPr>
-        <p:txBody>
-          <a:bodyPr/>
-          <a:lstStyle/>
-          <a:p>
-            <a:endParaRPr lang="en-AU"/>
-          </a:p>
-        </p:txBody>
-      </p:sp>
-      <p:sp>
-        <p:nvSpPr>
-          <p:cNvPr id="4" name="Text 2"/>
-          <p:cNvSpPr txBox="1"/>
-          <p:nvPr/>
-        </p:nvSpPr>
-        <p:spPr>
-          <a:xfrm>
-            <a:off x="502920" y="1874520"/>
-            <a:ext cx="868680" cy="868680"/>
-          </a:xfrm>
-          <a:prstGeom prst="rect">
-            <a:avLst/>
-          </a:prstGeom>
-          <a:noFill/>
-          <a:ln/>
-        </p:spPr>
-        <p:txBody>
-          <a:bodyPr wrap="square" lIns="0" tIns="0" rIns="0" bIns="0" rtlCol="0" anchor="ctr"/>
-          <a:lstStyle/>
-          <a:p>
-            <a:pPr marL="0" indent="0" algn="ctr">
-              <a:buNone/>
-            </a:pPr>
-            <a:r>
-              <a:rPr lang="en-US" sz="2200" b="1">
-                <a:solidFill>
-                  <a:srgbClr val="242C39"/>
-                </a:solidFill>
-              </a:rPr>
-              <a:t>03</a:t>
-            </a:r>
-            <a:endParaRPr lang="en-US" sz="2600"/>
-          </a:p>
-        </p:txBody>
-      </p:sp>
-      <p:sp>
-        <p:nvSpPr>
-          <p:cNvPr id="5" name="Text 3"/>
-          <p:cNvSpPr txBox="1"/>
-          <p:nvPr/>
-        </p:nvSpPr>
-        <p:spPr>
-          <a:xfrm>
-            <a:off x="502920" y="411480"/>
-            <a:ext cx="3657600" cy="274320"/>
-          </a:xfrm>
-          <a:prstGeom prst="rect">
-            <a:avLst/>
-          </a:prstGeom>
-          <a:noFill/>
-          <a:ln/>
-        </p:spPr>
-        <p:txBody>
-          <a:bodyPr wrap="square" lIns="0" tIns="0" rIns="0" bIns="0" rtlCol="0" anchor="ctr"/>
-          <a:lstStyle/>
-          <a:p>
-            <a:pPr marL="0" indent="0">
-              <a:buNone/>
-            </a:pPr>
-            <a:r>
-              <a:rPr lang="en-US" sz="950" b="1" kern="0" spc="220">
-                <a:solidFill>
-                  <a:srgbClr val="3FD0C9"/>
-                </a:solidFill>
-              </a:rPr>
-              <a:t>SECTION</a:t>
-            </a:r>
-            <a:endParaRPr lang="en-US" sz="950"/>
-          </a:p>
-        </p:txBody>
-      </p:sp>
-      <p:sp>
-        <p:nvSpPr>
-          <p:cNvPr id="6" name="Text 4"/>
-          <p:cNvSpPr txBox="1"/>
-          <p:nvPr/>
-        </p:nvSpPr>
-        <p:spPr>
-          <a:xfrm>
-            <a:off x="1600200" y="1874519"/>
-            <a:ext cx="5943600" cy="502920"/>
-          </a:xfrm>
-          <a:prstGeom prst="rect">
-            <a:avLst/>
-          </a:prstGeom>
-          <a:noFill/>
-          <a:ln/>
-        </p:spPr>
-        <p:txBody>
-          <a:bodyPr wrap="square" lIns="0" tIns="0" rIns="0" bIns="0" rtlCol="0" anchor="ctr"/>
-          <a:lstStyle/>
-          <a:p>
-            <a:pPr marL="0" indent="0">
-              <a:buNone/>
-            </a:pPr>
-            <a:r>
-              <a:rPr lang="en-US" sz="2300" b="1">
-                <a:solidFill>
-                  <a:srgbClr val="FFFFFF"/>
-                </a:solidFill>
-              </a:rPr>
-              <a:t>Customers and receivables</a:t>
-            </a:r>
-            <a:endParaRPr lang="en-US" sz="2800"/>
-          </a:p>
-        </p:txBody>
-      </p:sp>
-      <p:sp>
-        <p:nvSpPr>
-          <p:cNvPr id="7" name="Text 5"/>
-          <p:cNvSpPr txBox="1"/>
-          <p:nvPr/>
-        </p:nvSpPr>
-        <p:spPr>
-          <a:xfrm>
-            <a:off x="1600200" y="2395728"/>
-            <a:ext cx="5943600" cy="347472"/>
-          </a:xfrm>
-          <a:prstGeom prst="rect">
-            <a:avLst/>
-          </a:prstGeom>
-          <a:noFill/>
-          <a:ln/>
-        </p:spPr>
-        <p:txBody>
-          <a:bodyPr wrap="square" lIns="0" tIns="0" rIns="0" bIns="0" rtlCol="0" anchor="ctr"/>
-          <a:lstStyle/>
-          <a:p>
-            <a:pPr marL="0" indent="0">
-              <a:buNone/>
-            </a:pPr>
-            <a:r>
-              <a:rPr lang="en-US" sz="1200">
-                <a:solidFill>
-                  <a:srgbClr val="C9CED6"/>
-                </a:solidFill>
-              </a:rPr>
-              <a:t>Who pays us, how much, and how slowly</a:t>
-            </a:r>
-            <a:endParaRPr lang="en-US" sz="1200"/>
-          </a:p>
-        </p:txBody>
-      </p:sp>
     </p:spTree>
   </p:cSld>
   <p:clrMapOvr>
@@ -17165,6 +17479,289 @@
 
 <file path=ppt/slides/slide30.xml><?xml version="1.0" encoding="utf-8"?>
 <p:sld xmlns:a="http://schemas.openxmlformats.org/drawingml/2006/main" xmlns:r="http://schemas.openxmlformats.org/officeDocument/2006/relationships" xmlns:p="http://schemas.openxmlformats.org/presentationml/2006/main">
+  <p:cSld name="Slide 20">
+    <p:spTree>
+      <p:nvGrpSpPr>
+        <p:cNvPr id="1" name=""/>
+        <p:cNvGrpSpPr/>
+        <p:nvPr/>
+      </p:nvGrpSpPr>
+      <p:grpSpPr>
+        <a:xfrm>
+          <a:off x="0" y="0"/>
+          <a:ext cx="0" cy="0"/>
+          <a:chOff x="0" y="0"/>
+          <a:chExt cx="0" cy="0"/>
+        </a:xfrm>
+      </p:grpSpPr>
+      <p:sp>
+        <p:nvSpPr>
+          <p:cNvPr id="2" name="dot 2"/>
+          <p:cNvSpPr/>
+          <p:nvPr/>
+        </p:nvSpPr>
+        <p:spPr>
+          <a:xfrm>
+            <a:off x="6355080" y="2697480"/>
+            <a:ext cx="2240280" cy="2240280"/>
+          </a:xfrm>
+          <a:prstGeom prst="ellipse">
+            <a:avLst/>
+          </a:prstGeom>
+          <a:solidFill>
+            <a:srgbClr val="F33844">
+              <a:alpha val="55000"/>
+            </a:srgbClr>
+          </a:solidFill>
+          <a:ln/>
+        </p:spPr>
+        <p:txBody>
+          <a:bodyPr/>
+          <a:lstStyle/>
+          <a:p>
+            <a:endParaRPr lang="en-AU"/>
+          </a:p>
+        </p:txBody>
+      </p:sp>
+      <p:sp>
+        <p:nvSpPr>
+          <p:cNvPr id="8" name="dot 1"/>
+          <p:cNvSpPr/>
+          <p:nvPr/>
+        </p:nvSpPr>
+        <p:spPr>
+          <a:xfrm>
+            <a:off x="7086600" y="1828800"/>
+            <a:ext cx="1783080" cy="1783080"/>
+          </a:xfrm>
+          <a:prstGeom prst="ellipse">
+            <a:avLst/>
+          </a:prstGeom>
+          <a:solidFill>
+            <a:srgbClr val="6D71FF">
+              <a:alpha val="55000"/>
+            </a:srgbClr>
+          </a:solidFill>
+          <a:ln/>
+        </p:spPr>
+        <p:txBody>
+          <a:bodyPr/>
+          <a:lstStyle/>
+          <a:p>
+            <a:endParaRPr lang="en-AU"/>
+          </a:p>
+        </p:txBody>
+      </p:sp>
+      <p:sp>
+        <p:nvSpPr>
+          <p:cNvPr id="9" name="dot 0"/>
+          <p:cNvSpPr/>
+          <p:nvPr/>
+        </p:nvSpPr>
+        <p:spPr>
+          <a:xfrm>
+            <a:off x="6126480" y="914400"/>
+            <a:ext cx="2148840" cy="2148840"/>
+          </a:xfrm>
+          <a:prstGeom prst="ellipse">
+            <a:avLst/>
+          </a:prstGeom>
+          <a:solidFill>
+            <a:srgbClr val="3FD0C9">
+              <a:alpha val="55000"/>
+            </a:srgbClr>
+          </a:solidFill>
+          <a:ln/>
+        </p:spPr>
+        <p:txBody>
+          <a:bodyPr/>
+          <a:lstStyle/>
+          <a:p>
+            <a:endParaRPr lang="en-AU"/>
+          </a:p>
+        </p:txBody>
+      </p:sp>
+      <p:sp>
+        <p:nvSpPr>
+          <p:cNvPr id="3" name="Shape 1"/>
+          <p:cNvSpPr/>
+          <p:nvPr/>
+        </p:nvSpPr>
+        <p:spPr>
+          <a:xfrm>
+            <a:off x="502920" y="1874520"/>
+            <a:ext cx="868680" cy="868680"/>
+          </a:xfrm>
+          <a:prstGeom prst="rect">
+            <a:avLst/>
+          </a:prstGeom>
+          <a:solidFill>
+            <a:srgbClr val="3FD0C9"/>
+          </a:solidFill>
+          <a:ln/>
+        </p:spPr>
+        <p:txBody>
+          <a:bodyPr/>
+          <a:lstStyle/>
+          <a:p>
+            <a:endParaRPr lang="en-AU"/>
+          </a:p>
+        </p:txBody>
+      </p:sp>
+      <p:sp>
+        <p:nvSpPr>
+          <p:cNvPr id="4" name="Text 2"/>
+          <p:cNvSpPr txBox="1"/>
+          <p:nvPr/>
+        </p:nvSpPr>
+        <p:spPr>
+          <a:xfrm>
+            <a:off x="502920" y="1874520"/>
+            <a:ext cx="868680" cy="868680"/>
+          </a:xfrm>
+          <a:prstGeom prst="rect">
+            <a:avLst/>
+          </a:prstGeom>
+          <a:noFill/>
+          <a:ln/>
+        </p:spPr>
+        <p:txBody>
+          <a:bodyPr wrap="square" lIns="0" tIns="0" rIns="0" bIns="0" rtlCol="0" anchor="ctr"/>
+          <a:lstStyle/>
+          <a:p>
+            <a:pPr marL="0" indent="0" algn="ctr">
+              <a:buNone/>
+            </a:pPr>
+            <a:r>
+              <a:rPr lang="en-US" sz="2200" b="1">
+                <a:solidFill>
+                  <a:srgbClr val="242C39"/>
+                </a:solidFill>
+              </a:rPr>
+              <a:t>04</a:t>
+            </a:r>
+            <a:endParaRPr lang="en-US" sz="2600"/>
+          </a:p>
+        </p:txBody>
+      </p:sp>
+      <p:sp>
+        <p:nvSpPr>
+          <p:cNvPr id="5" name="Text 3"/>
+          <p:cNvSpPr txBox="1"/>
+          <p:nvPr/>
+        </p:nvSpPr>
+        <p:spPr>
+          <a:xfrm>
+            <a:off x="502920" y="411480"/>
+            <a:ext cx="3657600" cy="274320"/>
+          </a:xfrm>
+          <a:prstGeom prst="rect">
+            <a:avLst/>
+          </a:prstGeom>
+          <a:noFill/>
+          <a:ln/>
+        </p:spPr>
+        <p:txBody>
+          <a:bodyPr wrap="square" lIns="0" tIns="0" rIns="0" bIns="0" rtlCol="0" anchor="ctr"/>
+          <a:lstStyle/>
+          <a:p>
+            <a:pPr marL="0" indent="0">
+              <a:buNone/>
+            </a:pPr>
+            <a:r>
+              <a:rPr lang="en-US" sz="950" b="1" kern="0" spc="220">
+                <a:solidFill>
+                  <a:srgbClr val="3FD0C9"/>
+                </a:solidFill>
+              </a:rPr>
+              <a:t>SECTION</a:t>
+            </a:r>
+            <a:endParaRPr lang="en-US" sz="950"/>
+          </a:p>
+        </p:txBody>
+      </p:sp>
+      <p:sp>
+        <p:nvSpPr>
+          <p:cNvPr id="6" name="Text 4"/>
+          <p:cNvSpPr txBox="1"/>
+          <p:nvPr/>
+        </p:nvSpPr>
+        <p:spPr>
+          <a:xfrm>
+            <a:off x="1600200" y="1874519"/>
+            <a:ext cx="5943600" cy="502920"/>
+          </a:xfrm>
+          <a:prstGeom prst="rect">
+            <a:avLst/>
+          </a:prstGeom>
+          <a:noFill/>
+          <a:ln/>
+        </p:spPr>
+        <p:txBody>
+          <a:bodyPr wrap="square" lIns="0" tIns="0" rIns="0" bIns="0" rtlCol="0" anchor="ctr"/>
+          <a:lstStyle/>
+          <a:p>
+            <a:pPr marL="0" indent="0">
+              <a:buNone/>
+            </a:pPr>
+            <a:r>
+              <a:rPr lang="en-US" sz="2300" b="1">
+                <a:solidFill>
+                  <a:srgbClr val="FFFFFF"/>
+                </a:solidFill>
+              </a:rPr>
+              <a:t>Customers and receivables</a:t>
+            </a:r>
+            <a:endParaRPr lang="en-US" sz="2800"/>
+          </a:p>
+        </p:txBody>
+      </p:sp>
+      <p:sp>
+        <p:nvSpPr>
+          <p:cNvPr id="7" name="Text 5"/>
+          <p:cNvSpPr txBox="1"/>
+          <p:nvPr/>
+        </p:nvSpPr>
+        <p:spPr>
+          <a:xfrm>
+            <a:off x="1600200" y="2395728"/>
+            <a:ext cx="5943600" cy="347472"/>
+          </a:xfrm>
+          <a:prstGeom prst="rect">
+            <a:avLst/>
+          </a:prstGeom>
+          <a:noFill/>
+          <a:ln/>
+        </p:spPr>
+        <p:txBody>
+          <a:bodyPr wrap="square" lIns="0" tIns="0" rIns="0" bIns="0" rtlCol="0" anchor="ctr"/>
+          <a:lstStyle/>
+          <a:p>
+            <a:pPr marL="0" indent="0">
+              <a:buNone/>
+            </a:pPr>
+            <a:r>
+              <a:rPr lang="en-US" sz="1200">
+                <a:solidFill>
+                  <a:srgbClr val="C9CED6"/>
+                </a:solidFill>
+              </a:rPr>
+              <a:t>Who pays us, how much, and how slowly</a:t>
+            </a:r>
+            <a:endParaRPr lang="en-US" sz="1200"/>
+          </a:p>
+        </p:txBody>
+      </p:sp>
+    </p:spTree>
+  </p:cSld>
+  <p:clrMapOvr>
+    <a:masterClrMapping/>
+  </p:clrMapOvr>
+</p:sld>
+</file>
+
+<file path=ppt/slides/slide31.xml><?xml version="1.0" encoding="utf-8"?>
+<p:sld xmlns:a="http://schemas.openxmlformats.org/drawingml/2006/main" xmlns:r="http://schemas.openxmlformats.org/officeDocument/2006/relationships" xmlns:p="http://schemas.openxmlformats.org/presentationml/2006/main">
   <p:cSld name="Slide 21">
     <p:spTree>
       <p:nvGrpSpPr>
@@ -17569,7 +18166,7 @@
 </p:sld>
 </file>
 
-<file path=ppt/slides/slide31.xml><?xml version="1.0" encoding="utf-8"?>
+<file path=ppt/slides/slide32.xml><?xml version="1.0" encoding="utf-8"?>
 <p:sld xmlns:a="http://schemas.openxmlformats.org/drawingml/2006/main" xmlns:r="http://schemas.openxmlformats.org/officeDocument/2006/relationships" xmlns:p="http://schemas.openxmlformats.org/presentationml/2006/main">
   <p:cSld name="Slide 22">
     <p:spTree>
@@ -17975,7 +18572,7 @@
 </p:sld>
 </file>
 
-<file path=ppt/slides/slide32.xml><?xml version="1.0" encoding="utf-8"?>
+<file path=ppt/slides/slide33.xml><?xml version="1.0" encoding="utf-8"?>
 <p:sld xmlns:a="http://schemas.openxmlformats.org/drawingml/2006/main" xmlns:r="http://schemas.openxmlformats.org/officeDocument/2006/relationships" xmlns:p="http://schemas.openxmlformats.org/presentationml/2006/main">
   <p:cSld name="Slide 23">
     <p:spTree>
@@ -18381,7 +18978,7 @@
 </p:sld>
 </file>
 
-<file path=ppt/slides/slide33.xml><?xml version="1.0" encoding="utf-8"?>
+<file path=ppt/slides/slide34.xml><?xml version="1.0" encoding="utf-8"?>
 <p:sld xmlns:a="http://schemas.openxmlformats.org/drawingml/2006/main" xmlns:r="http://schemas.openxmlformats.org/officeDocument/2006/relationships" xmlns:p="http://schemas.openxmlformats.org/presentationml/2006/main">
   <p:cSld name="Slide 24">
     <p:spTree>
@@ -18542,7 +19139,7 @@
                   <a:srgbClr val="242C39"/>
                 </a:solidFill>
               </a:rPr>
-              <a:t>04</a:t>
+              <a:t>05</a:t>
             </a:r>
             <a:endParaRPr lang="en-US" sz="2600"/>
           </a:p>
@@ -18664,7 +19261,7 @@
 </p:sld>
 </file>
 
-<file path=ppt/slides/slide34.xml><?xml version="1.0" encoding="utf-8"?>
+<file path=ppt/slides/slide35.xml><?xml version="1.0" encoding="utf-8"?>
 <p:sld xmlns:a="http://schemas.openxmlformats.org/drawingml/2006/main" xmlns:r="http://schemas.openxmlformats.org/officeDocument/2006/relationships" xmlns:p="http://schemas.openxmlformats.org/presentationml/2006/main">
   <p:cSld name="Slide 25">
     <p:spTree>
@@ -19049,7 +19646,7 @@
 </p:sld>
 </file>
 
-<file path=ppt/slides/slide35.xml><?xml version="1.0" encoding="utf-8"?>
+<file path=ppt/slides/slide36.xml><?xml version="1.0" encoding="utf-8"?>
 <p:sld xmlns:a="http://schemas.openxmlformats.org/drawingml/2006/main" xmlns:r="http://schemas.openxmlformats.org/officeDocument/2006/relationships" xmlns:p="http://schemas.openxmlformats.org/presentationml/2006/main">
   <p:cSld name="Slide 26">
     <p:spTree>
@@ -19455,7 +20052,7 @@
 </p:sld>
 </file>
 
-<file path=ppt/slides/slide36.xml><?xml version="1.0" encoding="utf-8"?>
+<file path=ppt/slides/slide37.xml><?xml version="1.0" encoding="utf-8"?>
 <p:sld xmlns:a="http://schemas.openxmlformats.org/drawingml/2006/main" xmlns:r="http://schemas.openxmlformats.org/officeDocument/2006/relationships" xmlns:p="http://schemas.openxmlformats.org/presentationml/2006/main">
   <p:cSld name="Slide 27">
     <p:spTree>
@@ -19861,7 +20458,7 @@
 </p:sld>
 </file>
 
-<file path=ppt/slides/slide37.xml><?xml version="1.0" encoding="utf-8"?>
+<file path=ppt/slides/slide38.xml><?xml version="1.0" encoding="utf-8"?>
 <p:sld xmlns:a="http://schemas.openxmlformats.org/drawingml/2006/main" xmlns:r="http://schemas.openxmlformats.org/officeDocument/2006/relationships" xmlns:p="http://schemas.openxmlformats.org/presentationml/2006/main">
   <p:cSld name="Slide 28">
     <p:spTree>
@@ -20022,7 +20619,7 @@
                   <a:srgbClr val="242C39"/>
                 </a:solidFill>
               </a:rPr>
-              <a:t>05</a:t>
+              <a:t>06</a:t>
             </a:r>
             <a:endParaRPr lang="en-US" sz="2600"/>
           </a:p>
@@ -20144,7 +20741,7 @@
 </p:sld>
 </file>
 
-<file path=ppt/slides/slide38.xml><?xml version="1.0" encoding="utf-8"?>
+<file path=ppt/slides/slide39.xml><?xml version="1.0" encoding="utf-8"?>
 <p:sld xmlns:a="http://schemas.openxmlformats.org/drawingml/2006/main" xmlns:r="http://schemas.openxmlformats.org/officeDocument/2006/relationships" xmlns:p="http://schemas.openxmlformats.org/presentationml/2006/main">
   <p:cSld name="Slide 29">
     <p:spTree>
@@ -20550,7 +21147,290 @@
 </p:sld>
 </file>
 
-<file path=ppt/slides/slide39.xml><?xml version="1.0" encoding="utf-8"?>
+<file path=ppt/slides/slide4.xml><?xml version="1.0" encoding="utf-8"?>
+<p:sld xmlns:a="http://schemas.openxmlformats.org/drawingml/2006/main" xmlns:r="http://schemas.openxmlformats.org/officeDocument/2006/relationships" xmlns:p="http://schemas.openxmlformats.org/presentationml/2006/main">
+  <p:cSld name="Slide 4">
+    <p:spTree>
+      <p:nvGrpSpPr>
+        <p:cNvPr id="1" name=""/>
+        <p:cNvGrpSpPr/>
+        <p:nvPr/>
+      </p:nvGrpSpPr>
+      <p:grpSpPr>
+        <a:xfrm>
+          <a:off x="0" y="0"/>
+          <a:ext cx="0" cy="0"/>
+          <a:chOff x="0" y="0"/>
+          <a:chExt cx="0" cy="0"/>
+        </a:xfrm>
+      </p:grpSpPr>
+      <p:sp>
+        <p:nvSpPr>
+          <p:cNvPr id="2" name="dot 2"/>
+          <p:cNvSpPr/>
+          <p:nvPr/>
+        </p:nvSpPr>
+        <p:spPr>
+          <a:xfrm>
+            <a:off x="6537960" y="1965960"/>
+            <a:ext cx="2240280" cy="2240280"/>
+          </a:xfrm>
+          <a:prstGeom prst="ellipse">
+            <a:avLst/>
+          </a:prstGeom>
+          <a:solidFill>
+            <a:srgbClr val="F33844">
+              <a:alpha val="55000"/>
+            </a:srgbClr>
+          </a:solidFill>
+          <a:ln/>
+        </p:spPr>
+        <p:txBody>
+          <a:bodyPr/>
+          <a:lstStyle/>
+          <a:p>
+            <a:endParaRPr lang="en-AU"/>
+          </a:p>
+        </p:txBody>
+      </p:sp>
+      <p:sp>
+        <p:nvSpPr>
+          <p:cNvPr id="8" name="dot 1"/>
+          <p:cNvSpPr/>
+          <p:nvPr/>
+        </p:nvSpPr>
+        <p:spPr>
+          <a:xfrm>
+            <a:off x="7269480" y="1097280"/>
+            <a:ext cx="1783080" cy="1783080"/>
+          </a:xfrm>
+          <a:prstGeom prst="ellipse">
+            <a:avLst/>
+          </a:prstGeom>
+          <a:solidFill>
+            <a:srgbClr val="6D71FF">
+              <a:alpha val="55000"/>
+            </a:srgbClr>
+          </a:solidFill>
+          <a:ln/>
+        </p:spPr>
+        <p:txBody>
+          <a:bodyPr/>
+          <a:lstStyle/>
+          <a:p>
+            <a:endParaRPr lang="en-AU"/>
+          </a:p>
+        </p:txBody>
+      </p:sp>
+      <p:sp>
+        <p:nvSpPr>
+          <p:cNvPr id="9" name="dot 0"/>
+          <p:cNvSpPr/>
+          <p:nvPr/>
+        </p:nvSpPr>
+        <p:spPr>
+          <a:xfrm>
+            <a:off x="6309360" y="182880"/>
+            <a:ext cx="2148840" cy="2148840"/>
+          </a:xfrm>
+          <a:prstGeom prst="ellipse">
+            <a:avLst/>
+          </a:prstGeom>
+          <a:solidFill>
+            <a:srgbClr val="3FD0C9">
+              <a:alpha val="55000"/>
+            </a:srgbClr>
+          </a:solidFill>
+          <a:ln/>
+        </p:spPr>
+        <p:txBody>
+          <a:bodyPr/>
+          <a:lstStyle/>
+          <a:p>
+            <a:endParaRPr lang="en-AU"/>
+          </a:p>
+        </p:txBody>
+      </p:sp>
+      <p:sp>
+        <p:nvSpPr>
+          <p:cNvPr id="3" name="Shape 1"/>
+          <p:cNvSpPr/>
+          <p:nvPr/>
+        </p:nvSpPr>
+        <p:spPr>
+          <a:xfrm>
+            <a:off x="502920" y="1874520"/>
+            <a:ext cx="868680" cy="868680"/>
+          </a:xfrm>
+          <a:prstGeom prst="rect">
+            <a:avLst/>
+          </a:prstGeom>
+          <a:solidFill>
+            <a:srgbClr val="3FD0C9"/>
+          </a:solidFill>
+          <a:ln/>
+        </p:spPr>
+        <p:txBody>
+          <a:bodyPr/>
+          <a:lstStyle/>
+          <a:p>
+            <a:endParaRPr lang="en-AU"/>
+          </a:p>
+        </p:txBody>
+      </p:sp>
+      <p:sp>
+        <p:nvSpPr>
+          <p:cNvPr id="4" name="Text 2"/>
+          <p:cNvSpPr txBox="1"/>
+          <p:nvPr/>
+        </p:nvSpPr>
+        <p:spPr>
+          <a:xfrm>
+            <a:off x="502920" y="1874520"/>
+            <a:ext cx="868680" cy="868680"/>
+          </a:xfrm>
+          <a:prstGeom prst="rect">
+            <a:avLst/>
+          </a:prstGeom>
+          <a:noFill/>
+          <a:ln/>
+        </p:spPr>
+        <p:txBody>
+          <a:bodyPr wrap="square" lIns="0" tIns="0" rIns="0" bIns="0" rtlCol="0" anchor="ctr"/>
+          <a:lstStyle/>
+          <a:p>
+            <a:pPr marL="0" indent="0" algn="ctr">
+              <a:buNone/>
+            </a:pPr>
+            <a:r>
+              <a:rPr lang="en-US" sz="2200" b="1">
+                <a:solidFill>
+                  <a:srgbClr val="242C39"/>
+                </a:solidFill>
+              </a:rPr>
+              <a:t>01</a:t>
+            </a:r>
+            <a:endParaRPr lang="en-US" sz="2600"/>
+          </a:p>
+        </p:txBody>
+      </p:sp>
+      <p:sp>
+        <p:nvSpPr>
+          <p:cNvPr id="5" name="Text 3"/>
+          <p:cNvSpPr txBox="1"/>
+          <p:nvPr/>
+        </p:nvSpPr>
+        <p:spPr>
+          <a:xfrm>
+            <a:off x="502920" y="411480"/>
+            <a:ext cx="3657600" cy="274320"/>
+          </a:xfrm>
+          <a:prstGeom prst="rect">
+            <a:avLst/>
+          </a:prstGeom>
+          <a:noFill/>
+          <a:ln/>
+        </p:spPr>
+        <p:txBody>
+          <a:bodyPr wrap="square" lIns="0" tIns="0" rIns="0" bIns="0" rtlCol="0" anchor="ctr"/>
+          <a:lstStyle/>
+          <a:p>
+            <a:pPr marL="0" indent="0">
+              <a:buNone/>
+            </a:pPr>
+            <a:r>
+              <a:rPr lang="en-US" sz="950" b="1" kern="0" spc="220">
+                <a:solidFill>
+                  <a:srgbClr val="3FD0C9"/>
+                </a:solidFill>
+              </a:rPr>
+              <a:t>SECTION</a:t>
+            </a:r>
+            <a:endParaRPr lang="en-US" sz="950"/>
+          </a:p>
+        </p:txBody>
+      </p:sp>
+      <p:sp>
+        <p:nvSpPr>
+          <p:cNvPr id="6" name="Text 4"/>
+          <p:cNvSpPr txBox="1"/>
+          <p:nvPr/>
+        </p:nvSpPr>
+        <p:spPr>
+          <a:xfrm>
+            <a:off x="1600200" y="1874519"/>
+            <a:ext cx="5943600" cy="502920"/>
+          </a:xfrm>
+          <a:prstGeom prst="rect">
+            <a:avLst/>
+          </a:prstGeom>
+          <a:noFill/>
+          <a:ln/>
+        </p:spPr>
+        <p:txBody>
+          <a:bodyPr wrap="square" lIns="0" tIns="0" rIns="0" bIns="0" rtlCol="0" anchor="ctr"/>
+          <a:lstStyle/>
+          <a:p>
+            <a:pPr marL="0" indent="0">
+              <a:buNone/>
+            </a:pPr>
+            <a:r>
+              <a:rPr lang="en-US" sz="2300" b="1">
+                <a:solidFill>
+                  <a:srgbClr val="FFFFFF"/>
+                </a:solidFill>
+              </a:rPr>
+              <a:t>Financial performance</a:t>
+            </a:r>
+            <a:endParaRPr lang="en-US" sz="2800"/>
+          </a:p>
+        </p:txBody>
+      </p:sp>
+      <p:sp>
+        <p:nvSpPr>
+          <p:cNvPr id="7" name="Text 5"/>
+          <p:cNvSpPr txBox="1"/>
+          <p:nvPr/>
+        </p:nvSpPr>
+        <p:spPr>
+          <a:xfrm>
+            <a:off x="1600200" y="2395728"/>
+            <a:ext cx="5943600" cy="347472"/>
+          </a:xfrm>
+          <a:prstGeom prst="rect">
+            <a:avLst/>
+          </a:prstGeom>
+          <a:noFill/>
+          <a:ln/>
+        </p:spPr>
+        <p:txBody>
+          <a:bodyPr wrap="square" lIns="0" tIns="0" rIns="0" bIns="0" rtlCol="0" anchor="ctr"/>
+          <a:lstStyle/>
+          <a:p>
+            <a:pPr marL="0" indent="0">
+              <a:buNone/>
+            </a:pPr>
+            <a:r>
+              <a:rPr lang="en-US" sz="1200">
+                <a:solidFill>
+                  <a:srgbClr val="C9CED6"/>
+                </a:solidFill>
+              </a:rPr>
+              <a:t>The P&amp;L for September 2026 and the year to date</a:t>
+            </a:r>
+            <a:endParaRPr lang="en-US" sz="1200"/>
+          </a:p>
+        </p:txBody>
+      </p:sp>
+    </p:spTree>
+  </p:cSld>
+  <p:clrMapOvr>
+    <a:masterClrMapping/>
+  </p:clrMapOvr>
+</p:sld>
+</file>
+
+<file path=ppt/slides/slide40.xml><?xml version="1.0" encoding="utf-8"?>
 <p:sld xmlns:a="http://schemas.openxmlformats.org/drawingml/2006/main" xmlns:r="http://schemas.openxmlformats.org/officeDocument/2006/relationships" xmlns:p="http://schemas.openxmlformats.org/presentationml/2006/main">
   <p:cSld name="Slide 30">
     <p:spTree>
@@ -22696,290 +23576,7 @@
 </p:sld>
 </file>
 
-<file path=ppt/slides/slide4.xml><?xml version="1.0" encoding="utf-8"?>
-<p:sld xmlns:a="http://schemas.openxmlformats.org/drawingml/2006/main" xmlns:r="http://schemas.openxmlformats.org/officeDocument/2006/relationships" xmlns:p="http://schemas.openxmlformats.org/presentationml/2006/main">
-  <p:cSld name="Slide 4">
-    <p:spTree>
-      <p:nvGrpSpPr>
-        <p:cNvPr id="1" name=""/>
-        <p:cNvGrpSpPr/>
-        <p:nvPr/>
-      </p:nvGrpSpPr>
-      <p:grpSpPr>
-        <a:xfrm>
-          <a:off x="0" y="0"/>
-          <a:ext cx="0" cy="0"/>
-          <a:chOff x="0" y="0"/>
-          <a:chExt cx="0" cy="0"/>
-        </a:xfrm>
-      </p:grpSpPr>
-      <p:sp>
-        <p:nvSpPr>
-          <p:cNvPr id="2" name="dot 2"/>
-          <p:cNvSpPr/>
-          <p:nvPr/>
-        </p:nvSpPr>
-        <p:spPr>
-          <a:xfrm>
-            <a:off x="6537960" y="1965960"/>
-            <a:ext cx="2240280" cy="2240280"/>
-          </a:xfrm>
-          <a:prstGeom prst="ellipse">
-            <a:avLst/>
-          </a:prstGeom>
-          <a:solidFill>
-            <a:srgbClr val="F33844">
-              <a:alpha val="55000"/>
-            </a:srgbClr>
-          </a:solidFill>
-          <a:ln/>
-        </p:spPr>
-        <p:txBody>
-          <a:bodyPr/>
-          <a:lstStyle/>
-          <a:p>
-            <a:endParaRPr lang="en-AU"/>
-          </a:p>
-        </p:txBody>
-      </p:sp>
-      <p:sp>
-        <p:nvSpPr>
-          <p:cNvPr id="8" name="dot 1"/>
-          <p:cNvSpPr/>
-          <p:nvPr/>
-        </p:nvSpPr>
-        <p:spPr>
-          <a:xfrm>
-            <a:off x="7269480" y="1097280"/>
-            <a:ext cx="1783080" cy="1783080"/>
-          </a:xfrm>
-          <a:prstGeom prst="ellipse">
-            <a:avLst/>
-          </a:prstGeom>
-          <a:solidFill>
-            <a:srgbClr val="6D71FF">
-              <a:alpha val="55000"/>
-            </a:srgbClr>
-          </a:solidFill>
-          <a:ln/>
-        </p:spPr>
-        <p:txBody>
-          <a:bodyPr/>
-          <a:lstStyle/>
-          <a:p>
-            <a:endParaRPr lang="en-AU"/>
-          </a:p>
-        </p:txBody>
-      </p:sp>
-      <p:sp>
-        <p:nvSpPr>
-          <p:cNvPr id="9" name="dot 0"/>
-          <p:cNvSpPr/>
-          <p:nvPr/>
-        </p:nvSpPr>
-        <p:spPr>
-          <a:xfrm>
-            <a:off x="6309360" y="182880"/>
-            <a:ext cx="2148840" cy="2148840"/>
-          </a:xfrm>
-          <a:prstGeom prst="ellipse">
-            <a:avLst/>
-          </a:prstGeom>
-          <a:solidFill>
-            <a:srgbClr val="3FD0C9">
-              <a:alpha val="55000"/>
-            </a:srgbClr>
-          </a:solidFill>
-          <a:ln/>
-        </p:spPr>
-        <p:txBody>
-          <a:bodyPr/>
-          <a:lstStyle/>
-          <a:p>
-            <a:endParaRPr lang="en-AU"/>
-          </a:p>
-        </p:txBody>
-      </p:sp>
-      <p:sp>
-        <p:nvSpPr>
-          <p:cNvPr id="3" name="Shape 1"/>
-          <p:cNvSpPr/>
-          <p:nvPr/>
-        </p:nvSpPr>
-        <p:spPr>
-          <a:xfrm>
-            <a:off x="502920" y="1874520"/>
-            <a:ext cx="868680" cy="868680"/>
-          </a:xfrm>
-          <a:prstGeom prst="rect">
-            <a:avLst/>
-          </a:prstGeom>
-          <a:solidFill>
-            <a:srgbClr val="3FD0C9"/>
-          </a:solidFill>
-          <a:ln/>
-        </p:spPr>
-        <p:txBody>
-          <a:bodyPr/>
-          <a:lstStyle/>
-          <a:p>
-            <a:endParaRPr lang="en-AU"/>
-          </a:p>
-        </p:txBody>
-      </p:sp>
-      <p:sp>
-        <p:nvSpPr>
-          <p:cNvPr id="4" name="Text 2"/>
-          <p:cNvSpPr txBox="1"/>
-          <p:nvPr/>
-        </p:nvSpPr>
-        <p:spPr>
-          <a:xfrm>
-            <a:off x="502920" y="1874520"/>
-            <a:ext cx="868680" cy="868680"/>
-          </a:xfrm>
-          <a:prstGeom prst="rect">
-            <a:avLst/>
-          </a:prstGeom>
-          <a:noFill/>
-          <a:ln/>
-        </p:spPr>
-        <p:txBody>
-          <a:bodyPr wrap="square" lIns="0" tIns="0" rIns="0" bIns="0" rtlCol="0" anchor="ctr"/>
-          <a:lstStyle/>
-          <a:p>
-            <a:pPr marL="0" indent="0" algn="ctr">
-              <a:buNone/>
-            </a:pPr>
-            <a:r>
-              <a:rPr lang="en-US" sz="2200" b="1">
-                <a:solidFill>
-                  <a:srgbClr val="242C39"/>
-                </a:solidFill>
-              </a:rPr>
-              <a:t>01</a:t>
-            </a:r>
-            <a:endParaRPr lang="en-US" sz="2600"/>
-          </a:p>
-        </p:txBody>
-      </p:sp>
-      <p:sp>
-        <p:nvSpPr>
-          <p:cNvPr id="5" name="Text 3"/>
-          <p:cNvSpPr txBox="1"/>
-          <p:nvPr/>
-        </p:nvSpPr>
-        <p:spPr>
-          <a:xfrm>
-            <a:off x="502920" y="411480"/>
-            <a:ext cx="3657600" cy="274320"/>
-          </a:xfrm>
-          <a:prstGeom prst="rect">
-            <a:avLst/>
-          </a:prstGeom>
-          <a:noFill/>
-          <a:ln/>
-        </p:spPr>
-        <p:txBody>
-          <a:bodyPr wrap="square" lIns="0" tIns="0" rIns="0" bIns="0" rtlCol="0" anchor="ctr"/>
-          <a:lstStyle/>
-          <a:p>
-            <a:pPr marL="0" indent="0">
-              <a:buNone/>
-            </a:pPr>
-            <a:r>
-              <a:rPr lang="en-US" sz="950" b="1" kern="0" spc="220">
-                <a:solidFill>
-                  <a:srgbClr val="3FD0C9"/>
-                </a:solidFill>
-              </a:rPr>
-              <a:t>SECTION</a:t>
-            </a:r>
-            <a:endParaRPr lang="en-US" sz="950"/>
-          </a:p>
-        </p:txBody>
-      </p:sp>
-      <p:sp>
-        <p:nvSpPr>
-          <p:cNvPr id="6" name="Text 4"/>
-          <p:cNvSpPr txBox="1"/>
-          <p:nvPr/>
-        </p:nvSpPr>
-        <p:spPr>
-          <a:xfrm>
-            <a:off x="1600200" y="1874519"/>
-            <a:ext cx="5943600" cy="502920"/>
-          </a:xfrm>
-          <a:prstGeom prst="rect">
-            <a:avLst/>
-          </a:prstGeom>
-          <a:noFill/>
-          <a:ln/>
-        </p:spPr>
-        <p:txBody>
-          <a:bodyPr wrap="square" lIns="0" tIns="0" rIns="0" bIns="0" rtlCol="0" anchor="ctr"/>
-          <a:lstStyle/>
-          <a:p>
-            <a:pPr marL="0" indent="0">
-              <a:buNone/>
-            </a:pPr>
-            <a:r>
-              <a:rPr lang="en-US" sz="2300" b="1">
-                <a:solidFill>
-                  <a:srgbClr val="FFFFFF"/>
-                </a:solidFill>
-              </a:rPr>
-              <a:t>Financial performance</a:t>
-            </a:r>
-            <a:endParaRPr lang="en-US" sz="2800"/>
-          </a:p>
-        </p:txBody>
-      </p:sp>
-      <p:sp>
-        <p:nvSpPr>
-          <p:cNvPr id="7" name="Text 5"/>
-          <p:cNvSpPr txBox="1"/>
-          <p:nvPr/>
-        </p:nvSpPr>
-        <p:spPr>
-          <a:xfrm>
-            <a:off x="1600200" y="2395728"/>
-            <a:ext cx="5943600" cy="347472"/>
-          </a:xfrm>
-          <a:prstGeom prst="rect">
-            <a:avLst/>
-          </a:prstGeom>
-          <a:noFill/>
-          <a:ln/>
-        </p:spPr>
-        <p:txBody>
-          <a:bodyPr wrap="square" lIns="0" tIns="0" rIns="0" bIns="0" rtlCol="0" anchor="ctr"/>
-          <a:lstStyle/>
-          <a:p>
-            <a:pPr marL="0" indent="0">
-              <a:buNone/>
-            </a:pPr>
-            <a:r>
-              <a:rPr lang="en-US" sz="1200">
-                <a:solidFill>
-                  <a:srgbClr val="C9CED6"/>
-                </a:solidFill>
-              </a:rPr>
-              <a:t>The P&amp;L for September 2026 and the year to date</a:t>
-            </a:r>
-            <a:endParaRPr lang="en-US" sz="1200"/>
-          </a:p>
-        </p:txBody>
-      </p:sp>
-    </p:spTree>
-  </p:cSld>
-  <p:clrMapOvr>
-    <a:masterClrMapping/>
-  </p:clrMapOvr>
-</p:sld>
-</file>
-
-<file path=ppt/slides/slide40.xml><?xml version="1.0" encoding="utf-8"?>
+<file path=ppt/slides/slide41.xml><?xml version="1.0" encoding="utf-8"?>
 <p:sld xmlns:a="http://schemas.openxmlformats.org/drawingml/2006/main" xmlns:r="http://schemas.openxmlformats.org/officeDocument/2006/relationships" xmlns:p="http://schemas.openxmlformats.org/presentationml/2006/main">
   <p:cSld>
     <p:bg>
@@ -23184,7 +23781,7 @@
                   <a:srgbClr val="242C39"/>
                 </a:solidFill>
               </a:rPr>
-              <a:t>06</a:t>
+              <a:t>07</a:t>
             </a:r>
             <a:endParaRPr lang="en-US" sz="2600"/>
           </a:p>
@@ -23355,7 +23952,7 @@
 </p:sld>
 </file>
 
-<file path=ppt/slides/slide41.xml><?xml version="1.0" encoding="utf-8"?>
+<file path=ppt/slides/slide42.xml><?xml version="1.0" encoding="utf-8"?>
 <p:sld xmlns:a="http://schemas.openxmlformats.org/drawingml/2006/main" xmlns:r="http://schemas.openxmlformats.org/officeDocument/2006/relationships" xmlns:p="http://schemas.openxmlformats.org/presentationml/2006/main">
   <p:cSld name="Slide 31">
     <p:spTree>

</xml_diff>

<commit_message>
The department dots match the other dividers: 55 per cent opacity
Every dot on the existing dividers carries an alpha of 55000, so the circles
blend where they overlap. The five department dots were going on fully opaque,
which is why they read as flat discs against the rest of the deck.

python-pptx does not expose transparency, so the alpha element is appended to
the srgbClr by hand.

Co-Authored-By: Claude Opus 5 <noreply@anthropic.com>
Claude-Session: https://claude.ai/code/session_01CVBAFohBCYXt1ufjTVDiZj
</commit_message>
<xml_diff>
--- a/deck/CTS Monthly Business Review - 30092026.pptx
+++ b/deck/CTS Monthly Business Review - 30092026.pptx
@@ -8773,7 +8773,9 @@
             <a:avLst/>
           </a:prstGeom>
           <a:solidFill>
-            <a:srgbClr val="8F4AFA"/>
+            <a:srgbClr val="8F4AFA">
+              <a:alpha val="55000"/>
+            </a:srgbClr>
           </a:solidFill>
           <a:ln>
             <a:noFill/>
@@ -8817,7 +8819,9 @@
             <a:avLst/>
           </a:prstGeom>
           <a:solidFill>
-            <a:srgbClr val="6D71FF"/>
+            <a:srgbClr val="6D71FF">
+              <a:alpha val="55000"/>
+            </a:srgbClr>
           </a:solidFill>
           <a:ln>
             <a:noFill/>
@@ -8861,7 +8865,9 @@
             <a:avLst/>
           </a:prstGeom>
           <a:solidFill>
-            <a:srgbClr val="3FD0C9"/>
+            <a:srgbClr val="3FD0C9">
+              <a:alpha val="55000"/>
+            </a:srgbClr>
           </a:solidFill>
           <a:ln>
             <a:noFill/>
@@ -8905,7 +8911,9 @@
             <a:avLst/>
           </a:prstGeom>
           <a:solidFill>
-            <a:srgbClr val="005358"/>
+            <a:srgbClr val="005358">
+              <a:alpha val="55000"/>
+            </a:srgbClr>
           </a:solidFill>
           <a:ln>
             <a:noFill/>
@@ -8949,7 +8957,9 @@
             <a:avLst/>
           </a:prstGeom>
           <a:solidFill>
-            <a:srgbClr val="F33844"/>
+            <a:srgbClr val="F33844">
+              <a:alpha val="55000"/>
+            </a:srgbClr>
           </a:solidFill>
           <a:ln>
             <a:noFill/>

</xml_diff>

<commit_message>
A chart for the departmental result, with the table kept on the next page
Four cuts of section 7 were drawn and this is the one that explains the table
rather than restating it: what each department earned above the line, the
overhead charged to it below, and the result marked on top. A department can be
on a good margin and still finish below the line, which is visible here and on
none of the others.

It goes in as page 17 and the table moves to page 18, retitled so the two pages
are not both called the same thing.

Deck is 43 pages. This is a monthly page.

Co-Authored-By: Claude Opus 5 <noreply@anthropic.com>
Claude-Session: https://claude.ai/code/session_01CVBAFohBCYXt1ufjTVDiZj
</commit_message>
<xml_diff>
--- a/deck/CTS Monthly Business Review - 30092026.pptx
+++ b/deck/CTS Monthly Business Review - 30092026.pptx
@@ -24,6 +24,7 @@
     <p:sldId id="297" r:id="rId18"/>
     <p:sldId id="298" r:id="rId52"/>
     <p:sldId id="299" r:id="rId53"/>
+    <p:sldId id="300" r:id="rId54"/>
     <p:sldId id="262" r:id="rId19"/>
     <p:sldId id="263" r:id="rId20"/>
     <p:sldId id="264" r:id="rId21"/>
@@ -4996,6 +4997,114 @@
 </p:notes>
 </file>
 
+<file path=ppt/notesSlides/notesSlide43.xml><?xml version="1.0" encoding="utf-8"?>
+<p:notes xmlns:a="http://schemas.openxmlformats.org/drawingml/2006/main" xmlns:p="http://schemas.openxmlformats.org/presentationml/2006/main" xmlns:r="http://schemas.openxmlformats.org/officeDocument/2006/relationships">
+  <p:cSld>
+    <p:spTree>
+      <p:nvGrpSpPr>
+        <p:cNvPr id="1" name=""/>
+        <p:cNvGrpSpPr/>
+        <p:nvPr/>
+      </p:nvGrpSpPr>
+      <p:grpSpPr>
+        <a:xfrm>
+          <a:off x="0" y="0"/>
+          <a:ext cx="0" cy="0"/>
+          <a:chOff x="0" y="0"/>
+          <a:chExt cx="0" cy="0"/>
+        </a:xfrm>
+      </p:grpSpPr>
+      <p:sp>
+        <p:nvSpPr>
+          <p:cNvPr id="3" name="Notes Placeholder 2"/>
+          <p:cNvSpPr>
+            <a:spLocks noGrp="1"/>
+          </p:cNvSpPr>
+          <p:nvPr>
+            <p:ph type="body" idx="1"/>
+          </p:nvPr>
+        </p:nvSpPr>
+        <p:spPr/>
+        <p:txBody>
+          <a:bodyPr lIns="107095" tIns="53547" rIns="107095" bIns="53547"/>
+          <a:lstStyle/>
+          <a:p>
+            <a:r>
+              <a:t>Gross profit against the overhead charged to each department for September 2026, taken from section 7 of the Overhead Split tab. The bar above the line is what the department earned, the bar below is the overhead allocated to it, and the diamond is the result.</a:t>
+            </a:r>
+          </a:p>
+          <a:p/>
+          <a:p>
+            <a:r>
+              <a:t>Support earned $101,290 and carries $72,283, leaving $29,007.</a:t>
+            </a:r>
+          </a:p>
+          <a:p>
+            <a:r>
+              <a:t>Events earned $56,881 and carries $111,108, leaving a loss of $54,227.</a:t>
+            </a:r>
+          </a:p>
+          <a:p>
+            <a:r>
+              <a:t>Video earned $5,813 and carries $12,659, leaving a loss of $6,846.</a:t>
+            </a:r>
+          </a:p>
+          <a:p>
+            <a:r>
+              <a:t>Integration earned $23,756 and carries $13,285, leaving $10,471.</a:t>
+            </a:r>
+          </a:p>
+          <a:p>
+            <a:r>
+              <a:t>Consulting earned $74 and carries $19,944, leaving a loss of $19,870.</a:t>
+            </a:r>
+          </a:p>
+          <a:p/>
+          <a:p>
+            <a:r>
+              <a:t>The company earned $187,814 of gross profit against $229,278 of overhead. The $41,464 difference is the loss for the month. Put plainly, the business did not earn enough gross profit to carry its own overhead base.</a:t>
+            </a:r>
+          </a:p>
+          <a:p/>
+          <a:p>
+            <a:r>
+              <a:t>Two things come out of the shape of this chart.</a:t>
+            </a:r>
+          </a:p>
+          <a:p/>
+          <a:p>
+            <a:r>
+              <a:t>The first is Events. Its gross margin was 77.6%, the second highest of the five, and it still produced the largest loss on the page. It carries $111,108 of overhead, which is 48.5% of the company total, on $73,304 of revenue, which is 13.0% of the company total. No improvement in margin fixes that. Either Events carries more revenue or it carries less overhead, and the overhead keys are worth testing before the next budget.</a:t>
+            </a:r>
+          </a:p>
+          <a:p/>
+          <a:p>
+            <a:r>
+              <a:t>The second is Integration. It brought in $234,858 of revenue, the second largest of the five, and converted it into $23,756 of gross profit at a 10.1% margin. It covers its overhead and returns $10,471, so it is not a loss maker, but it is doing the most work for the least return.</a:t>
+            </a:r>
+          </a:p>
+          <a:p/>
+          <a:p>
+            <a:r>
+              <a:t>Support is the one department behaving as it should. A 41.7% margin on contract revenue, covering its allocated overhead, and returning $29,007.</a:t>
+            </a:r>
+          </a:p>
+          <a:p/>
+          <a:p>
+            <a:r>
+              <a:t>The full table is on the next page.</a:t>
+            </a:r>
+          </a:p>
+        </p:txBody>
+      </p:sp>
+    </p:spTree>
+  </p:cSld>
+  <p:clrMapOvr>
+    <a:masterClrMapping/>
+  </p:clrMapOvr>
+</p:notes>
+</file>
+
 <file path=ppt/notesSlides/notesSlide5.xml><?xml version="1.0" encoding="utf-8"?>
 <p:notes xmlns:a="http://schemas.openxmlformats.org/drawingml/2006/main" xmlns:r="http://schemas.openxmlformats.org/officeDocument/2006/relationships" xmlns:p="http://schemas.openxmlformats.org/presentationml/2006/main">
   <p:cSld>
@@ -9168,6 +9277,384 @@
 </file>
 
 <file path=ppt/slides/slide17.xml><?xml version="1.0" encoding="utf-8"?>
+<p:sld xmlns:a="http://schemas.openxmlformats.org/drawingml/2006/main" xmlns:p="http://schemas.openxmlformats.org/presentationml/2006/main" xmlns:r="http://schemas.openxmlformats.org/officeDocument/2006/relationships">
+  <p:cSld>
+    <p:spTree>
+      <p:nvGrpSpPr>
+        <p:cNvPr id="1" name=""/>
+        <p:cNvGrpSpPr/>
+        <p:nvPr/>
+      </p:nvGrpSpPr>
+      <p:grpSpPr/>
+      <p:pic>
+        <p:nvPicPr>
+          <p:cNvPr id="27" name="snip dept_mix" descr="dept_mix.png"/>
+          <p:cNvPicPr>
+            <a:picLocks noChangeAspect="1"/>
+          </p:cNvPicPr>
+          <p:nvPr/>
+        </p:nvPicPr>
+        <p:blipFill>
+          <a:blip r:embed="rId3"/>
+          <a:stretch>
+            <a:fillRect/>
+          </a:stretch>
+        </p:blipFill>
+        <p:spPr>
+          <a:xfrm>
+            <a:off x="535418" y="1005840"/>
+            <a:ext cx="8073163" cy="2523743"/>
+          </a:xfrm>
+          <a:prstGeom prst="rect">
+            <a:avLst/>
+          </a:prstGeom>
+        </p:spPr>
+      </p:pic>
+      <p:sp>
+        <p:nvSpPr>
+          <p:cNvPr id="2" name="Text 0"/>
+          <p:cNvSpPr txBox="1"/>
+          <p:nvPr/>
+        </p:nvSpPr>
+        <p:spPr>
+          <a:xfrm>
+            <a:off x="502920" y="365760"/>
+            <a:ext cx="6400800" cy="274320"/>
+          </a:xfrm>
+          <a:prstGeom prst="rect">
+            <a:avLst/>
+          </a:prstGeom>
+          <a:noFill/>
+          <a:ln/>
+        </p:spPr>
+        <p:txBody>
+          <a:bodyPr wrap="square" lIns="0" tIns="0" rIns="0" bIns="0" rtlCol="0" anchor="ctr"/>
+          <a:lstStyle/>
+          <a:p>
+            <a:pPr marL="0" indent="0">
+              <a:buNone/>
+            </a:pPr>
+            <a:r>
+              <a:rPr lang="en-US" sz="950" b="1" kern="0" spc="220">
+                <a:solidFill>
+                  <a:srgbClr val="122B82"/>
+                </a:solidFill>
+              </a:rPr>
+              <a:t>DEPARTMENTAL PERFORMANCE</a:t>
+            </a:r>
+            <a:endParaRPr lang="en-US" sz="950"/>
+          </a:p>
+        </p:txBody>
+      </p:sp>
+      <p:sp>
+        <p:nvSpPr>
+          <p:cNvPr id="3" name="Text 1"/>
+          <p:cNvSpPr txBox="1"/>
+          <p:nvPr/>
+        </p:nvSpPr>
+        <p:spPr>
+          <a:xfrm>
+            <a:off x="502920" y="640080"/>
+            <a:ext cx="7315200" cy="365760"/>
+          </a:xfrm>
+          <a:prstGeom prst="rect">
+            <a:avLst/>
+          </a:prstGeom>
+          <a:noFill/>
+          <a:ln/>
+        </p:spPr>
+        <p:txBody>
+          <a:bodyPr wrap="square" lIns="0" tIns="0" rIns="0" bIns="0" rtlCol="0" anchor="ctr"/>
+          <a:lstStyle/>
+          <a:p>
+            <a:pPr marL="0" indent="0" algn="ctr">
+              <a:buNone/>
+            </a:pPr>
+            <a:r>
+              <a:rPr lang="en-US" sz="2200" b="1" dirty="0">
+                <a:solidFill>
+                  <a:srgbClr val="242C39"/>
+                </a:solidFill>
+              </a:rPr>
+              <a:t>Departmental result, September 2026</a:t>
+            </a:r>
+            <a:endParaRPr lang="en-US" sz="2700" dirty="0"/>
+          </a:p>
+        </p:txBody>
+      </p:sp>
+      <p:sp>
+        <p:nvSpPr>
+          <p:cNvPr id="6" name="commentary panel"/>
+          <p:cNvSpPr/>
+          <p:nvPr/>
+        </p:nvSpPr>
+        <p:spPr>
+          <a:xfrm>
+            <a:off x="502920" y="3621023"/>
+            <a:ext cx="8138160" cy="1005840"/>
+          </a:xfrm>
+          <a:prstGeom prst="rect">
+            <a:avLst/>
+          </a:prstGeom>
+          <a:solidFill>
+            <a:srgbClr val="E8F9F8"/>
+          </a:solidFill>
+          <a:ln/>
+        </p:spPr>
+        <p:txBody>
+          <a:bodyPr/>
+          <a:lstStyle/>
+          <a:p>
+            <a:endParaRPr lang="en-AU"/>
+          </a:p>
+        </p:txBody>
+      </p:sp>
+      <p:sp>
+        <p:nvSpPr>
+          <p:cNvPr id="7" name="Text 4"/>
+          <p:cNvSpPr txBox="1"/>
+          <p:nvPr/>
+        </p:nvSpPr>
+        <p:spPr>
+          <a:xfrm>
+            <a:off x="685800" y="3694175"/>
+            <a:ext cx="2743200" cy="228600"/>
+          </a:xfrm>
+          <a:prstGeom prst="rect">
+            <a:avLst/>
+          </a:prstGeom>
+          <a:noFill/>
+          <a:ln/>
+        </p:spPr>
+        <p:txBody>
+          <a:bodyPr wrap="square" lIns="0" tIns="0" rIns="0" bIns="0" rtlCol="0" anchor="ctr"/>
+          <a:lstStyle/>
+          <a:p>
+            <a:pPr marL="0" indent="0">
+              <a:buNone/>
+            </a:pPr>
+            <a:r>
+              <a:rPr lang="en-US" sz="900" b="1" kern="0" spc="180">
+                <a:solidFill>
+                  <a:srgbClr val="005358"/>
+                </a:solidFill>
+              </a:rPr>
+              <a:t>COMMENTARY</a:t>
+            </a:r>
+            <a:endParaRPr lang="en-US" sz="900"/>
+          </a:p>
+        </p:txBody>
+      </p:sp>
+      <p:sp>
+        <p:nvSpPr>
+          <p:cNvPr id="8" name="Text 5"/>
+          <p:cNvSpPr txBox="1"/>
+          <p:nvPr/>
+        </p:nvSpPr>
+        <p:spPr>
+          <a:xfrm>
+            <a:off x="685800" y="3867911"/>
+            <a:ext cx="3703320" cy="731520"/>
+          </a:xfrm>
+          <a:prstGeom prst="rect">
+            <a:avLst/>
+          </a:prstGeom>
+          <a:noFill/>
+          <a:ln/>
+        </p:spPr>
+        <p:txBody>
+          <a:bodyPr wrap="square" lIns="0" tIns="0" rIns="0" bIns="0" rtlCol="0" anchor="t">
+            <a:normAutofit fontScale="85000" lnSpcReduction="10000"/>
+          </a:bodyPr>
+          <a:lstStyle/>
+          <a:p>
+            <a:pPr marL="342900" indent="-342900">
+              <a:lnSpc>
+                <a:spcPts val="1050"/>
+              </a:lnSpc>
+              <a:spcAft>
+                <a:spcPts val="400"/>
+              </a:spcAft>
+              <a:buSzPct val="100000"/>
+              <a:buChar char="•"/>
+            </a:pPr>
+            <a:r>
+              <a:rPr lang="en-US" sz="1000">
+                <a:solidFill>
+                  <a:srgbClr val="3A4453"/>
+                </a:solidFill>
+              </a:rPr>
+              <a:t>Gross profit of $188k did not cover overheads of $229k. That gap is the $41k loss.</a:t>
+            </a:r>
+            <a:endParaRPr lang="en-US" sz="850"/>
+          </a:p>
+          <a:p>
+            <a:pPr marL="342900" indent="-342900">
+              <a:lnSpc>
+                <a:spcPts val="1050"/>
+              </a:lnSpc>
+              <a:spcAft>
+                <a:spcPts val="400"/>
+              </a:spcAft>
+              <a:buSzPct val="100000"/>
+              <a:buChar char="•"/>
+            </a:pPr>
+            <a:r>
+              <a:rPr lang="en-US" sz="1000">
+                <a:solidFill>
+                  <a:srgbClr val="3A4453"/>
+                </a:solidFill>
+              </a:rPr>
+              <a:t>Only Support and Integration covered the overhead charged to them.</a:t>
+            </a:r>
+            <a:endParaRPr lang="en-US" sz="850"/>
+          </a:p>
+        </p:txBody>
+      </p:sp>
+      <p:sp>
+        <p:nvSpPr>
+          <p:cNvPr id="25" name="Slide Number Placeholder 0"/>
+          <p:cNvSpPr>
+            <a:spLocks noGrp="1"/>
+          </p:cNvSpPr>
+          <p:nvPr>
+            <p:ph type="sldNum" sz="quarter" idx="4294967295"/>
+          </p:nvPr>
+        </p:nvSpPr>
+        <p:spPr>
+          <a:xfrm>
+            <a:off x="8092440" y="4736592"/>
+            <a:ext cx="548640" cy="228600"/>
+          </a:xfrm>
+          <a:prstGeom prst="rect">
+            <a:avLst/>
+          </a:prstGeom>
+          <a:extLst>
+            <a:ext uri="{C572A759-6A51-4108-AA02-DFA0A04FC94B}">
+              <ma14:wrappingTextBoxFlag xmlns:ma14="http://schemas.microsoft.com/office/mac/drawingml/2011/main" xmlns="" val="0"/>
+            </a:ext>
+          </a:extLst>
+        </p:spPr>
+        <p:txBody>
+          <a:bodyPr/>
+          <a:lstStyle>
+            <a:lvl1pPr>
+              <a:defRPr sz="800">
+                <a:solidFill>
+                  <a:srgbClr val="6B7585"/>
+                </a:solidFill>
+              </a:defRPr>
+            </a:lvl1pPr>
+          </a:lstStyle>
+          <a:p>
+            <a:pPr algn="r"/>
+            <a:fld id="{F7021451-1387-4CA6-816F-3879F97B5CBC}" type="slidenum">
+              <a:rPr lang="en-US" b="0"/>
+              <a:t>9</a:t>
+            </a:fld>
+            <a:endParaRPr lang="en-US"/>
+          </a:p>
+        </p:txBody>
+      </p:sp>
+      <p:sp>
+        <p:nvSpPr>
+          <p:cNvPr id="4" name="Text 5b"/>
+          <p:cNvSpPr txBox="1"/>
+          <p:nvPr/>
+        </p:nvSpPr>
+        <p:spPr>
+          <a:xfrm>
+            <a:off x="4663440" y="3867911"/>
+            <a:ext cx="3703320" cy="731520"/>
+          </a:xfrm>
+          <a:prstGeom prst="rect">
+            <a:avLst/>
+          </a:prstGeom>
+          <a:noFill/>
+          <a:ln/>
+        </p:spPr>
+        <p:txBody>
+          <a:bodyPr wrap="square" lIns="0" tIns="0" rIns="0" bIns="0" rtlCol="0" anchor="t">
+            <a:normAutofit fontScale="85000" lnSpcReduction="10000"/>
+          </a:bodyPr>
+          <a:lstStyle/>
+          <a:p>
+            <a:pPr marL="342900" indent="-342900">
+              <a:lnSpc>
+                <a:spcPts val="1050"/>
+              </a:lnSpc>
+              <a:spcAft>
+                <a:spcPts val="400"/>
+              </a:spcAft>
+              <a:buSzPct val="100000"/>
+              <a:buChar char="•"/>
+            </a:pPr>
+            <a:r>
+              <a:rPr lang="en-US" sz="1000">
+                <a:solidFill>
+                  <a:srgbClr val="3A4453"/>
+                </a:solidFill>
+              </a:rPr>
+              <a:t>Events carries 48% of all overhead on 13% of revenue, so a 78% margin still ends in a $54k loss.</a:t>
+            </a:r>
+            <a:endParaRPr lang="en-US" sz="850"/>
+          </a:p>
+          <a:p>
+            <a:pPr marL="342900" indent="-342900">
+              <a:lnSpc>
+                <a:spcPts val="1050"/>
+              </a:lnSpc>
+              <a:spcAft>
+                <a:spcPts val="400"/>
+              </a:spcAft>
+              <a:buSzPct val="100000"/>
+              <a:buChar char="•"/>
+            </a:pPr>
+            <a:r>
+              <a:rPr lang="en-US" sz="1000">
+                <a:solidFill>
+                  <a:srgbClr val="3A4453"/>
+                </a:solidFill>
+              </a:rPr>
+              <a:t>Consulting earned $74 of gross profit on $4k of revenue and carries $20k of overhead.</a:t>
+            </a:r>
+            <a:endParaRPr lang="en-US" sz="850"/>
+          </a:p>
+        </p:txBody>
+      </p:sp>
+      <p:pic>
+        <p:nvPicPr>
+          <p:cNvPr id="26" name="cts logo" descr="image.png"/>
+          <p:cNvPicPr>
+            <a:picLocks noChangeAspect="1"/>
+          </p:cNvPicPr>
+          <p:nvPr/>
+        </p:nvPicPr>
+        <p:blipFill>
+          <a:blip r:embed="rId2"/>
+          <a:stretch>
+            <a:fillRect/>
+          </a:stretch>
+        </p:blipFill>
+        <p:spPr>
+          <a:xfrm>
+            <a:off x="7680959" y="182880"/>
+            <a:ext cx="960120" cy="539696"/>
+          </a:xfrm>
+          <a:prstGeom prst="rect">
+            <a:avLst/>
+          </a:prstGeom>
+        </p:spPr>
+      </p:pic>
+    </p:spTree>
+  </p:cSld>
+  <p:clrMapOvr>
+    <a:masterClrMapping/>
+  </p:clrMapOvr>
+</p:sld>
+</file>
+
+<file path=ppt/slides/slide18.xml><?xml version="1.0" encoding="utf-8"?>
 <p:sld xmlns:a="http://schemas.openxmlformats.org/drawingml/2006/main" xmlns:r="http://schemas.openxmlformats.org/officeDocument/2006/relationships" xmlns:p="http://schemas.openxmlformats.org/presentationml/2006/main">
   <p:cSld name="Slide 7">
     <p:spTree>
@@ -9250,7 +9737,7 @@
                   <a:srgbClr val="242C39"/>
                 </a:solidFill>
               </a:rPr>
-              <a:t>Departmental result, September 2026</a:t>
+              <a:t>Departmental result in full, September 2026</a:t>
             </a:r>
             <a:endParaRPr lang="en-US" sz="2700" dirty="0"/>
           </a:p>
@@ -9552,7 +10039,7 @@
 </p:sld>
 </file>
 
-<file path=ppt/slides/slide18.xml><?xml version="1.0" encoding="utf-8"?>
+<file path=ppt/slides/slide19.xml><?xml version="1.0" encoding="utf-8"?>
 <p:sld xmlns:a="http://schemas.openxmlformats.org/drawingml/2006/main" xmlns:r="http://schemas.openxmlformats.org/officeDocument/2006/relationships" xmlns:p="http://schemas.openxmlformats.org/presentationml/2006/main">
   <p:cSld name="Slide 8">
     <p:spTree>
@@ -9929,412 +10416,6 @@
           </a:prstGeom>
         </p:spPr>
       </p:pic>
-    </p:spTree>
-  </p:cSld>
-  <p:clrMapOvr>
-    <a:masterClrMapping/>
-  </p:clrMapOvr>
-</p:sld>
-</file>
-
-<file path=ppt/slides/slide19.xml><?xml version="1.0" encoding="utf-8"?>
-<p:sld xmlns:a="http://schemas.openxmlformats.org/drawingml/2006/main" xmlns:r="http://schemas.openxmlformats.org/officeDocument/2006/relationships" xmlns:p="http://schemas.openxmlformats.org/presentationml/2006/main">
-  <p:cSld name="Slide 9">
-    <p:spTree>
-      <p:nvGrpSpPr>
-        <p:cNvPr id="1" name=""/>
-        <p:cNvGrpSpPr/>
-        <p:nvPr/>
-      </p:nvGrpSpPr>
-      <p:grpSpPr>
-        <a:xfrm>
-          <a:off x="0" y="0"/>
-          <a:ext cx="0" cy="0"/>
-          <a:chOff x="0" y="0"/>
-          <a:chExt cx="0" cy="0"/>
-        </a:xfrm>
-      </p:grpSpPr>
-      <p:pic>
-        <p:nvPicPr>
-          <p:cNvPr id="27" name="snip dept_Support" descr="dept_Support.png"/>
-          <p:cNvPicPr>
-            <a:picLocks noChangeAspect="1"/>
-          </p:cNvPicPr>
-          <p:nvPr/>
-        </p:nvPicPr>
-        <p:blipFill>
-          <a:blip r:embed="rId3"/>
-          <a:stretch>
-            <a:fillRect/>
-          </a:stretch>
-        </p:blipFill>
-        <p:spPr>
-          <a:xfrm>
-            <a:off x="974377" y="1005840"/>
-            <a:ext cx="7195245" cy="2130551"/>
-          </a:xfrm>
-          <a:prstGeom prst="rect">
-            <a:avLst/>
-          </a:prstGeom>
-        </p:spPr>
-      </p:pic>
-      <p:sp>
-        <p:nvSpPr>
-          <p:cNvPr id="2" name="Text 0"/>
-          <p:cNvSpPr txBox="1"/>
-          <p:nvPr/>
-        </p:nvSpPr>
-        <p:spPr>
-          <a:xfrm>
-            <a:off x="502920" y="365760"/>
-            <a:ext cx="6400800" cy="274320"/>
-          </a:xfrm>
-          <a:prstGeom prst="rect">
-            <a:avLst/>
-          </a:prstGeom>
-          <a:noFill/>
-          <a:ln/>
-        </p:spPr>
-        <p:txBody>
-          <a:bodyPr wrap="square" lIns="0" tIns="0" rIns="0" bIns="0" rtlCol="0" anchor="ctr"/>
-          <a:lstStyle/>
-          <a:p>
-            <a:pPr marL="0" indent="0">
-              <a:buNone/>
-            </a:pPr>
-            <a:r>
-              <a:rPr lang="en-US" sz="950" b="1" kern="0" spc="220">
-                <a:solidFill>
-                  <a:srgbClr val="122B82"/>
-                </a:solidFill>
-              </a:rPr>
-              <a:t>DEPARTMENTAL PERFORMANCE</a:t>
-            </a:r>
-            <a:endParaRPr lang="en-US" sz="950"/>
-          </a:p>
-        </p:txBody>
-      </p:sp>
-      <p:sp>
-        <p:nvSpPr>
-          <p:cNvPr id="3" name="Text 1"/>
-          <p:cNvSpPr txBox="1"/>
-          <p:nvPr/>
-        </p:nvSpPr>
-        <p:spPr>
-          <a:xfrm>
-            <a:off x="502920" y="640080"/>
-            <a:ext cx="7315200" cy="365760"/>
-          </a:xfrm>
-          <a:prstGeom prst="rect">
-            <a:avLst/>
-          </a:prstGeom>
-          <a:noFill/>
-          <a:ln/>
-        </p:spPr>
-        <p:txBody>
-          <a:bodyPr wrap="square" lIns="0" tIns="0" rIns="0" bIns="0" rtlCol="0" anchor="ctr"/>
-          <a:lstStyle/>
-          <a:p>
-            <a:pPr marL="0" indent="0" algn="ctr">
-              <a:buNone/>
-            </a:pPr>
-            <a:r>
-              <a:rPr lang="en-US" sz="2200" b="1" dirty="0">
-                <a:solidFill>
-                  <a:srgbClr val="242C39"/>
-                </a:solidFill>
-              </a:rPr>
-              <a:t>Support, September 2026</a:t>
-            </a:r>
-            <a:endParaRPr lang="en-US" sz="2700" dirty="0"/>
-          </a:p>
-        </p:txBody>
-      </p:sp>
-      <p:sp>
-        <p:nvSpPr>
-          <p:cNvPr id="6" name="commentary panel"/>
-          <p:cNvSpPr/>
-          <p:nvPr/>
-        </p:nvSpPr>
-        <p:spPr>
-          <a:xfrm>
-            <a:off x="502920" y="3227831"/>
-            <a:ext cx="8138160" cy="1399032"/>
-          </a:xfrm>
-          <a:prstGeom prst="rect">
-            <a:avLst/>
-          </a:prstGeom>
-          <a:solidFill>
-            <a:srgbClr val="E8F9F8"/>
-          </a:solidFill>
-          <a:ln/>
-        </p:spPr>
-        <p:txBody>
-          <a:bodyPr/>
-          <a:lstStyle/>
-          <a:p>
-            <a:endParaRPr lang="en-AU"/>
-          </a:p>
-        </p:txBody>
-      </p:sp>
-      <p:sp>
-        <p:nvSpPr>
-          <p:cNvPr id="7" name="Text 4"/>
-          <p:cNvSpPr txBox="1"/>
-          <p:nvPr/>
-        </p:nvSpPr>
-        <p:spPr>
-          <a:xfrm>
-            <a:off x="685800" y="3300983"/>
-            <a:ext cx="2743200" cy="228600"/>
-          </a:xfrm>
-          <a:prstGeom prst="rect">
-            <a:avLst/>
-          </a:prstGeom>
-          <a:noFill/>
-          <a:ln/>
-        </p:spPr>
-        <p:txBody>
-          <a:bodyPr wrap="square" lIns="0" tIns="0" rIns="0" bIns="0" rtlCol="0" anchor="ctr"/>
-          <a:lstStyle/>
-          <a:p>
-            <a:pPr marL="0" indent="0">
-              <a:buNone/>
-            </a:pPr>
-            <a:r>
-              <a:rPr lang="en-US" sz="900" b="1" kern="0" spc="180">
-                <a:solidFill>
-                  <a:srgbClr val="005358"/>
-                </a:solidFill>
-              </a:rPr>
-              <a:t>COMMENTARY</a:t>
-            </a:r>
-            <a:endParaRPr lang="en-US" sz="900"/>
-          </a:p>
-        </p:txBody>
-      </p:sp>
-      <p:sp>
-        <p:nvSpPr>
-          <p:cNvPr id="8" name="Text 5"/>
-          <p:cNvSpPr txBox="1"/>
-          <p:nvPr/>
-        </p:nvSpPr>
-        <p:spPr>
-          <a:xfrm>
-            <a:off x="685800" y="3474719"/>
-            <a:ext cx="3703320" cy="1124712"/>
-          </a:xfrm>
-          <a:prstGeom prst="rect">
-            <a:avLst/>
-          </a:prstGeom>
-          <a:noFill/>
-          <a:ln/>
-        </p:spPr>
-        <p:txBody>
-          <a:bodyPr wrap="square" lIns="0" tIns="0" rIns="0" bIns="0" rtlCol="0" anchor="t">
-            <a:normAutofit/>
-          </a:bodyPr>
-          <a:lstStyle/>
-          <a:p>
-            <a:pPr marL="342900" indent="-342900">
-              <a:lnSpc>
-                <a:spcPts val="1050"/>
-              </a:lnSpc>
-              <a:spcAft>
-                <a:spcPts val="400"/>
-              </a:spcAft>
-              <a:buSzPct val="100000"/>
-              <a:buChar char="•"/>
-            </a:pPr>
-            <a:r>
-              <a:rPr lang="en-US" sz="1000">
-                <a:solidFill>
-                  <a:srgbClr val="3A4453"/>
-                </a:solidFill>
-              </a:rPr>
-              <a:t>Support generated $243k revenue against a $248k budget, broadly in line with expected recurring contract income.</a:t>
-            </a:r>
-            <a:endParaRPr lang="en-US" sz="850"/>
-          </a:p>
-          <a:p>
-            <a:pPr marL="342900" indent="-342900">
-              <a:lnSpc>
-                <a:spcPts val="1050"/>
-              </a:lnSpc>
-              <a:spcAft>
-                <a:spcPts val="400"/>
-              </a:spcAft>
-              <a:buSzPct val="100000"/>
-              <a:buChar char="•"/>
-            </a:pPr>
-            <a:r>
-              <a:rPr lang="en-US" sz="1000">
-                <a:solidFill>
-                  <a:srgbClr val="3A4453"/>
-                </a:solidFill>
-              </a:rPr>
-              <a:t>Gross margin was 41.7%, compared with 41.0% in September last year.</a:t>
-            </a:r>
-            <a:endParaRPr lang="en-US" sz="850"/>
-          </a:p>
-        </p:txBody>
-      </p:sp>
-      <p:sp>
-        <p:nvSpPr>
-          <p:cNvPr id="25" name="Slide Number Placeholder 0"/>
-          <p:cNvSpPr>
-            <a:spLocks noGrp="1"/>
-          </p:cNvSpPr>
-          <p:nvPr>
-            <p:ph type="sldNum" sz="quarter" idx="4294967295"/>
-          </p:nvPr>
-        </p:nvSpPr>
-        <p:spPr>
-          <a:xfrm>
-            <a:off x="8092440" y="4736592"/>
-            <a:ext cx="548640" cy="228600"/>
-          </a:xfrm>
-          <a:prstGeom prst="rect">
-            <a:avLst/>
-          </a:prstGeom>
-          <a:extLst>
-            <a:ext uri="{C572A759-6A51-4108-AA02-DFA0A04FC94B}">
-              <ma14:wrappingTextBoxFlag xmlns:ma14="http://schemas.microsoft.com/office/mac/drawingml/2011/main" xmlns="" val="0"/>
-            </a:ext>
-          </a:extLst>
-        </p:spPr>
-        <p:txBody>
-          <a:bodyPr/>
-          <a:lstStyle>
-            <a:lvl1pPr>
-              <a:defRPr sz="800">
-                <a:solidFill>
-                  <a:srgbClr val="6B7585"/>
-                </a:solidFill>
-              </a:defRPr>
-            </a:lvl1pPr>
-          </a:lstStyle>
-          <a:p>
-            <a:pPr algn="r"/>
-            <a:fld id="{F7021451-1387-4CA6-816F-3879F97B5CBC}" type="slidenum">
-              <a:rPr lang="en-US" b="0"/>
-              <a:t>17</a:t>
-            </a:fld>
-            <a:endParaRPr lang="en-US"/>
-          </a:p>
-        </p:txBody>
-      </p:sp>
-      <p:pic>
-        <p:nvPicPr>
-          <p:cNvPr id="26" name="cts logo" descr="cts-logo.png"/>
-          <p:cNvPicPr>
-            <a:picLocks noChangeAspect="1"/>
-          </p:cNvPicPr>
-          <p:nvPr/>
-        </p:nvPicPr>
-        <p:blipFill>
-          <a:blip r:embed="rId4"/>
-          <a:stretch>
-            <a:fillRect/>
-          </a:stretch>
-        </p:blipFill>
-        <p:spPr>
-          <a:xfrm>
-            <a:off x="7680959" y="182880"/>
-            <a:ext cx="960120" cy="539696"/>
-          </a:xfrm>
-          <a:prstGeom prst="rect">
-            <a:avLst/>
-          </a:prstGeom>
-        </p:spPr>
-      </p:pic>
-      <p:sp>
-        <p:nvSpPr>
-          <p:cNvPr id="4" name="Text 5b"/>
-          <p:cNvSpPr txBox="1"/>
-          <p:nvPr/>
-        </p:nvSpPr>
-        <p:spPr>
-          <a:xfrm>
-            <a:off x="4663440" y="3474719"/>
-            <a:ext cx="3703320" cy="1124712"/>
-          </a:xfrm>
-          <a:prstGeom prst="rect">
-            <a:avLst/>
-          </a:prstGeom>
-          <a:noFill/>
-          <a:ln/>
-        </p:spPr>
-        <p:txBody>
-          <a:bodyPr wrap="square" lIns="0" tIns="0" rIns="0" bIns="0" rtlCol="0" anchor="t">
-            <a:normAutofit/>
-          </a:bodyPr>
-          <a:lstStyle/>
-          <a:p>
-            <a:pPr marL="342900" indent="-342900">
-              <a:lnSpc>
-                <a:spcPts val="1050"/>
-              </a:lnSpc>
-              <a:spcAft>
-                <a:spcPts val="400"/>
-              </a:spcAft>
-              <a:buSzPct val="100000"/>
-              <a:buChar char="•"/>
-            </a:pPr>
-            <a:r>
-              <a:rPr lang="en-US" sz="1000">
-                <a:solidFill>
-                  <a:srgbClr val="3A4453"/>
-                </a:solidFill>
-              </a:rPr>
-              <a:t>After $72k of allocated overheads, Support recorded a $29k profit.</a:t>
-            </a:r>
-            <a:endParaRPr lang="en-US" sz="850"/>
-          </a:p>
-          <a:p>
-            <a:pPr marL="342900" indent="-342900">
-              <a:lnSpc>
-                <a:spcPts val="1050"/>
-              </a:lnSpc>
-              <a:spcAft>
-                <a:spcPts val="400"/>
-              </a:spcAft>
-              <a:buSzPct val="100000"/>
-              <a:buChar char="•"/>
-            </a:pPr>
-            <a:r>
-              <a:rPr lang="en-US" sz="1000">
-                <a:solidFill>
-                  <a:srgbClr val="3A4453"/>
-                </a:solidFill>
-              </a:rPr>
-              <a:t>Its allocated office wages were $42k, reflecting the established allocation method.</a:t>
-            </a:r>
-            <a:endParaRPr lang="en-US" sz="850"/>
-          </a:p>
-          <a:p>
-            <a:pPr marL="342900" indent="-342900">
-              <a:lnSpc>
-                <a:spcPts val="1050"/>
-              </a:lnSpc>
-              <a:spcAft>
-                <a:spcPts val="400"/>
-              </a:spcAft>
-              <a:buSzPct val="100000"/>
-              <a:buChar char="•"/>
-            </a:pPr>
-            <a:r>
-              <a:rPr lang="en-US" sz="1000">
-                <a:solidFill>
-                  <a:srgbClr val="3A4453"/>
-                </a:solidFill>
-              </a:rPr>
-              <a:t>Chargeable utilisation reached 91.2%, above the 88% target and the strongest result across the groups.</a:t>
-            </a:r>
-            <a:endParaRPr lang="en-US" sz="850"/>
-          </a:p>
-        </p:txBody>
-      </p:sp>
     </p:spTree>
   </p:cSld>
   <p:clrMapOvr>
@@ -11321,6 +11402,412 @@
 
 <file path=ppt/slides/slide20.xml><?xml version="1.0" encoding="utf-8"?>
 <p:sld xmlns:a="http://schemas.openxmlformats.org/drawingml/2006/main" xmlns:r="http://schemas.openxmlformats.org/officeDocument/2006/relationships" xmlns:p="http://schemas.openxmlformats.org/presentationml/2006/main">
+  <p:cSld name="Slide 9">
+    <p:spTree>
+      <p:nvGrpSpPr>
+        <p:cNvPr id="1" name=""/>
+        <p:cNvGrpSpPr/>
+        <p:nvPr/>
+      </p:nvGrpSpPr>
+      <p:grpSpPr>
+        <a:xfrm>
+          <a:off x="0" y="0"/>
+          <a:ext cx="0" cy="0"/>
+          <a:chOff x="0" y="0"/>
+          <a:chExt cx="0" cy="0"/>
+        </a:xfrm>
+      </p:grpSpPr>
+      <p:pic>
+        <p:nvPicPr>
+          <p:cNvPr id="27" name="snip dept_Support" descr="dept_Support.png"/>
+          <p:cNvPicPr>
+            <a:picLocks noChangeAspect="1"/>
+          </p:cNvPicPr>
+          <p:nvPr/>
+        </p:nvPicPr>
+        <p:blipFill>
+          <a:blip r:embed="rId3"/>
+          <a:stretch>
+            <a:fillRect/>
+          </a:stretch>
+        </p:blipFill>
+        <p:spPr>
+          <a:xfrm>
+            <a:off x="974377" y="1005840"/>
+            <a:ext cx="7195245" cy="2130551"/>
+          </a:xfrm>
+          <a:prstGeom prst="rect">
+            <a:avLst/>
+          </a:prstGeom>
+        </p:spPr>
+      </p:pic>
+      <p:sp>
+        <p:nvSpPr>
+          <p:cNvPr id="2" name="Text 0"/>
+          <p:cNvSpPr txBox="1"/>
+          <p:nvPr/>
+        </p:nvSpPr>
+        <p:spPr>
+          <a:xfrm>
+            <a:off x="502920" y="365760"/>
+            <a:ext cx="6400800" cy="274320"/>
+          </a:xfrm>
+          <a:prstGeom prst="rect">
+            <a:avLst/>
+          </a:prstGeom>
+          <a:noFill/>
+          <a:ln/>
+        </p:spPr>
+        <p:txBody>
+          <a:bodyPr wrap="square" lIns="0" tIns="0" rIns="0" bIns="0" rtlCol="0" anchor="ctr"/>
+          <a:lstStyle/>
+          <a:p>
+            <a:pPr marL="0" indent="0">
+              <a:buNone/>
+            </a:pPr>
+            <a:r>
+              <a:rPr lang="en-US" sz="950" b="1" kern="0" spc="220">
+                <a:solidFill>
+                  <a:srgbClr val="122B82"/>
+                </a:solidFill>
+              </a:rPr>
+              <a:t>DEPARTMENTAL PERFORMANCE</a:t>
+            </a:r>
+            <a:endParaRPr lang="en-US" sz="950"/>
+          </a:p>
+        </p:txBody>
+      </p:sp>
+      <p:sp>
+        <p:nvSpPr>
+          <p:cNvPr id="3" name="Text 1"/>
+          <p:cNvSpPr txBox="1"/>
+          <p:nvPr/>
+        </p:nvSpPr>
+        <p:spPr>
+          <a:xfrm>
+            <a:off x="502920" y="640080"/>
+            <a:ext cx="7315200" cy="365760"/>
+          </a:xfrm>
+          <a:prstGeom prst="rect">
+            <a:avLst/>
+          </a:prstGeom>
+          <a:noFill/>
+          <a:ln/>
+        </p:spPr>
+        <p:txBody>
+          <a:bodyPr wrap="square" lIns="0" tIns="0" rIns="0" bIns="0" rtlCol="0" anchor="ctr"/>
+          <a:lstStyle/>
+          <a:p>
+            <a:pPr marL="0" indent="0" algn="ctr">
+              <a:buNone/>
+            </a:pPr>
+            <a:r>
+              <a:rPr lang="en-US" sz="2200" b="1" dirty="0">
+                <a:solidFill>
+                  <a:srgbClr val="242C39"/>
+                </a:solidFill>
+              </a:rPr>
+              <a:t>Support, September 2026</a:t>
+            </a:r>
+            <a:endParaRPr lang="en-US" sz="2700" dirty="0"/>
+          </a:p>
+        </p:txBody>
+      </p:sp>
+      <p:sp>
+        <p:nvSpPr>
+          <p:cNvPr id="6" name="commentary panel"/>
+          <p:cNvSpPr/>
+          <p:nvPr/>
+        </p:nvSpPr>
+        <p:spPr>
+          <a:xfrm>
+            <a:off x="502920" y="3227831"/>
+            <a:ext cx="8138160" cy="1399032"/>
+          </a:xfrm>
+          <a:prstGeom prst="rect">
+            <a:avLst/>
+          </a:prstGeom>
+          <a:solidFill>
+            <a:srgbClr val="E8F9F8"/>
+          </a:solidFill>
+          <a:ln/>
+        </p:spPr>
+        <p:txBody>
+          <a:bodyPr/>
+          <a:lstStyle/>
+          <a:p>
+            <a:endParaRPr lang="en-AU"/>
+          </a:p>
+        </p:txBody>
+      </p:sp>
+      <p:sp>
+        <p:nvSpPr>
+          <p:cNvPr id="7" name="Text 4"/>
+          <p:cNvSpPr txBox="1"/>
+          <p:nvPr/>
+        </p:nvSpPr>
+        <p:spPr>
+          <a:xfrm>
+            <a:off x="685800" y="3300983"/>
+            <a:ext cx="2743200" cy="228600"/>
+          </a:xfrm>
+          <a:prstGeom prst="rect">
+            <a:avLst/>
+          </a:prstGeom>
+          <a:noFill/>
+          <a:ln/>
+        </p:spPr>
+        <p:txBody>
+          <a:bodyPr wrap="square" lIns="0" tIns="0" rIns="0" bIns="0" rtlCol="0" anchor="ctr"/>
+          <a:lstStyle/>
+          <a:p>
+            <a:pPr marL="0" indent="0">
+              <a:buNone/>
+            </a:pPr>
+            <a:r>
+              <a:rPr lang="en-US" sz="900" b="1" kern="0" spc="180">
+                <a:solidFill>
+                  <a:srgbClr val="005358"/>
+                </a:solidFill>
+              </a:rPr>
+              <a:t>COMMENTARY</a:t>
+            </a:r>
+            <a:endParaRPr lang="en-US" sz="900"/>
+          </a:p>
+        </p:txBody>
+      </p:sp>
+      <p:sp>
+        <p:nvSpPr>
+          <p:cNvPr id="8" name="Text 5"/>
+          <p:cNvSpPr txBox="1"/>
+          <p:nvPr/>
+        </p:nvSpPr>
+        <p:spPr>
+          <a:xfrm>
+            <a:off x="685800" y="3474719"/>
+            <a:ext cx="3703320" cy="1124712"/>
+          </a:xfrm>
+          <a:prstGeom prst="rect">
+            <a:avLst/>
+          </a:prstGeom>
+          <a:noFill/>
+          <a:ln/>
+        </p:spPr>
+        <p:txBody>
+          <a:bodyPr wrap="square" lIns="0" tIns="0" rIns="0" bIns="0" rtlCol="0" anchor="t">
+            <a:normAutofit/>
+          </a:bodyPr>
+          <a:lstStyle/>
+          <a:p>
+            <a:pPr marL="342900" indent="-342900">
+              <a:lnSpc>
+                <a:spcPts val="1050"/>
+              </a:lnSpc>
+              <a:spcAft>
+                <a:spcPts val="400"/>
+              </a:spcAft>
+              <a:buSzPct val="100000"/>
+              <a:buChar char="•"/>
+            </a:pPr>
+            <a:r>
+              <a:rPr lang="en-US" sz="1000">
+                <a:solidFill>
+                  <a:srgbClr val="3A4453"/>
+                </a:solidFill>
+              </a:rPr>
+              <a:t>Support generated $243k revenue against a $248k budget, broadly in line with expected recurring contract income.</a:t>
+            </a:r>
+            <a:endParaRPr lang="en-US" sz="850"/>
+          </a:p>
+          <a:p>
+            <a:pPr marL="342900" indent="-342900">
+              <a:lnSpc>
+                <a:spcPts val="1050"/>
+              </a:lnSpc>
+              <a:spcAft>
+                <a:spcPts val="400"/>
+              </a:spcAft>
+              <a:buSzPct val="100000"/>
+              <a:buChar char="•"/>
+            </a:pPr>
+            <a:r>
+              <a:rPr lang="en-US" sz="1000">
+                <a:solidFill>
+                  <a:srgbClr val="3A4453"/>
+                </a:solidFill>
+              </a:rPr>
+              <a:t>Gross margin was 41.7%, compared with 41.0% in September last year.</a:t>
+            </a:r>
+            <a:endParaRPr lang="en-US" sz="850"/>
+          </a:p>
+        </p:txBody>
+      </p:sp>
+      <p:sp>
+        <p:nvSpPr>
+          <p:cNvPr id="25" name="Slide Number Placeholder 0"/>
+          <p:cNvSpPr>
+            <a:spLocks noGrp="1"/>
+          </p:cNvSpPr>
+          <p:nvPr>
+            <p:ph type="sldNum" sz="quarter" idx="4294967295"/>
+          </p:nvPr>
+        </p:nvSpPr>
+        <p:spPr>
+          <a:xfrm>
+            <a:off x="8092440" y="4736592"/>
+            <a:ext cx="548640" cy="228600"/>
+          </a:xfrm>
+          <a:prstGeom prst="rect">
+            <a:avLst/>
+          </a:prstGeom>
+          <a:extLst>
+            <a:ext uri="{C572A759-6A51-4108-AA02-DFA0A04FC94B}">
+              <ma14:wrappingTextBoxFlag xmlns:ma14="http://schemas.microsoft.com/office/mac/drawingml/2011/main" xmlns="" val="0"/>
+            </a:ext>
+          </a:extLst>
+        </p:spPr>
+        <p:txBody>
+          <a:bodyPr/>
+          <a:lstStyle>
+            <a:lvl1pPr>
+              <a:defRPr sz="800">
+                <a:solidFill>
+                  <a:srgbClr val="6B7585"/>
+                </a:solidFill>
+              </a:defRPr>
+            </a:lvl1pPr>
+          </a:lstStyle>
+          <a:p>
+            <a:pPr algn="r"/>
+            <a:fld id="{F7021451-1387-4CA6-816F-3879F97B5CBC}" type="slidenum">
+              <a:rPr lang="en-US" b="0"/>
+              <a:t>17</a:t>
+            </a:fld>
+            <a:endParaRPr lang="en-US"/>
+          </a:p>
+        </p:txBody>
+      </p:sp>
+      <p:pic>
+        <p:nvPicPr>
+          <p:cNvPr id="26" name="cts logo" descr="cts-logo.png"/>
+          <p:cNvPicPr>
+            <a:picLocks noChangeAspect="1"/>
+          </p:cNvPicPr>
+          <p:nvPr/>
+        </p:nvPicPr>
+        <p:blipFill>
+          <a:blip r:embed="rId4"/>
+          <a:stretch>
+            <a:fillRect/>
+          </a:stretch>
+        </p:blipFill>
+        <p:spPr>
+          <a:xfrm>
+            <a:off x="7680959" y="182880"/>
+            <a:ext cx="960120" cy="539696"/>
+          </a:xfrm>
+          <a:prstGeom prst="rect">
+            <a:avLst/>
+          </a:prstGeom>
+        </p:spPr>
+      </p:pic>
+      <p:sp>
+        <p:nvSpPr>
+          <p:cNvPr id="4" name="Text 5b"/>
+          <p:cNvSpPr txBox="1"/>
+          <p:nvPr/>
+        </p:nvSpPr>
+        <p:spPr>
+          <a:xfrm>
+            <a:off x="4663440" y="3474719"/>
+            <a:ext cx="3703320" cy="1124712"/>
+          </a:xfrm>
+          <a:prstGeom prst="rect">
+            <a:avLst/>
+          </a:prstGeom>
+          <a:noFill/>
+          <a:ln/>
+        </p:spPr>
+        <p:txBody>
+          <a:bodyPr wrap="square" lIns="0" tIns="0" rIns="0" bIns="0" rtlCol="0" anchor="t">
+            <a:normAutofit/>
+          </a:bodyPr>
+          <a:lstStyle/>
+          <a:p>
+            <a:pPr marL="342900" indent="-342900">
+              <a:lnSpc>
+                <a:spcPts val="1050"/>
+              </a:lnSpc>
+              <a:spcAft>
+                <a:spcPts val="400"/>
+              </a:spcAft>
+              <a:buSzPct val="100000"/>
+              <a:buChar char="•"/>
+            </a:pPr>
+            <a:r>
+              <a:rPr lang="en-US" sz="1000">
+                <a:solidFill>
+                  <a:srgbClr val="3A4453"/>
+                </a:solidFill>
+              </a:rPr>
+              <a:t>After $72k of allocated overheads, Support recorded a $29k profit.</a:t>
+            </a:r>
+            <a:endParaRPr lang="en-US" sz="850"/>
+          </a:p>
+          <a:p>
+            <a:pPr marL="342900" indent="-342900">
+              <a:lnSpc>
+                <a:spcPts val="1050"/>
+              </a:lnSpc>
+              <a:spcAft>
+                <a:spcPts val="400"/>
+              </a:spcAft>
+              <a:buSzPct val="100000"/>
+              <a:buChar char="•"/>
+            </a:pPr>
+            <a:r>
+              <a:rPr lang="en-US" sz="1000">
+                <a:solidFill>
+                  <a:srgbClr val="3A4453"/>
+                </a:solidFill>
+              </a:rPr>
+              <a:t>Its allocated office wages were $42k, reflecting the established allocation method.</a:t>
+            </a:r>
+            <a:endParaRPr lang="en-US" sz="850"/>
+          </a:p>
+          <a:p>
+            <a:pPr marL="342900" indent="-342900">
+              <a:lnSpc>
+                <a:spcPts val="1050"/>
+              </a:lnSpc>
+              <a:spcAft>
+                <a:spcPts val="400"/>
+              </a:spcAft>
+              <a:buSzPct val="100000"/>
+              <a:buChar char="•"/>
+            </a:pPr>
+            <a:r>
+              <a:rPr lang="en-US" sz="1000">
+                <a:solidFill>
+                  <a:srgbClr val="3A4453"/>
+                </a:solidFill>
+              </a:rPr>
+              <a:t>Chargeable utilisation reached 91.2%, above the 88% target and the strongest result across the groups.</a:t>
+            </a:r>
+            <a:endParaRPr lang="en-US" sz="850"/>
+          </a:p>
+        </p:txBody>
+      </p:sp>
+    </p:spTree>
+  </p:cSld>
+  <p:clrMapOvr>
+    <a:masterClrMapping/>
+  </p:clrMapOvr>
+</p:sld>
+</file>
+
+<file path=ppt/slides/slide21.xml><?xml version="1.0" encoding="utf-8"?>
+<p:sld xmlns:a="http://schemas.openxmlformats.org/drawingml/2006/main" xmlns:r="http://schemas.openxmlformats.org/officeDocument/2006/relationships" xmlns:p="http://schemas.openxmlformats.org/presentationml/2006/main">
   <p:cSld name="Slide 10">
     <p:spTree>
       <p:nvGrpSpPr>
@@ -11725,7 +12212,7 @@
 </p:sld>
 </file>
 
-<file path=ppt/slides/slide21.xml><?xml version="1.0" encoding="utf-8"?>
+<file path=ppt/slides/slide22.xml><?xml version="1.0" encoding="utf-8"?>
 <p:sld xmlns:a="http://schemas.openxmlformats.org/drawingml/2006/main" xmlns:r="http://schemas.openxmlformats.org/officeDocument/2006/relationships" xmlns:p="http://schemas.openxmlformats.org/presentationml/2006/main">
   <p:cSld name="Slide 11">
     <p:spTree>
@@ -12131,7 +12618,7 @@
 </p:sld>
 </file>
 
-<file path=ppt/slides/slide22.xml><?xml version="1.0" encoding="utf-8"?>
+<file path=ppt/slides/slide23.xml><?xml version="1.0" encoding="utf-8"?>
 <p:sld xmlns:a="http://schemas.openxmlformats.org/drawingml/2006/main" xmlns:r="http://schemas.openxmlformats.org/officeDocument/2006/relationships" xmlns:p="http://schemas.openxmlformats.org/presentationml/2006/main">
   <p:cSld name="Slide 12">
     <p:spTree>
@@ -12537,7 +13024,7 @@
 </p:sld>
 </file>
 
-<file path=ppt/slides/slide23.xml><?xml version="1.0" encoding="utf-8"?>
+<file path=ppt/slides/slide24.xml><?xml version="1.0" encoding="utf-8"?>
 <p:sld xmlns:a="http://schemas.openxmlformats.org/drawingml/2006/main" xmlns:r="http://schemas.openxmlformats.org/officeDocument/2006/relationships" xmlns:p="http://schemas.openxmlformats.org/presentationml/2006/main">
   <p:cSld name="Slide 13">
     <p:spTree>
@@ -12943,7 +13430,7 @@
 </p:sld>
 </file>
 
-<file path=ppt/slides/slide24.xml><?xml version="1.0" encoding="utf-8"?>
+<file path=ppt/slides/slide25.xml><?xml version="1.0" encoding="utf-8"?>
 <p:sld xmlns:a="http://schemas.openxmlformats.org/drawingml/2006/main" xmlns:r="http://schemas.openxmlformats.org/officeDocument/2006/relationships" xmlns:p="http://schemas.openxmlformats.org/presentationml/2006/main">
   <p:cSld name="Slide 14">
     <p:spTree>
@@ -13349,7 +13836,7 @@
 </p:sld>
 </file>
 
-<file path=ppt/slides/slide25.xml><?xml version="1.0" encoding="utf-8"?>
+<file path=ppt/slides/slide26.xml><?xml version="1.0" encoding="utf-8"?>
 <p:sld xmlns:a="http://schemas.openxmlformats.org/drawingml/2006/main" xmlns:r="http://schemas.openxmlformats.org/officeDocument/2006/relationships" xmlns:p="http://schemas.openxmlformats.org/presentationml/2006/main">
   <p:cSld name="Slide 15">
     <p:spTree>
@@ -13632,7 +14119,7 @@
 </p:sld>
 </file>
 
-<file path=ppt/slides/slide26.xml><?xml version="1.0" encoding="utf-8"?>
+<file path=ppt/slides/slide27.xml><?xml version="1.0" encoding="utf-8"?>
 <p:sld xmlns:a="http://schemas.openxmlformats.org/drawingml/2006/main" xmlns:r="http://schemas.openxmlformats.org/officeDocument/2006/relationships" xmlns:p="http://schemas.openxmlformats.org/presentationml/2006/main">
   <p:cSld name="Slide 16">
     <p:spTree>
@@ -14038,7 +14525,7 @@
 </p:sld>
 </file>
 
-<file path=ppt/slides/slide27.xml><?xml version="1.0" encoding="utf-8"?>
+<file path=ppt/slides/slide28.xml><?xml version="1.0" encoding="utf-8"?>
 <p:sld xmlns:a="http://schemas.openxmlformats.org/drawingml/2006/main" xmlns:r="http://schemas.openxmlformats.org/officeDocument/2006/relationships" xmlns:p="http://schemas.openxmlformats.org/presentationml/2006/main">
   <p:cSld name="Slide 17">
     <p:spTree>
@@ -14444,7 +14931,7 @@
 </p:sld>
 </file>
 
-<file path=ppt/slides/slide28.xml><?xml version="1.0" encoding="utf-8"?>
+<file path=ppt/slides/slide29.xml><?xml version="1.0" encoding="utf-8"?>
 <p:sld xmlns:a="http://schemas.openxmlformats.org/drawingml/2006/main" xmlns:r="http://schemas.openxmlformats.org/officeDocument/2006/relationships" xmlns:p="http://schemas.openxmlformats.org/presentationml/2006/main">
   <p:cSld name="Slide 18">
     <p:spTree>
@@ -14842,391 +15329,6 @@
           </a:p>
         </p:txBody>
       </p:sp>
-    </p:spTree>
-  </p:cSld>
-  <p:clrMapOvr>
-    <a:masterClrMapping/>
-  </p:clrMapOvr>
-</p:sld>
-</file>
-
-<file path=ppt/slides/slide29.xml><?xml version="1.0" encoding="utf-8"?>
-<p:sld xmlns:a="http://schemas.openxmlformats.org/drawingml/2006/main" xmlns:r="http://schemas.openxmlformats.org/officeDocument/2006/relationships" xmlns:p="http://schemas.openxmlformats.org/presentationml/2006/main">
-  <p:cSld name="Slide 19">
-    <p:spTree>
-      <p:nvGrpSpPr>
-        <p:cNvPr id="1" name=""/>
-        <p:cNvGrpSpPr/>
-        <p:nvPr/>
-      </p:nvGrpSpPr>
-      <p:grpSpPr>
-        <a:xfrm>
-          <a:off x="0" y="0"/>
-          <a:ext cx="0" cy="0"/>
-          <a:chOff x="0" y="0"/>
-          <a:chExt cx="0" cy="0"/>
-        </a:xfrm>
-      </p:grpSpPr>
-      <p:sp>
-        <p:nvSpPr>
-          <p:cNvPr id="2" name="Text 0"/>
-          <p:cNvSpPr txBox="1"/>
-          <p:nvPr/>
-        </p:nvSpPr>
-        <p:spPr>
-          <a:xfrm>
-            <a:off x="502920" y="365760"/>
-            <a:ext cx="6400800" cy="274320"/>
-          </a:xfrm>
-          <a:prstGeom prst="rect">
-            <a:avLst/>
-          </a:prstGeom>
-          <a:noFill/>
-          <a:ln/>
-        </p:spPr>
-        <p:txBody>
-          <a:bodyPr wrap="square" lIns="0" tIns="0" rIns="0" bIns="0" rtlCol="0" anchor="ctr"/>
-          <a:lstStyle/>
-          <a:p>
-            <a:pPr marL="0" indent="0">
-              <a:buNone/>
-            </a:pPr>
-            <a:r>
-              <a:rPr lang="en-US" sz="950" b="1" kern="0" spc="220">
-                <a:solidFill>
-                  <a:srgbClr val="122B82"/>
-                </a:solidFill>
-              </a:rPr>
-              <a:t>OPERATING EXPENDITURE</a:t>
-            </a:r>
-            <a:endParaRPr lang="en-US" sz="950"/>
-          </a:p>
-        </p:txBody>
-      </p:sp>
-      <p:sp>
-        <p:nvSpPr>
-          <p:cNvPr id="3" name="Text 1"/>
-          <p:cNvSpPr txBox="1"/>
-          <p:nvPr/>
-        </p:nvSpPr>
-        <p:spPr>
-          <a:xfrm>
-            <a:off x="502920" y="640080"/>
-            <a:ext cx="7315200" cy="365760"/>
-          </a:xfrm>
-          <a:prstGeom prst="rect">
-            <a:avLst/>
-          </a:prstGeom>
-          <a:noFill/>
-          <a:ln/>
-        </p:spPr>
-        <p:txBody>
-          <a:bodyPr wrap="square" lIns="0" tIns="0" rIns="0" bIns="0" rtlCol="0" anchor="ctr"/>
-          <a:lstStyle/>
-          <a:p>
-            <a:pPr marL="0" indent="0" algn="ctr">
-              <a:buNone/>
-            </a:pPr>
-            <a:r>
-              <a:rPr lang="en-US" sz="2200" b="1">
-                <a:solidFill>
-                  <a:srgbClr val="242C39"/>
-                </a:solidFill>
-              </a:rPr>
-              <a:t>Employment expense by function</a:t>
-            </a:r>
-            <a:endParaRPr lang="en-US" sz="2700"/>
-          </a:p>
-        </p:txBody>
-      </p:sp>
-      <p:pic>
-        <p:nvPicPr>
-          <p:cNvPr id="4" name="snip staff_split" descr="/home/user/Claude/deck/snips/staff_split.png"/>
-          <p:cNvPicPr>
-            <a:picLocks noChangeAspect="1"/>
-          </p:cNvPicPr>
-          <p:nvPr/>
-        </p:nvPicPr>
-        <p:blipFill>
-          <a:blip r:embed="rId3"/>
-          <a:stretch>
-            <a:fillRect/>
-          </a:stretch>
-        </p:blipFill>
-        <p:spPr>
-          <a:xfrm>
-            <a:off x="587228" y="1005840"/>
-            <a:ext cx="7969542" cy="2130551"/>
-          </a:xfrm>
-          <a:prstGeom prst="rect">
-            <a:avLst/>
-          </a:prstGeom>
-        </p:spPr>
-      </p:pic>
-      <p:sp>
-        <p:nvSpPr>
-          <p:cNvPr id="6" name="commentary panel"/>
-          <p:cNvSpPr/>
-          <p:nvPr/>
-        </p:nvSpPr>
-        <p:spPr>
-          <a:xfrm>
-            <a:off x="502920" y="3227831"/>
-            <a:ext cx="8138160" cy="1399032"/>
-          </a:xfrm>
-          <a:prstGeom prst="rect">
-            <a:avLst/>
-          </a:prstGeom>
-          <a:solidFill>
-            <a:srgbClr val="E8F9F8"/>
-          </a:solidFill>
-          <a:ln/>
-        </p:spPr>
-        <p:txBody>
-          <a:bodyPr/>
-          <a:lstStyle/>
-          <a:p>
-            <a:endParaRPr lang="en-AU"/>
-          </a:p>
-        </p:txBody>
-      </p:sp>
-      <p:sp>
-        <p:nvSpPr>
-          <p:cNvPr id="7" name="Text 4"/>
-          <p:cNvSpPr txBox="1"/>
-          <p:nvPr/>
-        </p:nvSpPr>
-        <p:spPr>
-          <a:xfrm>
-            <a:off x="685800" y="3300983"/>
-            <a:ext cx="2743200" cy="228600"/>
-          </a:xfrm>
-          <a:prstGeom prst="rect">
-            <a:avLst/>
-          </a:prstGeom>
-          <a:noFill/>
-          <a:ln/>
-        </p:spPr>
-        <p:txBody>
-          <a:bodyPr wrap="square" lIns="0" tIns="0" rIns="0" bIns="0" rtlCol="0" anchor="ctr"/>
-          <a:lstStyle/>
-          <a:p>
-            <a:pPr marL="0" indent="0">
-              <a:buNone/>
-            </a:pPr>
-            <a:r>
-              <a:rPr lang="en-US" sz="850" b="1" kern="0" spc="180">
-                <a:solidFill>
-                  <a:srgbClr val="005358"/>
-                </a:solidFill>
-              </a:rPr>
-              <a:t>COMMENTARY</a:t>
-            </a:r>
-            <a:endParaRPr lang="en-US" sz="850"/>
-          </a:p>
-        </p:txBody>
-      </p:sp>
-      <p:sp>
-        <p:nvSpPr>
-          <p:cNvPr id="8" name="Text 5"/>
-          <p:cNvSpPr txBox="1"/>
-          <p:nvPr/>
-        </p:nvSpPr>
-        <p:spPr>
-          <a:xfrm>
-            <a:off x="685800" y="3474719"/>
-            <a:ext cx="3703320" cy="1124712"/>
-          </a:xfrm>
-          <a:prstGeom prst="rect">
-            <a:avLst/>
-          </a:prstGeom>
-          <a:noFill/>
-          <a:ln/>
-        </p:spPr>
-        <p:txBody>
-          <a:bodyPr wrap="square" lIns="0" tIns="0" rIns="0" bIns="0" rtlCol="0" anchor="t">
-            <a:normAutofit/>
-          </a:bodyPr>
-          <a:lstStyle/>
-          <a:p>
-            <a:pPr marL="342900" indent="-342900">
-              <a:lnSpc>
-                <a:spcPts val="1050"/>
-              </a:lnSpc>
-              <a:spcAft>
-                <a:spcPts val="300"/>
-              </a:spcAft>
-              <a:buSzPct val="100000"/>
-              <a:buChar char="•"/>
-            </a:pPr>
-            <a:r>
-              <a:rPr lang="en-US" sz="1000">
-                <a:solidFill>
-                  <a:srgbClr val="3A4453"/>
-                </a:solidFill>
-              </a:rPr>
-              <a:t>Office employment costs totalled $63,077 in September and were allocated across departments.</a:t>
-            </a:r>
-            <a:endParaRPr lang="en-US" sz="850"/>
-          </a:p>
-          <a:p>
-            <a:pPr marL="342900" indent="-342900">
-              <a:lnSpc>
-                <a:spcPts val="1050"/>
-              </a:lnSpc>
-              <a:spcAft>
-                <a:spcPts val="300"/>
-              </a:spcAft>
-              <a:buSzPct val="100000"/>
-              <a:buChar char="•"/>
-            </a:pPr>
-            <a:r>
-              <a:rPr lang="en-US" sz="1000">
-                <a:solidFill>
-                  <a:srgbClr val="3A4453"/>
-                </a:solidFill>
-              </a:rPr>
-              <a:t>Support received approximately 67% of the allocation under the rolling-hours methodology.</a:t>
-            </a:r>
-            <a:endParaRPr lang="en-US" sz="850"/>
-          </a:p>
-        </p:txBody>
-      </p:sp>
-      <p:sp>
-        <p:nvSpPr>
-          <p:cNvPr id="9" name="Text 5b"/>
-          <p:cNvSpPr txBox="1"/>
-          <p:nvPr/>
-        </p:nvSpPr>
-        <p:spPr>
-          <a:xfrm>
-            <a:off x="4663440" y="3474719"/>
-            <a:ext cx="3703320" cy="1124712"/>
-          </a:xfrm>
-          <a:prstGeom prst="rect">
-            <a:avLst/>
-          </a:prstGeom>
-          <a:noFill/>
-          <a:ln/>
-        </p:spPr>
-        <p:txBody>
-          <a:bodyPr wrap="square" lIns="0" tIns="0" rIns="0" bIns="0" rtlCol="0" anchor="t">
-            <a:normAutofit/>
-          </a:bodyPr>
-          <a:lstStyle/>
-          <a:p>
-            <a:pPr marL="342900" indent="-342900">
-              <a:lnSpc>
-                <a:spcPts val="1050"/>
-              </a:lnSpc>
-              <a:spcAft>
-                <a:spcPts val="300"/>
-              </a:spcAft>
-              <a:buSzPct val="100000"/>
-              <a:buChar char="•"/>
-            </a:pPr>
-            <a:r>
-              <a:rPr lang="en-US" sz="1000">
-                <a:solidFill>
-                  <a:srgbClr val="3A4453"/>
-                </a:solidFill>
-              </a:rPr>
-              <a:t>Events incurred $35,665 in direct departmental employment costs, alongside $15,294 in allocated office wages.</a:t>
-            </a:r>
-            <a:endParaRPr lang="en-US" sz="850"/>
-          </a:p>
-          <a:p>
-            <a:pPr marL="342900" indent="-342900">
-              <a:lnSpc>
-                <a:spcPts val="1050"/>
-              </a:lnSpc>
-              <a:spcAft>
-                <a:spcPts val="300"/>
-              </a:spcAft>
-              <a:buSzPct val="100000"/>
-              <a:buChar char="•"/>
-            </a:pPr>
-            <a:r>
-              <a:rPr lang="en-US" sz="1000">
-                <a:solidFill>
-                  <a:srgbClr val="3A4453"/>
-                </a:solidFill>
-              </a:rPr>
-              <a:t>Integration was allocated $269 in office wages, reflecting its comparatively low share under the allocation methodology.</a:t>
-            </a:r>
-            <a:endParaRPr lang="en-US" sz="850"/>
-          </a:p>
-        </p:txBody>
-      </p:sp>
-      <p:sp>
-        <p:nvSpPr>
-          <p:cNvPr id="25" name="Slide Number Placeholder 0"/>
-          <p:cNvSpPr>
-            <a:spLocks noGrp="1"/>
-          </p:cNvSpPr>
-          <p:nvPr>
-            <p:ph type="sldNum" sz="quarter" idx="4294967295"/>
-          </p:nvPr>
-        </p:nvSpPr>
-        <p:spPr>
-          <a:xfrm>
-            <a:off x="8092440" y="4736592"/>
-            <a:ext cx="548640" cy="228600"/>
-          </a:xfrm>
-          <a:prstGeom prst="rect">
-            <a:avLst/>
-          </a:prstGeom>
-          <a:extLst>
-            <a:ext uri="{C572A759-6A51-4108-AA02-DFA0A04FC94B}">
-              <ma14:wrappingTextBoxFlag xmlns:ma14="http://schemas.microsoft.com/office/mac/drawingml/2011/main" xmlns="" val="0"/>
-            </a:ext>
-          </a:extLst>
-        </p:spPr>
-        <p:txBody>
-          <a:bodyPr/>
-          <a:lstStyle>
-            <a:lvl1pPr>
-              <a:defRPr sz="800">
-                <a:solidFill>
-                  <a:srgbClr val="6B7585"/>
-                </a:solidFill>
-              </a:defRPr>
-            </a:lvl1pPr>
-          </a:lstStyle>
-          <a:p>
-            <a:pPr algn="r"/>
-            <a:fld id="{F7021451-1387-4CA6-816F-3879F97B5CBC}" type="slidenum">
-              <a:rPr lang="en-US" b="0"/>
-              <a:t>27</a:t>
-            </a:fld>
-            <a:endParaRPr lang="en-US"/>
-          </a:p>
-        </p:txBody>
-      </p:sp>
-      <p:pic>
-        <p:nvPicPr>
-          <p:cNvPr id="26" name="cts logo" descr="cts-logo.png"/>
-          <p:cNvPicPr>
-            <a:picLocks noChangeAspect="1"/>
-          </p:cNvPicPr>
-          <p:nvPr/>
-        </p:nvPicPr>
-        <p:blipFill>
-          <a:blip r:embed="rId4"/>
-          <a:stretch>
-            <a:fillRect/>
-          </a:stretch>
-        </p:blipFill>
-        <p:spPr>
-          <a:xfrm>
-            <a:off x="7680959" y="182880"/>
-            <a:ext cx="960120" cy="539696"/>
-          </a:xfrm>
-          <a:prstGeom prst="rect">
-            <a:avLst/>
-          </a:prstGeom>
-        </p:spPr>
-      </p:pic>
     </p:spTree>
   </p:cSld>
   <p:clrMapOvr>
@@ -17489,6 +17591,391 @@
 
 <file path=ppt/slides/slide30.xml><?xml version="1.0" encoding="utf-8"?>
 <p:sld xmlns:a="http://schemas.openxmlformats.org/drawingml/2006/main" xmlns:r="http://schemas.openxmlformats.org/officeDocument/2006/relationships" xmlns:p="http://schemas.openxmlformats.org/presentationml/2006/main">
+  <p:cSld name="Slide 19">
+    <p:spTree>
+      <p:nvGrpSpPr>
+        <p:cNvPr id="1" name=""/>
+        <p:cNvGrpSpPr/>
+        <p:nvPr/>
+      </p:nvGrpSpPr>
+      <p:grpSpPr>
+        <a:xfrm>
+          <a:off x="0" y="0"/>
+          <a:ext cx="0" cy="0"/>
+          <a:chOff x="0" y="0"/>
+          <a:chExt cx="0" cy="0"/>
+        </a:xfrm>
+      </p:grpSpPr>
+      <p:sp>
+        <p:nvSpPr>
+          <p:cNvPr id="2" name="Text 0"/>
+          <p:cNvSpPr txBox="1"/>
+          <p:nvPr/>
+        </p:nvSpPr>
+        <p:spPr>
+          <a:xfrm>
+            <a:off x="502920" y="365760"/>
+            <a:ext cx="6400800" cy="274320"/>
+          </a:xfrm>
+          <a:prstGeom prst="rect">
+            <a:avLst/>
+          </a:prstGeom>
+          <a:noFill/>
+          <a:ln/>
+        </p:spPr>
+        <p:txBody>
+          <a:bodyPr wrap="square" lIns="0" tIns="0" rIns="0" bIns="0" rtlCol="0" anchor="ctr"/>
+          <a:lstStyle/>
+          <a:p>
+            <a:pPr marL="0" indent="0">
+              <a:buNone/>
+            </a:pPr>
+            <a:r>
+              <a:rPr lang="en-US" sz="950" b="1" kern="0" spc="220">
+                <a:solidFill>
+                  <a:srgbClr val="122B82"/>
+                </a:solidFill>
+              </a:rPr>
+              <a:t>OPERATING EXPENDITURE</a:t>
+            </a:r>
+            <a:endParaRPr lang="en-US" sz="950"/>
+          </a:p>
+        </p:txBody>
+      </p:sp>
+      <p:sp>
+        <p:nvSpPr>
+          <p:cNvPr id="3" name="Text 1"/>
+          <p:cNvSpPr txBox="1"/>
+          <p:nvPr/>
+        </p:nvSpPr>
+        <p:spPr>
+          <a:xfrm>
+            <a:off x="502920" y="640080"/>
+            <a:ext cx="7315200" cy="365760"/>
+          </a:xfrm>
+          <a:prstGeom prst="rect">
+            <a:avLst/>
+          </a:prstGeom>
+          <a:noFill/>
+          <a:ln/>
+        </p:spPr>
+        <p:txBody>
+          <a:bodyPr wrap="square" lIns="0" tIns="0" rIns="0" bIns="0" rtlCol="0" anchor="ctr"/>
+          <a:lstStyle/>
+          <a:p>
+            <a:pPr marL="0" indent="0" algn="ctr">
+              <a:buNone/>
+            </a:pPr>
+            <a:r>
+              <a:rPr lang="en-US" sz="2200" b="1">
+                <a:solidFill>
+                  <a:srgbClr val="242C39"/>
+                </a:solidFill>
+              </a:rPr>
+              <a:t>Employment expense by function</a:t>
+            </a:r>
+            <a:endParaRPr lang="en-US" sz="2700"/>
+          </a:p>
+        </p:txBody>
+      </p:sp>
+      <p:pic>
+        <p:nvPicPr>
+          <p:cNvPr id="4" name="snip staff_split" descr="/home/user/Claude/deck/snips/staff_split.png"/>
+          <p:cNvPicPr>
+            <a:picLocks noChangeAspect="1"/>
+          </p:cNvPicPr>
+          <p:nvPr/>
+        </p:nvPicPr>
+        <p:blipFill>
+          <a:blip r:embed="rId3"/>
+          <a:stretch>
+            <a:fillRect/>
+          </a:stretch>
+        </p:blipFill>
+        <p:spPr>
+          <a:xfrm>
+            <a:off x="587228" y="1005840"/>
+            <a:ext cx="7969542" cy="2130551"/>
+          </a:xfrm>
+          <a:prstGeom prst="rect">
+            <a:avLst/>
+          </a:prstGeom>
+        </p:spPr>
+      </p:pic>
+      <p:sp>
+        <p:nvSpPr>
+          <p:cNvPr id="6" name="commentary panel"/>
+          <p:cNvSpPr/>
+          <p:nvPr/>
+        </p:nvSpPr>
+        <p:spPr>
+          <a:xfrm>
+            <a:off x="502920" y="3227831"/>
+            <a:ext cx="8138160" cy="1399032"/>
+          </a:xfrm>
+          <a:prstGeom prst="rect">
+            <a:avLst/>
+          </a:prstGeom>
+          <a:solidFill>
+            <a:srgbClr val="E8F9F8"/>
+          </a:solidFill>
+          <a:ln/>
+        </p:spPr>
+        <p:txBody>
+          <a:bodyPr/>
+          <a:lstStyle/>
+          <a:p>
+            <a:endParaRPr lang="en-AU"/>
+          </a:p>
+        </p:txBody>
+      </p:sp>
+      <p:sp>
+        <p:nvSpPr>
+          <p:cNvPr id="7" name="Text 4"/>
+          <p:cNvSpPr txBox="1"/>
+          <p:nvPr/>
+        </p:nvSpPr>
+        <p:spPr>
+          <a:xfrm>
+            <a:off x="685800" y="3300983"/>
+            <a:ext cx="2743200" cy="228600"/>
+          </a:xfrm>
+          <a:prstGeom prst="rect">
+            <a:avLst/>
+          </a:prstGeom>
+          <a:noFill/>
+          <a:ln/>
+        </p:spPr>
+        <p:txBody>
+          <a:bodyPr wrap="square" lIns="0" tIns="0" rIns="0" bIns="0" rtlCol="0" anchor="ctr"/>
+          <a:lstStyle/>
+          <a:p>
+            <a:pPr marL="0" indent="0">
+              <a:buNone/>
+            </a:pPr>
+            <a:r>
+              <a:rPr lang="en-US" sz="850" b="1" kern="0" spc="180">
+                <a:solidFill>
+                  <a:srgbClr val="005358"/>
+                </a:solidFill>
+              </a:rPr>
+              <a:t>COMMENTARY</a:t>
+            </a:r>
+            <a:endParaRPr lang="en-US" sz="850"/>
+          </a:p>
+        </p:txBody>
+      </p:sp>
+      <p:sp>
+        <p:nvSpPr>
+          <p:cNvPr id="8" name="Text 5"/>
+          <p:cNvSpPr txBox="1"/>
+          <p:nvPr/>
+        </p:nvSpPr>
+        <p:spPr>
+          <a:xfrm>
+            <a:off x="685800" y="3474719"/>
+            <a:ext cx="3703320" cy="1124712"/>
+          </a:xfrm>
+          <a:prstGeom prst="rect">
+            <a:avLst/>
+          </a:prstGeom>
+          <a:noFill/>
+          <a:ln/>
+        </p:spPr>
+        <p:txBody>
+          <a:bodyPr wrap="square" lIns="0" tIns="0" rIns="0" bIns="0" rtlCol="0" anchor="t">
+            <a:normAutofit/>
+          </a:bodyPr>
+          <a:lstStyle/>
+          <a:p>
+            <a:pPr marL="342900" indent="-342900">
+              <a:lnSpc>
+                <a:spcPts val="1050"/>
+              </a:lnSpc>
+              <a:spcAft>
+                <a:spcPts val="300"/>
+              </a:spcAft>
+              <a:buSzPct val="100000"/>
+              <a:buChar char="•"/>
+            </a:pPr>
+            <a:r>
+              <a:rPr lang="en-US" sz="1000">
+                <a:solidFill>
+                  <a:srgbClr val="3A4453"/>
+                </a:solidFill>
+              </a:rPr>
+              <a:t>Office employment costs totalled $63,077 in September and were allocated across departments.</a:t>
+            </a:r>
+            <a:endParaRPr lang="en-US" sz="850"/>
+          </a:p>
+          <a:p>
+            <a:pPr marL="342900" indent="-342900">
+              <a:lnSpc>
+                <a:spcPts val="1050"/>
+              </a:lnSpc>
+              <a:spcAft>
+                <a:spcPts val="300"/>
+              </a:spcAft>
+              <a:buSzPct val="100000"/>
+              <a:buChar char="•"/>
+            </a:pPr>
+            <a:r>
+              <a:rPr lang="en-US" sz="1000">
+                <a:solidFill>
+                  <a:srgbClr val="3A4453"/>
+                </a:solidFill>
+              </a:rPr>
+              <a:t>Support received approximately 67% of the allocation under the rolling-hours methodology.</a:t>
+            </a:r>
+            <a:endParaRPr lang="en-US" sz="850"/>
+          </a:p>
+        </p:txBody>
+      </p:sp>
+      <p:sp>
+        <p:nvSpPr>
+          <p:cNvPr id="9" name="Text 5b"/>
+          <p:cNvSpPr txBox="1"/>
+          <p:nvPr/>
+        </p:nvSpPr>
+        <p:spPr>
+          <a:xfrm>
+            <a:off x="4663440" y="3474719"/>
+            <a:ext cx="3703320" cy="1124712"/>
+          </a:xfrm>
+          <a:prstGeom prst="rect">
+            <a:avLst/>
+          </a:prstGeom>
+          <a:noFill/>
+          <a:ln/>
+        </p:spPr>
+        <p:txBody>
+          <a:bodyPr wrap="square" lIns="0" tIns="0" rIns="0" bIns="0" rtlCol="0" anchor="t">
+            <a:normAutofit/>
+          </a:bodyPr>
+          <a:lstStyle/>
+          <a:p>
+            <a:pPr marL="342900" indent="-342900">
+              <a:lnSpc>
+                <a:spcPts val="1050"/>
+              </a:lnSpc>
+              <a:spcAft>
+                <a:spcPts val="300"/>
+              </a:spcAft>
+              <a:buSzPct val="100000"/>
+              <a:buChar char="•"/>
+            </a:pPr>
+            <a:r>
+              <a:rPr lang="en-US" sz="1000">
+                <a:solidFill>
+                  <a:srgbClr val="3A4453"/>
+                </a:solidFill>
+              </a:rPr>
+              <a:t>Events incurred $35,665 in direct departmental employment costs, alongside $15,294 in allocated office wages.</a:t>
+            </a:r>
+            <a:endParaRPr lang="en-US" sz="850"/>
+          </a:p>
+          <a:p>
+            <a:pPr marL="342900" indent="-342900">
+              <a:lnSpc>
+                <a:spcPts val="1050"/>
+              </a:lnSpc>
+              <a:spcAft>
+                <a:spcPts val="300"/>
+              </a:spcAft>
+              <a:buSzPct val="100000"/>
+              <a:buChar char="•"/>
+            </a:pPr>
+            <a:r>
+              <a:rPr lang="en-US" sz="1000">
+                <a:solidFill>
+                  <a:srgbClr val="3A4453"/>
+                </a:solidFill>
+              </a:rPr>
+              <a:t>Integration was allocated $269 in office wages, reflecting its comparatively low share under the allocation methodology.</a:t>
+            </a:r>
+            <a:endParaRPr lang="en-US" sz="850"/>
+          </a:p>
+        </p:txBody>
+      </p:sp>
+      <p:sp>
+        <p:nvSpPr>
+          <p:cNvPr id="25" name="Slide Number Placeholder 0"/>
+          <p:cNvSpPr>
+            <a:spLocks noGrp="1"/>
+          </p:cNvSpPr>
+          <p:nvPr>
+            <p:ph type="sldNum" sz="quarter" idx="4294967295"/>
+          </p:nvPr>
+        </p:nvSpPr>
+        <p:spPr>
+          <a:xfrm>
+            <a:off x="8092440" y="4736592"/>
+            <a:ext cx="548640" cy="228600"/>
+          </a:xfrm>
+          <a:prstGeom prst="rect">
+            <a:avLst/>
+          </a:prstGeom>
+          <a:extLst>
+            <a:ext uri="{C572A759-6A51-4108-AA02-DFA0A04FC94B}">
+              <ma14:wrappingTextBoxFlag xmlns:ma14="http://schemas.microsoft.com/office/mac/drawingml/2011/main" xmlns="" val="0"/>
+            </a:ext>
+          </a:extLst>
+        </p:spPr>
+        <p:txBody>
+          <a:bodyPr/>
+          <a:lstStyle>
+            <a:lvl1pPr>
+              <a:defRPr sz="800">
+                <a:solidFill>
+                  <a:srgbClr val="6B7585"/>
+                </a:solidFill>
+              </a:defRPr>
+            </a:lvl1pPr>
+          </a:lstStyle>
+          <a:p>
+            <a:pPr algn="r"/>
+            <a:fld id="{F7021451-1387-4CA6-816F-3879F97B5CBC}" type="slidenum">
+              <a:rPr lang="en-US" b="0"/>
+              <a:t>27</a:t>
+            </a:fld>
+            <a:endParaRPr lang="en-US"/>
+          </a:p>
+        </p:txBody>
+      </p:sp>
+      <p:pic>
+        <p:nvPicPr>
+          <p:cNvPr id="26" name="cts logo" descr="cts-logo.png"/>
+          <p:cNvPicPr>
+            <a:picLocks noChangeAspect="1"/>
+          </p:cNvPicPr>
+          <p:nvPr/>
+        </p:nvPicPr>
+        <p:blipFill>
+          <a:blip r:embed="rId4"/>
+          <a:stretch>
+            <a:fillRect/>
+          </a:stretch>
+        </p:blipFill>
+        <p:spPr>
+          <a:xfrm>
+            <a:off x="7680959" y="182880"/>
+            <a:ext cx="960120" cy="539696"/>
+          </a:xfrm>
+          <a:prstGeom prst="rect">
+            <a:avLst/>
+          </a:prstGeom>
+        </p:spPr>
+      </p:pic>
+    </p:spTree>
+  </p:cSld>
+  <p:clrMapOvr>
+    <a:masterClrMapping/>
+  </p:clrMapOvr>
+</p:sld>
+</file>
+
+<file path=ppt/slides/slide31.xml><?xml version="1.0" encoding="utf-8"?>
+<p:sld xmlns:a="http://schemas.openxmlformats.org/drawingml/2006/main" xmlns:r="http://schemas.openxmlformats.org/officeDocument/2006/relationships" xmlns:p="http://schemas.openxmlformats.org/presentationml/2006/main">
   <p:cSld name="Slide 20">
     <p:spTree>
       <p:nvGrpSpPr>
@@ -17770,7 +18257,7 @@
 </p:sld>
 </file>
 
-<file path=ppt/slides/slide31.xml><?xml version="1.0" encoding="utf-8"?>
+<file path=ppt/slides/slide32.xml><?xml version="1.0" encoding="utf-8"?>
 <p:sld xmlns:a="http://schemas.openxmlformats.org/drawingml/2006/main" xmlns:r="http://schemas.openxmlformats.org/officeDocument/2006/relationships" xmlns:p="http://schemas.openxmlformats.org/presentationml/2006/main">
   <p:cSld name="Slide 21">
     <p:spTree>
@@ -18176,7 +18663,7 @@
 </p:sld>
 </file>
 
-<file path=ppt/slides/slide32.xml><?xml version="1.0" encoding="utf-8"?>
+<file path=ppt/slides/slide33.xml><?xml version="1.0" encoding="utf-8"?>
 <p:sld xmlns:a="http://schemas.openxmlformats.org/drawingml/2006/main" xmlns:r="http://schemas.openxmlformats.org/officeDocument/2006/relationships" xmlns:p="http://schemas.openxmlformats.org/presentationml/2006/main">
   <p:cSld name="Slide 22">
     <p:spTree>
@@ -18582,7 +19069,7 @@
 </p:sld>
 </file>
 
-<file path=ppt/slides/slide33.xml><?xml version="1.0" encoding="utf-8"?>
+<file path=ppt/slides/slide34.xml><?xml version="1.0" encoding="utf-8"?>
 <p:sld xmlns:a="http://schemas.openxmlformats.org/drawingml/2006/main" xmlns:r="http://schemas.openxmlformats.org/officeDocument/2006/relationships" xmlns:p="http://schemas.openxmlformats.org/presentationml/2006/main">
   <p:cSld name="Slide 23">
     <p:spTree>
@@ -18988,7 +19475,7 @@
 </p:sld>
 </file>
 
-<file path=ppt/slides/slide34.xml><?xml version="1.0" encoding="utf-8"?>
+<file path=ppt/slides/slide35.xml><?xml version="1.0" encoding="utf-8"?>
 <p:sld xmlns:a="http://schemas.openxmlformats.org/drawingml/2006/main" xmlns:r="http://schemas.openxmlformats.org/officeDocument/2006/relationships" xmlns:p="http://schemas.openxmlformats.org/presentationml/2006/main">
   <p:cSld name="Slide 24">
     <p:spTree>
@@ -19271,7 +19758,7 @@
 </p:sld>
 </file>
 
-<file path=ppt/slides/slide35.xml><?xml version="1.0" encoding="utf-8"?>
+<file path=ppt/slides/slide36.xml><?xml version="1.0" encoding="utf-8"?>
 <p:sld xmlns:a="http://schemas.openxmlformats.org/drawingml/2006/main" xmlns:r="http://schemas.openxmlformats.org/officeDocument/2006/relationships" xmlns:p="http://schemas.openxmlformats.org/presentationml/2006/main">
   <p:cSld name="Slide 25">
     <p:spTree>
@@ -19656,7 +20143,7 @@
 </p:sld>
 </file>
 
-<file path=ppt/slides/slide36.xml><?xml version="1.0" encoding="utf-8"?>
+<file path=ppt/slides/slide37.xml><?xml version="1.0" encoding="utf-8"?>
 <p:sld xmlns:a="http://schemas.openxmlformats.org/drawingml/2006/main" xmlns:r="http://schemas.openxmlformats.org/officeDocument/2006/relationships" xmlns:p="http://schemas.openxmlformats.org/presentationml/2006/main">
   <p:cSld name="Slide 26">
     <p:spTree>
@@ -20062,7 +20549,7 @@
 </p:sld>
 </file>
 
-<file path=ppt/slides/slide37.xml><?xml version="1.0" encoding="utf-8"?>
+<file path=ppt/slides/slide38.xml><?xml version="1.0" encoding="utf-8"?>
 <p:sld xmlns:a="http://schemas.openxmlformats.org/drawingml/2006/main" xmlns:r="http://schemas.openxmlformats.org/officeDocument/2006/relationships" xmlns:p="http://schemas.openxmlformats.org/presentationml/2006/main">
   <p:cSld name="Slide 27">
     <p:spTree>
@@ -20468,7 +20955,7 @@
 </p:sld>
 </file>
 
-<file path=ppt/slides/slide38.xml><?xml version="1.0" encoding="utf-8"?>
+<file path=ppt/slides/slide39.xml><?xml version="1.0" encoding="utf-8"?>
 <p:sld xmlns:a="http://schemas.openxmlformats.org/drawingml/2006/main" xmlns:r="http://schemas.openxmlformats.org/officeDocument/2006/relationships" xmlns:p="http://schemas.openxmlformats.org/presentationml/2006/main">
   <p:cSld name="Slide 28">
     <p:spTree>
@@ -20740,412 +21227,6 @@
               <a:t>What the rest of the year looks like and what we change</a:t>
             </a:r>
             <a:endParaRPr lang="en-US" sz="1200"/>
-          </a:p>
-        </p:txBody>
-      </p:sp>
-    </p:spTree>
-  </p:cSld>
-  <p:clrMapOvr>
-    <a:masterClrMapping/>
-  </p:clrMapOvr>
-</p:sld>
-</file>
-
-<file path=ppt/slides/slide39.xml><?xml version="1.0" encoding="utf-8"?>
-<p:sld xmlns:a="http://schemas.openxmlformats.org/drawingml/2006/main" xmlns:r="http://schemas.openxmlformats.org/officeDocument/2006/relationships" xmlns:p="http://schemas.openxmlformats.org/presentationml/2006/main">
-  <p:cSld name="Slide 29">
-    <p:spTree>
-      <p:nvGrpSpPr>
-        <p:cNvPr id="1" name=""/>
-        <p:cNvGrpSpPr/>
-        <p:nvPr/>
-      </p:nvGrpSpPr>
-      <p:grpSpPr>
-        <a:xfrm>
-          <a:off x="0" y="0"/>
-          <a:ext cx="0" cy="0"/>
-          <a:chOff x="0" y="0"/>
-          <a:chExt cx="0" cy="0"/>
-        </a:xfrm>
-      </p:grpSpPr>
-      <p:pic>
-        <p:nvPicPr>
-          <p:cNvPr id="27" name="snip income_month" descr="income_month.png"/>
-          <p:cNvPicPr>
-            <a:picLocks noChangeAspect="1"/>
-          </p:cNvPicPr>
-          <p:nvPr/>
-        </p:nvPicPr>
-        <p:blipFill>
-          <a:blip r:embed="rId3"/>
-          <a:stretch>
-            <a:fillRect/>
-          </a:stretch>
-        </p:blipFill>
-        <p:spPr>
-          <a:xfrm>
-            <a:off x="550168" y="1005840"/>
-            <a:ext cx="8043662" cy="2130551"/>
-          </a:xfrm>
-          <a:prstGeom prst="rect">
-            <a:avLst/>
-          </a:prstGeom>
-        </p:spPr>
-      </p:pic>
-      <p:sp>
-        <p:nvSpPr>
-          <p:cNvPr id="2" name="Text 0"/>
-          <p:cNvSpPr txBox="1"/>
-          <p:nvPr/>
-        </p:nvSpPr>
-        <p:spPr>
-          <a:xfrm>
-            <a:off x="502920" y="365760"/>
-            <a:ext cx="6400800" cy="274320"/>
-          </a:xfrm>
-          <a:prstGeom prst="rect">
-            <a:avLst/>
-          </a:prstGeom>
-          <a:noFill/>
-          <a:ln/>
-        </p:spPr>
-        <p:txBody>
-          <a:bodyPr wrap="square" lIns="0" tIns="0" rIns="0" bIns="0" rtlCol="0" anchor="ctr"/>
-          <a:lstStyle/>
-          <a:p>
-            <a:pPr marL="0" indent="0">
-              <a:buNone/>
-            </a:pPr>
-            <a:r>
-              <a:rPr lang="en-US" sz="950" b="1" kern="0" spc="220">
-                <a:solidFill>
-                  <a:srgbClr val="122B82"/>
-                </a:solidFill>
-              </a:rPr>
-              <a:t>BUDGET AND OUTLOOK</a:t>
-            </a:r>
-            <a:endParaRPr lang="en-US" sz="950"/>
-          </a:p>
-        </p:txBody>
-      </p:sp>
-      <p:sp>
-        <p:nvSpPr>
-          <p:cNvPr id="3" name="Text 1"/>
-          <p:cNvSpPr txBox="1"/>
-          <p:nvPr/>
-        </p:nvSpPr>
-        <p:spPr>
-          <a:xfrm>
-            <a:off x="502920" y="640080"/>
-            <a:ext cx="7315200" cy="365760"/>
-          </a:xfrm>
-          <a:prstGeom prst="rect">
-            <a:avLst/>
-          </a:prstGeom>
-          <a:noFill/>
-          <a:ln/>
-        </p:spPr>
-        <p:txBody>
-          <a:bodyPr wrap="square" lIns="0" tIns="0" rIns="0" bIns="0" rtlCol="0" anchor="ctr"/>
-          <a:lstStyle/>
-          <a:p>
-            <a:pPr marL="0" indent="0" algn="ctr">
-              <a:buNone/>
-            </a:pPr>
-            <a:r>
-              <a:rPr lang="en-US" sz="2200" b="1">
-                <a:solidFill>
-                  <a:srgbClr val="242C39"/>
-                </a:solidFill>
-              </a:rPr>
-              <a:t>Full year revenue against budget</a:t>
-            </a:r>
-            <a:endParaRPr lang="en-US" sz="2700"/>
-          </a:p>
-        </p:txBody>
-      </p:sp>
-      <p:sp>
-        <p:nvSpPr>
-          <p:cNvPr id="6" name="commentary panel"/>
-          <p:cNvSpPr/>
-          <p:nvPr/>
-        </p:nvSpPr>
-        <p:spPr>
-          <a:xfrm>
-            <a:off x="502920" y="3227831"/>
-            <a:ext cx="8138160" cy="1399032"/>
-          </a:xfrm>
-          <a:prstGeom prst="rect">
-            <a:avLst/>
-          </a:prstGeom>
-          <a:solidFill>
-            <a:srgbClr val="E8F9F8"/>
-          </a:solidFill>
-          <a:ln/>
-        </p:spPr>
-        <p:txBody>
-          <a:bodyPr/>
-          <a:lstStyle/>
-          <a:p>
-            <a:endParaRPr lang="en-AU"/>
-          </a:p>
-        </p:txBody>
-      </p:sp>
-      <p:sp>
-        <p:nvSpPr>
-          <p:cNvPr id="7" name="Text 4"/>
-          <p:cNvSpPr txBox="1"/>
-          <p:nvPr/>
-        </p:nvSpPr>
-        <p:spPr>
-          <a:xfrm>
-            <a:off x="685800" y="3300983"/>
-            <a:ext cx="2743200" cy="228600"/>
-          </a:xfrm>
-          <a:prstGeom prst="rect">
-            <a:avLst/>
-          </a:prstGeom>
-          <a:noFill/>
-          <a:ln/>
-        </p:spPr>
-        <p:txBody>
-          <a:bodyPr wrap="square" lIns="0" tIns="0" rIns="0" bIns="0" rtlCol="0" anchor="ctr"/>
-          <a:lstStyle/>
-          <a:p>
-            <a:pPr marL="0" indent="0">
-              <a:buNone/>
-            </a:pPr>
-            <a:r>
-              <a:rPr lang="en-US" sz="900" b="1" kern="0" spc="180">
-                <a:solidFill>
-                  <a:srgbClr val="005358"/>
-                </a:solidFill>
-              </a:rPr>
-              <a:t>COMMENTARY</a:t>
-            </a:r>
-            <a:endParaRPr lang="en-US" sz="900"/>
-          </a:p>
-        </p:txBody>
-      </p:sp>
-      <p:sp>
-        <p:nvSpPr>
-          <p:cNvPr id="8" name="Text 5"/>
-          <p:cNvSpPr txBox="1"/>
-          <p:nvPr/>
-        </p:nvSpPr>
-        <p:spPr>
-          <a:xfrm>
-            <a:off x="685800" y="3474719"/>
-            <a:ext cx="3703320" cy="1124712"/>
-          </a:xfrm>
-          <a:prstGeom prst="rect">
-            <a:avLst/>
-          </a:prstGeom>
-          <a:noFill/>
-          <a:ln/>
-        </p:spPr>
-        <p:txBody>
-          <a:bodyPr wrap="square" lIns="0" tIns="0" rIns="0" bIns="0" rtlCol="0" anchor="t">
-            <a:normAutofit fontScale="77500" lnSpcReduction="20000"/>
-          </a:bodyPr>
-          <a:lstStyle/>
-          <a:p>
-            <a:pPr marL="342900" indent="-342900">
-              <a:lnSpc>
-                <a:spcPts val="1150"/>
-              </a:lnSpc>
-              <a:spcAft>
-                <a:spcPts val="400"/>
-              </a:spcAft>
-              <a:buSzPct val="100000"/>
-              <a:buChar char="•"/>
-            </a:pPr>
-            <a:r>
-              <a:rPr lang="en-US" sz="1000">
-                <a:solidFill>
-                  <a:srgbClr val="3A4453"/>
-                </a:solidFill>
-              </a:rPr>
-              <a:t>First-quarter revenue was $372k below budget, with significant shortfalls in Consulting and Video.</a:t>
-            </a:r>
-            <a:endParaRPr lang="en-US" sz="900"/>
-          </a:p>
-          <a:p>
-            <a:pPr marL="342900" indent="-342900">
-              <a:lnSpc>
-                <a:spcPts val="1150"/>
-              </a:lnSpc>
-              <a:spcAft>
-                <a:spcPts val="400"/>
-              </a:spcAft>
-              <a:buSzPct val="100000"/>
-              <a:buChar char="•"/>
-            </a:pPr>
-            <a:r>
-              <a:rPr lang="en-US" sz="1000">
-                <a:solidFill>
-                  <a:srgbClr val="3A4453"/>
-                </a:solidFill>
-              </a:rPr>
-              <a:t>October to June currently reflects the original budget rather than an updated forecast.</a:t>
-            </a:r>
-            <a:endParaRPr lang="en-US" sz="900"/>
-          </a:p>
-          <a:p>
-            <a:pPr marL="342900" indent="-342900">
-              <a:lnSpc>
-                <a:spcPts val="1150"/>
-              </a:lnSpc>
-              <a:spcAft>
-                <a:spcPts val="400"/>
-              </a:spcAft>
-              <a:buSzPct val="100000"/>
-              <a:buChar char="•"/>
-            </a:pPr>
-            <a:r>
-              <a:rPr lang="en-US" sz="1000">
-                <a:solidFill>
-                  <a:srgbClr val="3A4453"/>
-                </a:solidFill>
-              </a:rPr>
-              <a:t>October revenue is budgeted at $950k, well above the highest actual month recorded so far this year.</a:t>
-            </a:r>
-            <a:endParaRPr lang="en-US" sz="900"/>
-          </a:p>
-        </p:txBody>
-      </p:sp>
-      <p:sp>
-        <p:nvSpPr>
-          <p:cNvPr id="25" name="Slide Number Placeholder 0"/>
-          <p:cNvSpPr>
-            <a:spLocks noGrp="1"/>
-          </p:cNvSpPr>
-          <p:nvPr>
-            <p:ph type="sldNum" sz="quarter" idx="4294967295"/>
-          </p:nvPr>
-        </p:nvSpPr>
-        <p:spPr>
-          <a:xfrm>
-            <a:off x="8092440" y="4736592"/>
-            <a:ext cx="548640" cy="228600"/>
-          </a:xfrm>
-          <a:prstGeom prst="rect">
-            <a:avLst/>
-          </a:prstGeom>
-          <a:extLst>
-            <a:ext uri="{C572A759-6A51-4108-AA02-DFA0A04FC94B}">
-              <ma14:wrappingTextBoxFlag xmlns:ma14="http://schemas.microsoft.com/office/mac/drawingml/2011/main" xmlns="" val="0"/>
-            </a:ext>
-          </a:extLst>
-        </p:spPr>
-        <p:txBody>
-          <a:bodyPr/>
-          <a:lstStyle>
-            <a:lvl1pPr>
-              <a:defRPr sz="800">
-                <a:solidFill>
-                  <a:srgbClr val="6B7585"/>
-                </a:solidFill>
-              </a:defRPr>
-            </a:lvl1pPr>
-          </a:lstStyle>
-          <a:p>
-            <a:pPr algn="r"/>
-            <a:fld id="{F7021451-1387-4CA6-816F-3879F97B5CBC}" type="slidenum">
-              <a:rPr lang="en-US" b="0"/>
-              <a:t>37</a:t>
-            </a:fld>
-            <a:endParaRPr lang="en-US"/>
-          </a:p>
-        </p:txBody>
-      </p:sp>
-      <p:pic>
-        <p:nvPicPr>
-          <p:cNvPr id="26" name="cts logo" descr="cts-logo.png"/>
-          <p:cNvPicPr>
-            <a:picLocks noChangeAspect="1"/>
-          </p:cNvPicPr>
-          <p:nvPr/>
-        </p:nvPicPr>
-        <p:blipFill>
-          <a:blip r:embed="rId4"/>
-          <a:stretch>
-            <a:fillRect/>
-          </a:stretch>
-        </p:blipFill>
-        <p:spPr>
-          <a:xfrm>
-            <a:off x="7680959" y="182880"/>
-            <a:ext cx="960120" cy="539696"/>
-          </a:xfrm>
-          <a:prstGeom prst="rect">
-            <a:avLst/>
-          </a:prstGeom>
-        </p:spPr>
-      </p:pic>
-      <p:sp>
-        <p:nvSpPr>
-          <p:cNvPr id="4" name="Text 5b"/>
-          <p:cNvSpPr txBox="1"/>
-          <p:nvPr/>
-        </p:nvSpPr>
-        <p:spPr>
-          <a:xfrm>
-            <a:off x="4663440" y="3474719"/>
-            <a:ext cx="3703320" cy="1124712"/>
-          </a:xfrm>
-          <a:prstGeom prst="rect">
-            <a:avLst/>
-          </a:prstGeom>
-          <a:noFill/>
-          <a:ln/>
-        </p:spPr>
-        <p:txBody>
-          <a:bodyPr wrap="square" lIns="0" tIns="0" rIns="0" bIns="0" rtlCol="0" anchor="t">
-            <a:normAutofit fontScale="77500" lnSpcReduction="20000"/>
-          </a:bodyPr>
-          <a:lstStyle/>
-          <a:p>
-            <a:pPr marL="342900" indent="-342900">
-              <a:lnSpc>
-                <a:spcPts val="1150"/>
-              </a:lnSpc>
-              <a:spcAft>
-                <a:spcPts val="400"/>
-              </a:spcAft>
-              <a:buSzPct val="100000"/>
-              <a:buChar char="•"/>
-            </a:pPr>
-            <a:r>
-              <a:rPr lang="en-US" sz="1000">
-                <a:solidFill>
-                  <a:srgbClr val="3A4453"/>
-                </a:solidFill>
-              </a:rPr>
-              <a:t>December includes a planned loss reflecting the two-week business closure, which should remain in the revised assumptions.</a:t>
-            </a:r>
-            <a:endParaRPr lang="en-US" sz="900"/>
-          </a:p>
-          <a:p>
-            <a:pPr marL="342900" indent="-342900">
-              <a:lnSpc>
-                <a:spcPts val="1150"/>
-              </a:lnSpc>
-              <a:spcAft>
-                <a:spcPts val="400"/>
-              </a:spcAft>
-              <a:buSzPct val="100000"/>
-              <a:buChar char="•"/>
-            </a:pPr>
-            <a:r>
-              <a:rPr lang="en-US" sz="1000">
-                <a:solidFill>
-                  <a:srgbClr val="3A4453"/>
-                </a:solidFill>
-              </a:rPr>
-              <a:t>Recommend preparing an updated rolling forecast using actual delivery capacity and achievable gross margins.</a:t>
-            </a:r>
-            <a:endParaRPr lang="en-US" sz="900"/>
           </a:p>
         </p:txBody>
       </p:sp>
@@ -21441,6 +21522,412 @@
 </file>
 
 <file path=ppt/slides/slide40.xml><?xml version="1.0" encoding="utf-8"?>
+<p:sld xmlns:a="http://schemas.openxmlformats.org/drawingml/2006/main" xmlns:r="http://schemas.openxmlformats.org/officeDocument/2006/relationships" xmlns:p="http://schemas.openxmlformats.org/presentationml/2006/main">
+  <p:cSld name="Slide 29">
+    <p:spTree>
+      <p:nvGrpSpPr>
+        <p:cNvPr id="1" name=""/>
+        <p:cNvGrpSpPr/>
+        <p:nvPr/>
+      </p:nvGrpSpPr>
+      <p:grpSpPr>
+        <a:xfrm>
+          <a:off x="0" y="0"/>
+          <a:ext cx="0" cy="0"/>
+          <a:chOff x="0" y="0"/>
+          <a:chExt cx="0" cy="0"/>
+        </a:xfrm>
+      </p:grpSpPr>
+      <p:pic>
+        <p:nvPicPr>
+          <p:cNvPr id="27" name="snip income_month" descr="income_month.png"/>
+          <p:cNvPicPr>
+            <a:picLocks noChangeAspect="1"/>
+          </p:cNvPicPr>
+          <p:nvPr/>
+        </p:nvPicPr>
+        <p:blipFill>
+          <a:blip r:embed="rId3"/>
+          <a:stretch>
+            <a:fillRect/>
+          </a:stretch>
+        </p:blipFill>
+        <p:spPr>
+          <a:xfrm>
+            <a:off x="550168" y="1005840"/>
+            <a:ext cx="8043662" cy="2130551"/>
+          </a:xfrm>
+          <a:prstGeom prst="rect">
+            <a:avLst/>
+          </a:prstGeom>
+        </p:spPr>
+      </p:pic>
+      <p:sp>
+        <p:nvSpPr>
+          <p:cNvPr id="2" name="Text 0"/>
+          <p:cNvSpPr txBox="1"/>
+          <p:nvPr/>
+        </p:nvSpPr>
+        <p:spPr>
+          <a:xfrm>
+            <a:off x="502920" y="365760"/>
+            <a:ext cx="6400800" cy="274320"/>
+          </a:xfrm>
+          <a:prstGeom prst="rect">
+            <a:avLst/>
+          </a:prstGeom>
+          <a:noFill/>
+          <a:ln/>
+        </p:spPr>
+        <p:txBody>
+          <a:bodyPr wrap="square" lIns="0" tIns="0" rIns="0" bIns="0" rtlCol="0" anchor="ctr"/>
+          <a:lstStyle/>
+          <a:p>
+            <a:pPr marL="0" indent="0">
+              <a:buNone/>
+            </a:pPr>
+            <a:r>
+              <a:rPr lang="en-US" sz="950" b="1" kern="0" spc="220">
+                <a:solidFill>
+                  <a:srgbClr val="122B82"/>
+                </a:solidFill>
+              </a:rPr>
+              <a:t>BUDGET AND OUTLOOK</a:t>
+            </a:r>
+            <a:endParaRPr lang="en-US" sz="950"/>
+          </a:p>
+        </p:txBody>
+      </p:sp>
+      <p:sp>
+        <p:nvSpPr>
+          <p:cNvPr id="3" name="Text 1"/>
+          <p:cNvSpPr txBox="1"/>
+          <p:nvPr/>
+        </p:nvSpPr>
+        <p:spPr>
+          <a:xfrm>
+            <a:off x="502920" y="640080"/>
+            <a:ext cx="7315200" cy="365760"/>
+          </a:xfrm>
+          <a:prstGeom prst="rect">
+            <a:avLst/>
+          </a:prstGeom>
+          <a:noFill/>
+          <a:ln/>
+        </p:spPr>
+        <p:txBody>
+          <a:bodyPr wrap="square" lIns="0" tIns="0" rIns="0" bIns="0" rtlCol="0" anchor="ctr"/>
+          <a:lstStyle/>
+          <a:p>
+            <a:pPr marL="0" indent="0" algn="ctr">
+              <a:buNone/>
+            </a:pPr>
+            <a:r>
+              <a:rPr lang="en-US" sz="2200" b="1">
+                <a:solidFill>
+                  <a:srgbClr val="242C39"/>
+                </a:solidFill>
+              </a:rPr>
+              <a:t>Full year revenue against budget</a:t>
+            </a:r>
+            <a:endParaRPr lang="en-US" sz="2700"/>
+          </a:p>
+        </p:txBody>
+      </p:sp>
+      <p:sp>
+        <p:nvSpPr>
+          <p:cNvPr id="6" name="commentary panel"/>
+          <p:cNvSpPr/>
+          <p:nvPr/>
+        </p:nvSpPr>
+        <p:spPr>
+          <a:xfrm>
+            <a:off x="502920" y="3227831"/>
+            <a:ext cx="8138160" cy="1399032"/>
+          </a:xfrm>
+          <a:prstGeom prst="rect">
+            <a:avLst/>
+          </a:prstGeom>
+          <a:solidFill>
+            <a:srgbClr val="E8F9F8"/>
+          </a:solidFill>
+          <a:ln/>
+        </p:spPr>
+        <p:txBody>
+          <a:bodyPr/>
+          <a:lstStyle/>
+          <a:p>
+            <a:endParaRPr lang="en-AU"/>
+          </a:p>
+        </p:txBody>
+      </p:sp>
+      <p:sp>
+        <p:nvSpPr>
+          <p:cNvPr id="7" name="Text 4"/>
+          <p:cNvSpPr txBox="1"/>
+          <p:nvPr/>
+        </p:nvSpPr>
+        <p:spPr>
+          <a:xfrm>
+            <a:off x="685800" y="3300983"/>
+            <a:ext cx="2743200" cy="228600"/>
+          </a:xfrm>
+          <a:prstGeom prst="rect">
+            <a:avLst/>
+          </a:prstGeom>
+          <a:noFill/>
+          <a:ln/>
+        </p:spPr>
+        <p:txBody>
+          <a:bodyPr wrap="square" lIns="0" tIns="0" rIns="0" bIns="0" rtlCol="0" anchor="ctr"/>
+          <a:lstStyle/>
+          <a:p>
+            <a:pPr marL="0" indent="0">
+              <a:buNone/>
+            </a:pPr>
+            <a:r>
+              <a:rPr lang="en-US" sz="900" b="1" kern="0" spc="180">
+                <a:solidFill>
+                  <a:srgbClr val="005358"/>
+                </a:solidFill>
+              </a:rPr>
+              <a:t>COMMENTARY</a:t>
+            </a:r>
+            <a:endParaRPr lang="en-US" sz="900"/>
+          </a:p>
+        </p:txBody>
+      </p:sp>
+      <p:sp>
+        <p:nvSpPr>
+          <p:cNvPr id="8" name="Text 5"/>
+          <p:cNvSpPr txBox="1"/>
+          <p:nvPr/>
+        </p:nvSpPr>
+        <p:spPr>
+          <a:xfrm>
+            <a:off x="685800" y="3474719"/>
+            <a:ext cx="3703320" cy="1124712"/>
+          </a:xfrm>
+          <a:prstGeom prst="rect">
+            <a:avLst/>
+          </a:prstGeom>
+          <a:noFill/>
+          <a:ln/>
+        </p:spPr>
+        <p:txBody>
+          <a:bodyPr wrap="square" lIns="0" tIns="0" rIns="0" bIns="0" rtlCol="0" anchor="t">
+            <a:normAutofit fontScale="77500" lnSpcReduction="20000"/>
+          </a:bodyPr>
+          <a:lstStyle/>
+          <a:p>
+            <a:pPr marL="342900" indent="-342900">
+              <a:lnSpc>
+                <a:spcPts val="1150"/>
+              </a:lnSpc>
+              <a:spcAft>
+                <a:spcPts val="400"/>
+              </a:spcAft>
+              <a:buSzPct val="100000"/>
+              <a:buChar char="•"/>
+            </a:pPr>
+            <a:r>
+              <a:rPr lang="en-US" sz="1000">
+                <a:solidFill>
+                  <a:srgbClr val="3A4453"/>
+                </a:solidFill>
+              </a:rPr>
+              <a:t>First-quarter revenue was $372k below budget, with significant shortfalls in Consulting and Video.</a:t>
+            </a:r>
+            <a:endParaRPr lang="en-US" sz="900"/>
+          </a:p>
+          <a:p>
+            <a:pPr marL="342900" indent="-342900">
+              <a:lnSpc>
+                <a:spcPts val="1150"/>
+              </a:lnSpc>
+              <a:spcAft>
+                <a:spcPts val="400"/>
+              </a:spcAft>
+              <a:buSzPct val="100000"/>
+              <a:buChar char="•"/>
+            </a:pPr>
+            <a:r>
+              <a:rPr lang="en-US" sz="1000">
+                <a:solidFill>
+                  <a:srgbClr val="3A4453"/>
+                </a:solidFill>
+              </a:rPr>
+              <a:t>October to June currently reflects the original budget rather than an updated forecast.</a:t>
+            </a:r>
+            <a:endParaRPr lang="en-US" sz="900"/>
+          </a:p>
+          <a:p>
+            <a:pPr marL="342900" indent="-342900">
+              <a:lnSpc>
+                <a:spcPts val="1150"/>
+              </a:lnSpc>
+              <a:spcAft>
+                <a:spcPts val="400"/>
+              </a:spcAft>
+              <a:buSzPct val="100000"/>
+              <a:buChar char="•"/>
+            </a:pPr>
+            <a:r>
+              <a:rPr lang="en-US" sz="1000">
+                <a:solidFill>
+                  <a:srgbClr val="3A4453"/>
+                </a:solidFill>
+              </a:rPr>
+              <a:t>October revenue is budgeted at $950k, well above the highest actual month recorded so far this year.</a:t>
+            </a:r>
+            <a:endParaRPr lang="en-US" sz="900"/>
+          </a:p>
+        </p:txBody>
+      </p:sp>
+      <p:sp>
+        <p:nvSpPr>
+          <p:cNvPr id="25" name="Slide Number Placeholder 0"/>
+          <p:cNvSpPr>
+            <a:spLocks noGrp="1"/>
+          </p:cNvSpPr>
+          <p:nvPr>
+            <p:ph type="sldNum" sz="quarter" idx="4294967295"/>
+          </p:nvPr>
+        </p:nvSpPr>
+        <p:spPr>
+          <a:xfrm>
+            <a:off x="8092440" y="4736592"/>
+            <a:ext cx="548640" cy="228600"/>
+          </a:xfrm>
+          <a:prstGeom prst="rect">
+            <a:avLst/>
+          </a:prstGeom>
+          <a:extLst>
+            <a:ext uri="{C572A759-6A51-4108-AA02-DFA0A04FC94B}">
+              <ma14:wrappingTextBoxFlag xmlns:ma14="http://schemas.microsoft.com/office/mac/drawingml/2011/main" xmlns="" val="0"/>
+            </a:ext>
+          </a:extLst>
+        </p:spPr>
+        <p:txBody>
+          <a:bodyPr/>
+          <a:lstStyle>
+            <a:lvl1pPr>
+              <a:defRPr sz="800">
+                <a:solidFill>
+                  <a:srgbClr val="6B7585"/>
+                </a:solidFill>
+              </a:defRPr>
+            </a:lvl1pPr>
+          </a:lstStyle>
+          <a:p>
+            <a:pPr algn="r"/>
+            <a:fld id="{F7021451-1387-4CA6-816F-3879F97B5CBC}" type="slidenum">
+              <a:rPr lang="en-US" b="0"/>
+              <a:t>37</a:t>
+            </a:fld>
+            <a:endParaRPr lang="en-US"/>
+          </a:p>
+        </p:txBody>
+      </p:sp>
+      <p:pic>
+        <p:nvPicPr>
+          <p:cNvPr id="26" name="cts logo" descr="cts-logo.png"/>
+          <p:cNvPicPr>
+            <a:picLocks noChangeAspect="1"/>
+          </p:cNvPicPr>
+          <p:nvPr/>
+        </p:nvPicPr>
+        <p:blipFill>
+          <a:blip r:embed="rId4"/>
+          <a:stretch>
+            <a:fillRect/>
+          </a:stretch>
+        </p:blipFill>
+        <p:spPr>
+          <a:xfrm>
+            <a:off x="7680959" y="182880"/>
+            <a:ext cx="960120" cy="539696"/>
+          </a:xfrm>
+          <a:prstGeom prst="rect">
+            <a:avLst/>
+          </a:prstGeom>
+        </p:spPr>
+      </p:pic>
+      <p:sp>
+        <p:nvSpPr>
+          <p:cNvPr id="4" name="Text 5b"/>
+          <p:cNvSpPr txBox="1"/>
+          <p:nvPr/>
+        </p:nvSpPr>
+        <p:spPr>
+          <a:xfrm>
+            <a:off x="4663440" y="3474719"/>
+            <a:ext cx="3703320" cy="1124712"/>
+          </a:xfrm>
+          <a:prstGeom prst="rect">
+            <a:avLst/>
+          </a:prstGeom>
+          <a:noFill/>
+          <a:ln/>
+        </p:spPr>
+        <p:txBody>
+          <a:bodyPr wrap="square" lIns="0" tIns="0" rIns="0" bIns="0" rtlCol="0" anchor="t">
+            <a:normAutofit fontScale="77500" lnSpcReduction="20000"/>
+          </a:bodyPr>
+          <a:lstStyle/>
+          <a:p>
+            <a:pPr marL="342900" indent="-342900">
+              <a:lnSpc>
+                <a:spcPts val="1150"/>
+              </a:lnSpc>
+              <a:spcAft>
+                <a:spcPts val="400"/>
+              </a:spcAft>
+              <a:buSzPct val="100000"/>
+              <a:buChar char="•"/>
+            </a:pPr>
+            <a:r>
+              <a:rPr lang="en-US" sz="1000">
+                <a:solidFill>
+                  <a:srgbClr val="3A4453"/>
+                </a:solidFill>
+              </a:rPr>
+              <a:t>December includes a planned loss reflecting the two-week business closure, which should remain in the revised assumptions.</a:t>
+            </a:r>
+            <a:endParaRPr lang="en-US" sz="900"/>
+          </a:p>
+          <a:p>
+            <a:pPr marL="342900" indent="-342900">
+              <a:lnSpc>
+                <a:spcPts val="1150"/>
+              </a:lnSpc>
+              <a:spcAft>
+                <a:spcPts val="400"/>
+              </a:spcAft>
+              <a:buSzPct val="100000"/>
+              <a:buChar char="•"/>
+            </a:pPr>
+            <a:r>
+              <a:rPr lang="en-US" sz="1000">
+                <a:solidFill>
+                  <a:srgbClr val="3A4453"/>
+                </a:solidFill>
+              </a:rPr>
+              <a:t>Recommend preparing an updated rolling forecast using actual delivery capacity and achievable gross margins.</a:t>
+            </a:r>
+            <a:endParaRPr lang="en-US" sz="900"/>
+          </a:p>
+        </p:txBody>
+      </p:sp>
+    </p:spTree>
+  </p:cSld>
+  <p:clrMapOvr>
+    <a:masterClrMapping/>
+  </p:clrMapOvr>
+</p:sld>
+</file>
+
+<file path=ppt/slides/slide41.xml><?xml version="1.0" encoding="utf-8"?>
 <p:sld xmlns:a="http://schemas.openxmlformats.org/drawingml/2006/main" xmlns:r="http://schemas.openxmlformats.org/officeDocument/2006/relationships" xmlns:p="http://schemas.openxmlformats.org/presentationml/2006/main">
   <p:cSld name="Slide 30">
     <p:spTree>
@@ -23586,7 +24073,7 @@
 </p:sld>
 </file>
 
-<file path=ppt/slides/slide41.xml><?xml version="1.0" encoding="utf-8"?>
+<file path=ppt/slides/slide42.xml><?xml version="1.0" encoding="utf-8"?>
 <p:sld xmlns:a="http://schemas.openxmlformats.org/drawingml/2006/main" xmlns:r="http://schemas.openxmlformats.org/officeDocument/2006/relationships" xmlns:p="http://schemas.openxmlformats.org/presentationml/2006/main">
   <p:cSld>
     <p:bg>
@@ -23962,7 +24449,7 @@
 </p:sld>
 </file>
 
-<file path=ppt/slides/slide42.xml><?xml version="1.0" encoding="utf-8"?>
+<file path=ppt/slides/slide43.xml><?xml version="1.0" encoding="utf-8"?>
 <p:sld xmlns:a="http://schemas.openxmlformats.org/drawingml/2006/main" xmlns:r="http://schemas.openxmlformats.org/officeDocument/2006/relationships" xmlns:p="http://schemas.openxmlformats.org/presentationml/2006/main">
   <p:cSld name="Slide 31">
     <p:spTree>

</xml_diff>

<commit_message>
The departmental result above and below the line
The gross profit page put all five departments above the line. That is true, every
department earns more than its direct cost, but read quickly it says everybody made
money and three of them did not.

A new page 26 shows the result after the overhead charged to each department, teal
above the line and red below. Two above, three below. The gross profit page moves
to 27 and is retitled "Gross profit before overhead, year on year" so it cannot be
read as the net result either.

The result is split into a profit column and a loss column at S and T on the
Overhead Split tab so the chart colours itself. Reading the sign in the build
script fails on a first run, because a freshly patched cell has no cached value
until recalc.

Deck is 46 pages. This is a monthly page.

Co-Authored-By: Claude Opus 5 <noreply@anthropic.com>
Claude-Session: https://claude.ai/code/session_01CVBAFohBCYXt1ufjTVDiZj
</commit_message>
<xml_diff>
--- a/deck/CTS Monthly Business Review - 30092026.pptx
+++ b/deck/CTS Monthly Business Review - 30092026.pptx
@@ -33,6 +33,7 @@
     <p:sldId id="267" r:id="rId27"/>
     <p:sldId id="268" r:id="rId28"/>
     <p:sldId id="301" r:id="rId55"/>
+    <p:sldId id="303" r:id="rId57"/>
     <p:sldId id="302" r:id="rId56"/>
     <p:sldId id="269" r:id="rId29"/>
     <p:sldId id="270" r:id="rId30"/>
@@ -5374,6 +5375,100 @@
 </p:notes>
 </file>
 
+<file path=ppt/notesSlides/notesSlide46.xml><?xml version="1.0" encoding="utf-8"?>
+<p:notes xmlns:a="http://schemas.openxmlformats.org/drawingml/2006/main" xmlns:p="http://schemas.openxmlformats.org/presentationml/2006/main" xmlns:r="http://schemas.openxmlformats.org/officeDocument/2006/relationships">
+  <p:cSld>
+    <p:spTree>
+      <p:nvGrpSpPr>
+        <p:cNvPr id="1" name=""/>
+        <p:cNvGrpSpPr/>
+        <p:nvPr/>
+      </p:nvGrpSpPr>
+      <p:grpSpPr>
+        <a:xfrm>
+          <a:off x="0" y="0"/>
+          <a:ext cx="0" cy="0"/>
+          <a:chOff x="0" y="0"/>
+          <a:chExt cx="0" cy="0"/>
+        </a:xfrm>
+      </p:grpSpPr>
+      <p:sp>
+        <p:nvSpPr>
+          <p:cNvPr id="3" name="Notes Placeholder 2"/>
+          <p:cNvSpPr>
+            <a:spLocks noGrp="1"/>
+          </p:cNvSpPr>
+          <p:nvPr>
+            <p:ph type="body" idx="1"/>
+          </p:nvPr>
+        </p:nvSpPr>
+        <p:spPr/>
+        <p:txBody>
+          <a:bodyPr lIns="107095" tIns="53547" rIns="107095" bIns="53547"/>
+          <a:lstStyle/>
+          <a:p>
+            <a:r>
+              <a:t>The result by department for September 2026 after the overhead charged to each one, taken from section 7 of the Overhead Split tab. Teal is above the line, red is below.</a:t>
+            </a:r>
+          </a:p>
+          <a:p/>
+          <a:p>
+            <a:r>
+              <a:t>Support $29,007. Integration $10,471. Video a loss of $6,846. Consulting a loss of $19,870. Events a loss of $54,227. The five add to the $41,464 loss for the month.</a:t>
+            </a:r>
+          </a:p>
+          <a:p/>
+          <a:p>
+            <a:r>
+              <a:t>Two of the five made a profit.</a:t>
+            </a:r>
+          </a:p>
+          <a:p/>
+          <a:p>
+            <a:r>
+              <a:t>The reason this page exists is that the gross profit page behind it shows all five departments above the line, and that is true: every department earned more than its direct cost. Support made $101,290 of gross profit, Events $56,881, Integration $23,756, Video $5,813 and even Consulting made $74. On gross profit nobody lost money.</a:t>
+            </a:r>
+          </a:p>
+          <a:p/>
+          <a:p>
+            <a:r>
+              <a:t>What puts three of them below the line is the overhead charged to them. $229,278 of it across the month, against $187,814 of gross profit earned. The company cannot cover its overhead base out of the margin it is making, and the departments where that bites hardest are the ones carrying overhead out of proportion to their revenue.</a:t>
+            </a:r>
+          </a:p>
+          <a:p/>
+          <a:p>
+            <a:r>
+              <a:t>Events is the clearest case. It carries $111,108 of overhead, 48.5% of the company total, on 13.0% of the revenue. Its margin is the second best of the five at 77.6% and it still posts the largest loss on the page.</a:t>
+            </a:r>
+          </a:p>
+          <a:p/>
+          <a:p>
+            <a:r>
+              <a:t>Consulting is the other kind of problem. It earned $74 of gross profit on $3,531 of revenue and carries $19,944 of overhead, so almost the whole of its loss is overhead on a department that is barely trading.</a:t>
+            </a:r>
+          </a:p>
+          <a:p/>
+          <a:p>
+            <a:r>
+              <a:t>Video's loss of $6,846 is the smallest and the least structural. It billed $7,303 against $20,025 in the same month last year, so it is a volume problem on a department with a 79.6% margin.</a:t>
+            </a:r>
+          </a:p>
+          <a:p/>
+          <a:p>
+            <a:r>
+              <a:t>Two points for the board. First, improving margin does not fix Events or Consulting, because their losses are overhead, not margin. Second, the overhead keys were set for FY27 and have not been tested since, which is the action already on the recommendations page.</a:t>
+            </a:r>
+          </a:p>
+        </p:txBody>
+      </p:sp>
+    </p:spTree>
+  </p:cSld>
+  <p:clrMapOvr>
+    <a:masterClrMapping/>
+  </p:clrMapOvr>
+</p:notes>
+</file>
+
 <file path=ppt/notesSlides/notesSlide5.xml><?xml version="1.0" encoding="utf-8"?>
 <p:notes xmlns:a="http://schemas.openxmlformats.org/drawingml/2006/main" xmlns:r="http://schemas.openxmlformats.org/officeDocument/2006/relationships" xmlns:p="http://schemas.openxmlformats.org/presentationml/2006/main">
   <p:cSld>
@@ -14021,7 +14116,7 @@
       <p:grpSpPr/>
       <p:pic>
         <p:nvPicPr>
-          <p:cNvPr id="27" name="snip dept_gp_yoy" descr="dept_gp_yoy.png"/>
+          <p:cNvPr id="27" name="snip dept_line" descr="dept_line.png"/>
           <p:cNvPicPr>
             <a:picLocks noChangeAspect="1"/>
           </p:cNvPicPr>
@@ -14109,7 +14204,7 @@
                   <a:srgbClr val="242C39"/>
                 </a:solidFill>
               </a:rPr>
-              <a:t>Gross profit by department, year on year</a:t>
+              <a:t>Result by department, above and below the line</a:t>
             </a:r>
             <a:endParaRPr lang="en-US" sz="2700" dirty="0"/>
           </a:p>
@@ -14217,7 +14312,7 @@
                   <a:srgbClr val="3A4453"/>
                 </a:solidFill>
               </a:rPr>
-              <a:t>Company gross profit was $188k against $162k last September, up $26k.</a:t>
+              <a:t>Two of the five made a profit. Support kept $29k and Integration $10k.</a:t>
             </a:r>
             <a:endParaRPr lang="en-US" sz="850"/>
           </a:p>
@@ -14238,7 +14333,7 @@
                   <a:srgbClr val="3A4453"/>
                 </a:solidFill>
               </a:rPr>
-              <a:t>Integration is up $18k, Events $9k and Support $7k.</a:t>
+              <a:t>Events lost $54k, Consulting $20k and Video $7k.</a:t>
             </a:r>
             <a:endParaRPr lang="en-US" sz="850"/>
           </a:p>
@@ -14328,7 +14423,7 @@
                   <a:srgbClr val="3A4453"/>
                 </a:solidFill>
               </a:rPr>
-              <a:t>Video fell from $13k to $6k and Consulting from $2k to almost nothing.</a:t>
+              <a:t>All five made a gross profit. It is the overhead charged to them that puts three below the line.</a:t>
             </a:r>
             <a:endParaRPr lang="en-US" sz="850"/>
           </a:p>
@@ -14349,7 +14444,7 @@
                   <a:srgbClr val="3A4453"/>
                 </a:solidFill>
               </a:rPr>
-              <a:t>Gross profit only. Overhead was not split by department before this year, so the net result cannot go back.</a:t>
+              <a:t>The five together are the $41k loss for the month.</a:t>
             </a:r>
             <a:endParaRPr lang="en-US" sz="850"/>
           </a:p>
@@ -14388,6 +14483,384 @@
 </file>
 
 <file path=ppt/slides/slide27.xml><?xml version="1.0" encoding="utf-8"?>
+<p:sld xmlns:a="http://schemas.openxmlformats.org/drawingml/2006/main" xmlns:p="http://schemas.openxmlformats.org/presentationml/2006/main" xmlns:r="http://schemas.openxmlformats.org/officeDocument/2006/relationships">
+  <p:cSld>
+    <p:spTree>
+      <p:nvGrpSpPr>
+        <p:cNvPr id="1" name=""/>
+        <p:cNvGrpSpPr/>
+        <p:nvPr/>
+      </p:nvGrpSpPr>
+      <p:grpSpPr/>
+      <p:pic>
+        <p:nvPicPr>
+          <p:cNvPr id="27" name="snip dept_gp_yoy" descr="dept_gp_yoy.png"/>
+          <p:cNvPicPr>
+            <a:picLocks noChangeAspect="1"/>
+          </p:cNvPicPr>
+          <p:nvPr/>
+        </p:nvPicPr>
+        <p:blipFill>
+          <a:blip r:embed="rId3"/>
+          <a:stretch>
+            <a:fillRect/>
+          </a:stretch>
+        </p:blipFill>
+        <p:spPr>
+          <a:xfrm>
+            <a:off x="535418" y="1005840"/>
+            <a:ext cx="8073163" cy="2523743"/>
+          </a:xfrm>
+          <a:prstGeom prst="rect">
+            <a:avLst/>
+          </a:prstGeom>
+        </p:spPr>
+      </p:pic>
+      <p:sp>
+        <p:nvSpPr>
+          <p:cNvPr id="2" name="Text 0"/>
+          <p:cNvSpPr txBox="1"/>
+          <p:nvPr/>
+        </p:nvSpPr>
+        <p:spPr>
+          <a:xfrm>
+            <a:off x="502920" y="365760"/>
+            <a:ext cx="6400800" cy="274320"/>
+          </a:xfrm>
+          <a:prstGeom prst="rect">
+            <a:avLst/>
+          </a:prstGeom>
+          <a:noFill/>
+          <a:ln/>
+        </p:spPr>
+        <p:txBody>
+          <a:bodyPr wrap="square" lIns="0" tIns="0" rIns="0" bIns="0" rtlCol="0" anchor="ctr"/>
+          <a:lstStyle/>
+          <a:p>
+            <a:pPr marL="0" indent="0">
+              <a:buNone/>
+            </a:pPr>
+            <a:r>
+              <a:rPr lang="en-US" sz="950" b="1" kern="0" spc="220">
+                <a:solidFill>
+                  <a:srgbClr val="122B82"/>
+                </a:solidFill>
+              </a:rPr>
+              <a:t>DEPARTMENTAL PERFORMANCE</a:t>
+            </a:r>
+            <a:endParaRPr lang="en-US" sz="950"/>
+          </a:p>
+        </p:txBody>
+      </p:sp>
+      <p:sp>
+        <p:nvSpPr>
+          <p:cNvPr id="3" name="Text 1"/>
+          <p:cNvSpPr txBox="1"/>
+          <p:nvPr/>
+        </p:nvSpPr>
+        <p:spPr>
+          <a:xfrm>
+            <a:off x="502920" y="640080"/>
+            <a:ext cx="7315200" cy="365760"/>
+          </a:xfrm>
+          <a:prstGeom prst="rect">
+            <a:avLst/>
+          </a:prstGeom>
+          <a:noFill/>
+          <a:ln/>
+        </p:spPr>
+        <p:txBody>
+          <a:bodyPr wrap="square" lIns="0" tIns="0" rIns="0" bIns="0" rtlCol="0" anchor="ctr"/>
+          <a:lstStyle/>
+          <a:p>
+            <a:pPr marL="0" indent="0" algn="ctr">
+              <a:buNone/>
+            </a:pPr>
+            <a:r>
+              <a:rPr lang="en-US" sz="2200" b="1" dirty="0">
+                <a:solidFill>
+                  <a:srgbClr val="242C39"/>
+                </a:solidFill>
+              </a:rPr>
+              <a:t>Gross profit before overhead, year on year</a:t>
+            </a:r>
+            <a:endParaRPr lang="en-US" sz="2700" dirty="0"/>
+          </a:p>
+        </p:txBody>
+      </p:sp>
+      <p:sp>
+        <p:nvSpPr>
+          <p:cNvPr id="6" name="commentary panel"/>
+          <p:cNvSpPr/>
+          <p:nvPr/>
+        </p:nvSpPr>
+        <p:spPr>
+          <a:xfrm>
+            <a:off x="502920" y="3621023"/>
+            <a:ext cx="8138160" cy="1005840"/>
+          </a:xfrm>
+          <a:prstGeom prst="rect">
+            <a:avLst/>
+          </a:prstGeom>
+          <a:solidFill>
+            <a:srgbClr val="E8F9F8"/>
+          </a:solidFill>
+          <a:ln/>
+        </p:spPr>
+        <p:txBody>
+          <a:bodyPr/>
+          <a:lstStyle/>
+          <a:p>
+            <a:endParaRPr lang="en-AU"/>
+          </a:p>
+        </p:txBody>
+      </p:sp>
+      <p:sp>
+        <p:nvSpPr>
+          <p:cNvPr id="7" name="Text 4"/>
+          <p:cNvSpPr txBox="1"/>
+          <p:nvPr/>
+        </p:nvSpPr>
+        <p:spPr>
+          <a:xfrm>
+            <a:off x="685800" y="3694175"/>
+            <a:ext cx="2743200" cy="228600"/>
+          </a:xfrm>
+          <a:prstGeom prst="rect">
+            <a:avLst/>
+          </a:prstGeom>
+          <a:noFill/>
+          <a:ln/>
+        </p:spPr>
+        <p:txBody>
+          <a:bodyPr wrap="square" lIns="0" tIns="0" rIns="0" bIns="0" rtlCol="0" anchor="ctr"/>
+          <a:lstStyle/>
+          <a:p>
+            <a:pPr marL="0" indent="0">
+              <a:buNone/>
+            </a:pPr>
+            <a:r>
+              <a:rPr lang="en-US" sz="900" b="1" kern="0" spc="180">
+                <a:solidFill>
+                  <a:srgbClr val="005358"/>
+                </a:solidFill>
+              </a:rPr>
+              <a:t>COMMENTARY</a:t>
+            </a:r>
+            <a:endParaRPr lang="en-US" sz="900"/>
+          </a:p>
+        </p:txBody>
+      </p:sp>
+      <p:sp>
+        <p:nvSpPr>
+          <p:cNvPr id="8" name="Text 5"/>
+          <p:cNvSpPr txBox="1"/>
+          <p:nvPr/>
+        </p:nvSpPr>
+        <p:spPr>
+          <a:xfrm>
+            <a:off x="685800" y="3867911"/>
+            <a:ext cx="3703320" cy="731520"/>
+          </a:xfrm>
+          <a:prstGeom prst="rect">
+            <a:avLst/>
+          </a:prstGeom>
+          <a:noFill/>
+          <a:ln/>
+        </p:spPr>
+        <p:txBody>
+          <a:bodyPr wrap="square" lIns="0" tIns="0" rIns="0" bIns="0" rtlCol="0" anchor="t">
+            <a:normAutofit fontScale="85000" lnSpcReduction="10000"/>
+          </a:bodyPr>
+          <a:lstStyle/>
+          <a:p>
+            <a:pPr marL="342900" indent="-342900">
+              <a:lnSpc>
+                <a:spcPts val="1050"/>
+              </a:lnSpc>
+              <a:spcAft>
+                <a:spcPts val="400"/>
+              </a:spcAft>
+              <a:buSzPct val="100000"/>
+              <a:buChar char="•"/>
+            </a:pPr>
+            <a:r>
+              <a:rPr lang="en-US" sz="1000">
+                <a:solidFill>
+                  <a:srgbClr val="3A4453"/>
+                </a:solidFill>
+              </a:rPr>
+              <a:t>Company gross profit was $188k against $162k last September, up $26k.</a:t>
+            </a:r>
+            <a:endParaRPr lang="en-US" sz="850"/>
+          </a:p>
+          <a:p>
+            <a:pPr marL="342900" indent="-342900">
+              <a:lnSpc>
+                <a:spcPts val="1050"/>
+              </a:lnSpc>
+              <a:spcAft>
+                <a:spcPts val="400"/>
+              </a:spcAft>
+              <a:buSzPct val="100000"/>
+              <a:buChar char="•"/>
+            </a:pPr>
+            <a:r>
+              <a:rPr lang="en-US" sz="1000">
+                <a:solidFill>
+                  <a:srgbClr val="3A4453"/>
+                </a:solidFill>
+              </a:rPr>
+              <a:t>Integration is up $18k, Events $9k and Support $7k.</a:t>
+            </a:r>
+            <a:endParaRPr lang="en-US" sz="850"/>
+          </a:p>
+        </p:txBody>
+      </p:sp>
+      <p:sp>
+        <p:nvSpPr>
+          <p:cNvPr id="25" name="Slide Number Placeholder 0"/>
+          <p:cNvSpPr>
+            <a:spLocks noGrp="1"/>
+          </p:cNvSpPr>
+          <p:nvPr>
+            <p:ph type="sldNum" sz="quarter" idx="4294967295"/>
+          </p:nvPr>
+        </p:nvSpPr>
+        <p:spPr>
+          <a:xfrm>
+            <a:off x="8092440" y="4736592"/>
+            <a:ext cx="548640" cy="228600"/>
+          </a:xfrm>
+          <a:prstGeom prst="rect">
+            <a:avLst/>
+          </a:prstGeom>
+          <a:extLst>
+            <a:ext uri="{C572A759-6A51-4108-AA02-DFA0A04FC94B}">
+              <ma14:wrappingTextBoxFlag xmlns="" xmlns:ma14="http://schemas.microsoft.com/office/mac/drawingml/2011/main" val="0"/>
+            </a:ext>
+          </a:extLst>
+        </p:spPr>
+        <p:txBody>
+          <a:bodyPr/>
+          <a:lstStyle>
+            <a:lvl1pPr>
+              <a:defRPr sz="800">
+                <a:solidFill>
+                  <a:srgbClr val="6B7585"/>
+                </a:solidFill>
+              </a:defRPr>
+            </a:lvl1pPr>
+          </a:lstStyle>
+          <a:p>
+            <a:pPr algn="r"/>
+            <a:fld id="{F7021451-1387-4CA6-816F-3879F97B5CBC}" type="slidenum">
+              <a:rPr lang="en-US" b="0"/>
+              <a:t>9</a:t>
+            </a:fld>
+            <a:endParaRPr lang="en-US"/>
+          </a:p>
+        </p:txBody>
+      </p:sp>
+      <p:sp>
+        <p:nvSpPr>
+          <p:cNvPr id="4" name="Text 5b"/>
+          <p:cNvSpPr txBox="1"/>
+          <p:nvPr/>
+        </p:nvSpPr>
+        <p:spPr>
+          <a:xfrm>
+            <a:off x="4663440" y="3867911"/>
+            <a:ext cx="3703320" cy="731520"/>
+          </a:xfrm>
+          <a:prstGeom prst="rect">
+            <a:avLst/>
+          </a:prstGeom>
+          <a:noFill/>
+          <a:ln/>
+        </p:spPr>
+        <p:txBody>
+          <a:bodyPr wrap="square" lIns="0" tIns="0" rIns="0" bIns="0" rtlCol="0" anchor="t">
+            <a:normAutofit fontScale="85000" lnSpcReduction="10000"/>
+          </a:bodyPr>
+          <a:lstStyle/>
+          <a:p>
+            <a:pPr marL="342900" indent="-342900">
+              <a:lnSpc>
+                <a:spcPts val="1050"/>
+              </a:lnSpc>
+              <a:spcAft>
+                <a:spcPts val="400"/>
+              </a:spcAft>
+              <a:buSzPct val="100000"/>
+              <a:buChar char="•"/>
+            </a:pPr>
+            <a:r>
+              <a:rPr lang="en-US" sz="1000">
+                <a:solidFill>
+                  <a:srgbClr val="3A4453"/>
+                </a:solidFill>
+              </a:rPr>
+              <a:t>Video fell from $13k to $6k and Consulting from $2k to almost nothing.</a:t>
+            </a:r>
+            <a:endParaRPr lang="en-US" sz="850"/>
+          </a:p>
+          <a:p>
+            <a:pPr marL="342900" indent="-342900">
+              <a:lnSpc>
+                <a:spcPts val="1050"/>
+              </a:lnSpc>
+              <a:spcAft>
+                <a:spcPts val="400"/>
+              </a:spcAft>
+              <a:buSzPct val="100000"/>
+              <a:buChar char="•"/>
+            </a:pPr>
+            <a:r>
+              <a:rPr lang="en-US" sz="1000">
+                <a:solidFill>
+                  <a:srgbClr val="3A4453"/>
+                </a:solidFill>
+              </a:rPr>
+              <a:t>Gross profit only. Overhead was not split by department before this year, so the net result cannot go back.</a:t>
+            </a:r>
+            <a:endParaRPr lang="en-US" sz="850"/>
+          </a:p>
+        </p:txBody>
+      </p:sp>
+      <p:pic>
+        <p:nvPicPr>
+          <p:cNvPr id="26" name="cts logo" descr="image.png"/>
+          <p:cNvPicPr>
+            <a:picLocks noChangeAspect="1"/>
+          </p:cNvPicPr>
+          <p:nvPr/>
+        </p:nvPicPr>
+        <p:blipFill>
+          <a:blip r:embed="rId2"/>
+          <a:stretch>
+            <a:fillRect/>
+          </a:stretch>
+        </p:blipFill>
+        <p:spPr>
+          <a:xfrm>
+            <a:off x="7680959" y="182880"/>
+            <a:ext cx="960120" cy="539696"/>
+          </a:xfrm>
+          <a:prstGeom prst="rect">
+            <a:avLst/>
+          </a:prstGeom>
+        </p:spPr>
+      </p:pic>
+    </p:spTree>
+  </p:cSld>
+  <p:clrMapOvr>
+    <a:masterClrMapping/>
+  </p:clrMapOvr>
+</p:sld>
+</file>
+
+<file path=ppt/slides/slide28.xml><?xml version="1.0" encoding="utf-8"?>
 <p:sld xmlns:a="http://schemas.openxmlformats.org/drawingml/2006/main" xmlns:r="http://schemas.openxmlformats.org/officeDocument/2006/relationships" xmlns:p="http://schemas.openxmlformats.org/presentationml/2006/main">
   <p:cSld name="Slide 14">
     <p:spTree>
@@ -14793,7 +15266,7 @@
 </p:sld>
 </file>
 
-<file path=ppt/slides/slide28.xml><?xml version="1.0" encoding="utf-8"?>
+<file path=ppt/slides/slide29.xml><?xml version="1.0" encoding="utf-8"?>
 <p:sld xmlns:a="http://schemas.openxmlformats.org/drawingml/2006/main" xmlns:r="http://schemas.openxmlformats.org/officeDocument/2006/relationships" xmlns:p="http://schemas.openxmlformats.org/presentationml/2006/main">
   <p:cSld name="Slide 15">
     <p:spTree>
@@ -15065,412 +15538,6 @@
               <a:t>Where the money goes and which lines move</a:t>
             </a:r>
             <a:endParaRPr lang="en-US" sz="1200"/>
-          </a:p>
-        </p:txBody>
-      </p:sp>
-    </p:spTree>
-  </p:cSld>
-  <p:clrMapOvr>
-    <a:masterClrMapping/>
-  </p:clrMapOvr>
-</p:sld>
-</file>
-
-<file path=ppt/slides/slide29.xml><?xml version="1.0" encoding="utf-8"?>
-<p:sld xmlns:a="http://schemas.openxmlformats.org/drawingml/2006/main" xmlns:r="http://schemas.openxmlformats.org/officeDocument/2006/relationships" xmlns:p="http://schemas.openxmlformats.org/presentationml/2006/main">
-  <p:cSld name="Slide 16">
-    <p:spTree>
-      <p:nvGrpSpPr>
-        <p:cNvPr id="1" name=""/>
-        <p:cNvGrpSpPr/>
-        <p:nvPr/>
-      </p:nvGrpSpPr>
-      <p:grpSpPr>
-        <a:xfrm>
-          <a:off x="0" y="0"/>
-          <a:ext cx="0" cy="0"/>
-          <a:chOff x="0" y="0"/>
-          <a:chExt cx="0" cy="0"/>
-        </a:xfrm>
-      </p:grpSpPr>
-      <p:pic>
-        <p:nvPicPr>
-          <p:cNvPr id="27" name="snip cost_dist" descr="cost_dist.png"/>
-          <p:cNvPicPr>
-            <a:picLocks noChangeAspect="1"/>
-          </p:cNvPicPr>
-          <p:nvPr/>
-        </p:nvPicPr>
-        <p:blipFill>
-          <a:blip r:embed="rId3"/>
-          <a:stretch>
-            <a:fillRect/>
-          </a:stretch>
-        </p:blipFill>
-        <p:spPr>
-          <a:xfrm>
-            <a:off x="2640967" y="1005840"/>
-            <a:ext cx="3862065" cy="1956815"/>
-          </a:xfrm>
-          <a:prstGeom prst="rect">
-            <a:avLst/>
-          </a:prstGeom>
-        </p:spPr>
-      </p:pic>
-      <p:sp>
-        <p:nvSpPr>
-          <p:cNvPr id="2" name="Text 0"/>
-          <p:cNvSpPr txBox="1"/>
-          <p:nvPr/>
-        </p:nvSpPr>
-        <p:spPr>
-          <a:xfrm>
-            <a:off x="502920" y="365760"/>
-            <a:ext cx="6400800" cy="274320"/>
-          </a:xfrm>
-          <a:prstGeom prst="rect">
-            <a:avLst/>
-          </a:prstGeom>
-          <a:noFill/>
-          <a:ln/>
-        </p:spPr>
-        <p:txBody>
-          <a:bodyPr wrap="square" lIns="0" tIns="0" rIns="0" bIns="0" rtlCol="0" anchor="ctr"/>
-          <a:lstStyle/>
-          <a:p>
-            <a:pPr marL="0" indent="0">
-              <a:buNone/>
-            </a:pPr>
-            <a:r>
-              <a:rPr lang="en-US" sz="950" b="1" kern="0" spc="220">
-                <a:solidFill>
-                  <a:srgbClr val="122B82"/>
-                </a:solidFill>
-              </a:rPr>
-              <a:t>OPERATING EXPENDITURE</a:t>
-            </a:r>
-            <a:endParaRPr lang="en-US" sz="950"/>
-          </a:p>
-        </p:txBody>
-      </p:sp>
-      <p:sp>
-        <p:nvSpPr>
-          <p:cNvPr id="3" name="Text 1"/>
-          <p:cNvSpPr txBox="1"/>
-          <p:nvPr/>
-        </p:nvSpPr>
-        <p:spPr>
-          <a:xfrm>
-            <a:off x="502920" y="640080"/>
-            <a:ext cx="7315200" cy="365760"/>
-          </a:xfrm>
-          <a:prstGeom prst="rect">
-            <a:avLst/>
-          </a:prstGeom>
-          <a:noFill/>
-          <a:ln/>
-        </p:spPr>
-        <p:txBody>
-          <a:bodyPr wrap="square" lIns="0" tIns="0" rIns="0" bIns="0" rtlCol="0" anchor="ctr"/>
-          <a:lstStyle/>
-          <a:p>
-            <a:pPr marL="0" indent="0" algn="ctr">
-              <a:buNone/>
-            </a:pPr>
-            <a:r>
-              <a:rPr lang="en-US" sz="2200" b="1">
-                <a:solidFill>
-                  <a:srgbClr val="242C39"/>
-                </a:solidFill>
-              </a:rPr>
-              <a:t>Operating cost distribution, year to date</a:t>
-            </a:r>
-            <a:endParaRPr lang="en-US" sz="2700"/>
-          </a:p>
-        </p:txBody>
-      </p:sp>
-      <p:sp>
-        <p:nvSpPr>
-          <p:cNvPr id="6" name="commentary panel"/>
-          <p:cNvSpPr/>
-          <p:nvPr/>
-        </p:nvSpPr>
-        <p:spPr>
-          <a:xfrm>
-            <a:off x="502920" y="3054096"/>
-            <a:ext cx="8138160" cy="1572768"/>
-          </a:xfrm>
-          <a:prstGeom prst="rect">
-            <a:avLst/>
-          </a:prstGeom>
-          <a:solidFill>
-            <a:srgbClr val="E8F9F8"/>
-          </a:solidFill>
-          <a:ln/>
-        </p:spPr>
-        <p:txBody>
-          <a:bodyPr/>
-          <a:lstStyle/>
-          <a:p>
-            <a:endParaRPr lang="en-AU"/>
-          </a:p>
-        </p:txBody>
-      </p:sp>
-      <p:sp>
-        <p:nvSpPr>
-          <p:cNvPr id="7" name="Text 4"/>
-          <p:cNvSpPr txBox="1"/>
-          <p:nvPr/>
-        </p:nvSpPr>
-        <p:spPr>
-          <a:xfrm>
-            <a:off x="685800" y="3127248"/>
-            <a:ext cx="2743200" cy="228600"/>
-          </a:xfrm>
-          <a:prstGeom prst="rect">
-            <a:avLst/>
-          </a:prstGeom>
-          <a:noFill/>
-          <a:ln/>
-        </p:spPr>
-        <p:txBody>
-          <a:bodyPr wrap="square" lIns="0" tIns="0" rIns="0" bIns="0" rtlCol="0" anchor="ctr"/>
-          <a:lstStyle/>
-          <a:p>
-            <a:pPr marL="0" indent="0">
-              <a:buNone/>
-            </a:pPr>
-            <a:r>
-              <a:rPr lang="en-US" sz="900" b="1" kern="0" spc="180">
-                <a:solidFill>
-                  <a:srgbClr val="005358"/>
-                </a:solidFill>
-              </a:rPr>
-              <a:t>COMMENTARY</a:t>
-            </a:r>
-            <a:endParaRPr lang="en-US" sz="900"/>
-          </a:p>
-        </p:txBody>
-      </p:sp>
-      <p:sp>
-        <p:nvSpPr>
-          <p:cNvPr id="8" name="Text 5"/>
-          <p:cNvSpPr txBox="1"/>
-          <p:nvPr/>
-        </p:nvSpPr>
-        <p:spPr>
-          <a:xfrm>
-            <a:off x="685800" y="3300984"/>
-            <a:ext cx="3703320" cy="1298448"/>
-          </a:xfrm>
-          <a:prstGeom prst="rect">
-            <a:avLst/>
-          </a:prstGeom>
-          <a:noFill/>
-          <a:ln/>
-        </p:spPr>
-        <p:txBody>
-          <a:bodyPr wrap="square" lIns="0" tIns="0" rIns="0" bIns="0" rtlCol="0" anchor="t">
-            <a:normAutofit fontScale="85000" lnSpcReduction="10000"/>
-          </a:bodyPr>
-          <a:lstStyle/>
-          <a:p>
-            <a:pPr marL="342900" indent="-342900">
-              <a:lnSpc>
-                <a:spcPts val="1050"/>
-              </a:lnSpc>
-              <a:spcAft>
-                <a:spcPts val="400"/>
-              </a:spcAft>
-              <a:buSzPct val="100000"/>
-              <a:buChar char="•"/>
-            </a:pPr>
-            <a:r>
-              <a:rPr lang="en-US" sz="1000">
-                <a:solidFill>
-                  <a:srgbClr val="3A4453"/>
-                </a:solidFill>
-              </a:rPr>
-              <a:t>Year-to-date direct labour costs total $621k, with a further $369k in employment overheads. Together, these represent a substantial share of total costs.</a:t>
-            </a:r>
-            <a:endParaRPr lang="en-US" sz="850"/>
-          </a:p>
-          <a:p>
-            <a:pPr marL="342900" indent="-342900">
-              <a:lnSpc>
-                <a:spcPts val="1050"/>
-              </a:lnSpc>
-              <a:spcAft>
-                <a:spcPts val="400"/>
-              </a:spcAft>
-              <a:buSzPct val="100000"/>
-              <a:buChar char="•"/>
-            </a:pPr>
-            <a:r>
-              <a:rPr lang="en-US" sz="1000">
-                <a:solidFill>
-                  <a:srgbClr val="3A4453"/>
-                </a:solidFill>
-              </a:rPr>
-              <a:t>Labour is the largest cost category and has a major impact on profitability.</a:t>
-            </a:r>
-            <a:endParaRPr lang="en-US" sz="850"/>
-          </a:p>
-        </p:txBody>
-      </p:sp>
-      <p:sp>
-        <p:nvSpPr>
-          <p:cNvPr id="25" name="Slide Number Placeholder 0"/>
-          <p:cNvSpPr>
-            <a:spLocks noGrp="1"/>
-          </p:cNvSpPr>
-          <p:nvPr>
-            <p:ph type="sldNum" sz="quarter" idx="4294967295"/>
-          </p:nvPr>
-        </p:nvSpPr>
-        <p:spPr>
-          <a:xfrm>
-            <a:off x="8092440" y="4736592"/>
-            <a:ext cx="548640" cy="228600"/>
-          </a:xfrm>
-          <a:prstGeom prst="rect">
-            <a:avLst/>
-          </a:prstGeom>
-          <a:extLst>
-            <a:ext uri="{C572A759-6A51-4108-AA02-DFA0A04FC94B}">
-              <ma14:wrappingTextBoxFlag xmlns="" xmlns:ma14="http://schemas.microsoft.com/office/mac/drawingml/2011/main" val="0"/>
-            </a:ext>
-          </a:extLst>
-        </p:spPr>
-        <p:txBody>
-          <a:bodyPr/>
-          <a:lstStyle>
-            <a:lvl1pPr>
-              <a:defRPr sz="800">
-                <a:solidFill>
-                  <a:srgbClr val="6B7585"/>
-                </a:solidFill>
-              </a:defRPr>
-            </a:lvl1pPr>
-          </a:lstStyle>
-          <a:p>
-            <a:pPr algn="r"/>
-            <a:fld id="{F7021451-1387-4CA6-816F-3879F97B5CBC}" type="slidenum">
-              <a:rPr lang="en-US" b="0"/>
-              <a:t>27</a:t>
-            </a:fld>
-            <a:endParaRPr lang="en-US"/>
-          </a:p>
-        </p:txBody>
-      </p:sp>
-      <p:pic>
-        <p:nvPicPr>
-          <p:cNvPr id="26" name="cts logo" descr="cts-logo.png"/>
-          <p:cNvPicPr>
-            <a:picLocks noChangeAspect="1"/>
-          </p:cNvPicPr>
-          <p:nvPr/>
-        </p:nvPicPr>
-        <p:blipFill>
-          <a:blip r:embed="rId4"/>
-          <a:stretch>
-            <a:fillRect/>
-          </a:stretch>
-        </p:blipFill>
-        <p:spPr>
-          <a:xfrm>
-            <a:off x="7680959" y="182880"/>
-            <a:ext cx="960120" cy="539696"/>
-          </a:xfrm>
-          <a:prstGeom prst="rect">
-            <a:avLst/>
-          </a:prstGeom>
-        </p:spPr>
-      </p:pic>
-      <p:sp>
-        <p:nvSpPr>
-          <p:cNvPr id="4" name="Text 5b"/>
-          <p:cNvSpPr txBox="1"/>
-          <p:nvPr/>
-        </p:nvSpPr>
-        <p:spPr>
-          <a:xfrm>
-            <a:off x="4663440" y="3300984"/>
-            <a:ext cx="3703320" cy="1298448"/>
-          </a:xfrm>
-          <a:prstGeom prst="rect">
-            <a:avLst/>
-          </a:prstGeom>
-          <a:noFill/>
-          <a:ln/>
-        </p:spPr>
-        <p:txBody>
-          <a:bodyPr wrap="square" lIns="0" tIns="0" rIns="0" bIns="0" rtlCol="0" anchor="t">
-            <a:normAutofit fontScale="85000" lnSpcReduction="10000"/>
-          </a:bodyPr>
-          <a:lstStyle/>
-          <a:p>
-            <a:pPr marL="342900" indent="-342900">
-              <a:lnSpc>
-                <a:spcPts val="1050"/>
-              </a:lnSpc>
-              <a:spcAft>
-                <a:spcPts val="400"/>
-              </a:spcAft>
-              <a:buSzPct val="100000"/>
-              <a:buChar char="•"/>
-            </a:pPr>
-            <a:r>
-              <a:rPr lang="en-US" sz="1000">
-                <a:solidFill>
-                  <a:srgbClr val="3A4453"/>
-                </a:solidFill>
-              </a:rPr>
-              <a:t>Much of the employment overhead is relatively fixed in the short term, even when revenue fluctuates.</a:t>
-            </a:r>
-            <a:endParaRPr lang="en-US" sz="850"/>
-          </a:p>
-          <a:p>
-            <a:pPr marL="342900" indent="-342900">
-              <a:lnSpc>
-                <a:spcPts val="1050"/>
-              </a:lnSpc>
-              <a:spcAft>
-                <a:spcPts val="400"/>
-              </a:spcAft>
-              <a:buSzPct val="100000"/>
-              <a:buChar char="•"/>
-            </a:pPr>
-            <a:r>
-              <a:rPr lang="en-US" sz="1000">
-                <a:solidFill>
-                  <a:srgbClr val="3A4453"/>
-                </a:solidFill>
-              </a:rPr>
-              <a:t>Equipment and services costs of $347k are more closely linked to project activity.</a:t>
-            </a:r>
-            <a:endParaRPr lang="en-US" sz="850"/>
-          </a:p>
-          <a:p>
-            <a:pPr marL="342900" indent="-342900">
-              <a:lnSpc>
-                <a:spcPts val="1050"/>
-              </a:lnSpc>
-              <a:spcAft>
-                <a:spcPts val="400"/>
-              </a:spcAft>
-              <a:buSzPct val="100000"/>
-              <a:buChar char="•"/>
-            </a:pPr>
-            <a:r>
-              <a:rPr lang="en-US" sz="1000">
-                <a:solidFill>
-                  <a:srgbClr val="3A4453"/>
-                </a:solidFill>
-              </a:rPr>
-              <a:t>Material cost reductions would require a review of staffing capacity, utilisation and premises costs, while maintaining service delivery.</a:t>
-            </a:r>
-            <a:endParaRPr lang="en-US" sz="850"/>
           </a:p>
         </p:txBody>
       </p:sp>
@@ -17736,6 +17803,412 @@
 
 <file path=ppt/slides/slide30.xml><?xml version="1.0" encoding="utf-8"?>
 <p:sld xmlns:a="http://schemas.openxmlformats.org/drawingml/2006/main" xmlns:r="http://schemas.openxmlformats.org/officeDocument/2006/relationships" xmlns:p="http://schemas.openxmlformats.org/presentationml/2006/main">
+  <p:cSld name="Slide 16">
+    <p:spTree>
+      <p:nvGrpSpPr>
+        <p:cNvPr id="1" name=""/>
+        <p:cNvGrpSpPr/>
+        <p:nvPr/>
+      </p:nvGrpSpPr>
+      <p:grpSpPr>
+        <a:xfrm>
+          <a:off x="0" y="0"/>
+          <a:ext cx="0" cy="0"/>
+          <a:chOff x="0" y="0"/>
+          <a:chExt cx="0" cy="0"/>
+        </a:xfrm>
+      </p:grpSpPr>
+      <p:pic>
+        <p:nvPicPr>
+          <p:cNvPr id="27" name="snip cost_dist" descr="cost_dist.png"/>
+          <p:cNvPicPr>
+            <a:picLocks noChangeAspect="1"/>
+          </p:cNvPicPr>
+          <p:nvPr/>
+        </p:nvPicPr>
+        <p:blipFill>
+          <a:blip r:embed="rId3"/>
+          <a:stretch>
+            <a:fillRect/>
+          </a:stretch>
+        </p:blipFill>
+        <p:spPr>
+          <a:xfrm>
+            <a:off x="2640967" y="1005840"/>
+            <a:ext cx="3862065" cy="1956815"/>
+          </a:xfrm>
+          <a:prstGeom prst="rect">
+            <a:avLst/>
+          </a:prstGeom>
+        </p:spPr>
+      </p:pic>
+      <p:sp>
+        <p:nvSpPr>
+          <p:cNvPr id="2" name="Text 0"/>
+          <p:cNvSpPr txBox="1"/>
+          <p:nvPr/>
+        </p:nvSpPr>
+        <p:spPr>
+          <a:xfrm>
+            <a:off x="502920" y="365760"/>
+            <a:ext cx="6400800" cy="274320"/>
+          </a:xfrm>
+          <a:prstGeom prst="rect">
+            <a:avLst/>
+          </a:prstGeom>
+          <a:noFill/>
+          <a:ln/>
+        </p:spPr>
+        <p:txBody>
+          <a:bodyPr wrap="square" lIns="0" tIns="0" rIns="0" bIns="0" rtlCol="0" anchor="ctr"/>
+          <a:lstStyle/>
+          <a:p>
+            <a:pPr marL="0" indent="0">
+              <a:buNone/>
+            </a:pPr>
+            <a:r>
+              <a:rPr lang="en-US" sz="950" b="1" kern="0" spc="220">
+                <a:solidFill>
+                  <a:srgbClr val="122B82"/>
+                </a:solidFill>
+              </a:rPr>
+              <a:t>OPERATING EXPENDITURE</a:t>
+            </a:r>
+            <a:endParaRPr lang="en-US" sz="950"/>
+          </a:p>
+        </p:txBody>
+      </p:sp>
+      <p:sp>
+        <p:nvSpPr>
+          <p:cNvPr id="3" name="Text 1"/>
+          <p:cNvSpPr txBox="1"/>
+          <p:nvPr/>
+        </p:nvSpPr>
+        <p:spPr>
+          <a:xfrm>
+            <a:off x="502920" y="640080"/>
+            <a:ext cx="7315200" cy="365760"/>
+          </a:xfrm>
+          <a:prstGeom prst="rect">
+            <a:avLst/>
+          </a:prstGeom>
+          <a:noFill/>
+          <a:ln/>
+        </p:spPr>
+        <p:txBody>
+          <a:bodyPr wrap="square" lIns="0" tIns="0" rIns="0" bIns="0" rtlCol="0" anchor="ctr"/>
+          <a:lstStyle/>
+          <a:p>
+            <a:pPr marL="0" indent="0" algn="ctr">
+              <a:buNone/>
+            </a:pPr>
+            <a:r>
+              <a:rPr lang="en-US" sz="2200" b="1">
+                <a:solidFill>
+                  <a:srgbClr val="242C39"/>
+                </a:solidFill>
+              </a:rPr>
+              <a:t>Operating cost distribution, year to date</a:t>
+            </a:r>
+            <a:endParaRPr lang="en-US" sz="2700"/>
+          </a:p>
+        </p:txBody>
+      </p:sp>
+      <p:sp>
+        <p:nvSpPr>
+          <p:cNvPr id="6" name="commentary panel"/>
+          <p:cNvSpPr/>
+          <p:nvPr/>
+        </p:nvSpPr>
+        <p:spPr>
+          <a:xfrm>
+            <a:off x="502920" y="3054096"/>
+            <a:ext cx="8138160" cy="1572768"/>
+          </a:xfrm>
+          <a:prstGeom prst="rect">
+            <a:avLst/>
+          </a:prstGeom>
+          <a:solidFill>
+            <a:srgbClr val="E8F9F8"/>
+          </a:solidFill>
+          <a:ln/>
+        </p:spPr>
+        <p:txBody>
+          <a:bodyPr/>
+          <a:lstStyle/>
+          <a:p>
+            <a:endParaRPr lang="en-AU"/>
+          </a:p>
+        </p:txBody>
+      </p:sp>
+      <p:sp>
+        <p:nvSpPr>
+          <p:cNvPr id="7" name="Text 4"/>
+          <p:cNvSpPr txBox="1"/>
+          <p:nvPr/>
+        </p:nvSpPr>
+        <p:spPr>
+          <a:xfrm>
+            <a:off x="685800" y="3127248"/>
+            <a:ext cx="2743200" cy="228600"/>
+          </a:xfrm>
+          <a:prstGeom prst="rect">
+            <a:avLst/>
+          </a:prstGeom>
+          <a:noFill/>
+          <a:ln/>
+        </p:spPr>
+        <p:txBody>
+          <a:bodyPr wrap="square" lIns="0" tIns="0" rIns="0" bIns="0" rtlCol="0" anchor="ctr"/>
+          <a:lstStyle/>
+          <a:p>
+            <a:pPr marL="0" indent="0">
+              <a:buNone/>
+            </a:pPr>
+            <a:r>
+              <a:rPr lang="en-US" sz="900" b="1" kern="0" spc="180">
+                <a:solidFill>
+                  <a:srgbClr val="005358"/>
+                </a:solidFill>
+              </a:rPr>
+              <a:t>COMMENTARY</a:t>
+            </a:r>
+            <a:endParaRPr lang="en-US" sz="900"/>
+          </a:p>
+        </p:txBody>
+      </p:sp>
+      <p:sp>
+        <p:nvSpPr>
+          <p:cNvPr id="8" name="Text 5"/>
+          <p:cNvSpPr txBox="1"/>
+          <p:nvPr/>
+        </p:nvSpPr>
+        <p:spPr>
+          <a:xfrm>
+            <a:off x="685800" y="3300984"/>
+            <a:ext cx="3703320" cy="1298448"/>
+          </a:xfrm>
+          <a:prstGeom prst="rect">
+            <a:avLst/>
+          </a:prstGeom>
+          <a:noFill/>
+          <a:ln/>
+        </p:spPr>
+        <p:txBody>
+          <a:bodyPr wrap="square" lIns="0" tIns="0" rIns="0" bIns="0" rtlCol="0" anchor="t">
+            <a:normAutofit fontScale="85000" lnSpcReduction="10000"/>
+          </a:bodyPr>
+          <a:lstStyle/>
+          <a:p>
+            <a:pPr marL="342900" indent="-342900">
+              <a:lnSpc>
+                <a:spcPts val="1050"/>
+              </a:lnSpc>
+              <a:spcAft>
+                <a:spcPts val="400"/>
+              </a:spcAft>
+              <a:buSzPct val="100000"/>
+              <a:buChar char="•"/>
+            </a:pPr>
+            <a:r>
+              <a:rPr lang="en-US" sz="1000">
+                <a:solidFill>
+                  <a:srgbClr val="3A4453"/>
+                </a:solidFill>
+              </a:rPr>
+              <a:t>Year-to-date direct labour costs total $621k, with a further $369k in employment overheads. Together, these represent a substantial share of total costs.</a:t>
+            </a:r>
+            <a:endParaRPr lang="en-US" sz="850"/>
+          </a:p>
+          <a:p>
+            <a:pPr marL="342900" indent="-342900">
+              <a:lnSpc>
+                <a:spcPts val="1050"/>
+              </a:lnSpc>
+              <a:spcAft>
+                <a:spcPts val="400"/>
+              </a:spcAft>
+              <a:buSzPct val="100000"/>
+              <a:buChar char="•"/>
+            </a:pPr>
+            <a:r>
+              <a:rPr lang="en-US" sz="1000">
+                <a:solidFill>
+                  <a:srgbClr val="3A4453"/>
+                </a:solidFill>
+              </a:rPr>
+              <a:t>Labour is the largest cost category and has a major impact on profitability.</a:t>
+            </a:r>
+            <a:endParaRPr lang="en-US" sz="850"/>
+          </a:p>
+        </p:txBody>
+      </p:sp>
+      <p:sp>
+        <p:nvSpPr>
+          <p:cNvPr id="25" name="Slide Number Placeholder 0"/>
+          <p:cNvSpPr>
+            <a:spLocks noGrp="1"/>
+          </p:cNvSpPr>
+          <p:nvPr>
+            <p:ph type="sldNum" sz="quarter" idx="4294967295"/>
+          </p:nvPr>
+        </p:nvSpPr>
+        <p:spPr>
+          <a:xfrm>
+            <a:off x="8092440" y="4736592"/>
+            <a:ext cx="548640" cy="228600"/>
+          </a:xfrm>
+          <a:prstGeom prst="rect">
+            <a:avLst/>
+          </a:prstGeom>
+          <a:extLst>
+            <a:ext uri="{C572A759-6A51-4108-AA02-DFA0A04FC94B}">
+              <ma14:wrappingTextBoxFlag xmlns="" xmlns:ma14="http://schemas.microsoft.com/office/mac/drawingml/2011/main" val="0"/>
+            </a:ext>
+          </a:extLst>
+        </p:spPr>
+        <p:txBody>
+          <a:bodyPr/>
+          <a:lstStyle>
+            <a:lvl1pPr>
+              <a:defRPr sz="800">
+                <a:solidFill>
+                  <a:srgbClr val="6B7585"/>
+                </a:solidFill>
+              </a:defRPr>
+            </a:lvl1pPr>
+          </a:lstStyle>
+          <a:p>
+            <a:pPr algn="r"/>
+            <a:fld id="{F7021451-1387-4CA6-816F-3879F97B5CBC}" type="slidenum">
+              <a:rPr lang="en-US" b="0"/>
+              <a:t>27</a:t>
+            </a:fld>
+            <a:endParaRPr lang="en-US"/>
+          </a:p>
+        </p:txBody>
+      </p:sp>
+      <p:pic>
+        <p:nvPicPr>
+          <p:cNvPr id="26" name="cts logo" descr="cts-logo.png"/>
+          <p:cNvPicPr>
+            <a:picLocks noChangeAspect="1"/>
+          </p:cNvPicPr>
+          <p:nvPr/>
+        </p:nvPicPr>
+        <p:blipFill>
+          <a:blip r:embed="rId4"/>
+          <a:stretch>
+            <a:fillRect/>
+          </a:stretch>
+        </p:blipFill>
+        <p:spPr>
+          <a:xfrm>
+            <a:off x="7680959" y="182880"/>
+            <a:ext cx="960120" cy="539696"/>
+          </a:xfrm>
+          <a:prstGeom prst="rect">
+            <a:avLst/>
+          </a:prstGeom>
+        </p:spPr>
+      </p:pic>
+      <p:sp>
+        <p:nvSpPr>
+          <p:cNvPr id="4" name="Text 5b"/>
+          <p:cNvSpPr txBox="1"/>
+          <p:nvPr/>
+        </p:nvSpPr>
+        <p:spPr>
+          <a:xfrm>
+            <a:off x="4663440" y="3300984"/>
+            <a:ext cx="3703320" cy="1298448"/>
+          </a:xfrm>
+          <a:prstGeom prst="rect">
+            <a:avLst/>
+          </a:prstGeom>
+          <a:noFill/>
+          <a:ln/>
+        </p:spPr>
+        <p:txBody>
+          <a:bodyPr wrap="square" lIns="0" tIns="0" rIns="0" bIns="0" rtlCol="0" anchor="t">
+            <a:normAutofit fontScale="85000" lnSpcReduction="10000"/>
+          </a:bodyPr>
+          <a:lstStyle/>
+          <a:p>
+            <a:pPr marL="342900" indent="-342900">
+              <a:lnSpc>
+                <a:spcPts val="1050"/>
+              </a:lnSpc>
+              <a:spcAft>
+                <a:spcPts val="400"/>
+              </a:spcAft>
+              <a:buSzPct val="100000"/>
+              <a:buChar char="•"/>
+            </a:pPr>
+            <a:r>
+              <a:rPr lang="en-US" sz="1000">
+                <a:solidFill>
+                  <a:srgbClr val="3A4453"/>
+                </a:solidFill>
+              </a:rPr>
+              <a:t>Much of the employment overhead is relatively fixed in the short term, even when revenue fluctuates.</a:t>
+            </a:r>
+            <a:endParaRPr lang="en-US" sz="850"/>
+          </a:p>
+          <a:p>
+            <a:pPr marL="342900" indent="-342900">
+              <a:lnSpc>
+                <a:spcPts val="1050"/>
+              </a:lnSpc>
+              <a:spcAft>
+                <a:spcPts val="400"/>
+              </a:spcAft>
+              <a:buSzPct val="100000"/>
+              <a:buChar char="•"/>
+            </a:pPr>
+            <a:r>
+              <a:rPr lang="en-US" sz="1000">
+                <a:solidFill>
+                  <a:srgbClr val="3A4453"/>
+                </a:solidFill>
+              </a:rPr>
+              <a:t>Equipment and services costs of $347k are more closely linked to project activity.</a:t>
+            </a:r>
+            <a:endParaRPr lang="en-US" sz="850"/>
+          </a:p>
+          <a:p>
+            <a:pPr marL="342900" indent="-342900">
+              <a:lnSpc>
+                <a:spcPts val="1050"/>
+              </a:lnSpc>
+              <a:spcAft>
+                <a:spcPts val="400"/>
+              </a:spcAft>
+              <a:buSzPct val="100000"/>
+              <a:buChar char="•"/>
+            </a:pPr>
+            <a:r>
+              <a:rPr lang="en-US" sz="1000">
+                <a:solidFill>
+                  <a:srgbClr val="3A4453"/>
+                </a:solidFill>
+              </a:rPr>
+              <a:t>Material cost reductions would require a review of staffing capacity, utilisation and premises costs, while maintaining service delivery.</a:t>
+            </a:r>
+            <a:endParaRPr lang="en-US" sz="850"/>
+          </a:p>
+        </p:txBody>
+      </p:sp>
+    </p:spTree>
+  </p:cSld>
+  <p:clrMapOvr>
+    <a:masterClrMapping/>
+  </p:clrMapOvr>
+</p:sld>
+</file>
+
+<file path=ppt/slides/slide31.xml><?xml version="1.0" encoding="utf-8"?>
+<p:sld xmlns:a="http://schemas.openxmlformats.org/drawingml/2006/main" xmlns:r="http://schemas.openxmlformats.org/officeDocument/2006/relationships" xmlns:p="http://schemas.openxmlformats.org/presentationml/2006/main">
   <p:cSld name="Slide 17">
     <p:spTree>
       <p:nvGrpSpPr>
@@ -18140,7 +18613,7 @@
 </p:sld>
 </file>
 
-<file path=ppt/slides/slide31.xml><?xml version="1.0" encoding="utf-8"?>
+<file path=ppt/slides/slide32.xml><?xml version="1.0" encoding="utf-8"?>
 <p:sld xmlns:a="http://schemas.openxmlformats.org/drawingml/2006/main" xmlns:r="http://schemas.openxmlformats.org/officeDocument/2006/relationships" xmlns:p="http://schemas.openxmlformats.org/presentationml/2006/main">
   <p:cSld name="Slide 18">
     <p:spTree>
@@ -18546,7 +19019,7 @@
 </p:sld>
 </file>
 
-<file path=ppt/slides/slide32.xml><?xml version="1.0" encoding="utf-8"?>
+<file path=ppt/slides/slide33.xml><?xml version="1.0" encoding="utf-8"?>
 <p:sld xmlns:a="http://schemas.openxmlformats.org/drawingml/2006/main" xmlns:r="http://schemas.openxmlformats.org/officeDocument/2006/relationships" xmlns:p="http://schemas.openxmlformats.org/presentationml/2006/main">
   <p:cSld name="Slide 19">
     <p:spTree>
@@ -18931,7 +19404,7 @@
 </p:sld>
 </file>
 
-<file path=ppt/slides/slide33.xml><?xml version="1.0" encoding="utf-8"?>
+<file path=ppt/slides/slide34.xml><?xml version="1.0" encoding="utf-8"?>
 <p:sld xmlns:a="http://schemas.openxmlformats.org/drawingml/2006/main" xmlns:r="http://schemas.openxmlformats.org/officeDocument/2006/relationships" xmlns:p="http://schemas.openxmlformats.org/presentationml/2006/main">
   <p:cSld name="Slide 20">
     <p:spTree>
@@ -19214,7 +19687,7 @@
 </p:sld>
 </file>
 
-<file path=ppt/slides/slide34.xml><?xml version="1.0" encoding="utf-8"?>
+<file path=ppt/slides/slide35.xml><?xml version="1.0" encoding="utf-8"?>
 <p:sld xmlns:a="http://schemas.openxmlformats.org/drawingml/2006/main" xmlns:r="http://schemas.openxmlformats.org/officeDocument/2006/relationships" xmlns:p="http://schemas.openxmlformats.org/presentationml/2006/main">
   <p:cSld name="Slide 21">
     <p:spTree>
@@ -19620,7 +20093,7 @@
 </p:sld>
 </file>
 
-<file path=ppt/slides/slide35.xml><?xml version="1.0" encoding="utf-8"?>
+<file path=ppt/slides/slide36.xml><?xml version="1.0" encoding="utf-8"?>
 <p:sld xmlns:a="http://schemas.openxmlformats.org/drawingml/2006/main" xmlns:r="http://schemas.openxmlformats.org/officeDocument/2006/relationships" xmlns:p="http://schemas.openxmlformats.org/presentationml/2006/main">
   <p:cSld name="Slide 22">
     <p:spTree>
@@ -20026,7 +20499,7 @@
 </p:sld>
 </file>
 
-<file path=ppt/slides/slide36.xml><?xml version="1.0" encoding="utf-8"?>
+<file path=ppt/slides/slide37.xml><?xml version="1.0" encoding="utf-8"?>
 <p:sld xmlns:a="http://schemas.openxmlformats.org/drawingml/2006/main" xmlns:r="http://schemas.openxmlformats.org/officeDocument/2006/relationships" xmlns:p="http://schemas.openxmlformats.org/presentationml/2006/main">
   <p:cSld name="Slide 23">
     <p:spTree>
@@ -20432,7 +20905,7 @@
 </p:sld>
 </file>
 
-<file path=ppt/slides/slide37.xml><?xml version="1.0" encoding="utf-8"?>
+<file path=ppt/slides/slide38.xml><?xml version="1.0" encoding="utf-8"?>
 <p:sld xmlns:a="http://schemas.openxmlformats.org/drawingml/2006/main" xmlns:r="http://schemas.openxmlformats.org/officeDocument/2006/relationships" xmlns:p="http://schemas.openxmlformats.org/presentationml/2006/main">
   <p:cSld name="Slide 24">
     <p:spTree>
@@ -20715,7 +21188,7 @@
 </p:sld>
 </file>
 
-<file path=ppt/slides/slide38.xml><?xml version="1.0" encoding="utf-8"?>
+<file path=ppt/slides/slide39.xml><?xml version="1.0" encoding="utf-8"?>
 <p:sld xmlns:a="http://schemas.openxmlformats.org/drawingml/2006/main" xmlns:r="http://schemas.openxmlformats.org/officeDocument/2006/relationships" xmlns:p="http://schemas.openxmlformats.org/presentationml/2006/main">
   <p:cSld name="Slide 25">
     <p:spTree>
@@ -21092,412 +21565,6 @@
           </a:prstGeom>
         </p:spPr>
       </p:pic>
-    </p:spTree>
-  </p:cSld>
-  <p:clrMapOvr>
-    <a:masterClrMapping/>
-  </p:clrMapOvr>
-</p:sld>
-</file>
-
-<file path=ppt/slides/slide39.xml><?xml version="1.0" encoding="utf-8"?>
-<p:sld xmlns:a="http://schemas.openxmlformats.org/drawingml/2006/main" xmlns:r="http://schemas.openxmlformats.org/officeDocument/2006/relationships" xmlns:p="http://schemas.openxmlformats.org/presentationml/2006/main">
-  <p:cSld name="Slide 26">
-    <p:spTree>
-      <p:nvGrpSpPr>
-        <p:cNvPr id="1" name=""/>
-        <p:cNvGrpSpPr/>
-        <p:nvPr/>
-      </p:nvGrpSpPr>
-      <p:grpSpPr>
-        <a:xfrm>
-          <a:off x="0" y="0"/>
-          <a:ext cx="0" cy="0"/>
-          <a:chOff x="0" y="0"/>
-          <a:chExt cx="0" cy="0"/>
-        </a:xfrm>
-      </p:grpSpPr>
-      <p:pic>
-        <p:nvPicPr>
-          <p:cNvPr id="27" name="snip util_chart" descr="util_chart.png"/>
-          <p:cNvPicPr>
-            <a:picLocks noChangeAspect="1"/>
-          </p:cNvPicPr>
-          <p:nvPr/>
-        </p:nvPicPr>
-        <p:blipFill>
-          <a:blip r:embed="rId3"/>
-          <a:stretch>
-            <a:fillRect/>
-          </a:stretch>
-        </p:blipFill>
-        <p:spPr>
-          <a:xfrm>
-            <a:off x="565963" y="1005840"/>
-            <a:ext cx="8012072" cy="2130551"/>
-          </a:xfrm>
-          <a:prstGeom prst="rect">
-            <a:avLst/>
-          </a:prstGeom>
-        </p:spPr>
-      </p:pic>
-      <p:sp>
-        <p:nvSpPr>
-          <p:cNvPr id="2" name="Text 0"/>
-          <p:cNvSpPr txBox="1"/>
-          <p:nvPr/>
-        </p:nvSpPr>
-        <p:spPr>
-          <a:xfrm>
-            <a:off x="502920" y="365760"/>
-            <a:ext cx="6400800" cy="274320"/>
-          </a:xfrm>
-          <a:prstGeom prst="rect">
-            <a:avLst/>
-          </a:prstGeom>
-          <a:noFill/>
-          <a:ln/>
-        </p:spPr>
-        <p:txBody>
-          <a:bodyPr wrap="square" lIns="0" tIns="0" rIns="0" bIns="0" rtlCol="0" anchor="ctr"/>
-          <a:lstStyle/>
-          <a:p>
-            <a:pPr marL="0" indent="0">
-              <a:buNone/>
-            </a:pPr>
-            <a:r>
-              <a:rPr lang="en-US" sz="950" b="1" kern="0" spc="220">
-                <a:solidFill>
-                  <a:srgbClr val="122B82"/>
-                </a:solidFill>
-              </a:rPr>
-              <a:t>PEOPLE AND UTILISATION</a:t>
-            </a:r>
-            <a:endParaRPr lang="en-US" sz="950"/>
-          </a:p>
-        </p:txBody>
-      </p:sp>
-      <p:sp>
-        <p:nvSpPr>
-          <p:cNvPr id="3" name="Text 1"/>
-          <p:cNvSpPr txBox="1"/>
-          <p:nvPr/>
-        </p:nvSpPr>
-        <p:spPr>
-          <a:xfrm>
-            <a:off x="502920" y="640080"/>
-            <a:ext cx="7315200" cy="365760"/>
-          </a:xfrm>
-          <a:prstGeom prst="rect">
-            <a:avLst/>
-          </a:prstGeom>
-          <a:noFill/>
-          <a:ln/>
-        </p:spPr>
-        <p:txBody>
-          <a:bodyPr wrap="square" lIns="0" tIns="0" rIns="0" bIns="0" rtlCol="0" anchor="ctr"/>
-          <a:lstStyle/>
-          <a:p>
-            <a:pPr marL="0" indent="0" algn="ctr">
-              <a:buNone/>
-            </a:pPr>
-            <a:r>
-              <a:rPr lang="en-US" sz="2200" b="1">
-                <a:solidFill>
-                  <a:srgbClr val="242C39"/>
-                </a:solidFill>
-              </a:rPr>
-              <a:t>Hours mix by department, September 2026</a:t>
-            </a:r>
-            <a:endParaRPr lang="en-US" sz="2700"/>
-          </a:p>
-        </p:txBody>
-      </p:sp>
-      <p:sp>
-        <p:nvSpPr>
-          <p:cNvPr id="6" name="commentary panel"/>
-          <p:cNvSpPr/>
-          <p:nvPr/>
-        </p:nvSpPr>
-        <p:spPr>
-          <a:xfrm>
-            <a:off x="502920" y="3227831"/>
-            <a:ext cx="8138160" cy="1399032"/>
-          </a:xfrm>
-          <a:prstGeom prst="rect">
-            <a:avLst/>
-          </a:prstGeom>
-          <a:solidFill>
-            <a:srgbClr val="E8F9F8"/>
-          </a:solidFill>
-          <a:ln/>
-        </p:spPr>
-        <p:txBody>
-          <a:bodyPr/>
-          <a:lstStyle/>
-          <a:p>
-            <a:endParaRPr lang="en-AU"/>
-          </a:p>
-        </p:txBody>
-      </p:sp>
-      <p:sp>
-        <p:nvSpPr>
-          <p:cNvPr id="7" name="Text 4"/>
-          <p:cNvSpPr txBox="1"/>
-          <p:nvPr/>
-        </p:nvSpPr>
-        <p:spPr>
-          <a:xfrm>
-            <a:off x="685800" y="3300983"/>
-            <a:ext cx="2743200" cy="228600"/>
-          </a:xfrm>
-          <a:prstGeom prst="rect">
-            <a:avLst/>
-          </a:prstGeom>
-          <a:noFill/>
-          <a:ln/>
-        </p:spPr>
-        <p:txBody>
-          <a:bodyPr wrap="square" lIns="0" tIns="0" rIns="0" bIns="0" rtlCol="0" anchor="ctr"/>
-          <a:lstStyle/>
-          <a:p>
-            <a:pPr marL="0" indent="0">
-              <a:buNone/>
-            </a:pPr>
-            <a:r>
-              <a:rPr lang="en-US" sz="900" b="1" kern="0" spc="180">
-                <a:solidFill>
-                  <a:srgbClr val="005358"/>
-                </a:solidFill>
-              </a:rPr>
-              <a:t>COMMENTARY</a:t>
-            </a:r>
-            <a:endParaRPr lang="en-US" sz="900"/>
-          </a:p>
-        </p:txBody>
-      </p:sp>
-      <p:sp>
-        <p:nvSpPr>
-          <p:cNvPr id="8" name="Text 5"/>
-          <p:cNvSpPr txBox="1"/>
-          <p:nvPr/>
-        </p:nvSpPr>
-        <p:spPr>
-          <a:xfrm>
-            <a:off x="685800" y="3474719"/>
-            <a:ext cx="3703320" cy="1124712"/>
-          </a:xfrm>
-          <a:prstGeom prst="rect">
-            <a:avLst/>
-          </a:prstGeom>
-          <a:noFill/>
-          <a:ln/>
-        </p:spPr>
-        <p:txBody>
-          <a:bodyPr wrap="square" lIns="0" tIns="0" rIns="0" bIns="0" rtlCol="0" anchor="t">
-            <a:normAutofit fontScale="92500"/>
-          </a:bodyPr>
-          <a:lstStyle/>
-          <a:p>
-            <a:pPr marL="342900" indent="-342900">
-              <a:lnSpc>
-                <a:spcPts val="1050"/>
-              </a:lnSpc>
-              <a:spcAft>
-                <a:spcPts val="400"/>
-              </a:spcAft>
-              <a:buSzPct val="100000"/>
-              <a:buChar char="•"/>
-            </a:pPr>
-            <a:r>
-              <a:rPr lang="en-US" sz="1000">
-                <a:solidFill>
-                  <a:srgbClr val="3A4453"/>
-                </a:solidFill>
-              </a:rPr>
-              <a:t>Each bar shows the mix of hours within its own department, rather than comparing total hours between departments.</a:t>
-            </a:r>
-            <a:endParaRPr lang="en-US" sz="850"/>
-          </a:p>
-          <a:p>
-            <a:pPr marL="342900" indent="-342900">
-              <a:lnSpc>
-                <a:spcPts val="1050"/>
-              </a:lnSpc>
-              <a:spcAft>
-                <a:spcPts val="400"/>
-              </a:spcAft>
-              <a:buSzPct val="100000"/>
-              <a:buChar char="•"/>
-            </a:pPr>
-            <a:r>
-              <a:rPr lang="en-US" sz="1000">
-                <a:solidFill>
-                  <a:srgbClr val="3A4453"/>
-                </a:solidFill>
-              </a:rPr>
-              <a:t>Support's hours were predominantly billable, supporting its positive financial result.</a:t>
-            </a:r>
-            <a:endParaRPr lang="en-US" sz="850"/>
-          </a:p>
-        </p:txBody>
-      </p:sp>
-      <p:sp>
-        <p:nvSpPr>
-          <p:cNvPr id="25" name="Slide Number Placeholder 0"/>
-          <p:cNvSpPr>
-            <a:spLocks noGrp="1"/>
-          </p:cNvSpPr>
-          <p:nvPr>
-            <p:ph type="sldNum" sz="quarter" idx="4294967295"/>
-          </p:nvPr>
-        </p:nvSpPr>
-        <p:spPr>
-          <a:xfrm>
-            <a:off x="8092440" y="4736592"/>
-            <a:ext cx="548640" cy="228600"/>
-          </a:xfrm>
-          <a:prstGeom prst="rect">
-            <a:avLst/>
-          </a:prstGeom>
-          <a:extLst>
-            <a:ext uri="{C572A759-6A51-4108-AA02-DFA0A04FC94B}">
-              <ma14:wrappingTextBoxFlag xmlns="" xmlns:ma14="http://schemas.microsoft.com/office/mac/drawingml/2011/main" val="0"/>
-            </a:ext>
-          </a:extLst>
-        </p:spPr>
-        <p:txBody>
-          <a:bodyPr/>
-          <a:lstStyle>
-            <a:lvl1pPr>
-              <a:defRPr sz="800">
-                <a:solidFill>
-                  <a:srgbClr val="6B7585"/>
-                </a:solidFill>
-              </a:defRPr>
-            </a:lvl1pPr>
-          </a:lstStyle>
-          <a:p>
-            <a:pPr algn="r"/>
-            <a:fld id="{F7021451-1387-4CA6-816F-3879F97B5CBC}" type="slidenum">
-              <a:rPr lang="en-US" b="0"/>
-              <a:t>37</a:t>
-            </a:fld>
-            <a:endParaRPr lang="en-US"/>
-          </a:p>
-        </p:txBody>
-      </p:sp>
-      <p:pic>
-        <p:nvPicPr>
-          <p:cNvPr id="26" name="cts logo" descr="cts-logo.png"/>
-          <p:cNvPicPr>
-            <a:picLocks noChangeAspect="1"/>
-          </p:cNvPicPr>
-          <p:nvPr/>
-        </p:nvPicPr>
-        <p:blipFill>
-          <a:blip r:embed="rId4"/>
-          <a:stretch>
-            <a:fillRect/>
-          </a:stretch>
-        </p:blipFill>
-        <p:spPr>
-          <a:xfrm>
-            <a:off x="7680959" y="182880"/>
-            <a:ext cx="960120" cy="539696"/>
-          </a:xfrm>
-          <a:prstGeom prst="rect">
-            <a:avLst/>
-          </a:prstGeom>
-        </p:spPr>
-      </p:pic>
-      <p:sp>
-        <p:nvSpPr>
-          <p:cNvPr id="4" name="Text 5b"/>
-          <p:cNvSpPr txBox="1"/>
-          <p:nvPr/>
-        </p:nvSpPr>
-        <p:spPr>
-          <a:xfrm>
-            <a:off x="4663440" y="3474719"/>
-            <a:ext cx="3703320" cy="1124712"/>
-          </a:xfrm>
-          <a:prstGeom prst="rect">
-            <a:avLst/>
-          </a:prstGeom>
-          <a:noFill/>
-          <a:ln/>
-        </p:spPr>
-        <p:txBody>
-          <a:bodyPr wrap="square" lIns="0" tIns="0" rIns="0" bIns="0" rtlCol="0" anchor="t">
-            <a:normAutofit fontScale="92500"/>
-          </a:bodyPr>
-          <a:lstStyle/>
-          <a:p>
-            <a:pPr marL="342900" indent="-342900">
-              <a:lnSpc>
-                <a:spcPts val="1050"/>
-              </a:lnSpc>
-              <a:spcAft>
-                <a:spcPts val="400"/>
-              </a:spcAft>
-              <a:buSzPct val="100000"/>
-              <a:buChar char="•"/>
-            </a:pPr>
-            <a:r>
-              <a:rPr lang="en-US" sz="1000">
-                <a:solidFill>
-                  <a:srgbClr val="3A4453"/>
-                </a:solidFill>
-              </a:rPr>
-              <a:t>Events recorded 333 hours of leave and 241 billable hours, reducing its available delivery capacity.</a:t>
-            </a:r>
-            <a:endParaRPr lang="en-US" sz="850"/>
-          </a:p>
-          <a:p>
-            <a:pPr marL="342900" indent="-342900">
-              <a:lnSpc>
-                <a:spcPts val="1050"/>
-              </a:lnSpc>
-              <a:spcAft>
-                <a:spcPts val="400"/>
-              </a:spcAft>
-              <a:buSzPct val="100000"/>
-              <a:buChar char="•"/>
-            </a:pPr>
-            <a:r>
-              <a:rPr lang="en-US" sz="1000">
-                <a:solidFill>
-                  <a:srgbClr val="3A4453"/>
-                </a:solidFill>
-              </a:rPr>
-              <a:t>Consulting recorded 84 non-billable hours compared with 31 billable hours.</a:t>
-            </a:r>
-            <a:endParaRPr lang="en-US" sz="850"/>
-          </a:p>
-          <a:p>
-            <a:pPr marL="342900" indent="-342900">
-              <a:lnSpc>
-                <a:spcPts val="1050"/>
-              </a:lnSpc>
-              <a:spcAft>
-                <a:spcPts val="400"/>
-              </a:spcAft>
-              <a:buSzPct val="100000"/>
-              <a:buChar char="•"/>
-            </a:pPr>
-            <a:r>
-              <a:rPr lang="en-US" sz="1000">
-                <a:solidFill>
-                  <a:srgbClr val="3A4453"/>
-                </a:solidFill>
-              </a:rPr>
-              <a:t>The non-billable and leave portions highlight opportunities to improve workforce planning and billable utilisation.</a:t>
-            </a:r>
-            <a:endParaRPr lang="en-US" sz="850"/>
-          </a:p>
-        </p:txBody>
-      </p:sp>
     </p:spTree>
   </p:cSld>
   <p:clrMapOvr>
@@ -21791,6 +21858,412 @@
 
 <file path=ppt/slides/slide40.xml><?xml version="1.0" encoding="utf-8"?>
 <p:sld xmlns:a="http://schemas.openxmlformats.org/drawingml/2006/main" xmlns:r="http://schemas.openxmlformats.org/officeDocument/2006/relationships" xmlns:p="http://schemas.openxmlformats.org/presentationml/2006/main">
+  <p:cSld name="Slide 26">
+    <p:spTree>
+      <p:nvGrpSpPr>
+        <p:cNvPr id="1" name=""/>
+        <p:cNvGrpSpPr/>
+        <p:nvPr/>
+      </p:nvGrpSpPr>
+      <p:grpSpPr>
+        <a:xfrm>
+          <a:off x="0" y="0"/>
+          <a:ext cx="0" cy="0"/>
+          <a:chOff x="0" y="0"/>
+          <a:chExt cx="0" cy="0"/>
+        </a:xfrm>
+      </p:grpSpPr>
+      <p:pic>
+        <p:nvPicPr>
+          <p:cNvPr id="27" name="snip util_chart" descr="util_chart.png"/>
+          <p:cNvPicPr>
+            <a:picLocks noChangeAspect="1"/>
+          </p:cNvPicPr>
+          <p:nvPr/>
+        </p:nvPicPr>
+        <p:blipFill>
+          <a:blip r:embed="rId3"/>
+          <a:stretch>
+            <a:fillRect/>
+          </a:stretch>
+        </p:blipFill>
+        <p:spPr>
+          <a:xfrm>
+            <a:off x="565963" y="1005840"/>
+            <a:ext cx="8012072" cy="2130551"/>
+          </a:xfrm>
+          <a:prstGeom prst="rect">
+            <a:avLst/>
+          </a:prstGeom>
+        </p:spPr>
+      </p:pic>
+      <p:sp>
+        <p:nvSpPr>
+          <p:cNvPr id="2" name="Text 0"/>
+          <p:cNvSpPr txBox="1"/>
+          <p:nvPr/>
+        </p:nvSpPr>
+        <p:spPr>
+          <a:xfrm>
+            <a:off x="502920" y="365760"/>
+            <a:ext cx="6400800" cy="274320"/>
+          </a:xfrm>
+          <a:prstGeom prst="rect">
+            <a:avLst/>
+          </a:prstGeom>
+          <a:noFill/>
+          <a:ln/>
+        </p:spPr>
+        <p:txBody>
+          <a:bodyPr wrap="square" lIns="0" tIns="0" rIns="0" bIns="0" rtlCol="0" anchor="ctr"/>
+          <a:lstStyle/>
+          <a:p>
+            <a:pPr marL="0" indent="0">
+              <a:buNone/>
+            </a:pPr>
+            <a:r>
+              <a:rPr lang="en-US" sz="950" b="1" kern="0" spc="220">
+                <a:solidFill>
+                  <a:srgbClr val="122B82"/>
+                </a:solidFill>
+              </a:rPr>
+              <a:t>PEOPLE AND UTILISATION</a:t>
+            </a:r>
+            <a:endParaRPr lang="en-US" sz="950"/>
+          </a:p>
+        </p:txBody>
+      </p:sp>
+      <p:sp>
+        <p:nvSpPr>
+          <p:cNvPr id="3" name="Text 1"/>
+          <p:cNvSpPr txBox="1"/>
+          <p:nvPr/>
+        </p:nvSpPr>
+        <p:spPr>
+          <a:xfrm>
+            <a:off x="502920" y="640080"/>
+            <a:ext cx="7315200" cy="365760"/>
+          </a:xfrm>
+          <a:prstGeom prst="rect">
+            <a:avLst/>
+          </a:prstGeom>
+          <a:noFill/>
+          <a:ln/>
+        </p:spPr>
+        <p:txBody>
+          <a:bodyPr wrap="square" lIns="0" tIns="0" rIns="0" bIns="0" rtlCol="0" anchor="ctr"/>
+          <a:lstStyle/>
+          <a:p>
+            <a:pPr marL="0" indent="0" algn="ctr">
+              <a:buNone/>
+            </a:pPr>
+            <a:r>
+              <a:rPr lang="en-US" sz="2200" b="1">
+                <a:solidFill>
+                  <a:srgbClr val="242C39"/>
+                </a:solidFill>
+              </a:rPr>
+              <a:t>Hours mix by department, September 2026</a:t>
+            </a:r>
+            <a:endParaRPr lang="en-US" sz="2700"/>
+          </a:p>
+        </p:txBody>
+      </p:sp>
+      <p:sp>
+        <p:nvSpPr>
+          <p:cNvPr id="6" name="commentary panel"/>
+          <p:cNvSpPr/>
+          <p:nvPr/>
+        </p:nvSpPr>
+        <p:spPr>
+          <a:xfrm>
+            <a:off x="502920" y="3227831"/>
+            <a:ext cx="8138160" cy="1399032"/>
+          </a:xfrm>
+          <a:prstGeom prst="rect">
+            <a:avLst/>
+          </a:prstGeom>
+          <a:solidFill>
+            <a:srgbClr val="E8F9F8"/>
+          </a:solidFill>
+          <a:ln/>
+        </p:spPr>
+        <p:txBody>
+          <a:bodyPr/>
+          <a:lstStyle/>
+          <a:p>
+            <a:endParaRPr lang="en-AU"/>
+          </a:p>
+        </p:txBody>
+      </p:sp>
+      <p:sp>
+        <p:nvSpPr>
+          <p:cNvPr id="7" name="Text 4"/>
+          <p:cNvSpPr txBox="1"/>
+          <p:nvPr/>
+        </p:nvSpPr>
+        <p:spPr>
+          <a:xfrm>
+            <a:off x="685800" y="3300983"/>
+            <a:ext cx="2743200" cy="228600"/>
+          </a:xfrm>
+          <a:prstGeom prst="rect">
+            <a:avLst/>
+          </a:prstGeom>
+          <a:noFill/>
+          <a:ln/>
+        </p:spPr>
+        <p:txBody>
+          <a:bodyPr wrap="square" lIns="0" tIns="0" rIns="0" bIns="0" rtlCol="0" anchor="ctr"/>
+          <a:lstStyle/>
+          <a:p>
+            <a:pPr marL="0" indent="0">
+              <a:buNone/>
+            </a:pPr>
+            <a:r>
+              <a:rPr lang="en-US" sz="900" b="1" kern="0" spc="180">
+                <a:solidFill>
+                  <a:srgbClr val="005358"/>
+                </a:solidFill>
+              </a:rPr>
+              <a:t>COMMENTARY</a:t>
+            </a:r>
+            <a:endParaRPr lang="en-US" sz="900"/>
+          </a:p>
+        </p:txBody>
+      </p:sp>
+      <p:sp>
+        <p:nvSpPr>
+          <p:cNvPr id="8" name="Text 5"/>
+          <p:cNvSpPr txBox="1"/>
+          <p:nvPr/>
+        </p:nvSpPr>
+        <p:spPr>
+          <a:xfrm>
+            <a:off x="685800" y="3474719"/>
+            <a:ext cx="3703320" cy="1124712"/>
+          </a:xfrm>
+          <a:prstGeom prst="rect">
+            <a:avLst/>
+          </a:prstGeom>
+          <a:noFill/>
+          <a:ln/>
+        </p:spPr>
+        <p:txBody>
+          <a:bodyPr wrap="square" lIns="0" tIns="0" rIns="0" bIns="0" rtlCol="0" anchor="t">
+            <a:normAutofit fontScale="92500"/>
+          </a:bodyPr>
+          <a:lstStyle/>
+          <a:p>
+            <a:pPr marL="342900" indent="-342900">
+              <a:lnSpc>
+                <a:spcPts val="1050"/>
+              </a:lnSpc>
+              <a:spcAft>
+                <a:spcPts val="400"/>
+              </a:spcAft>
+              <a:buSzPct val="100000"/>
+              <a:buChar char="•"/>
+            </a:pPr>
+            <a:r>
+              <a:rPr lang="en-US" sz="1000">
+                <a:solidFill>
+                  <a:srgbClr val="3A4453"/>
+                </a:solidFill>
+              </a:rPr>
+              <a:t>Each bar shows the mix of hours within its own department, rather than comparing total hours between departments.</a:t>
+            </a:r>
+            <a:endParaRPr lang="en-US" sz="850"/>
+          </a:p>
+          <a:p>
+            <a:pPr marL="342900" indent="-342900">
+              <a:lnSpc>
+                <a:spcPts val="1050"/>
+              </a:lnSpc>
+              <a:spcAft>
+                <a:spcPts val="400"/>
+              </a:spcAft>
+              <a:buSzPct val="100000"/>
+              <a:buChar char="•"/>
+            </a:pPr>
+            <a:r>
+              <a:rPr lang="en-US" sz="1000">
+                <a:solidFill>
+                  <a:srgbClr val="3A4453"/>
+                </a:solidFill>
+              </a:rPr>
+              <a:t>Support's hours were predominantly billable, supporting its positive financial result.</a:t>
+            </a:r>
+            <a:endParaRPr lang="en-US" sz="850"/>
+          </a:p>
+        </p:txBody>
+      </p:sp>
+      <p:sp>
+        <p:nvSpPr>
+          <p:cNvPr id="25" name="Slide Number Placeholder 0"/>
+          <p:cNvSpPr>
+            <a:spLocks noGrp="1"/>
+          </p:cNvSpPr>
+          <p:nvPr>
+            <p:ph type="sldNum" sz="quarter" idx="4294967295"/>
+          </p:nvPr>
+        </p:nvSpPr>
+        <p:spPr>
+          <a:xfrm>
+            <a:off x="8092440" y="4736592"/>
+            <a:ext cx="548640" cy="228600"/>
+          </a:xfrm>
+          <a:prstGeom prst="rect">
+            <a:avLst/>
+          </a:prstGeom>
+          <a:extLst>
+            <a:ext uri="{C572A759-6A51-4108-AA02-DFA0A04FC94B}">
+              <ma14:wrappingTextBoxFlag xmlns="" xmlns:ma14="http://schemas.microsoft.com/office/mac/drawingml/2011/main" val="0"/>
+            </a:ext>
+          </a:extLst>
+        </p:spPr>
+        <p:txBody>
+          <a:bodyPr/>
+          <a:lstStyle>
+            <a:lvl1pPr>
+              <a:defRPr sz="800">
+                <a:solidFill>
+                  <a:srgbClr val="6B7585"/>
+                </a:solidFill>
+              </a:defRPr>
+            </a:lvl1pPr>
+          </a:lstStyle>
+          <a:p>
+            <a:pPr algn="r"/>
+            <a:fld id="{F7021451-1387-4CA6-816F-3879F97B5CBC}" type="slidenum">
+              <a:rPr lang="en-US" b="0"/>
+              <a:t>37</a:t>
+            </a:fld>
+            <a:endParaRPr lang="en-US"/>
+          </a:p>
+        </p:txBody>
+      </p:sp>
+      <p:pic>
+        <p:nvPicPr>
+          <p:cNvPr id="26" name="cts logo" descr="cts-logo.png"/>
+          <p:cNvPicPr>
+            <a:picLocks noChangeAspect="1"/>
+          </p:cNvPicPr>
+          <p:nvPr/>
+        </p:nvPicPr>
+        <p:blipFill>
+          <a:blip r:embed="rId4"/>
+          <a:stretch>
+            <a:fillRect/>
+          </a:stretch>
+        </p:blipFill>
+        <p:spPr>
+          <a:xfrm>
+            <a:off x="7680959" y="182880"/>
+            <a:ext cx="960120" cy="539696"/>
+          </a:xfrm>
+          <a:prstGeom prst="rect">
+            <a:avLst/>
+          </a:prstGeom>
+        </p:spPr>
+      </p:pic>
+      <p:sp>
+        <p:nvSpPr>
+          <p:cNvPr id="4" name="Text 5b"/>
+          <p:cNvSpPr txBox="1"/>
+          <p:nvPr/>
+        </p:nvSpPr>
+        <p:spPr>
+          <a:xfrm>
+            <a:off x="4663440" y="3474719"/>
+            <a:ext cx="3703320" cy="1124712"/>
+          </a:xfrm>
+          <a:prstGeom prst="rect">
+            <a:avLst/>
+          </a:prstGeom>
+          <a:noFill/>
+          <a:ln/>
+        </p:spPr>
+        <p:txBody>
+          <a:bodyPr wrap="square" lIns="0" tIns="0" rIns="0" bIns="0" rtlCol="0" anchor="t">
+            <a:normAutofit fontScale="92500"/>
+          </a:bodyPr>
+          <a:lstStyle/>
+          <a:p>
+            <a:pPr marL="342900" indent="-342900">
+              <a:lnSpc>
+                <a:spcPts val="1050"/>
+              </a:lnSpc>
+              <a:spcAft>
+                <a:spcPts val="400"/>
+              </a:spcAft>
+              <a:buSzPct val="100000"/>
+              <a:buChar char="•"/>
+            </a:pPr>
+            <a:r>
+              <a:rPr lang="en-US" sz="1000">
+                <a:solidFill>
+                  <a:srgbClr val="3A4453"/>
+                </a:solidFill>
+              </a:rPr>
+              <a:t>Events recorded 333 hours of leave and 241 billable hours, reducing its available delivery capacity.</a:t>
+            </a:r>
+            <a:endParaRPr lang="en-US" sz="850"/>
+          </a:p>
+          <a:p>
+            <a:pPr marL="342900" indent="-342900">
+              <a:lnSpc>
+                <a:spcPts val="1050"/>
+              </a:lnSpc>
+              <a:spcAft>
+                <a:spcPts val="400"/>
+              </a:spcAft>
+              <a:buSzPct val="100000"/>
+              <a:buChar char="•"/>
+            </a:pPr>
+            <a:r>
+              <a:rPr lang="en-US" sz="1000">
+                <a:solidFill>
+                  <a:srgbClr val="3A4453"/>
+                </a:solidFill>
+              </a:rPr>
+              <a:t>Consulting recorded 84 non-billable hours compared with 31 billable hours.</a:t>
+            </a:r>
+            <a:endParaRPr lang="en-US" sz="850"/>
+          </a:p>
+          <a:p>
+            <a:pPr marL="342900" indent="-342900">
+              <a:lnSpc>
+                <a:spcPts val="1050"/>
+              </a:lnSpc>
+              <a:spcAft>
+                <a:spcPts val="400"/>
+              </a:spcAft>
+              <a:buSzPct val="100000"/>
+              <a:buChar char="•"/>
+            </a:pPr>
+            <a:r>
+              <a:rPr lang="en-US" sz="1000">
+                <a:solidFill>
+                  <a:srgbClr val="3A4453"/>
+                </a:solidFill>
+              </a:rPr>
+              <a:t>The non-billable and leave portions highlight opportunities to improve workforce planning and billable utilisation.</a:t>
+            </a:r>
+            <a:endParaRPr lang="en-US" sz="850"/>
+          </a:p>
+        </p:txBody>
+      </p:sp>
+    </p:spTree>
+  </p:cSld>
+  <p:clrMapOvr>
+    <a:masterClrMapping/>
+  </p:clrMapOvr>
+</p:sld>
+</file>
+
+<file path=ppt/slides/slide41.xml><?xml version="1.0" encoding="utf-8"?>
+<p:sld xmlns:a="http://schemas.openxmlformats.org/drawingml/2006/main" xmlns:r="http://schemas.openxmlformats.org/officeDocument/2006/relationships" xmlns:p="http://schemas.openxmlformats.org/presentationml/2006/main">
   <p:cSld name="Slide 27">
     <p:spTree>
       <p:nvGrpSpPr>
@@ -22195,7 +22668,7 @@
 </p:sld>
 </file>
 
-<file path=ppt/slides/slide41.xml><?xml version="1.0" encoding="utf-8"?>
+<file path=ppt/slides/slide42.xml><?xml version="1.0" encoding="utf-8"?>
 <p:sld xmlns:a="http://schemas.openxmlformats.org/drawingml/2006/main" xmlns:r="http://schemas.openxmlformats.org/officeDocument/2006/relationships" xmlns:p="http://schemas.openxmlformats.org/presentationml/2006/main">
   <p:cSld name="Slide 28">
     <p:spTree>
@@ -22478,7 +22951,7 @@
 </p:sld>
 </file>
 
-<file path=ppt/slides/slide42.xml><?xml version="1.0" encoding="utf-8"?>
+<file path=ppt/slides/slide43.xml><?xml version="1.0" encoding="utf-8"?>
 <p:sld xmlns:a="http://schemas.openxmlformats.org/drawingml/2006/main" xmlns:r="http://schemas.openxmlformats.org/officeDocument/2006/relationships" xmlns:p="http://schemas.openxmlformats.org/presentationml/2006/main">
   <p:cSld name="Slide 29">
     <p:spTree>
@@ -22884,7 +23357,7 @@
 </p:sld>
 </file>
 
-<file path=ppt/slides/slide43.xml><?xml version="1.0" encoding="utf-8"?>
+<file path=ppt/slides/slide44.xml><?xml version="1.0" encoding="utf-8"?>
 <p:sld xmlns:a="http://schemas.openxmlformats.org/drawingml/2006/main" xmlns:r="http://schemas.openxmlformats.org/officeDocument/2006/relationships" xmlns:p="http://schemas.openxmlformats.org/presentationml/2006/main">
   <p:cSld name="Slide 30">
     <p:spTree>
@@ -25030,7 +25503,7 @@
 </p:sld>
 </file>
 
-<file path=ppt/slides/slide44.xml><?xml version="1.0" encoding="utf-8"?>
+<file path=ppt/slides/slide45.xml><?xml version="1.0" encoding="utf-8"?>
 <p:sld xmlns:a="http://schemas.openxmlformats.org/drawingml/2006/main" xmlns:r="http://schemas.openxmlformats.org/officeDocument/2006/relationships" xmlns:p="http://schemas.openxmlformats.org/presentationml/2006/main">
   <p:cSld>
     <p:bg>
@@ -25406,7 +25879,7 @@
 </p:sld>
 </file>
 
-<file path=ppt/slides/slide45.xml><?xml version="1.0" encoding="utf-8"?>
+<file path=ppt/slides/slide46.xml><?xml version="1.0" encoding="utf-8"?>
 <p:sld xmlns:a="http://schemas.openxmlformats.org/drawingml/2006/main" xmlns:r="http://schemas.openxmlformats.org/officeDocument/2006/relationships" xmlns:p="http://schemas.openxmlformats.org/presentationml/2006/main">
   <p:cSld name="Slide 31">
     <p:spTree>

</xml_diff>

<commit_message>
Page 27 removed, its one useful finding folded into page 26
The gross profit year on year page was the only page in the deck that needed a
disclaimer to stop it being read as the net result, and it was the third
departmental chart in a row. It is out.

What was worth keeping off it was Integration, and the figure I had written in its
notes was wrong. Checked against the tabs: Integration's revenue went from 21,421
last September to 234,858 this September, close to eleven times, not the "roughly
56k" the old note claimed. That corrected point now sits on page 26 where the
reader already has the result in front of them.

Done in two passes. python-pptx hands two parts the same name if a slide is added
and another removed in one pass, so the commentary was rewritten first and the
page removed second.

Deck is 45 pages.

Co-Authored-By: Claude Opus 5 <noreply@anthropic.com>
Claude-Session: https://claude.ai/code/session_01CVBAFohBCYXt1ufjTVDiZj
</commit_message>
<xml_diff>
--- a/deck/CTS Monthly Business Review - 30092026.pptx
+++ b/deck/CTS Monthly Business Review - 30092026.pptx
@@ -34,7 +34,6 @@
     <p:sldId id="268" r:id="rId28"/>
     <p:sldId id="301" r:id="rId55"/>
     <p:sldId id="303" r:id="rId57"/>
-    <p:sldId id="302" r:id="rId56"/>
     <p:sldId id="269" r:id="rId29"/>
     <p:sldId id="270" r:id="rId30"/>
     <p:sldId id="271" r:id="rId31"/>
@@ -5250,131 +5249,6 @@
 </p:notes>
 </file>
 
-<file path=ppt/notesSlides/notesSlide45.xml><?xml version="1.0" encoding="utf-8"?>
-<p:notes xmlns:a="http://schemas.openxmlformats.org/drawingml/2006/main" xmlns:p="http://schemas.openxmlformats.org/presentationml/2006/main" xmlns:r="http://schemas.openxmlformats.org/officeDocument/2006/relationships">
-  <p:cSld>
-    <p:spTree>
-      <p:nvGrpSpPr>
-        <p:cNvPr id="1" name=""/>
-        <p:cNvGrpSpPr/>
-        <p:nvPr/>
-      </p:nvGrpSpPr>
-      <p:grpSpPr>
-        <a:xfrm>
-          <a:off x="0" y="0"/>
-          <a:ext cx="0" cy="0"/>
-          <a:chOff x="0" y="0"/>
-          <a:chExt cx="0" cy="0"/>
-        </a:xfrm>
-      </p:grpSpPr>
-      <p:sp>
-        <p:nvSpPr>
-          <p:cNvPr id="3" name="Notes Placeholder 2"/>
-          <p:cNvSpPr>
-            <a:spLocks noGrp="1"/>
-          </p:cNvSpPr>
-          <p:nvPr>
-            <p:ph type="body" idx="1"/>
-          </p:nvPr>
-        </p:nvSpPr>
-        <p:spPr/>
-        <p:txBody>
-          <a:bodyPr lIns="107095" tIns="53547" rIns="107095" bIns="53547"/>
-          <a:lstStyle/>
-          <a:p>
-            <a:r>
-              <a:t>Gross profit by department for September 2026 against September 2025, taken from the Actual FY26 and P&amp;L FY27 tabs.</a:t>
-            </a:r>
-          </a:p>
-          <a:p/>
-          <a:p>
-            <a:r>
-              <a:t>Support $101,290 against $94,701, up $6,589.</a:t>
-            </a:r>
-          </a:p>
-          <a:p>
-            <a:r>
-              <a:t>Events $56,881 against $47,493, up $9,388.</a:t>
-            </a:r>
-          </a:p>
-          <a:p>
-            <a:r>
-              <a:t>Video $5,813 against $12,625, down $6,812.</a:t>
-            </a:r>
-          </a:p>
-          <a:p>
-            <a:r>
-              <a:t>Integration $23,756 against $5,363, up $18,394.</a:t>
-            </a:r>
-          </a:p>
-          <a:p>
-            <a:r>
-              <a:t>Consulting $74 against $2,085, down $2,011.</a:t>
-            </a:r>
-          </a:p>
-          <a:p>
-            <a:r>
-              <a:t>Company $187,814 against $162,267, up $25,548.</a:t>
-            </a:r>
-          </a:p>
-          <a:p/>
-          <a:p>
-            <a:r>
-              <a:t>Read it with the revenue beside it, because the two do not move together.</a:t>
-            </a:r>
-          </a:p>
-          <a:p/>
-          <a:p>
-            <a:r>
-              <a:t>Integration added $18,394 of gross profit, the largest increase of the five, and did it on revenue that rose from roughly $56k to $234,858. So the extra gross profit came at about a 10% margin, which is why Integration appears strong here and only returns $10,471 after overhead.</a:t>
-            </a:r>
-          </a:p>
-          <a:p/>
-          <a:p>
-            <a:r>
-              <a:t>Events added $9,388 of gross profit on revenue that barely moved, which is a genuine margin improvement rather than a volume one.</a:t>
-            </a:r>
-          </a:p>
-          <a:p/>
-          <a:p>
-            <a:r>
-              <a:t>Video went the other way. Gross profit more than halved because the department billed $7,303 against $20,025 last September. That is a volume problem, not a margin one: its margin is still 79.6%.</a:t>
-            </a:r>
-          </a:p>
-          <a:p/>
-          <a:p>
-            <a:r>
-              <a:t>Now the limitation, and it matters for how this page is read.</a:t>
-            </a:r>
-          </a:p>
-          <a:p/>
-          <a:p>
-            <a:r>
-              <a:t>This is gross profit, not the net result. Overhead was not allocated to departments before this financial year. The department pages in this deck print "not split last year" against Total Expenses and Net Profit/Loss for exactly that reason, and the pack has no department split of overhead for FY26 to work from. So the net result by department, which is the figure on the previous page, cannot be shown against last year.</a:t>
-            </a:r>
-          </a:p>
-          <a:p/>
-          <a:p>
-            <a:r>
-              <a:t>September 2024 by department cannot be shown either. The pack holds departmental detail for FY26 and FY27 only, and Xero's profit and loss is by account rather than by department, so it cannot be rebuilt reliably from there.</a:t>
-            </a:r>
-          </a:p>
-          <a:p/>
-          <a:p>
-            <a:r>
-              <a:t>If the board wants a three year net result by department, the overhead keys would have to be applied backwards to FY26 and FY25. That is a decision about method, not a calculation, and I have not done it.</a:t>
-            </a:r>
-          </a:p>
-        </p:txBody>
-      </p:sp>
-    </p:spTree>
-  </p:cSld>
-  <p:clrMapOvr>
-    <a:masterClrMapping/>
-  </p:clrMapOvr>
-</p:notes>
-</file>
-
 <file path=ppt/notesSlides/notesSlide46.xml><?xml version="1.0" encoding="utf-8"?>
 <p:notes xmlns:a="http://schemas.openxmlformats.org/drawingml/2006/main" xmlns:p="http://schemas.openxmlformats.org/presentationml/2006/main" xmlns:r="http://schemas.openxmlformats.org/officeDocument/2006/relationships">
   <p:cSld>
@@ -5426,25 +5300,25 @@
           <a:p/>
           <a:p>
             <a:r>
-              <a:t>The reason this page exists is that the gross profit page behind it shows all five departments above the line, and that is true: every department earned more than its direct cost. Support made $101,290 of gross profit, Events $56,881, Integration $23,756, Video $5,813 and even Consulting made $74. On gross profit nobody lost money.</a:t>
+              <a:t>Every department made a gross profit. Support $101,290, Events $56,881, Integration $23,756, Video $5,813, and Consulting $74. On gross profit nobody lost money. What puts three of them below the line is the overhead charged to them: $229,278 across the month against $187,814 of gross profit earned. The company cannot cover its overhead base out of the margin it is making.</a:t>
             </a:r>
           </a:p>
           <a:p/>
           <a:p>
             <a:r>
-              <a:t>What puts three of them below the line is the overhead charged to them. $229,278 of it across the month, against $187,814 of gross profit earned. The company cannot cover its overhead base out of the margin it is making, and the departments where that bites hardest are the ones carrying overhead out of proportion to their revenue.</a:t>
+              <a:t>Events is the clearest case. It carries $111,108 of overhead, 48.5% of the company total, on 13.0% of the revenue. Its margin is the second best of the five at 77.6% and it still posts the largest loss on the page. Improving margin does not fix that. Either Events carries more revenue or it carries less overhead.</a:t>
             </a:r>
           </a:p>
           <a:p/>
           <a:p>
             <a:r>
-              <a:t>Events is the clearest case. It carries $111,108 of overhead, 48.5% of the company total, on 13.0% of the revenue. Its margin is the second best of the five at 77.6% and it still posts the largest loss on the page.</a:t>
+              <a:t>Consulting is a different problem. It earned $74 of gross profit on $3,531 of revenue and carries $19,944 of overhead, so almost the whole of its loss is overhead on a department that is barely trading.</a:t>
             </a:r>
           </a:p>
           <a:p/>
           <a:p>
             <a:r>
-              <a:t>Consulting is the other kind of problem. It earned $74 of gross profit on $3,531 of revenue and carries $19,944 of overhead, so almost the whole of its loss is overhead on a department that is barely trading.</a:t>
+              <a:t>Integration is the one to watch and it is easy to miss. Its revenue went from $21,421 last September to $234,858 this September, close to eleven times. Its gross profit rose from $5,363 to $23,756, the largest increase of the five. But that revenue carries a 10.1% margin against Support's 41.7%, so after $13,285 of overhead only $10,471 reached the line. Integration is now running the second largest revenue in the business for the smallest return on it.</a:t>
             </a:r>
           </a:p>
           <a:p/>
@@ -5456,7 +5330,7 @@
           <a:p/>
           <a:p>
             <a:r>
-              <a:t>Two points for the board. First, improving margin does not fix Events or Consulting, because their losses are overhead, not margin. Second, the overhead keys were set for FY27 and have not been tested since, which is the action already on the recommendations page.</a:t>
+              <a:t>Two points for the board. Improving margin does not fix Events or Consulting, because their losses are overhead rather than margin. And the overhead keys were set for FY27 and have not been tested since, which is the action already on the recommendations page.</a:t>
             </a:r>
           </a:p>
         </p:txBody>
@@ -14116,7 +13990,7 @@
       <p:grpSpPr/>
       <p:pic>
         <p:nvPicPr>
-          <p:cNvPr id="27" name="snip dept_line" descr="dept_line.png"/>
+          <p:cNvPr id="27" name="snip dept_line" descr="image.png"/>
           <p:cNvPicPr>
             <a:picLocks noChangeAspect="1"/>
           </p:cNvPicPr>
@@ -14333,7 +14207,7 @@
                   <a:srgbClr val="3A4453"/>
                 </a:solidFill>
               </a:rPr>
-              <a:t>Events lost $54k, Consulting $20k and Video $7k.</a:t>
+              <a:t>Events lost $54k, Consulting $20k and Video $7k. Together the five are the $41k loss.</a:t>
             </a:r>
             <a:endParaRPr lang="en-US" sz="850"/>
           </a:p>
@@ -14444,7 +14318,7 @@
                   <a:srgbClr val="3A4453"/>
                 </a:solidFill>
               </a:rPr>
-              <a:t>The five together are the $41k loss for the month.</a:t>
+              <a:t>Integration billed eleven times last September, but a 10% margin left only $10k after overhead.</a:t>
             </a:r>
             <a:endParaRPr lang="en-US" sz="850"/>
           </a:p>
@@ -14483,384 +14357,6 @@
 </file>
 
 <file path=ppt/slides/slide27.xml><?xml version="1.0" encoding="utf-8"?>
-<p:sld xmlns:a="http://schemas.openxmlformats.org/drawingml/2006/main" xmlns:p="http://schemas.openxmlformats.org/presentationml/2006/main" xmlns:r="http://schemas.openxmlformats.org/officeDocument/2006/relationships">
-  <p:cSld>
-    <p:spTree>
-      <p:nvGrpSpPr>
-        <p:cNvPr id="1" name=""/>
-        <p:cNvGrpSpPr/>
-        <p:nvPr/>
-      </p:nvGrpSpPr>
-      <p:grpSpPr/>
-      <p:pic>
-        <p:nvPicPr>
-          <p:cNvPr id="27" name="snip dept_gp_yoy" descr="dept_gp_yoy.png"/>
-          <p:cNvPicPr>
-            <a:picLocks noChangeAspect="1"/>
-          </p:cNvPicPr>
-          <p:nvPr/>
-        </p:nvPicPr>
-        <p:blipFill>
-          <a:blip r:embed="rId3"/>
-          <a:stretch>
-            <a:fillRect/>
-          </a:stretch>
-        </p:blipFill>
-        <p:spPr>
-          <a:xfrm>
-            <a:off x="535418" y="1005840"/>
-            <a:ext cx="8073163" cy="2523743"/>
-          </a:xfrm>
-          <a:prstGeom prst="rect">
-            <a:avLst/>
-          </a:prstGeom>
-        </p:spPr>
-      </p:pic>
-      <p:sp>
-        <p:nvSpPr>
-          <p:cNvPr id="2" name="Text 0"/>
-          <p:cNvSpPr txBox="1"/>
-          <p:nvPr/>
-        </p:nvSpPr>
-        <p:spPr>
-          <a:xfrm>
-            <a:off x="502920" y="365760"/>
-            <a:ext cx="6400800" cy="274320"/>
-          </a:xfrm>
-          <a:prstGeom prst="rect">
-            <a:avLst/>
-          </a:prstGeom>
-          <a:noFill/>
-          <a:ln/>
-        </p:spPr>
-        <p:txBody>
-          <a:bodyPr wrap="square" lIns="0" tIns="0" rIns="0" bIns="0" rtlCol="0" anchor="ctr"/>
-          <a:lstStyle/>
-          <a:p>
-            <a:pPr marL="0" indent="0">
-              <a:buNone/>
-            </a:pPr>
-            <a:r>
-              <a:rPr lang="en-US" sz="950" b="1" kern="0" spc="220">
-                <a:solidFill>
-                  <a:srgbClr val="122B82"/>
-                </a:solidFill>
-              </a:rPr>
-              <a:t>DEPARTMENTAL PERFORMANCE</a:t>
-            </a:r>
-            <a:endParaRPr lang="en-US" sz="950"/>
-          </a:p>
-        </p:txBody>
-      </p:sp>
-      <p:sp>
-        <p:nvSpPr>
-          <p:cNvPr id="3" name="Text 1"/>
-          <p:cNvSpPr txBox="1"/>
-          <p:nvPr/>
-        </p:nvSpPr>
-        <p:spPr>
-          <a:xfrm>
-            <a:off x="502920" y="640080"/>
-            <a:ext cx="7315200" cy="365760"/>
-          </a:xfrm>
-          <a:prstGeom prst="rect">
-            <a:avLst/>
-          </a:prstGeom>
-          <a:noFill/>
-          <a:ln/>
-        </p:spPr>
-        <p:txBody>
-          <a:bodyPr wrap="square" lIns="0" tIns="0" rIns="0" bIns="0" rtlCol="0" anchor="ctr"/>
-          <a:lstStyle/>
-          <a:p>
-            <a:pPr marL="0" indent="0" algn="ctr">
-              <a:buNone/>
-            </a:pPr>
-            <a:r>
-              <a:rPr lang="en-US" sz="2200" b="1" dirty="0">
-                <a:solidFill>
-                  <a:srgbClr val="242C39"/>
-                </a:solidFill>
-              </a:rPr>
-              <a:t>Gross profit before overhead, year on year</a:t>
-            </a:r>
-            <a:endParaRPr lang="en-US" sz="2700" dirty="0"/>
-          </a:p>
-        </p:txBody>
-      </p:sp>
-      <p:sp>
-        <p:nvSpPr>
-          <p:cNvPr id="6" name="commentary panel"/>
-          <p:cNvSpPr/>
-          <p:nvPr/>
-        </p:nvSpPr>
-        <p:spPr>
-          <a:xfrm>
-            <a:off x="502920" y="3621023"/>
-            <a:ext cx="8138160" cy="1005840"/>
-          </a:xfrm>
-          <a:prstGeom prst="rect">
-            <a:avLst/>
-          </a:prstGeom>
-          <a:solidFill>
-            <a:srgbClr val="E8F9F8"/>
-          </a:solidFill>
-          <a:ln/>
-        </p:spPr>
-        <p:txBody>
-          <a:bodyPr/>
-          <a:lstStyle/>
-          <a:p>
-            <a:endParaRPr lang="en-AU"/>
-          </a:p>
-        </p:txBody>
-      </p:sp>
-      <p:sp>
-        <p:nvSpPr>
-          <p:cNvPr id="7" name="Text 4"/>
-          <p:cNvSpPr txBox="1"/>
-          <p:nvPr/>
-        </p:nvSpPr>
-        <p:spPr>
-          <a:xfrm>
-            <a:off x="685800" y="3694175"/>
-            <a:ext cx="2743200" cy="228600"/>
-          </a:xfrm>
-          <a:prstGeom prst="rect">
-            <a:avLst/>
-          </a:prstGeom>
-          <a:noFill/>
-          <a:ln/>
-        </p:spPr>
-        <p:txBody>
-          <a:bodyPr wrap="square" lIns="0" tIns="0" rIns="0" bIns="0" rtlCol="0" anchor="ctr"/>
-          <a:lstStyle/>
-          <a:p>
-            <a:pPr marL="0" indent="0">
-              <a:buNone/>
-            </a:pPr>
-            <a:r>
-              <a:rPr lang="en-US" sz="900" b="1" kern="0" spc="180">
-                <a:solidFill>
-                  <a:srgbClr val="005358"/>
-                </a:solidFill>
-              </a:rPr>
-              <a:t>COMMENTARY</a:t>
-            </a:r>
-            <a:endParaRPr lang="en-US" sz="900"/>
-          </a:p>
-        </p:txBody>
-      </p:sp>
-      <p:sp>
-        <p:nvSpPr>
-          <p:cNvPr id="8" name="Text 5"/>
-          <p:cNvSpPr txBox="1"/>
-          <p:nvPr/>
-        </p:nvSpPr>
-        <p:spPr>
-          <a:xfrm>
-            <a:off x="685800" y="3867911"/>
-            <a:ext cx="3703320" cy="731520"/>
-          </a:xfrm>
-          <a:prstGeom prst="rect">
-            <a:avLst/>
-          </a:prstGeom>
-          <a:noFill/>
-          <a:ln/>
-        </p:spPr>
-        <p:txBody>
-          <a:bodyPr wrap="square" lIns="0" tIns="0" rIns="0" bIns="0" rtlCol="0" anchor="t">
-            <a:normAutofit fontScale="85000" lnSpcReduction="10000"/>
-          </a:bodyPr>
-          <a:lstStyle/>
-          <a:p>
-            <a:pPr marL="342900" indent="-342900">
-              <a:lnSpc>
-                <a:spcPts val="1050"/>
-              </a:lnSpc>
-              <a:spcAft>
-                <a:spcPts val="400"/>
-              </a:spcAft>
-              <a:buSzPct val="100000"/>
-              <a:buChar char="•"/>
-            </a:pPr>
-            <a:r>
-              <a:rPr lang="en-US" sz="1000">
-                <a:solidFill>
-                  <a:srgbClr val="3A4453"/>
-                </a:solidFill>
-              </a:rPr>
-              <a:t>Company gross profit was $188k against $162k last September, up $26k.</a:t>
-            </a:r>
-            <a:endParaRPr lang="en-US" sz="850"/>
-          </a:p>
-          <a:p>
-            <a:pPr marL="342900" indent="-342900">
-              <a:lnSpc>
-                <a:spcPts val="1050"/>
-              </a:lnSpc>
-              <a:spcAft>
-                <a:spcPts val="400"/>
-              </a:spcAft>
-              <a:buSzPct val="100000"/>
-              <a:buChar char="•"/>
-            </a:pPr>
-            <a:r>
-              <a:rPr lang="en-US" sz="1000">
-                <a:solidFill>
-                  <a:srgbClr val="3A4453"/>
-                </a:solidFill>
-              </a:rPr>
-              <a:t>Integration is up $18k, Events $9k and Support $7k.</a:t>
-            </a:r>
-            <a:endParaRPr lang="en-US" sz="850"/>
-          </a:p>
-        </p:txBody>
-      </p:sp>
-      <p:sp>
-        <p:nvSpPr>
-          <p:cNvPr id="25" name="Slide Number Placeholder 0"/>
-          <p:cNvSpPr>
-            <a:spLocks noGrp="1"/>
-          </p:cNvSpPr>
-          <p:nvPr>
-            <p:ph type="sldNum" sz="quarter" idx="4294967295"/>
-          </p:nvPr>
-        </p:nvSpPr>
-        <p:spPr>
-          <a:xfrm>
-            <a:off x="8092440" y="4736592"/>
-            <a:ext cx="548640" cy="228600"/>
-          </a:xfrm>
-          <a:prstGeom prst="rect">
-            <a:avLst/>
-          </a:prstGeom>
-          <a:extLst>
-            <a:ext uri="{C572A759-6A51-4108-AA02-DFA0A04FC94B}">
-              <ma14:wrappingTextBoxFlag xmlns="" xmlns:ma14="http://schemas.microsoft.com/office/mac/drawingml/2011/main" val="0"/>
-            </a:ext>
-          </a:extLst>
-        </p:spPr>
-        <p:txBody>
-          <a:bodyPr/>
-          <a:lstStyle>
-            <a:lvl1pPr>
-              <a:defRPr sz="800">
-                <a:solidFill>
-                  <a:srgbClr val="6B7585"/>
-                </a:solidFill>
-              </a:defRPr>
-            </a:lvl1pPr>
-          </a:lstStyle>
-          <a:p>
-            <a:pPr algn="r"/>
-            <a:fld id="{F7021451-1387-4CA6-816F-3879F97B5CBC}" type="slidenum">
-              <a:rPr lang="en-US" b="0"/>
-              <a:t>9</a:t>
-            </a:fld>
-            <a:endParaRPr lang="en-US"/>
-          </a:p>
-        </p:txBody>
-      </p:sp>
-      <p:sp>
-        <p:nvSpPr>
-          <p:cNvPr id="4" name="Text 5b"/>
-          <p:cNvSpPr txBox="1"/>
-          <p:nvPr/>
-        </p:nvSpPr>
-        <p:spPr>
-          <a:xfrm>
-            <a:off x="4663440" y="3867911"/>
-            <a:ext cx="3703320" cy="731520"/>
-          </a:xfrm>
-          <a:prstGeom prst="rect">
-            <a:avLst/>
-          </a:prstGeom>
-          <a:noFill/>
-          <a:ln/>
-        </p:spPr>
-        <p:txBody>
-          <a:bodyPr wrap="square" lIns="0" tIns="0" rIns="0" bIns="0" rtlCol="0" anchor="t">
-            <a:normAutofit fontScale="85000" lnSpcReduction="10000"/>
-          </a:bodyPr>
-          <a:lstStyle/>
-          <a:p>
-            <a:pPr marL="342900" indent="-342900">
-              <a:lnSpc>
-                <a:spcPts val="1050"/>
-              </a:lnSpc>
-              <a:spcAft>
-                <a:spcPts val="400"/>
-              </a:spcAft>
-              <a:buSzPct val="100000"/>
-              <a:buChar char="•"/>
-            </a:pPr>
-            <a:r>
-              <a:rPr lang="en-US" sz="1000">
-                <a:solidFill>
-                  <a:srgbClr val="3A4453"/>
-                </a:solidFill>
-              </a:rPr>
-              <a:t>Video fell from $13k to $6k and Consulting from $2k to almost nothing.</a:t>
-            </a:r>
-            <a:endParaRPr lang="en-US" sz="850"/>
-          </a:p>
-          <a:p>
-            <a:pPr marL="342900" indent="-342900">
-              <a:lnSpc>
-                <a:spcPts val="1050"/>
-              </a:lnSpc>
-              <a:spcAft>
-                <a:spcPts val="400"/>
-              </a:spcAft>
-              <a:buSzPct val="100000"/>
-              <a:buChar char="•"/>
-            </a:pPr>
-            <a:r>
-              <a:rPr lang="en-US" sz="1000">
-                <a:solidFill>
-                  <a:srgbClr val="3A4453"/>
-                </a:solidFill>
-              </a:rPr>
-              <a:t>Gross profit only. Overhead was not split by department before this year, so the net result cannot go back.</a:t>
-            </a:r>
-            <a:endParaRPr lang="en-US" sz="850"/>
-          </a:p>
-        </p:txBody>
-      </p:sp>
-      <p:pic>
-        <p:nvPicPr>
-          <p:cNvPr id="26" name="cts logo" descr="image.png"/>
-          <p:cNvPicPr>
-            <a:picLocks noChangeAspect="1"/>
-          </p:cNvPicPr>
-          <p:nvPr/>
-        </p:nvPicPr>
-        <p:blipFill>
-          <a:blip r:embed="rId2"/>
-          <a:stretch>
-            <a:fillRect/>
-          </a:stretch>
-        </p:blipFill>
-        <p:spPr>
-          <a:xfrm>
-            <a:off x="7680959" y="182880"/>
-            <a:ext cx="960120" cy="539696"/>
-          </a:xfrm>
-          <a:prstGeom prst="rect">
-            <a:avLst/>
-          </a:prstGeom>
-        </p:spPr>
-      </p:pic>
-    </p:spTree>
-  </p:cSld>
-  <p:clrMapOvr>
-    <a:masterClrMapping/>
-  </p:clrMapOvr>
-</p:sld>
-</file>
-
-<file path=ppt/slides/slide28.xml><?xml version="1.0" encoding="utf-8"?>
 <p:sld xmlns:a="http://schemas.openxmlformats.org/drawingml/2006/main" xmlns:r="http://schemas.openxmlformats.org/officeDocument/2006/relationships" xmlns:p="http://schemas.openxmlformats.org/presentationml/2006/main">
   <p:cSld name="Slide 14">
     <p:spTree>
@@ -15266,7 +14762,7 @@
 </p:sld>
 </file>
 
-<file path=ppt/slides/slide29.xml><?xml version="1.0" encoding="utf-8"?>
+<file path=ppt/slides/slide28.xml><?xml version="1.0" encoding="utf-8"?>
 <p:sld xmlns:a="http://schemas.openxmlformats.org/drawingml/2006/main" xmlns:r="http://schemas.openxmlformats.org/officeDocument/2006/relationships" xmlns:p="http://schemas.openxmlformats.org/presentationml/2006/main">
   <p:cSld name="Slide 15">
     <p:spTree>
@@ -15538,6 +15034,412 @@
               <a:t>Where the money goes and which lines move</a:t>
             </a:r>
             <a:endParaRPr lang="en-US" sz="1200"/>
+          </a:p>
+        </p:txBody>
+      </p:sp>
+    </p:spTree>
+  </p:cSld>
+  <p:clrMapOvr>
+    <a:masterClrMapping/>
+  </p:clrMapOvr>
+</p:sld>
+</file>
+
+<file path=ppt/slides/slide29.xml><?xml version="1.0" encoding="utf-8"?>
+<p:sld xmlns:a="http://schemas.openxmlformats.org/drawingml/2006/main" xmlns:r="http://schemas.openxmlformats.org/officeDocument/2006/relationships" xmlns:p="http://schemas.openxmlformats.org/presentationml/2006/main">
+  <p:cSld name="Slide 16">
+    <p:spTree>
+      <p:nvGrpSpPr>
+        <p:cNvPr id="1" name=""/>
+        <p:cNvGrpSpPr/>
+        <p:nvPr/>
+      </p:nvGrpSpPr>
+      <p:grpSpPr>
+        <a:xfrm>
+          <a:off x="0" y="0"/>
+          <a:ext cx="0" cy="0"/>
+          <a:chOff x="0" y="0"/>
+          <a:chExt cx="0" cy="0"/>
+        </a:xfrm>
+      </p:grpSpPr>
+      <p:pic>
+        <p:nvPicPr>
+          <p:cNvPr id="27" name="snip cost_dist" descr="cost_dist.png"/>
+          <p:cNvPicPr>
+            <a:picLocks noChangeAspect="1"/>
+          </p:cNvPicPr>
+          <p:nvPr/>
+        </p:nvPicPr>
+        <p:blipFill>
+          <a:blip r:embed="rId3"/>
+          <a:stretch>
+            <a:fillRect/>
+          </a:stretch>
+        </p:blipFill>
+        <p:spPr>
+          <a:xfrm>
+            <a:off x="2640967" y="1005840"/>
+            <a:ext cx="3862065" cy="1956815"/>
+          </a:xfrm>
+          <a:prstGeom prst="rect">
+            <a:avLst/>
+          </a:prstGeom>
+        </p:spPr>
+      </p:pic>
+      <p:sp>
+        <p:nvSpPr>
+          <p:cNvPr id="2" name="Text 0"/>
+          <p:cNvSpPr txBox="1"/>
+          <p:nvPr/>
+        </p:nvSpPr>
+        <p:spPr>
+          <a:xfrm>
+            <a:off x="502920" y="365760"/>
+            <a:ext cx="6400800" cy="274320"/>
+          </a:xfrm>
+          <a:prstGeom prst="rect">
+            <a:avLst/>
+          </a:prstGeom>
+          <a:noFill/>
+          <a:ln/>
+        </p:spPr>
+        <p:txBody>
+          <a:bodyPr wrap="square" lIns="0" tIns="0" rIns="0" bIns="0" rtlCol="0" anchor="ctr"/>
+          <a:lstStyle/>
+          <a:p>
+            <a:pPr marL="0" indent="0">
+              <a:buNone/>
+            </a:pPr>
+            <a:r>
+              <a:rPr lang="en-US" sz="950" b="1" kern="0" spc="220">
+                <a:solidFill>
+                  <a:srgbClr val="122B82"/>
+                </a:solidFill>
+              </a:rPr>
+              <a:t>OPERATING EXPENDITURE</a:t>
+            </a:r>
+            <a:endParaRPr lang="en-US" sz="950"/>
+          </a:p>
+        </p:txBody>
+      </p:sp>
+      <p:sp>
+        <p:nvSpPr>
+          <p:cNvPr id="3" name="Text 1"/>
+          <p:cNvSpPr txBox="1"/>
+          <p:nvPr/>
+        </p:nvSpPr>
+        <p:spPr>
+          <a:xfrm>
+            <a:off x="502920" y="640080"/>
+            <a:ext cx="7315200" cy="365760"/>
+          </a:xfrm>
+          <a:prstGeom prst="rect">
+            <a:avLst/>
+          </a:prstGeom>
+          <a:noFill/>
+          <a:ln/>
+        </p:spPr>
+        <p:txBody>
+          <a:bodyPr wrap="square" lIns="0" tIns="0" rIns="0" bIns="0" rtlCol="0" anchor="ctr"/>
+          <a:lstStyle/>
+          <a:p>
+            <a:pPr marL="0" indent="0" algn="ctr">
+              <a:buNone/>
+            </a:pPr>
+            <a:r>
+              <a:rPr lang="en-US" sz="2200" b="1">
+                <a:solidFill>
+                  <a:srgbClr val="242C39"/>
+                </a:solidFill>
+              </a:rPr>
+              <a:t>Operating cost distribution, year to date</a:t>
+            </a:r>
+            <a:endParaRPr lang="en-US" sz="2700"/>
+          </a:p>
+        </p:txBody>
+      </p:sp>
+      <p:sp>
+        <p:nvSpPr>
+          <p:cNvPr id="6" name="commentary panel"/>
+          <p:cNvSpPr/>
+          <p:nvPr/>
+        </p:nvSpPr>
+        <p:spPr>
+          <a:xfrm>
+            <a:off x="502920" y="3054096"/>
+            <a:ext cx="8138160" cy="1572768"/>
+          </a:xfrm>
+          <a:prstGeom prst="rect">
+            <a:avLst/>
+          </a:prstGeom>
+          <a:solidFill>
+            <a:srgbClr val="E8F9F8"/>
+          </a:solidFill>
+          <a:ln/>
+        </p:spPr>
+        <p:txBody>
+          <a:bodyPr/>
+          <a:lstStyle/>
+          <a:p>
+            <a:endParaRPr lang="en-AU"/>
+          </a:p>
+        </p:txBody>
+      </p:sp>
+      <p:sp>
+        <p:nvSpPr>
+          <p:cNvPr id="7" name="Text 4"/>
+          <p:cNvSpPr txBox="1"/>
+          <p:nvPr/>
+        </p:nvSpPr>
+        <p:spPr>
+          <a:xfrm>
+            <a:off x="685800" y="3127248"/>
+            <a:ext cx="2743200" cy="228600"/>
+          </a:xfrm>
+          <a:prstGeom prst="rect">
+            <a:avLst/>
+          </a:prstGeom>
+          <a:noFill/>
+          <a:ln/>
+        </p:spPr>
+        <p:txBody>
+          <a:bodyPr wrap="square" lIns="0" tIns="0" rIns="0" bIns="0" rtlCol="0" anchor="ctr"/>
+          <a:lstStyle/>
+          <a:p>
+            <a:pPr marL="0" indent="0">
+              <a:buNone/>
+            </a:pPr>
+            <a:r>
+              <a:rPr lang="en-US" sz="900" b="1" kern="0" spc="180">
+                <a:solidFill>
+                  <a:srgbClr val="005358"/>
+                </a:solidFill>
+              </a:rPr>
+              <a:t>COMMENTARY</a:t>
+            </a:r>
+            <a:endParaRPr lang="en-US" sz="900"/>
+          </a:p>
+        </p:txBody>
+      </p:sp>
+      <p:sp>
+        <p:nvSpPr>
+          <p:cNvPr id="8" name="Text 5"/>
+          <p:cNvSpPr txBox="1"/>
+          <p:nvPr/>
+        </p:nvSpPr>
+        <p:spPr>
+          <a:xfrm>
+            <a:off x="685800" y="3300984"/>
+            <a:ext cx="3703320" cy="1298448"/>
+          </a:xfrm>
+          <a:prstGeom prst="rect">
+            <a:avLst/>
+          </a:prstGeom>
+          <a:noFill/>
+          <a:ln/>
+        </p:spPr>
+        <p:txBody>
+          <a:bodyPr wrap="square" lIns="0" tIns="0" rIns="0" bIns="0" rtlCol="0" anchor="t">
+            <a:normAutofit fontScale="85000" lnSpcReduction="10000"/>
+          </a:bodyPr>
+          <a:lstStyle/>
+          <a:p>
+            <a:pPr marL="342900" indent="-342900">
+              <a:lnSpc>
+                <a:spcPts val="1050"/>
+              </a:lnSpc>
+              <a:spcAft>
+                <a:spcPts val="400"/>
+              </a:spcAft>
+              <a:buSzPct val="100000"/>
+              <a:buChar char="•"/>
+            </a:pPr>
+            <a:r>
+              <a:rPr lang="en-US" sz="1000">
+                <a:solidFill>
+                  <a:srgbClr val="3A4453"/>
+                </a:solidFill>
+              </a:rPr>
+              <a:t>Year-to-date direct labour costs total $621k, with a further $369k in employment overheads. Together, these represent a substantial share of total costs.</a:t>
+            </a:r>
+            <a:endParaRPr lang="en-US" sz="850"/>
+          </a:p>
+          <a:p>
+            <a:pPr marL="342900" indent="-342900">
+              <a:lnSpc>
+                <a:spcPts val="1050"/>
+              </a:lnSpc>
+              <a:spcAft>
+                <a:spcPts val="400"/>
+              </a:spcAft>
+              <a:buSzPct val="100000"/>
+              <a:buChar char="•"/>
+            </a:pPr>
+            <a:r>
+              <a:rPr lang="en-US" sz="1000">
+                <a:solidFill>
+                  <a:srgbClr val="3A4453"/>
+                </a:solidFill>
+              </a:rPr>
+              <a:t>Labour is the largest cost category and has a major impact on profitability.</a:t>
+            </a:r>
+            <a:endParaRPr lang="en-US" sz="850"/>
+          </a:p>
+        </p:txBody>
+      </p:sp>
+      <p:sp>
+        <p:nvSpPr>
+          <p:cNvPr id="25" name="Slide Number Placeholder 0"/>
+          <p:cNvSpPr>
+            <a:spLocks noGrp="1"/>
+          </p:cNvSpPr>
+          <p:nvPr>
+            <p:ph type="sldNum" sz="quarter" idx="4294967295"/>
+          </p:nvPr>
+        </p:nvSpPr>
+        <p:spPr>
+          <a:xfrm>
+            <a:off x="8092440" y="4736592"/>
+            <a:ext cx="548640" cy="228600"/>
+          </a:xfrm>
+          <a:prstGeom prst="rect">
+            <a:avLst/>
+          </a:prstGeom>
+          <a:extLst>
+            <a:ext uri="{C572A759-6A51-4108-AA02-DFA0A04FC94B}">
+              <ma14:wrappingTextBoxFlag xmlns="" xmlns:ma14="http://schemas.microsoft.com/office/mac/drawingml/2011/main" val="0"/>
+            </a:ext>
+          </a:extLst>
+        </p:spPr>
+        <p:txBody>
+          <a:bodyPr/>
+          <a:lstStyle>
+            <a:lvl1pPr>
+              <a:defRPr sz="800">
+                <a:solidFill>
+                  <a:srgbClr val="6B7585"/>
+                </a:solidFill>
+              </a:defRPr>
+            </a:lvl1pPr>
+          </a:lstStyle>
+          <a:p>
+            <a:pPr algn="r"/>
+            <a:fld id="{F7021451-1387-4CA6-816F-3879F97B5CBC}" type="slidenum">
+              <a:rPr lang="en-US" b="0"/>
+              <a:t>27</a:t>
+            </a:fld>
+            <a:endParaRPr lang="en-US"/>
+          </a:p>
+        </p:txBody>
+      </p:sp>
+      <p:pic>
+        <p:nvPicPr>
+          <p:cNvPr id="26" name="cts logo" descr="cts-logo.png"/>
+          <p:cNvPicPr>
+            <a:picLocks noChangeAspect="1"/>
+          </p:cNvPicPr>
+          <p:nvPr/>
+        </p:nvPicPr>
+        <p:blipFill>
+          <a:blip r:embed="rId4"/>
+          <a:stretch>
+            <a:fillRect/>
+          </a:stretch>
+        </p:blipFill>
+        <p:spPr>
+          <a:xfrm>
+            <a:off x="7680959" y="182880"/>
+            <a:ext cx="960120" cy="539696"/>
+          </a:xfrm>
+          <a:prstGeom prst="rect">
+            <a:avLst/>
+          </a:prstGeom>
+        </p:spPr>
+      </p:pic>
+      <p:sp>
+        <p:nvSpPr>
+          <p:cNvPr id="4" name="Text 5b"/>
+          <p:cNvSpPr txBox="1"/>
+          <p:nvPr/>
+        </p:nvSpPr>
+        <p:spPr>
+          <a:xfrm>
+            <a:off x="4663440" y="3300984"/>
+            <a:ext cx="3703320" cy="1298448"/>
+          </a:xfrm>
+          <a:prstGeom prst="rect">
+            <a:avLst/>
+          </a:prstGeom>
+          <a:noFill/>
+          <a:ln/>
+        </p:spPr>
+        <p:txBody>
+          <a:bodyPr wrap="square" lIns="0" tIns="0" rIns="0" bIns="0" rtlCol="0" anchor="t">
+            <a:normAutofit fontScale="85000" lnSpcReduction="10000"/>
+          </a:bodyPr>
+          <a:lstStyle/>
+          <a:p>
+            <a:pPr marL="342900" indent="-342900">
+              <a:lnSpc>
+                <a:spcPts val="1050"/>
+              </a:lnSpc>
+              <a:spcAft>
+                <a:spcPts val="400"/>
+              </a:spcAft>
+              <a:buSzPct val="100000"/>
+              <a:buChar char="•"/>
+            </a:pPr>
+            <a:r>
+              <a:rPr lang="en-US" sz="1000">
+                <a:solidFill>
+                  <a:srgbClr val="3A4453"/>
+                </a:solidFill>
+              </a:rPr>
+              <a:t>Much of the employment overhead is relatively fixed in the short term, even when revenue fluctuates.</a:t>
+            </a:r>
+            <a:endParaRPr lang="en-US" sz="850"/>
+          </a:p>
+          <a:p>
+            <a:pPr marL="342900" indent="-342900">
+              <a:lnSpc>
+                <a:spcPts val="1050"/>
+              </a:lnSpc>
+              <a:spcAft>
+                <a:spcPts val="400"/>
+              </a:spcAft>
+              <a:buSzPct val="100000"/>
+              <a:buChar char="•"/>
+            </a:pPr>
+            <a:r>
+              <a:rPr lang="en-US" sz="1000">
+                <a:solidFill>
+                  <a:srgbClr val="3A4453"/>
+                </a:solidFill>
+              </a:rPr>
+              <a:t>Equipment and services costs of $347k are more closely linked to project activity.</a:t>
+            </a:r>
+            <a:endParaRPr lang="en-US" sz="850"/>
+          </a:p>
+          <a:p>
+            <a:pPr marL="342900" indent="-342900">
+              <a:lnSpc>
+                <a:spcPts val="1050"/>
+              </a:lnSpc>
+              <a:spcAft>
+                <a:spcPts val="400"/>
+              </a:spcAft>
+              <a:buSzPct val="100000"/>
+              <a:buChar char="•"/>
+            </a:pPr>
+            <a:r>
+              <a:rPr lang="en-US" sz="1000">
+                <a:solidFill>
+                  <a:srgbClr val="3A4453"/>
+                </a:solidFill>
+              </a:rPr>
+              <a:t>Material cost reductions would require a review of staffing capacity, utilisation and premises costs, while maintaining service delivery.</a:t>
+            </a:r>
+            <a:endParaRPr lang="en-US" sz="850"/>
           </a:p>
         </p:txBody>
       </p:sp>
@@ -17803,412 +17705,6 @@
 
 <file path=ppt/slides/slide30.xml><?xml version="1.0" encoding="utf-8"?>
 <p:sld xmlns:a="http://schemas.openxmlformats.org/drawingml/2006/main" xmlns:r="http://schemas.openxmlformats.org/officeDocument/2006/relationships" xmlns:p="http://schemas.openxmlformats.org/presentationml/2006/main">
-  <p:cSld name="Slide 16">
-    <p:spTree>
-      <p:nvGrpSpPr>
-        <p:cNvPr id="1" name=""/>
-        <p:cNvGrpSpPr/>
-        <p:nvPr/>
-      </p:nvGrpSpPr>
-      <p:grpSpPr>
-        <a:xfrm>
-          <a:off x="0" y="0"/>
-          <a:ext cx="0" cy="0"/>
-          <a:chOff x="0" y="0"/>
-          <a:chExt cx="0" cy="0"/>
-        </a:xfrm>
-      </p:grpSpPr>
-      <p:pic>
-        <p:nvPicPr>
-          <p:cNvPr id="27" name="snip cost_dist" descr="cost_dist.png"/>
-          <p:cNvPicPr>
-            <a:picLocks noChangeAspect="1"/>
-          </p:cNvPicPr>
-          <p:nvPr/>
-        </p:nvPicPr>
-        <p:blipFill>
-          <a:blip r:embed="rId3"/>
-          <a:stretch>
-            <a:fillRect/>
-          </a:stretch>
-        </p:blipFill>
-        <p:spPr>
-          <a:xfrm>
-            <a:off x="2640967" y="1005840"/>
-            <a:ext cx="3862065" cy="1956815"/>
-          </a:xfrm>
-          <a:prstGeom prst="rect">
-            <a:avLst/>
-          </a:prstGeom>
-        </p:spPr>
-      </p:pic>
-      <p:sp>
-        <p:nvSpPr>
-          <p:cNvPr id="2" name="Text 0"/>
-          <p:cNvSpPr txBox="1"/>
-          <p:nvPr/>
-        </p:nvSpPr>
-        <p:spPr>
-          <a:xfrm>
-            <a:off x="502920" y="365760"/>
-            <a:ext cx="6400800" cy="274320"/>
-          </a:xfrm>
-          <a:prstGeom prst="rect">
-            <a:avLst/>
-          </a:prstGeom>
-          <a:noFill/>
-          <a:ln/>
-        </p:spPr>
-        <p:txBody>
-          <a:bodyPr wrap="square" lIns="0" tIns="0" rIns="0" bIns="0" rtlCol="0" anchor="ctr"/>
-          <a:lstStyle/>
-          <a:p>
-            <a:pPr marL="0" indent="0">
-              <a:buNone/>
-            </a:pPr>
-            <a:r>
-              <a:rPr lang="en-US" sz="950" b="1" kern="0" spc="220">
-                <a:solidFill>
-                  <a:srgbClr val="122B82"/>
-                </a:solidFill>
-              </a:rPr>
-              <a:t>OPERATING EXPENDITURE</a:t>
-            </a:r>
-            <a:endParaRPr lang="en-US" sz="950"/>
-          </a:p>
-        </p:txBody>
-      </p:sp>
-      <p:sp>
-        <p:nvSpPr>
-          <p:cNvPr id="3" name="Text 1"/>
-          <p:cNvSpPr txBox="1"/>
-          <p:nvPr/>
-        </p:nvSpPr>
-        <p:spPr>
-          <a:xfrm>
-            <a:off x="502920" y="640080"/>
-            <a:ext cx="7315200" cy="365760"/>
-          </a:xfrm>
-          <a:prstGeom prst="rect">
-            <a:avLst/>
-          </a:prstGeom>
-          <a:noFill/>
-          <a:ln/>
-        </p:spPr>
-        <p:txBody>
-          <a:bodyPr wrap="square" lIns="0" tIns="0" rIns="0" bIns="0" rtlCol="0" anchor="ctr"/>
-          <a:lstStyle/>
-          <a:p>
-            <a:pPr marL="0" indent="0" algn="ctr">
-              <a:buNone/>
-            </a:pPr>
-            <a:r>
-              <a:rPr lang="en-US" sz="2200" b="1">
-                <a:solidFill>
-                  <a:srgbClr val="242C39"/>
-                </a:solidFill>
-              </a:rPr>
-              <a:t>Operating cost distribution, year to date</a:t>
-            </a:r>
-            <a:endParaRPr lang="en-US" sz="2700"/>
-          </a:p>
-        </p:txBody>
-      </p:sp>
-      <p:sp>
-        <p:nvSpPr>
-          <p:cNvPr id="6" name="commentary panel"/>
-          <p:cNvSpPr/>
-          <p:nvPr/>
-        </p:nvSpPr>
-        <p:spPr>
-          <a:xfrm>
-            <a:off x="502920" y="3054096"/>
-            <a:ext cx="8138160" cy="1572768"/>
-          </a:xfrm>
-          <a:prstGeom prst="rect">
-            <a:avLst/>
-          </a:prstGeom>
-          <a:solidFill>
-            <a:srgbClr val="E8F9F8"/>
-          </a:solidFill>
-          <a:ln/>
-        </p:spPr>
-        <p:txBody>
-          <a:bodyPr/>
-          <a:lstStyle/>
-          <a:p>
-            <a:endParaRPr lang="en-AU"/>
-          </a:p>
-        </p:txBody>
-      </p:sp>
-      <p:sp>
-        <p:nvSpPr>
-          <p:cNvPr id="7" name="Text 4"/>
-          <p:cNvSpPr txBox="1"/>
-          <p:nvPr/>
-        </p:nvSpPr>
-        <p:spPr>
-          <a:xfrm>
-            <a:off x="685800" y="3127248"/>
-            <a:ext cx="2743200" cy="228600"/>
-          </a:xfrm>
-          <a:prstGeom prst="rect">
-            <a:avLst/>
-          </a:prstGeom>
-          <a:noFill/>
-          <a:ln/>
-        </p:spPr>
-        <p:txBody>
-          <a:bodyPr wrap="square" lIns="0" tIns="0" rIns="0" bIns="0" rtlCol="0" anchor="ctr"/>
-          <a:lstStyle/>
-          <a:p>
-            <a:pPr marL="0" indent="0">
-              <a:buNone/>
-            </a:pPr>
-            <a:r>
-              <a:rPr lang="en-US" sz="900" b="1" kern="0" spc="180">
-                <a:solidFill>
-                  <a:srgbClr val="005358"/>
-                </a:solidFill>
-              </a:rPr>
-              <a:t>COMMENTARY</a:t>
-            </a:r>
-            <a:endParaRPr lang="en-US" sz="900"/>
-          </a:p>
-        </p:txBody>
-      </p:sp>
-      <p:sp>
-        <p:nvSpPr>
-          <p:cNvPr id="8" name="Text 5"/>
-          <p:cNvSpPr txBox="1"/>
-          <p:nvPr/>
-        </p:nvSpPr>
-        <p:spPr>
-          <a:xfrm>
-            <a:off x="685800" y="3300984"/>
-            <a:ext cx="3703320" cy="1298448"/>
-          </a:xfrm>
-          <a:prstGeom prst="rect">
-            <a:avLst/>
-          </a:prstGeom>
-          <a:noFill/>
-          <a:ln/>
-        </p:spPr>
-        <p:txBody>
-          <a:bodyPr wrap="square" lIns="0" tIns="0" rIns="0" bIns="0" rtlCol="0" anchor="t">
-            <a:normAutofit fontScale="85000" lnSpcReduction="10000"/>
-          </a:bodyPr>
-          <a:lstStyle/>
-          <a:p>
-            <a:pPr marL="342900" indent="-342900">
-              <a:lnSpc>
-                <a:spcPts val="1050"/>
-              </a:lnSpc>
-              <a:spcAft>
-                <a:spcPts val="400"/>
-              </a:spcAft>
-              <a:buSzPct val="100000"/>
-              <a:buChar char="•"/>
-            </a:pPr>
-            <a:r>
-              <a:rPr lang="en-US" sz="1000">
-                <a:solidFill>
-                  <a:srgbClr val="3A4453"/>
-                </a:solidFill>
-              </a:rPr>
-              <a:t>Year-to-date direct labour costs total $621k, with a further $369k in employment overheads. Together, these represent a substantial share of total costs.</a:t>
-            </a:r>
-            <a:endParaRPr lang="en-US" sz="850"/>
-          </a:p>
-          <a:p>
-            <a:pPr marL="342900" indent="-342900">
-              <a:lnSpc>
-                <a:spcPts val="1050"/>
-              </a:lnSpc>
-              <a:spcAft>
-                <a:spcPts val="400"/>
-              </a:spcAft>
-              <a:buSzPct val="100000"/>
-              <a:buChar char="•"/>
-            </a:pPr>
-            <a:r>
-              <a:rPr lang="en-US" sz="1000">
-                <a:solidFill>
-                  <a:srgbClr val="3A4453"/>
-                </a:solidFill>
-              </a:rPr>
-              <a:t>Labour is the largest cost category and has a major impact on profitability.</a:t>
-            </a:r>
-            <a:endParaRPr lang="en-US" sz="850"/>
-          </a:p>
-        </p:txBody>
-      </p:sp>
-      <p:sp>
-        <p:nvSpPr>
-          <p:cNvPr id="25" name="Slide Number Placeholder 0"/>
-          <p:cNvSpPr>
-            <a:spLocks noGrp="1"/>
-          </p:cNvSpPr>
-          <p:nvPr>
-            <p:ph type="sldNum" sz="quarter" idx="4294967295"/>
-          </p:nvPr>
-        </p:nvSpPr>
-        <p:spPr>
-          <a:xfrm>
-            <a:off x="8092440" y="4736592"/>
-            <a:ext cx="548640" cy="228600"/>
-          </a:xfrm>
-          <a:prstGeom prst="rect">
-            <a:avLst/>
-          </a:prstGeom>
-          <a:extLst>
-            <a:ext uri="{C572A759-6A51-4108-AA02-DFA0A04FC94B}">
-              <ma14:wrappingTextBoxFlag xmlns="" xmlns:ma14="http://schemas.microsoft.com/office/mac/drawingml/2011/main" val="0"/>
-            </a:ext>
-          </a:extLst>
-        </p:spPr>
-        <p:txBody>
-          <a:bodyPr/>
-          <a:lstStyle>
-            <a:lvl1pPr>
-              <a:defRPr sz="800">
-                <a:solidFill>
-                  <a:srgbClr val="6B7585"/>
-                </a:solidFill>
-              </a:defRPr>
-            </a:lvl1pPr>
-          </a:lstStyle>
-          <a:p>
-            <a:pPr algn="r"/>
-            <a:fld id="{F7021451-1387-4CA6-816F-3879F97B5CBC}" type="slidenum">
-              <a:rPr lang="en-US" b="0"/>
-              <a:t>27</a:t>
-            </a:fld>
-            <a:endParaRPr lang="en-US"/>
-          </a:p>
-        </p:txBody>
-      </p:sp>
-      <p:pic>
-        <p:nvPicPr>
-          <p:cNvPr id="26" name="cts logo" descr="cts-logo.png"/>
-          <p:cNvPicPr>
-            <a:picLocks noChangeAspect="1"/>
-          </p:cNvPicPr>
-          <p:nvPr/>
-        </p:nvPicPr>
-        <p:blipFill>
-          <a:blip r:embed="rId4"/>
-          <a:stretch>
-            <a:fillRect/>
-          </a:stretch>
-        </p:blipFill>
-        <p:spPr>
-          <a:xfrm>
-            <a:off x="7680959" y="182880"/>
-            <a:ext cx="960120" cy="539696"/>
-          </a:xfrm>
-          <a:prstGeom prst="rect">
-            <a:avLst/>
-          </a:prstGeom>
-        </p:spPr>
-      </p:pic>
-      <p:sp>
-        <p:nvSpPr>
-          <p:cNvPr id="4" name="Text 5b"/>
-          <p:cNvSpPr txBox="1"/>
-          <p:nvPr/>
-        </p:nvSpPr>
-        <p:spPr>
-          <a:xfrm>
-            <a:off x="4663440" y="3300984"/>
-            <a:ext cx="3703320" cy="1298448"/>
-          </a:xfrm>
-          <a:prstGeom prst="rect">
-            <a:avLst/>
-          </a:prstGeom>
-          <a:noFill/>
-          <a:ln/>
-        </p:spPr>
-        <p:txBody>
-          <a:bodyPr wrap="square" lIns="0" tIns="0" rIns="0" bIns="0" rtlCol="0" anchor="t">
-            <a:normAutofit fontScale="85000" lnSpcReduction="10000"/>
-          </a:bodyPr>
-          <a:lstStyle/>
-          <a:p>
-            <a:pPr marL="342900" indent="-342900">
-              <a:lnSpc>
-                <a:spcPts val="1050"/>
-              </a:lnSpc>
-              <a:spcAft>
-                <a:spcPts val="400"/>
-              </a:spcAft>
-              <a:buSzPct val="100000"/>
-              <a:buChar char="•"/>
-            </a:pPr>
-            <a:r>
-              <a:rPr lang="en-US" sz="1000">
-                <a:solidFill>
-                  <a:srgbClr val="3A4453"/>
-                </a:solidFill>
-              </a:rPr>
-              <a:t>Much of the employment overhead is relatively fixed in the short term, even when revenue fluctuates.</a:t>
-            </a:r>
-            <a:endParaRPr lang="en-US" sz="850"/>
-          </a:p>
-          <a:p>
-            <a:pPr marL="342900" indent="-342900">
-              <a:lnSpc>
-                <a:spcPts val="1050"/>
-              </a:lnSpc>
-              <a:spcAft>
-                <a:spcPts val="400"/>
-              </a:spcAft>
-              <a:buSzPct val="100000"/>
-              <a:buChar char="•"/>
-            </a:pPr>
-            <a:r>
-              <a:rPr lang="en-US" sz="1000">
-                <a:solidFill>
-                  <a:srgbClr val="3A4453"/>
-                </a:solidFill>
-              </a:rPr>
-              <a:t>Equipment and services costs of $347k are more closely linked to project activity.</a:t>
-            </a:r>
-            <a:endParaRPr lang="en-US" sz="850"/>
-          </a:p>
-          <a:p>
-            <a:pPr marL="342900" indent="-342900">
-              <a:lnSpc>
-                <a:spcPts val="1050"/>
-              </a:lnSpc>
-              <a:spcAft>
-                <a:spcPts val="400"/>
-              </a:spcAft>
-              <a:buSzPct val="100000"/>
-              <a:buChar char="•"/>
-            </a:pPr>
-            <a:r>
-              <a:rPr lang="en-US" sz="1000">
-                <a:solidFill>
-                  <a:srgbClr val="3A4453"/>
-                </a:solidFill>
-              </a:rPr>
-              <a:t>Material cost reductions would require a review of staffing capacity, utilisation and premises costs, while maintaining service delivery.</a:t>
-            </a:r>
-            <a:endParaRPr lang="en-US" sz="850"/>
-          </a:p>
-        </p:txBody>
-      </p:sp>
-    </p:spTree>
-  </p:cSld>
-  <p:clrMapOvr>
-    <a:masterClrMapping/>
-  </p:clrMapOvr>
-</p:sld>
-</file>
-
-<file path=ppt/slides/slide31.xml><?xml version="1.0" encoding="utf-8"?>
-<p:sld xmlns:a="http://schemas.openxmlformats.org/drawingml/2006/main" xmlns:r="http://schemas.openxmlformats.org/officeDocument/2006/relationships" xmlns:p="http://schemas.openxmlformats.org/presentationml/2006/main">
   <p:cSld name="Slide 17">
     <p:spTree>
       <p:nvGrpSpPr>
@@ -18613,7 +18109,7 @@
 </p:sld>
 </file>
 
-<file path=ppt/slides/slide32.xml><?xml version="1.0" encoding="utf-8"?>
+<file path=ppt/slides/slide31.xml><?xml version="1.0" encoding="utf-8"?>
 <p:sld xmlns:a="http://schemas.openxmlformats.org/drawingml/2006/main" xmlns:r="http://schemas.openxmlformats.org/officeDocument/2006/relationships" xmlns:p="http://schemas.openxmlformats.org/presentationml/2006/main">
   <p:cSld name="Slide 18">
     <p:spTree>
@@ -19019,7 +18515,7 @@
 </p:sld>
 </file>
 
-<file path=ppt/slides/slide33.xml><?xml version="1.0" encoding="utf-8"?>
+<file path=ppt/slides/slide32.xml><?xml version="1.0" encoding="utf-8"?>
 <p:sld xmlns:a="http://schemas.openxmlformats.org/drawingml/2006/main" xmlns:r="http://schemas.openxmlformats.org/officeDocument/2006/relationships" xmlns:p="http://schemas.openxmlformats.org/presentationml/2006/main">
   <p:cSld name="Slide 19">
     <p:spTree>
@@ -19404,7 +18900,7 @@
 </p:sld>
 </file>
 
-<file path=ppt/slides/slide34.xml><?xml version="1.0" encoding="utf-8"?>
+<file path=ppt/slides/slide33.xml><?xml version="1.0" encoding="utf-8"?>
 <p:sld xmlns:a="http://schemas.openxmlformats.org/drawingml/2006/main" xmlns:r="http://schemas.openxmlformats.org/officeDocument/2006/relationships" xmlns:p="http://schemas.openxmlformats.org/presentationml/2006/main">
   <p:cSld name="Slide 20">
     <p:spTree>
@@ -19687,7 +19183,7 @@
 </p:sld>
 </file>
 
-<file path=ppt/slides/slide35.xml><?xml version="1.0" encoding="utf-8"?>
+<file path=ppt/slides/slide34.xml><?xml version="1.0" encoding="utf-8"?>
 <p:sld xmlns:a="http://schemas.openxmlformats.org/drawingml/2006/main" xmlns:r="http://schemas.openxmlformats.org/officeDocument/2006/relationships" xmlns:p="http://schemas.openxmlformats.org/presentationml/2006/main">
   <p:cSld name="Slide 21">
     <p:spTree>
@@ -20093,7 +19589,7 @@
 </p:sld>
 </file>
 
-<file path=ppt/slides/slide36.xml><?xml version="1.0" encoding="utf-8"?>
+<file path=ppt/slides/slide35.xml><?xml version="1.0" encoding="utf-8"?>
 <p:sld xmlns:a="http://schemas.openxmlformats.org/drawingml/2006/main" xmlns:r="http://schemas.openxmlformats.org/officeDocument/2006/relationships" xmlns:p="http://schemas.openxmlformats.org/presentationml/2006/main">
   <p:cSld name="Slide 22">
     <p:spTree>
@@ -20499,7 +19995,7 @@
 </p:sld>
 </file>
 
-<file path=ppt/slides/slide37.xml><?xml version="1.0" encoding="utf-8"?>
+<file path=ppt/slides/slide36.xml><?xml version="1.0" encoding="utf-8"?>
 <p:sld xmlns:a="http://schemas.openxmlformats.org/drawingml/2006/main" xmlns:r="http://schemas.openxmlformats.org/officeDocument/2006/relationships" xmlns:p="http://schemas.openxmlformats.org/presentationml/2006/main">
   <p:cSld name="Slide 23">
     <p:spTree>
@@ -20905,7 +20401,7 @@
 </p:sld>
 </file>
 
-<file path=ppt/slides/slide38.xml><?xml version="1.0" encoding="utf-8"?>
+<file path=ppt/slides/slide37.xml><?xml version="1.0" encoding="utf-8"?>
 <p:sld xmlns:a="http://schemas.openxmlformats.org/drawingml/2006/main" xmlns:r="http://schemas.openxmlformats.org/officeDocument/2006/relationships" xmlns:p="http://schemas.openxmlformats.org/presentationml/2006/main">
   <p:cSld name="Slide 24">
     <p:spTree>
@@ -21188,7 +20684,7 @@
 </p:sld>
 </file>
 
-<file path=ppt/slides/slide39.xml><?xml version="1.0" encoding="utf-8"?>
+<file path=ppt/slides/slide38.xml><?xml version="1.0" encoding="utf-8"?>
 <p:sld xmlns:a="http://schemas.openxmlformats.org/drawingml/2006/main" xmlns:r="http://schemas.openxmlformats.org/officeDocument/2006/relationships" xmlns:p="http://schemas.openxmlformats.org/presentationml/2006/main">
   <p:cSld name="Slide 25">
     <p:spTree>
@@ -21565,6 +21061,412 @@
           </a:prstGeom>
         </p:spPr>
       </p:pic>
+    </p:spTree>
+  </p:cSld>
+  <p:clrMapOvr>
+    <a:masterClrMapping/>
+  </p:clrMapOvr>
+</p:sld>
+</file>
+
+<file path=ppt/slides/slide39.xml><?xml version="1.0" encoding="utf-8"?>
+<p:sld xmlns:a="http://schemas.openxmlformats.org/drawingml/2006/main" xmlns:r="http://schemas.openxmlformats.org/officeDocument/2006/relationships" xmlns:p="http://schemas.openxmlformats.org/presentationml/2006/main">
+  <p:cSld name="Slide 26">
+    <p:spTree>
+      <p:nvGrpSpPr>
+        <p:cNvPr id="1" name=""/>
+        <p:cNvGrpSpPr/>
+        <p:nvPr/>
+      </p:nvGrpSpPr>
+      <p:grpSpPr>
+        <a:xfrm>
+          <a:off x="0" y="0"/>
+          <a:ext cx="0" cy="0"/>
+          <a:chOff x="0" y="0"/>
+          <a:chExt cx="0" cy="0"/>
+        </a:xfrm>
+      </p:grpSpPr>
+      <p:pic>
+        <p:nvPicPr>
+          <p:cNvPr id="27" name="snip util_chart" descr="util_chart.png"/>
+          <p:cNvPicPr>
+            <a:picLocks noChangeAspect="1"/>
+          </p:cNvPicPr>
+          <p:nvPr/>
+        </p:nvPicPr>
+        <p:blipFill>
+          <a:blip r:embed="rId3"/>
+          <a:stretch>
+            <a:fillRect/>
+          </a:stretch>
+        </p:blipFill>
+        <p:spPr>
+          <a:xfrm>
+            <a:off x="565963" y="1005840"/>
+            <a:ext cx="8012072" cy="2130551"/>
+          </a:xfrm>
+          <a:prstGeom prst="rect">
+            <a:avLst/>
+          </a:prstGeom>
+        </p:spPr>
+      </p:pic>
+      <p:sp>
+        <p:nvSpPr>
+          <p:cNvPr id="2" name="Text 0"/>
+          <p:cNvSpPr txBox="1"/>
+          <p:nvPr/>
+        </p:nvSpPr>
+        <p:spPr>
+          <a:xfrm>
+            <a:off x="502920" y="365760"/>
+            <a:ext cx="6400800" cy="274320"/>
+          </a:xfrm>
+          <a:prstGeom prst="rect">
+            <a:avLst/>
+          </a:prstGeom>
+          <a:noFill/>
+          <a:ln/>
+        </p:spPr>
+        <p:txBody>
+          <a:bodyPr wrap="square" lIns="0" tIns="0" rIns="0" bIns="0" rtlCol="0" anchor="ctr"/>
+          <a:lstStyle/>
+          <a:p>
+            <a:pPr marL="0" indent="0">
+              <a:buNone/>
+            </a:pPr>
+            <a:r>
+              <a:rPr lang="en-US" sz="950" b="1" kern="0" spc="220">
+                <a:solidFill>
+                  <a:srgbClr val="122B82"/>
+                </a:solidFill>
+              </a:rPr>
+              <a:t>PEOPLE AND UTILISATION</a:t>
+            </a:r>
+            <a:endParaRPr lang="en-US" sz="950"/>
+          </a:p>
+        </p:txBody>
+      </p:sp>
+      <p:sp>
+        <p:nvSpPr>
+          <p:cNvPr id="3" name="Text 1"/>
+          <p:cNvSpPr txBox="1"/>
+          <p:nvPr/>
+        </p:nvSpPr>
+        <p:spPr>
+          <a:xfrm>
+            <a:off x="502920" y="640080"/>
+            <a:ext cx="7315200" cy="365760"/>
+          </a:xfrm>
+          <a:prstGeom prst="rect">
+            <a:avLst/>
+          </a:prstGeom>
+          <a:noFill/>
+          <a:ln/>
+        </p:spPr>
+        <p:txBody>
+          <a:bodyPr wrap="square" lIns="0" tIns="0" rIns="0" bIns="0" rtlCol="0" anchor="ctr"/>
+          <a:lstStyle/>
+          <a:p>
+            <a:pPr marL="0" indent="0" algn="ctr">
+              <a:buNone/>
+            </a:pPr>
+            <a:r>
+              <a:rPr lang="en-US" sz="2200" b="1">
+                <a:solidFill>
+                  <a:srgbClr val="242C39"/>
+                </a:solidFill>
+              </a:rPr>
+              <a:t>Hours mix by department, September 2026</a:t>
+            </a:r>
+            <a:endParaRPr lang="en-US" sz="2700"/>
+          </a:p>
+        </p:txBody>
+      </p:sp>
+      <p:sp>
+        <p:nvSpPr>
+          <p:cNvPr id="6" name="commentary panel"/>
+          <p:cNvSpPr/>
+          <p:nvPr/>
+        </p:nvSpPr>
+        <p:spPr>
+          <a:xfrm>
+            <a:off x="502920" y="3227831"/>
+            <a:ext cx="8138160" cy="1399032"/>
+          </a:xfrm>
+          <a:prstGeom prst="rect">
+            <a:avLst/>
+          </a:prstGeom>
+          <a:solidFill>
+            <a:srgbClr val="E8F9F8"/>
+          </a:solidFill>
+          <a:ln/>
+        </p:spPr>
+        <p:txBody>
+          <a:bodyPr/>
+          <a:lstStyle/>
+          <a:p>
+            <a:endParaRPr lang="en-AU"/>
+          </a:p>
+        </p:txBody>
+      </p:sp>
+      <p:sp>
+        <p:nvSpPr>
+          <p:cNvPr id="7" name="Text 4"/>
+          <p:cNvSpPr txBox="1"/>
+          <p:nvPr/>
+        </p:nvSpPr>
+        <p:spPr>
+          <a:xfrm>
+            <a:off x="685800" y="3300983"/>
+            <a:ext cx="2743200" cy="228600"/>
+          </a:xfrm>
+          <a:prstGeom prst="rect">
+            <a:avLst/>
+          </a:prstGeom>
+          <a:noFill/>
+          <a:ln/>
+        </p:spPr>
+        <p:txBody>
+          <a:bodyPr wrap="square" lIns="0" tIns="0" rIns="0" bIns="0" rtlCol="0" anchor="ctr"/>
+          <a:lstStyle/>
+          <a:p>
+            <a:pPr marL="0" indent="0">
+              <a:buNone/>
+            </a:pPr>
+            <a:r>
+              <a:rPr lang="en-US" sz="900" b="1" kern="0" spc="180">
+                <a:solidFill>
+                  <a:srgbClr val="005358"/>
+                </a:solidFill>
+              </a:rPr>
+              <a:t>COMMENTARY</a:t>
+            </a:r>
+            <a:endParaRPr lang="en-US" sz="900"/>
+          </a:p>
+        </p:txBody>
+      </p:sp>
+      <p:sp>
+        <p:nvSpPr>
+          <p:cNvPr id="8" name="Text 5"/>
+          <p:cNvSpPr txBox="1"/>
+          <p:nvPr/>
+        </p:nvSpPr>
+        <p:spPr>
+          <a:xfrm>
+            <a:off x="685800" y="3474719"/>
+            <a:ext cx="3703320" cy="1124712"/>
+          </a:xfrm>
+          <a:prstGeom prst="rect">
+            <a:avLst/>
+          </a:prstGeom>
+          <a:noFill/>
+          <a:ln/>
+        </p:spPr>
+        <p:txBody>
+          <a:bodyPr wrap="square" lIns="0" tIns="0" rIns="0" bIns="0" rtlCol="0" anchor="t">
+            <a:normAutofit fontScale="92500"/>
+          </a:bodyPr>
+          <a:lstStyle/>
+          <a:p>
+            <a:pPr marL="342900" indent="-342900">
+              <a:lnSpc>
+                <a:spcPts val="1050"/>
+              </a:lnSpc>
+              <a:spcAft>
+                <a:spcPts val="400"/>
+              </a:spcAft>
+              <a:buSzPct val="100000"/>
+              <a:buChar char="•"/>
+            </a:pPr>
+            <a:r>
+              <a:rPr lang="en-US" sz="1000">
+                <a:solidFill>
+                  <a:srgbClr val="3A4453"/>
+                </a:solidFill>
+              </a:rPr>
+              <a:t>Each bar shows the mix of hours within its own department, rather than comparing total hours between departments.</a:t>
+            </a:r>
+            <a:endParaRPr lang="en-US" sz="850"/>
+          </a:p>
+          <a:p>
+            <a:pPr marL="342900" indent="-342900">
+              <a:lnSpc>
+                <a:spcPts val="1050"/>
+              </a:lnSpc>
+              <a:spcAft>
+                <a:spcPts val="400"/>
+              </a:spcAft>
+              <a:buSzPct val="100000"/>
+              <a:buChar char="•"/>
+            </a:pPr>
+            <a:r>
+              <a:rPr lang="en-US" sz="1000">
+                <a:solidFill>
+                  <a:srgbClr val="3A4453"/>
+                </a:solidFill>
+              </a:rPr>
+              <a:t>Support's hours were predominantly billable, supporting its positive financial result.</a:t>
+            </a:r>
+            <a:endParaRPr lang="en-US" sz="850"/>
+          </a:p>
+        </p:txBody>
+      </p:sp>
+      <p:sp>
+        <p:nvSpPr>
+          <p:cNvPr id="25" name="Slide Number Placeholder 0"/>
+          <p:cNvSpPr>
+            <a:spLocks noGrp="1"/>
+          </p:cNvSpPr>
+          <p:nvPr>
+            <p:ph type="sldNum" sz="quarter" idx="4294967295"/>
+          </p:nvPr>
+        </p:nvSpPr>
+        <p:spPr>
+          <a:xfrm>
+            <a:off x="8092440" y="4736592"/>
+            <a:ext cx="548640" cy="228600"/>
+          </a:xfrm>
+          <a:prstGeom prst="rect">
+            <a:avLst/>
+          </a:prstGeom>
+          <a:extLst>
+            <a:ext uri="{C572A759-6A51-4108-AA02-DFA0A04FC94B}">
+              <ma14:wrappingTextBoxFlag xmlns="" xmlns:ma14="http://schemas.microsoft.com/office/mac/drawingml/2011/main" val="0"/>
+            </a:ext>
+          </a:extLst>
+        </p:spPr>
+        <p:txBody>
+          <a:bodyPr/>
+          <a:lstStyle>
+            <a:lvl1pPr>
+              <a:defRPr sz="800">
+                <a:solidFill>
+                  <a:srgbClr val="6B7585"/>
+                </a:solidFill>
+              </a:defRPr>
+            </a:lvl1pPr>
+          </a:lstStyle>
+          <a:p>
+            <a:pPr algn="r"/>
+            <a:fld id="{F7021451-1387-4CA6-816F-3879F97B5CBC}" type="slidenum">
+              <a:rPr lang="en-US" b="0"/>
+              <a:t>37</a:t>
+            </a:fld>
+            <a:endParaRPr lang="en-US"/>
+          </a:p>
+        </p:txBody>
+      </p:sp>
+      <p:pic>
+        <p:nvPicPr>
+          <p:cNvPr id="26" name="cts logo" descr="cts-logo.png"/>
+          <p:cNvPicPr>
+            <a:picLocks noChangeAspect="1"/>
+          </p:cNvPicPr>
+          <p:nvPr/>
+        </p:nvPicPr>
+        <p:blipFill>
+          <a:blip r:embed="rId4"/>
+          <a:stretch>
+            <a:fillRect/>
+          </a:stretch>
+        </p:blipFill>
+        <p:spPr>
+          <a:xfrm>
+            <a:off x="7680959" y="182880"/>
+            <a:ext cx="960120" cy="539696"/>
+          </a:xfrm>
+          <a:prstGeom prst="rect">
+            <a:avLst/>
+          </a:prstGeom>
+        </p:spPr>
+      </p:pic>
+      <p:sp>
+        <p:nvSpPr>
+          <p:cNvPr id="4" name="Text 5b"/>
+          <p:cNvSpPr txBox="1"/>
+          <p:nvPr/>
+        </p:nvSpPr>
+        <p:spPr>
+          <a:xfrm>
+            <a:off x="4663440" y="3474719"/>
+            <a:ext cx="3703320" cy="1124712"/>
+          </a:xfrm>
+          <a:prstGeom prst="rect">
+            <a:avLst/>
+          </a:prstGeom>
+          <a:noFill/>
+          <a:ln/>
+        </p:spPr>
+        <p:txBody>
+          <a:bodyPr wrap="square" lIns="0" tIns="0" rIns="0" bIns="0" rtlCol="0" anchor="t">
+            <a:normAutofit fontScale="92500"/>
+          </a:bodyPr>
+          <a:lstStyle/>
+          <a:p>
+            <a:pPr marL="342900" indent="-342900">
+              <a:lnSpc>
+                <a:spcPts val="1050"/>
+              </a:lnSpc>
+              <a:spcAft>
+                <a:spcPts val="400"/>
+              </a:spcAft>
+              <a:buSzPct val="100000"/>
+              <a:buChar char="•"/>
+            </a:pPr>
+            <a:r>
+              <a:rPr lang="en-US" sz="1000">
+                <a:solidFill>
+                  <a:srgbClr val="3A4453"/>
+                </a:solidFill>
+              </a:rPr>
+              <a:t>Events recorded 333 hours of leave and 241 billable hours, reducing its available delivery capacity.</a:t>
+            </a:r>
+            <a:endParaRPr lang="en-US" sz="850"/>
+          </a:p>
+          <a:p>
+            <a:pPr marL="342900" indent="-342900">
+              <a:lnSpc>
+                <a:spcPts val="1050"/>
+              </a:lnSpc>
+              <a:spcAft>
+                <a:spcPts val="400"/>
+              </a:spcAft>
+              <a:buSzPct val="100000"/>
+              <a:buChar char="•"/>
+            </a:pPr>
+            <a:r>
+              <a:rPr lang="en-US" sz="1000">
+                <a:solidFill>
+                  <a:srgbClr val="3A4453"/>
+                </a:solidFill>
+              </a:rPr>
+              <a:t>Consulting recorded 84 non-billable hours compared with 31 billable hours.</a:t>
+            </a:r>
+            <a:endParaRPr lang="en-US" sz="850"/>
+          </a:p>
+          <a:p>
+            <a:pPr marL="342900" indent="-342900">
+              <a:lnSpc>
+                <a:spcPts val="1050"/>
+              </a:lnSpc>
+              <a:spcAft>
+                <a:spcPts val="400"/>
+              </a:spcAft>
+              <a:buSzPct val="100000"/>
+              <a:buChar char="•"/>
+            </a:pPr>
+            <a:r>
+              <a:rPr lang="en-US" sz="1000">
+                <a:solidFill>
+                  <a:srgbClr val="3A4453"/>
+                </a:solidFill>
+              </a:rPr>
+              <a:t>The non-billable and leave portions highlight opportunities to improve workforce planning and billable utilisation.</a:t>
+            </a:r>
+            <a:endParaRPr lang="en-US" sz="850"/>
+          </a:p>
+        </p:txBody>
+      </p:sp>
     </p:spTree>
   </p:cSld>
   <p:clrMapOvr>
@@ -21858,412 +21760,6 @@
 
 <file path=ppt/slides/slide40.xml><?xml version="1.0" encoding="utf-8"?>
 <p:sld xmlns:a="http://schemas.openxmlformats.org/drawingml/2006/main" xmlns:r="http://schemas.openxmlformats.org/officeDocument/2006/relationships" xmlns:p="http://schemas.openxmlformats.org/presentationml/2006/main">
-  <p:cSld name="Slide 26">
-    <p:spTree>
-      <p:nvGrpSpPr>
-        <p:cNvPr id="1" name=""/>
-        <p:cNvGrpSpPr/>
-        <p:nvPr/>
-      </p:nvGrpSpPr>
-      <p:grpSpPr>
-        <a:xfrm>
-          <a:off x="0" y="0"/>
-          <a:ext cx="0" cy="0"/>
-          <a:chOff x="0" y="0"/>
-          <a:chExt cx="0" cy="0"/>
-        </a:xfrm>
-      </p:grpSpPr>
-      <p:pic>
-        <p:nvPicPr>
-          <p:cNvPr id="27" name="snip util_chart" descr="util_chart.png"/>
-          <p:cNvPicPr>
-            <a:picLocks noChangeAspect="1"/>
-          </p:cNvPicPr>
-          <p:nvPr/>
-        </p:nvPicPr>
-        <p:blipFill>
-          <a:blip r:embed="rId3"/>
-          <a:stretch>
-            <a:fillRect/>
-          </a:stretch>
-        </p:blipFill>
-        <p:spPr>
-          <a:xfrm>
-            <a:off x="565963" y="1005840"/>
-            <a:ext cx="8012072" cy="2130551"/>
-          </a:xfrm>
-          <a:prstGeom prst="rect">
-            <a:avLst/>
-          </a:prstGeom>
-        </p:spPr>
-      </p:pic>
-      <p:sp>
-        <p:nvSpPr>
-          <p:cNvPr id="2" name="Text 0"/>
-          <p:cNvSpPr txBox="1"/>
-          <p:nvPr/>
-        </p:nvSpPr>
-        <p:spPr>
-          <a:xfrm>
-            <a:off x="502920" y="365760"/>
-            <a:ext cx="6400800" cy="274320"/>
-          </a:xfrm>
-          <a:prstGeom prst="rect">
-            <a:avLst/>
-          </a:prstGeom>
-          <a:noFill/>
-          <a:ln/>
-        </p:spPr>
-        <p:txBody>
-          <a:bodyPr wrap="square" lIns="0" tIns="0" rIns="0" bIns="0" rtlCol="0" anchor="ctr"/>
-          <a:lstStyle/>
-          <a:p>
-            <a:pPr marL="0" indent="0">
-              <a:buNone/>
-            </a:pPr>
-            <a:r>
-              <a:rPr lang="en-US" sz="950" b="1" kern="0" spc="220">
-                <a:solidFill>
-                  <a:srgbClr val="122B82"/>
-                </a:solidFill>
-              </a:rPr>
-              <a:t>PEOPLE AND UTILISATION</a:t>
-            </a:r>
-            <a:endParaRPr lang="en-US" sz="950"/>
-          </a:p>
-        </p:txBody>
-      </p:sp>
-      <p:sp>
-        <p:nvSpPr>
-          <p:cNvPr id="3" name="Text 1"/>
-          <p:cNvSpPr txBox="1"/>
-          <p:nvPr/>
-        </p:nvSpPr>
-        <p:spPr>
-          <a:xfrm>
-            <a:off x="502920" y="640080"/>
-            <a:ext cx="7315200" cy="365760"/>
-          </a:xfrm>
-          <a:prstGeom prst="rect">
-            <a:avLst/>
-          </a:prstGeom>
-          <a:noFill/>
-          <a:ln/>
-        </p:spPr>
-        <p:txBody>
-          <a:bodyPr wrap="square" lIns="0" tIns="0" rIns="0" bIns="0" rtlCol="0" anchor="ctr"/>
-          <a:lstStyle/>
-          <a:p>
-            <a:pPr marL="0" indent="0" algn="ctr">
-              <a:buNone/>
-            </a:pPr>
-            <a:r>
-              <a:rPr lang="en-US" sz="2200" b="1">
-                <a:solidFill>
-                  <a:srgbClr val="242C39"/>
-                </a:solidFill>
-              </a:rPr>
-              <a:t>Hours mix by department, September 2026</a:t>
-            </a:r>
-            <a:endParaRPr lang="en-US" sz="2700"/>
-          </a:p>
-        </p:txBody>
-      </p:sp>
-      <p:sp>
-        <p:nvSpPr>
-          <p:cNvPr id="6" name="commentary panel"/>
-          <p:cNvSpPr/>
-          <p:nvPr/>
-        </p:nvSpPr>
-        <p:spPr>
-          <a:xfrm>
-            <a:off x="502920" y="3227831"/>
-            <a:ext cx="8138160" cy="1399032"/>
-          </a:xfrm>
-          <a:prstGeom prst="rect">
-            <a:avLst/>
-          </a:prstGeom>
-          <a:solidFill>
-            <a:srgbClr val="E8F9F8"/>
-          </a:solidFill>
-          <a:ln/>
-        </p:spPr>
-        <p:txBody>
-          <a:bodyPr/>
-          <a:lstStyle/>
-          <a:p>
-            <a:endParaRPr lang="en-AU"/>
-          </a:p>
-        </p:txBody>
-      </p:sp>
-      <p:sp>
-        <p:nvSpPr>
-          <p:cNvPr id="7" name="Text 4"/>
-          <p:cNvSpPr txBox="1"/>
-          <p:nvPr/>
-        </p:nvSpPr>
-        <p:spPr>
-          <a:xfrm>
-            <a:off x="685800" y="3300983"/>
-            <a:ext cx="2743200" cy="228600"/>
-          </a:xfrm>
-          <a:prstGeom prst="rect">
-            <a:avLst/>
-          </a:prstGeom>
-          <a:noFill/>
-          <a:ln/>
-        </p:spPr>
-        <p:txBody>
-          <a:bodyPr wrap="square" lIns="0" tIns="0" rIns="0" bIns="0" rtlCol="0" anchor="ctr"/>
-          <a:lstStyle/>
-          <a:p>
-            <a:pPr marL="0" indent="0">
-              <a:buNone/>
-            </a:pPr>
-            <a:r>
-              <a:rPr lang="en-US" sz="900" b="1" kern="0" spc="180">
-                <a:solidFill>
-                  <a:srgbClr val="005358"/>
-                </a:solidFill>
-              </a:rPr>
-              <a:t>COMMENTARY</a:t>
-            </a:r>
-            <a:endParaRPr lang="en-US" sz="900"/>
-          </a:p>
-        </p:txBody>
-      </p:sp>
-      <p:sp>
-        <p:nvSpPr>
-          <p:cNvPr id="8" name="Text 5"/>
-          <p:cNvSpPr txBox="1"/>
-          <p:nvPr/>
-        </p:nvSpPr>
-        <p:spPr>
-          <a:xfrm>
-            <a:off x="685800" y="3474719"/>
-            <a:ext cx="3703320" cy="1124712"/>
-          </a:xfrm>
-          <a:prstGeom prst="rect">
-            <a:avLst/>
-          </a:prstGeom>
-          <a:noFill/>
-          <a:ln/>
-        </p:spPr>
-        <p:txBody>
-          <a:bodyPr wrap="square" lIns="0" tIns="0" rIns="0" bIns="0" rtlCol="0" anchor="t">
-            <a:normAutofit fontScale="92500"/>
-          </a:bodyPr>
-          <a:lstStyle/>
-          <a:p>
-            <a:pPr marL="342900" indent="-342900">
-              <a:lnSpc>
-                <a:spcPts val="1050"/>
-              </a:lnSpc>
-              <a:spcAft>
-                <a:spcPts val="400"/>
-              </a:spcAft>
-              <a:buSzPct val="100000"/>
-              <a:buChar char="•"/>
-            </a:pPr>
-            <a:r>
-              <a:rPr lang="en-US" sz="1000">
-                <a:solidFill>
-                  <a:srgbClr val="3A4453"/>
-                </a:solidFill>
-              </a:rPr>
-              <a:t>Each bar shows the mix of hours within its own department, rather than comparing total hours between departments.</a:t>
-            </a:r>
-            <a:endParaRPr lang="en-US" sz="850"/>
-          </a:p>
-          <a:p>
-            <a:pPr marL="342900" indent="-342900">
-              <a:lnSpc>
-                <a:spcPts val="1050"/>
-              </a:lnSpc>
-              <a:spcAft>
-                <a:spcPts val="400"/>
-              </a:spcAft>
-              <a:buSzPct val="100000"/>
-              <a:buChar char="•"/>
-            </a:pPr>
-            <a:r>
-              <a:rPr lang="en-US" sz="1000">
-                <a:solidFill>
-                  <a:srgbClr val="3A4453"/>
-                </a:solidFill>
-              </a:rPr>
-              <a:t>Support's hours were predominantly billable, supporting its positive financial result.</a:t>
-            </a:r>
-            <a:endParaRPr lang="en-US" sz="850"/>
-          </a:p>
-        </p:txBody>
-      </p:sp>
-      <p:sp>
-        <p:nvSpPr>
-          <p:cNvPr id="25" name="Slide Number Placeholder 0"/>
-          <p:cNvSpPr>
-            <a:spLocks noGrp="1"/>
-          </p:cNvSpPr>
-          <p:nvPr>
-            <p:ph type="sldNum" sz="quarter" idx="4294967295"/>
-          </p:nvPr>
-        </p:nvSpPr>
-        <p:spPr>
-          <a:xfrm>
-            <a:off x="8092440" y="4736592"/>
-            <a:ext cx="548640" cy="228600"/>
-          </a:xfrm>
-          <a:prstGeom prst="rect">
-            <a:avLst/>
-          </a:prstGeom>
-          <a:extLst>
-            <a:ext uri="{C572A759-6A51-4108-AA02-DFA0A04FC94B}">
-              <ma14:wrappingTextBoxFlag xmlns="" xmlns:ma14="http://schemas.microsoft.com/office/mac/drawingml/2011/main" val="0"/>
-            </a:ext>
-          </a:extLst>
-        </p:spPr>
-        <p:txBody>
-          <a:bodyPr/>
-          <a:lstStyle>
-            <a:lvl1pPr>
-              <a:defRPr sz="800">
-                <a:solidFill>
-                  <a:srgbClr val="6B7585"/>
-                </a:solidFill>
-              </a:defRPr>
-            </a:lvl1pPr>
-          </a:lstStyle>
-          <a:p>
-            <a:pPr algn="r"/>
-            <a:fld id="{F7021451-1387-4CA6-816F-3879F97B5CBC}" type="slidenum">
-              <a:rPr lang="en-US" b="0"/>
-              <a:t>37</a:t>
-            </a:fld>
-            <a:endParaRPr lang="en-US"/>
-          </a:p>
-        </p:txBody>
-      </p:sp>
-      <p:pic>
-        <p:nvPicPr>
-          <p:cNvPr id="26" name="cts logo" descr="cts-logo.png"/>
-          <p:cNvPicPr>
-            <a:picLocks noChangeAspect="1"/>
-          </p:cNvPicPr>
-          <p:nvPr/>
-        </p:nvPicPr>
-        <p:blipFill>
-          <a:blip r:embed="rId4"/>
-          <a:stretch>
-            <a:fillRect/>
-          </a:stretch>
-        </p:blipFill>
-        <p:spPr>
-          <a:xfrm>
-            <a:off x="7680959" y="182880"/>
-            <a:ext cx="960120" cy="539696"/>
-          </a:xfrm>
-          <a:prstGeom prst="rect">
-            <a:avLst/>
-          </a:prstGeom>
-        </p:spPr>
-      </p:pic>
-      <p:sp>
-        <p:nvSpPr>
-          <p:cNvPr id="4" name="Text 5b"/>
-          <p:cNvSpPr txBox="1"/>
-          <p:nvPr/>
-        </p:nvSpPr>
-        <p:spPr>
-          <a:xfrm>
-            <a:off x="4663440" y="3474719"/>
-            <a:ext cx="3703320" cy="1124712"/>
-          </a:xfrm>
-          <a:prstGeom prst="rect">
-            <a:avLst/>
-          </a:prstGeom>
-          <a:noFill/>
-          <a:ln/>
-        </p:spPr>
-        <p:txBody>
-          <a:bodyPr wrap="square" lIns="0" tIns="0" rIns="0" bIns="0" rtlCol="0" anchor="t">
-            <a:normAutofit fontScale="92500"/>
-          </a:bodyPr>
-          <a:lstStyle/>
-          <a:p>
-            <a:pPr marL="342900" indent="-342900">
-              <a:lnSpc>
-                <a:spcPts val="1050"/>
-              </a:lnSpc>
-              <a:spcAft>
-                <a:spcPts val="400"/>
-              </a:spcAft>
-              <a:buSzPct val="100000"/>
-              <a:buChar char="•"/>
-            </a:pPr>
-            <a:r>
-              <a:rPr lang="en-US" sz="1000">
-                <a:solidFill>
-                  <a:srgbClr val="3A4453"/>
-                </a:solidFill>
-              </a:rPr>
-              <a:t>Events recorded 333 hours of leave and 241 billable hours, reducing its available delivery capacity.</a:t>
-            </a:r>
-            <a:endParaRPr lang="en-US" sz="850"/>
-          </a:p>
-          <a:p>
-            <a:pPr marL="342900" indent="-342900">
-              <a:lnSpc>
-                <a:spcPts val="1050"/>
-              </a:lnSpc>
-              <a:spcAft>
-                <a:spcPts val="400"/>
-              </a:spcAft>
-              <a:buSzPct val="100000"/>
-              <a:buChar char="•"/>
-            </a:pPr>
-            <a:r>
-              <a:rPr lang="en-US" sz="1000">
-                <a:solidFill>
-                  <a:srgbClr val="3A4453"/>
-                </a:solidFill>
-              </a:rPr>
-              <a:t>Consulting recorded 84 non-billable hours compared with 31 billable hours.</a:t>
-            </a:r>
-            <a:endParaRPr lang="en-US" sz="850"/>
-          </a:p>
-          <a:p>
-            <a:pPr marL="342900" indent="-342900">
-              <a:lnSpc>
-                <a:spcPts val="1050"/>
-              </a:lnSpc>
-              <a:spcAft>
-                <a:spcPts val="400"/>
-              </a:spcAft>
-              <a:buSzPct val="100000"/>
-              <a:buChar char="•"/>
-            </a:pPr>
-            <a:r>
-              <a:rPr lang="en-US" sz="1000">
-                <a:solidFill>
-                  <a:srgbClr val="3A4453"/>
-                </a:solidFill>
-              </a:rPr>
-              <a:t>The non-billable and leave portions highlight opportunities to improve workforce planning and billable utilisation.</a:t>
-            </a:r>
-            <a:endParaRPr lang="en-US" sz="850"/>
-          </a:p>
-        </p:txBody>
-      </p:sp>
-    </p:spTree>
-  </p:cSld>
-  <p:clrMapOvr>
-    <a:masterClrMapping/>
-  </p:clrMapOvr>
-</p:sld>
-</file>
-
-<file path=ppt/slides/slide41.xml><?xml version="1.0" encoding="utf-8"?>
-<p:sld xmlns:a="http://schemas.openxmlformats.org/drawingml/2006/main" xmlns:r="http://schemas.openxmlformats.org/officeDocument/2006/relationships" xmlns:p="http://schemas.openxmlformats.org/presentationml/2006/main">
   <p:cSld name="Slide 27">
     <p:spTree>
       <p:nvGrpSpPr>
@@ -22668,7 +22164,7 @@
 </p:sld>
 </file>
 
-<file path=ppt/slides/slide42.xml><?xml version="1.0" encoding="utf-8"?>
+<file path=ppt/slides/slide41.xml><?xml version="1.0" encoding="utf-8"?>
 <p:sld xmlns:a="http://schemas.openxmlformats.org/drawingml/2006/main" xmlns:r="http://schemas.openxmlformats.org/officeDocument/2006/relationships" xmlns:p="http://schemas.openxmlformats.org/presentationml/2006/main">
   <p:cSld name="Slide 28">
     <p:spTree>
@@ -22951,7 +22447,7 @@
 </p:sld>
 </file>
 
-<file path=ppt/slides/slide43.xml><?xml version="1.0" encoding="utf-8"?>
+<file path=ppt/slides/slide42.xml><?xml version="1.0" encoding="utf-8"?>
 <p:sld xmlns:a="http://schemas.openxmlformats.org/drawingml/2006/main" xmlns:r="http://schemas.openxmlformats.org/officeDocument/2006/relationships" xmlns:p="http://schemas.openxmlformats.org/presentationml/2006/main">
   <p:cSld name="Slide 29">
     <p:spTree>
@@ -23357,7 +22853,7 @@
 </p:sld>
 </file>
 
-<file path=ppt/slides/slide44.xml><?xml version="1.0" encoding="utf-8"?>
+<file path=ppt/slides/slide43.xml><?xml version="1.0" encoding="utf-8"?>
 <p:sld xmlns:a="http://schemas.openxmlformats.org/drawingml/2006/main" xmlns:r="http://schemas.openxmlformats.org/officeDocument/2006/relationships" xmlns:p="http://schemas.openxmlformats.org/presentationml/2006/main">
   <p:cSld name="Slide 30">
     <p:spTree>
@@ -25503,7 +24999,7 @@
 </p:sld>
 </file>
 
-<file path=ppt/slides/slide45.xml><?xml version="1.0" encoding="utf-8"?>
+<file path=ppt/slides/slide44.xml><?xml version="1.0" encoding="utf-8"?>
 <p:sld xmlns:a="http://schemas.openxmlformats.org/drawingml/2006/main" xmlns:r="http://schemas.openxmlformats.org/officeDocument/2006/relationships" xmlns:p="http://schemas.openxmlformats.org/presentationml/2006/main">
   <p:cSld>
     <p:bg>
@@ -25879,7 +25375,7 @@
 </p:sld>
 </file>
 
-<file path=ppt/slides/slide46.xml><?xml version="1.0" encoding="utf-8"?>
+<file path=ppt/slides/slide45.xml><?xml version="1.0" encoding="utf-8"?>
 <p:sld xmlns:a="http://schemas.openxmlformats.org/drawingml/2006/main" xmlns:r="http://schemas.openxmlformats.org/officeDocument/2006/relationships" xmlns:p="http://schemas.openxmlformats.org/presentationml/2006/main">
   <p:cSld name="Slide 31">
     <p:spTree>

</xml_diff>

<commit_message>
Two wording corrections on pages 3 and 25
Both were wrong before any of this month's work, and she asked for them fixed.

Page 3 said Support was the only department covering its allocated overheads.
Integration covers its own as well, 23,756 of gross profit against 13,193 of
overhead, which is what page 18 already says. Changed in the summary panel and
in the speaker notes.

Page 19 is left as it was. It reads the month as three groups rather than five
departments, and on that basis Support really is the only one covering.

Page 25's note called Events the second largest loss. At 46,496 it is the
largest of the five.

Co-Authored-By: Claude Opus 5 <noreply@anthropic.com>
Claude-Session: https://claude.ai/code/session_01CVBAFohBCYXt1ufjTVDiZj
</commit_message>
<xml_diff>
--- a/deck/CTS Monthly Business Review - 30092026.pptx
+++ b/deck/CTS Monthly Business Review - 30092026.pptx
@@ -3387,7 +3387,7 @@
           </a:p>
           <a:p>
             <a:r>
-              <a:t>In summary, revenue exceeded budget while the company remained in loss. Support is the only department covering its allocated overheads. The revenue variance arose almost entirely in Integration at a 10.1% gross margin, which contributed turnover with very little profit.</a:t>
+              <a:t>In summary, revenue exceeded budget while the company remained in loss. Support and Integration are the only departments covering their allocated overheads. The revenue variance arose almost entirely in Integration at a 10.1% gross margin, which contributed turnover with very little profit.</a:t>
             </a:r>
           </a:p>
         </p:txBody>
@@ -5230,7 +5230,7 @@
           <a:p/>
           <a:p>
             <a:r>
-              <a:t>Events is the opposite problem. It is the smallest cost base of the three large departments and the second largest loss, because $103,377 of the $119,800 it costs is allocated overhead rather than cost of sales.</a:t>
+              <a:t>Events is the opposite problem. It is the smallest cost base of the three large departments and the largest loss, because $103,377 of the $119,800 it costs is allocated overhead rather than cost of sales.</a:t>
             </a:r>
           </a:p>
           <a:p/>
@@ -17365,7 +17365,7 @@
                   <a:srgbClr val="242C39"/>
                 </a:solidFill>
               </a:rPr>
-              <a:t>The month in summary. </a:t>
+              <a:t>The month in summary. September revenue exceeded budget by $148k, while EBITDA remained a loss of $32k. Support and Integration are the only departments covering their allocated overheads. The revenue variance arose almost entirely in Integration at a 10.1% gross margin, contributing turnover with very little profit. At the year-to-date gross margin of 38.9%, monthly revenue of approximately $549k is required to cover overheads, against a current average of $541k.</a:t>
             </a:r>
             <a:r>
               <a:rPr lang="en-US" sz="1000">
@@ -17373,7 +17373,7 @@
                   <a:srgbClr val="3A4453"/>
                 </a:solidFill>
               </a:rPr>
-              <a:t>September revenue exceeded budget by $148k, while EBITDA remained a loss of $32k. Support is the only department covering its allocated overheads. The revenue variance arose almost entirely in Integration at a 10.1% gross margin, contributing turnover with very little profit. At the year-to-date gross margin of 38.9%, monthly revenue of approximately $549k is required to cover overheads, against a current average of $541k.</a:t>
+              <a:t/>
             </a:r>
             <a:endParaRPr lang="en-US" sz="1000"/>
           </a:p>

</xml_diff>